<commit_message>
Fix Bana audit findings: tax-loss lapse, CFADS fees, decision-date postings, deck wording
Co-Authored-By: Claude Opus 5.5 <noreply@anthropic.com>
Claude-Session: https://claude.ai/code/session_01AWS1t9WtpkQHcCU1WceGZT
</commit_message>
<xml_diff>
--- a/projects/bana/out/Bana_IC.pptx
+++ b/projects/bana/out/Bana_IC.pptx
@@ -246,10 +246,10 @@
                 <c:formatCode>0.0%</c:formatCode>
                 <c:ptCount val="2"/>
                 <c:pt idx="0">
-                  <c:v>0.606310623674776</c:v>
+                  <c:v>0.609860122902974</c:v>
                 </c:pt>
                 <c:pt idx="1">
-                  <c:v>0.12221225150224</c:v>
+                  <c:v>0.122239087401663</c:v>
                 </c:pt>
               </c:numCache>
             </c:numRef>
@@ -296,10 +296,10 @@
                 <c:formatCode>0.0%</c:formatCode>
                 <c:ptCount val="2"/>
                 <c:pt idx="0">
-                  <c:v>0.465605123297348</c:v>
+                  <c:v>0.467905968268763</c:v>
                 </c:pt>
                 <c:pt idx="1">
-                  <c:v>0.128070846872012</c:v>
+                  <c:v>0.128179632485241</c:v>
                 </c:pt>
               </c:numCache>
             </c:numRef>
@@ -6030,7 +6030,7 @@
           <a:lstStyle/>
           <a:p>
             <a:r>
-              <a:t>At €4.50m, Bana returns 60.6% (European) / 46.6% (Chinese) on a sale at COD and 12.2% / 12.8% if held</a:t>
+              <a:t>At €4.50m, Bana returns 61.0% (European) / 46.8% (Chinese) on a sale at COD and 12.2% / 12.8% if held</a:t>
             </a:r>
           </a:p>
         </p:txBody>
@@ -7016,7 +7016,7 @@
                           </a:solidFill>
                           <a:latin typeface="Aptos"/>
                         </a:rPr>
-                        <a:t>60.6%</a:t>
+                        <a:t>61.0%</a:t>
                       </a:r>
                     </a:p>
                   </a:txBody>
@@ -7039,7 +7039,7 @@
                           </a:solidFill>
                           <a:latin typeface="Aptos"/>
                         </a:rPr>
-                        <a:t>46.6%</a:t>
+                        <a:t>46.8%</a:t>
                       </a:r>
                     </a:p>
                   </a:txBody>
@@ -7110,7 +7110,7 @@
                           </a:solidFill>
                           <a:latin typeface="Aptos"/>
                         </a:rPr>
-                        <a:t>2.72x</a:t>
+                        <a:t>2.71x</a:t>
                       </a:r>
                     </a:p>
                   </a:txBody>
@@ -7131,7 +7131,7 @@
                           </a:solidFill>
                           <a:latin typeface="Aptos"/>
                         </a:rPr>
-                        <a:t>2.04x</a:t>
+                        <a:t>2.03x</a:t>
                       </a:r>
                     </a:p>
                   </a:txBody>
@@ -7361,7 +7361,7 @@
                           </a:solidFill>
                           <a:latin typeface="Aptos"/>
                         </a:rPr>
-                        <a:t>6.28x</a:t>
+                        <a:t>6.27x</a:t>
                       </a:r>
                     </a:p>
                   </a:txBody>
@@ -7541,7 +7541,7 @@
                           </a:solidFill>
                           <a:latin typeface="Aptos"/>
                         </a:rPr>
-                        <a:t>1.59x</a:t>
+                        <a:t>1.58x</a:t>
                       </a:r>
                     </a:p>
                   </a:txBody>
@@ -7562,7 +7562,7 @@
                           </a:solidFill>
                           <a:latin typeface="Aptos"/>
                         </a:rPr>
-                        <a:t>1.98x</a:t>
+                        <a:t>1.97x</a:t>
                       </a:r>
                     </a:p>
                   </a:txBody>
@@ -9836,7 +9836,7 @@
                 </a:solidFill>
                 <a:latin typeface="Aptos"/>
               </a:rPr>
-              <a:t>European turbines add 12 points but need a permit amendment; no other commitment above the minimum is offered.</a:t>
+              <a:t>European turbines add 12 points but need a permit amendment; the PB stays at the minimum and partial award, shared connection and EU transformers are not offered.</a:t>
             </a:r>
           </a:p>
         </p:txBody>
@@ -12193,7 +12193,7 @@
                           </a:solidFill>
                           <a:latin typeface="Aptos"/>
                         </a:rPr>
-                        <a:t>4.3</a:t>
+                        <a:t>4.4</a:t>
                       </a:r>
                     </a:p>
                   </a:txBody>
@@ -13403,7 +13403,7 @@
                           </a:solidFill>
                           <a:latin typeface="Aptos"/>
                         </a:rPr>
-                        <a:t>0.32</a:t>
+                        <a:t>0.31</a:t>
                       </a:r>
                     </a:p>
                   </a:txBody>
@@ -13521,7 +13521,7 @@
           <a:lstStyle/>
           <a:p>
             <a:r>
-              <a:t>A sale at COD turns €22.5m of equity into €61.1m (2.72x); holding earns 12.2% at a 1.59x DSCR (European)</a:t>
+              <a:t>A sale at COD turns €22.5m of equity into €61.1m (2.71x); holding earns 12.2% at a 1.58x DSCR (European)</a:t>
             </a:r>
           </a:p>
         </p:txBody>
@@ -13865,7 +13865,7 @@
                 </a:solidFill>
                 <a:latin typeface="Aptos"/>
               </a:rPr>
-              <a:t>With Chinese turbines the sale returns 46.6% and the hold 12.8%; the debt-share cap binds on both routes, below the DSCR capacity.</a:t>
+              <a:t>With Chinese turbines the sale returns 46.8% and the hold 12.8%; debt is sized at 80% / 70% of construction cost.</a:t>
             </a:r>
           </a:p>
         </p:txBody>
@@ -14182,7 +14182,7 @@
                           </a:solidFill>
                           <a:latin typeface="Aptos"/>
                         </a:rPr>
-                        <a:t>Senior debt repaid at COD</a:t>
+                        <a:t>Senior debt assumed by the buyer</a:t>
                       </a:r>
                     </a:p>
                   </a:txBody>
@@ -14666,7 +14666,7 @@
                           </a:solidFill>
                           <a:latin typeface="Aptos"/>
                         </a:rPr>
-                        <a:t>125.6</a:t>
+                        <a:t>125.5</a:t>
                       </a:r>
                     </a:p>
                   </a:txBody>
@@ -14687,7 +14687,7 @@
                           </a:solidFill>
                           <a:latin typeface="Aptos"/>
                         </a:rPr>
-                        <a:t>138.2</a:t>
+                        <a:t>138.1</a:t>
                       </a:r>
                     </a:p>
                   </a:txBody>
@@ -14756,7 +14756,7 @@
                           </a:solidFill>
                           <a:latin typeface="Aptos"/>
                         </a:rPr>
-                        <a:t>60.6%</a:t>
+                        <a:t>61.0%</a:t>
                       </a:r>
                     </a:p>
                   </a:txBody>
@@ -14779,7 +14779,7 @@
                           </a:solidFill>
                           <a:latin typeface="Aptos"/>
                         </a:rPr>
-                        <a:t>46.6%</a:t>
+                        <a:t>46.8%</a:t>
                       </a:r>
                     </a:p>
                   </a:txBody>
@@ -14896,7 +14896,7 @@
                           </a:solidFill>
                           <a:latin typeface="Aptos"/>
                         </a:rPr>
-                        <a:t>2.72x</a:t>
+                        <a:t>2.71x</a:t>
                       </a:r>
                     </a:p>
                   </a:txBody>
@@ -14917,7 +14917,7 @@
                           </a:solidFill>
                           <a:latin typeface="Aptos"/>
                         </a:rPr>
-                        <a:t>2.04x</a:t>
+                        <a:t>2.03x</a:t>
                       </a:r>
                     </a:p>
                   </a:txBody>
@@ -14938,7 +14938,7 @@
                           </a:solidFill>
                           <a:latin typeface="Aptos"/>
                         </a:rPr>
-                        <a:t>6.28x</a:t>
+                        <a:t>6.27x</a:t>
                       </a:r>
                     </a:p>
                   </a:txBody>
@@ -15049,7 +15049,7 @@
                           </a:solidFill>
                           <a:latin typeface="Aptos"/>
                         </a:rPr>
-                        <a:t>18.7</a:t>
+                        <a:t>18.6</a:t>
                       </a:r>
                     </a:p>
                   </a:txBody>
@@ -15114,7 +15114,7 @@
                           </a:solidFill>
                           <a:latin typeface="Aptos"/>
                         </a:rPr>
-                        <a:t>Project IRR, post-tax, before financing</a:t>
+                        <a:t>Project IRR, actual tax, before financing</a:t>
                       </a:r>
                     </a:p>
                   </a:txBody>
@@ -15246,7 +15246,7 @@
                           </a:solidFill>
                           <a:latin typeface="Aptos"/>
                         </a:rPr>
-                        <a:t>Minimum DSCR (sculpted, flat)</a:t>
+                        <a:t>Minimum DSCR (sculpted repayment)</a:t>
                       </a:r>
                     </a:p>
                   </a:txBody>
@@ -15334,7 +15334,7 @@
                           </a:solidFill>
                           <a:latin typeface="Aptos"/>
                         </a:rPr>
-                        <a:t>1.59x</a:t>
+                        <a:t>1.58x</a:t>
                       </a:r>
                     </a:p>
                   </a:txBody>
@@ -15355,7 +15355,7 @@
                           </a:solidFill>
                           <a:latin typeface="Aptos"/>
                         </a:rPr>
-                        <a:t>1.98x</a:t>
+                        <a:t>1.97x</a:t>
                       </a:r>
                     </a:p>
                   </a:txBody>
@@ -15466,7 +15466,7 @@
                           </a:solidFill>
                           <a:latin typeface="Aptos"/>
                         </a:rPr>
-                        <a:t>(12.4)</a:t>
+                        <a:t>(12.5)</a:t>
                       </a:r>
                     </a:p>
                   </a:txBody>
@@ -15591,7 +15591,7 @@
                 </a:solidFill>
                 <a:latin typeface="Aptos"/>
               </a:rPr>
-              <a:t>1.20x target DSCR over 18 years, 5.0% fixed; sized at the lower of the DSCR capacity and 80% / 70% of cost. The cap binds: 76% / 61% of capacity used.</a:t>
+              <a:t>1.20x target DSCR over 18 years, 5.0% fixed; sized at the lower of the DSCR capacity and 80% / 70% of cost; 76% / 61% of the DSCR capacity is used.</a:t>
             </a:r>
           </a:p>
           <a:p>
@@ -15616,7 +15616,7 @@
                 </a:solidFill>
                 <a:latin typeface="Aptos"/>
               </a:rPr>
-              <a:t>CIT 9%; 20-year depreciation; losses capped at 50% of the base. Gain on the COD share sale exempt.</a:t>
+              <a:t>CIT 9%; 20-year depreciation; losses capped at 50% of the base and lapse after 5 years. Gain on the COD share sale exempt.</a:t>
             </a:r>
           </a:p>
         </p:txBody>
@@ -15650,7 +15650,7 @@
                 </a:solidFill>
                 <a:latin typeface="Aptos"/>
               </a:rPr>
-              <a:t>Sale price 2,450 / 2,100 k€ per MW. Hold: PPA 90 €/MWh, 30-year life; DSRA of 6 months funded at COD. HIPA 2% and the innovation contribution on revenue. NPV at 8%.</a:t>
+              <a:t>Sale price 2,450 / 2,100 k€ per MW; the buyer takes the SPV with its debt and funds the DSRA. Hold: PPA 90 €/MWh, 30-year life; DSRA of 6 months funded at COD. HIPA 2% and the innovation contribution on revenue. NPV at 8%.</a:t>
             </a:r>
           </a:p>
           <a:p>
@@ -15705,7 +15705,7 @@
           <a:lstStyle/>
           <a:p>
             <a:r>
-              <a:t>A 10 % lower COD price is the largest risk to the sale (46.7%); yield and PPA price drive the hold (9.6% / 9.3%)</a:t>
+              <a:t>A lower COD price is the largest risk to the sale (46.9%); yield and PPA price drive the hold (9.6% / 9.3%)</a:t>
             </a:r>
           </a:p>
         </p:txBody>
@@ -16281,7 +16281,7 @@
                           </a:solidFill>
                           <a:latin typeface="Aptos"/>
                         </a:rPr>
-                        <a:t>60.6%</a:t>
+                        <a:t>61.0%</a:t>
                       </a:r>
                     </a:p>
                   </a:txBody>
@@ -16304,7 +16304,7 @@
                           </a:solidFill>
                           <a:latin typeface="Aptos"/>
                         </a:rPr>
-                        <a:t>46.6%</a:t>
+                        <a:t>46.8%</a:t>
                       </a:r>
                     </a:p>
                   </a:txBody>
@@ -16373,7 +16373,7 @@
                           </a:solidFill>
                           <a:latin typeface="Aptos"/>
                         </a:rPr>
-                        <a:t>1.59x</a:t>
+                        <a:t>1.58x</a:t>
                       </a:r>
                     </a:p>
                   </a:txBody>
@@ -16396,7 +16396,7 @@
                           </a:solidFill>
                           <a:latin typeface="Aptos"/>
                         </a:rPr>
-                        <a:t>1.98x</a:t>
+                        <a:t>1.97x</a:t>
                       </a:r>
                     </a:p>
                   </a:txBody>
@@ -16444,7 +16444,7 @@
                           </a:solidFill>
                           <a:latin typeface="Aptos"/>
                         </a:rPr>
-                        <a:t>46.7%</a:t>
+                        <a:t>46.9%</a:t>
                       </a:r>
                     </a:p>
                   </a:txBody>
@@ -16465,7 +16465,7 @@
                           </a:solidFill>
                           <a:latin typeface="Aptos"/>
                         </a:rPr>
-                        <a:t>32.8%</a:t>
+                        <a:t>33.0%</a:t>
                       </a:r>
                     </a:p>
                   </a:txBody>
@@ -16528,7 +16528,7 @@
                           </a:solidFill>
                           <a:latin typeface="Aptos"/>
                         </a:rPr>
-                        <a:t>1.59x</a:t>
+                        <a:t>1.58x</a:t>
                       </a:r>
                     </a:p>
                   </a:txBody>
@@ -16549,7 +16549,7 @@
                           </a:solidFill>
                           <a:latin typeface="Aptos"/>
                         </a:rPr>
-                        <a:t>1.98x</a:t>
+                        <a:t>1.97x</a:t>
                       </a:r>
                     </a:p>
                   </a:txBody>
@@ -16595,7 +16595,7 @@
                           </a:solidFill>
                           <a:latin typeface="Aptos"/>
                         </a:rPr>
-                        <a:t>56.7%</a:t>
+                        <a:t>57.0%</a:t>
                       </a:r>
                     </a:p>
                   </a:txBody>
@@ -16616,7 +16616,7 @@
                           </a:solidFill>
                           <a:latin typeface="Aptos"/>
                         </a:rPr>
-                        <a:t>42.8%</a:t>
+                        <a:t>43.0%</a:t>
                       </a:r>
                     </a:p>
                   </a:txBody>
@@ -16679,7 +16679,7 @@
                           </a:solidFill>
                           <a:latin typeface="Aptos"/>
                         </a:rPr>
-                        <a:t>1.53x</a:t>
+                        <a:t>1.52x</a:t>
                       </a:r>
                     </a:p>
                   </a:txBody>
@@ -16700,7 +16700,7 @@
                           </a:solidFill>
                           <a:latin typeface="Aptos"/>
                         </a:rPr>
-                        <a:t>1.91x</a:t>
+                        <a:t>1.90x</a:t>
                       </a:r>
                     </a:p>
                   </a:txBody>
@@ -16746,7 +16746,7 @@
                           </a:solidFill>
                           <a:latin typeface="Aptos"/>
                         </a:rPr>
-                        <a:t>60.6%</a:t>
+                        <a:t>61.0%</a:t>
                       </a:r>
                     </a:p>
                   </a:txBody>
@@ -16767,7 +16767,7 @@
                           </a:solidFill>
                           <a:latin typeface="Aptos"/>
                         </a:rPr>
-                        <a:t>46.6%</a:t>
+                        <a:t>46.8%</a:t>
                       </a:r>
                     </a:p>
                   </a:txBody>
@@ -16830,7 +16830,7 @@
                           </a:solidFill>
                           <a:latin typeface="Aptos"/>
                         </a:rPr>
-                        <a:t>1.41x</a:t>
+                        <a:t>1.40x</a:t>
                       </a:r>
                     </a:p>
                   </a:txBody>
@@ -16897,7 +16897,7 @@
                           </a:solidFill>
                           <a:latin typeface="Aptos"/>
                         </a:rPr>
-                        <a:t>60.6%</a:t>
+                        <a:t>61.0%</a:t>
                       </a:r>
                     </a:p>
                   </a:txBody>
@@ -16918,7 +16918,7 @@
                           </a:solidFill>
                           <a:latin typeface="Aptos"/>
                         </a:rPr>
-                        <a:t>46.6%</a:t>
+                        <a:t>46.8%</a:t>
                       </a:r>
                     </a:p>
                   </a:txBody>
@@ -16981,7 +16981,7 @@
                           </a:solidFill>
                           <a:latin typeface="Aptos"/>
                         </a:rPr>
-                        <a:t>1.39x</a:t>
+                        <a:t>1.38x</a:t>
                       </a:r>
                     </a:p>
                   </a:txBody>
@@ -17002,7 +17002,7 @@
                           </a:solidFill>
                           <a:latin typeface="Aptos"/>
                         </a:rPr>
-                        <a:t>1.73x</a:t>
+                        <a:t>1.72x</a:t>
                       </a:r>
                     </a:p>
                   </a:txBody>
@@ -17048,7 +17048,7 @@
                           </a:solidFill>
                           <a:latin typeface="Aptos"/>
                         </a:rPr>
-                        <a:t>58.0%</a:t>
+                        <a:t>58.3%</a:t>
                       </a:r>
                     </a:p>
                   </a:txBody>
@@ -17069,7 +17069,7 @@
                           </a:solidFill>
                           <a:latin typeface="Aptos"/>
                         </a:rPr>
-                        <a:t>44.4%</a:t>
+                        <a:t>44.6%</a:t>
                       </a:r>
                     </a:p>
                   </a:txBody>
@@ -17153,7 +17153,7 @@
                           </a:solidFill>
                           <a:latin typeface="Aptos"/>
                         </a:rPr>
-                        <a:t>1.98x</a:t>
+                        <a:t>1.97x</a:t>
                       </a:r>
                     </a:p>
                   </a:txBody>
@@ -17199,7 +17199,7 @@
                           </a:solidFill>
                           <a:latin typeface="Aptos"/>
                         </a:rPr>
-                        <a:t>60.0%</a:t>
+                        <a:t>60.4%</a:t>
                       </a:r>
                     </a:p>
                   </a:txBody>
@@ -17220,7 +17220,7 @@
                           </a:solidFill>
                           <a:latin typeface="Aptos"/>
                         </a:rPr>
-                        <a:t>46.0%</a:t>
+                        <a:t>46.2%</a:t>
                       </a:r>
                     </a:p>
                   </a:txBody>
@@ -17283,7 +17283,7 @@
                           </a:solidFill>
                           <a:latin typeface="Aptos"/>
                         </a:rPr>
-                        <a:t>1.47x</a:t>
+                        <a:t>1.46x</a:t>
                       </a:r>
                     </a:p>
                   </a:txBody>
@@ -17350,7 +17350,7 @@
                           </a:solidFill>
                           <a:latin typeface="Aptos"/>
                         </a:rPr>
-                        <a:t>56.9%</a:t>
+                        <a:t>57.1%</a:t>
                       </a:r>
                     </a:p>
                   </a:txBody>
@@ -17371,7 +17371,7 @@
                           </a:solidFill>
                           <a:latin typeface="Aptos"/>
                         </a:rPr>
-                        <a:t>46.6%</a:t>
+                        <a:t>46.8%</a:t>
                       </a:r>
                     </a:p>
                   </a:txBody>
@@ -17650,7 +17650,7 @@
                 </a:solidFill>
                 <a:latin typeface="Aptos"/>
               </a:rPr>
-              <a:t>Sets: COD price, turbine price, yield (P50 hours), PPA price and purchase price changed by 10 % as named; debt rate +1 pp; tenor 10 years. Stored by the scenario macro with the tax solver; base = live model.</a:t>
+              <a:t>Each set changes one input, as named; tenor 10 years. Stored by the scenario macro with the tax solver; base = live model. Model checks in every set: all pass.</a:t>
             </a:r>
           </a:p>
           <a:p>

</xml_diff>

<commit_message>
Bid Bana with 20% overbuild and build 10%; add the PB sanction cases
Co-Authored-By: Claude Opus 5.5 <noreply@anthropic.com>
Claude-Session: https://claude.ai/code/session_01AWS1t9WtpkQHcCU1WceGZT
</commit_message>
<xml_diff>
--- a/projects/bana/out/Bana_IC.pptx
+++ b/projects/bana/out/Bana_IC.pptx
@@ -246,10 +246,10 @@
                 <c:formatCode>0.0%</c:formatCode>
                 <c:ptCount val="2"/>
                 <c:pt idx="0">
-                  <c:v>0.609860122902974</c:v>
+                  <c:v>0.663535311491085</c:v>
                 </c:pt>
                 <c:pt idx="1">
-                  <c:v>0.122239087401663</c:v>
+                  <c:v>0.129381611423992</c:v>
                 </c:pt>
               </c:numCache>
             </c:numRef>
@@ -296,10 +296,10 @@
                 <c:formatCode>0.0%</c:formatCode>
                 <c:ptCount val="2"/>
                 <c:pt idx="0">
-                  <c:v>0.467905968268763</c:v>
+                  <c:v>0.518123392285528</c:v>
                 </c:pt>
                 <c:pt idx="1">
-                  <c:v>0.128179632485241</c:v>
+                  <c:v>0.134805776932951</c:v>
                 </c:pt>
               </c:numCache>
             </c:numRef>
@@ -5897,7 +5897,7 @@
                 <a:latin typeface="Aptos"/>
                 <a:cs typeface="Aptos"/>
               </a:rPr>
-              <a:t>50 MW wind development project opportunity</a:t>
+              <a:t>55 MW wind development project opportunity</a:t>
             </a:r>
             <a:endParaRPr lang="en-GB" sz="5400" b="1" noProof="0" dirty="0">
               <a:latin typeface="Aptos"/>
@@ -6030,7 +6030,7 @@
           <a:lstStyle/>
           <a:p>
             <a:r>
-              <a:t>At €4.50m, Bana returns 61.0% (European) / 46.8% (Chinese) on a sale at COD and 12.2% / 12.8% if held</a:t>
+              <a:t>At €4.50m, Bana returns 66.4% (European) / 51.8% (Chinese) on a sale at COD and 12.9% / 13.5% if held</a:t>
             </a:r>
           </a:p>
         </p:txBody>
@@ -6374,7 +6374,7 @@
                 </a:solidFill>
                 <a:latin typeface="Aptos"/>
               </a:rPr>
-              <a:t>FEP funds €22.5m of equity to COD (€27.5m Chinese) and bids 29 points (17 Chinese) into the 30 October tender; the European route needs a permit amendment.</a:t>
+              <a:t>FEP funds €23.8m of equity to COD (€29.1m Chinese) and bids 34 points (22 Chinese) into the 30 October tender; the European route needs a permit amendment.</a:t>
             </a:r>
           </a:p>
         </p:txBody>
@@ -6679,7 +6679,7 @@
                           </a:solidFill>
                           <a:latin typeface="Aptos"/>
                         </a:rPr>
-                        <a:t>29</a:t>
+                        <a:t>34</a:t>
                       </a:r>
                     </a:p>
                   </a:txBody>
@@ -6700,7 +6700,7 @@
                           </a:solidFill>
                           <a:latin typeface="Aptos"/>
                         </a:rPr>
-                        <a:t>17</a:t>
+                        <a:t>22</a:t>
                       </a:r>
                     </a:p>
                   </a:txBody>
@@ -6769,7 +6769,7 @@
                           </a:solidFill>
                           <a:latin typeface="Aptos"/>
                         </a:rPr>
-                        <a:t>22.5</a:t>
+                        <a:t>23.8</a:t>
                       </a:r>
                     </a:p>
                   </a:txBody>
@@ -6790,7 +6790,7 @@
                           </a:solidFill>
                           <a:latin typeface="Aptos"/>
                         </a:rPr>
-                        <a:t>27.5</a:t>
+                        <a:t>29.1</a:t>
                       </a:r>
                     </a:p>
                   </a:txBody>
@@ -6926,7 +6926,7 @@
                           </a:solidFill>
                           <a:latin typeface="Aptos"/>
                         </a:rPr>
-                        <a:t>38.6</a:t>
+                        <a:t>44.8</a:t>
                       </a:r>
                     </a:p>
                   </a:txBody>
@@ -6947,7 +6947,7 @@
                           </a:solidFill>
                           <a:latin typeface="Aptos"/>
                         </a:rPr>
-                        <a:t>28.5</a:t>
+                        <a:t>33.6</a:t>
                       </a:r>
                     </a:p>
                   </a:txBody>
@@ -7016,7 +7016,7 @@
                           </a:solidFill>
                           <a:latin typeface="Aptos"/>
                         </a:rPr>
-                        <a:t>61.0%</a:t>
+                        <a:t>66.4%</a:t>
                       </a:r>
                     </a:p>
                   </a:txBody>
@@ -7039,7 +7039,7 @@
                           </a:solidFill>
                           <a:latin typeface="Aptos"/>
                         </a:rPr>
-                        <a:t>46.8%</a:t>
+                        <a:t>51.8%</a:t>
                       </a:r>
                     </a:p>
                   </a:txBody>
@@ -7110,7 +7110,7 @@
                           </a:solidFill>
                           <a:latin typeface="Aptos"/>
                         </a:rPr>
-                        <a:t>2.71x</a:t>
+                        <a:t>2.89x</a:t>
                       </a:r>
                     </a:p>
                   </a:txBody>
@@ -7131,7 +7131,7 @@
                           </a:solidFill>
                           <a:latin typeface="Aptos"/>
                         </a:rPr>
-                        <a:t>2.03x</a:t>
+                        <a:t>2.16x</a:t>
                       </a:r>
                     </a:p>
                   </a:txBody>
@@ -7267,7 +7267,7 @@
                           </a:solidFill>
                           <a:latin typeface="Aptos"/>
                         </a:rPr>
-                        <a:t>12.2%</a:t>
+                        <a:t>12.9%</a:t>
                       </a:r>
                     </a:p>
                   </a:txBody>
@@ -7290,7 +7290,7 @@
                           </a:solidFill>
                           <a:latin typeface="Aptos"/>
                         </a:rPr>
-                        <a:t>12.8%</a:t>
+                        <a:t>13.5%</a:t>
                       </a:r>
                     </a:p>
                   </a:txBody>
@@ -7361,7 +7361,7 @@
                           </a:solidFill>
                           <a:latin typeface="Aptos"/>
                         </a:rPr>
-                        <a:t>6.27x</a:t>
+                        <a:t>6.60x</a:t>
                       </a:r>
                     </a:p>
                   </a:txBody>
@@ -7382,7 +7382,7 @@
                           </a:solidFill>
                           <a:latin typeface="Aptos"/>
                         </a:rPr>
-                        <a:t>5.84x</a:t>
+                        <a:t>6.12x</a:t>
                       </a:r>
                     </a:p>
                   </a:txBody>
@@ -7451,7 +7451,7 @@
                           </a:solidFill>
                           <a:latin typeface="Aptos"/>
                         </a:rPr>
-                        <a:t>13.1</a:t>
+                        <a:t>16.2</a:t>
                       </a:r>
                     </a:p>
                   </a:txBody>
@@ -7472,7 +7472,7 @@
                           </a:solidFill>
                           <a:latin typeface="Aptos"/>
                         </a:rPr>
-                        <a:t>16.3</a:t>
+                        <a:t>19.6</a:t>
                       </a:r>
                     </a:p>
                   </a:txBody>
@@ -7541,7 +7541,7 @@
                           </a:solidFill>
                           <a:latin typeface="Aptos"/>
                         </a:rPr>
-                        <a:t>1.58x</a:t>
+                        <a:t>1.62x</a:t>
                       </a:r>
                     </a:p>
                   </a:txBody>
@@ -7562,7 +7562,7 @@
                           </a:solidFill>
                           <a:latin typeface="Aptos"/>
                         </a:rPr>
-                        <a:t>1.97x</a:t>
+                        <a:t>2.02x</a:t>
                       </a:r>
                     </a:p>
                   </a:txBody>
@@ -9492,7 +9492,7 @@
           <a:lstStyle/>
           <a:p>
             <a:r>
-              <a:t>50 MW producing 120.4 GWh a year; the bid scores 29 points with European turbines and 17 with Chinese</a:t>
+              <a:t>55 MW producing 131.9 GWh a year; the bid scores 34 points with European turbines and 22 with Chinese</a:t>
             </a:r>
           </a:p>
         </p:txBody>
@@ -9836,7 +9836,7 @@
                 </a:solidFill>
                 <a:latin typeface="Aptos"/>
               </a:rPr>
-              <a:t>European turbines add 12 points but need a permit amendment; the PB stays at the minimum and partial award, shared connection and EU transformers are not offered.</a:t>
+              <a:t>The bid commits 20% overbuild (60 MW, 5 points) and FEP builds 55 MW, inside the tolerance; European turbines add 12 points but need a permit amendment.</a:t>
             </a:r>
           </a:p>
         </p:txBody>
@@ -10010,7 +10010,7 @@
                           </a:solidFill>
                           <a:latin typeface="Aptos"/>
                         </a:rPr>
-                        <a:t>Net connection capacity / installed wind</a:t>
+                        <a:t>Connection / wind committed / built</a:t>
                       </a:r>
                     </a:p>
                   </a:txBody>
@@ -10033,7 +10033,7 @@
                           </a:solidFill>
                           <a:latin typeface="Aptos"/>
                         </a:rPr>
-                        <a:t>50 MVA / 50 MW</a:t>
+                        <a:t>50 MVA / 60 MW / 55 MW</a:t>
                       </a:r>
                     </a:p>
                   </a:txBody>
@@ -10210,7 +10210,7 @@
                           </a:solidFill>
                           <a:latin typeface="Aptos"/>
                         </a:rPr>
-                        <a:t>120.4 GWh</a:t>
+                        <a:t>131.9 GWh</a:t>
                       </a:r>
                     </a:p>
                   </a:txBody>
@@ -10495,7 +10495,7 @@
         </p:nvGraphicFramePr>
         <p:xfrm>
           <a:off x="12207240" y="2240280"/>
-          <a:ext cx="5989320" cy="3941064"/>
+          <a:ext cx="5989320" cy="4507992"/>
         </p:xfrm>
         <a:graphic>
           <a:graphicData uri="http://schemas.openxmlformats.org/drawingml/2006/table">
@@ -10793,7 +10793,7 @@
                           </a:solidFill>
                           <a:latin typeface="Aptos"/>
                         </a:rPr>
-                        <a:t>ÖSZ-6 performance security</a:t>
+                        <a:t>ÖSZ-3 overbuild</a:t>
                       </a:r>
                     </a:p>
                   </a:txBody>
@@ -10816,7 +10816,7 @@
                           </a:solidFill>
                           <a:latin typeface="Aptos"/>
                         </a:rPr>
-                        <a:t>1.0x of the minimum</a:t>
+                        <a:t>20% of MVA; 10% built</a:t>
                       </a:r>
                     </a:p>
                   </a:txBody>
@@ -10837,7 +10837,7 @@
                           </a:solidFill>
                           <a:latin typeface="Aptos"/>
                         </a:rPr>
-                        <a:t>0</a:t>
+                        <a:t>5</a:t>
                       </a:r>
                     </a:p>
                   </a:txBody>
@@ -10858,7 +10858,7 @@
                           </a:solidFill>
                           <a:latin typeface="Aptos"/>
                         </a:rPr>
-                        <a:t>0</a:t>
+                        <a:t>5</a:t>
                       </a:r>
                     </a:p>
                   </a:txBody>
@@ -10881,7 +10881,7 @@
                           </a:solidFill>
                           <a:latin typeface="Aptos"/>
                         </a:rPr>
-                        <a:t>ÖSZ-9 European turbines ≥ 80 %</a:t>
+                        <a:t>ÖSZ-6 performance security</a:t>
                       </a:r>
                     </a:p>
                   </a:txBody>
@@ -10904,7 +10904,7 @@
                           </a:solidFill>
                           <a:latin typeface="Aptos"/>
                         </a:rPr>
-                        <a:t>European route only</a:t>
+                        <a:t>1.0x of the minimum</a:t>
                       </a:r>
                     </a:p>
                   </a:txBody>
@@ -10925,7 +10925,7 @@
                           </a:solidFill>
                           <a:latin typeface="Aptos"/>
                         </a:rPr>
-                        <a:t>12</a:t>
+                        <a:t>0</a:t>
                       </a:r>
                     </a:p>
                   </a:txBody>
@@ -10969,7 +10969,7 @@
                           </a:solidFill>
                           <a:latin typeface="Aptos"/>
                         </a:rPr>
-                        <a:t>ÖSZ-5 partial award, ÖSZ-8 shared connection, ÖSZ-9 EU transformers</a:t>
+                        <a:t>ÖSZ-9 European turbines ≥ 80 %</a:t>
                       </a:r>
                     </a:p>
                   </a:txBody>
@@ -10992,7 +10992,7 @@
                           </a:solidFill>
                           <a:latin typeface="Aptos"/>
                         </a:rPr>
-                        <a:t>not offered</a:t>
+                        <a:t>European route only</a:t>
                       </a:r>
                     </a:p>
                   </a:txBody>
@@ -11013,7 +11013,7 @@
                           </a:solidFill>
                           <a:latin typeface="Aptos"/>
                         </a:rPr>
-                        <a:t>0 / 0 / 0</a:t>
+                        <a:t>12</a:t>
                       </a:r>
                     </a:p>
                   </a:txBody>
@@ -11034,7 +11034,7 @@
                           </a:solidFill>
                           <a:latin typeface="Aptos"/>
                         </a:rPr>
-                        <a:t>0 / 0 / 0</a:t>
+                        <a:t>0</a:t>
                       </a:r>
                     </a:p>
                   </a:txBody>
@@ -11051,13 +11051,13 @@
                     <a:p>
                       <a:pPr algn="l"/>
                       <a:r>
-                        <a:rPr sz="1300" b="1">
-                          <a:solidFill>
-                            <a:srgbClr val="3C3C3B"/>
-                          </a:solidFill>
-                          <a:latin typeface="Aptos"/>
-                        </a:rPr>
-                        <a:t>Total score</a:t>
+                        <a:rPr sz="1300" b="0">
+                          <a:solidFill>
+                            <a:srgbClr val="3C3C3B"/>
+                          </a:solidFill>
+                          <a:latin typeface="Aptos"/>
+                        </a:rPr>
+                        <a:t>ÖSZ-5 partial award, ÖSZ-8 shared connection, ÖSZ-9 EU transformers</a:t>
                       </a:r>
                     </a:p>
                   </a:txBody>
@@ -11073,6 +11073,94 @@
                     <a:lstStyle/>
                     <a:p>
                       <a:pPr algn="l"/>
+                      <a:r>
+                        <a:rPr sz="1300" b="0">
+                          <a:solidFill>
+                            <a:srgbClr val="3C3C3B"/>
+                          </a:solidFill>
+                          <a:latin typeface="Aptos"/>
+                        </a:rPr>
+                        <a:t>not offered</a:t>
+                      </a:r>
+                    </a:p>
+                  </a:txBody>
+                  <a:tcPr marL="73152" marR="73152" marT="27432" marB="27432" anchor="ctr">
+                    <a:noFill/>
+                  </a:tcPr>
+                </a:tc>
+                <a:tc>
+                  <a:txBody>
+                    <a:bodyPr/>
+                    <a:lstStyle/>
+                    <a:p>
+                      <a:pPr algn="r"/>
+                      <a:r>
+                        <a:rPr sz="1300" b="0">
+                          <a:solidFill>
+                            <a:srgbClr val="3C3C3B"/>
+                          </a:solidFill>
+                          <a:latin typeface="Aptos"/>
+                        </a:rPr>
+                        <a:t>0 / 0 / 0</a:t>
+                      </a:r>
+                    </a:p>
+                  </a:txBody>
+                  <a:tcPr marL="73152" marR="73152" marT="27432" marB="27432" anchor="ctr">
+                    <a:noFill/>
+                  </a:tcPr>
+                </a:tc>
+                <a:tc>
+                  <a:txBody>
+                    <a:bodyPr/>
+                    <a:lstStyle/>
+                    <a:p>
+                      <a:pPr algn="r"/>
+                      <a:r>
+                        <a:rPr sz="1300" b="0">
+                          <a:solidFill>
+                            <a:srgbClr val="3C3C3B"/>
+                          </a:solidFill>
+                          <a:latin typeface="Aptos"/>
+                        </a:rPr>
+                        <a:t>0 / 0 / 0</a:t>
+                      </a:r>
+                    </a:p>
+                  </a:txBody>
+                  <a:tcPr marL="73152" marR="73152" marT="27432" marB="27432" anchor="ctr">
+                    <a:noFill/>
+                  </a:tcPr>
+                </a:tc>
+              </a:tr>
+              <a:tr h="566928">
+                <a:tc>
+                  <a:txBody>
+                    <a:bodyPr/>
+                    <a:lstStyle/>
+                    <a:p>
+                      <a:pPr algn="l"/>
+                      <a:r>
+                        <a:rPr sz="1300" b="1">
+                          <a:solidFill>
+                            <a:srgbClr val="3C3C3B"/>
+                          </a:solidFill>
+                          <a:latin typeface="Aptos"/>
+                        </a:rPr>
+                        <a:t>Total score</a:t>
+                      </a:r>
+                    </a:p>
+                  </a:txBody>
+                  <a:tcPr marL="73152" marR="73152" marT="27432" marB="27432" anchor="ctr">
+                    <a:solidFill>
+                      <a:srgbClr val="F2F2F2"/>
+                    </a:solidFill>
+                  </a:tcPr>
+                </a:tc>
+                <a:tc>
+                  <a:txBody>
+                    <a:bodyPr/>
+                    <a:lstStyle/>
+                    <a:p>
+                      <a:pPr algn="l"/>
                     </a:p>
                   </a:txBody>
                   <a:tcPr marL="73152" marR="73152" marT="27432" marB="27432" anchor="ctr">
@@ -11094,7 +11182,7 @@
                           </a:solidFill>
                           <a:latin typeface="Aptos"/>
                         </a:rPr>
-                        <a:t>29</a:t>
+                        <a:t>34</a:t>
                       </a:r>
                     </a:p>
                   </a:txBody>
@@ -11117,7 +11205,7 @@
                           </a:solidFill>
                           <a:latin typeface="Aptos"/>
                         </a:rPr>
-                        <a:t>17</a:t>
+                        <a:t>22</a:t>
                       </a:r>
                     </a:p>
                   </a:txBody>
@@ -11161,7 +11249,7 @@
                 </a:solidFill>
                 <a:latin typeface="Aptos"/>
               </a:rPr>
-              <a:t>Points are the model's own score on the MEKH 2026 bands (Kiírás Annex 3-4). Overbuild (ÖSZ-3), BESS (ÖSZ-4) and brownfield (ÖSZ-7) are not available at Bana. The municipal one-off is paid at COD.</a:t>
+              <a:t>Points are the model's own score on the MEKH 2026 bands (Kiírás Annex 3-4). BESS (ÖSZ-4) and brownfield (ÖSZ-7) are not available at Bana. Build shortfall 8.3% against the commitment, inside the 10% tolerance (GYIK 28/30). The municipal one-off is paid at COD.</a:t>
             </a:r>
           </a:p>
           <a:p>
@@ -11216,7 +11304,7 @@
           <a:lstStyle/>
           <a:p>
             <a:r>
-              <a:t>Uses to COD of €83.4m with European turbines (€76.0m Chinese); senior debt funds 73% (64%) and FEP the rest</a:t>
+              <a:t>Uses to COD of €88.8m with European turbines (€80.8m Chinese); senior debt funds 73% (64%) and FEP the rest</a:t>
             </a:r>
           </a:p>
         </p:txBody>
@@ -11560,7 +11648,7 @@
                 </a:solidFill>
                 <a:latin typeface="Aptos"/>
               </a:rPr>
-              <a:t>A €0.28m bid guarantee at the bid; after the award a €1.39m PB guarantee and €0.62m of TSO cash; the €8.2m connection fees fall due at the HCSSZ, 08‑Jan‑29.</a:t>
+              <a:t>A €0.33m bid guarantee at the bid; after the award a €1.67m PB guarantee and €0.62m of TSO cash; the €8.2m connection fees fall due at the HCSSZ, 08‑Jan‑29.</a:t>
             </a:r>
           </a:p>
         </p:txBody>
@@ -11833,7 +11921,7 @@
                           </a:solidFill>
                           <a:latin typeface="Aptos"/>
                         </a:rPr>
-                        <a:t>0.9</a:t>
+                        <a:t>1.0</a:t>
                       </a:r>
                     </a:p>
                   </a:txBody>
@@ -11854,7 +11942,7 @@
                           </a:solidFill>
                           <a:latin typeface="Aptos"/>
                         </a:rPr>
-                        <a:t>0.9</a:t>
+                        <a:t>1.0</a:t>
                       </a:r>
                     </a:p>
                   </a:txBody>
@@ -11923,7 +12011,7 @@
                           </a:solidFill>
                           <a:latin typeface="Aptos"/>
                         </a:rPr>
-                        <a:t>62.7</a:t>
+                        <a:t>67.8</a:t>
                       </a:r>
                     </a:p>
                   </a:txBody>
@@ -11944,7 +12032,7 @@
                           </a:solidFill>
                           <a:latin typeface="Aptos"/>
                         </a:rPr>
-                        <a:t>56.2</a:t>
+                        <a:t>60.7</a:t>
                       </a:r>
                     </a:p>
                   </a:txBody>
@@ -12193,7 +12281,7 @@
                           </a:solidFill>
                           <a:latin typeface="Aptos"/>
                         </a:rPr>
-                        <a:t>4.4</a:t>
+                        <a:t>4.7</a:t>
                       </a:r>
                     </a:p>
                   </a:txBody>
@@ -12214,7 +12302,7 @@
                           </a:solidFill>
                           <a:latin typeface="Aptos"/>
                         </a:rPr>
-                        <a:t>3.5</a:t>
+                        <a:t>3.7</a:t>
                       </a:r>
                     </a:p>
                   </a:txBody>
@@ -12373,7 +12461,7 @@
                           </a:solidFill>
                           <a:latin typeface="Aptos"/>
                         </a:rPr>
-                        <a:t>83.4</a:t>
+                        <a:t>88.8</a:t>
                       </a:r>
                     </a:p>
                   </a:txBody>
@@ -12396,7 +12484,7 @@
                           </a:solidFill>
                           <a:latin typeface="Aptos"/>
                         </a:rPr>
-                        <a:t>76.0</a:t>
+                        <a:t>80.8</a:t>
                       </a:r>
                     </a:p>
                   </a:txBody>
@@ -12467,7 +12555,7 @@
                           </a:solidFill>
                           <a:latin typeface="Aptos"/>
                         </a:rPr>
-                        <a:t>60.9</a:t>
+                        <a:t>65.1</a:t>
                       </a:r>
                     </a:p>
                   </a:txBody>
@@ -12488,7 +12576,7 @@
                           </a:solidFill>
                           <a:latin typeface="Aptos"/>
                         </a:rPr>
-                        <a:t>48.5</a:t>
+                        <a:t>51.8</a:t>
                       </a:r>
                     </a:p>
                   </a:txBody>
@@ -12557,7 +12645,7 @@
                           </a:solidFill>
                           <a:latin typeface="Aptos"/>
                         </a:rPr>
-                        <a:t>22.5</a:t>
+                        <a:t>23.8</a:t>
                       </a:r>
                     </a:p>
                   </a:txBody>
@@ -12580,7 +12668,7 @@
                           </a:solidFill>
                           <a:latin typeface="Aptos"/>
                         </a:rPr>
-                        <a:t>27.5</a:t>
+                        <a:t>29.1</a:t>
                       </a:r>
                     </a:p>
                   </a:txBody>
@@ -12651,7 +12739,7 @@
                           </a:solidFill>
                           <a:latin typeface="Aptos"/>
                         </a:rPr>
-                        <a:t>23.8</a:t>
+                        <a:t>25.1</a:t>
                       </a:r>
                     </a:p>
                   </a:txBody>
@@ -12672,7 +12760,7 @@
                           </a:solidFill>
                           <a:latin typeface="Aptos"/>
                         </a:rPr>
-                        <a:t>28.5</a:t>
+                        <a:t>30.1</a:t>
                       </a:r>
                     </a:p>
                   </a:txBody>
@@ -12953,7 +13041,7 @@
                           </a:solidFill>
                           <a:latin typeface="Aptos"/>
                         </a:rPr>
-                        <a:t>0.28</a:t>
+                        <a:t>0.33</a:t>
                       </a:r>
                     </a:p>
                   </a:txBody>
@@ -13043,7 +13131,7 @@
                           </a:solidFill>
                           <a:latin typeface="Aptos"/>
                         </a:rPr>
-                        <a:t>1.39</a:t>
+                        <a:t>1.67</a:t>
                       </a:r>
                     </a:p>
                   </a:txBody>
@@ -13403,7 +13491,7 @@
                           </a:solidFill>
                           <a:latin typeface="Aptos"/>
                         </a:rPr>
-                        <a:t>0.31</a:t>
+                        <a:t>0.37</a:t>
                       </a:r>
                     </a:p>
                   </a:txBody>
@@ -13521,7 +13609,7 @@
           <a:lstStyle/>
           <a:p>
             <a:r>
-              <a:t>A sale at COD turns €22.5m of equity into €61.1m (2.71x); holding earns 12.2% at a 1.58x DSCR (European)</a:t>
+              <a:t>A sale at COD turns €23.8m of equity into €68.6m (2.89x); holding earns 12.9% at a 1.62x DSCR (European)</a:t>
             </a:r>
           </a:p>
         </p:txBody>
@@ -13865,7 +13953,7 @@
                 </a:solidFill>
                 <a:latin typeface="Aptos"/>
               </a:rPr>
-              <a:t>With Chinese turbines the sale returns 46.8% and the hold 12.8%; debt is sized at 80% / 70% of construction cost.</a:t>
+              <a:t>With Chinese turbines the sale returns 51.8% and the hold 13.5%; debt is sized at 80% / 70% of construction cost.</a:t>
             </a:r>
           </a:p>
         </p:txBody>
@@ -14096,7 +14184,7 @@
                           </a:solidFill>
                           <a:latin typeface="Aptos"/>
                         </a:rPr>
-                        <a:t>122.5</a:t>
+                        <a:t>134.1</a:t>
                       </a:r>
                     </a:p>
                   </a:txBody>
@@ -14117,7 +14205,7 @@
                           </a:solidFill>
                           <a:latin typeface="Aptos"/>
                         </a:rPr>
-                        <a:t>105.0</a:t>
+                        <a:t>115.0</a:t>
                       </a:r>
                     </a:p>
                   </a:txBody>
@@ -14228,7 +14316,7 @@
                           </a:solidFill>
                           <a:latin typeface="Aptos"/>
                         </a:rPr>
-                        <a:t>(60.9)</a:t>
+                        <a:t>(65.1)</a:t>
                       </a:r>
                     </a:p>
                   </a:txBody>
@@ -14249,7 +14337,7 @@
                           </a:solidFill>
                           <a:latin typeface="Aptos"/>
                         </a:rPr>
-                        <a:t>(48.5)</a:t>
+                        <a:t>(51.8)</a:t>
                       </a:r>
                     </a:p>
                   </a:txBody>
@@ -14360,7 +14448,7 @@
                           </a:solidFill>
                           <a:latin typeface="Aptos"/>
                         </a:rPr>
-                        <a:t>61.1</a:t>
+                        <a:t>68.6</a:t>
                       </a:r>
                     </a:p>
                   </a:txBody>
@@ -14381,7 +14469,7 @@
                           </a:solidFill>
                           <a:latin typeface="Aptos"/>
                         </a:rPr>
-                        <a:t>56.0</a:t>
+                        <a:t>62.7</a:t>
                       </a:r>
                     </a:p>
                   </a:txBody>
@@ -14492,7 +14580,7 @@
                           </a:solidFill>
                           <a:latin typeface="Aptos"/>
                         </a:rPr>
-                        <a:t>22.5</a:t>
+                        <a:t>23.8</a:t>
                       </a:r>
                     </a:p>
                   </a:txBody>
@@ -14513,7 +14601,7 @@
                           </a:solidFill>
                           <a:latin typeface="Aptos"/>
                         </a:rPr>
-                        <a:t>27.5</a:t>
+                        <a:t>29.1</a:t>
                       </a:r>
                     </a:p>
                   </a:txBody>
@@ -14534,7 +14622,7 @@
                           </a:solidFill>
                           <a:latin typeface="Aptos"/>
                         </a:rPr>
-                        <a:t>23.8</a:t>
+                        <a:t>25.1</a:t>
                       </a:r>
                     </a:p>
                   </a:txBody>
@@ -14555,7 +14643,7 @@
                           </a:solidFill>
                           <a:latin typeface="Aptos"/>
                         </a:rPr>
-                        <a:t>28.5</a:t>
+                        <a:t>30.1</a:t>
                       </a:r>
                     </a:p>
                   </a:txBody>
@@ -14624,7 +14712,7 @@
                           </a:solidFill>
                           <a:latin typeface="Aptos"/>
                         </a:rPr>
-                        <a:t>38.6</a:t>
+                        <a:t>44.8</a:t>
                       </a:r>
                     </a:p>
                   </a:txBody>
@@ -14645,7 +14733,7 @@
                           </a:solidFill>
                           <a:latin typeface="Aptos"/>
                         </a:rPr>
-                        <a:t>28.5</a:t>
+                        <a:t>33.6</a:t>
                       </a:r>
                     </a:p>
                   </a:txBody>
@@ -14666,7 +14754,7 @@
                           </a:solidFill>
                           <a:latin typeface="Aptos"/>
                         </a:rPr>
-                        <a:t>125.5</a:t>
+                        <a:t>140.8</a:t>
                       </a:r>
                     </a:p>
                   </a:txBody>
@@ -14687,7 +14775,7 @@
                           </a:solidFill>
                           <a:latin typeface="Aptos"/>
                         </a:rPr>
-                        <a:t>138.1</a:t>
+                        <a:t>154.4</a:t>
                       </a:r>
                     </a:p>
                   </a:txBody>
@@ -14756,7 +14844,7 @@
                           </a:solidFill>
                           <a:latin typeface="Aptos"/>
                         </a:rPr>
-                        <a:t>61.0%</a:t>
+                        <a:t>66.4%</a:t>
                       </a:r>
                     </a:p>
                   </a:txBody>
@@ -14779,7 +14867,7 @@
                           </a:solidFill>
                           <a:latin typeface="Aptos"/>
                         </a:rPr>
-                        <a:t>46.8%</a:t>
+                        <a:t>51.8%</a:t>
                       </a:r>
                     </a:p>
                   </a:txBody>
@@ -14802,7 +14890,7 @@
                           </a:solidFill>
                           <a:latin typeface="Aptos"/>
                         </a:rPr>
-                        <a:t>12.2%</a:t>
+                        <a:t>12.9%</a:t>
                       </a:r>
                     </a:p>
                   </a:txBody>
@@ -14825,7 +14913,7 @@
                           </a:solidFill>
                           <a:latin typeface="Aptos"/>
                         </a:rPr>
-                        <a:t>12.8%</a:t>
+                        <a:t>13.5%</a:t>
                       </a:r>
                     </a:p>
                   </a:txBody>
@@ -14896,7 +14984,7 @@
                           </a:solidFill>
                           <a:latin typeface="Aptos"/>
                         </a:rPr>
-                        <a:t>2.71x</a:t>
+                        <a:t>2.89x</a:t>
                       </a:r>
                     </a:p>
                   </a:txBody>
@@ -14917,7 +15005,7 @@
                           </a:solidFill>
                           <a:latin typeface="Aptos"/>
                         </a:rPr>
-                        <a:t>2.03x</a:t>
+                        <a:t>2.16x</a:t>
                       </a:r>
                     </a:p>
                   </a:txBody>
@@ -14938,7 +15026,7 @@
                           </a:solidFill>
                           <a:latin typeface="Aptos"/>
                         </a:rPr>
-                        <a:t>6.27x</a:t>
+                        <a:t>6.60x</a:t>
                       </a:r>
                     </a:p>
                   </a:txBody>
@@ -14959,7 +15047,7 @@
                           </a:solidFill>
                           <a:latin typeface="Aptos"/>
                         </a:rPr>
-                        <a:t>5.84x</a:t>
+                        <a:t>6.12x</a:t>
                       </a:r>
                     </a:p>
                   </a:txBody>
@@ -15028,7 +15116,7 @@
                           </a:solidFill>
                           <a:latin typeface="Aptos"/>
                         </a:rPr>
-                        <a:t>26.5</a:t>
+                        <a:t>31.1</a:t>
                       </a:r>
                     </a:p>
                   </a:txBody>
@@ -15049,7 +15137,7 @@
                           </a:solidFill>
                           <a:latin typeface="Aptos"/>
                         </a:rPr>
-                        <a:t>18.6</a:t>
+                        <a:t>22.4</a:t>
                       </a:r>
                     </a:p>
                   </a:txBody>
@@ -15070,7 +15158,7 @@
                           </a:solidFill>
                           <a:latin typeface="Aptos"/>
                         </a:rPr>
-                        <a:t>13.1</a:t>
+                        <a:t>16.2</a:t>
                       </a:r>
                     </a:p>
                   </a:txBody>
@@ -15091,7 +15179,7 @@
                           </a:solidFill>
                           <a:latin typeface="Aptos"/>
                         </a:rPr>
-                        <a:t>16.3</a:t>
+                        <a:t>19.6</a:t>
                       </a:r>
                     </a:p>
                   </a:txBody>
@@ -15202,7 +15290,7 @@
                           </a:solidFill>
                           <a:latin typeface="Aptos"/>
                         </a:rPr>
-                        <a:t>8.8%</a:t>
+                        <a:t>9.1%</a:t>
                       </a:r>
                     </a:p>
                   </a:txBody>
@@ -15223,7 +15311,7 @@
                           </a:solidFill>
                           <a:latin typeface="Aptos"/>
                         </a:rPr>
-                        <a:t>9.6%</a:t>
+                        <a:t>10.0%</a:t>
                       </a:r>
                     </a:p>
                   </a:txBody>
@@ -15334,7 +15422,7 @@
                           </a:solidFill>
                           <a:latin typeface="Aptos"/>
                         </a:rPr>
-                        <a:t>1.58x</a:t>
+                        <a:t>1.62x</a:t>
                       </a:r>
                     </a:p>
                   </a:txBody>
@@ -15355,7 +15443,7 @@
                           </a:solidFill>
                           <a:latin typeface="Aptos"/>
                         </a:rPr>
-                        <a:t>1.97x</a:t>
+                        <a:t>2.02x</a:t>
                       </a:r>
                     </a:p>
                   </a:txBody>
@@ -15466,7 +15554,7 @@
                           </a:solidFill>
                           <a:latin typeface="Aptos"/>
                         </a:rPr>
-                        <a:t>(12.5)</a:t>
+                        <a:t>(13.9)</a:t>
                       </a:r>
                     </a:p>
                   </a:txBody>
@@ -15487,7 +15575,7 @@
                           </a:solidFill>
                           <a:latin typeface="Aptos"/>
                         </a:rPr>
-                        <a:t>(13.7)</a:t>
+                        <a:t>(15.3)</a:t>
                       </a:r>
                     </a:p>
                   </a:txBody>
@@ -15591,7 +15679,7 @@
                 </a:solidFill>
                 <a:latin typeface="Aptos"/>
               </a:rPr>
-              <a:t>1.20x target DSCR over 18 years, 5.0% fixed; sized at the lower of the DSCR capacity and 80% / 70% of cost; 76% / 61% of the DSCR capacity is used.</a:t>
+              <a:t>1.20x target DSCR over 18 years, 5.0% fixed; sized at the lower of the DSCR capacity and 80% / 70% of cost; 74% / 59% of the DSCR capacity is used.</a:t>
             </a:r>
           </a:p>
           <a:p>
@@ -15650,7 +15738,7 @@
                 </a:solidFill>
                 <a:latin typeface="Aptos"/>
               </a:rPr>
-              <a:t>Sale price 2,450 / 2,100 k€ per MW; the buyer takes the SPV with its debt and funds the DSRA. Hold: PPA 90 €/MWh, 30-year life; DSRA of 6 months funded at COD. HIPA 2% and the innovation contribution on revenue. NPV at 8%.</a:t>
+              <a:t>Sale price 2,450 / 2,100 k€ per built MW, less the 0.45% bottleneck loss; the buyer takes the SPV with its debt and funds the DSRA. Hold: PPA 90 €/MWh, 30-year life; DSRA of 6 months funded at COD. HIPA 2% and the innovation contribution on revenue. NPV at 8%.</a:t>
             </a:r>
           </a:p>
           <a:p>
@@ -15705,7 +15793,7 @@
           <a:lstStyle/>
           <a:p>
             <a:r>
-              <a:t>A lower COD price is the largest risk to the sale (46.9%); yield and PPA price drive the hold (9.6% / 9.3%)</a:t>
+              <a:t>A lower COD price is the largest risk to the sale (52.3%); yield and PPA price drive the hold (10.2% / 9.9%)</a:t>
             </a:r>
           </a:p>
         </p:txBody>
@@ -16281,7 +16369,7 @@
                           </a:solidFill>
                           <a:latin typeface="Aptos"/>
                         </a:rPr>
-                        <a:t>61.0%</a:t>
+                        <a:t>66.4%</a:t>
                       </a:r>
                     </a:p>
                   </a:txBody>
@@ -16304,7 +16392,7 @@
                           </a:solidFill>
                           <a:latin typeface="Aptos"/>
                         </a:rPr>
-                        <a:t>46.8%</a:t>
+                        <a:t>51.8%</a:t>
                       </a:r>
                     </a:p>
                   </a:txBody>
@@ -16327,7 +16415,7 @@
                           </a:solidFill>
                           <a:latin typeface="Aptos"/>
                         </a:rPr>
-                        <a:t>12.2%</a:t>
+                        <a:t>12.9%</a:t>
                       </a:r>
                     </a:p>
                   </a:txBody>
@@ -16350,7 +16438,7 @@
                           </a:solidFill>
                           <a:latin typeface="Aptos"/>
                         </a:rPr>
-                        <a:t>12.8%</a:t>
+                        <a:t>13.5%</a:t>
                       </a:r>
                     </a:p>
                   </a:txBody>
@@ -16373,7 +16461,7 @@
                           </a:solidFill>
                           <a:latin typeface="Aptos"/>
                         </a:rPr>
-                        <a:t>1.58x</a:t>
+                        <a:t>1.62x</a:t>
                       </a:r>
                     </a:p>
                   </a:txBody>
@@ -16396,7 +16484,7 @@
                           </a:solidFill>
                           <a:latin typeface="Aptos"/>
                         </a:rPr>
-                        <a:t>1.97x</a:t>
+                        <a:t>2.02x</a:t>
                       </a:r>
                     </a:p>
                   </a:txBody>
@@ -16444,7 +16532,7 @@
                           </a:solidFill>
                           <a:latin typeface="Aptos"/>
                         </a:rPr>
-                        <a:t>46.9%</a:t>
+                        <a:t>52.3%</a:t>
                       </a:r>
                     </a:p>
                   </a:txBody>
@@ -16465,7 +16553,7 @@
                           </a:solidFill>
                           <a:latin typeface="Aptos"/>
                         </a:rPr>
-                        <a:t>33.0%</a:t>
+                        <a:t>38.0%</a:t>
                       </a:r>
                     </a:p>
                   </a:txBody>
@@ -16486,7 +16574,7 @@
                           </a:solidFill>
                           <a:latin typeface="Aptos"/>
                         </a:rPr>
-                        <a:t>12.2%</a:t>
+                        <a:t>12.9%</a:t>
                       </a:r>
                     </a:p>
                   </a:txBody>
@@ -16507,7 +16595,7 @@
                           </a:solidFill>
                           <a:latin typeface="Aptos"/>
                         </a:rPr>
-                        <a:t>12.8%</a:t>
+                        <a:t>13.5%</a:t>
                       </a:r>
                     </a:p>
                   </a:txBody>
@@ -16528,7 +16616,7 @@
                           </a:solidFill>
                           <a:latin typeface="Aptos"/>
                         </a:rPr>
-                        <a:t>1.58x</a:t>
+                        <a:t>1.62x</a:t>
                       </a:r>
                     </a:p>
                   </a:txBody>
@@ -16549,7 +16637,7 @@
                           </a:solidFill>
                           <a:latin typeface="Aptos"/>
                         </a:rPr>
-                        <a:t>1.97x</a:t>
+                        <a:t>2.02x</a:t>
                       </a:r>
                     </a:p>
                   </a:txBody>
@@ -16595,7 +16683,7 @@
                           </a:solidFill>
                           <a:latin typeface="Aptos"/>
                         </a:rPr>
-                        <a:t>57.0%</a:t>
+                        <a:t>62.3%</a:t>
                       </a:r>
                     </a:p>
                   </a:txBody>
@@ -16616,7 +16704,7 @@
                           </a:solidFill>
                           <a:latin typeface="Aptos"/>
                         </a:rPr>
-                        <a:t>43.0%</a:t>
+                        <a:t>47.9%</a:t>
                       </a:r>
                     </a:p>
                   </a:txBody>
@@ -16637,7 +16725,7 @@
                           </a:solidFill>
                           <a:latin typeface="Aptos"/>
                         </a:rPr>
-                        <a:t>11.5%</a:t>
+                        <a:t>12.1%</a:t>
                       </a:r>
                     </a:p>
                   </a:txBody>
@@ -16658,7 +16746,7 @@
                           </a:solidFill>
                           <a:latin typeface="Aptos"/>
                         </a:rPr>
-                        <a:t>12.2%</a:t>
+                        <a:t>12.8%</a:t>
                       </a:r>
                     </a:p>
                   </a:txBody>
@@ -16679,7 +16767,7 @@
                           </a:solidFill>
                           <a:latin typeface="Aptos"/>
                         </a:rPr>
-                        <a:t>1.52x</a:t>
+                        <a:t>1.56x</a:t>
                       </a:r>
                     </a:p>
                   </a:txBody>
@@ -16700,7 +16788,7 @@
                           </a:solidFill>
                           <a:latin typeface="Aptos"/>
                         </a:rPr>
-                        <a:t>1.90x</a:t>
+                        <a:t>1.95x</a:t>
                       </a:r>
                     </a:p>
                   </a:txBody>
@@ -16746,7 +16834,7 @@
                           </a:solidFill>
                           <a:latin typeface="Aptos"/>
                         </a:rPr>
-                        <a:t>61.0%</a:t>
+                        <a:t>66.4%</a:t>
                       </a:r>
                     </a:p>
                   </a:txBody>
@@ -16767,7 +16855,7 @@
                           </a:solidFill>
                           <a:latin typeface="Aptos"/>
                         </a:rPr>
-                        <a:t>46.8%</a:t>
+                        <a:t>51.8%</a:t>
                       </a:r>
                     </a:p>
                   </a:txBody>
@@ -16788,7 +16876,7 @@
                           </a:solidFill>
                           <a:latin typeface="Aptos"/>
                         </a:rPr>
-                        <a:t>9.6%</a:t>
+                        <a:t>10.2%</a:t>
                       </a:r>
                     </a:p>
                   </a:txBody>
@@ -16809,7 +16897,7 @@
                           </a:solidFill>
                           <a:latin typeface="Aptos"/>
                         </a:rPr>
-                        <a:t>10.5%</a:t>
+                        <a:t>11.1%</a:t>
                       </a:r>
                     </a:p>
                   </a:txBody>
@@ -16830,7 +16918,7 @@
                           </a:solidFill>
                           <a:latin typeface="Aptos"/>
                         </a:rPr>
-                        <a:t>1.40x</a:t>
+                        <a:t>1.44x</a:t>
                       </a:r>
                     </a:p>
                   </a:txBody>
@@ -16851,7 +16939,7 @@
                           </a:solidFill>
                           <a:latin typeface="Aptos"/>
                         </a:rPr>
-                        <a:t>1.75x</a:t>
+                        <a:t>1.79x</a:t>
                       </a:r>
                     </a:p>
                   </a:txBody>
@@ -16897,7 +16985,7 @@
                           </a:solidFill>
                           <a:latin typeface="Aptos"/>
                         </a:rPr>
-                        <a:t>61.0%</a:t>
+                        <a:t>66.4%</a:t>
                       </a:r>
                     </a:p>
                   </a:txBody>
@@ -16918,7 +17006,7 @@
                           </a:solidFill>
                           <a:latin typeface="Aptos"/>
                         </a:rPr>
-                        <a:t>46.8%</a:t>
+                        <a:t>51.8%</a:t>
                       </a:r>
                     </a:p>
                   </a:txBody>
@@ -16939,7 +17027,7 @@
                           </a:solidFill>
                           <a:latin typeface="Aptos"/>
                         </a:rPr>
-                        <a:t>9.3%</a:t>
+                        <a:t>9.9%</a:t>
                       </a:r>
                     </a:p>
                   </a:txBody>
@@ -16960,7 +17048,7 @@
                           </a:solidFill>
                           <a:latin typeface="Aptos"/>
                         </a:rPr>
-                        <a:t>10.2%</a:t>
+                        <a:t>10.8%</a:t>
                       </a:r>
                     </a:p>
                   </a:txBody>
@@ -16981,7 +17069,7 @@
                           </a:solidFill>
                           <a:latin typeface="Aptos"/>
                         </a:rPr>
-                        <a:t>1.38x</a:t>
+                        <a:t>1.42x</a:t>
                       </a:r>
                     </a:p>
                   </a:txBody>
@@ -17002,7 +17090,7 @@
                           </a:solidFill>
                           <a:latin typeface="Aptos"/>
                         </a:rPr>
-                        <a:t>1.72x</a:t>
+                        <a:t>1.77x</a:t>
                       </a:r>
                     </a:p>
                   </a:txBody>
@@ -17025,7 +17113,7 @@
                           </a:solidFill>
                           <a:latin typeface="Aptos"/>
                         </a:rPr>
-                        <a:t>Purchase +10%</a:t>
+                        <a:t>Full PB call</a:t>
                       </a:r>
                     </a:p>
                   </a:txBody>
@@ -17048,7 +17136,7 @@
                           </a:solidFill>
                           <a:latin typeface="Aptos"/>
                         </a:rPr>
-                        <a:t>58.3%</a:t>
+                        <a:t>64.7%</a:t>
                       </a:r>
                     </a:p>
                   </a:txBody>
@@ -17069,7 +17157,7 @@
                           </a:solidFill>
                           <a:latin typeface="Aptos"/>
                         </a:rPr>
-                        <a:t>44.6%</a:t>
+                        <a:t>50.0%</a:t>
                       </a:r>
                     </a:p>
                   </a:txBody>
@@ -17090,7 +17178,7 @@
                           </a:solidFill>
                           <a:latin typeface="Aptos"/>
                         </a:rPr>
-                        <a:t>12.0%</a:t>
+                        <a:t>12.4%</a:t>
                       </a:r>
                     </a:p>
                   </a:txBody>
@@ -17111,7 +17199,7 @@
                           </a:solidFill>
                           <a:latin typeface="Aptos"/>
                         </a:rPr>
-                        <a:t>12.6%</a:t>
+                        <a:t>13.0%</a:t>
                       </a:r>
                     </a:p>
                   </a:txBody>
@@ -17132,7 +17220,7 @@
                           </a:solidFill>
                           <a:latin typeface="Aptos"/>
                         </a:rPr>
-                        <a:t>1.59x</a:t>
+                        <a:t>1.62x</a:t>
                       </a:r>
                     </a:p>
                   </a:txBody>
@@ -17153,7 +17241,7 @@
                           </a:solidFill>
                           <a:latin typeface="Aptos"/>
                         </a:rPr>
-                        <a:t>1.97x</a:t>
+                        <a:t>2.02x</a:t>
                       </a:r>
                     </a:p>
                   </a:txBody>
@@ -17199,7 +17287,7 @@
                           </a:solidFill>
                           <a:latin typeface="Aptos"/>
                         </a:rPr>
-                        <a:t>60.4%</a:t>
+                        <a:t>65.7%</a:t>
                       </a:r>
                     </a:p>
                   </a:txBody>
@@ -17220,7 +17308,7 @@
                           </a:solidFill>
                           <a:latin typeface="Aptos"/>
                         </a:rPr>
-                        <a:t>46.2%</a:t>
+                        <a:t>51.3%</a:t>
                       </a:r>
                     </a:p>
                   </a:txBody>
@@ -17241,7 +17329,7 @@
                           </a:solidFill>
                           <a:latin typeface="Aptos"/>
                         </a:rPr>
-                        <a:t>11.2%</a:t>
+                        <a:t>11.9%</a:t>
                       </a:r>
                     </a:p>
                   </a:txBody>
@@ -17262,7 +17350,7 @@
                           </a:solidFill>
                           <a:latin typeface="Aptos"/>
                         </a:rPr>
-                        <a:t>12.1%</a:t>
+                        <a:t>12.7%</a:t>
                       </a:r>
                     </a:p>
                   </a:txBody>
@@ -17283,7 +17371,7 @@
                           </a:solidFill>
                           <a:latin typeface="Aptos"/>
                         </a:rPr>
-                        <a:t>1.46x</a:t>
+                        <a:t>1.50x</a:t>
                       </a:r>
                     </a:p>
                   </a:txBody>
@@ -17304,7 +17392,7 @@
                           </a:solidFill>
                           <a:latin typeface="Aptos"/>
                         </a:rPr>
-                        <a:t>1.82x</a:t>
+                        <a:t>1.86x</a:t>
                       </a:r>
                     </a:p>
                   </a:txBody>
@@ -17350,7 +17438,7 @@
                           </a:solidFill>
                           <a:latin typeface="Aptos"/>
                         </a:rPr>
-                        <a:t>57.1%</a:t>
+                        <a:t>62.8%</a:t>
                       </a:r>
                     </a:p>
                   </a:txBody>
@@ -17371,7 +17459,7 @@
                           </a:solidFill>
                           <a:latin typeface="Aptos"/>
                         </a:rPr>
-                        <a:t>46.8%</a:t>
+                        <a:t>51.8%</a:t>
                       </a:r>
                     </a:p>
                   </a:txBody>
@@ -17392,7 +17480,7 @@
                           </a:solidFill>
                           <a:latin typeface="Aptos"/>
                         </a:rPr>
-                        <a:t>10.0%</a:t>
+                        <a:t>10.5%</a:t>
                       </a:r>
                     </a:p>
                   </a:txBody>
@@ -17413,7 +17501,7 @@
                           </a:solidFill>
                           <a:latin typeface="Aptos"/>
                         </a:rPr>
-                        <a:t>11.2%</a:t>
+                        <a:t>11.7%</a:t>
                       </a:r>
                     </a:p>
                   </a:txBody>
@@ -17455,7 +17543,7 @@
                           </a:solidFill>
                           <a:latin typeface="Aptos"/>
                         </a:rPr>
-                        <a:t>1.30x</a:t>
+                        <a:t>1.33x</a:t>
                       </a:r>
                     </a:p>
                   </a:txBody>
@@ -17477,7 +17565,7 @@
         <p:spPr>
           <a:xfrm>
             <a:off x="14127480" y="2240280"/>
-            <a:ext cx="4069080" cy="6035040"/>
+            <a:ext cx="4069080" cy="4937760"/>
           </a:xfrm>
           <a:prstGeom prst="rect">
             <a:avLst/>
@@ -17557,6 +17645,31 @@
                 </a:solidFill>
                 <a:latin typeface="Aptos"/>
               </a:rPr>
+              <a:t>Overbuild: </a:t>
+            </a:r>
+            <a:r>
+              <a:rPr sz="1300" b="0">
+                <a:solidFill>
+                  <a:srgbClr val="3C3C3B"/>
+                </a:solidFill>
+                <a:latin typeface="Aptos"/>
+              </a:rPr>
+              <a:t>55 MW built against 60 MW committed. Pro rata (GYIK 28/30) there is no PB call; if the full-call reading (GYIK 72) applies, the €1.67m PB is lost: COD IRR 64.7%, hold IRR 12.4% (European).</a:t>
+            </a:r>
+          </a:p>
+          <a:p>
+            <a:pPr algn="l">
+              <a:spcBef>
+                <a:spcPts val="800"/>
+              </a:spcBef>
+            </a:pPr>
+            <a:r>
+              <a:rPr sz="1300" b="1">
+                <a:solidFill>
+                  <a:srgbClr val="3C3C3B"/>
+                </a:solidFill>
+                <a:latin typeface="Aptos"/>
+              </a:rPr>
               <a:t>COD price: </a:t>
             </a:r>
             <a:r>
@@ -17616,7 +17729,7 @@
                 </a:solidFill>
                 <a:latin typeface="Aptos"/>
               </a:rPr>
-              <a:t>a 10-year tenor makes the DSCR bind and cuts the European hold IRR to 10.0%.</a:t>
+              <a:t>a 10-year tenor makes the DSCR bind and cuts the European hold IRR to 10.5%.</a:t>
             </a:r>
           </a:p>
         </p:txBody>

</xml_diff>

<commit_message>
Add a 20% BESS to the Bana bid; municipal 50 k€/MW, community 3 €/MWh
Co-Authored-By: Claude Opus 5.5 <noreply@anthropic.com>
Claude-Session: https://claude.ai/code/session_01AWS1t9WtpkQHcCU1WceGZT
</commit_message>
<xml_diff>
--- a/projects/bana/out/Bana_IC.pptx
+++ b/projects/bana/out/Bana_IC.pptx
@@ -246,10 +246,10 @@
                 <c:formatCode>0.0%</c:formatCode>
                 <c:ptCount val="2"/>
                 <c:pt idx="0">
-                  <c:v>0.663535311491085</c:v>
+                  <c:v>0.624343544593479</c:v>
                 </c:pt>
                 <c:pt idx="1">
-                  <c:v>0.129381611423992</c:v>
+                  <c:v>0.119964137616349</c:v>
                 </c:pt>
               </c:numCache>
             </c:numRef>
@@ -296,10 +296,10 @@
                 <c:formatCode>0.0%</c:formatCode>
                 <c:ptCount val="2"/>
                 <c:pt idx="0">
-                  <c:v>0.518123392285528</c:v>
+                  <c:v>0.47383720841244</c:v>
                 </c:pt>
                 <c:pt idx="1">
-                  <c:v>0.134805776932951</c:v>
+                  <c:v>0.12592370397166</c:v>
                 </c:pt>
               </c:numCache>
             </c:numRef>
@@ -6030,7 +6030,7 @@
           <a:lstStyle/>
           <a:p>
             <a:r>
-              <a:t>At €4.50m, Bana returns 66.4% (European) / 51.8% (Chinese) on a sale at COD and 12.9% / 13.5% if held</a:t>
+              <a:t>At €4.50m, Bana returns 62.4% (European) / 47.4% (Chinese) on a sale at COD and 12.0% / 12.6% if held</a:t>
             </a:r>
           </a:p>
         </p:txBody>
@@ -6374,7 +6374,7 @@
                 </a:solidFill>
                 <a:latin typeface="Aptos"/>
               </a:rPr>
-              <a:t>FEP funds €23.8m of equity to COD (€29.1m Chinese) and bids 34 points (22 Chinese) into the 30 October tender; the European route needs a permit amendment.</a:t>
+              <a:t>FEP funds €24.6m of equity to COD (€30.2m Chinese) and bids 59.5 points (47.5 Chinese) into the 30 October tender; the European route needs a permit amendment.</a:t>
             </a:r>
           </a:p>
         </p:txBody>
@@ -6679,7 +6679,7 @@
                           </a:solidFill>
                           <a:latin typeface="Aptos"/>
                         </a:rPr>
-                        <a:t>34</a:t>
+                        <a:t>59.5</a:t>
                       </a:r>
                     </a:p>
                   </a:txBody>
@@ -6700,7 +6700,7 @@
                           </a:solidFill>
                           <a:latin typeface="Aptos"/>
                         </a:rPr>
-                        <a:t>22</a:t>
+                        <a:t>47.5</a:t>
                       </a:r>
                     </a:p>
                   </a:txBody>
@@ -6769,7 +6769,7 @@
                           </a:solidFill>
                           <a:latin typeface="Aptos"/>
                         </a:rPr>
-                        <a:t>23.8</a:t>
+                        <a:t>24.6</a:t>
                       </a:r>
                     </a:p>
                   </a:txBody>
@@ -6790,7 +6790,7 @@
                           </a:solidFill>
                           <a:latin typeface="Aptos"/>
                         </a:rPr>
-                        <a:t>29.1</a:t>
+                        <a:t>30.2</a:t>
                       </a:r>
                     </a:p>
                   </a:txBody>
@@ -6926,7 +6926,7 @@
                           </a:solidFill>
                           <a:latin typeface="Aptos"/>
                         </a:rPr>
-                        <a:t>44.8</a:t>
+                        <a:t>41.4</a:t>
                       </a:r>
                     </a:p>
                   </a:txBody>
@@ -6947,7 +6947,7 @@
                           </a:solidFill>
                           <a:latin typeface="Aptos"/>
                         </a:rPr>
-                        <a:t>33.6</a:t>
+                        <a:t>30.2</a:t>
                       </a:r>
                     </a:p>
                   </a:txBody>
@@ -7016,7 +7016,7 @@
                           </a:solidFill>
                           <a:latin typeface="Aptos"/>
                         </a:rPr>
-                        <a:t>66.4%</a:t>
+                        <a:t>62.4%</a:t>
                       </a:r>
                     </a:p>
                   </a:txBody>
@@ -7039,7 +7039,7 @@
                           </a:solidFill>
                           <a:latin typeface="Aptos"/>
                         </a:rPr>
-                        <a:t>51.8%</a:t>
+                        <a:t>47.4%</a:t>
                       </a:r>
                     </a:p>
                   </a:txBody>
@@ -7110,7 +7110,7 @@
                           </a:solidFill>
                           <a:latin typeface="Aptos"/>
                         </a:rPr>
-                        <a:t>2.89x</a:t>
+                        <a:t>2.68x</a:t>
                       </a:r>
                     </a:p>
                   </a:txBody>
@@ -7131,7 +7131,7 @@
                           </a:solidFill>
                           <a:latin typeface="Aptos"/>
                         </a:rPr>
-                        <a:t>2.16x</a:t>
+                        <a:t>2.00x</a:t>
                       </a:r>
                     </a:p>
                   </a:txBody>
@@ -7267,7 +7267,7 @@
                           </a:solidFill>
                           <a:latin typeface="Aptos"/>
                         </a:rPr>
-                        <a:t>12.9%</a:t>
+                        <a:t>12.0%</a:t>
                       </a:r>
                     </a:p>
                   </a:txBody>
@@ -7290,7 +7290,7 @@
                           </a:solidFill>
                           <a:latin typeface="Aptos"/>
                         </a:rPr>
-                        <a:t>13.5%</a:t>
+                        <a:t>12.6%</a:t>
                       </a:r>
                     </a:p>
                   </a:txBody>
@@ -7361,7 +7361,7 @@
                           </a:solidFill>
                           <a:latin typeface="Aptos"/>
                         </a:rPr>
-                        <a:t>6.60x</a:t>
+                        <a:t>6.17x</a:t>
                       </a:r>
                     </a:p>
                   </a:txBody>
@@ -7382,7 +7382,7 @@
                           </a:solidFill>
                           <a:latin typeface="Aptos"/>
                         </a:rPr>
-                        <a:t>6.12x</a:t>
+                        <a:t>5.74x</a:t>
                       </a:r>
                     </a:p>
                   </a:txBody>
@@ -7451,7 +7451,7 @@
                           </a:solidFill>
                           <a:latin typeface="Aptos"/>
                         </a:rPr>
-                        <a:t>16.2</a:t>
+                        <a:t>13.5</a:t>
                       </a:r>
                     </a:p>
                   </a:txBody>
@@ -7472,7 +7472,7 @@
                           </a:solidFill>
                           <a:latin typeface="Aptos"/>
                         </a:rPr>
-                        <a:t>19.6</a:t>
+                        <a:t>16.9</a:t>
                       </a:r>
                     </a:p>
                   </a:txBody>
@@ -7541,7 +7541,7 @@
                           </a:solidFill>
                           <a:latin typeface="Aptos"/>
                         </a:rPr>
-                        <a:t>1.62x</a:t>
+                        <a:t>1.55x</a:t>
                       </a:r>
                     </a:p>
                   </a:txBody>
@@ -7562,7 +7562,7 @@
                           </a:solidFill>
                           <a:latin typeface="Aptos"/>
                         </a:rPr>
-                        <a:t>2.02x</a:t>
+                        <a:t>1.93x</a:t>
                       </a:r>
                     </a:p>
                   </a:txBody>
@@ -9492,7 +9492,7 @@
           <a:lstStyle/>
           <a:p>
             <a:r>
-              <a:t>55 MW producing 131.9 GWh a year; the bid scores 34 points with European turbines and 22 with Chinese</a:t>
+              <a:t>55 MW producing 131.9 GWh a year; the bid scores 59.5 points with European turbines and 47.5 with Chinese</a:t>
             </a:r>
           </a:p>
         </p:txBody>
@@ -9836,7 +9836,7 @@
                 </a:solidFill>
                 <a:latin typeface="Aptos"/>
               </a:rPr>
-              <a:t>The bid commits 20% overbuild (60 MW, 5 points) and FEP builds 55 MW, inside the tolerance; European turbines add 12 points but need a permit amendment.</a:t>
+              <a:t>Overbuild 20% (5 points, 55 of 60 MW built, inside the tolerance) and BESS 20% of MVA (7.5 points); European turbines add 12 points but need a permit amendment.</a:t>
             </a:r>
           </a:p>
         </p:txBody>
@@ -9851,7 +9851,7 @@
         </p:nvGraphicFramePr>
         <p:xfrm>
           <a:off x="4498848" y="2240280"/>
-          <a:ext cx="7406640" cy="7077456"/>
+          <a:ext cx="7406640" cy="7196328"/>
         </p:xfrm>
         <a:graphic>
           <a:graphicData uri="http://schemas.openxmlformats.org/drawingml/2006/table">
@@ -9911,7 +9911,7 @@
                   </a:tcPr>
                 </a:tc>
               </a:tr>
-              <a:tr h="502920">
+              <a:tr h="475488">
                 <a:tc>
                   <a:txBody>
                     <a:bodyPr/>
@@ -9950,7 +9950,7 @@
                   </a:tcPr>
                 </a:tc>
               </a:tr>
-              <a:tr h="502920">
+              <a:tr h="475488">
                 <a:tc>
                   <a:txBody>
                     <a:bodyPr/>
@@ -9996,7 +9996,7 @@
                   </a:tcPr>
                 </a:tc>
               </a:tr>
-              <a:tr h="502920">
+              <a:tr h="475488">
                 <a:tc>
                   <a:txBody>
                     <a:bodyPr/>
@@ -10042,7 +10042,53 @@
                   </a:tcPr>
                 </a:tc>
               </a:tr>
-              <a:tr h="502920">
+              <a:tr h="475488">
+                <a:tc>
+                  <a:txBody>
+                    <a:bodyPr/>
+                    <a:lstStyle/>
+                    <a:p>
+                      <a:pPr algn="l"/>
+                      <a:r>
+                        <a:rPr sz="1300" b="0">
+                          <a:solidFill>
+                            <a:srgbClr val="3C3C3B"/>
+                          </a:solidFill>
+                          <a:latin typeface="Aptos"/>
+                        </a:rPr>
+                        <a:t>BESS committed and built</a:t>
+                      </a:r>
+                    </a:p>
+                  </a:txBody>
+                  <a:tcPr marL="73152" marR="73152" marT="27432" marB="27432" anchor="ctr">
+                    <a:solidFill>
+                      <a:srgbClr val="F2F2F2"/>
+                    </a:solidFill>
+                  </a:tcPr>
+                </a:tc>
+                <a:tc>
+                  <a:txBody>
+                    <a:bodyPr/>
+                    <a:lstStyle/>
+                    <a:p>
+                      <a:pPr algn="l"/>
+                      <a:r>
+                        <a:rPr sz="1300" b="0">
+                          <a:solidFill>
+                            <a:srgbClr val="3C3C3B"/>
+                          </a:solidFill>
+                          <a:latin typeface="Aptos"/>
+                        </a:rPr>
+                        <a:t>10 MW / 40 MWh at 240 k€/MW</a:t>
+                      </a:r>
+                    </a:p>
+                  </a:txBody>
+                  <a:tcPr marL="73152" marR="73152" marT="27432" marB="27432" anchor="ctr">
+                    <a:noFill/>
+                  </a:tcPr>
+                </a:tc>
+              </a:tr>
+              <a:tr h="475488">
                 <a:tc>
                   <a:txBody>
                     <a:bodyPr/>
@@ -10081,7 +10127,7 @@
                   </a:tcPr>
                 </a:tc>
               </a:tr>
-              <a:tr h="502920">
+              <a:tr h="475488">
                 <a:tc>
                   <a:txBody>
                     <a:bodyPr/>
@@ -10127,7 +10173,7 @@
                   </a:tcPr>
                 </a:tc>
               </a:tr>
-              <a:tr h="502920">
+              <a:tr h="475488">
                 <a:tc>
                   <a:txBody>
                     <a:bodyPr/>
@@ -10173,7 +10219,7 @@
                   </a:tcPr>
                 </a:tc>
               </a:tr>
-              <a:tr h="502920">
+              <a:tr h="475488">
                 <a:tc>
                   <a:txBody>
                     <a:bodyPr/>
@@ -10219,7 +10265,7 @@
                   </a:tcPr>
                 </a:tc>
               </a:tr>
-              <a:tr h="502920">
+              <a:tr h="475488">
                 <a:tc>
                   <a:txBody>
                     <a:bodyPr/>
@@ -10265,7 +10311,7 @@
                   </a:tcPr>
                 </a:tc>
               </a:tr>
-              <a:tr h="502920">
+              <a:tr h="475488">
                 <a:tc>
                   <a:txBody>
                     <a:bodyPr/>
@@ -10304,7 +10350,7 @@
                   </a:tcPr>
                 </a:tc>
               </a:tr>
-              <a:tr h="502920">
+              <a:tr h="475488">
                 <a:tc>
                   <a:txBody>
                     <a:bodyPr/>
@@ -10350,7 +10396,7 @@
                   </a:tcPr>
                 </a:tc>
               </a:tr>
-              <a:tr h="502920">
+              <a:tr h="475488">
                 <a:tc>
                   <a:txBody>
                     <a:bodyPr/>
@@ -10396,7 +10442,7 @@
                   </a:tcPr>
                 </a:tc>
               </a:tr>
-              <a:tr h="502920">
+              <a:tr h="475488">
                 <a:tc>
                   <a:txBody>
                     <a:bodyPr/>
@@ -10435,7 +10481,7 @@
                   </a:tcPr>
                 </a:tc>
               </a:tr>
-              <a:tr h="502920">
+              <a:tr h="475488">
                 <a:tc>
                   <a:txBody>
                     <a:bodyPr/>
@@ -10495,7 +10541,7 @@
         </p:nvGraphicFramePr>
         <p:xfrm>
           <a:off x="12207240" y="2240280"/>
-          <a:ext cx="5989320" cy="4507992"/>
+          <a:ext cx="5989320" cy="4928616"/>
         </p:xfrm>
         <a:graphic>
           <a:graphicData uri="http://schemas.openxmlformats.org/drawingml/2006/table">
@@ -10603,7 +10649,7 @@
                   </a:tcPr>
                 </a:tc>
               </a:tr>
-              <a:tr h="566928">
+              <a:tr h="548640">
                 <a:tc>
                   <a:txBody>
                     <a:bodyPr/>
@@ -10640,7 +10686,7 @@
                           </a:solidFill>
                           <a:latin typeface="Aptos"/>
                         </a:rPr>
-                        <a:t>35 k€/MW (€1.75m)</a:t>
+                        <a:t>50 k€/MW (€2.50m)</a:t>
                       </a:r>
                     </a:p>
                   </a:txBody>
@@ -10661,7 +10707,7 @@
                           </a:solidFill>
                           <a:latin typeface="Aptos"/>
                         </a:rPr>
-                        <a:t>11</a:t>
+                        <a:t>20</a:t>
                       </a:r>
                     </a:p>
                   </a:txBody>
@@ -10682,7 +10728,7 @@
                           </a:solidFill>
                           <a:latin typeface="Aptos"/>
                         </a:rPr>
-                        <a:t>11</a:t>
+                        <a:t>20</a:t>
                       </a:r>
                     </a:p>
                   </a:txBody>
@@ -10691,7 +10737,7 @@
                   </a:tcPr>
                 </a:tc>
               </a:tr>
-              <a:tr h="566928">
+              <a:tr h="548640">
                 <a:tc>
                   <a:txBody>
                     <a:bodyPr/>
@@ -10728,7 +10774,7 @@
                           </a:solidFill>
                           <a:latin typeface="Aptos"/>
                         </a:rPr>
-                        <a:t>2.5 €/MWh</a:t>
+                        <a:t>3.0 €/MWh</a:t>
                       </a:r>
                     </a:p>
                   </a:txBody>
@@ -10749,7 +10795,7 @@
                           </a:solidFill>
                           <a:latin typeface="Aptos"/>
                         </a:rPr>
-                        <a:t>6</a:t>
+                        <a:t>15</a:t>
                       </a:r>
                     </a:p>
                   </a:txBody>
@@ -10770,7 +10816,7 @@
                           </a:solidFill>
                           <a:latin typeface="Aptos"/>
                         </a:rPr>
-                        <a:t>6</a:t>
+                        <a:t>15</a:t>
                       </a:r>
                     </a:p>
                   </a:txBody>
@@ -10779,7 +10825,7 @@
                   </a:tcPr>
                 </a:tc>
               </a:tr>
-              <a:tr h="566928">
+              <a:tr h="548640">
                 <a:tc>
                   <a:txBody>
                     <a:bodyPr/>
@@ -10867,21 +10913,21 @@
                   </a:tcPr>
                 </a:tc>
               </a:tr>
-              <a:tr h="566928">
-                <a:tc>
-                  <a:txBody>
-                    <a:bodyPr/>
-                    <a:lstStyle/>
-                    <a:p>
-                      <a:pPr algn="l"/>
-                      <a:r>
-                        <a:rPr sz="1300" b="0">
-                          <a:solidFill>
-                            <a:srgbClr val="3C3C3B"/>
-                          </a:solidFill>
-                          <a:latin typeface="Aptos"/>
-                        </a:rPr>
-                        <a:t>ÖSZ-6 performance security</a:t>
+              <a:tr h="548640">
+                <a:tc>
+                  <a:txBody>
+                    <a:bodyPr/>
+                    <a:lstStyle/>
+                    <a:p>
+                      <a:pPr algn="l"/>
+                      <a:r>
+                        <a:rPr sz="1300" b="0">
+                          <a:solidFill>
+                            <a:srgbClr val="3C3C3B"/>
+                          </a:solidFill>
+                          <a:latin typeface="Aptos"/>
+                        </a:rPr>
+                        <a:t>ÖSZ-4 BESS power</a:t>
                       </a:r>
                     </a:p>
                   </a:txBody>
@@ -10904,7 +10950,7 @@
                           </a:solidFill>
                           <a:latin typeface="Aptos"/>
                         </a:rPr>
-                        <a:t>1.0x of the minimum</a:t>
+                        <a:t>20% of MVA, 4 h; built</a:t>
                       </a:r>
                     </a:p>
                   </a:txBody>
@@ -10925,7 +10971,7 @@
                           </a:solidFill>
                           <a:latin typeface="Aptos"/>
                         </a:rPr>
-                        <a:t>0</a:t>
+                        <a:t>7.5</a:t>
                       </a:r>
                     </a:p>
                   </a:txBody>
@@ -10946,7 +10992,7 @@
                           </a:solidFill>
                           <a:latin typeface="Aptos"/>
                         </a:rPr>
-                        <a:t>0</a:t>
+                        <a:t>7.5</a:t>
                       </a:r>
                     </a:p>
                   </a:txBody>
@@ -10955,21 +11001,21 @@
                   </a:tcPr>
                 </a:tc>
               </a:tr>
-              <a:tr h="566928">
-                <a:tc>
-                  <a:txBody>
-                    <a:bodyPr/>
-                    <a:lstStyle/>
-                    <a:p>
-                      <a:pPr algn="l"/>
-                      <a:r>
-                        <a:rPr sz="1300" b="0">
-                          <a:solidFill>
-                            <a:srgbClr val="3C3C3B"/>
-                          </a:solidFill>
-                          <a:latin typeface="Aptos"/>
-                        </a:rPr>
-                        <a:t>ÖSZ-9 European turbines ≥ 80 %</a:t>
+              <a:tr h="548640">
+                <a:tc>
+                  <a:txBody>
+                    <a:bodyPr/>
+                    <a:lstStyle/>
+                    <a:p>
+                      <a:pPr algn="l"/>
+                      <a:r>
+                        <a:rPr sz="1300" b="0">
+                          <a:solidFill>
+                            <a:srgbClr val="3C3C3B"/>
+                          </a:solidFill>
+                          <a:latin typeface="Aptos"/>
+                        </a:rPr>
+                        <a:t>ÖSZ-6 performance security</a:t>
                       </a:r>
                     </a:p>
                   </a:txBody>
@@ -10992,7 +11038,7 @@
                           </a:solidFill>
                           <a:latin typeface="Aptos"/>
                         </a:rPr>
-                        <a:t>European route only</a:t>
+                        <a:t>1.0x of the minimum</a:t>
                       </a:r>
                     </a:p>
                   </a:txBody>
@@ -11013,7 +11059,7 @@
                           </a:solidFill>
                           <a:latin typeface="Aptos"/>
                         </a:rPr>
-                        <a:t>12</a:t>
+                        <a:t>0</a:t>
                       </a:r>
                     </a:p>
                   </a:txBody>
@@ -11043,21 +11089,21 @@
                   </a:tcPr>
                 </a:tc>
               </a:tr>
-              <a:tr h="566928">
-                <a:tc>
-                  <a:txBody>
-                    <a:bodyPr/>
-                    <a:lstStyle/>
-                    <a:p>
-                      <a:pPr algn="l"/>
-                      <a:r>
-                        <a:rPr sz="1300" b="0">
-                          <a:solidFill>
-                            <a:srgbClr val="3C3C3B"/>
-                          </a:solidFill>
-                          <a:latin typeface="Aptos"/>
-                        </a:rPr>
-                        <a:t>ÖSZ-5 partial award, ÖSZ-8 shared connection, ÖSZ-9 EU transformers</a:t>
+              <a:tr h="548640">
+                <a:tc>
+                  <a:txBody>
+                    <a:bodyPr/>
+                    <a:lstStyle/>
+                    <a:p>
+                      <a:pPr algn="l"/>
+                      <a:r>
+                        <a:rPr sz="1300" b="0">
+                          <a:solidFill>
+                            <a:srgbClr val="3C3C3B"/>
+                          </a:solidFill>
+                          <a:latin typeface="Aptos"/>
+                        </a:rPr>
+                        <a:t>ÖSZ-9 European turbines ≥ 80 %</a:t>
                       </a:r>
                     </a:p>
                   </a:txBody>
@@ -11080,7 +11126,7 @@
                           </a:solidFill>
                           <a:latin typeface="Aptos"/>
                         </a:rPr>
-                        <a:t>not offered</a:t>
+                        <a:t>European route only</a:t>
                       </a:r>
                     </a:p>
                   </a:txBody>
@@ -11101,7 +11147,7 @@
                           </a:solidFill>
                           <a:latin typeface="Aptos"/>
                         </a:rPr>
-                        <a:t>0 / 0 / 0</a:t>
+                        <a:t>12</a:t>
                       </a:r>
                     </a:p>
                   </a:txBody>
@@ -11122,7 +11168,7 @@
                           </a:solidFill>
                           <a:latin typeface="Aptos"/>
                         </a:rPr>
-                        <a:t>0 / 0 / 0</a:t>
+                        <a:t>0</a:t>
                       </a:r>
                     </a:p>
                   </a:txBody>
@@ -11131,21 +11177,21 @@
                   </a:tcPr>
                 </a:tc>
               </a:tr>
-              <a:tr h="566928">
-                <a:tc>
-                  <a:txBody>
-                    <a:bodyPr/>
-                    <a:lstStyle/>
-                    <a:p>
-                      <a:pPr algn="l"/>
-                      <a:r>
-                        <a:rPr sz="1300" b="1">
-                          <a:solidFill>
-                            <a:srgbClr val="3C3C3B"/>
-                          </a:solidFill>
-                          <a:latin typeface="Aptos"/>
-                        </a:rPr>
-                        <a:t>Total score</a:t>
+              <a:tr h="548640">
+                <a:tc>
+                  <a:txBody>
+                    <a:bodyPr/>
+                    <a:lstStyle/>
+                    <a:p>
+                      <a:pPr algn="l"/>
+                      <a:r>
+                        <a:rPr sz="1300" b="0">
+                          <a:solidFill>
+                            <a:srgbClr val="3C3C3B"/>
+                          </a:solidFill>
+                          <a:latin typeface="Aptos"/>
+                        </a:rPr>
+                        <a:t>ÖSZ-5 partial award, ÖSZ-8 shared connection, ÖSZ-9 EU transformers</a:t>
                       </a:r>
                     </a:p>
                   </a:txBody>
@@ -11161,6 +11207,94 @@
                     <a:lstStyle/>
                     <a:p>
                       <a:pPr algn="l"/>
+                      <a:r>
+                        <a:rPr sz="1300" b="0">
+                          <a:solidFill>
+                            <a:srgbClr val="3C3C3B"/>
+                          </a:solidFill>
+                          <a:latin typeface="Aptos"/>
+                        </a:rPr>
+                        <a:t>not offered</a:t>
+                      </a:r>
+                    </a:p>
+                  </a:txBody>
+                  <a:tcPr marL="73152" marR="73152" marT="27432" marB="27432" anchor="ctr">
+                    <a:noFill/>
+                  </a:tcPr>
+                </a:tc>
+                <a:tc>
+                  <a:txBody>
+                    <a:bodyPr/>
+                    <a:lstStyle/>
+                    <a:p>
+                      <a:pPr algn="r"/>
+                      <a:r>
+                        <a:rPr sz="1300" b="0">
+                          <a:solidFill>
+                            <a:srgbClr val="3C3C3B"/>
+                          </a:solidFill>
+                          <a:latin typeface="Aptos"/>
+                        </a:rPr>
+                        <a:t>0 / 0 / 0</a:t>
+                      </a:r>
+                    </a:p>
+                  </a:txBody>
+                  <a:tcPr marL="73152" marR="73152" marT="27432" marB="27432" anchor="ctr">
+                    <a:noFill/>
+                  </a:tcPr>
+                </a:tc>
+                <a:tc>
+                  <a:txBody>
+                    <a:bodyPr/>
+                    <a:lstStyle/>
+                    <a:p>
+                      <a:pPr algn="r"/>
+                      <a:r>
+                        <a:rPr sz="1300" b="0">
+                          <a:solidFill>
+                            <a:srgbClr val="3C3C3B"/>
+                          </a:solidFill>
+                          <a:latin typeface="Aptos"/>
+                        </a:rPr>
+                        <a:t>0 / 0 / 0</a:t>
+                      </a:r>
+                    </a:p>
+                  </a:txBody>
+                  <a:tcPr marL="73152" marR="73152" marT="27432" marB="27432" anchor="ctr">
+                    <a:noFill/>
+                  </a:tcPr>
+                </a:tc>
+              </a:tr>
+              <a:tr h="548640">
+                <a:tc>
+                  <a:txBody>
+                    <a:bodyPr/>
+                    <a:lstStyle/>
+                    <a:p>
+                      <a:pPr algn="l"/>
+                      <a:r>
+                        <a:rPr sz="1300" b="1">
+                          <a:solidFill>
+                            <a:srgbClr val="3C3C3B"/>
+                          </a:solidFill>
+                          <a:latin typeface="Aptos"/>
+                        </a:rPr>
+                        <a:t>Total score</a:t>
+                      </a:r>
+                    </a:p>
+                  </a:txBody>
+                  <a:tcPr marL="73152" marR="73152" marT="27432" marB="27432" anchor="ctr">
+                    <a:solidFill>
+                      <a:srgbClr val="F2F2F2"/>
+                    </a:solidFill>
+                  </a:tcPr>
+                </a:tc>
+                <a:tc>
+                  <a:txBody>
+                    <a:bodyPr/>
+                    <a:lstStyle/>
+                    <a:p>
+                      <a:pPr algn="l"/>
                     </a:p>
                   </a:txBody>
                   <a:tcPr marL="73152" marR="73152" marT="27432" marB="27432" anchor="ctr">
@@ -11182,7 +11316,7 @@
                           </a:solidFill>
                           <a:latin typeface="Aptos"/>
                         </a:rPr>
-                        <a:t>34</a:t>
+                        <a:t>59.5</a:t>
                       </a:r>
                     </a:p>
                   </a:txBody>
@@ -11205,7 +11339,7 @@
                           </a:solidFill>
                           <a:latin typeface="Aptos"/>
                         </a:rPr>
-                        <a:t>22</a:t>
+                        <a:t>47.5</a:t>
                       </a:r>
                     </a:p>
                   </a:txBody>
@@ -11249,7 +11383,7 @@
                 </a:solidFill>
                 <a:latin typeface="Aptos"/>
               </a:rPr>
-              <a:t>Points are the model's own score on the MEKH 2026 bands (Kiírás Annex 3-4). BESS (ÖSZ-4) and brownfield (ÖSZ-7) are not available at Bana. Build shortfall 8.3% against the commitment, inside the 10% tolerance (GYIK 28/30). The municipal one-off is paid at COD.</a:t>
+              <a:t>Points are the model's own score on the MEKH 2026 bands (Kiírás Annex 3-4). ÖSZ-4 is scored on net MVA (as Bora); BESS at capex only, no revenue or opex, not in the COD price. Brownfield (ÖSZ-7) is not available. Build shortfall 8.3% against the commitment, inside the 10% tolerance (GYIK 28/30). The municipal one-off is paid at COD.</a:t>
             </a:r>
           </a:p>
           <a:p>
@@ -11304,7 +11438,7 @@
           <a:lstStyle/>
           <a:p>
             <a:r>
-              <a:t>Uses to COD of €88.8m with European turbines (€80.8m Chinese); senior debt funds 73% (64%) and FEP the rest</a:t>
+              <a:t>Uses to COD of €92.3m with European turbines (€84.2m Chinese); senior debt funds 73% (64%) and FEP the rest</a:t>
             </a:r>
           </a:p>
         </p:txBody>
@@ -11648,7 +11782,7 @@
                 </a:solidFill>
                 <a:latin typeface="Aptos"/>
               </a:rPr>
-              <a:t>A €0.33m bid guarantee at the bid; after the award a €1.67m PB guarantee and €0.62m of TSO cash; the €8.2m connection fees fall due at the HCSSZ, 08‑Jan‑29.</a:t>
+              <a:t>A €0.44m bid guarantee at the bid; after the award a €2.22m PB guarantee and €0.62m of TSO cash; the €8.2m connection fees fall due at the HCSSZ, 08‑Jan‑29.</a:t>
             </a:r>
           </a:p>
         </p:txBody>
@@ -11921,7 +12055,7 @@
                           </a:solidFill>
                           <a:latin typeface="Aptos"/>
                         </a:rPr>
-                        <a:t>1.0</a:t>
+                        <a:t>1.1</a:t>
                       </a:r>
                     </a:p>
                   </a:txBody>
@@ -11942,7 +12076,7 @@
                           </a:solidFill>
                           <a:latin typeface="Aptos"/>
                         </a:rPr>
-                        <a:t>1.0</a:t>
+                        <a:t>1.1</a:t>
                       </a:r>
                     </a:p>
                   </a:txBody>
@@ -12011,7 +12145,7 @@
                           </a:solidFill>
                           <a:latin typeface="Aptos"/>
                         </a:rPr>
-                        <a:t>67.8</a:t>
+                        <a:t>70.2</a:t>
                       </a:r>
                     </a:p>
                   </a:txBody>
@@ -12032,7 +12166,7 @@
                           </a:solidFill>
                           <a:latin typeface="Aptos"/>
                         </a:rPr>
-                        <a:t>60.7</a:t>
+                        <a:t>63.1</a:t>
                       </a:r>
                     </a:p>
                   </a:txBody>
@@ -12191,7 +12325,7 @@
                           </a:solidFill>
                           <a:latin typeface="Aptos"/>
                         </a:rPr>
-                        <a:t>1.8</a:t>
+                        <a:t>2.5</a:t>
                       </a:r>
                     </a:p>
                   </a:txBody>
@@ -12212,7 +12346,7 @@
                           </a:solidFill>
                           <a:latin typeface="Aptos"/>
                         </a:rPr>
-                        <a:t>1.8</a:t>
+                        <a:t>2.5</a:t>
                       </a:r>
                     </a:p>
                   </a:txBody>
@@ -12281,7 +12415,7 @@
                           </a:solidFill>
                           <a:latin typeface="Aptos"/>
                         </a:rPr>
-                        <a:t>4.7</a:t>
+                        <a:t>4.8</a:t>
                       </a:r>
                     </a:p>
                   </a:txBody>
@@ -12302,7 +12436,7 @@
                           </a:solidFill>
                           <a:latin typeface="Aptos"/>
                         </a:rPr>
-                        <a:t>3.7</a:t>
+                        <a:t>3.9</a:t>
                       </a:r>
                     </a:p>
                   </a:txBody>
@@ -12461,7 +12595,7 @@
                           </a:solidFill>
                           <a:latin typeface="Aptos"/>
                         </a:rPr>
-                        <a:t>88.8</a:t>
+                        <a:t>92.3</a:t>
                       </a:r>
                     </a:p>
                   </a:txBody>
@@ -12484,7 +12618,7 @@
                           </a:solidFill>
                           <a:latin typeface="Aptos"/>
                         </a:rPr>
-                        <a:t>80.8</a:t>
+                        <a:t>84.2</a:t>
                       </a:r>
                     </a:p>
                   </a:txBody>
@@ -12555,7 +12689,7 @@
                           </a:solidFill>
                           <a:latin typeface="Aptos"/>
                         </a:rPr>
-                        <a:t>65.1</a:t>
+                        <a:t>67.7</a:t>
                       </a:r>
                     </a:p>
                   </a:txBody>
@@ -12576,7 +12710,7 @@
                           </a:solidFill>
                           <a:latin typeface="Aptos"/>
                         </a:rPr>
-                        <a:t>51.8</a:t>
+                        <a:t>54.1</a:t>
                       </a:r>
                     </a:p>
                   </a:txBody>
@@ -12645,7 +12779,7 @@
                           </a:solidFill>
                           <a:latin typeface="Aptos"/>
                         </a:rPr>
-                        <a:t>23.8</a:t>
+                        <a:t>24.6</a:t>
                       </a:r>
                     </a:p>
                   </a:txBody>
@@ -12668,7 +12802,7 @@
                           </a:solidFill>
                           <a:latin typeface="Aptos"/>
                         </a:rPr>
-                        <a:t>29.1</a:t>
+                        <a:t>30.2</a:t>
                       </a:r>
                     </a:p>
                   </a:txBody>
@@ -12739,7 +12873,7 @@
                           </a:solidFill>
                           <a:latin typeface="Aptos"/>
                         </a:rPr>
-                        <a:t>25.1</a:t>
+                        <a:t>26.0</a:t>
                       </a:r>
                     </a:p>
                   </a:txBody>
@@ -12760,7 +12894,7 @@
                           </a:solidFill>
                           <a:latin typeface="Aptos"/>
                         </a:rPr>
-                        <a:t>30.1</a:t>
+                        <a:t>31.3</a:t>
                       </a:r>
                     </a:p>
                   </a:txBody>
@@ -13041,7 +13175,7 @@
                           </a:solidFill>
                           <a:latin typeface="Aptos"/>
                         </a:rPr>
-                        <a:t>0.33</a:t>
+                        <a:t>0.44</a:t>
                       </a:r>
                     </a:p>
                   </a:txBody>
@@ -13131,7 +13265,7 @@
                           </a:solidFill>
                           <a:latin typeface="Aptos"/>
                         </a:rPr>
-                        <a:t>1.67</a:t>
+                        <a:t>2.22</a:t>
                       </a:r>
                     </a:p>
                   </a:txBody>
@@ -13491,7 +13625,7 @@
                           </a:solidFill>
                           <a:latin typeface="Aptos"/>
                         </a:rPr>
-                        <a:t>0.37</a:t>
+                        <a:t>0.49</a:t>
                       </a:r>
                     </a:p>
                   </a:txBody>
@@ -13609,7 +13743,7 @@
           <a:lstStyle/>
           <a:p>
             <a:r>
-              <a:t>A sale at COD turns €23.8m of equity into €68.6m (2.89x); holding earns 12.9% at a 1.62x DSCR (European)</a:t>
+              <a:t>A sale at COD turns €24.6m of equity into €66.0m (2.68x); holding earns 12.0% at a 1.55x DSCR (European)</a:t>
             </a:r>
           </a:p>
         </p:txBody>
@@ -13953,7 +14087,7 @@
                 </a:solidFill>
                 <a:latin typeface="Aptos"/>
               </a:rPr>
-              <a:t>With Chinese turbines the sale returns 51.8% and the hold 13.5%; debt is sized at 80% / 70% of construction cost.</a:t>
+              <a:t>With Chinese turbines the sale returns 47.4% and the hold 12.6%; debt is sized at 80% / 70% of construction cost.</a:t>
             </a:r>
           </a:p>
         </p:txBody>
@@ -14316,7 +14450,7 @@
                           </a:solidFill>
                           <a:latin typeface="Aptos"/>
                         </a:rPr>
-                        <a:t>(65.1)</a:t>
+                        <a:t>(67.7)</a:t>
                       </a:r>
                     </a:p>
                   </a:txBody>
@@ -14337,7 +14471,7 @@
                           </a:solidFill>
                           <a:latin typeface="Aptos"/>
                         </a:rPr>
-                        <a:t>(51.8)</a:t>
+                        <a:t>(54.1)</a:t>
                       </a:r>
                     </a:p>
                   </a:txBody>
@@ -14448,7 +14582,7 @@
                           </a:solidFill>
                           <a:latin typeface="Aptos"/>
                         </a:rPr>
-                        <a:t>68.6</a:t>
+                        <a:t>66.0</a:t>
                       </a:r>
                     </a:p>
                   </a:txBody>
@@ -14469,7 +14603,7 @@
                           </a:solidFill>
                           <a:latin typeface="Aptos"/>
                         </a:rPr>
-                        <a:t>62.7</a:t>
+                        <a:t>60.4</a:t>
                       </a:r>
                     </a:p>
                   </a:txBody>
@@ -14580,7 +14714,7 @@
                           </a:solidFill>
                           <a:latin typeface="Aptos"/>
                         </a:rPr>
-                        <a:t>23.8</a:t>
+                        <a:t>24.6</a:t>
                       </a:r>
                     </a:p>
                   </a:txBody>
@@ -14601,7 +14735,7 @@
                           </a:solidFill>
                           <a:latin typeface="Aptos"/>
                         </a:rPr>
-                        <a:t>29.1</a:t>
+                        <a:t>30.2</a:t>
                       </a:r>
                     </a:p>
                   </a:txBody>
@@ -14622,7 +14756,7 @@
                           </a:solidFill>
                           <a:latin typeface="Aptos"/>
                         </a:rPr>
-                        <a:t>25.1</a:t>
+                        <a:t>26.0</a:t>
                       </a:r>
                     </a:p>
                   </a:txBody>
@@ -14643,7 +14777,7 @@
                           </a:solidFill>
                           <a:latin typeface="Aptos"/>
                         </a:rPr>
-                        <a:t>30.1</a:t>
+                        <a:t>31.3</a:t>
                       </a:r>
                     </a:p>
                   </a:txBody>
@@ -14712,7 +14846,7 @@
                           </a:solidFill>
                           <a:latin typeface="Aptos"/>
                         </a:rPr>
-                        <a:t>44.8</a:t>
+                        <a:t>41.4</a:t>
                       </a:r>
                     </a:p>
                   </a:txBody>
@@ -14733,7 +14867,7 @@
                           </a:solidFill>
                           <a:latin typeface="Aptos"/>
                         </a:rPr>
-                        <a:t>33.6</a:t>
+                        <a:t>30.2</a:t>
                       </a:r>
                     </a:p>
                   </a:txBody>
@@ -14754,7 +14888,7 @@
                           </a:solidFill>
                           <a:latin typeface="Aptos"/>
                         </a:rPr>
-                        <a:t>140.8</a:t>
+                        <a:t>134.5</a:t>
                       </a:r>
                     </a:p>
                   </a:txBody>
@@ -14775,7 +14909,7 @@
                           </a:solidFill>
                           <a:latin typeface="Aptos"/>
                         </a:rPr>
-                        <a:t>154.4</a:t>
+                        <a:t>148.4</a:t>
                       </a:r>
                     </a:p>
                   </a:txBody>
@@ -14844,7 +14978,7 @@
                           </a:solidFill>
                           <a:latin typeface="Aptos"/>
                         </a:rPr>
-                        <a:t>66.4%</a:t>
+                        <a:t>62.4%</a:t>
                       </a:r>
                     </a:p>
                   </a:txBody>
@@ -14867,7 +15001,7 @@
                           </a:solidFill>
                           <a:latin typeface="Aptos"/>
                         </a:rPr>
-                        <a:t>51.8%</a:t>
+                        <a:t>47.4%</a:t>
                       </a:r>
                     </a:p>
                   </a:txBody>
@@ -14890,7 +15024,7 @@
                           </a:solidFill>
                           <a:latin typeface="Aptos"/>
                         </a:rPr>
-                        <a:t>12.9%</a:t>
+                        <a:t>12.0%</a:t>
                       </a:r>
                     </a:p>
                   </a:txBody>
@@ -14913,7 +15047,7 @@
                           </a:solidFill>
                           <a:latin typeface="Aptos"/>
                         </a:rPr>
-                        <a:t>13.5%</a:t>
+                        <a:t>12.6%</a:t>
                       </a:r>
                     </a:p>
                   </a:txBody>
@@ -14984,7 +15118,7 @@
                           </a:solidFill>
                           <a:latin typeface="Aptos"/>
                         </a:rPr>
-                        <a:t>2.89x</a:t>
+                        <a:t>2.68x</a:t>
                       </a:r>
                     </a:p>
                   </a:txBody>
@@ -15005,7 +15139,7 @@
                           </a:solidFill>
                           <a:latin typeface="Aptos"/>
                         </a:rPr>
-                        <a:t>2.16x</a:t>
+                        <a:t>2.00x</a:t>
                       </a:r>
                     </a:p>
                   </a:txBody>
@@ -15026,7 +15160,7 @@
                           </a:solidFill>
                           <a:latin typeface="Aptos"/>
                         </a:rPr>
-                        <a:t>6.60x</a:t>
+                        <a:t>6.17x</a:t>
                       </a:r>
                     </a:p>
                   </a:txBody>
@@ -15047,7 +15181,7 @@
                           </a:solidFill>
                           <a:latin typeface="Aptos"/>
                         </a:rPr>
-                        <a:t>6.12x</a:t>
+                        <a:t>5.74x</a:t>
                       </a:r>
                     </a:p>
                   </a:txBody>
@@ -15116,7 +15250,7 @@
                           </a:solidFill>
                           <a:latin typeface="Aptos"/>
                         </a:rPr>
-                        <a:t>31.1</a:t>
+                        <a:t>28.5</a:t>
                       </a:r>
                     </a:p>
                   </a:txBody>
@@ -15137,7 +15271,7 @@
                           </a:solidFill>
                           <a:latin typeface="Aptos"/>
                         </a:rPr>
-                        <a:t>22.4</a:t>
+                        <a:t>19.8</a:t>
                       </a:r>
                     </a:p>
                   </a:txBody>
@@ -15158,7 +15292,7 @@
                           </a:solidFill>
                           <a:latin typeface="Aptos"/>
                         </a:rPr>
-                        <a:t>16.2</a:t>
+                        <a:t>13.5</a:t>
                       </a:r>
                     </a:p>
                   </a:txBody>
@@ -15179,7 +15313,7 @@
                           </a:solidFill>
                           <a:latin typeface="Aptos"/>
                         </a:rPr>
-                        <a:t>19.6</a:t>
+                        <a:t>16.9</a:t>
                       </a:r>
                     </a:p>
                   </a:txBody>
@@ -15290,7 +15424,7 @@
                           </a:solidFill>
                           <a:latin typeface="Aptos"/>
                         </a:rPr>
-                        <a:t>9.1%</a:t>
+                        <a:t>8.7%</a:t>
                       </a:r>
                     </a:p>
                   </a:txBody>
@@ -15311,7 +15445,7 @@
                           </a:solidFill>
                           <a:latin typeface="Aptos"/>
                         </a:rPr>
-                        <a:t>10.0%</a:t>
+                        <a:t>9.5%</a:t>
                       </a:r>
                     </a:p>
                   </a:txBody>
@@ -15422,7 +15556,7 @@
                           </a:solidFill>
                           <a:latin typeface="Aptos"/>
                         </a:rPr>
-                        <a:t>1.62x</a:t>
+                        <a:t>1.55x</a:t>
                       </a:r>
                     </a:p>
                   </a:txBody>
@@ -15443,7 +15577,7 @@
                           </a:solidFill>
                           <a:latin typeface="Aptos"/>
                         </a:rPr>
-                        <a:t>2.02x</a:t>
+                        <a:t>1.93x</a:t>
                       </a:r>
                     </a:p>
                   </a:txBody>
@@ -15554,7 +15688,7 @@
                           </a:solidFill>
                           <a:latin typeface="Aptos"/>
                         </a:rPr>
-                        <a:t>(13.9)</a:t>
+                        <a:t>(13.4)</a:t>
                       </a:r>
                     </a:p>
                   </a:txBody>
@@ -15575,7 +15709,7 @@
                           </a:solidFill>
                           <a:latin typeface="Aptos"/>
                         </a:rPr>
-                        <a:t>(15.3)</a:t>
+                        <a:t>(14.7)</a:t>
                       </a:r>
                     </a:p>
                   </a:txBody>
@@ -15679,7 +15813,7 @@
                 </a:solidFill>
                 <a:latin typeface="Aptos"/>
               </a:rPr>
-              <a:t>1.20x target DSCR over 18 years, 5.0% fixed; sized at the lower of the DSCR capacity and 80% / 70% of cost; 74% / 59% of the DSCR capacity is used.</a:t>
+              <a:t>1.20x target DSCR over 18 years, 5.0% fixed; sized at the lower of the DSCR capacity and 80% / 70% of cost; 77% / 62% of the DSCR capacity is used.</a:t>
             </a:r>
           </a:p>
           <a:p>
@@ -15793,7 +15927,7 @@
           <a:lstStyle/>
           <a:p>
             <a:r>
-              <a:t>A lower COD price is the largest risk to the sale (52.3%); yield and PPA price drive the hold (10.2% / 9.9%)</a:t>
+              <a:t>A lower COD price is the largest risk to the sale (47.7%); yield and PPA price drive the hold (9.4% / 9.1%)</a:t>
             </a:r>
           </a:p>
         </p:txBody>
@@ -16369,7 +16503,7 @@
                           </a:solidFill>
                           <a:latin typeface="Aptos"/>
                         </a:rPr>
-                        <a:t>66.4%</a:t>
+                        <a:t>62.4%</a:t>
                       </a:r>
                     </a:p>
                   </a:txBody>
@@ -16392,7 +16526,7 @@
                           </a:solidFill>
                           <a:latin typeface="Aptos"/>
                         </a:rPr>
-                        <a:t>51.8%</a:t>
+                        <a:t>47.4%</a:t>
                       </a:r>
                     </a:p>
                   </a:txBody>
@@ -16415,7 +16549,7 @@
                           </a:solidFill>
                           <a:latin typeface="Aptos"/>
                         </a:rPr>
-                        <a:t>12.9%</a:t>
+                        <a:t>12.0%</a:t>
                       </a:r>
                     </a:p>
                   </a:txBody>
@@ -16438,7 +16572,7 @@
                           </a:solidFill>
                           <a:latin typeface="Aptos"/>
                         </a:rPr>
-                        <a:t>13.5%</a:t>
+                        <a:t>12.6%</a:t>
                       </a:r>
                     </a:p>
                   </a:txBody>
@@ -16461,7 +16595,7 @@
                           </a:solidFill>
                           <a:latin typeface="Aptos"/>
                         </a:rPr>
-                        <a:t>1.62x</a:t>
+                        <a:t>1.55x</a:t>
                       </a:r>
                     </a:p>
                   </a:txBody>
@@ -16484,7 +16618,7 @@
                           </a:solidFill>
                           <a:latin typeface="Aptos"/>
                         </a:rPr>
-                        <a:t>2.02x</a:t>
+                        <a:t>1.93x</a:t>
                       </a:r>
                     </a:p>
                   </a:txBody>
@@ -16532,7 +16666,7 @@
                           </a:solidFill>
                           <a:latin typeface="Aptos"/>
                         </a:rPr>
-                        <a:t>52.3%</a:t>
+                        <a:t>47.7%</a:t>
                       </a:r>
                     </a:p>
                   </a:txBody>
@@ -16553,7 +16687,7 @@
                           </a:solidFill>
                           <a:latin typeface="Aptos"/>
                         </a:rPr>
-                        <a:t>38.0%</a:t>
+                        <a:t>32.8%</a:t>
                       </a:r>
                     </a:p>
                   </a:txBody>
@@ -16574,7 +16708,7 @@
                           </a:solidFill>
                           <a:latin typeface="Aptos"/>
                         </a:rPr>
-                        <a:t>12.9%</a:t>
+                        <a:t>12.0%</a:t>
                       </a:r>
                     </a:p>
                   </a:txBody>
@@ -16595,7 +16729,7 @@
                           </a:solidFill>
                           <a:latin typeface="Aptos"/>
                         </a:rPr>
-                        <a:t>13.5%</a:t>
+                        <a:t>12.6%</a:t>
                       </a:r>
                     </a:p>
                   </a:txBody>
@@ -16616,7 +16750,7 @@
                           </a:solidFill>
                           <a:latin typeface="Aptos"/>
                         </a:rPr>
-                        <a:t>1.62x</a:t>
+                        <a:t>1.55x</a:t>
                       </a:r>
                     </a:p>
                   </a:txBody>
@@ -16637,7 +16771,7 @@
                           </a:solidFill>
                           <a:latin typeface="Aptos"/>
                         </a:rPr>
-                        <a:t>2.02x</a:t>
+                        <a:t>1.93x</a:t>
                       </a:r>
                     </a:p>
                   </a:txBody>
@@ -16683,7 +16817,7 @@
                           </a:solidFill>
                           <a:latin typeface="Aptos"/>
                         </a:rPr>
-                        <a:t>62.3%</a:t>
+                        <a:t>58.2%</a:t>
                       </a:r>
                     </a:p>
                   </a:txBody>
@@ -16704,7 +16838,7 @@
                           </a:solidFill>
                           <a:latin typeface="Aptos"/>
                         </a:rPr>
-                        <a:t>47.9%</a:t>
+                        <a:t>43.3%</a:t>
                       </a:r>
                     </a:p>
                   </a:txBody>
@@ -16725,7 +16859,7 @@
                           </a:solidFill>
                           <a:latin typeface="Aptos"/>
                         </a:rPr>
-                        <a:t>12.1%</a:t>
+                        <a:t>11.2%</a:t>
                       </a:r>
                     </a:p>
                   </a:txBody>
@@ -16746,7 +16880,7 @@
                           </a:solidFill>
                           <a:latin typeface="Aptos"/>
                         </a:rPr>
-                        <a:t>12.8%</a:t>
+                        <a:t>12.0%</a:t>
                       </a:r>
                     </a:p>
                   </a:txBody>
@@ -16767,7 +16901,7 @@
                           </a:solidFill>
                           <a:latin typeface="Aptos"/>
                         </a:rPr>
-                        <a:t>1.56x</a:t>
+                        <a:t>1.49x</a:t>
                       </a:r>
                     </a:p>
                   </a:txBody>
@@ -16788,7 +16922,7 @@
                           </a:solidFill>
                           <a:latin typeface="Aptos"/>
                         </a:rPr>
-                        <a:t>1.95x</a:t>
+                        <a:t>1.86x</a:t>
                       </a:r>
                     </a:p>
                   </a:txBody>
@@ -16834,7 +16968,7 @@
                           </a:solidFill>
                           <a:latin typeface="Aptos"/>
                         </a:rPr>
-                        <a:t>66.4%</a:t>
+                        <a:t>62.4%</a:t>
                       </a:r>
                     </a:p>
                   </a:txBody>
@@ -16855,7 +16989,7 @@
                           </a:solidFill>
                           <a:latin typeface="Aptos"/>
                         </a:rPr>
-                        <a:t>51.8%</a:t>
+                        <a:t>47.4%</a:t>
                       </a:r>
                     </a:p>
                   </a:txBody>
@@ -16876,6 +17010,27 @@
                           </a:solidFill>
                           <a:latin typeface="Aptos"/>
                         </a:rPr>
+                        <a:t>9.4%</a:t>
+                      </a:r>
+                    </a:p>
+                  </a:txBody>
+                  <a:tcPr marL="73152" marR="73152" marT="27432" marB="27432" anchor="ctr">
+                    <a:noFill/>
+                  </a:tcPr>
+                </a:tc>
+                <a:tc>
+                  <a:txBody>
+                    <a:bodyPr/>
+                    <a:lstStyle/>
+                    <a:p>
+                      <a:pPr algn="r"/>
+                      <a:r>
+                        <a:rPr sz="1300" b="0">
+                          <a:solidFill>
+                            <a:srgbClr val="3C3C3B"/>
+                          </a:solidFill>
+                          <a:latin typeface="Aptos"/>
+                        </a:rPr>
                         <a:t>10.2%</a:t>
                       </a:r>
                     </a:p>
@@ -16897,7 +17052,7 @@
                           </a:solidFill>
                           <a:latin typeface="Aptos"/>
                         </a:rPr>
-                        <a:t>11.1%</a:t>
+                        <a:t>1.37x</a:t>
                       </a:r>
                     </a:p>
                   </a:txBody>
@@ -16918,28 +17073,7 @@
                           </a:solidFill>
                           <a:latin typeface="Aptos"/>
                         </a:rPr>
-                        <a:t>1.44x</a:t>
-                      </a:r>
-                    </a:p>
-                  </a:txBody>
-                  <a:tcPr marL="73152" marR="73152" marT="27432" marB="27432" anchor="ctr">
-                    <a:noFill/>
-                  </a:tcPr>
-                </a:tc>
-                <a:tc>
-                  <a:txBody>
-                    <a:bodyPr/>
-                    <a:lstStyle/>
-                    <a:p>
-                      <a:pPr algn="r"/>
-                      <a:r>
-                        <a:rPr sz="1300" b="0">
-                          <a:solidFill>
-                            <a:srgbClr val="3C3C3B"/>
-                          </a:solidFill>
-                          <a:latin typeface="Aptos"/>
-                        </a:rPr>
-                        <a:t>1.79x</a:t>
+                        <a:t>1.71x</a:t>
                       </a:r>
                     </a:p>
                   </a:txBody>
@@ -16985,7 +17119,7 @@
                           </a:solidFill>
                           <a:latin typeface="Aptos"/>
                         </a:rPr>
-                        <a:t>66.4%</a:t>
+                        <a:t>62.4%</a:t>
                       </a:r>
                     </a:p>
                   </a:txBody>
@@ -17006,7 +17140,7 @@
                           </a:solidFill>
                           <a:latin typeface="Aptos"/>
                         </a:rPr>
-                        <a:t>51.8%</a:t>
+                        <a:t>47.4%</a:t>
                       </a:r>
                     </a:p>
                   </a:txBody>
@@ -17027,7 +17161,7 @@
                           </a:solidFill>
                           <a:latin typeface="Aptos"/>
                         </a:rPr>
-                        <a:t>9.9%</a:t>
+                        <a:t>9.1%</a:t>
                       </a:r>
                     </a:p>
                   </a:txBody>
@@ -17048,7 +17182,7 @@
                           </a:solidFill>
                           <a:latin typeface="Aptos"/>
                         </a:rPr>
-                        <a:t>10.8%</a:t>
+                        <a:t>10.0%</a:t>
                       </a:r>
                     </a:p>
                   </a:txBody>
@@ -17069,7 +17203,7 @@
                           </a:solidFill>
                           <a:latin typeface="Aptos"/>
                         </a:rPr>
-                        <a:t>1.42x</a:t>
+                        <a:t>1.35x</a:t>
                       </a:r>
                     </a:p>
                   </a:txBody>
@@ -17090,7 +17224,7 @@
                           </a:solidFill>
                           <a:latin typeface="Aptos"/>
                         </a:rPr>
-                        <a:t>1.77x</a:t>
+                        <a:t>1.68x</a:t>
                       </a:r>
                     </a:p>
                   </a:txBody>
@@ -17136,7 +17270,7 @@
                           </a:solidFill>
                           <a:latin typeface="Aptos"/>
                         </a:rPr>
-                        <a:t>64.7%</a:t>
+                        <a:t>60.2%</a:t>
                       </a:r>
                     </a:p>
                   </a:txBody>
@@ -17157,7 +17291,7 @@
                           </a:solidFill>
                           <a:latin typeface="Aptos"/>
                         </a:rPr>
-                        <a:t>50.0%</a:t>
+                        <a:t>44.8%</a:t>
                       </a:r>
                     </a:p>
                   </a:txBody>
@@ -17178,7 +17312,7 @@
                           </a:solidFill>
                           <a:latin typeface="Aptos"/>
                         </a:rPr>
-                        <a:t>12.4%</a:t>
+                        <a:t>11.4%</a:t>
                       </a:r>
                     </a:p>
                   </a:txBody>
@@ -17199,7 +17333,7 @@
                           </a:solidFill>
                           <a:latin typeface="Aptos"/>
                         </a:rPr>
-                        <a:t>13.0%</a:t>
+                        <a:t>12.0%</a:t>
                       </a:r>
                     </a:p>
                   </a:txBody>
@@ -17220,7 +17354,7 @@
                           </a:solidFill>
                           <a:latin typeface="Aptos"/>
                         </a:rPr>
-                        <a:t>1.62x</a:t>
+                        <a:t>1.55x</a:t>
                       </a:r>
                     </a:p>
                   </a:txBody>
@@ -17241,7 +17375,7 @@
                           </a:solidFill>
                           <a:latin typeface="Aptos"/>
                         </a:rPr>
-                        <a:t>2.02x</a:t>
+                        <a:t>1.93x</a:t>
                       </a:r>
                     </a:p>
                   </a:txBody>
@@ -17287,7 +17421,7 @@
                           </a:solidFill>
                           <a:latin typeface="Aptos"/>
                         </a:rPr>
-                        <a:t>65.7%</a:t>
+                        <a:t>61.8%</a:t>
                       </a:r>
                     </a:p>
                   </a:txBody>
@@ -17308,7 +17442,7 @@
                           </a:solidFill>
                           <a:latin typeface="Aptos"/>
                         </a:rPr>
-                        <a:t>51.3%</a:t>
+                        <a:t>46.8%</a:t>
                       </a:r>
                     </a:p>
                   </a:txBody>
@@ -17329,7 +17463,7 @@
                           </a:solidFill>
                           <a:latin typeface="Aptos"/>
                         </a:rPr>
-                        <a:t>11.9%</a:t>
+                        <a:t>10.9%</a:t>
                       </a:r>
                     </a:p>
                   </a:txBody>
@@ -17350,7 +17484,7 @@
                           </a:solidFill>
                           <a:latin typeface="Aptos"/>
                         </a:rPr>
-                        <a:t>12.7%</a:t>
+                        <a:t>11.8%</a:t>
                       </a:r>
                     </a:p>
                   </a:txBody>
@@ -17371,7 +17505,7 @@
                           </a:solidFill>
                           <a:latin typeface="Aptos"/>
                         </a:rPr>
-                        <a:t>1.50x</a:t>
+                        <a:t>1.43x</a:t>
                       </a:r>
                     </a:p>
                   </a:txBody>
@@ -17392,7 +17526,7 @@
                           </a:solidFill>
                           <a:latin typeface="Aptos"/>
                         </a:rPr>
-                        <a:t>1.86x</a:t>
+                        <a:t>1.78x</a:t>
                       </a:r>
                     </a:p>
                   </a:txBody>
@@ -17438,7 +17572,7 @@
                           </a:solidFill>
                           <a:latin typeface="Aptos"/>
                         </a:rPr>
-                        <a:t>62.8%</a:t>
+                        <a:t>57.7%</a:t>
                       </a:r>
                     </a:p>
                   </a:txBody>
@@ -17459,7 +17593,7 @@
                           </a:solidFill>
                           <a:latin typeface="Aptos"/>
                         </a:rPr>
-                        <a:t>51.8%</a:t>
+                        <a:t>47.4%</a:t>
                       </a:r>
                     </a:p>
                   </a:txBody>
@@ -17480,7 +17614,7 @@
                           </a:solidFill>
                           <a:latin typeface="Aptos"/>
                         </a:rPr>
-                        <a:t>10.5%</a:t>
+                        <a:t>9.7%</a:t>
                       </a:r>
                     </a:p>
                   </a:txBody>
@@ -17501,7 +17635,7 @@
                           </a:solidFill>
                           <a:latin typeface="Aptos"/>
                         </a:rPr>
-                        <a:t>11.7%</a:t>
+                        <a:t>11.0%</a:t>
                       </a:r>
                     </a:p>
                   </a:txBody>
@@ -17543,7 +17677,7 @@
                           </a:solidFill>
                           <a:latin typeface="Aptos"/>
                         </a:rPr>
-                        <a:t>1.33x</a:t>
+                        <a:t>1.27x</a:t>
                       </a:r>
                     </a:p>
                   </a:txBody>
@@ -17654,7 +17788,7 @@
                 </a:solidFill>
                 <a:latin typeface="Aptos"/>
               </a:rPr>
-              <a:t>55 MW built against 60 MW committed. Pro rata (GYIK 28/30) there is no PB call; if the full-call reading (GYIK 72) applies, the €1.67m PB is lost: COD IRR 64.7%, hold IRR 12.4% (European).</a:t>
+              <a:t>55 MW built against 60 MW committed. Pro rata (GYIK 28/30) there is no PB call; if the full-call reading (GYIK 72) applies, the €2.22m PB is lost: COD IRR 60.2%, hold IRR 11.4% (European).</a:t>
             </a:r>
           </a:p>
           <a:p>
@@ -17729,7 +17863,7 @@
                 </a:solidFill>
                 <a:latin typeface="Aptos"/>
               </a:rPr>
-              <a:t>a 10-year tenor makes the DSCR bind and cuts the European hold IRR to 10.5%.</a:t>
+              <a:t>a 10-year tenor makes the DSCR bind and cuts the European hold IRR to 9.7%.</a:t>
             </a:r>
           </a:p>
         </p:txBody>

</xml_diff>

<commit_message>
Apply the user's Bana input corrections and slide 2 edits
Co-Authored-By: Claude Opus 5.5 <noreply@anthropic.com>
Claude-Session: https://claude.ai/code/session_01AWS1t9WtpkQHcCU1WceGZT
</commit_message>
<xml_diff>
--- a/projects/bana/out/Bana_IC.pptx
+++ b/projects/bana/out/Bana_IC.pptx
@@ -246,10 +246,10 @@
                 <c:formatCode>0.0%</c:formatCode>
                 <c:ptCount val="2"/>
                 <c:pt idx="0">
-                  <c:v>0.624343544593479</c:v>
+                  <c:v>0.284084033636541</c:v>
                 </c:pt>
                 <c:pt idx="1">
-                  <c:v>0.119964137616349</c:v>
+                  <c:v>0.0829084182180928</c:v>
                 </c:pt>
               </c:numCache>
             </c:numRef>
@@ -296,10 +296,10 @@
                 <c:formatCode>0.0%</c:formatCode>
                 <c:ptCount val="2"/>
                 <c:pt idx="0">
-                  <c:v>0.47383720841244</c:v>
+                  <c:v>0.419177951567796</c:v>
                 </c:pt>
                 <c:pt idx="1">
-                  <c:v>0.12592370397166</c:v>
+                  <c:v>0.121759269455934</c:v>
                 </c:pt>
               </c:numCache>
             </c:numRef>
@@ -6030,7 +6030,7 @@
           <a:lstStyle/>
           <a:p>
             <a:r>
-              <a:t>At €4.50m, Bana returns 62.4% (European) / 47.4% (Chinese) on a sale at COD and 12.0% / 12.6% if held</a:t>
+              <a:t>At €4.50m, Bana returns 28.4% (European) / 41.9% (Chinese) on a sale at COD and 8.3% / 12.2% if held</a:t>
             </a:r>
           </a:p>
         </p:txBody>
@@ -6374,7 +6374,7 @@
                 </a:solidFill>
                 <a:latin typeface="Aptos"/>
               </a:rPr>
-              <a:t>FEP funds €24.6m of equity to COD (€30.2m Chinese) and bids 59.5 points (47.5 Chinese) into the 30 October tender; the European route needs a permit amendment.</a:t>
+              <a:t>FEP funds €53.6m of equity to COD (€44.5m Chinese) and bids 59.5 points (47.5 Chinese) into the 30 October tender; the European route needs a permit amendment.</a:t>
             </a:r>
           </a:p>
         </p:txBody>
@@ -6388,7 +6388,7 @@
         <p:spPr>
           <a:xfrm>
             <a:off x="4498848" y="2240280"/>
-            <a:ext cx="6949440" cy="7223760"/>
+            <a:ext cx="6949440" cy="5751576"/>
           </a:xfrm>
           <a:prstGeom prst="rect">
             <a:avLst/>
@@ -6402,7 +6402,7 @@
           <a:lstStyle/>
           <a:p>
             <a:r>
-              <a:rPr sz="1500" b="0">
+              <a:rPr sz="1600" b="0">
                 <a:solidFill>
                   <a:srgbClr val="3C3C3B"/>
                 </a:solidFill>
@@ -6413,7 +6413,7 @@
           </a:p>
           <a:p>
             <a:r>
-              <a:rPr sz="1500" b="0">
+              <a:rPr sz="1600" b="0">
                 <a:solidFill>
                   <a:srgbClr val="3C3C3B"/>
                 </a:solidFill>
@@ -6424,7 +6424,7 @@
           </a:p>
           <a:p>
             <a:r>
-              <a:rPr sz="1500" b="0">
+              <a:rPr sz="1600" b="0">
                 <a:solidFill>
                   <a:srgbClr val="3C3C3B"/>
                 </a:solidFill>
@@ -6435,7 +6435,7 @@
           </a:p>
           <a:p>
             <a:r>
-              <a:rPr sz="1500" b="0">
+              <a:rPr sz="1600" b="0">
                 <a:solidFill>
                   <a:srgbClr val="3C3C3B"/>
                 </a:solidFill>
@@ -6446,7 +6446,7 @@
           </a:p>
           <a:p>
             <a:r>
-              <a:rPr sz="1500" b="0">
+              <a:rPr sz="1600" b="0">
                 <a:solidFill>
                   <a:srgbClr val="3C3C3B"/>
                 </a:solidFill>
@@ -6457,7 +6457,7 @@
           </a:p>
           <a:p>
             <a:r>
-              <a:rPr sz="1500" b="0">
+              <a:rPr sz="1600" b="0">
                 <a:solidFill>
                   <a:srgbClr val="3C3C3B"/>
                 </a:solidFill>
@@ -6468,7 +6468,7 @@
           </a:p>
           <a:p>
             <a:r>
-              <a:rPr sz="1500" b="0">
+              <a:rPr sz="1600" b="0">
                 <a:solidFill>
                   <a:srgbClr val="3C3C3B"/>
                 </a:solidFill>
@@ -6479,7 +6479,7 @@
           </a:p>
           <a:p>
             <a:r>
-              <a:rPr sz="1500" b="0">
+              <a:rPr sz="1600" b="0">
                 <a:solidFill>
                   <a:srgbClr val="3C3C3B"/>
                 </a:solidFill>
@@ -6490,13 +6490,35 @@
           </a:p>
           <a:p>
             <a:r>
-              <a:rPr sz="1500" b="0">
+              <a:rPr sz="1600" b="0">
                 <a:solidFill>
                   <a:srgbClr val="3C3C3B"/>
                 </a:solidFill>
                 <a:latin typeface="Aptos"/>
               </a:rPr>
               <a:t>FEP asks the IC to approve the purchase price and to give its view on buying and developing the project.</a:t>
+            </a:r>
+          </a:p>
+          <a:p>
+            <a:r>
+              <a:rPr sz="1600" b="0">
+                <a:solidFill>
+                  <a:srgbClr val="3C3C3B"/>
+                </a:solidFill>
+                <a:latin typeface="Aptos"/>
+              </a:rPr>
+              <a:t/>
+            </a:r>
+          </a:p>
+          <a:p>
+            <a:r>
+              <a:rPr sz="1600" b="0">
+                <a:solidFill>
+                  <a:srgbClr val="3C3C3B"/>
+                </a:solidFill>
+                <a:latin typeface="Aptos"/>
+              </a:rPr>
+              <a:t>We are assuming a COD sale price of €2.45m/MW with EU turbines and €2.10m/MW with Chinese turbines</a:t>
             </a:r>
           </a:p>
         </p:txBody>
@@ -6769,7 +6791,7 @@
                           </a:solidFill>
                           <a:latin typeface="Aptos"/>
                         </a:rPr>
-                        <a:t>24.6</a:t>
+                        <a:t>53.6</a:t>
                       </a:r>
                     </a:p>
                   </a:txBody>
@@ -6790,7 +6812,7 @@
                           </a:solidFill>
                           <a:latin typeface="Aptos"/>
                         </a:rPr>
-                        <a:t>30.2</a:t>
+                        <a:t>44.5</a:t>
                       </a:r>
                     </a:p>
                   </a:txBody>
@@ -6926,7 +6948,7 @@
                           </a:solidFill>
                           <a:latin typeface="Aptos"/>
                         </a:rPr>
-                        <a:t>41.4</a:t>
+                        <a:t>21.9</a:t>
                       </a:r>
                     </a:p>
                   </a:txBody>
@@ -6947,7 +6969,7 @@
                           </a:solidFill>
                           <a:latin typeface="Aptos"/>
                         </a:rPr>
-                        <a:t>30.2</a:t>
+                        <a:t>31.3</a:t>
                       </a:r>
                     </a:p>
                   </a:txBody>
@@ -7016,7 +7038,7 @@
                           </a:solidFill>
                           <a:latin typeface="Aptos"/>
                         </a:rPr>
-                        <a:t>62.4%</a:t>
+                        <a:t>28.4%</a:t>
                       </a:r>
                     </a:p>
                   </a:txBody>
@@ -7039,7 +7061,7 @@
                           </a:solidFill>
                           <a:latin typeface="Aptos"/>
                         </a:rPr>
-                        <a:t>47.4%</a:t>
+                        <a:t>41.9%</a:t>
                       </a:r>
                     </a:p>
                   </a:txBody>
@@ -7110,7 +7132,7 @@
                           </a:solidFill>
                           <a:latin typeface="Aptos"/>
                         </a:rPr>
-                        <a:t>2.68x</a:t>
+                        <a:t>1.41x</a:t>
                       </a:r>
                     </a:p>
                   </a:txBody>
@@ -7131,7 +7153,7 @@
                           </a:solidFill>
                           <a:latin typeface="Aptos"/>
                         </a:rPr>
-                        <a:t>2.00x</a:t>
+                        <a:t>1.70x</a:t>
                       </a:r>
                     </a:p>
                   </a:txBody>
@@ -7267,7 +7289,7 @@
                           </a:solidFill>
                           <a:latin typeface="Aptos"/>
                         </a:rPr>
-                        <a:t>12.0%</a:t>
+                        <a:t>8.3%</a:t>
                       </a:r>
                     </a:p>
                   </a:txBody>
@@ -7290,7 +7312,7 @@
                           </a:solidFill>
                           <a:latin typeface="Aptos"/>
                         </a:rPr>
-                        <a:t>12.6%</a:t>
+                        <a:t>12.2%</a:t>
                       </a:r>
                     </a:p>
                   </a:txBody>
@@ -7361,7 +7383,7 @@
                           </a:solidFill>
                           <a:latin typeface="Aptos"/>
                         </a:rPr>
-                        <a:t>6.17x</a:t>
+                        <a:t>3.54x</a:t>
                       </a:r>
                     </a:p>
                   </a:txBody>
@@ -7382,7 +7404,7 @@
                           </a:solidFill>
                           <a:latin typeface="Aptos"/>
                         </a:rPr>
-                        <a:t>5.74x</a:t>
+                        <a:t>4.85x</a:t>
                       </a:r>
                     </a:p>
                   </a:txBody>
@@ -7451,7 +7473,7 @@
                           </a:solidFill>
                           <a:latin typeface="Aptos"/>
                         </a:rPr>
-                        <a:t>13.5</a:t>
+                        <a:t>1.6</a:t>
                       </a:r>
                     </a:p>
                   </a:txBody>
@@ -7472,7 +7494,7 @@
                           </a:solidFill>
                           <a:latin typeface="Aptos"/>
                         </a:rPr>
-                        <a:t>16.9</a:t>
+                        <a:t>19.7</a:t>
                       </a:r>
                     </a:p>
                   </a:txBody>
@@ -7541,7 +7563,7 @@
                           </a:solidFill>
                           <a:latin typeface="Aptos"/>
                         </a:rPr>
-                        <a:t>1.55x</a:t>
+                        <a:t>1.94x</a:t>
                       </a:r>
                     </a:p>
                   </a:txBody>
@@ -7562,7 +7584,7 @@
                           </a:solidFill>
                           <a:latin typeface="Aptos"/>
                         </a:rPr>
-                        <a:t>1.93x</a:t>
+                        <a:t>2.86x</a:t>
                       </a:r>
                     </a:p>
                   </a:txBody>
@@ -9492,7 +9514,7 @@
           <a:lstStyle/>
           <a:p>
             <a:r>
-              <a:t>55 MW producing 131.9 GWh a year; the bid scores 59.5 points with European turbines and 47.5 with Chinese</a:t>
+              <a:t>55 MW producing 139.4 GWh a year; the bid scores 59.5 points with European turbines and 47.5 with Chinese</a:t>
             </a:r>
           </a:p>
         </p:txBody>
@@ -10164,7 +10186,7 @@
                           </a:solidFill>
                           <a:latin typeface="Aptos"/>
                         </a:rPr>
-                        <a:t>2,460 h</a:t>
+                        <a:t>2,600 h</a:t>
                       </a:r>
                     </a:p>
                   </a:txBody>
@@ -10256,7 +10278,7 @@
                           </a:solidFill>
                           <a:latin typeface="Aptos"/>
                         </a:rPr>
-                        <a:t>131.9 GWh</a:t>
+                        <a:t>139.4 GWh</a:t>
                       </a:r>
                     </a:p>
                   </a:txBody>
@@ -11438,7 +11460,7 @@
           <a:lstStyle/>
           <a:p>
             <a:r>
-              <a:t>Uses to COD of €92.3m with European turbines (€84.2m Chinese); senior debt funds 73% (64%) and FEP the rest</a:t>
+              <a:t>Uses to COD of €111.8m with European turbines (€83.1m Chinese); senior debt funds 52% (46%) and FEP the rest</a:t>
             </a:r>
           </a:p>
         </p:txBody>
@@ -12145,7 +12167,7 @@
                           </a:solidFill>
                           <a:latin typeface="Aptos"/>
                         </a:rPr>
-                        <a:t>70.2</a:t>
+                        <a:t>90.4</a:t>
                       </a:r>
                     </a:p>
                   </a:txBody>
@@ -12415,7 +12437,7 @@
                           </a:solidFill>
                           <a:latin typeface="Aptos"/>
                         </a:rPr>
-                        <a:t>4.8</a:t>
+                        <a:t>4.1</a:t>
                       </a:r>
                     </a:p>
                   </a:txBody>
@@ -12436,7 +12458,7 @@
                           </a:solidFill>
                           <a:latin typeface="Aptos"/>
                         </a:rPr>
-                        <a:t>3.9</a:t>
+                        <a:t>2.8</a:t>
                       </a:r>
                     </a:p>
                   </a:txBody>
@@ -12595,7 +12617,7 @@
                           </a:solidFill>
                           <a:latin typeface="Aptos"/>
                         </a:rPr>
-                        <a:t>92.3</a:t>
+                        <a:t>111.8</a:t>
                       </a:r>
                     </a:p>
                   </a:txBody>
@@ -12618,7 +12640,7 @@
                           </a:solidFill>
                           <a:latin typeface="Aptos"/>
                         </a:rPr>
-                        <a:t>84.2</a:t>
+                        <a:t>83.1</a:t>
                       </a:r>
                     </a:p>
                   </a:txBody>
@@ -12689,7 +12711,7 @@
                           </a:solidFill>
                           <a:latin typeface="Aptos"/>
                         </a:rPr>
-                        <a:t>67.7</a:t>
+                        <a:t>58.1</a:t>
                       </a:r>
                     </a:p>
                   </a:txBody>
@@ -12710,7 +12732,7 @@
                           </a:solidFill>
                           <a:latin typeface="Aptos"/>
                         </a:rPr>
-                        <a:t>54.1</a:t>
+                        <a:t>38.6</a:t>
                       </a:r>
                     </a:p>
                   </a:txBody>
@@ -12779,7 +12801,7 @@
                           </a:solidFill>
                           <a:latin typeface="Aptos"/>
                         </a:rPr>
-                        <a:t>24.6</a:t>
+                        <a:t>53.6</a:t>
                       </a:r>
                     </a:p>
                   </a:txBody>
@@ -12802,7 +12824,7 @@
                           </a:solidFill>
                           <a:latin typeface="Aptos"/>
                         </a:rPr>
-                        <a:t>30.2</a:t>
+                        <a:t>44.5</a:t>
                       </a:r>
                     </a:p>
                   </a:txBody>
@@ -12873,7 +12895,7 @@
                           </a:solidFill>
                           <a:latin typeface="Aptos"/>
                         </a:rPr>
-                        <a:t>26.0</a:t>
+                        <a:t>54.8</a:t>
                       </a:r>
                     </a:p>
                   </a:txBody>
@@ -12894,7 +12916,7 @@
                           </a:solidFill>
                           <a:latin typeface="Aptos"/>
                         </a:rPr>
-                        <a:t>31.3</a:t>
+                        <a:t>45.3</a:t>
                       </a:r>
                     </a:p>
                   </a:txBody>
@@ -13688,7 +13710,7 @@
                 </a:solidFill>
                 <a:latin typeface="Aptos"/>
               </a:rPr>
-              <a:t>Debt share = senior debt at COD ÷ total uses. Debt draws pro rata with construction costs at up to 80% (European) / 70% (Chinese) of cost; interest capitalised to COD. Securities are the same on both routes; HUF amounts at 365 HUF/EUR.</a:t>
+              <a:t>Debt share = senior debt at COD ÷ total uses. Debt draws pro rata with construction costs at up to 55% (European) / 50% (Chinese) of cost; interest capitalised to COD. Securities are the same on both routes; HUF amounts at 365 HUF/EUR.</a:t>
             </a:r>
           </a:p>
           <a:p>
@@ -13743,7 +13765,7 @@
           <a:lstStyle/>
           <a:p>
             <a:r>
-              <a:t>A sale at COD turns €24.6m of equity into €66.0m (2.68x); holding earns 12.0% at a 1.55x DSCR (European)</a:t>
+              <a:t>A sale at COD turns €53.6m of equity into €75.5m (1.41x); holding earns 8.3% at a 1.94x DSCR (European)</a:t>
             </a:r>
           </a:p>
         </p:txBody>
@@ -14087,7 +14109,7 @@
                 </a:solidFill>
                 <a:latin typeface="Aptos"/>
               </a:rPr>
-              <a:t>With Chinese turbines the sale returns 47.4% and the hold 12.6%; debt is sized at 80% / 70% of construction cost.</a:t>
+              <a:t>With Chinese turbines the sale returns 41.9% and the hold 12.2%; debt is sized at 55% / 50% of construction cost.</a:t>
             </a:r>
           </a:p>
         </p:txBody>
@@ -14450,7 +14472,7 @@
                           </a:solidFill>
                           <a:latin typeface="Aptos"/>
                         </a:rPr>
-                        <a:t>(67.7)</a:t>
+                        <a:t>(58.1)</a:t>
                       </a:r>
                     </a:p>
                   </a:txBody>
@@ -14471,7 +14493,7 @@
                           </a:solidFill>
                           <a:latin typeface="Aptos"/>
                         </a:rPr>
-                        <a:t>(54.1)</a:t>
+                        <a:t>(38.6)</a:t>
                       </a:r>
                     </a:p>
                   </a:txBody>
@@ -14582,7 +14604,7 @@
                           </a:solidFill>
                           <a:latin typeface="Aptos"/>
                         </a:rPr>
-                        <a:t>66.0</a:t>
+                        <a:t>75.5</a:t>
                       </a:r>
                     </a:p>
                   </a:txBody>
@@ -14603,7 +14625,7 @@
                           </a:solidFill>
                           <a:latin typeface="Aptos"/>
                         </a:rPr>
-                        <a:t>60.4</a:t>
+                        <a:t>75.9</a:t>
                       </a:r>
                     </a:p>
                   </a:txBody>
@@ -14714,7 +14736,7 @@
                           </a:solidFill>
                           <a:latin typeface="Aptos"/>
                         </a:rPr>
-                        <a:t>24.6</a:t>
+                        <a:t>53.6</a:t>
                       </a:r>
                     </a:p>
                   </a:txBody>
@@ -14735,7 +14757,7 @@
                           </a:solidFill>
                           <a:latin typeface="Aptos"/>
                         </a:rPr>
-                        <a:t>30.2</a:t>
+                        <a:t>44.5</a:t>
                       </a:r>
                     </a:p>
                   </a:txBody>
@@ -14756,7 +14778,7 @@
                           </a:solidFill>
                           <a:latin typeface="Aptos"/>
                         </a:rPr>
-                        <a:t>26.0</a:t>
+                        <a:t>54.8</a:t>
                       </a:r>
                     </a:p>
                   </a:txBody>
@@ -14777,7 +14799,7 @@
                           </a:solidFill>
                           <a:latin typeface="Aptos"/>
                         </a:rPr>
-                        <a:t>31.3</a:t>
+                        <a:t>45.3</a:t>
                       </a:r>
                     </a:p>
                   </a:txBody>
@@ -14846,7 +14868,7 @@
                           </a:solidFill>
                           <a:latin typeface="Aptos"/>
                         </a:rPr>
-                        <a:t>41.4</a:t>
+                        <a:t>21.9</a:t>
                       </a:r>
                     </a:p>
                   </a:txBody>
@@ -14867,7 +14889,7 @@
                           </a:solidFill>
                           <a:latin typeface="Aptos"/>
                         </a:rPr>
-                        <a:t>30.2</a:t>
+                        <a:t>31.3</a:t>
                       </a:r>
                     </a:p>
                   </a:txBody>
@@ -14888,7 +14910,7 @@
                           </a:solidFill>
                           <a:latin typeface="Aptos"/>
                         </a:rPr>
-                        <a:t>134.5</a:t>
+                        <a:t>139.3</a:t>
                       </a:r>
                     </a:p>
                   </a:txBody>
@@ -14909,7 +14931,7 @@
                           </a:solidFill>
                           <a:latin typeface="Aptos"/>
                         </a:rPr>
-                        <a:t>148.4</a:t>
+                        <a:t>174.7</a:t>
                       </a:r>
                     </a:p>
                   </a:txBody>
@@ -14978,7 +15000,7 @@
                           </a:solidFill>
                           <a:latin typeface="Aptos"/>
                         </a:rPr>
-                        <a:t>62.4%</a:t>
+                        <a:t>28.4%</a:t>
                       </a:r>
                     </a:p>
                   </a:txBody>
@@ -15001,7 +15023,7 @@
                           </a:solidFill>
                           <a:latin typeface="Aptos"/>
                         </a:rPr>
-                        <a:t>47.4%</a:t>
+                        <a:t>41.9%</a:t>
                       </a:r>
                     </a:p>
                   </a:txBody>
@@ -15024,7 +15046,7 @@
                           </a:solidFill>
                           <a:latin typeface="Aptos"/>
                         </a:rPr>
-                        <a:t>12.0%</a:t>
+                        <a:t>8.3%</a:t>
                       </a:r>
                     </a:p>
                   </a:txBody>
@@ -15047,7 +15069,7 @@
                           </a:solidFill>
                           <a:latin typeface="Aptos"/>
                         </a:rPr>
-                        <a:t>12.6%</a:t>
+                        <a:t>12.2%</a:t>
                       </a:r>
                     </a:p>
                   </a:txBody>
@@ -15118,7 +15140,7 @@
                           </a:solidFill>
                           <a:latin typeface="Aptos"/>
                         </a:rPr>
-                        <a:t>2.68x</a:t>
+                        <a:t>1.41x</a:t>
                       </a:r>
                     </a:p>
                   </a:txBody>
@@ -15139,7 +15161,7 @@
                           </a:solidFill>
                           <a:latin typeface="Aptos"/>
                         </a:rPr>
-                        <a:t>2.00x</a:t>
+                        <a:t>1.70x</a:t>
                       </a:r>
                     </a:p>
                   </a:txBody>
@@ -15160,7 +15182,7 @@
                           </a:solidFill>
                           <a:latin typeface="Aptos"/>
                         </a:rPr>
-                        <a:t>6.17x</a:t>
+                        <a:t>3.54x</a:t>
                       </a:r>
                     </a:p>
                   </a:txBody>
@@ -15181,7 +15203,7 @@
                           </a:solidFill>
                           <a:latin typeface="Aptos"/>
                         </a:rPr>
-                        <a:t>5.74x</a:t>
+                        <a:t>4.85x</a:t>
                       </a:r>
                     </a:p>
                   </a:txBody>
@@ -15250,7 +15272,7 @@
                           </a:solidFill>
                           <a:latin typeface="Aptos"/>
                         </a:rPr>
-                        <a:t>28.5</a:t>
+                        <a:t>12.3</a:t>
                       </a:r>
                     </a:p>
                   </a:txBody>
@@ -15271,7 +15293,7 @@
                           </a:solidFill>
                           <a:latin typeface="Aptos"/>
                         </a:rPr>
-                        <a:t>19.8</a:t>
+                        <a:t>19.9</a:t>
                       </a:r>
                     </a:p>
                   </a:txBody>
@@ -15292,7 +15314,7 @@
                           </a:solidFill>
                           <a:latin typeface="Aptos"/>
                         </a:rPr>
-                        <a:t>13.5</a:t>
+                        <a:t>1.6</a:t>
                       </a:r>
                     </a:p>
                   </a:txBody>
@@ -15313,7 +15335,7 @@
                           </a:solidFill>
                           <a:latin typeface="Aptos"/>
                         </a:rPr>
-                        <a:t>16.9</a:t>
+                        <a:t>19.7</a:t>
                       </a:r>
                     </a:p>
                   </a:txBody>
@@ -15424,7 +15446,7 @@
                           </a:solidFill>
                           <a:latin typeface="Aptos"/>
                         </a:rPr>
-                        <a:t>8.7%</a:t>
+                        <a:t>7.4%</a:t>
                       </a:r>
                     </a:p>
                   </a:txBody>
@@ -15445,7 +15467,7 @@
                           </a:solidFill>
                           <a:latin typeface="Aptos"/>
                         </a:rPr>
-                        <a:t>9.5%</a:t>
+                        <a:t>10.1%</a:t>
                       </a:r>
                     </a:p>
                   </a:txBody>
@@ -15556,7 +15578,7 @@
                           </a:solidFill>
                           <a:latin typeface="Aptos"/>
                         </a:rPr>
-                        <a:t>1.55x</a:t>
+                        <a:t>1.94x</a:t>
                       </a:r>
                     </a:p>
                   </a:txBody>
@@ -15577,7 +15599,7 @@
                           </a:solidFill>
                           <a:latin typeface="Aptos"/>
                         </a:rPr>
-                        <a:t>1.93x</a:t>
+                        <a:t>2.86x</a:t>
                       </a:r>
                     </a:p>
                   </a:txBody>
@@ -15688,7 +15710,7 @@
                           </a:solidFill>
                           <a:latin typeface="Aptos"/>
                         </a:rPr>
-                        <a:t>(13.4)</a:t>
+                        <a:t>(13.8)</a:t>
                       </a:r>
                     </a:p>
                   </a:txBody>
@@ -15709,7 +15731,7 @@
                           </a:solidFill>
                           <a:latin typeface="Aptos"/>
                         </a:rPr>
-                        <a:t>(14.7)</a:t>
+                        <a:t>(17.3)</a:t>
                       </a:r>
                     </a:p>
                   </a:txBody>
@@ -15813,7 +15835,7 @@
                 </a:solidFill>
                 <a:latin typeface="Aptos"/>
               </a:rPr>
-              <a:t>1.20x target DSCR over 18 years, 5.0% fixed; sized at the lower of the DSCR capacity and 80% / 70% of cost; 77% / 62% of the DSCR capacity is used.</a:t>
+              <a:t>1.20x target DSCR over 18 years, 5.0% fixed; sized at the lower of the DSCR capacity and 55% / 50% of cost; 62% / 42% of the DSCR capacity is used.</a:t>
             </a:r>
           </a:p>
           <a:p>
@@ -15927,7 +15949,7 @@
           <a:lstStyle/>
           <a:p>
             <a:r>
-              <a:t>A lower COD price is the largest risk to the sale (47.7%); yield and PPA price drive the hold (9.4% / 9.1%)</a:t>
+              <a:t>A lower COD price is the largest risk to the sale (12.1%); the hold moves with yield (6.5% if lower) and PPA price (10.1% if higher)</a:t>
             </a:r>
           </a:p>
         </p:txBody>
@@ -16503,7 +16525,7 @@
                           </a:solidFill>
                           <a:latin typeface="Aptos"/>
                         </a:rPr>
-                        <a:t>62.4%</a:t>
+                        <a:t>28.4%</a:t>
                       </a:r>
                     </a:p>
                   </a:txBody>
@@ -16526,7 +16548,7 @@
                           </a:solidFill>
                           <a:latin typeface="Aptos"/>
                         </a:rPr>
-                        <a:t>47.4%</a:t>
+                        <a:t>41.9%</a:t>
                       </a:r>
                     </a:p>
                   </a:txBody>
@@ -16549,7 +16571,7 @@
                           </a:solidFill>
                           <a:latin typeface="Aptos"/>
                         </a:rPr>
-                        <a:t>12.0%</a:t>
+                        <a:t>8.3%</a:t>
                       </a:r>
                     </a:p>
                   </a:txBody>
@@ -16572,7 +16594,7 @@
                           </a:solidFill>
                           <a:latin typeface="Aptos"/>
                         </a:rPr>
-                        <a:t>12.6%</a:t>
+                        <a:t>12.2%</a:t>
                       </a:r>
                     </a:p>
                   </a:txBody>
@@ -16595,7 +16617,7 @@
                           </a:solidFill>
                           <a:latin typeface="Aptos"/>
                         </a:rPr>
-                        <a:t>1.55x</a:t>
+                        <a:t>1.94x</a:t>
                       </a:r>
                     </a:p>
                   </a:txBody>
@@ -16618,7 +16640,7 @@
                           </a:solidFill>
                           <a:latin typeface="Aptos"/>
                         </a:rPr>
-                        <a:t>1.93x</a:t>
+                        <a:t>2.86x</a:t>
                       </a:r>
                     </a:p>
                   </a:txBody>
@@ -16666,7 +16688,7 @@
                           </a:solidFill>
                           <a:latin typeface="Aptos"/>
                         </a:rPr>
-                        <a:t>47.7%</a:t>
+                        <a:t>12.1%</a:t>
                       </a:r>
                     </a:p>
                   </a:txBody>
@@ -16687,7 +16709,7 @@
                           </a:solidFill>
                           <a:latin typeface="Aptos"/>
                         </a:rPr>
-                        <a:t>32.8%</a:t>
+                        <a:t>28.9%</a:t>
                       </a:r>
                     </a:p>
                   </a:txBody>
@@ -16708,7 +16730,7 @@
                           </a:solidFill>
                           <a:latin typeface="Aptos"/>
                         </a:rPr>
-                        <a:t>12.0%</a:t>
+                        <a:t>8.3%</a:t>
                       </a:r>
                     </a:p>
                   </a:txBody>
@@ -16729,7 +16751,7 @@
                           </a:solidFill>
                           <a:latin typeface="Aptos"/>
                         </a:rPr>
-                        <a:t>12.6%</a:t>
+                        <a:t>12.2%</a:t>
                       </a:r>
                     </a:p>
                   </a:txBody>
@@ -16750,7 +16772,7 @@
                           </a:solidFill>
                           <a:latin typeface="Aptos"/>
                         </a:rPr>
-                        <a:t>1.55x</a:t>
+                        <a:t>1.94x</a:t>
                       </a:r>
                     </a:p>
                   </a:txBody>
@@ -16771,7 +16793,7 @@
                           </a:solidFill>
                           <a:latin typeface="Aptos"/>
                         </a:rPr>
-                        <a:t>1.93x</a:t>
+                        <a:t>2.86x</a:t>
                       </a:r>
                     </a:p>
                   </a:txBody>
@@ -16817,7 +16839,7 @@
                           </a:solidFill>
                           <a:latin typeface="Aptos"/>
                         </a:rPr>
-                        <a:t>58.2%</a:t>
+                        <a:t>21.2%</a:t>
                       </a:r>
                     </a:p>
                   </a:txBody>
@@ -16838,7 +16860,7 @@
                           </a:solidFill>
                           <a:latin typeface="Aptos"/>
                         </a:rPr>
-                        <a:t>43.3%</a:t>
+                        <a:t>38.1%</a:t>
                       </a:r>
                     </a:p>
                   </a:txBody>
@@ -16859,7 +16881,7 @@
                           </a:solidFill>
                           <a:latin typeface="Aptos"/>
                         </a:rPr>
-                        <a:t>11.2%</a:t>
+                        <a:t>7.6%</a:t>
                       </a:r>
                     </a:p>
                   </a:txBody>
@@ -16880,7 +16902,7 @@
                           </a:solidFill>
                           <a:latin typeface="Aptos"/>
                         </a:rPr>
-                        <a:t>12.0%</a:t>
+                        <a:t>11.7%</a:t>
                       </a:r>
                     </a:p>
                   </a:txBody>
@@ -16901,7 +16923,7 @@
                           </a:solidFill>
                           <a:latin typeface="Aptos"/>
                         </a:rPr>
-                        <a:t>1.49x</a:t>
+                        <a:t>1.84x</a:t>
                       </a:r>
                     </a:p>
                   </a:txBody>
@@ -16922,7 +16944,7 @@
                           </a:solidFill>
                           <a:latin typeface="Aptos"/>
                         </a:rPr>
-                        <a:t>1.86x</a:t>
+                        <a:t>2.76x</a:t>
                       </a:r>
                     </a:p>
                   </a:txBody>
@@ -16968,7 +16990,7 @@
                           </a:solidFill>
                           <a:latin typeface="Aptos"/>
                         </a:rPr>
-                        <a:t>62.4%</a:t>
+                        <a:t>28.4%</a:t>
                       </a:r>
                     </a:p>
                   </a:txBody>
@@ -16989,7 +17011,7 @@
                           </a:solidFill>
                           <a:latin typeface="Aptos"/>
                         </a:rPr>
-                        <a:t>47.4%</a:t>
+                        <a:t>41.9%</a:t>
                       </a:r>
                     </a:p>
                   </a:txBody>
@@ -17010,7 +17032,7 @@
                           </a:solidFill>
                           <a:latin typeface="Aptos"/>
                         </a:rPr>
-                        <a:t>9.4%</a:t>
+                        <a:t>6.5%</a:t>
                       </a:r>
                     </a:p>
                   </a:txBody>
@@ -17031,7 +17053,7 @@
                           </a:solidFill>
                           <a:latin typeface="Aptos"/>
                         </a:rPr>
-                        <a:t>10.2%</a:t>
+                        <a:t>10.3%</a:t>
                       </a:r>
                     </a:p>
                   </a:txBody>
@@ -17052,7 +17074,7 @@
                           </a:solidFill>
                           <a:latin typeface="Aptos"/>
                         </a:rPr>
-                        <a:t>1.37x</a:t>
+                        <a:t>1.72x</a:t>
                       </a:r>
                     </a:p>
                   </a:txBody>
@@ -17073,7 +17095,7 @@
                           </a:solidFill>
                           <a:latin typeface="Aptos"/>
                         </a:rPr>
-                        <a:t>1.71x</a:t>
+                        <a:t>2.53x</a:t>
                       </a:r>
                     </a:p>
                   </a:txBody>
@@ -17096,7 +17118,7 @@
                           </a:solidFill>
                           <a:latin typeface="Aptos"/>
                         </a:rPr>
-                        <a:t>PPA −10%</a:t>
+                        <a:t>PPA +10%</a:t>
                       </a:r>
                     </a:p>
                   </a:txBody>
@@ -17119,7 +17141,7 @@
                           </a:solidFill>
                           <a:latin typeface="Aptos"/>
                         </a:rPr>
-                        <a:t>62.4%</a:t>
+                        <a:t>28.4%</a:t>
                       </a:r>
                     </a:p>
                   </a:txBody>
@@ -17140,7 +17162,7 @@
                           </a:solidFill>
                           <a:latin typeface="Aptos"/>
                         </a:rPr>
-                        <a:t>47.4%</a:t>
+                        <a:t>41.9%</a:t>
                       </a:r>
                     </a:p>
                   </a:txBody>
@@ -17161,7 +17183,7 @@
                           </a:solidFill>
                           <a:latin typeface="Aptos"/>
                         </a:rPr>
-                        <a:t>9.1%</a:t>
+                        <a:t>10.1%</a:t>
                       </a:r>
                     </a:p>
                   </a:txBody>
@@ -17182,7 +17204,7 @@
                           </a:solidFill>
                           <a:latin typeface="Aptos"/>
                         </a:rPr>
-                        <a:t>10.0%</a:t>
+                        <a:t>14.2%</a:t>
                       </a:r>
                     </a:p>
                   </a:txBody>
@@ -17203,7 +17225,7 @@
                           </a:solidFill>
                           <a:latin typeface="Aptos"/>
                         </a:rPr>
-                        <a:t>1.35x</a:t>
+                        <a:t>2.18x</a:t>
                       </a:r>
                     </a:p>
                   </a:txBody>
@@ -17224,7 +17246,7 @@
                           </a:solidFill>
                           <a:latin typeface="Aptos"/>
                         </a:rPr>
-                        <a:t>1.68x</a:t>
+                        <a:t>3.22x</a:t>
                       </a:r>
                     </a:p>
                   </a:txBody>
@@ -17270,7 +17292,7 @@
                           </a:solidFill>
                           <a:latin typeface="Aptos"/>
                         </a:rPr>
-                        <a:t>60.2%</a:t>
+                        <a:t>25.9%</a:t>
                       </a:r>
                     </a:p>
                   </a:txBody>
@@ -17291,7 +17313,7 @@
                           </a:solidFill>
                           <a:latin typeface="Aptos"/>
                         </a:rPr>
-                        <a:t>44.8%</a:t>
+                        <a:t>39.6%</a:t>
                       </a:r>
                     </a:p>
                   </a:txBody>
@@ -17312,7 +17334,7 @@
                           </a:solidFill>
                           <a:latin typeface="Aptos"/>
                         </a:rPr>
-                        <a:t>11.4%</a:t>
+                        <a:t>8.0%</a:t>
                       </a:r>
                     </a:p>
                   </a:txBody>
@@ -17333,7 +17355,7 @@
                           </a:solidFill>
                           <a:latin typeface="Aptos"/>
                         </a:rPr>
-                        <a:t>12.0%</a:t>
+                        <a:t>11.7%</a:t>
                       </a:r>
                     </a:p>
                   </a:txBody>
@@ -17354,7 +17376,7 @@
                           </a:solidFill>
                           <a:latin typeface="Aptos"/>
                         </a:rPr>
-                        <a:t>1.55x</a:t>
+                        <a:t>1.94x</a:t>
                       </a:r>
                     </a:p>
                   </a:txBody>
@@ -17375,7 +17397,7 @@
                           </a:solidFill>
                           <a:latin typeface="Aptos"/>
                         </a:rPr>
-                        <a:t>1.93x</a:t>
+                        <a:t>2.86x</a:t>
                       </a:r>
                     </a:p>
                   </a:txBody>
@@ -17421,7 +17443,7 @@
                           </a:solidFill>
                           <a:latin typeface="Aptos"/>
                         </a:rPr>
-                        <a:t>61.8%</a:t>
+                        <a:t>27.8%</a:t>
                       </a:r>
                     </a:p>
                   </a:txBody>
@@ -17442,7 +17464,7 @@
                           </a:solidFill>
                           <a:latin typeface="Aptos"/>
                         </a:rPr>
-                        <a:t>46.8%</a:t>
+                        <a:t>41.5%</a:t>
                       </a:r>
                     </a:p>
                   </a:txBody>
@@ -17463,7 +17485,7 @@
                           </a:solidFill>
                           <a:latin typeface="Aptos"/>
                         </a:rPr>
-                        <a:t>10.9%</a:t>
+                        <a:t>7.8%</a:t>
                       </a:r>
                     </a:p>
                   </a:txBody>
@@ -17505,7 +17527,7 @@
                           </a:solidFill>
                           <a:latin typeface="Aptos"/>
                         </a:rPr>
-                        <a:t>1.43x</a:t>
+                        <a:t>1.78x</a:t>
                       </a:r>
                     </a:p>
                   </a:txBody>
@@ -17526,7 +17548,7 @@
                           </a:solidFill>
                           <a:latin typeface="Aptos"/>
                         </a:rPr>
-                        <a:t>1.78x</a:t>
+                        <a:t>2.63x</a:t>
                       </a:r>
                     </a:p>
                   </a:txBody>
@@ -17572,7 +17594,7 @@
                           </a:solidFill>
                           <a:latin typeface="Aptos"/>
                         </a:rPr>
-                        <a:t>57.7%</a:t>
+                        <a:t>28.4%</a:t>
                       </a:r>
                     </a:p>
                   </a:txBody>
@@ -17593,7 +17615,7 @@
                           </a:solidFill>
                           <a:latin typeface="Aptos"/>
                         </a:rPr>
-                        <a:t>47.4%</a:t>
+                        <a:t>41.9%</a:t>
                       </a:r>
                     </a:p>
                   </a:txBody>
@@ -17614,7 +17636,7 @@
                           </a:solidFill>
                           <a:latin typeface="Aptos"/>
                         </a:rPr>
-                        <a:t>9.7%</a:t>
+                        <a:t>7.7%</a:t>
                       </a:r>
                     </a:p>
                   </a:txBody>
@@ -17635,7 +17657,7 @@
                           </a:solidFill>
                           <a:latin typeface="Aptos"/>
                         </a:rPr>
-                        <a:t>11.0%</a:t>
+                        <a:t>11.3%</a:t>
                       </a:r>
                     </a:p>
                   </a:txBody>
@@ -17656,7 +17678,7 @@
                           </a:solidFill>
                           <a:latin typeface="Aptos"/>
                         </a:rPr>
-                        <a:t>1.20x</a:t>
+                        <a:t>1.27x</a:t>
                       </a:r>
                     </a:p>
                   </a:txBody>
@@ -17677,7 +17699,7 @@
                           </a:solidFill>
                           <a:latin typeface="Aptos"/>
                         </a:rPr>
-                        <a:t>1.27x</a:t>
+                        <a:t>1.88x</a:t>
                       </a:r>
                     </a:p>
                   </a:txBody>
@@ -17788,7 +17810,7 @@
                 </a:solidFill>
                 <a:latin typeface="Aptos"/>
               </a:rPr>
-              <a:t>55 MW built against 60 MW committed. Pro rata (GYIK 28/30) there is no PB call; if the full-call reading (GYIK 72) applies, the €2.22m PB is lost: COD IRR 60.2%, hold IRR 11.4% (European).</a:t>
+              <a:t>55 MW built against 60 MW committed. Pro rata (GYIK 28/30) there is no PB call; if the full-call reading (GYIK 72) applies, the €2.22m PB is lost: COD IRR 25.9%, hold IRR 8.0% (European).</a:t>
             </a:r>
           </a:p>
           <a:p>
@@ -17863,7 +17885,7 @@
                 </a:solidFill>
                 <a:latin typeface="Aptos"/>
               </a:rPr>
-              <a:t>a 10-year tenor makes the DSCR bind and cuts the European hold IRR to 9.7%.</a:t>
+              <a:t>a 10-year tenor lowers the European minimum DSCR to 1.27x and the hold IRR to 7.7%.</a:t>
             </a:r>
           </a:p>
         </p:txBody>

</xml_diff>

<commit_message>
Fix the buyer PB-call double count; flag Robin Hood and the 15% tax proxy; max-debt info in the deck
Co-Authored-By: Claude Opus 5.5 <noreply@anthropic.com>
Claude-Session: https://claude.ai/code/session_01AWS1t9WtpkQHcCU1WceGZT
</commit_message>
<xml_diff>
--- a/projects/bana/out/Bana_IC.pptx
+++ b/projects/bana/out/Bana_IC.pptx
@@ -5919,7 +5919,7 @@
                 <a:latin typeface="Aptos"/>
                 <a:cs typeface="Aptos"/>
               </a:rPr>
-              <a:t>13 October 2026</a:t>
+              <a:t>14 October 2026</a:t>
             </a:r>
             <a:endParaRPr lang="en-GB" sz="4950" spc="-10" noProof="0" dirty="0">
               <a:solidFill>
@@ -7766,7 +7766,7 @@
                 </a:solidFill>
                 <a:latin typeface="Aptos"/>
               </a:rPr>
-              <a:t>Source: Bana_Model.xlsm, 13 Oct 2026.</a:t>
+              <a:t>Source: Bana_Model.xlsm, 14 Oct 2026.</a:t>
             </a:r>
           </a:p>
         </p:txBody>
@@ -11621,7 +11621,7 @@
                 </a:solidFill>
                 <a:latin typeface="Aptos"/>
               </a:rPr>
-              <a:t>Source: Bana_Model.xlsm, 13 Oct 2026.</a:t>
+              <a:t>Source: Bana_Model.xlsm, 14 Oct 2026.</a:t>
             </a:r>
           </a:p>
         </p:txBody>
@@ -13964,7 +13964,7 @@
                 </a:solidFill>
                 <a:latin typeface="Aptos"/>
               </a:rPr>
-              <a:t>Source: Bana_Model.xlsm, 13 Oct 2026.</a:t>
+              <a:t>Source: Bana_Model.xlsm, 14 Oct 2026.</a:t>
             </a:r>
           </a:p>
         </p:txBody>
@@ -16184,7 +16184,7 @@
         <p:spPr>
           <a:xfrm>
             <a:off x="14127480" y="5715000"/>
-            <a:ext cx="4069080" cy="3566160"/>
+            <a:ext cx="4069080" cy="3840480"/>
           </a:xfrm>
           <a:prstGeom prst="rect">
             <a:avLst/>
@@ -16264,6 +16264,31 @@
                 </a:solidFill>
                 <a:latin typeface="Aptos"/>
               </a:rPr>
+              <a:t>Maximum debt, no cap: </a:t>
+            </a:r>
+            <a:r>
+              <a:rPr sz="1300" b="0">
+                <a:solidFill>
+                  <a:srgbClr val="3C3C3B"/>
+                </a:solidFill>
+                <a:latin typeface="Aptos"/>
+              </a:rPr>
+              <a:t>€100.9m at 1.10x / €92.5m at 1.20x DSCR European (90% / 83% of uses); €97.8m / €89.7m Chinese.</a:t>
+            </a:r>
+          </a:p>
+          <a:p>
+            <a:pPr algn="l">
+              <a:spcBef>
+                <a:spcPts val="800"/>
+              </a:spcBef>
+            </a:pPr>
+            <a:r>
+              <a:rPr sz="1300" b="1">
+                <a:solidFill>
+                  <a:srgbClr val="3C3C3B"/>
+                </a:solidFill>
+                <a:latin typeface="Aptos"/>
+              </a:rPr>
               <a:t>Tax: </a:t>
             </a:r>
             <a:r>
@@ -16273,7 +16298,7 @@
                 </a:solidFill>
                 <a:latin typeface="Aptos"/>
               </a:rPr>
-              <a:t>CIT 15% (Pillar Two minimum), no Robin Hood tax in the base; 20-year depreciation; losses capped at 50% of the base and lapse after 5 years. Gain on the COD share sale exempt.</a:t>
+              <a:t>CIT 15%, a proxy for 9 % plus a possible Pillar Two top-up. Robin Hood tax is not in the base, but the 55 MW build crosses the 50 MW threshold its exemption relies on (to confirm). 20-year depreciation; losses capped at 50% of the base and lapse after 5 years. Gain on the COD share sale exempt.</a:t>
             </a:r>
           </a:p>
         </p:txBody>
@@ -16318,7 +16343,7 @@
                 </a:solidFill>
                 <a:latin typeface="Aptos"/>
               </a:rPr>
-              <a:t>Source: Bana_Model.xlsm, 13 Oct 2026.</a:t>
+              <a:t>Source: Bana_Model.xlsm, 14 Oct 2026.</a:t>
             </a:r>
           </a:p>
         </p:txBody>
@@ -16744,7 +16769,7 @@
                 </a:solidFill>
                 <a:latin typeface="Aptos"/>
               </a:rPr>
-              <a:t>The buyer receives the same cash flows on both routes, so the higher European price lowers its return; the price per MW is an estimate, not a bid.</a:t>
+              <a:t>The buyer receives the same EBITDA on both routes, so the higher European price lowers its return; the price per MW is an estimate, not a bid.</a:t>
             </a:r>
           </a:p>
         </p:txBody>
@@ -17615,7 +17640,7 @@
                 </a:solidFill>
                 <a:latin typeface="Aptos"/>
               </a:rPr>
-              <a:t>Buyer unlevered: pays the enterprise value at COD and receives EBITDA less tax, guarantee fees and any PB call. Buyer levered: pays the price less the senior debt, funds the DSRA and services the debt. Share deal: SPV tax, debt and depreciation continue.</a:t>
+              <a:t>Buyer unlevered: pays the enterprise value at COD and receives EBITDA less tax, guarantee fees and any PB call. Buyer levered: pays the price less the senior debt, funds the DSRA and services the debt. Share deal: SPV tax, debt and depreciation continue; the unlevered IRR uses the SPV's actual tax.</a:t>
             </a:r>
           </a:p>
           <a:p>
@@ -17626,7 +17651,7 @@
                 </a:solidFill>
                 <a:latin typeface="Aptos"/>
               </a:rPr>
-              <a:t>Source: Bana_Model.xlsm, 13 Oct 2026.</a:t>
+              <a:t>Source: Bana_Model.xlsm, 14 Oct 2026.</a:t>
             </a:r>
           </a:p>
         </p:txBody>
@@ -17670,7 +17695,7 @@
           <a:lstStyle/>
           <a:p>
             <a:r>
-              <a:t>A lower COD price is the largest risk to the sale (12.1%); the hold moves with yield (6.3% if lower) and PPA price (9.8% if higher)</a:t>
+              <a:t>A lower COD price hits the sale most (12.1%); Robin Hood tax (6.1%) and lower yield (6.3%) hit the hold</a:t>
             </a:r>
           </a:p>
         </p:txBody>
@@ -20047,7 +20072,7 @@
                 </a:solidFill>
                 <a:latin typeface="Aptos"/>
               </a:rPr>
-              <a:t>if the 31% levy applies, the hold IRR falls to 6.1% / 9.1%.</a:t>
+              <a:t>55 MW built may lose the 50 MW exemption; if the 31% levy applies, the hold IRR falls to 6.1% / 9.1%.</a:t>
             </a:r>
           </a:p>
           <a:p>
@@ -20142,7 +20167,7 @@
                 </a:solidFill>
                 <a:latin typeface="Aptos"/>
               </a:rPr>
-              <a:t>Source: Bana_Model.xlsm, 13 Oct 2026.</a:t>
+              <a:t>Source: Bana_Model.xlsm, 14 Oct 2026.</a:t>
             </a:r>
           </a:p>
         </p:txBody>

</xml_diff>

<commit_message>
Apply the Robin Hood tax in the Bana base case; set 10 becomes No Robin Hood
Co-Authored-By: Claude Opus 5.5 <noreply@anthropic.com>
Claude-Session: https://claude.ai/code/session_01AWS1t9WtpkQHcCU1WceGZT
</commit_message>
<xml_diff>
--- a/projects/bana/out/Bana_IC.pptx
+++ b/projects/bana/out/Bana_IC.pptx
@@ -250,7 +250,7 @@
                   <c:v>0.284084033636541</c:v>
                 </c:pt>
                 <c:pt idx="1">
-                  <c:v>0.0798286717747364</c:v>
+                  <c:v>0.0606372162720292</c:v>
                 </c:pt>
               </c:numCache>
             </c:numRef>
@@ -300,7 +300,7 @@
                   <c:v>0.431605205102548</c:v>
                 </c:pt>
                 <c:pt idx="1">
-                  <c:v>0.120333275856183</c:v>
+                  <c:v>0.0905083310230022</c:v>
                 </c:pt>
               </c:numCache>
             </c:numRef>
@@ -6031,7 +6031,7 @@
           <a:lstStyle/>
           <a:p>
             <a:r>
-              <a:t>At €4.50m, Bana returns 28.4% (European) / 43.2% (Chinese) on a sale at COD and 8.0% / 12.0% if held</a:t>
+              <a:t>At €4.50m, Bana returns 28.4% (European) / 43.2% (Chinese) on a sale at COD and 6.1% / 9.1% if held</a:t>
             </a:r>
           </a:p>
         </p:txBody>
@@ -7261,7 +7261,7 @@
                           </a:solidFill>
                           <a:latin typeface="Aptos"/>
                         </a:rPr>
-                        <a:t>5.7%</a:t>
+                        <a:t>4.3%</a:t>
                       </a:r>
                     </a:p>
                   </a:txBody>
@@ -7282,7 +7282,7 @@
                           </a:solidFill>
                           <a:latin typeface="Aptos"/>
                         </a:rPr>
-                        <a:t>7.0%</a:t>
+                        <a:t>4.9%</a:t>
                       </a:r>
                     </a:p>
                   </a:txBody>
@@ -7418,7 +7418,7 @@
                           </a:solidFill>
                           <a:latin typeface="Aptos"/>
                         </a:rPr>
-                        <a:t>8.0%</a:t>
+                        <a:t>6.1%</a:t>
                       </a:r>
                     </a:p>
                   </a:txBody>
@@ -7441,7 +7441,7 @@
                           </a:solidFill>
                           <a:latin typeface="Aptos"/>
                         </a:rPr>
-                        <a:t>12.0%</a:t>
+                        <a:t>9.1%</a:t>
                       </a:r>
                     </a:p>
                   </a:txBody>
@@ -7512,7 +7512,7 @@
                           </a:solidFill>
                           <a:latin typeface="Aptos"/>
                         </a:rPr>
-                        <a:t>3.37x</a:t>
+                        <a:t>2.50x</a:t>
                       </a:r>
                     </a:p>
                   </a:txBody>
@@ -7533,7 +7533,7 @@
                           </a:solidFill>
                           <a:latin typeface="Aptos"/>
                         </a:rPr>
-                        <a:t>4.85x</a:t>
+                        <a:t>3.44x</a:t>
                       </a:r>
                     </a:p>
                   </a:txBody>
@@ -7602,7 +7602,7 @@
                           </a:solidFill>
                           <a:latin typeface="Aptos"/>
                         </a:rPr>
-                        <a:t>(0.1)</a:t>
+                        <a:t>(9.3)</a:t>
                       </a:r>
                     </a:p>
                   </a:txBody>
@@ -7623,7 +7623,7 @@
                           </a:solidFill>
                           <a:latin typeface="Aptos"/>
                         </a:rPr>
-                        <a:t>17.7</a:t>
+                        <a:t>4.1</a:t>
                       </a:r>
                     </a:p>
                   </a:txBody>
@@ -7692,7 +7692,7 @@
                           </a:solidFill>
                           <a:latin typeface="Aptos"/>
                         </a:rPr>
-                        <a:t>1.91x</a:t>
+                        <a:t>1.76x</a:t>
                       </a:r>
                     </a:p>
                   </a:txBody>
@@ -7713,7 +7713,7 @@
                           </a:solidFill>
                           <a:latin typeface="Aptos"/>
                         </a:rPr>
-                        <a:t>2.53x</a:t>
+                        <a:t>2.16x</a:t>
                       </a:r>
                     </a:p>
                   </a:txBody>
@@ -14008,7 +14008,7 @@
           <a:lstStyle/>
           <a:p>
             <a:r>
-              <a:t>A sale at COD turns €53.6m of equity into €75.5m (1.41x); holding earns 8.0% at a 1.91x DSCR (European)</a:t>
+              <a:t>A sale at COD turns €53.6m of equity into €75.5m (1.41x); holding earns 6.1% at a 1.76x DSCR (European)</a:t>
             </a:r>
           </a:p>
         </p:txBody>
@@ -14390,7 +14390,7 @@
                 </a:solidFill>
                 <a:latin typeface="Aptos"/>
               </a:rPr>
-              <a:t>With Chinese turbines the sale returns 43.2% and the hold 12.0%; debt is capped at 55% of construction cost on both routes.</a:t>
+              <a:t>With Chinese turbines the sale returns 43.2% and the hold 9.1%; debt is capped at 55% of construction cost on both routes.</a:t>
             </a:r>
           </a:p>
         </p:txBody>
@@ -15017,7 +15017,7 @@
                           </a:solidFill>
                           <a:latin typeface="Aptos"/>
                         </a:rPr>
-                        <a:t>5.7% / 5.9%</a:t>
+                        <a:t>4.3% / 3.9%</a:t>
                       </a:r>
                     </a:p>
                   </a:txBody>
@@ -15038,7 +15038,7 @@
                           </a:solidFill>
                           <a:latin typeface="Aptos"/>
                         </a:rPr>
-                        <a:t>7.0% / 7.5%</a:t>
+                        <a:t>4.9% / 4.8%</a:t>
                       </a:r>
                     </a:p>
                   </a:txBody>
@@ -15323,7 +15323,7 @@
                           </a:solidFill>
                           <a:latin typeface="Aptos"/>
                         </a:rPr>
-                        <a:t>130.2</a:t>
+                        <a:t>82.4</a:t>
                       </a:r>
                     </a:p>
                   </a:txBody>
@@ -15344,7 +15344,7 @@
                           </a:solidFill>
                           <a:latin typeface="Aptos"/>
                         </a:rPr>
-                        <a:t>161.3</a:t>
+                        <a:t>102.1</a:t>
                       </a:r>
                     </a:p>
                   </a:txBody>
@@ -15459,7 +15459,7 @@
                           </a:solidFill>
                           <a:latin typeface="Aptos"/>
                         </a:rPr>
-                        <a:t>8.0%</a:t>
+                        <a:t>6.1%</a:t>
                       </a:r>
                     </a:p>
                   </a:txBody>
@@ -15482,7 +15482,7 @@
                           </a:solidFill>
                           <a:latin typeface="Aptos"/>
                         </a:rPr>
-                        <a:t>12.0%</a:t>
+                        <a:t>9.1%</a:t>
                       </a:r>
                     </a:p>
                   </a:txBody>
@@ -15595,7 +15595,7 @@
                           </a:solidFill>
                           <a:latin typeface="Aptos"/>
                         </a:rPr>
-                        <a:t>3.37x</a:t>
+                        <a:t>2.50x</a:t>
                       </a:r>
                     </a:p>
                   </a:txBody>
@@ -15616,7 +15616,7 @@
                           </a:solidFill>
                           <a:latin typeface="Aptos"/>
                         </a:rPr>
-                        <a:t>4.85x</a:t>
+                        <a:t>3.44x</a:t>
                       </a:r>
                     </a:p>
                   </a:txBody>
@@ -15727,7 +15727,7 @@
                           </a:solidFill>
                           <a:latin typeface="Aptos"/>
                         </a:rPr>
-                        <a:t>(0.1)</a:t>
+                        <a:t>(9.3)</a:t>
                       </a:r>
                     </a:p>
                   </a:txBody>
@@ -15748,7 +15748,7 @@
                           </a:solidFill>
                           <a:latin typeface="Aptos"/>
                         </a:rPr>
-                        <a:t>17.7</a:t>
+                        <a:t>4.1</a:t>
                       </a:r>
                     </a:p>
                   </a:txBody>
@@ -15859,7 +15859,7 @@
                           </a:solidFill>
                           <a:latin typeface="Aptos"/>
                         </a:rPr>
-                        <a:t>7.2%</a:t>
+                        <a:t>5.9%</a:t>
                       </a:r>
                     </a:p>
                   </a:txBody>
@@ -15880,7 +15880,7 @@
                           </a:solidFill>
                           <a:latin typeface="Aptos"/>
                         </a:rPr>
-                        <a:t>9.8%</a:t>
+                        <a:t>7.8%</a:t>
                       </a:r>
                     </a:p>
                   </a:txBody>
@@ -15991,7 +15991,7 @@
                           </a:solidFill>
                           <a:latin typeface="Aptos"/>
                         </a:rPr>
-                        <a:t>1.91x</a:t>
+                        <a:t>1.76x</a:t>
                       </a:r>
                     </a:p>
                   </a:txBody>
@@ -16012,7 +16012,7 @@
                           </a:solidFill>
                           <a:latin typeface="Aptos"/>
                         </a:rPr>
-                        <a:t>2.53x</a:t>
+                        <a:t>2.16x</a:t>
                       </a:r>
                     </a:p>
                   </a:txBody>
@@ -16123,7 +16123,7 @@
                           </a:solidFill>
                           <a:latin typeface="Aptos"/>
                         </a:rPr>
-                        <a:t>(23.1)</a:t>
+                        <a:t>(71.7)</a:t>
                       </a:r>
                     </a:p>
                   </a:txBody>
@@ -16144,7 +16144,7 @@
                           </a:solidFill>
                           <a:latin typeface="Aptos"/>
                         </a:rPr>
-                        <a:t>(28.5)</a:t>
+                        <a:t>(88.1)</a:t>
                       </a:r>
                     </a:p>
                   </a:txBody>
@@ -16248,7 +16248,7 @@
                 </a:solidFill>
                 <a:latin typeface="Aptos"/>
               </a:rPr>
-              <a:t>1.20x target DSCR over 18 years, 5.0% fixed; sized at the lower of the DSCR capacity and 55% of cost on both routes; 63% / 47% of the DSCR capacity is used.</a:t>
+              <a:t>1.20x target DSCR over 18 years, 5.0% fixed; sized at the lower of the DSCR capacity and 55% of cost on both routes; 68% / 55% of the DSCR capacity is used.</a:t>
             </a:r>
           </a:p>
           <a:p>
@@ -16273,7 +16273,7 @@
                 </a:solidFill>
                 <a:latin typeface="Aptos"/>
               </a:rPr>
-              <a:t>€100.9m at 1.10x / €92.5m at 1.20x DSCR European (90% / 83% of uses); €97.8m / €89.7m Chinese.</a:t>
+              <a:t>€92.8m at 1.10x / €85.1m at 1.20x DSCR European (83% / 76% of uses); €83.5m / €76.5m Chinese.</a:t>
             </a:r>
           </a:p>
           <a:p>
@@ -16298,7 +16298,7 @@
                 </a:solidFill>
                 <a:latin typeface="Aptos"/>
               </a:rPr>
-              <a:t>CIT 15%, a proxy for 9 % plus a possible Pillar Two top-up. Robin Hood tax is not in the base, but the 55 MW build crosses the 50 MW threshold its exemption relies on (to confirm). 20-year depreciation; losses capped at 50% of the base and lapse after 5 years. Gain on the COD share sale exempt.</a:t>
+              <a:t>CIT 15%, a proxy for 9 % plus a possible Pillar Two top-up; Robin Hood tax 31% of pre-tax profit (its exemption covers only KÁT/METÁR plants; Bana sells under a PPA). 20-year depreciation; losses capped at 50% of the base and lapse after 5 years. Gain on the COD share sale exempt.</a:t>
             </a:r>
           </a:p>
         </p:txBody>
@@ -16387,7 +16387,7 @@
           <a:lstStyle/>
           <a:p>
             <a:r>
-              <a:t>At 2,450 / 2,100 k€/MW a buyer earns 5.7% / 7.0%; at the lower price 6.7% / 8.1%, but FEP's sale IRR falls to 12.1% / 29.7%</a:t>
+              <a:t>At 2,450 / 2,100 k€/MW a buyer earns 4.3% / 4.9%; at the lower price 5.4% / 6.0%, but FEP's sale IRR falls to 12.1% / 29.7%</a:t>
             </a:r>
           </a:p>
         </p:txBody>
@@ -17070,7 +17070,7 @@
                           </a:solidFill>
                           <a:latin typeface="Aptos"/>
                         </a:rPr>
-                        <a:t>6.7%</a:t>
+                        <a:t>5.4%</a:t>
                       </a:r>
                     </a:p>
                   </a:txBody>
@@ -17091,7 +17091,7 @@
                           </a:solidFill>
                           <a:latin typeface="Aptos"/>
                         </a:rPr>
-                        <a:t>7.5%</a:t>
+                        <a:t>5.4%</a:t>
                       </a:r>
                     </a:p>
                   </a:txBody>
@@ -17154,7 +17154,7 @@
                           </a:solidFill>
                           <a:latin typeface="Aptos"/>
                         </a:rPr>
-                        <a:t>8.1%</a:t>
+                        <a:t>6.0%</a:t>
                       </a:r>
                     </a:p>
                   </a:txBody>
@@ -17175,7 +17175,7 @@
                           </a:solidFill>
                           <a:latin typeface="Aptos"/>
                         </a:rPr>
-                        <a:t>9.3%</a:t>
+                        <a:t>6.3%</a:t>
                       </a:r>
                     </a:p>
                   </a:txBody>
@@ -17265,7 +17265,7 @@
                           </a:solidFill>
                           <a:latin typeface="Aptos"/>
                         </a:rPr>
-                        <a:t>5.7%</a:t>
+                        <a:t>4.3%</a:t>
                       </a:r>
                     </a:p>
                   </a:txBody>
@@ -17288,7 +17288,7 @@
                           </a:solidFill>
                           <a:latin typeface="Aptos"/>
                         </a:rPr>
-                        <a:t>5.9%</a:t>
+                        <a:t>3.9%</a:t>
                       </a:r>
                     </a:p>
                   </a:txBody>
@@ -17357,7 +17357,7 @@
                           </a:solidFill>
                           <a:latin typeface="Aptos"/>
                         </a:rPr>
-                        <a:t>7.0%</a:t>
+                        <a:t>4.9%</a:t>
                       </a:r>
                     </a:p>
                   </a:txBody>
@@ -17380,7 +17380,7 @@
                           </a:solidFill>
                           <a:latin typeface="Aptos"/>
                         </a:rPr>
-                        <a:t>7.5%</a:t>
+                        <a:t>4.8%</a:t>
                       </a:r>
                     </a:p>
                   </a:txBody>
@@ -17472,7 +17472,7 @@
                           </a:solidFill>
                           <a:latin typeface="Aptos"/>
                         </a:rPr>
-                        <a:t>4.8%</a:t>
+                        <a:t>3.4%</a:t>
                       </a:r>
                     </a:p>
                   </a:txBody>
@@ -17493,7 +17493,7 @@
                           </a:solidFill>
                           <a:latin typeface="Aptos"/>
                         </a:rPr>
-                        <a:t>4.6%</a:t>
+                        <a:t>2.7%</a:t>
                       </a:r>
                     </a:p>
                   </a:txBody>
@@ -17556,7 +17556,7 @@
                           </a:solidFill>
                           <a:latin typeface="Aptos"/>
                         </a:rPr>
-                        <a:t>6.0%</a:t>
+                        <a:t>4.0%</a:t>
                       </a:r>
                     </a:p>
                   </a:txBody>
@@ -17577,7 +17577,7 @@
                           </a:solidFill>
                           <a:latin typeface="Aptos"/>
                         </a:rPr>
-                        <a:t>6.2%</a:t>
+                        <a:t>3.6%</a:t>
                       </a:r>
                     </a:p>
                   </a:txBody>
@@ -17695,7 +17695,7 @@
           <a:lstStyle/>
           <a:p>
             <a:r>
-              <a:t>A lower COD price hits the sale most (12.1%); Robin Hood tax (6.1%) and lower yield (6.3%) hit the hold</a:t>
+              <a:t>A lower COD price hits the sale most (12.1%); lower yield hits the hold most (4.8%)</a:t>
             </a:r>
           </a:p>
         </p:txBody>
@@ -18355,7 +18355,7 @@
                           </a:solidFill>
                           <a:latin typeface="Aptos"/>
                         </a:rPr>
-                        <a:t>8.0%</a:t>
+                        <a:t>6.1%</a:t>
                       </a:r>
                     </a:p>
                   </a:txBody>
@@ -18378,7 +18378,7 @@
                           </a:solidFill>
                           <a:latin typeface="Aptos"/>
                         </a:rPr>
-                        <a:t>12.0%</a:t>
+                        <a:t>9.1%</a:t>
                       </a:r>
                     </a:p>
                   </a:txBody>
@@ -18401,7 +18401,7 @@
                           </a:solidFill>
                           <a:latin typeface="Aptos"/>
                         </a:rPr>
-                        <a:t>1.91x</a:t>
+                        <a:t>1.76x</a:t>
                       </a:r>
                     </a:p>
                   </a:txBody>
@@ -18424,7 +18424,7 @@
                           </a:solidFill>
                           <a:latin typeface="Aptos"/>
                         </a:rPr>
-                        <a:t>2.53x</a:t>
+                        <a:t>2.16x</a:t>
                       </a:r>
                     </a:p>
                   </a:txBody>
@@ -18514,7 +18514,7 @@
                           </a:solidFill>
                           <a:latin typeface="Aptos"/>
                         </a:rPr>
-                        <a:t>8.0%</a:t>
+                        <a:t>6.1%</a:t>
                       </a:r>
                     </a:p>
                   </a:txBody>
@@ -18535,7 +18535,7 @@
                           </a:solidFill>
                           <a:latin typeface="Aptos"/>
                         </a:rPr>
-                        <a:t>12.0%</a:t>
+                        <a:t>9.1%</a:t>
                       </a:r>
                     </a:p>
                   </a:txBody>
@@ -18556,7 +18556,7 @@
                           </a:solidFill>
                           <a:latin typeface="Aptos"/>
                         </a:rPr>
-                        <a:t>1.91x</a:t>
+                        <a:t>1.76x</a:t>
                       </a:r>
                     </a:p>
                   </a:txBody>
@@ -18577,7 +18577,7 @@
                           </a:solidFill>
                           <a:latin typeface="Aptos"/>
                         </a:rPr>
-                        <a:t>2.53x</a:t>
+                        <a:t>2.16x</a:t>
                       </a:r>
                     </a:p>
                   </a:txBody>
@@ -18665,7 +18665,7 @@
                           </a:solidFill>
                           <a:latin typeface="Aptos"/>
                         </a:rPr>
-                        <a:t>8.0%</a:t>
+                        <a:t>6.1%</a:t>
                       </a:r>
                     </a:p>
                   </a:txBody>
@@ -18686,7 +18686,7 @@
                           </a:solidFill>
                           <a:latin typeface="Aptos"/>
                         </a:rPr>
-                        <a:t>12.0%</a:t>
+                        <a:t>9.1%</a:t>
                       </a:r>
                     </a:p>
                   </a:txBody>
@@ -18707,7 +18707,7 @@
                           </a:solidFill>
                           <a:latin typeface="Aptos"/>
                         </a:rPr>
-                        <a:t>1.91x</a:t>
+                        <a:t>1.76x</a:t>
                       </a:r>
                     </a:p>
                   </a:txBody>
@@ -18728,7 +18728,7 @@
                           </a:solidFill>
                           <a:latin typeface="Aptos"/>
                         </a:rPr>
-                        <a:t>2.53x</a:t>
+                        <a:t>2.16x</a:t>
                       </a:r>
                     </a:p>
                   </a:txBody>
@@ -18816,7 +18816,7 @@
                           </a:solidFill>
                           <a:latin typeface="Aptos"/>
                         </a:rPr>
-                        <a:t>7.3%</a:t>
+                        <a:t>5.6%</a:t>
                       </a:r>
                     </a:p>
                   </a:txBody>
@@ -18837,7 +18837,7 @@
                           </a:solidFill>
                           <a:latin typeface="Aptos"/>
                         </a:rPr>
-                        <a:t>11.5%</a:t>
+                        <a:t>8.7%</a:t>
                       </a:r>
                     </a:p>
                   </a:txBody>
@@ -18858,7 +18858,7 @@
                           </a:solidFill>
                           <a:latin typeface="Aptos"/>
                         </a:rPr>
-                        <a:t>1.82x</a:t>
+                        <a:t>1.70x</a:t>
                       </a:r>
                     </a:p>
                   </a:txBody>
@@ -18879,7 +18879,7 @@
                           </a:solidFill>
                           <a:latin typeface="Aptos"/>
                         </a:rPr>
-                        <a:t>2.45x</a:t>
+                        <a:t>2.11x</a:t>
                       </a:r>
                     </a:p>
                   </a:txBody>
@@ -18967,7 +18967,7 @@
                           </a:solidFill>
                           <a:latin typeface="Aptos"/>
                         </a:rPr>
-                        <a:t>6.3%</a:t>
+                        <a:t>4.8%</a:t>
                       </a:r>
                     </a:p>
                   </a:txBody>
@@ -18988,7 +18988,7 @@
                           </a:solidFill>
                           <a:latin typeface="Aptos"/>
                         </a:rPr>
-                        <a:t>10.1%</a:t>
+                        <a:t>7.6%</a:t>
                       </a:r>
                     </a:p>
                   </a:txBody>
@@ -19009,7 +19009,7 @@
                           </a:solidFill>
                           <a:latin typeface="Aptos"/>
                         </a:rPr>
-                        <a:t>1.70x</a:t>
+                        <a:t>1.62x</a:t>
                       </a:r>
                     </a:p>
                   </a:txBody>
@@ -19030,7 +19030,7 @@
                           </a:solidFill>
                           <a:latin typeface="Aptos"/>
                         </a:rPr>
-                        <a:t>2.26x</a:t>
+                        <a:t>1.99x</a:t>
                       </a:r>
                     </a:p>
                   </a:txBody>
@@ -19118,7 +19118,7 @@
                           </a:solidFill>
                           <a:latin typeface="Aptos"/>
                         </a:rPr>
-                        <a:t>9.8%</a:t>
+                        <a:t>7.4%</a:t>
                       </a:r>
                     </a:p>
                   </a:txBody>
@@ -19139,7 +19139,7 @@
                           </a:solidFill>
                           <a:latin typeface="Aptos"/>
                         </a:rPr>
-                        <a:t>14.1%</a:t>
+                        <a:t>10.6%</a:t>
                       </a:r>
                     </a:p>
                   </a:txBody>
@@ -19160,7 +19160,7 @@
                           </a:solidFill>
                           <a:latin typeface="Aptos"/>
                         </a:rPr>
-                        <a:t>2.13x</a:t>
+                        <a:t>1.90x</a:t>
                       </a:r>
                     </a:p>
                   </a:txBody>
@@ -19181,7 +19181,7 @@
                           </a:solidFill>
                           <a:latin typeface="Aptos"/>
                         </a:rPr>
-                        <a:t>2.84x</a:t>
+                        <a:t>2.36x</a:t>
                       </a:r>
                     </a:p>
                   </a:txBody>
@@ -19269,7 +19269,7 @@
                           </a:solidFill>
                           <a:latin typeface="Aptos"/>
                         </a:rPr>
-                        <a:t>7.7%</a:t>
+                        <a:t>5.8%</a:t>
                       </a:r>
                     </a:p>
                   </a:txBody>
@@ -19290,7 +19290,7 @@
                           </a:solidFill>
                           <a:latin typeface="Aptos"/>
                         </a:rPr>
-                        <a:t>11.6%</a:t>
+                        <a:t>8.6%</a:t>
                       </a:r>
                     </a:p>
                   </a:txBody>
@@ -19311,7 +19311,7 @@
                           </a:solidFill>
                           <a:latin typeface="Aptos"/>
                         </a:rPr>
-                        <a:t>1.91x</a:t>
+                        <a:t>1.76x</a:t>
                       </a:r>
                     </a:p>
                   </a:txBody>
@@ -19332,7 +19332,7 @@
                           </a:solidFill>
                           <a:latin typeface="Aptos"/>
                         </a:rPr>
-                        <a:t>2.53x</a:t>
+                        <a:t>2.16x</a:t>
                       </a:r>
                     </a:p>
                   </a:txBody>
@@ -19420,7 +19420,7 @@
                           </a:solidFill>
                           <a:latin typeface="Aptos"/>
                         </a:rPr>
-                        <a:t>7.5%</a:t>
+                        <a:t>5.7%</a:t>
                       </a:r>
                     </a:p>
                   </a:txBody>
@@ -19441,7 +19441,7 @@
                           </a:solidFill>
                           <a:latin typeface="Aptos"/>
                         </a:rPr>
-                        <a:t>11.6%</a:t>
+                        <a:t>8.7%</a:t>
                       </a:r>
                     </a:p>
                   </a:txBody>
@@ -19462,7 +19462,7 @@
                           </a:solidFill>
                           <a:latin typeface="Aptos"/>
                         </a:rPr>
-                        <a:t>1.76x</a:t>
+                        <a:t>1.65x</a:t>
                       </a:r>
                     </a:p>
                   </a:txBody>
@@ -19483,7 +19483,7 @@
                           </a:solidFill>
                           <a:latin typeface="Aptos"/>
                         </a:rPr>
-                        <a:t>2.34x</a:t>
+                        <a:t>2.03x</a:t>
                       </a:r>
                     </a:p>
                   </a:txBody>
@@ -19529,7 +19529,7 @@
                           </a:solidFill>
                           <a:latin typeface="Aptos"/>
                         </a:rPr>
-                        <a:t>28.4%</a:t>
+                        <a:t>27.9%</a:t>
                       </a:r>
                     </a:p>
                   </a:txBody>
@@ -19571,7 +19571,7 @@
                           </a:solidFill>
                           <a:latin typeface="Aptos"/>
                         </a:rPr>
-                        <a:t>7.4%</a:t>
+                        <a:t>5.5%</a:t>
                       </a:r>
                     </a:p>
                   </a:txBody>
@@ -19592,7 +19592,7 @@
                           </a:solidFill>
                           <a:latin typeface="Aptos"/>
                         </a:rPr>
-                        <a:t>10.9%</a:t>
+                        <a:t>8.1%</a:t>
                       </a:r>
                     </a:p>
                   </a:txBody>
@@ -19613,7 +19613,7 @@
                           </a:solidFill>
                           <a:latin typeface="Aptos"/>
                         </a:rPr>
-                        <a:t>1.25x</a:t>
+                        <a:t>1.20x</a:t>
                       </a:r>
                     </a:p>
                   </a:txBody>
@@ -19634,7 +19634,7 @@
                           </a:solidFill>
                           <a:latin typeface="Aptos"/>
                         </a:rPr>
-                        <a:t>1.66x</a:t>
+                        <a:t>1.42x</a:t>
                       </a:r>
                     </a:p>
                   </a:txBody>
@@ -19657,7 +19657,7 @@
                           </a:solidFill>
                           <a:latin typeface="Aptos"/>
                         </a:rPr>
-                        <a:t>Robin Hood 31%</a:t>
+                        <a:t>No Robin Hood</a:t>
                       </a:r>
                     </a:p>
                   </a:txBody>
@@ -19722,7 +19722,7 @@
                           </a:solidFill>
                           <a:latin typeface="Aptos"/>
                         </a:rPr>
-                        <a:t>6.1%</a:t>
+                        <a:t>8.0%</a:t>
                       </a:r>
                     </a:p>
                   </a:txBody>
@@ -19743,7 +19743,7 @@
                           </a:solidFill>
                           <a:latin typeface="Aptos"/>
                         </a:rPr>
-                        <a:t>9.1%</a:t>
+                        <a:t>12.0%</a:t>
                       </a:r>
                     </a:p>
                   </a:txBody>
@@ -19764,7 +19764,7 @@
                           </a:solidFill>
                           <a:latin typeface="Aptos"/>
                         </a:rPr>
-                        <a:t>1.76x</a:t>
+                        <a:t>1.91x</a:t>
                       </a:r>
                     </a:p>
                   </a:txBody>
@@ -19785,7 +19785,7 @@
                           </a:solidFill>
                           <a:latin typeface="Aptos"/>
                         </a:rPr>
-                        <a:t>2.16x</a:t>
+                        <a:t>2.53x</a:t>
                       </a:r>
                     </a:p>
                   </a:txBody>
@@ -19873,7 +19873,7 @@
                           </a:solidFill>
                           <a:latin typeface="Aptos"/>
                         </a:rPr>
-                        <a:t>8.3%</a:t>
+                        <a:t>6.5%</a:t>
                       </a:r>
                     </a:p>
                   </a:txBody>
@@ -19894,7 +19894,7 @@
                           </a:solidFill>
                           <a:latin typeface="Aptos"/>
                         </a:rPr>
-                        <a:t>12.5%</a:t>
+                        <a:t>9.7%</a:t>
                       </a:r>
                     </a:p>
                   </a:txBody>
@@ -19915,7 +19915,7 @@
                           </a:solidFill>
                           <a:latin typeface="Aptos"/>
                         </a:rPr>
-                        <a:t>1.94x</a:t>
+                        <a:t>1.78x</a:t>
                       </a:r>
                     </a:p>
                   </a:txBody>
@@ -19936,7 +19936,7 @@
                           </a:solidFill>
                           <a:latin typeface="Aptos"/>
                         </a:rPr>
-                        <a:t>2.60x</a:t>
+                        <a:t>2.23x</a:t>
                       </a:r>
                     </a:p>
                   </a:txBody>
@@ -20047,7 +20047,7 @@
                 </a:solidFill>
                 <a:latin typeface="Aptos"/>
               </a:rPr>
-              <a:t>55 MW built against 60 MW committed. Pro rata (GYIK 28/30) there is no PB call; if the full-call reading (GYIK 72) applies, the €2.22m PB is lost: COD IRR 25.9%, hold IRR 7.7% (European).</a:t>
+              <a:t>55 MW built against 60 MW committed. Pro rata (GYIK 28/30) there is no PB call; if the full-call reading (GYIK 72) applies, the €2.22m PB is lost: COD IRR 25.9%, hold IRR 5.8% (European).</a:t>
             </a:r>
           </a:p>
           <a:p>
@@ -20072,7 +20072,7 @@
                 </a:solidFill>
                 <a:latin typeface="Aptos"/>
               </a:rPr>
-              <a:t>55 MW built may lose the 50 MW exemption; if the 31% levy applies, the hold IRR falls to 6.1% / 9.1%.</a:t>
+              <a:t>in the base at 31%; without it the hold IRR would be 8.0% / 12.0%.</a:t>
             </a:r>
           </a:p>
           <a:p>
@@ -20122,7 +20122,7 @@
                 </a:solidFill>
                 <a:latin typeface="Aptos"/>
               </a:rPr>
-              <a:t>a 10-year tenor lowers the European minimum DSCR to 1.25x and the hold IRR to 7.4%.</a:t>
+              <a:t>a 10-year tenor lowers the European minimum DSCR to 1.20x and the hold IRR to 5.5%.</a:t>
             </a:r>
           </a:p>
         </p:txBody>

</xml_diff>

<commit_message>
Keep Robin Hood tax as a sensitivity only; rebuild only when needed
Co-Authored-By: Claude Opus 5.5 <noreply@anthropic.com>
Claude-Session: https://claude.ai/code/session_01AWS1t9WtpkQHcCU1WceGZT
</commit_message>
<xml_diff>
--- a/projects/bana/out/Bana_IC.pptx
+++ b/projects/bana/out/Bana_IC.pptx
@@ -250,7 +250,7 @@
                   <c:v>0.284084033636541</c:v>
                 </c:pt>
                 <c:pt idx="1">
-                  <c:v>0.0606372162720292</c:v>
+                  <c:v>0.0798286717747364</c:v>
                 </c:pt>
               </c:numCache>
             </c:numRef>
@@ -300,7 +300,7 @@
                   <c:v>0.431605205102548</c:v>
                 </c:pt>
                 <c:pt idx="1">
-                  <c:v>0.0905083310230022</c:v>
+                  <c:v>0.120333275856183</c:v>
                 </c:pt>
               </c:numCache>
             </c:numRef>
@@ -6031,7 +6031,7 @@
           <a:lstStyle/>
           <a:p>
             <a:r>
-              <a:t>At €4.50m, Bana returns 28.4% (European) / 43.2% (Chinese) on a sale at COD and 6.1% / 9.1% if held</a:t>
+              <a:t>At €4.50m, Bana returns 28.4% (European) / 43.2% (Chinese) on a sale at COD and 8.0% / 12.0% if held</a:t>
             </a:r>
           </a:p>
         </p:txBody>
@@ -7261,7 +7261,7 @@
                           </a:solidFill>
                           <a:latin typeface="Aptos"/>
                         </a:rPr>
-                        <a:t>4.3%</a:t>
+                        <a:t>5.7%</a:t>
                       </a:r>
                     </a:p>
                   </a:txBody>
@@ -7282,7 +7282,7 @@
                           </a:solidFill>
                           <a:latin typeface="Aptos"/>
                         </a:rPr>
-                        <a:t>4.9%</a:t>
+                        <a:t>7.0%</a:t>
                       </a:r>
                     </a:p>
                   </a:txBody>
@@ -7418,7 +7418,7 @@
                           </a:solidFill>
                           <a:latin typeface="Aptos"/>
                         </a:rPr>
-                        <a:t>6.1%</a:t>
+                        <a:t>8.0%</a:t>
                       </a:r>
                     </a:p>
                   </a:txBody>
@@ -7441,7 +7441,7 @@
                           </a:solidFill>
                           <a:latin typeface="Aptos"/>
                         </a:rPr>
-                        <a:t>9.1%</a:t>
+                        <a:t>12.0%</a:t>
                       </a:r>
                     </a:p>
                   </a:txBody>
@@ -7512,7 +7512,7 @@
                           </a:solidFill>
                           <a:latin typeface="Aptos"/>
                         </a:rPr>
-                        <a:t>2.50x</a:t>
+                        <a:t>3.37x</a:t>
                       </a:r>
                     </a:p>
                   </a:txBody>
@@ -7533,7 +7533,7 @@
                           </a:solidFill>
                           <a:latin typeface="Aptos"/>
                         </a:rPr>
-                        <a:t>3.44x</a:t>
+                        <a:t>4.85x</a:t>
                       </a:r>
                     </a:p>
                   </a:txBody>
@@ -7602,7 +7602,7 @@
                           </a:solidFill>
                           <a:latin typeface="Aptos"/>
                         </a:rPr>
-                        <a:t>(9.3)</a:t>
+                        <a:t>(0.1)</a:t>
                       </a:r>
                     </a:p>
                   </a:txBody>
@@ -7623,7 +7623,7 @@
                           </a:solidFill>
                           <a:latin typeface="Aptos"/>
                         </a:rPr>
-                        <a:t>4.1</a:t>
+                        <a:t>17.7</a:t>
                       </a:r>
                     </a:p>
                   </a:txBody>
@@ -7692,7 +7692,7 @@
                           </a:solidFill>
                           <a:latin typeface="Aptos"/>
                         </a:rPr>
-                        <a:t>1.76x</a:t>
+                        <a:t>1.91x</a:t>
                       </a:r>
                     </a:p>
                   </a:txBody>
@@ -7713,7 +7713,7 @@
                           </a:solidFill>
                           <a:latin typeface="Aptos"/>
                         </a:rPr>
-                        <a:t>2.16x</a:t>
+                        <a:t>2.53x</a:t>
                       </a:r>
                     </a:p>
                   </a:txBody>
@@ -14008,7 +14008,7 @@
           <a:lstStyle/>
           <a:p>
             <a:r>
-              <a:t>A sale at COD turns €53.6m of equity into €75.5m (1.41x); holding earns 6.1% at a 1.76x DSCR (European)</a:t>
+              <a:t>A sale at COD turns €53.6m of equity into €75.5m (1.41x); holding earns 8.0% at a 1.91x DSCR (European)</a:t>
             </a:r>
           </a:p>
         </p:txBody>
@@ -14390,7 +14390,7 @@
                 </a:solidFill>
                 <a:latin typeface="Aptos"/>
               </a:rPr>
-              <a:t>With Chinese turbines the sale returns 43.2% and the hold 9.1%; debt is capped at 55% of construction cost on both routes.</a:t>
+              <a:t>With Chinese turbines the sale returns 43.2% and the hold 12.0%; debt is capped at 55% of construction cost on both routes.</a:t>
             </a:r>
           </a:p>
         </p:txBody>
@@ -15017,7 +15017,7 @@
                           </a:solidFill>
                           <a:latin typeface="Aptos"/>
                         </a:rPr>
-                        <a:t>4.3% / 3.9%</a:t>
+                        <a:t>5.7% / 5.9%</a:t>
                       </a:r>
                     </a:p>
                   </a:txBody>
@@ -15038,7 +15038,7 @@
                           </a:solidFill>
                           <a:latin typeface="Aptos"/>
                         </a:rPr>
-                        <a:t>4.9% / 4.8%</a:t>
+                        <a:t>7.0% / 7.5%</a:t>
                       </a:r>
                     </a:p>
                   </a:txBody>
@@ -15323,7 +15323,7 @@
                           </a:solidFill>
                           <a:latin typeface="Aptos"/>
                         </a:rPr>
-                        <a:t>82.4</a:t>
+                        <a:t>130.2</a:t>
                       </a:r>
                     </a:p>
                   </a:txBody>
@@ -15344,7 +15344,7 @@
                           </a:solidFill>
                           <a:latin typeface="Aptos"/>
                         </a:rPr>
-                        <a:t>102.1</a:t>
+                        <a:t>161.3</a:t>
                       </a:r>
                     </a:p>
                   </a:txBody>
@@ -15459,7 +15459,7 @@
                           </a:solidFill>
                           <a:latin typeface="Aptos"/>
                         </a:rPr>
-                        <a:t>6.1%</a:t>
+                        <a:t>8.0%</a:t>
                       </a:r>
                     </a:p>
                   </a:txBody>
@@ -15482,7 +15482,7 @@
                           </a:solidFill>
                           <a:latin typeface="Aptos"/>
                         </a:rPr>
-                        <a:t>9.1%</a:t>
+                        <a:t>12.0%</a:t>
                       </a:r>
                     </a:p>
                   </a:txBody>
@@ -15595,7 +15595,7 @@
                           </a:solidFill>
                           <a:latin typeface="Aptos"/>
                         </a:rPr>
-                        <a:t>2.50x</a:t>
+                        <a:t>3.37x</a:t>
                       </a:r>
                     </a:p>
                   </a:txBody>
@@ -15616,7 +15616,7 @@
                           </a:solidFill>
                           <a:latin typeface="Aptos"/>
                         </a:rPr>
-                        <a:t>3.44x</a:t>
+                        <a:t>4.85x</a:t>
                       </a:r>
                     </a:p>
                   </a:txBody>
@@ -15727,7 +15727,7 @@
                           </a:solidFill>
                           <a:latin typeface="Aptos"/>
                         </a:rPr>
-                        <a:t>(9.3)</a:t>
+                        <a:t>(0.1)</a:t>
                       </a:r>
                     </a:p>
                   </a:txBody>
@@ -15748,7 +15748,7 @@
                           </a:solidFill>
                           <a:latin typeface="Aptos"/>
                         </a:rPr>
-                        <a:t>4.1</a:t>
+                        <a:t>17.7</a:t>
                       </a:r>
                     </a:p>
                   </a:txBody>
@@ -15859,7 +15859,7 @@
                           </a:solidFill>
                           <a:latin typeface="Aptos"/>
                         </a:rPr>
-                        <a:t>5.9%</a:t>
+                        <a:t>7.2%</a:t>
                       </a:r>
                     </a:p>
                   </a:txBody>
@@ -15880,7 +15880,7 @@
                           </a:solidFill>
                           <a:latin typeface="Aptos"/>
                         </a:rPr>
-                        <a:t>7.8%</a:t>
+                        <a:t>9.8%</a:t>
                       </a:r>
                     </a:p>
                   </a:txBody>
@@ -15991,7 +15991,7 @@
                           </a:solidFill>
                           <a:latin typeface="Aptos"/>
                         </a:rPr>
-                        <a:t>1.76x</a:t>
+                        <a:t>1.91x</a:t>
                       </a:r>
                     </a:p>
                   </a:txBody>
@@ -16012,7 +16012,7 @@
                           </a:solidFill>
                           <a:latin typeface="Aptos"/>
                         </a:rPr>
-                        <a:t>2.16x</a:t>
+                        <a:t>2.53x</a:t>
                       </a:r>
                     </a:p>
                   </a:txBody>
@@ -16123,7 +16123,7 @@
                           </a:solidFill>
                           <a:latin typeface="Aptos"/>
                         </a:rPr>
-                        <a:t>(71.7)</a:t>
+                        <a:t>(23.1)</a:t>
                       </a:r>
                     </a:p>
                   </a:txBody>
@@ -16144,7 +16144,7 @@
                           </a:solidFill>
                           <a:latin typeface="Aptos"/>
                         </a:rPr>
-                        <a:t>(88.1)</a:t>
+                        <a:t>(28.5)</a:t>
                       </a:r>
                     </a:p>
                   </a:txBody>
@@ -16248,7 +16248,7 @@
                 </a:solidFill>
                 <a:latin typeface="Aptos"/>
               </a:rPr>
-              <a:t>1.20x target DSCR over 18 years, 5.0% fixed; sized at the lower of the DSCR capacity and 55% of cost on both routes; 68% / 55% of the DSCR capacity is used.</a:t>
+              <a:t>1.20x target DSCR over 18 years, 5.0% fixed; sized at the lower of the DSCR capacity and 55% of cost on both routes; 63% / 47% of the DSCR capacity is used.</a:t>
             </a:r>
           </a:p>
           <a:p>
@@ -16273,7 +16273,7 @@
                 </a:solidFill>
                 <a:latin typeface="Aptos"/>
               </a:rPr>
-              <a:t>€92.8m at 1.10x / €85.1m at 1.20x DSCR European (83% / 76% of uses); €83.5m / €76.5m Chinese.</a:t>
+              <a:t>€100.9m at 1.10x / €92.5m at 1.20x DSCR European (90% / 83% of uses); €97.8m / €89.7m Chinese.</a:t>
             </a:r>
           </a:p>
           <a:p>
@@ -16298,7 +16298,7 @@
                 </a:solidFill>
                 <a:latin typeface="Aptos"/>
               </a:rPr>
-              <a:t>CIT 15%, a proxy for 9 % plus a possible Pillar Two top-up; Robin Hood tax 31% of pre-tax profit (its exemption covers only KÁT/METÁR plants; Bana sells under a PPA). 20-year depreciation; losses capped at 50% of the base and lapse after 5 years. Gain on the COD share sale exempt.</a:t>
+              <a:t>CIT 15%, a proxy for 9 % plus a possible Pillar Two top-up. Robin Hood tax (31%) is not in the base; it may apply, as its exemption covers only KÁT/METÁR plants (see sensitivities). 20-year depreciation; losses capped at 50% of the base and lapse after 5 years. Gain on the COD share sale exempt.</a:t>
             </a:r>
           </a:p>
         </p:txBody>
@@ -16387,7 +16387,7 @@
           <a:lstStyle/>
           <a:p>
             <a:r>
-              <a:t>At 2,450 / 2,100 k€/MW a buyer earns 4.3% / 4.9%; at the lower price 5.4% / 6.0%, but FEP's sale IRR falls to 12.1% / 29.7%</a:t>
+              <a:t>At 2,450 / 2,100 k€/MW a buyer earns 5.7% / 7.0%; at the lower price 6.7% / 8.1%, but FEP's sale IRR falls to 12.1% / 29.7%</a:t>
             </a:r>
           </a:p>
         </p:txBody>
@@ -17070,7 +17070,7 @@
                           </a:solidFill>
                           <a:latin typeface="Aptos"/>
                         </a:rPr>
-                        <a:t>5.4%</a:t>
+                        <a:t>6.7%</a:t>
                       </a:r>
                     </a:p>
                   </a:txBody>
@@ -17091,7 +17091,7 @@
                           </a:solidFill>
                           <a:latin typeface="Aptos"/>
                         </a:rPr>
-                        <a:t>5.4%</a:t>
+                        <a:t>7.5%</a:t>
                       </a:r>
                     </a:p>
                   </a:txBody>
@@ -17154,7 +17154,7 @@
                           </a:solidFill>
                           <a:latin typeface="Aptos"/>
                         </a:rPr>
-                        <a:t>6.0%</a:t>
+                        <a:t>8.1%</a:t>
                       </a:r>
                     </a:p>
                   </a:txBody>
@@ -17175,7 +17175,7 @@
                           </a:solidFill>
                           <a:latin typeface="Aptos"/>
                         </a:rPr>
-                        <a:t>6.3%</a:t>
+                        <a:t>9.3%</a:t>
                       </a:r>
                     </a:p>
                   </a:txBody>
@@ -17265,7 +17265,7 @@
                           </a:solidFill>
                           <a:latin typeface="Aptos"/>
                         </a:rPr>
-                        <a:t>4.3%</a:t>
+                        <a:t>5.7%</a:t>
                       </a:r>
                     </a:p>
                   </a:txBody>
@@ -17288,7 +17288,7 @@
                           </a:solidFill>
                           <a:latin typeface="Aptos"/>
                         </a:rPr>
-                        <a:t>3.9%</a:t>
+                        <a:t>5.9%</a:t>
                       </a:r>
                     </a:p>
                   </a:txBody>
@@ -17357,7 +17357,7 @@
                           </a:solidFill>
                           <a:latin typeface="Aptos"/>
                         </a:rPr>
-                        <a:t>4.9%</a:t>
+                        <a:t>7.0%</a:t>
                       </a:r>
                     </a:p>
                   </a:txBody>
@@ -17380,7 +17380,7 @@
                           </a:solidFill>
                           <a:latin typeface="Aptos"/>
                         </a:rPr>
-                        <a:t>4.8%</a:t>
+                        <a:t>7.5%</a:t>
                       </a:r>
                     </a:p>
                   </a:txBody>
@@ -17472,7 +17472,7 @@
                           </a:solidFill>
                           <a:latin typeface="Aptos"/>
                         </a:rPr>
-                        <a:t>3.4%</a:t>
+                        <a:t>4.8%</a:t>
                       </a:r>
                     </a:p>
                   </a:txBody>
@@ -17493,7 +17493,7 @@
                           </a:solidFill>
                           <a:latin typeface="Aptos"/>
                         </a:rPr>
-                        <a:t>2.7%</a:t>
+                        <a:t>4.6%</a:t>
                       </a:r>
                     </a:p>
                   </a:txBody>
@@ -17556,7 +17556,7 @@
                           </a:solidFill>
                           <a:latin typeface="Aptos"/>
                         </a:rPr>
-                        <a:t>4.0%</a:t>
+                        <a:t>6.0%</a:t>
                       </a:r>
                     </a:p>
                   </a:txBody>
@@ -17577,7 +17577,7 @@
                           </a:solidFill>
                           <a:latin typeface="Aptos"/>
                         </a:rPr>
-                        <a:t>3.6%</a:t>
+                        <a:t>6.2%</a:t>
                       </a:r>
                     </a:p>
                   </a:txBody>
@@ -17695,7 +17695,7 @@
           <a:lstStyle/>
           <a:p>
             <a:r>
-              <a:t>A lower COD price hits the sale most (12.1%); lower yield hits the hold most (4.8%)</a:t>
+              <a:t>A lower COD price hits the sale most (12.1%); Robin Hood tax (6.1%) and lower yield (6.3%) hit the hold</a:t>
             </a:r>
           </a:p>
         </p:txBody>
@@ -18355,7 +18355,7 @@
                           </a:solidFill>
                           <a:latin typeface="Aptos"/>
                         </a:rPr>
-                        <a:t>6.1%</a:t>
+                        <a:t>8.0%</a:t>
                       </a:r>
                     </a:p>
                   </a:txBody>
@@ -18378,7 +18378,7 @@
                           </a:solidFill>
                           <a:latin typeface="Aptos"/>
                         </a:rPr>
-                        <a:t>9.1%</a:t>
+                        <a:t>12.0%</a:t>
                       </a:r>
                     </a:p>
                   </a:txBody>
@@ -18401,7 +18401,7 @@
                           </a:solidFill>
                           <a:latin typeface="Aptos"/>
                         </a:rPr>
-                        <a:t>1.76x</a:t>
+                        <a:t>1.91x</a:t>
                       </a:r>
                     </a:p>
                   </a:txBody>
@@ -18424,7 +18424,7 @@
                           </a:solidFill>
                           <a:latin typeface="Aptos"/>
                         </a:rPr>
-                        <a:t>2.16x</a:t>
+                        <a:t>2.53x</a:t>
                       </a:r>
                     </a:p>
                   </a:txBody>
@@ -18514,7 +18514,7 @@
                           </a:solidFill>
                           <a:latin typeface="Aptos"/>
                         </a:rPr>
-                        <a:t>6.1%</a:t>
+                        <a:t>8.0%</a:t>
                       </a:r>
                     </a:p>
                   </a:txBody>
@@ -18535,7 +18535,7 @@
                           </a:solidFill>
                           <a:latin typeface="Aptos"/>
                         </a:rPr>
-                        <a:t>9.1%</a:t>
+                        <a:t>12.0%</a:t>
                       </a:r>
                     </a:p>
                   </a:txBody>
@@ -18556,7 +18556,7 @@
                           </a:solidFill>
                           <a:latin typeface="Aptos"/>
                         </a:rPr>
-                        <a:t>1.76x</a:t>
+                        <a:t>1.91x</a:t>
                       </a:r>
                     </a:p>
                   </a:txBody>
@@ -18577,7 +18577,7 @@
                           </a:solidFill>
                           <a:latin typeface="Aptos"/>
                         </a:rPr>
-                        <a:t>2.16x</a:t>
+                        <a:t>2.53x</a:t>
                       </a:r>
                     </a:p>
                   </a:txBody>
@@ -18665,7 +18665,7 @@
                           </a:solidFill>
                           <a:latin typeface="Aptos"/>
                         </a:rPr>
-                        <a:t>6.1%</a:t>
+                        <a:t>8.0%</a:t>
                       </a:r>
                     </a:p>
                   </a:txBody>
@@ -18686,7 +18686,7 @@
                           </a:solidFill>
                           <a:latin typeface="Aptos"/>
                         </a:rPr>
-                        <a:t>9.1%</a:t>
+                        <a:t>12.0%</a:t>
                       </a:r>
                     </a:p>
                   </a:txBody>
@@ -18707,7 +18707,7 @@
                           </a:solidFill>
                           <a:latin typeface="Aptos"/>
                         </a:rPr>
-                        <a:t>1.76x</a:t>
+                        <a:t>1.91x</a:t>
                       </a:r>
                     </a:p>
                   </a:txBody>
@@ -18728,7 +18728,7 @@
                           </a:solidFill>
                           <a:latin typeface="Aptos"/>
                         </a:rPr>
-                        <a:t>2.16x</a:t>
+                        <a:t>2.53x</a:t>
                       </a:r>
                     </a:p>
                   </a:txBody>
@@ -18816,7 +18816,7 @@
                           </a:solidFill>
                           <a:latin typeface="Aptos"/>
                         </a:rPr>
-                        <a:t>5.6%</a:t>
+                        <a:t>7.3%</a:t>
                       </a:r>
                     </a:p>
                   </a:txBody>
@@ -18837,7 +18837,7 @@
                           </a:solidFill>
                           <a:latin typeface="Aptos"/>
                         </a:rPr>
-                        <a:t>8.7%</a:t>
+                        <a:t>11.5%</a:t>
                       </a:r>
                     </a:p>
                   </a:txBody>
@@ -18858,7 +18858,7 @@
                           </a:solidFill>
                           <a:latin typeface="Aptos"/>
                         </a:rPr>
-                        <a:t>1.70x</a:t>
+                        <a:t>1.82x</a:t>
                       </a:r>
                     </a:p>
                   </a:txBody>
@@ -18879,7 +18879,7 @@
                           </a:solidFill>
                           <a:latin typeface="Aptos"/>
                         </a:rPr>
-                        <a:t>2.11x</a:t>
+                        <a:t>2.45x</a:t>
                       </a:r>
                     </a:p>
                   </a:txBody>
@@ -18967,7 +18967,7 @@
                           </a:solidFill>
                           <a:latin typeface="Aptos"/>
                         </a:rPr>
-                        <a:t>4.8%</a:t>
+                        <a:t>6.3%</a:t>
                       </a:r>
                     </a:p>
                   </a:txBody>
@@ -18988,7 +18988,7 @@
                           </a:solidFill>
                           <a:latin typeface="Aptos"/>
                         </a:rPr>
-                        <a:t>7.6%</a:t>
+                        <a:t>10.1%</a:t>
                       </a:r>
                     </a:p>
                   </a:txBody>
@@ -19009,7 +19009,7 @@
                           </a:solidFill>
                           <a:latin typeface="Aptos"/>
                         </a:rPr>
-                        <a:t>1.62x</a:t>
+                        <a:t>1.70x</a:t>
                       </a:r>
                     </a:p>
                   </a:txBody>
@@ -19030,7 +19030,7 @@
                           </a:solidFill>
                           <a:latin typeface="Aptos"/>
                         </a:rPr>
-                        <a:t>1.99x</a:t>
+                        <a:t>2.26x</a:t>
                       </a:r>
                     </a:p>
                   </a:txBody>
@@ -19118,7 +19118,7 @@
                           </a:solidFill>
                           <a:latin typeface="Aptos"/>
                         </a:rPr>
-                        <a:t>7.4%</a:t>
+                        <a:t>9.8%</a:t>
                       </a:r>
                     </a:p>
                   </a:txBody>
@@ -19139,7 +19139,7 @@
                           </a:solidFill>
                           <a:latin typeface="Aptos"/>
                         </a:rPr>
-                        <a:t>10.6%</a:t>
+                        <a:t>14.1%</a:t>
                       </a:r>
                     </a:p>
                   </a:txBody>
@@ -19160,7 +19160,7 @@
                           </a:solidFill>
                           <a:latin typeface="Aptos"/>
                         </a:rPr>
-                        <a:t>1.90x</a:t>
+                        <a:t>2.13x</a:t>
                       </a:r>
                     </a:p>
                   </a:txBody>
@@ -19181,7 +19181,7 @@
                           </a:solidFill>
                           <a:latin typeface="Aptos"/>
                         </a:rPr>
-                        <a:t>2.36x</a:t>
+                        <a:t>2.84x</a:t>
                       </a:r>
                     </a:p>
                   </a:txBody>
@@ -19269,7 +19269,7 @@
                           </a:solidFill>
                           <a:latin typeface="Aptos"/>
                         </a:rPr>
-                        <a:t>5.8%</a:t>
+                        <a:t>7.7%</a:t>
                       </a:r>
                     </a:p>
                   </a:txBody>
@@ -19290,7 +19290,7 @@
                           </a:solidFill>
                           <a:latin typeface="Aptos"/>
                         </a:rPr>
-                        <a:t>8.6%</a:t>
+                        <a:t>11.6%</a:t>
                       </a:r>
                     </a:p>
                   </a:txBody>
@@ -19311,7 +19311,7 @@
                           </a:solidFill>
                           <a:latin typeface="Aptos"/>
                         </a:rPr>
-                        <a:t>1.76x</a:t>
+                        <a:t>1.91x</a:t>
                       </a:r>
                     </a:p>
                   </a:txBody>
@@ -19332,7 +19332,7 @@
                           </a:solidFill>
                           <a:latin typeface="Aptos"/>
                         </a:rPr>
-                        <a:t>2.16x</a:t>
+                        <a:t>2.53x</a:t>
                       </a:r>
                     </a:p>
                   </a:txBody>
@@ -19420,7 +19420,7 @@
                           </a:solidFill>
                           <a:latin typeface="Aptos"/>
                         </a:rPr>
-                        <a:t>5.7%</a:t>
+                        <a:t>7.5%</a:t>
                       </a:r>
                     </a:p>
                   </a:txBody>
@@ -19441,7 +19441,7 @@
                           </a:solidFill>
                           <a:latin typeface="Aptos"/>
                         </a:rPr>
-                        <a:t>8.7%</a:t>
+                        <a:t>11.6%</a:t>
                       </a:r>
                     </a:p>
                   </a:txBody>
@@ -19462,7 +19462,7 @@
                           </a:solidFill>
                           <a:latin typeface="Aptos"/>
                         </a:rPr>
-                        <a:t>1.65x</a:t>
+                        <a:t>1.76x</a:t>
                       </a:r>
                     </a:p>
                   </a:txBody>
@@ -19483,7 +19483,7 @@
                           </a:solidFill>
                           <a:latin typeface="Aptos"/>
                         </a:rPr>
-                        <a:t>2.03x</a:t>
+                        <a:t>2.34x</a:t>
                       </a:r>
                     </a:p>
                   </a:txBody>
@@ -19529,7 +19529,7 @@
                           </a:solidFill>
                           <a:latin typeface="Aptos"/>
                         </a:rPr>
-                        <a:t>27.9%</a:t>
+                        <a:t>28.4%</a:t>
                       </a:r>
                     </a:p>
                   </a:txBody>
@@ -19571,7 +19571,7 @@
                           </a:solidFill>
                           <a:latin typeface="Aptos"/>
                         </a:rPr>
-                        <a:t>5.5%</a:t>
+                        <a:t>7.4%</a:t>
                       </a:r>
                     </a:p>
                   </a:txBody>
@@ -19592,7 +19592,7 @@
                           </a:solidFill>
                           <a:latin typeface="Aptos"/>
                         </a:rPr>
-                        <a:t>8.1%</a:t>
+                        <a:t>10.9%</a:t>
                       </a:r>
                     </a:p>
                   </a:txBody>
@@ -19613,7 +19613,7 @@
                           </a:solidFill>
                           <a:latin typeface="Aptos"/>
                         </a:rPr>
-                        <a:t>1.20x</a:t>
+                        <a:t>1.25x</a:t>
                       </a:r>
                     </a:p>
                   </a:txBody>
@@ -19634,7 +19634,7 @@
                           </a:solidFill>
                           <a:latin typeface="Aptos"/>
                         </a:rPr>
-                        <a:t>1.42x</a:t>
+                        <a:t>1.66x</a:t>
                       </a:r>
                     </a:p>
                   </a:txBody>
@@ -19657,7 +19657,7 @@
                           </a:solidFill>
                           <a:latin typeface="Aptos"/>
                         </a:rPr>
-                        <a:t>No Robin Hood</a:t>
+                        <a:t>Robin Hood 31%</a:t>
                       </a:r>
                     </a:p>
                   </a:txBody>
@@ -19722,7 +19722,7 @@
                           </a:solidFill>
                           <a:latin typeface="Aptos"/>
                         </a:rPr>
-                        <a:t>8.0%</a:t>
+                        <a:t>6.1%</a:t>
                       </a:r>
                     </a:p>
                   </a:txBody>
@@ -19743,7 +19743,7 @@
                           </a:solidFill>
                           <a:latin typeface="Aptos"/>
                         </a:rPr>
-                        <a:t>12.0%</a:t>
+                        <a:t>9.1%</a:t>
                       </a:r>
                     </a:p>
                   </a:txBody>
@@ -19764,7 +19764,7 @@
                           </a:solidFill>
                           <a:latin typeface="Aptos"/>
                         </a:rPr>
-                        <a:t>1.91x</a:t>
+                        <a:t>1.76x</a:t>
                       </a:r>
                     </a:p>
                   </a:txBody>
@@ -19785,7 +19785,7 @@
                           </a:solidFill>
                           <a:latin typeface="Aptos"/>
                         </a:rPr>
-                        <a:t>2.53x</a:t>
+                        <a:t>2.16x</a:t>
                       </a:r>
                     </a:p>
                   </a:txBody>
@@ -19873,7 +19873,7 @@
                           </a:solidFill>
                           <a:latin typeface="Aptos"/>
                         </a:rPr>
-                        <a:t>6.5%</a:t>
+                        <a:t>8.3%</a:t>
                       </a:r>
                     </a:p>
                   </a:txBody>
@@ -19894,7 +19894,7 @@
                           </a:solidFill>
                           <a:latin typeface="Aptos"/>
                         </a:rPr>
-                        <a:t>9.7%</a:t>
+                        <a:t>12.5%</a:t>
                       </a:r>
                     </a:p>
                   </a:txBody>
@@ -19915,7 +19915,7 @@
                           </a:solidFill>
                           <a:latin typeface="Aptos"/>
                         </a:rPr>
-                        <a:t>1.78x</a:t>
+                        <a:t>1.94x</a:t>
                       </a:r>
                     </a:p>
                   </a:txBody>
@@ -19936,7 +19936,7 @@
                           </a:solidFill>
                           <a:latin typeface="Aptos"/>
                         </a:rPr>
-                        <a:t>2.23x</a:t>
+                        <a:t>2.60x</a:t>
                       </a:r>
                     </a:p>
                   </a:txBody>
@@ -20047,7 +20047,7 @@
                 </a:solidFill>
                 <a:latin typeface="Aptos"/>
               </a:rPr>
-              <a:t>55 MW built against 60 MW committed. Pro rata (GYIK 28/30) there is no PB call; if the full-call reading (GYIK 72) applies, the €2.22m PB is lost: COD IRR 25.9%, hold IRR 5.8% (European).</a:t>
+              <a:t>55 MW built against 60 MW committed. Pro rata (GYIK 28/30) there is no PB call; if the full-call reading (GYIK 72) applies, the €2.22m PB is lost: COD IRR 25.9%, hold IRR 7.7% (European).</a:t>
             </a:r>
           </a:p>
           <a:p>
@@ -20072,7 +20072,7 @@
                 </a:solidFill>
                 <a:latin typeface="Aptos"/>
               </a:rPr>
-              <a:t>in the base at 31%; without it the hold IRR would be 8.0% / 12.0%.</a:t>
+              <a:t>not in the base; if the 31% levy applies (its exemption covers only KÁT/METÁR plants), the hold IRR falls to 6.1% / 9.1%.</a:t>
             </a:r>
           </a:p>
           <a:p>
@@ -20122,7 +20122,7 @@
                 </a:solidFill>
                 <a:latin typeface="Aptos"/>
               </a:rPr>
-              <a:t>a 10-year tenor lowers the European minimum DSCR to 1.20x and the hold IRR to 5.5%.</a:t>
+              <a:t>a 10-year tenor lowers the European minimum DSCR to 1.25x and the hold IRR to 7.4%.</a:t>
             </a:r>
           </a:p>
         </p:txBody>

</xml_diff>

<commit_message>
Fix the buyer IRR in Excel (XIRR from COD); add a 6x EBITDA debt set; lint XIRR ranges that start at 0
Co-Authored-By: Claude Opus 5.5 <noreply@anthropic.com>
Claude-Session: https://claude.ai/code/session_01AWS1t9WtpkQHcCU1WceGZT
</commit_message>
<xml_diff>
--- a/projects/bana/out/Bana_IC.pptx
+++ b/projects/bana/out/Bana_IC.pptx
@@ -250,7 +250,7 @@
                   <c:v>0.284084033636541</c:v>
                 </c:pt>
                 <c:pt idx="1">
-                  <c:v>0.0798286717747364</c:v>
+                  <c:v>0.0798286717747287</c:v>
                 </c:pt>
               </c:numCache>
             </c:numRef>
@@ -300,7 +300,7 @@
                   <c:v>0.431605205102548</c:v>
                 </c:pt>
                 <c:pt idx="1">
-                  <c:v>0.120333275856183</c:v>
+                  <c:v>0.120333275856178</c:v>
                 </c:pt>
               </c:numCache>
             </c:numRef>
@@ -18077,7 +18077,7 @@
                 </a:solidFill>
                 <a:latin typeface="Aptos"/>
               </a:rPr>
-              <a:t>FEP IRR by key-assumption set, each change on its own (buyer IRR on the previous slide); the sale at COD does not depend on yield or PPA price because its price is fixed per MW.</a:t>
+              <a:t>FEP and buyer (unlevered) IRR by key-assumption set, each change on its own; the sale at COD does not depend on yield or PPA price because its price is fixed per MW.</a:t>
             </a:r>
           </a:p>
         </p:txBody>
@@ -18092,7 +18092,7 @@
         </p:nvGraphicFramePr>
         <p:xfrm>
           <a:off x="4498848" y="2240280"/>
-          <a:ext cx="9418320" cy="5568696"/>
+          <a:ext cx="9418320" cy="5586984"/>
         </p:xfrm>
         <a:graphic>
           <a:graphicData uri="http://schemas.openxmlformats.org/drawingml/2006/table">
@@ -18101,13 +18101,15 @@
                 <a:tableStyleId>{5C22544A-7EE6-4342-B048-85BDC9FD1C3A}</a:tableStyleId>
               </a:tblPr>
               <a:tblGrid>
-                <a:gridCol w="2560320"/>
-                <a:gridCol w="1143000"/>
-                <a:gridCol w="1143000"/>
-                <a:gridCol w="1143000"/>
-                <a:gridCol w="1143000"/>
-                <a:gridCol w="1143000"/>
-                <a:gridCol w="1143000"/>
+                <a:gridCol w="2103120"/>
+                <a:gridCol w="914400"/>
+                <a:gridCol w="914400"/>
+                <a:gridCol w="914400"/>
+                <a:gridCol w="914400"/>
+                <a:gridCol w="914400"/>
+                <a:gridCol w="914400"/>
+                <a:gridCol w="914400"/>
+                <a:gridCol w="914400"/>
               </a:tblGrid>
               <a:tr h="539496">
                 <a:tc>
@@ -18146,7 +18148,7 @@
                           </a:solidFill>
                           <a:latin typeface="Aptos"/>
                         </a:rPr>
-                        <a:t>COD – EU</a:t>
+                        <a:t>COD EU</a:t>
                       </a:r>
                     </a:p>
                   </a:txBody>
@@ -18169,7 +18171,7 @@
                           </a:solidFill>
                           <a:latin typeface="Aptos"/>
                         </a:rPr>
-                        <a:t>COD – CN</a:t>
+                        <a:t>COD CN</a:t>
                       </a:r>
                     </a:p>
                   </a:txBody>
@@ -18192,7 +18194,7 @@
                           </a:solidFill>
                           <a:latin typeface="Aptos"/>
                         </a:rPr>
-                        <a:t>Hold – EU</a:t>
+                        <a:t>Buyer EU</a:t>
                       </a:r>
                     </a:p>
                   </a:txBody>
@@ -18215,7 +18217,7 @@
                           </a:solidFill>
                           <a:latin typeface="Aptos"/>
                         </a:rPr>
-                        <a:t>Hold – CN</a:t>
+                        <a:t>Buyer CN</a:t>
                       </a:r>
                     </a:p>
                   </a:txBody>
@@ -18238,7 +18240,7 @@
                           </a:solidFill>
                           <a:latin typeface="Aptos"/>
                         </a:rPr>
-                        <a:t>DSCR – EU</a:t>
+                        <a:t>Hold EU</a:t>
                       </a:r>
                     </a:p>
                   </a:txBody>
@@ -18261,7 +18263,7 @@
                           </a:solidFill>
                           <a:latin typeface="Aptos"/>
                         </a:rPr>
-                        <a:t>DSCR – CN</a:t>
+                        <a:t>Hold CN</a:t>
                       </a:r>
                     </a:p>
                   </a:txBody>
@@ -18271,8 +18273,54 @@
                     </a:solidFill>
                   </a:tcPr>
                 </a:tc>
+                <a:tc>
+                  <a:txBody>
+                    <a:bodyPr/>
+                    <a:lstStyle/>
+                    <a:p>
+                      <a:pPr algn="r"/>
+                      <a:r>
+                        <a:rPr sz="1300" b="1">
+                          <a:solidFill>
+                            <a:srgbClr val="FFFFFF"/>
+                          </a:solidFill>
+                          <a:latin typeface="Aptos"/>
+                        </a:rPr>
+                        <a:t>DSCR EU</a:t>
+                      </a:r>
+                    </a:p>
+                  </a:txBody>
+                  <a:tcPr marL="73152" marR="73152" marT="27432" marB="27432" anchor="ctr">
+                    <a:solidFill>
+                      <a:srgbClr val="00A651"/>
+                    </a:solidFill>
+                  </a:tcPr>
+                </a:tc>
+                <a:tc>
+                  <a:txBody>
+                    <a:bodyPr/>
+                    <a:lstStyle/>
+                    <a:p>
+                      <a:pPr algn="r"/>
+                      <a:r>
+                        <a:rPr sz="1300" b="1">
+                          <a:solidFill>
+                            <a:srgbClr val="FFFFFF"/>
+                          </a:solidFill>
+                          <a:latin typeface="Aptos"/>
+                        </a:rPr>
+                        <a:t>DSCR CN</a:t>
+                      </a:r>
+                    </a:p>
+                  </a:txBody>
+                  <a:tcPr marL="73152" marR="73152" marT="27432" marB="27432" anchor="ctr">
+                    <a:solidFill>
+                      <a:srgbClr val="00A651"/>
+                    </a:solidFill>
+                  </a:tcPr>
+                </a:tc>
               </a:tr>
-              <a:tr h="457200">
+              <a:tr h="420624">
                 <a:tc>
                   <a:txBody>
                     <a:bodyPr/>
@@ -18355,6 +18403,52 @@
                           </a:solidFill>
                           <a:latin typeface="Aptos"/>
                         </a:rPr>
+                        <a:t>5.7%</a:t>
+                      </a:r>
+                    </a:p>
+                  </a:txBody>
+                  <a:tcPr marL="73152" marR="73152" marT="27432" marB="27432" anchor="ctr">
+                    <a:solidFill>
+                      <a:srgbClr val="E6F4EC"/>
+                    </a:solidFill>
+                  </a:tcPr>
+                </a:tc>
+                <a:tc>
+                  <a:txBody>
+                    <a:bodyPr/>
+                    <a:lstStyle/>
+                    <a:p>
+                      <a:pPr algn="r"/>
+                      <a:r>
+                        <a:rPr sz="1300" b="1">
+                          <a:solidFill>
+                            <a:srgbClr val="3C3C3B"/>
+                          </a:solidFill>
+                          <a:latin typeface="Aptos"/>
+                        </a:rPr>
+                        <a:t>7.0%</a:t>
+                      </a:r>
+                    </a:p>
+                  </a:txBody>
+                  <a:tcPr marL="73152" marR="73152" marT="27432" marB="27432" anchor="ctr">
+                    <a:solidFill>
+                      <a:srgbClr val="E6F4EC"/>
+                    </a:solidFill>
+                  </a:tcPr>
+                </a:tc>
+                <a:tc>
+                  <a:txBody>
+                    <a:bodyPr/>
+                    <a:lstStyle/>
+                    <a:p>
+                      <a:pPr algn="r"/>
+                      <a:r>
+                        <a:rPr sz="1300" b="1">
+                          <a:solidFill>
+                            <a:srgbClr val="3C3C3B"/>
+                          </a:solidFill>
+                          <a:latin typeface="Aptos"/>
+                        </a:rPr>
                         <a:t>8.0%</a:t>
                       </a:r>
                     </a:p>
@@ -18435,7 +18529,7 @@
                   </a:tcPr>
                 </a:tc>
               </a:tr>
-              <a:tr h="457200">
+              <a:tr h="420624">
                 <a:tc>
                   <a:txBody>
                     <a:bodyPr/>
@@ -18514,6 +18608,48 @@
                           </a:solidFill>
                           <a:latin typeface="Aptos"/>
                         </a:rPr>
+                        <a:t>6.7%</a:t>
+                      </a:r>
+                    </a:p>
+                  </a:txBody>
+                  <a:tcPr marL="73152" marR="73152" marT="27432" marB="27432" anchor="ctr">
+                    <a:noFill/>
+                  </a:tcPr>
+                </a:tc>
+                <a:tc>
+                  <a:txBody>
+                    <a:bodyPr/>
+                    <a:lstStyle/>
+                    <a:p>
+                      <a:pPr algn="r"/>
+                      <a:r>
+                        <a:rPr sz="1300" b="0">
+                          <a:solidFill>
+                            <a:srgbClr val="3C3C3B"/>
+                          </a:solidFill>
+                          <a:latin typeface="Aptos"/>
+                        </a:rPr>
+                        <a:t>8.1%</a:t>
+                      </a:r>
+                    </a:p>
+                  </a:txBody>
+                  <a:tcPr marL="73152" marR="73152" marT="27432" marB="27432" anchor="ctr">
+                    <a:noFill/>
+                  </a:tcPr>
+                </a:tc>
+                <a:tc>
+                  <a:txBody>
+                    <a:bodyPr/>
+                    <a:lstStyle/>
+                    <a:p>
+                      <a:pPr algn="r"/>
+                      <a:r>
+                        <a:rPr sz="1300" b="0">
+                          <a:solidFill>
+                            <a:srgbClr val="3C3C3B"/>
+                          </a:solidFill>
+                          <a:latin typeface="Aptos"/>
+                        </a:rPr>
                         <a:t>8.0%</a:t>
                       </a:r>
                     </a:p>
@@ -18586,7 +18722,7 @@
                   </a:tcPr>
                 </a:tc>
               </a:tr>
-              <a:tr h="457200">
+              <a:tr h="420624">
                 <a:tc>
                   <a:txBody>
                     <a:bodyPr/>
@@ -18665,6 +18801,48 @@
                           </a:solidFill>
                           <a:latin typeface="Aptos"/>
                         </a:rPr>
+                        <a:t>4.8%</a:t>
+                      </a:r>
+                    </a:p>
+                  </a:txBody>
+                  <a:tcPr marL="73152" marR="73152" marT="27432" marB="27432" anchor="ctr">
+                    <a:noFill/>
+                  </a:tcPr>
+                </a:tc>
+                <a:tc>
+                  <a:txBody>
+                    <a:bodyPr/>
+                    <a:lstStyle/>
+                    <a:p>
+                      <a:pPr algn="r"/>
+                      <a:r>
+                        <a:rPr sz="1300" b="0">
+                          <a:solidFill>
+                            <a:srgbClr val="3C3C3B"/>
+                          </a:solidFill>
+                          <a:latin typeface="Aptos"/>
+                        </a:rPr>
+                        <a:t>6.0%</a:t>
+                      </a:r>
+                    </a:p>
+                  </a:txBody>
+                  <a:tcPr marL="73152" marR="73152" marT="27432" marB="27432" anchor="ctr">
+                    <a:noFill/>
+                  </a:tcPr>
+                </a:tc>
+                <a:tc>
+                  <a:txBody>
+                    <a:bodyPr/>
+                    <a:lstStyle/>
+                    <a:p>
+                      <a:pPr algn="r"/>
+                      <a:r>
+                        <a:rPr sz="1300" b="0">
+                          <a:solidFill>
+                            <a:srgbClr val="3C3C3B"/>
+                          </a:solidFill>
+                          <a:latin typeface="Aptos"/>
+                        </a:rPr>
                         <a:t>8.0%</a:t>
                       </a:r>
                     </a:p>
@@ -18737,7 +18915,7 @@
                   </a:tcPr>
                 </a:tc>
               </a:tr>
-              <a:tr h="457200">
+              <a:tr h="420624">
                 <a:tc>
                   <a:txBody>
                     <a:bodyPr/>
@@ -18816,6 +18994,48 @@
                           </a:solidFill>
                           <a:latin typeface="Aptos"/>
                         </a:rPr>
+                        <a:t>5.7%</a:t>
+                      </a:r>
+                    </a:p>
+                  </a:txBody>
+                  <a:tcPr marL="73152" marR="73152" marT="27432" marB="27432" anchor="ctr">
+                    <a:noFill/>
+                  </a:tcPr>
+                </a:tc>
+                <a:tc>
+                  <a:txBody>
+                    <a:bodyPr/>
+                    <a:lstStyle/>
+                    <a:p>
+                      <a:pPr algn="r"/>
+                      <a:r>
+                        <a:rPr sz="1300" b="0">
+                          <a:solidFill>
+                            <a:srgbClr val="3C3C3B"/>
+                          </a:solidFill>
+                          <a:latin typeface="Aptos"/>
+                        </a:rPr>
+                        <a:t>7.0%</a:t>
+                      </a:r>
+                    </a:p>
+                  </a:txBody>
+                  <a:tcPr marL="73152" marR="73152" marT="27432" marB="27432" anchor="ctr">
+                    <a:noFill/>
+                  </a:tcPr>
+                </a:tc>
+                <a:tc>
+                  <a:txBody>
+                    <a:bodyPr/>
+                    <a:lstStyle/>
+                    <a:p>
+                      <a:pPr algn="r"/>
+                      <a:r>
+                        <a:rPr sz="1300" b="0">
+                          <a:solidFill>
+                            <a:srgbClr val="3C3C3B"/>
+                          </a:solidFill>
+                          <a:latin typeface="Aptos"/>
+                        </a:rPr>
                         <a:t>7.3%</a:t>
                       </a:r>
                     </a:p>
@@ -18888,7 +19108,7 @@
                   </a:tcPr>
                 </a:tc>
               </a:tr>
-              <a:tr h="457200">
+              <a:tr h="420624">
                 <a:tc>
                   <a:txBody>
                     <a:bodyPr/>
@@ -18967,6 +19187,48 @@
                           </a:solidFill>
                           <a:latin typeface="Aptos"/>
                         </a:rPr>
+                        <a:t>4.6%</a:t>
+                      </a:r>
+                    </a:p>
+                  </a:txBody>
+                  <a:tcPr marL="73152" marR="73152" marT="27432" marB="27432" anchor="ctr">
+                    <a:noFill/>
+                  </a:tcPr>
+                </a:tc>
+                <a:tc>
+                  <a:txBody>
+                    <a:bodyPr/>
+                    <a:lstStyle/>
+                    <a:p>
+                      <a:pPr algn="r"/>
+                      <a:r>
+                        <a:rPr sz="1300" b="0">
+                          <a:solidFill>
+                            <a:srgbClr val="3C3C3B"/>
+                          </a:solidFill>
+                          <a:latin typeface="Aptos"/>
+                        </a:rPr>
+                        <a:t>5.8%</a:t>
+                      </a:r>
+                    </a:p>
+                  </a:txBody>
+                  <a:tcPr marL="73152" marR="73152" marT="27432" marB="27432" anchor="ctr">
+                    <a:noFill/>
+                  </a:tcPr>
+                </a:tc>
+                <a:tc>
+                  <a:txBody>
+                    <a:bodyPr/>
+                    <a:lstStyle/>
+                    <a:p>
+                      <a:pPr algn="r"/>
+                      <a:r>
+                        <a:rPr sz="1300" b="0">
+                          <a:solidFill>
+                            <a:srgbClr val="3C3C3B"/>
+                          </a:solidFill>
+                          <a:latin typeface="Aptos"/>
+                        </a:rPr>
                         <a:t>6.3%</a:t>
                       </a:r>
                     </a:p>
@@ -19039,7 +19301,7 @@
                   </a:tcPr>
                 </a:tc>
               </a:tr>
-              <a:tr h="457200">
+              <a:tr h="420624">
                 <a:tc>
                   <a:txBody>
                     <a:bodyPr/>
@@ -19118,6 +19380,48 @@
                           </a:solidFill>
                           <a:latin typeface="Aptos"/>
                         </a:rPr>
+                        <a:t>6.8%</a:t>
+                      </a:r>
+                    </a:p>
+                  </a:txBody>
+                  <a:tcPr marL="73152" marR="73152" marT="27432" marB="27432" anchor="ctr">
+                    <a:noFill/>
+                  </a:tcPr>
+                </a:tc>
+                <a:tc>
+                  <a:txBody>
+                    <a:bodyPr/>
+                    <a:lstStyle/>
+                    <a:p>
+                      <a:pPr algn="r"/>
+                      <a:r>
+                        <a:rPr sz="1300" b="0">
+                          <a:solidFill>
+                            <a:srgbClr val="3C3C3B"/>
+                          </a:solidFill>
+                          <a:latin typeface="Aptos"/>
+                        </a:rPr>
+                        <a:t>8.2%</a:t>
+                      </a:r>
+                    </a:p>
+                  </a:txBody>
+                  <a:tcPr marL="73152" marR="73152" marT="27432" marB="27432" anchor="ctr">
+                    <a:noFill/>
+                  </a:tcPr>
+                </a:tc>
+                <a:tc>
+                  <a:txBody>
+                    <a:bodyPr/>
+                    <a:lstStyle/>
+                    <a:p>
+                      <a:pPr algn="r"/>
+                      <a:r>
+                        <a:rPr sz="1300" b="0">
+                          <a:solidFill>
+                            <a:srgbClr val="3C3C3B"/>
+                          </a:solidFill>
+                          <a:latin typeface="Aptos"/>
+                        </a:rPr>
                         <a:t>9.8%</a:t>
                       </a:r>
                     </a:p>
@@ -19190,7 +19494,7 @@
                   </a:tcPr>
                 </a:tc>
               </a:tr>
-              <a:tr h="457200">
+              <a:tr h="420624">
                 <a:tc>
                   <a:txBody>
                     <a:bodyPr/>
@@ -19269,6 +19573,48 @@
                           </a:solidFill>
                           <a:latin typeface="Aptos"/>
                         </a:rPr>
+                        <a:t>5.7%</a:t>
+                      </a:r>
+                    </a:p>
+                  </a:txBody>
+                  <a:tcPr marL="73152" marR="73152" marT="27432" marB="27432" anchor="ctr">
+                    <a:noFill/>
+                  </a:tcPr>
+                </a:tc>
+                <a:tc>
+                  <a:txBody>
+                    <a:bodyPr/>
+                    <a:lstStyle/>
+                    <a:p>
+                      <a:pPr algn="r"/>
+                      <a:r>
+                        <a:rPr sz="1300" b="0">
+                          <a:solidFill>
+                            <a:srgbClr val="3C3C3B"/>
+                          </a:solidFill>
+                          <a:latin typeface="Aptos"/>
+                        </a:rPr>
+                        <a:t>7.0%</a:t>
+                      </a:r>
+                    </a:p>
+                  </a:txBody>
+                  <a:tcPr marL="73152" marR="73152" marT="27432" marB="27432" anchor="ctr">
+                    <a:noFill/>
+                  </a:tcPr>
+                </a:tc>
+                <a:tc>
+                  <a:txBody>
+                    <a:bodyPr/>
+                    <a:lstStyle/>
+                    <a:p>
+                      <a:pPr algn="r"/>
+                      <a:r>
+                        <a:rPr sz="1300" b="0">
+                          <a:solidFill>
+                            <a:srgbClr val="3C3C3B"/>
+                          </a:solidFill>
+                          <a:latin typeface="Aptos"/>
+                        </a:rPr>
                         <a:t>7.7%</a:t>
                       </a:r>
                     </a:p>
@@ -19341,7 +19687,7 @@
                   </a:tcPr>
                 </a:tc>
               </a:tr>
-              <a:tr h="457200">
+              <a:tr h="420624">
                 <a:tc>
                   <a:txBody>
                     <a:bodyPr/>
@@ -19420,6 +19766,48 @@
                           </a:solidFill>
                           <a:latin typeface="Aptos"/>
                         </a:rPr>
+                        <a:t>5.7%</a:t>
+                      </a:r>
+                    </a:p>
+                  </a:txBody>
+                  <a:tcPr marL="73152" marR="73152" marT="27432" marB="27432" anchor="ctr">
+                    <a:noFill/>
+                  </a:tcPr>
+                </a:tc>
+                <a:tc>
+                  <a:txBody>
+                    <a:bodyPr/>
+                    <a:lstStyle/>
+                    <a:p>
+                      <a:pPr algn="r"/>
+                      <a:r>
+                        <a:rPr sz="1300" b="0">
+                          <a:solidFill>
+                            <a:srgbClr val="3C3C3B"/>
+                          </a:solidFill>
+                          <a:latin typeface="Aptos"/>
+                        </a:rPr>
+                        <a:t>7.0%</a:t>
+                      </a:r>
+                    </a:p>
+                  </a:txBody>
+                  <a:tcPr marL="73152" marR="73152" marT="27432" marB="27432" anchor="ctr">
+                    <a:noFill/>
+                  </a:tcPr>
+                </a:tc>
+                <a:tc>
+                  <a:txBody>
+                    <a:bodyPr/>
+                    <a:lstStyle/>
+                    <a:p>
+                      <a:pPr algn="r"/>
+                      <a:r>
+                        <a:rPr sz="1300" b="0">
+                          <a:solidFill>
+                            <a:srgbClr val="3C3C3B"/>
+                          </a:solidFill>
+                          <a:latin typeface="Aptos"/>
+                        </a:rPr>
                         <a:t>7.5%</a:t>
                       </a:r>
                     </a:p>
@@ -19492,7 +19880,7 @@
                   </a:tcPr>
                 </a:tc>
               </a:tr>
-              <a:tr h="457200">
+              <a:tr h="420624">
                 <a:tc>
                   <a:txBody>
                     <a:bodyPr/>
@@ -19571,6 +19959,48 @@
                           </a:solidFill>
                           <a:latin typeface="Aptos"/>
                         </a:rPr>
+                        <a:t>5.6%</a:t>
+                      </a:r>
+                    </a:p>
+                  </a:txBody>
+                  <a:tcPr marL="73152" marR="73152" marT="27432" marB="27432" anchor="ctr">
+                    <a:noFill/>
+                  </a:tcPr>
+                </a:tc>
+                <a:tc>
+                  <a:txBody>
+                    <a:bodyPr/>
+                    <a:lstStyle/>
+                    <a:p>
+                      <a:pPr algn="r"/>
+                      <a:r>
+                        <a:rPr sz="1300" b="0">
+                          <a:solidFill>
+                            <a:srgbClr val="3C3C3B"/>
+                          </a:solidFill>
+                          <a:latin typeface="Aptos"/>
+                        </a:rPr>
+                        <a:t>6.9%</a:t>
+                      </a:r>
+                    </a:p>
+                  </a:txBody>
+                  <a:tcPr marL="73152" marR="73152" marT="27432" marB="27432" anchor="ctr">
+                    <a:noFill/>
+                  </a:tcPr>
+                </a:tc>
+                <a:tc>
+                  <a:txBody>
+                    <a:bodyPr/>
+                    <a:lstStyle/>
+                    <a:p>
+                      <a:pPr algn="r"/>
+                      <a:r>
+                        <a:rPr sz="1300" b="0">
+                          <a:solidFill>
+                            <a:srgbClr val="3C3C3B"/>
+                          </a:solidFill>
+                          <a:latin typeface="Aptos"/>
+                        </a:rPr>
                         <a:t>7.4%</a:t>
                       </a:r>
                     </a:p>
@@ -19643,7 +20073,7 @@
                   </a:tcPr>
                 </a:tc>
               </a:tr>
-              <a:tr h="457200">
+              <a:tr h="420624">
                 <a:tc>
                   <a:txBody>
                     <a:bodyPr/>
@@ -19722,6 +20152,48 @@
                           </a:solidFill>
                           <a:latin typeface="Aptos"/>
                         </a:rPr>
+                        <a:t>4.3%</a:t>
+                      </a:r>
+                    </a:p>
+                  </a:txBody>
+                  <a:tcPr marL="73152" marR="73152" marT="27432" marB="27432" anchor="ctr">
+                    <a:noFill/>
+                  </a:tcPr>
+                </a:tc>
+                <a:tc>
+                  <a:txBody>
+                    <a:bodyPr/>
+                    <a:lstStyle/>
+                    <a:p>
+                      <a:pPr algn="r"/>
+                      <a:r>
+                        <a:rPr sz="1300" b="0">
+                          <a:solidFill>
+                            <a:srgbClr val="3C3C3B"/>
+                          </a:solidFill>
+                          <a:latin typeface="Aptos"/>
+                        </a:rPr>
+                        <a:t>4.9%</a:t>
+                      </a:r>
+                    </a:p>
+                  </a:txBody>
+                  <a:tcPr marL="73152" marR="73152" marT="27432" marB="27432" anchor="ctr">
+                    <a:noFill/>
+                  </a:tcPr>
+                </a:tc>
+                <a:tc>
+                  <a:txBody>
+                    <a:bodyPr/>
+                    <a:lstStyle/>
+                    <a:p>
+                      <a:pPr algn="r"/>
+                      <a:r>
+                        <a:rPr sz="1300" b="0">
+                          <a:solidFill>
+                            <a:srgbClr val="3C3C3B"/>
+                          </a:solidFill>
+                          <a:latin typeface="Aptos"/>
+                        </a:rPr>
                         <a:t>6.1%</a:t>
                       </a:r>
                     </a:p>
@@ -19794,7 +20266,7 @@
                   </a:tcPr>
                 </a:tc>
               </a:tr>
-              <a:tr h="457200">
+              <a:tr h="420624">
                 <a:tc>
                   <a:txBody>
                     <a:bodyPr/>
@@ -19873,6 +20345,48 @@
                           </a:solidFill>
                           <a:latin typeface="Aptos"/>
                         </a:rPr>
+                        <a:t>5.9%</a:t>
+                      </a:r>
+                    </a:p>
+                  </a:txBody>
+                  <a:tcPr marL="73152" marR="73152" marT="27432" marB="27432" anchor="ctr">
+                    <a:noFill/>
+                  </a:tcPr>
+                </a:tc>
+                <a:tc>
+                  <a:txBody>
+                    <a:bodyPr/>
+                    <a:lstStyle/>
+                    <a:p>
+                      <a:pPr algn="r"/>
+                      <a:r>
+                        <a:rPr sz="1300" b="0">
+                          <a:solidFill>
+                            <a:srgbClr val="3C3C3B"/>
+                          </a:solidFill>
+                          <a:latin typeface="Aptos"/>
+                        </a:rPr>
+                        <a:t>7.3%</a:t>
+                      </a:r>
+                    </a:p>
+                  </a:txBody>
+                  <a:tcPr marL="73152" marR="73152" marT="27432" marB="27432" anchor="ctr">
+                    <a:noFill/>
+                  </a:tcPr>
+                </a:tc>
+                <a:tc>
+                  <a:txBody>
+                    <a:bodyPr/>
+                    <a:lstStyle/>
+                    <a:p>
+                      <a:pPr algn="r"/>
+                      <a:r>
+                        <a:rPr sz="1300" b="0">
+                          <a:solidFill>
+                            <a:srgbClr val="3C3C3B"/>
+                          </a:solidFill>
+                          <a:latin typeface="Aptos"/>
+                        </a:rPr>
                         <a:t>8.3%</a:t>
                       </a:r>
                     </a:p>
@@ -19937,6 +20451,199 @@
                           <a:latin typeface="Aptos"/>
                         </a:rPr>
                         <a:t>2.60x</a:t>
+                      </a:r>
+                    </a:p>
+                  </a:txBody>
+                  <a:tcPr marL="73152" marR="73152" marT="27432" marB="27432" anchor="ctr">
+                    <a:noFill/>
+                  </a:tcPr>
+                </a:tc>
+              </a:tr>
+              <a:tr h="420624">
+                <a:tc>
+                  <a:txBody>
+                    <a:bodyPr/>
+                    <a:lstStyle/>
+                    <a:p>
+                      <a:pPr algn="l"/>
+                      <a:r>
+                        <a:rPr sz="1300" b="0">
+                          <a:solidFill>
+                            <a:srgbClr val="3C3C3B"/>
+                          </a:solidFill>
+                          <a:latin typeface="Aptos"/>
+                        </a:rPr>
+                        <a:t>Debt 6x EBITDA</a:t>
+                      </a:r>
+                    </a:p>
+                  </a:txBody>
+                  <a:tcPr marL="73152" marR="73152" marT="27432" marB="27432" anchor="ctr">
+                    <a:solidFill>
+                      <a:srgbClr val="F2F2F2"/>
+                    </a:solidFill>
+                  </a:tcPr>
+                </a:tc>
+                <a:tc>
+                  <a:txBody>
+                    <a:bodyPr/>
+                    <a:lstStyle/>
+                    <a:p>
+                      <a:pPr algn="l"/>
+                      <a:r>
+                        <a:rPr sz="1300" b="0">
+                          <a:solidFill>
+                            <a:srgbClr val="3C3C3B"/>
+                          </a:solidFill>
+                          <a:latin typeface="Aptos"/>
+                        </a:rPr>
+                        <a:t>28.3%</a:t>
+                      </a:r>
+                    </a:p>
+                  </a:txBody>
+                  <a:tcPr marL="73152" marR="73152" marT="27432" marB="27432" anchor="ctr">
+                    <a:noFill/>
+                  </a:tcPr>
+                </a:tc>
+                <a:tc>
+                  <a:txBody>
+                    <a:bodyPr/>
+                    <a:lstStyle/>
+                    <a:p>
+                      <a:pPr algn="r"/>
+                      <a:r>
+                        <a:rPr sz="1300" b="0">
+                          <a:solidFill>
+                            <a:srgbClr val="3C3C3B"/>
+                          </a:solidFill>
+                          <a:latin typeface="Aptos"/>
+                        </a:rPr>
+                        <a:t>47.4%</a:t>
+                      </a:r>
+                    </a:p>
+                  </a:txBody>
+                  <a:tcPr marL="73152" marR="73152" marT="27432" marB="27432" anchor="ctr">
+                    <a:noFill/>
+                  </a:tcPr>
+                </a:tc>
+                <a:tc>
+                  <a:txBody>
+                    <a:bodyPr/>
+                    <a:lstStyle/>
+                    <a:p>
+                      <a:pPr algn="r"/>
+                      <a:r>
+                        <a:rPr sz="1300" b="0">
+                          <a:solidFill>
+                            <a:srgbClr val="3C3C3B"/>
+                          </a:solidFill>
+                          <a:latin typeface="Aptos"/>
+                        </a:rPr>
+                        <a:t>5.7%</a:t>
+                      </a:r>
+                    </a:p>
+                  </a:txBody>
+                  <a:tcPr marL="73152" marR="73152" marT="27432" marB="27432" anchor="ctr">
+                    <a:noFill/>
+                  </a:tcPr>
+                </a:tc>
+                <a:tc>
+                  <a:txBody>
+                    <a:bodyPr/>
+                    <a:lstStyle/>
+                    <a:p>
+                      <a:pPr algn="r"/>
+                      <a:r>
+                        <a:rPr sz="1300" b="0">
+                          <a:solidFill>
+                            <a:srgbClr val="3C3C3B"/>
+                          </a:solidFill>
+                          <a:latin typeface="Aptos"/>
+                        </a:rPr>
+                        <a:t>7.0%</a:t>
+                      </a:r>
+                    </a:p>
+                  </a:txBody>
+                  <a:tcPr marL="73152" marR="73152" marT="27432" marB="27432" anchor="ctr">
+                    <a:noFill/>
+                  </a:tcPr>
+                </a:tc>
+                <a:tc>
+                  <a:txBody>
+                    <a:bodyPr/>
+                    <a:lstStyle/>
+                    <a:p>
+                      <a:pPr algn="r"/>
+                      <a:r>
+                        <a:rPr sz="1300" b="0">
+                          <a:solidFill>
+                            <a:srgbClr val="3C3C3B"/>
+                          </a:solidFill>
+                          <a:latin typeface="Aptos"/>
+                        </a:rPr>
+                        <a:t>8.0%</a:t>
+                      </a:r>
+                    </a:p>
+                  </a:txBody>
+                  <a:tcPr marL="73152" marR="73152" marT="27432" marB="27432" anchor="ctr">
+                    <a:noFill/>
+                  </a:tcPr>
+                </a:tc>
+                <a:tc>
+                  <a:txBody>
+                    <a:bodyPr/>
+                    <a:lstStyle/>
+                    <a:p>
+                      <a:pPr algn="r"/>
+                      <a:r>
+                        <a:rPr sz="1300" b="0">
+                          <a:solidFill>
+                            <a:srgbClr val="3C3C3B"/>
+                          </a:solidFill>
+                          <a:latin typeface="Aptos"/>
+                        </a:rPr>
+                        <a:t>13.4%</a:t>
+                      </a:r>
+                    </a:p>
+                  </a:txBody>
+                  <a:tcPr marL="73152" marR="73152" marT="27432" marB="27432" anchor="ctr">
+                    <a:noFill/>
+                  </a:tcPr>
+                </a:tc>
+                <a:tc>
+                  <a:txBody>
+                    <a:bodyPr/>
+                    <a:lstStyle/>
+                    <a:p>
+                      <a:pPr algn="r"/>
+                      <a:r>
+                        <a:rPr sz="1300" b="0">
+                          <a:solidFill>
+                            <a:srgbClr val="3C3C3B"/>
+                          </a:solidFill>
+                          <a:latin typeface="Aptos"/>
+                        </a:rPr>
+                        <a:t>1.93x</a:t>
+                      </a:r>
+                    </a:p>
+                  </a:txBody>
+                  <a:tcPr marL="73152" marR="73152" marT="27432" marB="27432" anchor="ctr">
+                    <a:noFill/>
+                  </a:tcPr>
+                </a:tc>
+                <a:tc>
+                  <a:txBody>
+                    <a:bodyPr/>
+                    <a:lstStyle/>
+                    <a:p>
+                      <a:pPr algn="r"/>
+                      <a:r>
+                        <a:rPr sz="1300" b="0">
+                          <a:solidFill>
+                            <a:srgbClr val="3C3C3B"/>
+                          </a:solidFill>
+                          <a:latin typeface="Aptos"/>
+                        </a:rPr>
+                        <a:t>2.00x</a:t>
                       </a:r>
                     </a:p>
                   </a:txBody>
@@ -19958,7 +20665,7 @@
         <p:spPr>
           <a:xfrm>
             <a:off x="14127480" y="2240280"/>
-            <a:ext cx="4069080" cy="6583680"/>
+            <a:ext cx="4069080" cy="5852160"/>
           </a:xfrm>
           <a:prstGeom prst="rect">
             <a:avLst/>
@@ -20125,6 +20832,31 @@
               <a:t>a 10-year tenor lowers the European minimum DSCR to 1.25x and the hold IRR to 7.4%.</a:t>
             </a:r>
           </a:p>
+          <a:p>
+            <a:pPr algn="l">
+              <a:spcBef>
+                <a:spcPts val="800"/>
+              </a:spcBef>
+            </a:pPr>
+            <a:r>
+              <a:rPr sz="1300" b="1">
+                <a:solidFill>
+                  <a:srgbClr val="3C3C3B"/>
+                </a:solidFill>
+                <a:latin typeface="Aptos"/>
+              </a:rPr>
+              <a:t>Higher gearing: </a:t>
+            </a:r>
+            <a:r>
+              <a:rPr sz="1300" b="0">
+                <a:solidFill>
+                  <a:srgbClr val="3C3C3B"/>
+                </a:solidFill>
+                <a:latin typeface="Aptos"/>
+              </a:rPr>
+              <a:t>debt at 6x first-year EBITDA, capped at 70% of cost, is €57.3m / €54.1m; hold IRR 8.0% / 13.4%.</a:t>
+            </a:r>
+          </a:p>
         </p:txBody>
       </p:sp>
       <p:sp>
@@ -20156,7 +20888,7 @@
                 </a:solidFill>
                 <a:latin typeface="Aptos"/>
               </a:rPr>
-              <a:t>Each set changes one input, as named; tenor 10 years. Stored by the scenario macro with the tax solver; base = live model. Model checks in every set: all pass.</a:t>
+              <a:t>Each set changes one input, as named (the EBITDA set also raises the debt cap); tenor 10 years. Stored by the scenario macro with the tax solver; base = live model. Model checks in every set: all pass.</a:t>
             </a:r>
           </a:p>
           <a:p>

</xml_diff>

<commit_message>
Add BESS 100 MWh and promise-but-don't-build cases; allow 16 sets
Co-Authored-By: Claude Opus 5.5 <noreply@anthropic.com>
Claude-Session: https://claude.ai/code/session_01AWS1t9WtpkQHcCU1WceGZT
</commit_message>
<xml_diff>
--- a/projects/bana/out/Bana_IC.pptx
+++ b/projects/bana/out/Bana_IC.pptx
@@ -250,7 +250,7 @@
                   <c:v>0.284084033636541</c:v>
                 </c:pt>
                 <c:pt idx="1">
-                  <c:v>0.0798286717747287</c:v>
+                  <c:v>0.0798286717746915</c:v>
                 </c:pt>
               </c:numCache>
             </c:numRef>
@@ -300,7 +300,7 @@
                   <c:v>0.431605205102548</c:v>
                 </c:pt>
                 <c:pt idx="1">
-                  <c:v>0.120333275856178</c:v>
+                  <c:v>0.120333275856187</c:v>
                 </c:pt>
               </c:numCache>
             </c:numRef>
@@ -18092,7 +18092,7 @@
         </p:nvGraphicFramePr>
         <p:xfrm>
           <a:off x="4498848" y="2240280"/>
-          <a:ext cx="9418320" cy="5586984"/>
+          <a:ext cx="9509760" cy="6684264"/>
         </p:xfrm>
         <a:graphic>
           <a:graphicData uri="http://schemas.openxmlformats.org/drawingml/2006/table">
@@ -18101,15 +18101,16 @@
                 <a:tableStyleId>{5C22544A-7EE6-4342-B048-85BDC9FD1C3A}</a:tableStyleId>
               </a:tblPr>
               <a:tblGrid>
-                <a:gridCol w="2103120"/>
-                <a:gridCol w="914400"/>
-                <a:gridCol w="914400"/>
-                <a:gridCol w="914400"/>
-                <a:gridCol w="914400"/>
-                <a:gridCol w="914400"/>
-                <a:gridCol w="914400"/>
-                <a:gridCol w="914400"/>
-                <a:gridCol w="914400"/>
+                <a:gridCol w="1828800"/>
+                <a:gridCol w="731520"/>
+                <a:gridCol w="868680"/>
+                <a:gridCol w="868680"/>
+                <a:gridCol w="868680"/>
+                <a:gridCol w="868680"/>
+                <a:gridCol w="868680"/>
+                <a:gridCol w="868680"/>
+                <a:gridCol w="868680"/>
+                <a:gridCol w="868680"/>
               </a:tblGrid>
               <a:tr h="539496">
                 <a:tc>
@@ -18148,7 +18149,7 @@
                           </a:solidFill>
                           <a:latin typeface="Aptos"/>
                         </a:rPr>
-                        <a:t>COD EU</a:t>
+                        <a:t>Points EU</a:t>
                       </a:r>
                     </a:p>
                   </a:txBody>
@@ -18171,7 +18172,7 @@
                           </a:solidFill>
                           <a:latin typeface="Aptos"/>
                         </a:rPr>
-                        <a:t>COD CN</a:t>
+                        <a:t>COD EU</a:t>
                       </a:r>
                     </a:p>
                   </a:txBody>
@@ -18194,7 +18195,7 @@
                           </a:solidFill>
                           <a:latin typeface="Aptos"/>
                         </a:rPr>
-                        <a:t>Buyer EU</a:t>
+                        <a:t>COD CN</a:t>
                       </a:r>
                     </a:p>
                   </a:txBody>
@@ -18217,7 +18218,7 @@
                           </a:solidFill>
                           <a:latin typeface="Aptos"/>
                         </a:rPr>
-                        <a:t>Buyer CN</a:t>
+                        <a:t>Buyer EU</a:t>
                       </a:r>
                     </a:p>
                   </a:txBody>
@@ -18240,7 +18241,7 @@
                           </a:solidFill>
                           <a:latin typeface="Aptos"/>
                         </a:rPr>
-                        <a:t>Hold EU</a:t>
+                        <a:t>Buyer CN</a:t>
                       </a:r>
                     </a:p>
                   </a:txBody>
@@ -18263,7 +18264,7 @@
                           </a:solidFill>
                           <a:latin typeface="Aptos"/>
                         </a:rPr>
-                        <a:t>Hold CN</a:t>
+                        <a:t>Hold EU</a:t>
                       </a:r>
                     </a:p>
                   </a:txBody>
@@ -18286,7 +18287,7 @@
                           </a:solidFill>
                           <a:latin typeface="Aptos"/>
                         </a:rPr>
-                        <a:t>DSCR EU</a:t>
+                        <a:t>Hold CN</a:t>
                       </a:r>
                     </a:p>
                   </a:txBody>
@@ -18309,7 +18310,7 @@
                           </a:solidFill>
                           <a:latin typeface="Aptos"/>
                         </a:rPr>
-                        <a:t>DSCR CN</a:t>
+                        <a:t>DSCR EU</a:t>
                       </a:r>
                     </a:p>
                   </a:txBody>
@@ -18319,8 +18320,31 @@
                     </a:solidFill>
                   </a:tcPr>
                 </a:tc>
+                <a:tc>
+                  <a:txBody>
+                    <a:bodyPr/>
+                    <a:lstStyle/>
+                    <a:p>
+                      <a:pPr algn="r"/>
+                      <a:r>
+                        <a:rPr sz="1300" b="1">
+                          <a:solidFill>
+                            <a:srgbClr val="FFFFFF"/>
+                          </a:solidFill>
+                          <a:latin typeface="Aptos"/>
+                        </a:rPr>
+                        <a:t>DSCR CN</a:t>
+                      </a:r>
+                    </a:p>
+                  </a:txBody>
+                  <a:tcPr marL="73152" marR="73152" marT="27432" marB="27432" anchor="ctr">
+                    <a:solidFill>
+                      <a:srgbClr val="00A651"/>
+                    </a:solidFill>
+                  </a:tcPr>
+                </a:tc>
               </a:tr>
-              <a:tr h="420624">
+              <a:tr h="384048">
                 <a:tc>
                   <a:txBody>
                     <a:bodyPr/>
@@ -18357,7 +18381,7 @@
                           </a:solidFill>
                           <a:latin typeface="Aptos"/>
                         </a:rPr>
-                        <a:t>28.4%</a:t>
+                        <a:t>59.5</a:t>
                       </a:r>
                     </a:p>
                   </a:txBody>
@@ -18380,7 +18404,7 @@
                           </a:solidFill>
                           <a:latin typeface="Aptos"/>
                         </a:rPr>
-                        <a:t>43.2%</a:t>
+                        <a:t>28.4%</a:t>
                       </a:r>
                     </a:p>
                   </a:txBody>
@@ -18403,7 +18427,7 @@
                           </a:solidFill>
                           <a:latin typeface="Aptos"/>
                         </a:rPr>
-                        <a:t>5.7%</a:t>
+                        <a:t>43.2%</a:t>
                       </a:r>
                     </a:p>
                   </a:txBody>
@@ -18426,7 +18450,7 @@
                           </a:solidFill>
                           <a:latin typeface="Aptos"/>
                         </a:rPr>
-                        <a:t>7.0%</a:t>
+                        <a:t>5.7%</a:t>
                       </a:r>
                     </a:p>
                   </a:txBody>
@@ -18449,7 +18473,7 @@
                           </a:solidFill>
                           <a:latin typeface="Aptos"/>
                         </a:rPr>
-                        <a:t>8.0%</a:t>
+                        <a:t>7.0%</a:t>
                       </a:r>
                     </a:p>
                   </a:txBody>
@@ -18472,7 +18496,7 @@
                           </a:solidFill>
                           <a:latin typeface="Aptos"/>
                         </a:rPr>
-                        <a:t>12.0%</a:t>
+                        <a:t>8.0%</a:t>
                       </a:r>
                     </a:p>
                   </a:txBody>
@@ -18495,7 +18519,7 @@
                           </a:solidFill>
                           <a:latin typeface="Aptos"/>
                         </a:rPr>
-                        <a:t>1.91x</a:t>
+                        <a:t>12.0%</a:t>
                       </a:r>
                     </a:p>
                   </a:txBody>
@@ -18518,7 +18542,7 @@
                           </a:solidFill>
                           <a:latin typeface="Aptos"/>
                         </a:rPr>
-                        <a:t>2.53x</a:t>
+                        <a:t>1.91x</a:t>
                       </a:r>
                     </a:p>
                   </a:txBody>
@@ -18528,8 +18552,31 @@
                     </a:solidFill>
                   </a:tcPr>
                 </a:tc>
+                <a:tc>
+                  <a:txBody>
+                    <a:bodyPr/>
+                    <a:lstStyle/>
+                    <a:p>
+                      <a:pPr algn="r"/>
+                      <a:r>
+                        <a:rPr sz="1300" b="1">
+                          <a:solidFill>
+                            <a:srgbClr val="3C3C3B"/>
+                          </a:solidFill>
+                          <a:latin typeface="Aptos"/>
+                        </a:rPr>
+                        <a:t>2.53x</a:t>
+                      </a:r>
+                    </a:p>
+                  </a:txBody>
+                  <a:tcPr marL="73152" marR="73152" marT="27432" marB="27432" anchor="ctr">
+                    <a:solidFill>
+                      <a:srgbClr val="E6F4EC"/>
+                    </a:solidFill>
+                  </a:tcPr>
+                </a:tc>
               </a:tr>
-              <a:tr h="420624">
+              <a:tr h="384048">
                 <a:tc>
                   <a:txBody>
                     <a:bodyPr/>
@@ -18566,6 +18613,27 @@
                           </a:solidFill>
                           <a:latin typeface="Aptos"/>
                         </a:rPr>
+                        <a:t>59.5</a:t>
+                      </a:r>
+                    </a:p>
+                  </a:txBody>
+                  <a:tcPr marL="73152" marR="73152" marT="27432" marB="27432" anchor="ctr">
+                    <a:noFill/>
+                  </a:tcPr>
+                </a:tc>
+                <a:tc>
+                  <a:txBody>
+                    <a:bodyPr/>
+                    <a:lstStyle/>
+                    <a:p>
+                      <a:pPr algn="r"/>
+                      <a:r>
+                        <a:rPr sz="1300" b="0">
+                          <a:solidFill>
+                            <a:srgbClr val="3C3C3B"/>
+                          </a:solidFill>
+                          <a:latin typeface="Aptos"/>
+                        </a:rPr>
                         <a:t>12.1%</a:t>
                       </a:r>
                     </a:p>
@@ -18722,7 +18790,7 @@
                   </a:tcPr>
                 </a:tc>
               </a:tr>
-              <a:tr h="420624">
+              <a:tr h="384048">
                 <a:tc>
                   <a:txBody>
                     <a:bodyPr/>
@@ -18759,6 +18827,27 @@
                           </a:solidFill>
                           <a:latin typeface="Aptos"/>
                         </a:rPr>
+                        <a:t>59.5</a:t>
+                      </a:r>
+                    </a:p>
+                  </a:txBody>
+                  <a:tcPr marL="73152" marR="73152" marT="27432" marB="27432" anchor="ctr">
+                    <a:noFill/>
+                  </a:tcPr>
+                </a:tc>
+                <a:tc>
+                  <a:txBody>
+                    <a:bodyPr/>
+                    <a:lstStyle/>
+                    <a:p>
+                      <a:pPr algn="r"/>
+                      <a:r>
+                        <a:rPr sz="1300" b="0">
+                          <a:solidFill>
+                            <a:srgbClr val="3C3C3B"/>
+                          </a:solidFill>
+                          <a:latin typeface="Aptos"/>
+                        </a:rPr>
                         <a:t>42.2%</a:t>
                       </a:r>
                     </a:p>
@@ -18915,7 +19004,7 @@
                   </a:tcPr>
                 </a:tc>
               </a:tr>
-              <a:tr h="420624">
+              <a:tr h="384048">
                 <a:tc>
                   <a:txBody>
                     <a:bodyPr/>
@@ -18952,6 +19041,27 @@
                           </a:solidFill>
                           <a:latin typeface="Aptos"/>
                         </a:rPr>
+                        <a:t>59.5</a:t>
+                      </a:r>
+                    </a:p>
+                  </a:txBody>
+                  <a:tcPr marL="73152" marR="73152" marT="27432" marB="27432" anchor="ctr">
+                    <a:noFill/>
+                  </a:tcPr>
+                </a:tc>
+                <a:tc>
+                  <a:txBody>
+                    <a:bodyPr/>
+                    <a:lstStyle/>
+                    <a:p>
+                      <a:pPr algn="r"/>
+                      <a:r>
+                        <a:rPr sz="1300" b="0">
+                          <a:solidFill>
+                            <a:srgbClr val="3C3C3B"/>
+                          </a:solidFill>
+                          <a:latin typeface="Aptos"/>
+                        </a:rPr>
                         <a:t>21.2%</a:t>
                       </a:r>
                     </a:p>
@@ -19108,7 +19218,7 @@
                   </a:tcPr>
                 </a:tc>
               </a:tr>
-              <a:tr h="420624">
+              <a:tr h="384048">
                 <a:tc>
                   <a:txBody>
                     <a:bodyPr/>
@@ -19145,6 +19255,27 @@
                           </a:solidFill>
                           <a:latin typeface="Aptos"/>
                         </a:rPr>
+                        <a:t>59.5</a:t>
+                      </a:r>
+                    </a:p>
+                  </a:txBody>
+                  <a:tcPr marL="73152" marR="73152" marT="27432" marB="27432" anchor="ctr">
+                    <a:noFill/>
+                  </a:tcPr>
+                </a:tc>
+                <a:tc>
+                  <a:txBody>
+                    <a:bodyPr/>
+                    <a:lstStyle/>
+                    <a:p>
+                      <a:pPr algn="r"/>
+                      <a:r>
+                        <a:rPr sz="1300" b="0">
+                          <a:solidFill>
+                            <a:srgbClr val="3C3C3B"/>
+                          </a:solidFill>
+                          <a:latin typeface="Aptos"/>
+                        </a:rPr>
                         <a:t>28.4%</a:t>
                       </a:r>
                     </a:p>
@@ -19301,7 +19432,7 @@
                   </a:tcPr>
                 </a:tc>
               </a:tr>
-              <a:tr h="420624">
+              <a:tr h="384048">
                 <a:tc>
                   <a:txBody>
                     <a:bodyPr/>
@@ -19338,6 +19469,27 @@
                           </a:solidFill>
                           <a:latin typeface="Aptos"/>
                         </a:rPr>
+                        <a:t>59.5</a:t>
+                      </a:r>
+                    </a:p>
+                  </a:txBody>
+                  <a:tcPr marL="73152" marR="73152" marT="27432" marB="27432" anchor="ctr">
+                    <a:noFill/>
+                  </a:tcPr>
+                </a:tc>
+                <a:tc>
+                  <a:txBody>
+                    <a:bodyPr/>
+                    <a:lstStyle/>
+                    <a:p>
+                      <a:pPr algn="r"/>
+                      <a:r>
+                        <a:rPr sz="1300" b="0">
+                          <a:solidFill>
+                            <a:srgbClr val="3C3C3B"/>
+                          </a:solidFill>
+                          <a:latin typeface="Aptos"/>
+                        </a:rPr>
                         <a:t>28.4%</a:t>
                       </a:r>
                     </a:p>
@@ -19494,7 +19646,7 @@
                   </a:tcPr>
                 </a:tc>
               </a:tr>
-              <a:tr h="420624">
+              <a:tr h="384048">
                 <a:tc>
                   <a:txBody>
                     <a:bodyPr/>
@@ -19531,6 +19683,27 @@
                           </a:solidFill>
                           <a:latin typeface="Aptos"/>
                         </a:rPr>
+                        <a:t>59.5</a:t>
+                      </a:r>
+                    </a:p>
+                  </a:txBody>
+                  <a:tcPr marL="73152" marR="73152" marT="27432" marB="27432" anchor="ctr">
+                    <a:noFill/>
+                  </a:tcPr>
+                </a:tc>
+                <a:tc>
+                  <a:txBody>
+                    <a:bodyPr/>
+                    <a:lstStyle/>
+                    <a:p>
+                      <a:pPr algn="r"/>
+                      <a:r>
+                        <a:rPr sz="1300" b="0">
+                          <a:solidFill>
+                            <a:srgbClr val="3C3C3B"/>
+                          </a:solidFill>
+                          <a:latin typeface="Aptos"/>
+                        </a:rPr>
                         <a:t>25.9%</a:t>
                       </a:r>
                     </a:p>
@@ -19687,7 +19860,7 @@
                   </a:tcPr>
                 </a:tc>
               </a:tr>
-              <a:tr h="420624">
+              <a:tr h="384048">
                 <a:tc>
                   <a:txBody>
                     <a:bodyPr/>
@@ -19724,6 +19897,27 @@
                           </a:solidFill>
                           <a:latin typeface="Aptos"/>
                         </a:rPr>
+                        <a:t>59.5</a:t>
+                      </a:r>
+                    </a:p>
+                  </a:txBody>
+                  <a:tcPr marL="73152" marR="73152" marT="27432" marB="27432" anchor="ctr">
+                    <a:noFill/>
+                  </a:tcPr>
+                </a:tc>
+                <a:tc>
+                  <a:txBody>
+                    <a:bodyPr/>
+                    <a:lstStyle/>
+                    <a:p>
+                      <a:pPr algn="r"/>
+                      <a:r>
+                        <a:rPr sz="1300" b="0">
+                          <a:solidFill>
+                            <a:srgbClr val="3C3C3B"/>
+                          </a:solidFill>
+                          <a:latin typeface="Aptos"/>
+                        </a:rPr>
                         <a:t>27.8%</a:t>
                       </a:r>
                     </a:p>
@@ -19880,7 +20074,7 @@
                   </a:tcPr>
                 </a:tc>
               </a:tr>
-              <a:tr h="420624">
+              <a:tr h="384048">
                 <a:tc>
                   <a:txBody>
                     <a:bodyPr/>
@@ -19917,6 +20111,27 @@
                           </a:solidFill>
                           <a:latin typeface="Aptos"/>
                         </a:rPr>
+                        <a:t>59.5</a:t>
+                      </a:r>
+                    </a:p>
+                  </a:txBody>
+                  <a:tcPr marL="73152" marR="73152" marT="27432" marB="27432" anchor="ctr">
+                    <a:noFill/>
+                  </a:tcPr>
+                </a:tc>
+                <a:tc>
+                  <a:txBody>
+                    <a:bodyPr/>
+                    <a:lstStyle/>
+                    <a:p>
+                      <a:pPr algn="r"/>
+                      <a:r>
+                        <a:rPr sz="1300" b="0">
+                          <a:solidFill>
+                            <a:srgbClr val="3C3C3B"/>
+                          </a:solidFill>
+                          <a:latin typeface="Aptos"/>
+                        </a:rPr>
                         <a:t>28.4%</a:t>
                       </a:r>
                     </a:p>
@@ -20073,7 +20288,7 @@
                   </a:tcPr>
                 </a:tc>
               </a:tr>
-              <a:tr h="420624">
+              <a:tr h="384048">
                 <a:tc>
                   <a:txBody>
                     <a:bodyPr/>
@@ -20110,6 +20325,27 @@
                           </a:solidFill>
                           <a:latin typeface="Aptos"/>
                         </a:rPr>
+                        <a:t>59.5</a:t>
+                      </a:r>
+                    </a:p>
+                  </a:txBody>
+                  <a:tcPr marL="73152" marR="73152" marT="27432" marB="27432" anchor="ctr">
+                    <a:noFill/>
+                  </a:tcPr>
+                </a:tc>
+                <a:tc>
+                  <a:txBody>
+                    <a:bodyPr/>
+                    <a:lstStyle/>
+                    <a:p>
+                      <a:pPr algn="r"/>
+                      <a:r>
+                        <a:rPr sz="1300" b="0">
+                          <a:solidFill>
+                            <a:srgbClr val="3C3C3B"/>
+                          </a:solidFill>
+                          <a:latin typeface="Aptos"/>
+                        </a:rPr>
                         <a:t>28.4%</a:t>
                       </a:r>
                     </a:p>
@@ -20266,7 +20502,7 @@
                   </a:tcPr>
                 </a:tc>
               </a:tr>
-              <a:tr h="420624">
+              <a:tr h="384048">
                 <a:tc>
                   <a:txBody>
                     <a:bodyPr/>
@@ -20303,6 +20539,27 @@
                           </a:solidFill>
                           <a:latin typeface="Aptos"/>
                         </a:rPr>
+                        <a:t>59.5</a:t>
+                      </a:r>
+                    </a:p>
+                  </a:txBody>
+                  <a:tcPr marL="73152" marR="73152" marT="27432" marB="27432" anchor="ctr">
+                    <a:noFill/>
+                  </a:tcPr>
+                </a:tc>
+                <a:tc>
+                  <a:txBody>
+                    <a:bodyPr/>
+                    <a:lstStyle/>
+                    <a:p>
+                      <a:pPr algn="r"/>
+                      <a:r>
+                        <a:rPr sz="1300" b="0">
+                          <a:solidFill>
+                            <a:srgbClr val="3C3C3B"/>
+                          </a:solidFill>
+                          <a:latin typeface="Aptos"/>
+                        </a:rPr>
                         <a:t>28.4%</a:t>
                       </a:r>
                     </a:p>
@@ -20459,7 +20716,7 @@
                   </a:tcPr>
                 </a:tc>
               </a:tr>
-              <a:tr h="420624">
+              <a:tr h="384048">
                 <a:tc>
                   <a:txBody>
                     <a:bodyPr/>
@@ -20496,6 +20753,27 @@
                           </a:solidFill>
                           <a:latin typeface="Aptos"/>
                         </a:rPr>
+                        <a:t>59.5</a:t>
+                      </a:r>
+                    </a:p>
+                  </a:txBody>
+                  <a:tcPr marL="73152" marR="73152" marT="27432" marB="27432" anchor="ctr">
+                    <a:noFill/>
+                  </a:tcPr>
+                </a:tc>
+                <a:tc>
+                  <a:txBody>
+                    <a:bodyPr/>
+                    <a:lstStyle/>
+                    <a:p>
+                      <a:pPr algn="r"/>
+                      <a:r>
+                        <a:rPr sz="1300" b="0">
+                          <a:solidFill>
+                            <a:srgbClr val="3C3C3B"/>
+                          </a:solidFill>
+                          <a:latin typeface="Aptos"/>
+                        </a:rPr>
                         <a:t>28.3%</a:t>
                       </a:r>
                     </a:p>
@@ -20644,6 +20922,862 @@
                           <a:latin typeface="Aptos"/>
                         </a:rPr>
                         <a:t>2.00x</a:t>
+                      </a:r>
+                    </a:p>
+                  </a:txBody>
+                  <a:tcPr marL="73152" marR="73152" marT="27432" marB="27432" anchor="ctr">
+                    <a:noFill/>
+                  </a:tcPr>
+                </a:tc>
+              </a:tr>
+              <a:tr h="384048">
+                <a:tc>
+                  <a:txBody>
+                    <a:bodyPr/>
+                    <a:lstStyle/>
+                    <a:p>
+                      <a:pPr algn="l"/>
+                      <a:r>
+                        <a:rPr sz="1300" b="0">
+                          <a:solidFill>
+                            <a:srgbClr val="3C3C3B"/>
+                          </a:solidFill>
+                          <a:latin typeface="Aptos"/>
+                        </a:rPr>
+                        <a:t>BESS 100 MWh</a:t>
+                      </a:r>
+                    </a:p>
+                  </a:txBody>
+                  <a:tcPr marL="73152" marR="73152" marT="27432" marB="27432" anchor="ctr">
+                    <a:solidFill>
+                      <a:srgbClr val="F2F2F2"/>
+                    </a:solidFill>
+                  </a:tcPr>
+                </a:tc>
+                <a:tc>
+                  <a:txBody>
+                    <a:bodyPr/>
+                    <a:lstStyle/>
+                    <a:p>
+                      <a:pPr algn="l"/>
+                      <a:r>
+                        <a:rPr sz="1300" b="0">
+                          <a:solidFill>
+                            <a:srgbClr val="3C3C3B"/>
+                          </a:solidFill>
+                          <a:latin typeface="Aptos"/>
+                        </a:rPr>
+                        <a:t>65.5</a:t>
+                      </a:r>
+                    </a:p>
+                  </a:txBody>
+                  <a:tcPr marL="73152" marR="73152" marT="27432" marB="27432" anchor="ctr">
+                    <a:noFill/>
+                  </a:tcPr>
+                </a:tc>
+                <a:tc>
+                  <a:txBody>
+                    <a:bodyPr/>
+                    <a:lstStyle/>
+                    <a:p>
+                      <a:pPr algn="r"/>
+                      <a:r>
+                        <a:rPr sz="1300" b="0">
+                          <a:solidFill>
+                            <a:srgbClr val="3C3C3B"/>
+                          </a:solidFill>
+                          <a:latin typeface="Aptos"/>
+                        </a:rPr>
+                        <a:t>23.4%</a:t>
+                      </a:r>
+                    </a:p>
+                  </a:txBody>
+                  <a:tcPr marL="73152" marR="73152" marT="27432" marB="27432" anchor="ctr">
+                    <a:noFill/>
+                  </a:tcPr>
+                </a:tc>
+                <a:tc>
+                  <a:txBody>
+                    <a:bodyPr/>
+                    <a:lstStyle/>
+                    <a:p>
+                      <a:pPr algn="r"/>
+                      <a:r>
+                        <a:rPr sz="1300" b="0">
+                          <a:solidFill>
+                            <a:srgbClr val="3C3C3B"/>
+                          </a:solidFill>
+                          <a:latin typeface="Aptos"/>
+                        </a:rPr>
+                        <a:t>38.0%</a:t>
+                      </a:r>
+                    </a:p>
+                  </a:txBody>
+                  <a:tcPr marL="73152" marR="73152" marT="27432" marB="27432" anchor="ctr">
+                    <a:noFill/>
+                  </a:tcPr>
+                </a:tc>
+                <a:tc>
+                  <a:txBody>
+                    <a:bodyPr/>
+                    <a:lstStyle/>
+                    <a:p>
+                      <a:pPr algn="r"/>
+                      <a:r>
+                        <a:rPr sz="1300" b="0">
+                          <a:solidFill>
+                            <a:srgbClr val="3C3C3B"/>
+                          </a:solidFill>
+                          <a:latin typeface="Aptos"/>
+                        </a:rPr>
+                        <a:t>5.7%</a:t>
+                      </a:r>
+                    </a:p>
+                  </a:txBody>
+                  <a:tcPr marL="73152" marR="73152" marT="27432" marB="27432" anchor="ctr">
+                    <a:noFill/>
+                  </a:tcPr>
+                </a:tc>
+                <a:tc>
+                  <a:txBody>
+                    <a:bodyPr/>
+                    <a:lstStyle/>
+                    <a:p>
+                      <a:pPr algn="r"/>
+                      <a:r>
+                        <a:rPr sz="1300" b="0">
+                          <a:solidFill>
+                            <a:srgbClr val="3C3C3B"/>
+                          </a:solidFill>
+                          <a:latin typeface="Aptos"/>
+                        </a:rPr>
+                        <a:t>7.0%</a:t>
+                      </a:r>
+                    </a:p>
+                  </a:txBody>
+                  <a:tcPr marL="73152" marR="73152" marT="27432" marB="27432" anchor="ctr">
+                    <a:noFill/>
+                  </a:tcPr>
+                </a:tc>
+                <a:tc>
+                  <a:txBody>
+                    <a:bodyPr/>
+                    <a:lstStyle/>
+                    <a:p>
+                      <a:pPr algn="r"/>
+                      <a:r>
+                        <a:rPr sz="1300" b="0">
+                          <a:solidFill>
+                            <a:srgbClr val="3C3C3B"/>
+                          </a:solidFill>
+                          <a:latin typeface="Aptos"/>
+                        </a:rPr>
+                        <a:t>7.5%</a:t>
+                      </a:r>
+                    </a:p>
+                  </a:txBody>
+                  <a:tcPr marL="73152" marR="73152" marT="27432" marB="27432" anchor="ctr">
+                    <a:noFill/>
+                  </a:tcPr>
+                </a:tc>
+                <a:tc>
+                  <a:txBody>
+                    <a:bodyPr/>
+                    <a:lstStyle/>
+                    <a:p>
+                      <a:pPr algn="r"/>
+                      <a:r>
+                        <a:rPr sz="1300" b="0">
+                          <a:solidFill>
+                            <a:srgbClr val="3C3C3B"/>
+                          </a:solidFill>
+                          <a:latin typeface="Aptos"/>
+                        </a:rPr>
+                        <a:t>11.3%</a:t>
+                      </a:r>
+                    </a:p>
+                  </a:txBody>
+                  <a:tcPr marL="73152" marR="73152" marT="27432" marB="27432" anchor="ctr">
+                    <a:noFill/>
+                  </a:tcPr>
+                </a:tc>
+                <a:tc>
+                  <a:txBody>
+                    <a:bodyPr/>
+                    <a:lstStyle/>
+                    <a:p>
+                      <a:pPr algn="r"/>
+                      <a:r>
+                        <a:rPr sz="1300" b="0">
+                          <a:solidFill>
+                            <a:srgbClr val="3C3C3B"/>
+                          </a:solidFill>
+                          <a:latin typeface="Aptos"/>
+                        </a:rPr>
+                        <a:t>1.85x</a:t>
+                      </a:r>
+                    </a:p>
+                  </a:txBody>
+                  <a:tcPr marL="73152" marR="73152" marT="27432" marB="27432" anchor="ctr">
+                    <a:noFill/>
+                  </a:tcPr>
+                </a:tc>
+                <a:tc>
+                  <a:txBody>
+                    <a:bodyPr/>
+                    <a:lstStyle/>
+                    <a:p>
+                      <a:pPr algn="r"/>
+                      <a:r>
+                        <a:rPr sz="1300" b="0">
+                          <a:solidFill>
+                            <a:srgbClr val="3C3C3B"/>
+                          </a:solidFill>
+                          <a:latin typeface="Aptos"/>
+                        </a:rPr>
+                        <a:t>2.42x</a:t>
+                      </a:r>
+                    </a:p>
+                  </a:txBody>
+                  <a:tcPr marL="73152" marR="73152" marT="27432" marB="27432" anchor="ctr">
+                    <a:noFill/>
+                  </a:tcPr>
+                </a:tc>
+              </a:tr>
+              <a:tr h="384048">
+                <a:tc>
+                  <a:txBody>
+                    <a:bodyPr/>
+                    <a:lstStyle/>
+                    <a:p>
+                      <a:pPr algn="l"/>
+                      <a:r>
+                        <a:rPr sz="1300" b="0">
+                          <a:solidFill>
+                            <a:srgbClr val="3C3C3B"/>
+                          </a:solidFill>
+                          <a:latin typeface="Aptos"/>
+                        </a:rPr>
+                        <a:t>Not built, pro rata</a:t>
+                      </a:r>
+                    </a:p>
+                  </a:txBody>
+                  <a:tcPr marL="73152" marR="73152" marT="27432" marB="27432" anchor="ctr">
+                    <a:solidFill>
+                      <a:srgbClr val="F2F2F2"/>
+                    </a:solidFill>
+                  </a:tcPr>
+                </a:tc>
+                <a:tc>
+                  <a:txBody>
+                    <a:bodyPr/>
+                    <a:lstStyle/>
+                    <a:p>
+                      <a:pPr algn="l"/>
+                      <a:r>
+                        <a:rPr sz="1300" b="0">
+                          <a:solidFill>
+                            <a:srgbClr val="3C3C3B"/>
+                          </a:solidFill>
+                          <a:latin typeface="Aptos"/>
+                        </a:rPr>
+                        <a:t>59.5</a:t>
+                      </a:r>
+                    </a:p>
+                  </a:txBody>
+                  <a:tcPr marL="73152" marR="73152" marT="27432" marB="27432" anchor="ctr">
+                    <a:noFill/>
+                  </a:tcPr>
+                </a:tc>
+                <a:tc>
+                  <a:txBody>
+                    <a:bodyPr/>
+                    <a:lstStyle/>
+                    <a:p>
+                      <a:pPr algn="r"/>
+                      <a:r>
+                        <a:rPr sz="1300" b="0">
+                          <a:solidFill>
+                            <a:srgbClr val="3C3C3B"/>
+                          </a:solidFill>
+                          <a:latin typeface="Aptos"/>
+                        </a:rPr>
+                        <a:t>26.4%</a:t>
+                      </a:r>
+                    </a:p>
+                  </a:txBody>
+                  <a:tcPr marL="73152" marR="73152" marT="27432" marB="27432" anchor="ctr">
+                    <a:noFill/>
+                  </a:tcPr>
+                </a:tc>
+                <a:tc>
+                  <a:txBody>
+                    <a:bodyPr/>
+                    <a:lstStyle/>
+                    <a:p>
+                      <a:pPr algn="r"/>
+                      <a:r>
+                        <a:rPr sz="1300" b="0">
+                          <a:solidFill>
+                            <a:srgbClr val="3C3C3B"/>
+                          </a:solidFill>
+                          <a:latin typeface="Aptos"/>
+                        </a:rPr>
+                        <a:t>40.6%</a:t>
+                      </a:r>
+                    </a:p>
+                  </a:txBody>
+                  <a:tcPr marL="73152" marR="73152" marT="27432" marB="27432" anchor="ctr">
+                    <a:noFill/>
+                  </a:tcPr>
+                </a:tc>
+                <a:tc>
+                  <a:txBody>
+                    <a:bodyPr/>
+                    <a:lstStyle/>
+                    <a:p>
+                      <a:pPr algn="r"/>
+                      <a:r>
+                        <a:rPr sz="1300" b="0">
+                          <a:solidFill>
+                            <a:srgbClr val="3C3C3B"/>
+                          </a:solidFill>
+                          <a:latin typeface="Aptos"/>
+                        </a:rPr>
+                        <a:t>5.7%</a:t>
+                      </a:r>
+                    </a:p>
+                  </a:txBody>
+                  <a:tcPr marL="73152" marR="73152" marT="27432" marB="27432" anchor="ctr">
+                    <a:noFill/>
+                  </a:tcPr>
+                </a:tc>
+                <a:tc>
+                  <a:txBody>
+                    <a:bodyPr/>
+                    <a:lstStyle/>
+                    <a:p>
+                      <a:pPr algn="r"/>
+                      <a:r>
+                        <a:rPr sz="1300" b="0">
+                          <a:solidFill>
+                            <a:srgbClr val="3C3C3B"/>
+                          </a:solidFill>
+                          <a:latin typeface="Aptos"/>
+                        </a:rPr>
+                        <a:t>7.0%</a:t>
+                      </a:r>
+                    </a:p>
+                  </a:txBody>
+                  <a:tcPr marL="73152" marR="73152" marT="27432" marB="27432" anchor="ctr">
+                    <a:noFill/>
+                  </a:tcPr>
+                </a:tc>
+                <a:tc>
+                  <a:txBody>
+                    <a:bodyPr/>
+                    <a:lstStyle/>
+                    <a:p>
+                      <a:pPr algn="r"/>
+                      <a:r>
+                        <a:rPr sz="1300" b="0">
+                          <a:solidFill>
+                            <a:srgbClr val="3C3C3B"/>
+                          </a:solidFill>
+                          <a:latin typeface="Aptos"/>
+                        </a:rPr>
+                        <a:t>7.8%</a:t>
+                      </a:r>
+                    </a:p>
+                  </a:txBody>
+                  <a:tcPr marL="73152" marR="73152" marT="27432" marB="27432" anchor="ctr">
+                    <a:noFill/>
+                  </a:tcPr>
+                </a:tc>
+                <a:tc>
+                  <a:txBody>
+                    <a:bodyPr/>
+                    <a:lstStyle/>
+                    <a:p>
+                      <a:pPr algn="r"/>
+                      <a:r>
+                        <a:rPr sz="1300" b="0">
+                          <a:solidFill>
+                            <a:srgbClr val="3C3C3B"/>
+                          </a:solidFill>
+                          <a:latin typeface="Aptos"/>
+                        </a:rPr>
+                        <a:t>11.7%</a:t>
+                      </a:r>
+                    </a:p>
+                  </a:txBody>
+                  <a:tcPr marL="73152" marR="73152" marT="27432" marB="27432" anchor="ctr">
+                    <a:noFill/>
+                  </a:tcPr>
+                </a:tc>
+                <a:tc>
+                  <a:txBody>
+                    <a:bodyPr/>
+                    <a:lstStyle/>
+                    <a:p>
+                      <a:pPr algn="r"/>
+                      <a:r>
+                        <a:rPr sz="1300" b="0">
+                          <a:solidFill>
+                            <a:srgbClr val="3C3C3B"/>
+                          </a:solidFill>
+                          <a:latin typeface="Aptos"/>
+                        </a:rPr>
+                        <a:t>1.92x</a:t>
+                      </a:r>
+                    </a:p>
+                  </a:txBody>
+                  <a:tcPr marL="73152" marR="73152" marT="27432" marB="27432" anchor="ctr">
+                    <a:noFill/>
+                  </a:tcPr>
+                </a:tc>
+                <a:tc>
+                  <a:txBody>
+                    <a:bodyPr/>
+                    <a:lstStyle/>
+                    <a:p>
+                      <a:pPr algn="r"/>
+                      <a:r>
+                        <a:rPr sz="1300" b="0">
+                          <a:solidFill>
+                            <a:srgbClr val="3C3C3B"/>
+                          </a:solidFill>
+                          <a:latin typeface="Aptos"/>
+                        </a:rPr>
+                        <a:t>2.55x</a:t>
+                      </a:r>
+                    </a:p>
+                  </a:txBody>
+                  <a:tcPr marL="73152" marR="73152" marT="27432" marB="27432" anchor="ctr">
+                    <a:noFill/>
+                  </a:tcPr>
+                </a:tc>
+              </a:tr>
+              <a:tr h="384048">
+                <a:tc>
+                  <a:txBody>
+                    <a:bodyPr/>
+                    <a:lstStyle/>
+                    <a:p>
+                      <a:pPr algn="l"/>
+                      <a:r>
+                        <a:rPr sz="1300" b="0">
+                          <a:solidFill>
+                            <a:srgbClr val="3C3C3B"/>
+                          </a:solidFill>
+                          <a:latin typeface="Aptos"/>
+                        </a:rPr>
+                        <a:t>Not built, full call</a:t>
+                      </a:r>
+                    </a:p>
+                  </a:txBody>
+                  <a:tcPr marL="73152" marR="73152" marT="27432" marB="27432" anchor="ctr">
+                    <a:solidFill>
+                      <a:srgbClr val="F2F2F2"/>
+                    </a:solidFill>
+                  </a:tcPr>
+                </a:tc>
+                <a:tc>
+                  <a:txBody>
+                    <a:bodyPr/>
+                    <a:lstStyle/>
+                    <a:p>
+                      <a:pPr algn="l"/>
+                      <a:r>
+                        <a:rPr sz="1300" b="0">
+                          <a:solidFill>
+                            <a:srgbClr val="3C3C3B"/>
+                          </a:solidFill>
+                          <a:latin typeface="Aptos"/>
+                        </a:rPr>
+                        <a:t>59.5</a:t>
+                      </a:r>
+                    </a:p>
+                  </a:txBody>
+                  <a:tcPr marL="73152" marR="73152" marT="27432" marB="27432" anchor="ctr">
+                    <a:noFill/>
+                  </a:tcPr>
+                </a:tc>
+                <a:tc>
+                  <a:txBody>
+                    <a:bodyPr/>
+                    <a:lstStyle/>
+                    <a:p>
+                      <a:pPr algn="r"/>
+                      <a:r>
+                        <a:rPr sz="1300" b="0">
+                          <a:solidFill>
+                            <a:srgbClr val="3C3C3B"/>
+                          </a:solidFill>
+                          <a:latin typeface="Aptos"/>
+                        </a:rPr>
+                        <a:t>24.8%</a:t>
+                      </a:r>
+                    </a:p>
+                  </a:txBody>
+                  <a:tcPr marL="73152" marR="73152" marT="27432" marB="27432" anchor="ctr">
+                    <a:noFill/>
+                  </a:tcPr>
+                </a:tc>
+                <a:tc>
+                  <a:txBody>
+                    <a:bodyPr/>
+                    <a:lstStyle/>
+                    <a:p>
+                      <a:pPr algn="r"/>
+                      <a:r>
+                        <a:rPr sz="1300" b="0">
+                          <a:solidFill>
+                            <a:srgbClr val="3C3C3B"/>
+                          </a:solidFill>
+                          <a:latin typeface="Aptos"/>
+                        </a:rPr>
+                        <a:t>39.0%</a:t>
+                      </a:r>
+                    </a:p>
+                  </a:txBody>
+                  <a:tcPr marL="73152" marR="73152" marT="27432" marB="27432" anchor="ctr">
+                    <a:noFill/>
+                  </a:tcPr>
+                </a:tc>
+                <a:tc>
+                  <a:txBody>
+                    <a:bodyPr/>
+                    <a:lstStyle/>
+                    <a:p>
+                      <a:pPr algn="r"/>
+                      <a:r>
+                        <a:rPr sz="1300" b="0">
+                          <a:solidFill>
+                            <a:srgbClr val="3C3C3B"/>
+                          </a:solidFill>
+                          <a:latin typeface="Aptos"/>
+                        </a:rPr>
+                        <a:t>5.7%</a:t>
+                      </a:r>
+                    </a:p>
+                  </a:txBody>
+                  <a:tcPr marL="73152" marR="73152" marT="27432" marB="27432" anchor="ctr">
+                    <a:noFill/>
+                  </a:tcPr>
+                </a:tc>
+                <a:tc>
+                  <a:txBody>
+                    <a:bodyPr/>
+                    <a:lstStyle/>
+                    <a:p>
+                      <a:pPr algn="r"/>
+                      <a:r>
+                        <a:rPr sz="1300" b="0">
+                          <a:solidFill>
+                            <a:srgbClr val="3C3C3B"/>
+                          </a:solidFill>
+                          <a:latin typeface="Aptos"/>
+                        </a:rPr>
+                        <a:t>7.0%</a:t>
+                      </a:r>
+                    </a:p>
+                  </a:txBody>
+                  <a:tcPr marL="73152" marR="73152" marT="27432" marB="27432" anchor="ctr">
+                    <a:noFill/>
+                  </a:tcPr>
+                </a:tc>
+                <a:tc>
+                  <a:txBody>
+                    <a:bodyPr/>
+                    <a:lstStyle/>
+                    <a:p>
+                      <a:pPr algn="r"/>
+                      <a:r>
+                        <a:rPr sz="1300" b="0">
+                          <a:solidFill>
+                            <a:srgbClr val="3C3C3B"/>
+                          </a:solidFill>
+                          <a:latin typeface="Aptos"/>
+                        </a:rPr>
+                        <a:t>7.6%</a:t>
+                      </a:r>
+                    </a:p>
+                  </a:txBody>
+                  <a:tcPr marL="73152" marR="73152" marT="27432" marB="27432" anchor="ctr">
+                    <a:noFill/>
+                  </a:tcPr>
+                </a:tc>
+                <a:tc>
+                  <a:txBody>
+                    <a:bodyPr/>
+                    <a:lstStyle/>
+                    <a:p>
+                      <a:pPr algn="r"/>
+                      <a:r>
+                        <a:rPr sz="1300" b="0">
+                          <a:solidFill>
+                            <a:srgbClr val="3C3C3B"/>
+                          </a:solidFill>
+                          <a:latin typeface="Aptos"/>
+                        </a:rPr>
+                        <a:t>11.4%</a:t>
+                      </a:r>
+                    </a:p>
+                  </a:txBody>
+                  <a:tcPr marL="73152" marR="73152" marT="27432" marB="27432" anchor="ctr">
+                    <a:noFill/>
+                  </a:tcPr>
+                </a:tc>
+                <a:tc>
+                  <a:txBody>
+                    <a:bodyPr/>
+                    <a:lstStyle/>
+                    <a:p>
+                      <a:pPr algn="r"/>
+                      <a:r>
+                        <a:rPr sz="1300" b="0">
+                          <a:solidFill>
+                            <a:srgbClr val="3C3C3B"/>
+                          </a:solidFill>
+                          <a:latin typeface="Aptos"/>
+                        </a:rPr>
+                        <a:t>1.92x</a:t>
+                      </a:r>
+                    </a:p>
+                  </a:txBody>
+                  <a:tcPr marL="73152" marR="73152" marT="27432" marB="27432" anchor="ctr">
+                    <a:noFill/>
+                  </a:tcPr>
+                </a:tc>
+                <a:tc>
+                  <a:txBody>
+                    <a:bodyPr/>
+                    <a:lstStyle/>
+                    <a:p>
+                      <a:pPr algn="r"/>
+                      <a:r>
+                        <a:rPr sz="1300" b="0">
+                          <a:solidFill>
+                            <a:srgbClr val="3C3C3B"/>
+                          </a:solidFill>
+                          <a:latin typeface="Aptos"/>
+                        </a:rPr>
+                        <a:t>2.55x</a:t>
+                      </a:r>
+                    </a:p>
+                  </a:txBody>
+                  <a:tcPr marL="73152" marR="73152" marT="27432" marB="27432" anchor="ctr">
+                    <a:noFill/>
+                  </a:tcPr>
+                </a:tc>
+              </a:tr>
+              <a:tr h="384048">
+                <a:tc>
+                  <a:txBody>
+                    <a:bodyPr/>
+                    <a:lstStyle/>
+                    <a:p>
+                      <a:pPr algn="l"/>
+                      <a:r>
+                        <a:rPr sz="1300" b="0">
+                          <a:solidFill>
+                            <a:srgbClr val="3C3C3B"/>
+                          </a:solidFill>
+                          <a:latin typeface="Aptos"/>
+                        </a:rPr>
+                        <a:t>BESS not built</a:t>
+                      </a:r>
+                    </a:p>
+                  </a:txBody>
+                  <a:tcPr marL="73152" marR="73152" marT="27432" marB="27432" anchor="ctr">
+                    <a:solidFill>
+                      <a:srgbClr val="F2F2F2"/>
+                    </a:solidFill>
+                  </a:tcPr>
+                </a:tc>
+                <a:tc>
+                  <a:txBody>
+                    <a:bodyPr/>
+                    <a:lstStyle/>
+                    <a:p>
+                      <a:pPr algn="l"/>
+                      <a:r>
+                        <a:rPr sz="1300" b="0">
+                          <a:solidFill>
+                            <a:srgbClr val="3C3C3B"/>
+                          </a:solidFill>
+                          <a:latin typeface="Aptos"/>
+                        </a:rPr>
+                        <a:t>59.5</a:t>
+                      </a:r>
+                    </a:p>
+                  </a:txBody>
+                  <a:tcPr marL="73152" marR="73152" marT="27432" marB="27432" anchor="ctr">
+                    <a:noFill/>
+                  </a:tcPr>
+                </a:tc>
+                <a:tc>
+                  <a:txBody>
+                    <a:bodyPr/>
+                    <a:lstStyle/>
+                    <a:p>
+                      <a:pPr algn="r"/>
+                      <a:r>
+                        <a:rPr sz="1300" b="0">
+                          <a:solidFill>
+                            <a:srgbClr val="3C3C3B"/>
+                          </a:solidFill>
+                          <a:latin typeface="Aptos"/>
+                        </a:rPr>
+                        <a:t>30.9%</a:t>
+                      </a:r>
+                    </a:p>
+                  </a:txBody>
+                  <a:tcPr marL="73152" marR="73152" marT="27432" marB="27432" anchor="ctr">
+                    <a:noFill/>
+                  </a:tcPr>
+                </a:tc>
+                <a:tc>
+                  <a:txBody>
+                    <a:bodyPr/>
+                    <a:lstStyle/>
+                    <a:p>
+                      <a:pPr algn="r"/>
+                      <a:r>
+                        <a:rPr sz="1300" b="0">
+                          <a:solidFill>
+                            <a:srgbClr val="3C3C3B"/>
+                          </a:solidFill>
+                          <a:latin typeface="Aptos"/>
+                        </a:rPr>
+                        <a:t>45.7%</a:t>
+                      </a:r>
+                    </a:p>
+                  </a:txBody>
+                  <a:tcPr marL="73152" marR="73152" marT="27432" marB="27432" anchor="ctr">
+                    <a:noFill/>
+                  </a:tcPr>
+                </a:tc>
+                <a:tc>
+                  <a:txBody>
+                    <a:bodyPr/>
+                    <a:lstStyle/>
+                    <a:p>
+                      <a:pPr algn="r"/>
+                      <a:r>
+                        <a:rPr sz="1300" b="0">
+                          <a:solidFill>
+                            <a:srgbClr val="3C3C3B"/>
+                          </a:solidFill>
+                          <a:latin typeface="Aptos"/>
+                        </a:rPr>
+                        <a:t>5.7%</a:t>
+                      </a:r>
+                    </a:p>
+                  </a:txBody>
+                  <a:tcPr marL="73152" marR="73152" marT="27432" marB="27432" anchor="ctr">
+                    <a:noFill/>
+                  </a:tcPr>
+                </a:tc>
+                <a:tc>
+                  <a:txBody>
+                    <a:bodyPr/>
+                    <a:lstStyle/>
+                    <a:p>
+                      <a:pPr algn="r"/>
+                      <a:r>
+                        <a:rPr sz="1300" b="0">
+                          <a:solidFill>
+                            <a:srgbClr val="3C3C3B"/>
+                          </a:solidFill>
+                          <a:latin typeface="Aptos"/>
+                        </a:rPr>
+                        <a:t>6.9%</a:t>
+                      </a:r>
+                    </a:p>
+                  </a:txBody>
+                  <a:tcPr marL="73152" marR="73152" marT="27432" marB="27432" anchor="ctr">
+                    <a:noFill/>
+                  </a:tcPr>
+                </a:tc>
+                <a:tc>
+                  <a:txBody>
+                    <a:bodyPr/>
+                    <a:lstStyle/>
+                    <a:p>
+                      <a:pPr algn="r"/>
+                      <a:r>
+                        <a:rPr sz="1300" b="0">
+                          <a:solidFill>
+                            <a:srgbClr val="3C3C3B"/>
+                          </a:solidFill>
+                          <a:latin typeface="Aptos"/>
+                        </a:rPr>
+                        <a:t>8.2%</a:t>
+                      </a:r>
+                    </a:p>
+                  </a:txBody>
+                  <a:tcPr marL="73152" marR="73152" marT="27432" marB="27432" anchor="ctr">
+                    <a:noFill/>
+                  </a:tcPr>
+                </a:tc>
+                <a:tc>
+                  <a:txBody>
+                    <a:bodyPr/>
+                    <a:lstStyle/>
+                    <a:p>
+                      <a:pPr algn="r"/>
+                      <a:r>
+                        <a:rPr sz="1300" b="0">
+                          <a:solidFill>
+                            <a:srgbClr val="3C3C3B"/>
+                          </a:solidFill>
+                          <a:latin typeface="Aptos"/>
+                        </a:rPr>
+                        <a:t>12.4%</a:t>
+                      </a:r>
+                    </a:p>
+                  </a:txBody>
+                  <a:tcPr marL="73152" marR="73152" marT="27432" marB="27432" anchor="ctr">
+                    <a:noFill/>
+                  </a:tcPr>
+                </a:tc>
+                <a:tc>
+                  <a:txBody>
+                    <a:bodyPr/>
+                    <a:lstStyle/>
+                    <a:p>
+                      <a:pPr algn="r"/>
+                      <a:r>
+                        <a:rPr sz="1300" b="0">
+                          <a:solidFill>
+                            <a:srgbClr val="3C3C3B"/>
+                          </a:solidFill>
+                          <a:latin typeface="Aptos"/>
+                        </a:rPr>
+                        <a:t>1.95x</a:t>
+                      </a:r>
+                    </a:p>
+                  </a:txBody>
+                  <a:tcPr marL="73152" marR="73152" marT="27432" marB="27432" anchor="ctr">
+                    <a:noFill/>
+                  </a:tcPr>
+                </a:tc>
+                <a:tc>
+                  <a:txBody>
+                    <a:bodyPr/>
+                    <a:lstStyle/>
+                    <a:p>
+                      <a:pPr algn="r"/>
+                      <a:r>
+                        <a:rPr sz="1300" b="0">
+                          <a:solidFill>
+                            <a:srgbClr val="3C3C3B"/>
+                          </a:solidFill>
+                          <a:latin typeface="Aptos"/>
+                        </a:rPr>
+                        <a:t>2.61x</a:t>
                       </a:r>
                     </a:p>
                   </a:txBody>
@@ -20665,7 +21799,7 @@
         <p:spPr>
           <a:xfrm>
             <a:off x="14127480" y="2240280"/>
-            <a:ext cx="4069080" cy="5852160"/>
+            <a:ext cx="4069080" cy="7223760"/>
           </a:xfrm>
           <a:prstGeom prst="rect">
             <a:avLst/>
@@ -20745,7 +21879,7 @@
                 </a:solidFill>
                 <a:latin typeface="Aptos"/>
               </a:rPr>
-              <a:t>Overbuild: </a:t>
+              <a:t>Promise, don't build: </a:t>
             </a:r>
             <a:r>
               <a:rPr sz="1300" b="0">
@@ -20754,7 +21888,32 @@
                 </a:solidFill>
                 <a:latin typeface="Aptos"/>
               </a:rPr>
-              <a:t>55 MW built against 60 MW committed. Pro rata (GYIK 28/30) there is no PB call; if the full-call reading (GYIK 72) applies, the €2.22m PB is lost: COD IRR 25.9%, hold IRR 7.7% (European).</a:t>
+              <a:t>if neither the overbuild nor the BESS is built, the PB call is €0.8m pro rata (€2.2m on a full call) and 8.3 MVA of connection right may be lost; COD IRR 26.4% / 40.6%, hold IRR 7.8% / 11.7% (pro rata). Not building only the BESS: COD IRR 30.9%, hold IRR 8.2%.</a:t>
+            </a:r>
+          </a:p>
+          <a:p>
+            <a:pPr algn="l">
+              <a:spcBef>
+                <a:spcPts val="800"/>
+              </a:spcBef>
+            </a:pPr>
+            <a:r>
+              <a:rPr sz="1300" b="1">
+                <a:solidFill>
+                  <a:srgbClr val="3C3C3B"/>
+                </a:solidFill>
+                <a:latin typeface="Aptos"/>
+              </a:rPr>
+              <a:t>BESS 100 MWh: </a:t>
+            </a:r>
+            <a:r>
+              <a:rPr sz="1300" b="0">
+                <a:solidFill>
+                  <a:srgbClr val="3C3C3B"/>
+                </a:solidFill>
+                <a:latin typeface="Aptos"/>
+              </a:rPr>
+              <a:t>65.5 points but COD IRR 23.4% and hold IRR 7.5% (European).</a:t>
             </a:r>
           </a:p>
           <a:p>
@@ -20888,7 +22047,7 @@
                 </a:solidFill>
                 <a:latin typeface="Aptos"/>
               </a:rPr>
-              <a:t>Each set changes one input, as named (the EBITDA set also raises the debt cap); tenor 10 years. Stored by the scenario macro with the tax solver; base = live model. Model checks in every set: all pass.</a:t>
+              <a:t>Each set changes only the inputs its name describes; tenor 10 years. Stored by the scenario macro with the tax solver; base = live model. Model checks in every set: all pass.</a:t>
             </a:r>
           </a:p>
           <a:p>

</xml_diff>

<commit_message>
Cost the Bana BESS at 100 k€/MWh
Co-Authored-By: Claude Opus 5.5 <noreply@anthropic.com>
Claude-Session: https://claude.ai/code/session_01AWS1t9WtpkQHcCU1WceGZT
</commit_message>
<xml_diff>
--- a/projects/bana/out/Bana_IC.pptx
+++ b/projects/bana/out/Bana_IC.pptx
@@ -247,10 +247,10 @@
                 <c:formatCode>0.0%</c:formatCode>
                 <c:ptCount val="2"/>
                 <c:pt idx="0">
-                  <c:v>0.284084033636541</c:v>
+                  <c:v>0.2632612602034</c:v>
                 </c:pt>
                 <c:pt idx="1">
-                  <c:v>0.0798286717746915</c:v>
+                  <c:v>0.0778882731983792</c:v>
                 </c:pt>
               </c:numCache>
             </c:numRef>
@@ -297,10 +297,10 @@
                 <c:formatCode>0.0%</c:formatCode>
                 <c:ptCount val="2"/>
                 <c:pt idx="0">
-                  <c:v>0.431605205102548</c:v>
+                  <c:v>0.410318082809979</c:v>
                 </c:pt>
                 <c:pt idx="1">
-                  <c:v>0.120333275856187</c:v>
+                  <c:v>0.117451501890167</c:v>
                 </c:pt>
               </c:numCache>
             </c:numRef>
@@ -6031,7 +6031,7 @@
           <a:lstStyle/>
           <a:p>
             <a:r>
-              <a:t>At €4.50m, Bana returns 28.4% (European) / 43.2% (Chinese) on a sale at COD and 8.0% / 12.0% if held</a:t>
+              <a:t>At €4.50m, Bana returns 26.3% (European) / 41.0% (Chinese) on a sale at COD and 7.8% / 11.7% if held</a:t>
             </a:r>
           </a:p>
         </p:txBody>
@@ -6413,7 +6413,7 @@
                 </a:solidFill>
                 <a:latin typeface="Aptos"/>
               </a:rPr>
-              <a:t>FEP funds €53.6m of equity to COD (€40.9m Chinese) and bids 59.5 points (47.5 Chinese) into the 30 October tender; the European route needs a permit amendment.</a:t>
+              <a:t>FEP funds €54.4m of equity to COD (€41.7m Chinese) and bids 59.5 points (47.5 Chinese) into the 30 October tender; the European route needs a permit amendment.</a:t>
             </a:r>
           </a:p>
         </p:txBody>
@@ -6830,28 +6830,28 @@
                           </a:solidFill>
                           <a:latin typeface="Aptos"/>
                         </a:rPr>
-                        <a:t>53.6</a:t>
-                      </a:r>
-                    </a:p>
-                  </a:txBody>
-                  <a:tcPr marL="73152" marR="73152" marT="27432" marB="27432" anchor="ctr">
-                    <a:noFill/>
-                  </a:tcPr>
-                </a:tc>
-                <a:tc>
-                  <a:txBody>
-                    <a:bodyPr/>
-                    <a:lstStyle/>
-                    <a:p>
-                      <a:pPr algn="r"/>
-                      <a:r>
-                        <a:rPr sz="1300" b="0">
-                          <a:solidFill>
-                            <a:srgbClr val="3C3C3B"/>
-                          </a:solidFill>
-                          <a:latin typeface="Aptos"/>
-                        </a:rPr>
-                        <a:t>40.9</a:t>
+                        <a:t>54.4</a:t>
+                      </a:r>
+                    </a:p>
+                  </a:txBody>
+                  <a:tcPr marL="73152" marR="73152" marT="27432" marB="27432" anchor="ctr">
+                    <a:noFill/>
+                  </a:tcPr>
+                </a:tc>
+                <a:tc>
+                  <a:txBody>
+                    <a:bodyPr/>
+                    <a:lstStyle/>
+                    <a:p>
+                      <a:pPr algn="r"/>
+                      <a:r>
+                        <a:rPr sz="1300" b="0">
+                          <a:solidFill>
+                            <a:srgbClr val="3C3C3B"/>
+                          </a:solidFill>
+                          <a:latin typeface="Aptos"/>
+                        </a:rPr>
+                        <a:t>41.7</a:t>
                       </a:r>
                     </a:p>
                   </a:txBody>
@@ -6987,28 +6987,28 @@
                           </a:solidFill>
                           <a:latin typeface="Aptos"/>
                         </a:rPr>
-                        <a:t>21.9</a:t>
-                      </a:r>
-                    </a:p>
-                  </a:txBody>
-                  <a:tcPr marL="73152" marR="73152" marT="27432" marB="27432" anchor="ctr">
-                    <a:noFill/>
-                  </a:tcPr>
-                </a:tc>
-                <a:tc>
-                  <a:txBody>
-                    <a:bodyPr/>
-                    <a:lstStyle/>
-                    <a:p>
-                      <a:pPr algn="r"/>
-                      <a:r>
-                        <a:rPr sz="1300" b="0">
-                          <a:solidFill>
-                            <a:srgbClr val="3C3C3B"/>
-                          </a:solidFill>
-                          <a:latin typeface="Aptos"/>
-                        </a:rPr>
-                        <a:t>31.1</a:t>
+                        <a:t>20.2</a:t>
+                      </a:r>
+                    </a:p>
+                  </a:txBody>
+                  <a:tcPr marL="73152" marR="73152" marT="27432" marB="27432" anchor="ctr">
+                    <a:noFill/>
+                  </a:tcPr>
+                </a:tc>
+                <a:tc>
+                  <a:txBody>
+                    <a:bodyPr/>
+                    <a:lstStyle/>
+                    <a:p>
+                      <a:pPr algn="r"/>
+                      <a:r>
+                        <a:rPr sz="1300" b="0">
+                          <a:solidFill>
+                            <a:srgbClr val="3C3C3B"/>
+                          </a:solidFill>
+                          <a:latin typeface="Aptos"/>
+                        </a:rPr>
+                        <a:t>29.4</a:t>
                       </a:r>
                     </a:p>
                   </a:txBody>
@@ -7077,7 +7077,7 @@
                           </a:solidFill>
                           <a:latin typeface="Aptos"/>
                         </a:rPr>
-                        <a:t>28.4%</a:t>
+                        <a:t>26.3%</a:t>
                       </a:r>
                     </a:p>
                   </a:txBody>
@@ -7100,7 +7100,7 @@
                           </a:solidFill>
                           <a:latin typeface="Aptos"/>
                         </a:rPr>
-                        <a:t>43.2%</a:t>
+                        <a:t>41.0%</a:t>
                       </a:r>
                     </a:p>
                   </a:txBody>
@@ -7171,28 +7171,28 @@
                           </a:solidFill>
                           <a:latin typeface="Aptos"/>
                         </a:rPr>
-                        <a:t>1.41x</a:t>
-                      </a:r>
-                    </a:p>
-                  </a:txBody>
-                  <a:tcPr marL="73152" marR="73152" marT="27432" marB="27432" anchor="ctr">
-                    <a:noFill/>
-                  </a:tcPr>
-                </a:tc>
-                <a:tc>
-                  <a:txBody>
-                    <a:bodyPr/>
-                    <a:lstStyle/>
-                    <a:p>
-                      <a:pPr algn="r"/>
-                      <a:r>
-                        <a:rPr sz="1300" b="0">
-                          <a:solidFill>
-                            <a:srgbClr val="3C3C3B"/>
-                          </a:solidFill>
-                          <a:latin typeface="Aptos"/>
-                        </a:rPr>
-                        <a:t>1.76x</a:t>
+                        <a:t>1.37x</a:t>
+                      </a:r>
+                    </a:p>
+                  </a:txBody>
+                  <a:tcPr marL="73152" marR="73152" marT="27432" marB="27432" anchor="ctr">
+                    <a:noFill/>
+                  </a:tcPr>
+                </a:tc>
+                <a:tc>
+                  <a:txBody>
+                    <a:bodyPr/>
+                    <a:lstStyle/>
+                    <a:p>
+                      <a:pPr algn="r"/>
+                      <a:r>
+                        <a:rPr sz="1300" b="0">
+                          <a:solidFill>
+                            <a:srgbClr val="3C3C3B"/>
+                          </a:solidFill>
+                          <a:latin typeface="Aptos"/>
+                        </a:rPr>
+                        <a:t>1.71x</a:t>
                       </a:r>
                     </a:p>
                   </a:txBody>
@@ -7418,7 +7418,7 @@
                           </a:solidFill>
                           <a:latin typeface="Aptos"/>
                         </a:rPr>
-                        <a:t>8.0%</a:t>
+                        <a:t>7.8%</a:t>
                       </a:r>
                     </a:p>
                   </a:txBody>
@@ -7441,7 +7441,7 @@
                           </a:solidFill>
                           <a:latin typeface="Aptos"/>
                         </a:rPr>
-                        <a:t>12.0%</a:t>
+                        <a:t>11.7%</a:t>
                       </a:r>
                     </a:p>
                   </a:txBody>
@@ -7512,28 +7512,28 @@
                           </a:solidFill>
                           <a:latin typeface="Aptos"/>
                         </a:rPr>
-                        <a:t>3.37x</a:t>
-                      </a:r>
-                    </a:p>
-                  </a:txBody>
-                  <a:tcPr marL="73152" marR="73152" marT="27432" marB="27432" anchor="ctr">
-                    <a:noFill/>
-                  </a:tcPr>
-                </a:tc>
-                <a:tc>
-                  <a:txBody>
-                    <a:bodyPr/>
-                    <a:lstStyle/>
-                    <a:p>
-                      <a:pPr algn="r"/>
-                      <a:r>
-                        <a:rPr sz="1300" b="0">
-                          <a:solidFill>
-                            <a:srgbClr val="3C3C3B"/>
-                          </a:solidFill>
-                          <a:latin typeface="Aptos"/>
-                        </a:rPr>
-                        <a:t>4.85x</a:t>
+                        <a:t>3.31x</a:t>
+                      </a:r>
+                    </a:p>
+                  </a:txBody>
+                  <a:tcPr marL="73152" marR="73152" marT="27432" marB="27432" anchor="ctr">
+                    <a:noFill/>
+                  </a:tcPr>
+                </a:tc>
+                <a:tc>
+                  <a:txBody>
+                    <a:bodyPr/>
+                    <a:lstStyle/>
+                    <a:p>
+                      <a:pPr algn="r"/>
+                      <a:r>
+                        <a:rPr sz="1300" b="0">
+                          <a:solidFill>
+                            <a:srgbClr val="3C3C3B"/>
+                          </a:solidFill>
+                          <a:latin typeface="Aptos"/>
+                        </a:rPr>
+                        <a:t>4.74x</a:t>
                       </a:r>
                     </a:p>
                   </a:txBody>
@@ -7602,28 +7602,28 @@
                           </a:solidFill>
                           <a:latin typeface="Aptos"/>
                         </a:rPr>
-                        <a:t>(0.1)</a:t>
-                      </a:r>
-                    </a:p>
-                  </a:txBody>
-                  <a:tcPr marL="73152" marR="73152" marT="27432" marB="27432" anchor="ctr">
-                    <a:noFill/>
-                  </a:tcPr>
-                </a:tc>
-                <a:tc>
-                  <a:txBody>
-                    <a:bodyPr/>
-                    <a:lstStyle/>
-                    <a:p>
-                      <a:pPr algn="r"/>
-                      <a:r>
-                        <a:rPr sz="1300" b="0">
-                          <a:solidFill>
-                            <a:srgbClr val="3C3C3B"/>
-                          </a:solidFill>
-                          <a:latin typeface="Aptos"/>
-                        </a:rPr>
-                        <a:t>17.7</a:t>
+                        <a:t>(1.2)</a:t>
+                      </a:r>
+                    </a:p>
+                  </a:txBody>
+                  <a:tcPr marL="73152" marR="73152" marT="27432" marB="27432" anchor="ctr">
+                    <a:noFill/>
+                  </a:tcPr>
+                </a:tc>
+                <a:tc>
+                  <a:txBody>
+                    <a:bodyPr/>
+                    <a:lstStyle/>
+                    <a:p>
+                      <a:pPr algn="r"/>
+                      <a:r>
+                        <a:rPr sz="1300" b="0">
+                          <a:solidFill>
+                            <a:srgbClr val="3C3C3B"/>
+                          </a:solidFill>
+                          <a:latin typeface="Aptos"/>
+                        </a:rPr>
+                        <a:t>16.7</a:t>
                       </a:r>
                     </a:p>
                   </a:txBody>
@@ -7692,28 +7692,28 @@
                           </a:solidFill>
                           <a:latin typeface="Aptos"/>
                         </a:rPr>
-                        <a:t>1.91x</a:t>
-                      </a:r>
-                    </a:p>
-                  </a:txBody>
-                  <a:tcPr marL="73152" marR="73152" marT="27432" marB="27432" anchor="ctr">
-                    <a:noFill/>
-                  </a:tcPr>
-                </a:tc>
-                <a:tc>
-                  <a:txBody>
-                    <a:bodyPr/>
-                    <a:lstStyle/>
-                    <a:p>
-                      <a:pPr algn="r"/>
-                      <a:r>
-                        <a:rPr sz="1300" b="0">
-                          <a:solidFill>
-                            <a:srgbClr val="3C3C3B"/>
-                          </a:solidFill>
-                          <a:latin typeface="Aptos"/>
-                        </a:rPr>
-                        <a:t>2.53x</a:t>
+                        <a:t>1.88x</a:t>
+                      </a:r>
+                    </a:p>
+                  </a:txBody>
+                  <a:tcPr marL="73152" marR="73152" marT="27432" marB="27432" anchor="ctr">
+                    <a:noFill/>
+                  </a:tcPr>
+                </a:tc>
+                <a:tc>
+                  <a:txBody>
+                    <a:bodyPr/>
+                    <a:lstStyle/>
+                    <a:p>
+                      <a:pPr algn="r"/>
+                      <a:r>
+                        <a:rPr sz="1300" b="0">
+                          <a:solidFill>
+                            <a:srgbClr val="3C3C3B"/>
+                          </a:solidFill>
+                          <a:latin typeface="Aptos"/>
+                        </a:rPr>
+                        <a:t>2.48x</a:t>
                       </a:r>
                     </a:p>
                   </a:txBody>
@@ -10306,7 +10306,7 @@
                           </a:solidFill>
                           <a:latin typeface="Aptos"/>
                         </a:rPr>
-                        <a:t>10 MW / 40 MWh at 240 k€/MW</a:t>
+                        <a:t>10 MW / 40 MWh at 100 k€/MWh</a:t>
                       </a:r>
                     </a:p>
                   </a:txBody>
@@ -11665,7 +11665,7 @@
           <a:lstStyle/>
           <a:p>
             <a:r>
-              <a:t>Uses to COD of €111.8m with European turbines (€83.4m Chinese); senior debt funds 52% (51%) and FEP the rest</a:t>
+              <a:t>Uses to COD of €113.4m with European turbines (€85.1m Chinese); senior debt funds 52% (51%) and FEP the rest</a:t>
             </a:r>
           </a:p>
         </p:txBody>
@@ -12410,28 +12410,28 @@
                           </a:solidFill>
                           <a:latin typeface="Aptos"/>
                         </a:rPr>
-                        <a:t>90.4</a:t>
-                      </a:r>
-                    </a:p>
-                  </a:txBody>
-                  <a:tcPr marL="73152" marR="73152" marT="27432" marB="27432" anchor="ctr">
-                    <a:noFill/>
-                  </a:tcPr>
-                </a:tc>
-                <a:tc>
-                  <a:txBody>
-                    <a:bodyPr/>
-                    <a:lstStyle/>
-                    <a:p>
-                      <a:pPr algn="r"/>
-                      <a:r>
-                        <a:rPr sz="1300" b="0">
-                          <a:solidFill>
-                            <a:srgbClr val="3C3C3B"/>
-                          </a:solidFill>
-                          <a:latin typeface="Aptos"/>
-                        </a:rPr>
-                        <a:t>63.1</a:t>
+                        <a:t>92.0</a:t>
+                      </a:r>
+                    </a:p>
+                  </a:txBody>
+                  <a:tcPr marL="73152" marR="73152" marT="27432" marB="27432" anchor="ctr">
+                    <a:noFill/>
+                  </a:tcPr>
+                </a:tc>
+                <a:tc>
+                  <a:txBody>
+                    <a:bodyPr/>
+                    <a:lstStyle/>
+                    <a:p>
+                      <a:pPr algn="r"/>
+                      <a:r>
+                        <a:rPr sz="1300" b="0">
+                          <a:solidFill>
+                            <a:srgbClr val="3C3C3B"/>
+                          </a:solidFill>
+                          <a:latin typeface="Aptos"/>
+                        </a:rPr>
+                        <a:t>64.7</a:t>
                       </a:r>
                     </a:p>
                   </a:txBody>
@@ -12680,28 +12680,28 @@
                           </a:solidFill>
                           <a:latin typeface="Aptos"/>
                         </a:rPr>
-                        <a:t>4.1</a:t>
-                      </a:r>
-                    </a:p>
-                  </a:txBody>
-                  <a:tcPr marL="73152" marR="73152" marT="27432" marB="27432" anchor="ctr">
-                    <a:noFill/>
-                  </a:tcPr>
-                </a:tc>
-                <a:tc>
-                  <a:txBody>
-                    <a:bodyPr/>
-                    <a:lstStyle/>
-                    <a:p>
-                      <a:pPr algn="r"/>
-                      <a:r>
-                        <a:rPr sz="1300" b="0">
-                          <a:solidFill>
-                            <a:srgbClr val="3C3C3B"/>
-                          </a:solidFill>
-                          <a:latin typeface="Aptos"/>
-                        </a:rPr>
-                        <a:t>3.0</a:t>
+                        <a:t>4.2</a:t>
+                      </a:r>
+                    </a:p>
+                  </a:txBody>
+                  <a:tcPr marL="73152" marR="73152" marT="27432" marB="27432" anchor="ctr">
+                    <a:noFill/>
+                  </a:tcPr>
+                </a:tc>
+                <a:tc>
+                  <a:txBody>
+                    <a:bodyPr/>
+                    <a:lstStyle/>
+                    <a:p>
+                      <a:pPr algn="r"/>
+                      <a:r>
+                        <a:rPr sz="1300" b="0">
+                          <a:solidFill>
+                            <a:srgbClr val="3C3C3B"/>
+                          </a:solidFill>
+                          <a:latin typeface="Aptos"/>
+                        </a:rPr>
+                        <a:t>3.1</a:t>
                       </a:r>
                     </a:p>
                   </a:txBody>
@@ -12860,7 +12860,7 @@
                           </a:solidFill>
                           <a:latin typeface="Aptos"/>
                         </a:rPr>
-                        <a:t>111.8</a:t>
+                        <a:t>113.4</a:t>
                       </a:r>
                     </a:p>
                   </a:txBody>
@@ -12883,7 +12883,7 @@
                           </a:solidFill>
                           <a:latin typeface="Aptos"/>
                         </a:rPr>
-                        <a:t>83.4</a:t>
+                        <a:t>85.1</a:t>
                       </a:r>
                     </a:p>
                   </a:txBody>
@@ -12954,28 +12954,28 @@
                           </a:solidFill>
                           <a:latin typeface="Aptos"/>
                         </a:rPr>
-                        <a:t>58.1</a:t>
-                      </a:r>
-                    </a:p>
-                  </a:txBody>
-                  <a:tcPr marL="73152" marR="73152" marT="27432" marB="27432" anchor="ctr">
-                    <a:noFill/>
-                  </a:tcPr>
-                </a:tc>
-                <a:tc>
-                  <a:txBody>
-                    <a:bodyPr/>
-                    <a:lstStyle/>
-                    <a:p>
-                      <a:pPr algn="r"/>
-                      <a:r>
-                        <a:rPr sz="1300" b="0">
-                          <a:solidFill>
-                            <a:srgbClr val="3C3C3B"/>
-                          </a:solidFill>
-                          <a:latin typeface="Aptos"/>
-                        </a:rPr>
-                        <a:t>42.5</a:t>
+                        <a:t>59.1</a:t>
+                      </a:r>
+                    </a:p>
+                  </a:txBody>
+                  <a:tcPr marL="73152" marR="73152" marT="27432" marB="27432" anchor="ctr">
+                    <a:noFill/>
+                  </a:tcPr>
+                </a:tc>
+                <a:tc>
+                  <a:txBody>
+                    <a:bodyPr/>
+                    <a:lstStyle/>
+                    <a:p>
+                      <a:pPr algn="r"/>
+                      <a:r>
+                        <a:rPr sz="1300" b="0">
+                          <a:solidFill>
+                            <a:srgbClr val="3C3C3B"/>
+                          </a:solidFill>
+                          <a:latin typeface="Aptos"/>
+                        </a:rPr>
+                        <a:t>43.4</a:t>
                       </a:r>
                     </a:p>
                   </a:txBody>
@@ -13044,7 +13044,7 @@
                           </a:solidFill>
                           <a:latin typeface="Aptos"/>
                         </a:rPr>
-                        <a:t>53.6</a:t>
+                        <a:t>54.4</a:t>
                       </a:r>
                     </a:p>
                   </a:txBody>
@@ -13067,7 +13067,7 @@
                           </a:solidFill>
                           <a:latin typeface="Aptos"/>
                         </a:rPr>
-                        <a:t>40.9</a:t>
+                        <a:t>41.7</a:t>
                       </a:r>
                     </a:p>
                   </a:txBody>
@@ -13138,28 +13138,28 @@
                           </a:solidFill>
                           <a:latin typeface="Aptos"/>
                         </a:rPr>
-                        <a:t>54.9</a:t>
-                      </a:r>
-                    </a:p>
-                  </a:txBody>
-                  <a:tcPr marL="73152" marR="73152" marT="27432" marB="27432" anchor="ctr">
-                    <a:noFill/>
-                  </a:tcPr>
-                </a:tc>
-                <a:tc>
-                  <a:txBody>
-                    <a:bodyPr/>
-                    <a:lstStyle/>
-                    <a:p>
-                      <a:pPr algn="r"/>
-                      <a:r>
-                        <a:rPr sz="1300" b="0">
-                          <a:solidFill>
-                            <a:srgbClr val="3C3C3B"/>
-                          </a:solidFill>
-                          <a:latin typeface="Aptos"/>
-                        </a:rPr>
-                        <a:t>41.9</a:t>
+                        <a:t>55.6</a:t>
+                      </a:r>
+                    </a:p>
+                  </a:txBody>
+                  <a:tcPr marL="73152" marR="73152" marT="27432" marB="27432" anchor="ctr">
+                    <a:noFill/>
+                  </a:tcPr>
+                </a:tc>
+                <a:tc>
+                  <a:txBody>
+                    <a:bodyPr/>
+                    <a:lstStyle/>
+                    <a:p>
+                      <a:pPr algn="r"/>
+                      <a:r>
+                        <a:rPr sz="1300" b="0">
+                          <a:solidFill>
+                            <a:srgbClr val="3C3C3B"/>
+                          </a:solidFill>
+                          <a:latin typeface="Aptos"/>
+                        </a:rPr>
+                        <a:t>42.6</a:t>
                       </a:r>
                     </a:p>
                   </a:txBody>
@@ -14008,7 +14008,7 @@
           <a:lstStyle/>
           <a:p>
             <a:r>
-              <a:t>A sale at COD turns €53.6m of equity into €75.5m (1.41x); holding earns 8.0% at a 1.91x DSCR (European)</a:t>
+              <a:t>A sale at COD turns €54.4m of equity into €74.6m (1.37x); holding earns 7.8% at a 1.88x DSCR (European)</a:t>
             </a:r>
           </a:p>
         </p:txBody>
@@ -14390,7 +14390,7 @@
                 </a:solidFill>
                 <a:latin typeface="Aptos"/>
               </a:rPr>
-              <a:t>With Chinese turbines the sale returns 43.2% and the hold 12.0%; debt is capped at 55% of construction cost on both routes.</a:t>
+              <a:t>With Chinese turbines the sale returns 41.0% and the hold 11.7%; debt is capped at 55% of construction cost on both routes.</a:t>
             </a:r>
           </a:p>
         </p:txBody>
@@ -14753,28 +14753,28 @@
                           </a:solidFill>
                           <a:latin typeface="Aptos"/>
                         </a:rPr>
-                        <a:t>(58.1)</a:t>
-                      </a:r>
-                    </a:p>
-                  </a:txBody>
-                  <a:tcPr marL="73152" marR="73152" marT="27432" marB="27432" anchor="ctr">
-                    <a:noFill/>
-                  </a:tcPr>
-                </a:tc>
-                <a:tc>
-                  <a:txBody>
-                    <a:bodyPr/>
-                    <a:lstStyle/>
-                    <a:p>
-                      <a:pPr algn="r"/>
-                      <a:r>
-                        <a:rPr sz="1300" b="0">
-                          <a:solidFill>
-                            <a:srgbClr val="3C3C3B"/>
-                          </a:solidFill>
-                          <a:latin typeface="Aptos"/>
-                        </a:rPr>
-                        <a:t>(42.5)</a:t>
+                        <a:t>(59.1)</a:t>
+                      </a:r>
+                    </a:p>
+                  </a:txBody>
+                  <a:tcPr marL="73152" marR="73152" marT="27432" marB="27432" anchor="ctr">
+                    <a:noFill/>
+                  </a:tcPr>
+                </a:tc>
+                <a:tc>
+                  <a:txBody>
+                    <a:bodyPr/>
+                    <a:lstStyle/>
+                    <a:p>
+                      <a:pPr algn="r"/>
+                      <a:r>
+                        <a:rPr sz="1300" b="0">
+                          <a:solidFill>
+                            <a:srgbClr val="3C3C3B"/>
+                          </a:solidFill>
+                          <a:latin typeface="Aptos"/>
+                        </a:rPr>
+                        <a:t>(43.4)</a:t>
                       </a:r>
                     </a:p>
                   </a:txBody>
@@ -14885,28 +14885,28 @@
                           </a:solidFill>
                           <a:latin typeface="Aptos"/>
                         </a:rPr>
-                        <a:t>75.5</a:t>
-                      </a:r>
-                    </a:p>
-                  </a:txBody>
-                  <a:tcPr marL="73152" marR="73152" marT="27432" marB="27432" anchor="ctr">
-                    <a:noFill/>
-                  </a:tcPr>
-                </a:tc>
-                <a:tc>
-                  <a:txBody>
-                    <a:bodyPr/>
-                    <a:lstStyle/>
-                    <a:p>
-                      <a:pPr algn="r"/>
-                      <a:r>
-                        <a:rPr sz="1300" b="0">
-                          <a:solidFill>
-                            <a:srgbClr val="3C3C3B"/>
-                          </a:solidFill>
-                          <a:latin typeface="Aptos"/>
-                        </a:rPr>
-                        <a:t>72.0</a:t>
+                        <a:t>74.6</a:t>
+                      </a:r>
+                    </a:p>
+                  </a:txBody>
+                  <a:tcPr marL="73152" marR="73152" marT="27432" marB="27432" anchor="ctr">
+                    <a:noFill/>
+                  </a:tcPr>
+                </a:tc>
+                <a:tc>
+                  <a:txBody>
+                    <a:bodyPr/>
+                    <a:lstStyle/>
+                    <a:p>
+                      <a:pPr algn="r"/>
+                      <a:r>
+                        <a:rPr sz="1300" b="0">
+                          <a:solidFill>
+                            <a:srgbClr val="3C3C3B"/>
+                          </a:solidFill>
+                          <a:latin typeface="Aptos"/>
+                        </a:rPr>
+                        <a:t>71.1</a:t>
                       </a:r>
                     </a:p>
                   </a:txBody>
@@ -15038,7 +15038,7 @@
                           </a:solidFill>
                           <a:latin typeface="Aptos"/>
                         </a:rPr>
-                        <a:t>7.0% / 7.5%</a:t>
+                        <a:t>7.0% / 7.6%</a:t>
                       </a:r>
                     </a:p>
                   </a:txBody>
@@ -15149,70 +15149,70 @@
                           </a:solidFill>
                           <a:latin typeface="Aptos"/>
                         </a:rPr>
-                        <a:t>53.6</a:t>
-                      </a:r>
-                    </a:p>
-                  </a:txBody>
-                  <a:tcPr marL="73152" marR="73152" marT="27432" marB="27432" anchor="ctr">
-                    <a:noFill/>
-                  </a:tcPr>
-                </a:tc>
-                <a:tc>
-                  <a:txBody>
-                    <a:bodyPr/>
-                    <a:lstStyle/>
-                    <a:p>
-                      <a:pPr algn="r"/>
-                      <a:r>
-                        <a:rPr sz="1300" b="0">
-                          <a:solidFill>
-                            <a:srgbClr val="3C3C3B"/>
-                          </a:solidFill>
-                          <a:latin typeface="Aptos"/>
-                        </a:rPr>
-                        <a:t>40.9</a:t>
-                      </a:r>
-                    </a:p>
-                  </a:txBody>
-                  <a:tcPr marL="73152" marR="73152" marT="27432" marB="27432" anchor="ctr">
-                    <a:noFill/>
-                  </a:tcPr>
-                </a:tc>
-                <a:tc>
-                  <a:txBody>
-                    <a:bodyPr/>
-                    <a:lstStyle/>
-                    <a:p>
-                      <a:pPr algn="r"/>
-                      <a:r>
-                        <a:rPr sz="1300" b="0">
-                          <a:solidFill>
-                            <a:srgbClr val="3C3C3B"/>
-                          </a:solidFill>
-                          <a:latin typeface="Aptos"/>
-                        </a:rPr>
-                        <a:t>54.9</a:t>
-                      </a:r>
-                    </a:p>
-                  </a:txBody>
-                  <a:tcPr marL="73152" marR="73152" marT="27432" marB="27432" anchor="ctr">
-                    <a:noFill/>
-                  </a:tcPr>
-                </a:tc>
-                <a:tc>
-                  <a:txBody>
-                    <a:bodyPr/>
-                    <a:lstStyle/>
-                    <a:p>
-                      <a:pPr algn="r"/>
-                      <a:r>
-                        <a:rPr sz="1300" b="0">
-                          <a:solidFill>
-                            <a:srgbClr val="3C3C3B"/>
-                          </a:solidFill>
-                          <a:latin typeface="Aptos"/>
-                        </a:rPr>
-                        <a:t>41.9</a:t>
+                        <a:t>54.4</a:t>
+                      </a:r>
+                    </a:p>
+                  </a:txBody>
+                  <a:tcPr marL="73152" marR="73152" marT="27432" marB="27432" anchor="ctr">
+                    <a:noFill/>
+                  </a:tcPr>
+                </a:tc>
+                <a:tc>
+                  <a:txBody>
+                    <a:bodyPr/>
+                    <a:lstStyle/>
+                    <a:p>
+                      <a:pPr algn="r"/>
+                      <a:r>
+                        <a:rPr sz="1300" b="0">
+                          <a:solidFill>
+                            <a:srgbClr val="3C3C3B"/>
+                          </a:solidFill>
+                          <a:latin typeface="Aptos"/>
+                        </a:rPr>
+                        <a:t>41.7</a:t>
+                      </a:r>
+                    </a:p>
+                  </a:txBody>
+                  <a:tcPr marL="73152" marR="73152" marT="27432" marB="27432" anchor="ctr">
+                    <a:noFill/>
+                  </a:tcPr>
+                </a:tc>
+                <a:tc>
+                  <a:txBody>
+                    <a:bodyPr/>
+                    <a:lstStyle/>
+                    <a:p>
+                      <a:pPr algn="r"/>
+                      <a:r>
+                        <a:rPr sz="1300" b="0">
+                          <a:solidFill>
+                            <a:srgbClr val="3C3C3B"/>
+                          </a:solidFill>
+                          <a:latin typeface="Aptos"/>
+                        </a:rPr>
+                        <a:t>55.6</a:t>
+                      </a:r>
+                    </a:p>
+                  </a:txBody>
+                  <a:tcPr marL="73152" marR="73152" marT="27432" marB="27432" anchor="ctr">
+                    <a:noFill/>
+                  </a:tcPr>
+                </a:tc>
+                <a:tc>
+                  <a:txBody>
+                    <a:bodyPr/>
+                    <a:lstStyle/>
+                    <a:p>
+                      <a:pPr algn="r"/>
+                      <a:r>
+                        <a:rPr sz="1300" b="0">
+                          <a:solidFill>
+                            <a:srgbClr val="3C3C3B"/>
+                          </a:solidFill>
+                          <a:latin typeface="Aptos"/>
+                        </a:rPr>
+                        <a:t>42.6</a:t>
                       </a:r>
                     </a:p>
                   </a:txBody>
@@ -15281,70 +15281,70 @@
                           </a:solidFill>
                           <a:latin typeface="Aptos"/>
                         </a:rPr>
-                        <a:t>21.9</a:t>
-                      </a:r>
-                    </a:p>
-                  </a:txBody>
-                  <a:tcPr marL="73152" marR="73152" marT="27432" marB="27432" anchor="ctr">
-                    <a:noFill/>
-                  </a:tcPr>
-                </a:tc>
-                <a:tc>
-                  <a:txBody>
-                    <a:bodyPr/>
-                    <a:lstStyle/>
-                    <a:p>
-                      <a:pPr algn="r"/>
-                      <a:r>
-                        <a:rPr sz="1300" b="0">
-                          <a:solidFill>
-                            <a:srgbClr val="3C3C3B"/>
-                          </a:solidFill>
-                          <a:latin typeface="Aptos"/>
-                        </a:rPr>
-                        <a:t>31.1</a:t>
-                      </a:r>
-                    </a:p>
-                  </a:txBody>
-                  <a:tcPr marL="73152" marR="73152" marT="27432" marB="27432" anchor="ctr">
-                    <a:noFill/>
-                  </a:tcPr>
-                </a:tc>
-                <a:tc>
-                  <a:txBody>
-                    <a:bodyPr/>
-                    <a:lstStyle/>
-                    <a:p>
-                      <a:pPr algn="r"/>
-                      <a:r>
-                        <a:rPr sz="1300" b="0">
-                          <a:solidFill>
-                            <a:srgbClr val="3C3C3B"/>
-                          </a:solidFill>
-                          <a:latin typeface="Aptos"/>
-                        </a:rPr>
-                        <a:t>130.2</a:t>
-                      </a:r>
-                    </a:p>
-                  </a:txBody>
-                  <a:tcPr marL="73152" marR="73152" marT="27432" marB="27432" anchor="ctr">
-                    <a:noFill/>
-                  </a:tcPr>
-                </a:tc>
-                <a:tc>
-                  <a:txBody>
-                    <a:bodyPr/>
-                    <a:lstStyle/>
-                    <a:p>
-                      <a:pPr algn="r"/>
-                      <a:r>
-                        <a:rPr sz="1300" b="0">
-                          <a:solidFill>
-                            <a:srgbClr val="3C3C3B"/>
-                          </a:solidFill>
-                          <a:latin typeface="Aptos"/>
-                        </a:rPr>
-                        <a:t>161.3</a:t>
+                        <a:t>20.2</a:t>
+                      </a:r>
+                    </a:p>
+                  </a:txBody>
+                  <a:tcPr marL="73152" marR="73152" marT="27432" marB="27432" anchor="ctr">
+                    <a:noFill/>
+                  </a:tcPr>
+                </a:tc>
+                <a:tc>
+                  <a:txBody>
+                    <a:bodyPr/>
+                    <a:lstStyle/>
+                    <a:p>
+                      <a:pPr algn="r"/>
+                      <a:r>
+                        <a:rPr sz="1300" b="0">
+                          <a:solidFill>
+                            <a:srgbClr val="3C3C3B"/>
+                          </a:solidFill>
+                          <a:latin typeface="Aptos"/>
+                        </a:rPr>
+                        <a:t>29.4</a:t>
+                      </a:r>
+                    </a:p>
+                  </a:txBody>
+                  <a:tcPr marL="73152" marR="73152" marT="27432" marB="27432" anchor="ctr">
+                    <a:noFill/>
+                  </a:tcPr>
+                </a:tc>
+                <a:tc>
+                  <a:txBody>
+                    <a:bodyPr/>
+                    <a:lstStyle/>
+                    <a:p>
+                      <a:pPr algn="r"/>
+                      <a:r>
+                        <a:rPr sz="1300" b="0">
+                          <a:solidFill>
+                            <a:srgbClr val="3C3C3B"/>
+                          </a:solidFill>
+                          <a:latin typeface="Aptos"/>
+                        </a:rPr>
+                        <a:t>128.4</a:t>
+                      </a:r>
+                    </a:p>
+                  </a:txBody>
+                  <a:tcPr marL="73152" marR="73152" marT="27432" marB="27432" anchor="ctr">
+                    <a:noFill/>
+                  </a:tcPr>
+                </a:tc>
+                <a:tc>
+                  <a:txBody>
+                    <a:bodyPr/>
+                    <a:lstStyle/>
+                    <a:p>
+                      <a:pPr algn="r"/>
+                      <a:r>
+                        <a:rPr sz="1300" b="0">
+                          <a:solidFill>
+                            <a:srgbClr val="3C3C3B"/>
+                          </a:solidFill>
+                          <a:latin typeface="Aptos"/>
+                        </a:rPr>
+                        <a:t>159.5</a:t>
                       </a:r>
                     </a:p>
                   </a:txBody>
@@ -15413,7 +15413,7 @@
                           </a:solidFill>
                           <a:latin typeface="Aptos"/>
                         </a:rPr>
-                        <a:t>28.4%</a:t>
+                        <a:t>26.3%</a:t>
                       </a:r>
                     </a:p>
                   </a:txBody>
@@ -15436,7 +15436,7 @@
                           </a:solidFill>
                           <a:latin typeface="Aptos"/>
                         </a:rPr>
-                        <a:t>43.2%</a:t>
+                        <a:t>41.0%</a:t>
                       </a:r>
                     </a:p>
                   </a:txBody>
@@ -15459,7 +15459,7 @@
                           </a:solidFill>
                           <a:latin typeface="Aptos"/>
                         </a:rPr>
-                        <a:t>8.0%</a:t>
+                        <a:t>7.8%</a:t>
                       </a:r>
                     </a:p>
                   </a:txBody>
@@ -15482,7 +15482,7 @@
                           </a:solidFill>
                           <a:latin typeface="Aptos"/>
                         </a:rPr>
-                        <a:t>12.0%</a:t>
+                        <a:t>11.7%</a:t>
                       </a:r>
                     </a:p>
                   </a:txBody>
@@ -15553,70 +15553,70 @@
                           </a:solidFill>
                           <a:latin typeface="Aptos"/>
                         </a:rPr>
-                        <a:t>1.41x</a:t>
-                      </a:r>
-                    </a:p>
-                  </a:txBody>
-                  <a:tcPr marL="73152" marR="73152" marT="27432" marB="27432" anchor="ctr">
-                    <a:noFill/>
-                  </a:tcPr>
-                </a:tc>
-                <a:tc>
-                  <a:txBody>
-                    <a:bodyPr/>
-                    <a:lstStyle/>
-                    <a:p>
-                      <a:pPr algn="r"/>
-                      <a:r>
-                        <a:rPr sz="1300" b="0">
-                          <a:solidFill>
-                            <a:srgbClr val="3C3C3B"/>
-                          </a:solidFill>
-                          <a:latin typeface="Aptos"/>
-                        </a:rPr>
-                        <a:t>1.76x</a:t>
-                      </a:r>
-                    </a:p>
-                  </a:txBody>
-                  <a:tcPr marL="73152" marR="73152" marT="27432" marB="27432" anchor="ctr">
-                    <a:noFill/>
-                  </a:tcPr>
-                </a:tc>
-                <a:tc>
-                  <a:txBody>
-                    <a:bodyPr/>
-                    <a:lstStyle/>
-                    <a:p>
-                      <a:pPr algn="r"/>
-                      <a:r>
-                        <a:rPr sz="1300" b="0">
-                          <a:solidFill>
-                            <a:srgbClr val="3C3C3B"/>
-                          </a:solidFill>
-                          <a:latin typeface="Aptos"/>
-                        </a:rPr>
-                        <a:t>3.37x</a:t>
-                      </a:r>
-                    </a:p>
-                  </a:txBody>
-                  <a:tcPr marL="73152" marR="73152" marT="27432" marB="27432" anchor="ctr">
-                    <a:noFill/>
-                  </a:tcPr>
-                </a:tc>
-                <a:tc>
-                  <a:txBody>
-                    <a:bodyPr/>
-                    <a:lstStyle/>
-                    <a:p>
-                      <a:pPr algn="r"/>
-                      <a:r>
-                        <a:rPr sz="1300" b="0">
-                          <a:solidFill>
-                            <a:srgbClr val="3C3C3B"/>
-                          </a:solidFill>
-                          <a:latin typeface="Aptos"/>
-                        </a:rPr>
-                        <a:t>4.85x</a:t>
+                        <a:t>1.37x</a:t>
+                      </a:r>
+                    </a:p>
+                  </a:txBody>
+                  <a:tcPr marL="73152" marR="73152" marT="27432" marB="27432" anchor="ctr">
+                    <a:noFill/>
+                  </a:tcPr>
+                </a:tc>
+                <a:tc>
+                  <a:txBody>
+                    <a:bodyPr/>
+                    <a:lstStyle/>
+                    <a:p>
+                      <a:pPr algn="r"/>
+                      <a:r>
+                        <a:rPr sz="1300" b="0">
+                          <a:solidFill>
+                            <a:srgbClr val="3C3C3B"/>
+                          </a:solidFill>
+                          <a:latin typeface="Aptos"/>
+                        </a:rPr>
+                        <a:t>1.71x</a:t>
+                      </a:r>
+                    </a:p>
+                  </a:txBody>
+                  <a:tcPr marL="73152" marR="73152" marT="27432" marB="27432" anchor="ctr">
+                    <a:noFill/>
+                  </a:tcPr>
+                </a:tc>
+                <a:tc>
+                  <a:txBody>
+                    <a:bodyPr/>
+                    <a:lstStyle/>
+                    <a:p>
+                      <a:pPr algn="r"/>
+                      <a:r>
+                        <a:rPr sz="1300" b="0">
+                          <a:solidFill>
+                            <a:srgbClr val="3C3C3B"/>
+                          </a:solidFill>
+                          <a:latin typeface="Aptos"/>
+                        </a:rPr>
+                        <a:t>3.31x</a:t>
+                      </a:r>
+                    </a:p>
+                  </a:txBody>
+                  <a:tcPr marL="73152" marR="73152" marT="27432" marB="27432" anchor="ctr">
+                    <a:noFill/>
+                  </a:tcPr>
+                </a:tc>
+                <a:tc>
+                  <a:txBody>
+                    <a:bodyPr/>
+                    <a:lstStyle/>
+                    <a:p>
+                      <a:pPr algn="r"/>
+                      <a:r>
+                        <a:rPr sz="1300" b="0">
+                          <a:solidFill>
+                            <a:srgbClr val="3C3C3B"/>
+                          </a:solidFill>
+                          <a:latin typeface="Aptos"/>
+                        </a:rPr>
+                        <a:t>4.74x</a:t>
                       </a:r>
                     </a:p>
                   </a:txBody>
@@ -15685,70 +15685,70 @@
                           </a:solidFill>
                           <a:latin typeface="Aptos"/>
                         </a:rPr>
-                        <a:t>12.3</a:t>
-                      </a:r>
-                    </a:p>
-                  </a:txBody>
-                  <a:tcPr marL="73152" marR="73152" marT="27432" marB="27432" anchor="ctr">
-                    <a:noFill/>
-                  </a:tcPr>
-                </a:tc>
-                <a:tc>
-                  <a:txBody>
-                    <a:bodyPr/>
-                    <a:lstStyle/>
-                    <a:p>
-                      <a:pPr algn="r"/>
-                      <a:r>
-                        <a:rPr sz="1300" b="0">
-                          <a:solidFill>
-                            <a:srgbClr val="3C3C3B"/>
-                          </a:solidFill>
-                          <a:latin typeface="Aptos"/>
-                        </a:rPr>
-                        <a:t>19.8</a:t>
-                      </a:r>
-                    </a:p>
-                  </a:txBody>
-                  <a:tcPr marL="73152" marR="73152" marT="27432" marB="27432" anchor="ctr">
-                    <a:noFill/>
-                  </a:tcPr>
-                </a:tc>
-                <a:tc>
-                  <a:txBody>
-                    <a:bodyPr/>
-                    <a:lstStyle/>
-                    <a:p>
-                      <a:pPr algn="r"/>
-                      <a:r>
-                        <a:rPr sz="1300" b="0">
-                          <a:solidFill>
-                            <a:srgbClr val="3C3C3B"/>
-                          </a:solidFill>
-                          <a:latin typeface="Aptos"/>
-                        </a:rPr>
-                        <a:t>(0.1)</a:t>
-                      </a:r>
-                    </a:p>
-                  </a:txBody>
-                  <a:tcPr marL="73152" marR="73152" marT="27432" marB="27432" anchor="ctr">
-                    <a:noFill/>
-                  </a:tcPr>
-                </a:tc>
-                <a:tc>
-                  <a:txBody>
-                    <a:bodyPr/>
-                    <a:lstStyle/>
-                    <a:p>
-                      <a:pPr algn="r"/>
-                      <a:r>
-                        <a:rPr sz="1300" b="0">
-                          <a:solidFill>
-                            <a:srgbClr val="3C3C3B"/>
-                          </a:solidFill>
-                          <a:latin typeface="Aptos"/>
-                        </a:rPr>
-                        <a:t>17.7</a:t>
+                        <a:t>11.0</a:t>
+                      </a:r>
+                    </a:p>
+                  </a:txBody>
+                  <a:tcPr marL="73152" marR="73152" marT="27432" marB="27432" anchor="ctr">
+                    <a:noFill/>
+                  </a:tcPr>
+                </a:tc>
+                <a:tc>
+                  <a:txBody>
+                    <a:bodyPr/>
+                    <a:lstStyle/>
+                    <a:p>
+                      <a:pPr algn="r"/>
+                      <a:r>
+                        <a:rPr sz="1300" b="0">
+                          <a:solidFill>
+                            <a:srgbClr val="3C3C3B"/>
+                          </a:solidFill>
+                          <a:latin typeface="Aptos"/>
+                        </a:rPr>
+                        <a:t>18.6</a:t>
+                      </a:r>
+                    </a:p>
+                  </a:txBody>
+                  <a:tcPr marL="73152" marR="73152" marT="27432" marB="27432" anchor="ctr">
+                    <a:noFill/>
+                  </a:tcPr>
+                </a:tc>
+                <a:tc>
+                  <a:txBody>
+                    <a:bodyPr/>
+                    <a:lstStyle/>
+                    <a:p>
+                      <a:pPr algn="r"/>
+                      <a:r>
+                        <a:rPr sz="1300" b="0">
+                          <a:solidFill>
+                            <a:srgbClr val="3C3C3B"/>
+                          </a:solidFill>
+                          <a:latin typeface="Aptos"/>
+                        </a:rPr>
+                        <a:t>(1.2)</a:t>
+                      </a:r>
+                    </a:p>
+                  </a:txBody>
+                  <a:tcPr marL="73152" marR="73152" marT="27432" marB="27432" anchor="ctr">
+                    <a:noFill/>
+                  </a:tcPr>
+                </a:tc>
+                <a:tc>
+                  <a:txBody>
+                    <a:bodyPr/>
+                    <a:lstStyle/>
+                    <a:p>
+                      <a:pPr algn="r"/>
+                      <a:r>
+                        <a:rPr sz="1300" b="0">
+                          <a:solidFill>
+                            <a:srgbClr val="3C3C3B"/>
+                          </a:solidFill>
+                          <a:latin typeface="Aptos"/>
+                        </a:rPr>
+                        <a:t>16.7</a:t>
                       </a:r>
                     </a:p>
                   </a:txBody>
@@ -15859,28 +15859,28 @@
                           </a:solidFill>
                           <a:latin typeface="Aptos"/>
                         </a:rPr>
-                        <a:t>7.2%</a:t>
-                      </a:r>
-                    </a:p>
-                  </a:txBody>
-                  <a:tcPr marL="73152" marR="73152" marT="27432" marB="27432" anchor="ctr">
-                    <a:noFill/>
-                  </a:tcPr>
-                </a:tc>
-                <a:tc>
-                  <a:txBody>
-                    <a:bodyPr/>
-                    <a:lstStyle/>
-                    <a:p>
-                      <a:pPr algn="r"/>
-                      <a:r>
-                        <a:rPr sz="1300" b="0">
-                          <a:solidFill>
-                            <a:srgbClr val="3C3C3B"/>
-                          </a:solidFill>
-                          <a:latin typeface="Aptos"/>
-                        </a:rPr>
-                        <a:t>9.8%</a:t>
+                        <a:t>7.0%</a:t>
+                      </a:r>
+                    </a:p>
+                  </a:txBody>
+                  <a:tcPr marL="73152" marR="73152" marT="27432" marB="27432" anchor="ctr">
+                    <a:noFill/>
+                  </a:tcPr>
+                </a:tc>
+                <a:tc>
+                  <a:txBody>
+                    <a:bodyPr/>
+                    <a:lstStyle/>
+                    <a:p>
+                      <a:pPr algn="r"/>
+                      <a:r>
+                        <a:rPr sz="1300" b="0">
+                          <a:solidFill>
+                            <a:srgbClr val="3C3C3B"/>
+                          </a:solidFill>
+                          <a:latin typeface="Aptos"/>
+                        </a:rPr>
+                        <a:t>9.6%</a:t>
                       </a:r>
                     </a:p>
                   </a:txBody>
@@ -15991,28 +15991,28 @@
                           </a:solidFill>
                           <a:latin typeface="Aptos"/>
                         </a:rPr>
-                        <a:t>1.91x</a:t>
-                      </a:r>
-                    </a:p>
-                  </a:txBody>
-                  <a:tcPr marL="73152" marR="73152" marT="27432" marB="27432" anchor="ctr">
-                    <a:noFill/>
-                  </a:tcPr>
-                </a:tc>
-                <a:tc>
-                  <a:txBody>
-                    <a:bodyPr/>
-                    <a:lstStyle/>
-                    <a:p>
-                      <a:pPr algn="r"/>
-                      <a:r>
-                        <a:rPr sz="1300" b="0">
-                          <a:solidFill>
-                            <a:srgbClr val="3C3C3B"/>
-                          </a:solidFill>
-                          <a:latin typeface="Aptos"/>
-                        </a:rPr>
-                        <a:t>2.53x</a:t>
+                        <a:t>1.88x</a:t>
+                      </a:r>
+                    </a:p>
+                  </a:txBody>
+                  <a:tcPr marL="73152" marR="73152" marT="27432" marB="27432" anchor="ctr">
+                    <a:noFill/>
+                  </a:tcPr>
+                </a:tc>
+                <a:tc>
+                  <a:txBody>
+                    <a:bodyPr/>
+                    <a:lstStyle/>
+                    <a:p>
+                      <a:pPr algn="r"/>
+                      <a:r>
+                        <a:rPr sz="1300" b="0">
+                          <a:solidFill>
+                            <a:srgbClr val="3C3C3B"/>
+                          </a:solidFill>
+                          <a:latin typeface="Aptos"/>
+                        </a:rPr>
+                        <a:t>2.48x</a:t>
                       </a:r>
                     </a:p>
                   </a:txBody>
@@ -16123,28 +16123,28 @@
                           </a:solidFill>
                           <a:latin typeface="Aptos"/>
                         </a:rPr>
-                        <a:t>(23.1)</a:t>
-                      </a:r>
-                    </a:p>
-                  </a:txBody>
-                  <a:tcPr marL="73152" marR="73152" marT="27432" marB="27432" anchor="ctr">
-                    <a:noFill/>
-                  </a:tcPr>
-                </a:tc>
-                <a:tc>
-                  <a:txBody>
-                    <a:bodyPr/>
-                    <a:lstStyle/>
-                    <a:p>
-                      <a:pPr algn="r"/>
-                      <a:r>
-                        <a:rPr sz="1300" b="0">
-                          <a:solidFill>
-                            <a:srgbClr val="3C3C3B"/>
-                          </a:solidFill>
-                          <a:latin typeface="Aptos"/>
-                        </a:rPr>
-                        <a:t>(28.5)</a:t>
+                        <a:t>(22.8)</a:t>
+                      </a:r>
+                    </a:p>
+                  </a:txBody>
+                  <a:tcPr marL="73152" marR="73152" marT="27432" marB="27432" anchor="ctr">
+                    <a:noFill/>
+                  </a:tcPr>
+                </a:tc>
+                <a:tc>
+                  <a:txBody>
+                    <a:bodyPr/>
+                    <a:lstStyle/>
+                    <a:p>
+                      <a:pPr algn="r"/>
+                      <a:r>
+                        <a:rPr sz="1300" b="0">
+                          <a:solidFill>
+                            <a:srgbClr val="3C3C3B"/>
+                          </a:solidFill>
+                          <a:latin typeface="Aptos"/>
+                        </a:rPr>
+                        <a:t>(28.1)</a:t>
                       </a:r>
                     </a:p>
                   </a:txBody>
@@ -16248,7 +16248,7 @@
                 </a:solidFill>
                 <a:latin typeface="Aptos"/>
               </a:rPr>
-              <a:t>1.20x target DSCR over 18 years, 5.0% fixed; sized at the lower of the DSCR capacity and 55% of cost on both routes; 63% / 47% of the DSCR capacity is used.</a:t>
+              <a:t>1.20x target DSCR over 18 years, 5.0% fixed; sized at the lower of the DSCR capacity and 55% of cost on both routes; 64% / 48% of the DSCR capacity is used.</a:t>
             </a:r>
           </a:p>
           <a:p>
@@ -16273,7 +16273,7 @@
                 </a:solidFill>
                 <a:latin typeface="Aptos"/>
               </a:rPr>
-              <a:t>€100.9m at 1.10x / €92.5m at 1.20x DSCR European (90% / 83% of uses); €97.8m / €89.7m Chinese.</a:t>
+              <a:t>€101.0m at 1.10x / €92.6m at 1.20x DSCR European (89% / 82% of uses); €98.0m / €89.8m Chinese.</a:t>
             </a:r>
           </a:p>
           <a:p>
@@ -16387,7 +16387,7 @@
           <a:lstStyle/>
           <a:p>
             <a:r>
-              <a:t>At 2,450 / 2,100 k€/MW a buyer earns 5.7% / 7.0%; at the lower price 6.7% / 8.1%, but FEP's sale IRR falls to 12.1% / 29.7%</a:t>
+              <a:t>At 2,450 / 2,100 k€/MW a buyer earns 5.7% / 7.0%; at the lower price 6.7% / 8.1%, but FEP's sale IRR falls to 9.7% / 27.4%</a:t>
             </a:r>
           </a:p>
         </p:txBody>
@@ -17112,7 +17112,7 @@
                           </a:solidFill>
                           <a:latin typeface="Aptos"/>
                         </a:rPr>
-                        <a:t>12.1%</a:t>
+                        <a:t>9.7%</a:t>
                       </a:r>
                     </a:p>
                   </a:txBody>
@@ -17196,7 +17196,7 @@
                           </a:solidFill>
                           <a:latin typeface="Aptos"/>
                         </a:rPr>
-                        <a:t>29.7%</a:t>
+                        <a:t>27.4%</a:t>
                       </a:r>
                     </a:p>
                   </a:txBody>
@@ -17311,7 +17311,7 @@
                           </a:solidFill>
                           <a:latin typeface="Aptos"/>
                         </a:rPr>
-                        <a:t>28.4%</a:t>
+                        <a:t>26.3%</a:t>
                       </a:r>
                     </a:p>
                   </a:txBody>
@@ -17380,7 +17380,7 @@
                           </a:solidFill>
                           <a:latin typeface="Aptos"/>
                         </a:rPr>
-                        <a:t>7.5%</a:t>
+                        <a:t>7.6%</a:t>
                       </a:r>
                     </a:p>
                   </a:txBody>
@@ -17403,7 +17403,7 @@
                           </a:solidFill>
                           <a:latin typeface="Aptos"/>
                         </a:rPr>
-                        <a:t>43.2%</a:t>
+                        <a:t>41.0%</a:t>
                       </a:r>
                     </a:p>
                   </a:txBody>
@@ -17514,7 +17514,7 @@
                           </a:solidFill>
                           <a:latin typeface="Aptos"/>
                         </a:rPr>
-                        <a:t>42.2%</a:t>
+                        <a:t>40.4%</a:t>
                       </a:r>
                     </a:p>
                   </a:txBody>
@@ -17598,7 +17598,7 @@
                           </a:solidFill>
                           <a:latin typeface="Aptos"/>
                         </a:rPr>
-                        <a:t>54.7%</a:t>
+                        <a:t>52.7%</a:t>
                       </a:r>
                     </a:p>
                   </a:txBody>
@@ -17695,7 +17695,7 @@
           <a:lstStyle/>
           <a:p>
             <a:r>
-              <a:t>A lower COD price hits the sale most (12.1%); Robin Hood tax (6.1%) and lower yield (6.3%) hit the hold</a:t>
+              <a:t>A lower COD price hits the sale most (9.7%); Robin Hood tax (5.9%) and lower yield (6.1%) hit the hold</a:t>
             </a:r>
           </a:p>
         </p:txBody>
@@ -18404,7 +18404,7 @@
                           </a:solidFill>
                           <a:latin typeface="Aptos"/>
                         </a:rPr>
-                        <a:t>28.4%</a:t>
+                        <a:t>26.3%</a:t>
                       </a:r>
                     </a:p>
                   </a:txBody>
@@ -18427,7 +18427,7 @@
                           </a:solidFill>
                           <a:latin typeface="Aptos"/>
                         </a:rPr>
-                        <a:t>43.2%</a:t>
+                        <a:t>41.0%</a:t>
                       </a:r>
                     </a:p>
                   </a:txBody>
@@ -18496,7 +18496,7 @@
                           </a:solidFill>
                           <a:latin typeface="Aptos"/>
                         </a:rPr>
-                        <a:t>8.0%</a:t>
+                        <a:t>7.8%</a:t>
                       </a:r>
                     </a:p>
                   </a:txBody>
@@ -18519,7 +18519,7 @@
                           </a:solidFill>
                           <a:latin typeface="Aptos"/>
                         </a:rPr>
-                        <a:t>12.0%</a:t>
+                        <a:t>11.7%</a:t>
                       </a:r>
                     </a:p>
                   </a:txBody>
@@ -18542,7 +18542,7 @@
                           </a:solidFill>
                           <a:latin typeface="Aptos"/>
                         </a:rPr>
-                        <a:t>1.91x</a:t>
+                        <a:t>1.88x</a:t>
                       </a:r>
                     </a:p>
                   </a:txBody>
@@ -18565,7 +18565,7 @@
                           </a:solidFill>
                           <a:latin typeface="Aptos"/>
                         </a:rPr>
-                        <a:t>2.53x</a:t>
+                        <a:t>2.48x</a:t>
                       </a:r>
                     </a:p>
                   </a:txBody>
@@ -18634,28 +18634,28 @@
                           </a:solidFill>
                           <a:latin typeface="Aptos"/>
                         </a:rPr>
-                        <a:t>12.1%</a:t>
-                      </a:r>
-                    </a:p>
-                  </a:txBody>
-                  <a:tcPr marL="73152" marR="73152" marT="27432" marB="27432" anchor="ctr">
-                    <a:noFill/>
-                  </a:tcPr>
-                </a:tc>
-                <a:tc>
-                  <a:txBody>
-                    <a:bodyPr/>
-                    <a:lstStyle/>
-                    <a:p>
-                      <a:pPr algn="r"/>
-                      <a:r>
-                        <a:rPr sz="1300" b="0">
-                          <a:solidFill>
-                            <a:srgbClr val="3C3C3B"/>
-                          </a:solidFill>
-                          <a:latin typeface="Aptos"/>
-                        </a:rPr>
-                        <a:t>29.7%</a:t>
+                        <a:t>9.7%</a:t>
+                      </a:r>
+                    </a:p>
+                  </a:txBody>
+                  <a:tcPr marL="73152" marR="73152" marT="27432" marB="27432" anchor="ctr">
+                    <a:noFill/>
+                  </a:tcPr>
+                </a:tc>
+                <a:tc>
+                  <a:txBody>
+                    <a:bodyPr/>
+                    <a:lstStyle/>
+                    <a:p>
+                      <a:pPr algn="r"/>
+                      <a:r>
+                        <a:rPr sz="1300" b="0">
+                          <a:solidFill>
+                            <a:srgbClr val="3C3C3B"/>
+                          </a:solidFill>
+                          <a:latin typeface="Aptos"/>
+                        </a:rPr>
+                        <a:t>27.4%</a:t>
                       </a:r>
                     </a:p>
                   </a:txBody>
@@ -18718,70 +18718,70 @@
                           </a:solidFill>
                           <a:latin typeface="Aptos"/>
                         </a:rPr>
-                        <a:t>8.0%</a:t>
-                      </a:r>
-                    </a:p>
-                  </a:txBody>
-                  <a:tcPr marL="73152" marR="73152" marT="27432" marB="27432" anchor="ctr">
-                    <a:noFill/>
-                  </a:tcPr>
-                </a:tc>
-                <a:tc>
-                  <a:txBody>
-                    <a:bodyPr/>
-                    <a:lstStyle/>
-                    <a:p>
-                      <a:pPr algn="r"/>
-                      <a:r>
-                        <a:rPr sz="1300" b="0">
-                          <a:solidFill>
-                            <a:srgbClr val="3C3C3B"/>
-                          </a:solidFill>
-                          <a:latin typeface="Aptos"/>
-                        </a:rPr>
-                        <a:t>12.0%</a:t>
-                      </a:r>
-                    </a:p>
-                  </a:txBody>
-                  <a:tcPr marL="73152" marR="73152" marT="27432" marB="27432" anchor="ctr">
-                    <a:noFill/>
-                  </a:tcPr>
-                </a:tc>
-                <a:tc>
-                  <a:txBody>
-                    <a:bodyPr/>
-                    <a:lstStyle/>
-                    <a:p>
-                      <a:pPr algn="r"/>
-                      <a:r>
-                        <a:rPr sz="1300" b="0">
-                          <a:solidFill>
-                            <a:srgbClr val="3C3C3B"/>
-                          </a:solidFill>
-                          <a:latin typeface="Aptos"/>
-                        </a:rPr>
-                        <a:t>1.91x</a:t>
-                      </a:r>
-                    </a:p>
-                  </a:txBody>
-                  <a:tcPr marL="73152" marR="73152" marT="27432" marB="27432" anchor="ctr">
-                    <a:noFill/>
-                  </a:tcPr>
-                </a:tc>
-                <a:tc>
-                  <a:txBody>
-                    <a:bodyPr/>
-                    <a:lstStyle/>
-                    <a:p>
-                      <a:pPr algn="r"/>
-                      <a:r>
-                        <a:rPr sz="1300" b="0">
-                          <a:solidFill>
-                            <a:srgbClr val="3C3C3B"/>
-                          </a:solidFill>
-                          <a:latin typeface="Aptos"/>
-                        </a:rPr>
-                        <a:t>2.53x</a:t>
+                        <a:t>7.8%</a:t>
+                      </a:r>
+                    </a:p>
+                  </a:txBody>
+                  <a:tcPr marL="73152" marR="73152" marT="27432" marB="27432" anchor="ctr">
+                    <a:noFill/>
+                  </a:tcPr>
+                </a:tc>
+                <a:tc>
+                  <a:txBody>
+                    <a:bodyPr/>
+                    <a:lstStyle/>
+                    <a:p>
+                      <a:pPr algn="r"/>
+                      <a:r>
+                        <a:rPr sz="1300" b="0">
+                          <a:solidFill>
+                            <a:srgbClr val="3C3C3B"/>
+                          </a:solidFill>
+                          <a:latin typeface="Aptos"/>
+                        </a:rPr>
+                        <a:t>11.7%</a:t>
+                      </a:r>
+                    </a:p>
+                  </a:txBody>
+                  <a:tcPr marL="73152" marR="73152" marT="27432" marB="27432" anchor="ctr">
+                    <a:noFill/>
+                  </a:tcPr>
+                </a:tc>
+                <a:tc>
+                  <a:txBody>
+                    <a:bodyPr/>
+                    <a:lstStyle/>
+                    <a:p>
+                      <a:pPr algn="r"/>
+                      <a:r>
+                        <a:rPr sz="1300" b="0">
+                          <a:solidFill>
+                            <a:srgbClr val="3C3C3B"/>
+                          </a:solidFill>
+                          <a:latin typeface="Aptos"/>
+                        </a:rPr>
+                        <a:t>1.88x</a:t>
+                      </a:r>
+                    </a:p>
+                  </a:txBody>
+                  <a:tcPr marL="73152" marR="73152" marT="27432" marB="27432" anchor="ctr">
+                    <a:noFill/>
+                  </a:tcPr>
+                </a:tc>
+                <a:tc>
+                  <a:txBody>
+                    <a:bodyPr/>
+                    <a:lstStyle/>
+                    <a:p>
+                      <a:pPr algn="r"/>
+                      <a:r>
+                        <a:rPr sz="1300" b="0">
+                          <a:solidFill>
+                            <a:srgbClr val="3C3C3B"/>
+                          </a:solidFill>
+                          <a:latin typeface="Aptos"/>
+                        </a:rPr>
+                        <a:t>2.48x</a:t>
                       </a:r>
                     </a:p>
                   </a:txBody>
@@ -18848,28 +18848,28 @@
                           </a:solidFill>
                           <a:latin typeface="Aptos"/>
                         </a:rPr>
-                        <a:t>42.2%</a:t>
-                      </a:r>
-                    </a:p>
-                  </a:txBody>
-                  <a:tcPr marL="73152" marR="73152" marT="27432" marB="27432" anchor="ctr">
-                    <a:noFill/>
-                  </a:tcPr>
-                </a:tc>
-                <a:tc>
-                  <a:txBody>
-                    <a:bodyPr/>
-                    <a:lstStyle/>
-                    <a:p>
-                      <a:pPr algn="r"/>
-                      <a:r>
-                        <a:rPr sz="1300" b="0">
-                          <a:solidFill>
-                            <a:srgbClr val="3C3C3B"/>
-                          </a:solidFill>
-                          <a:latin typeface="Aptos"/>
-                        </a:rPr>
-                        <a:t>54.7%</a:t>
+                        <a:t>40.4%</a:t>
+                      </a:r>
+                    </a:p>
+                  </a:txBody>
+                  <a:tcPr marL="73152" marR="73152" marT="27432" marB="27432" anchor="ctr">
+                    <a:noFill/>
+                  </a:tcPr>
+                </a:tc>
+                <a:tc>
+                  <a:txBody>
+                    <a:bodyPr/>
+                    <a:lstStyle/>
+                    <a:p>
+                      <a:pPr algn="r"/>
+                      <a:r>
+                        <a:rPr sz="1300" b="0">
+                          <a:solidFill>
+                            <a:srgbClr val="3C3C3B"/>
+                          </a:solidFill>
+                          <a:latin typeface="Aptos"/>
+                        </a:rPr>
+                        <a:t>52.7%</a:t>
                       </a:r>
                     </a:p>
                   </a:txBody>
@@ -18932,70 +18932,70 @@
                           </a:solidFill>
                           <a:latin typeface="Aptos"/>
                         </a:rPr>
-                        <a:t>8.0%</a:t>
-                      </a:r>
-                    </a:p>
-                  </a:txBody>
-                  <a:tcPr marL="73152" marR="73152" marT="27432" marB="27432" anchor="ctr">
-                    <a:noFill/>
-                  </a:tcPr>
-                </a:tc>
-                <a:tc>
-                  <a:txBody>
-                    <a:bodyPr/>
-                    <a:lstStyle/>
-                    <a:p>
-                      <a:pPr algn="r"/>
-                      <a:r>
-                        <a:rPr sz="1300" b="0">
-                          <a:solidFill>
-                            <a:srgbClr val="3C3C3B"/>
-                          </a:solidFill>
-                          <a:latin typeface="Aptos"/>
-                        </a:rPr>
-                        <a:t>12.0%</a:t>
-                      </a:r>
-                    </a:p>
-                  </a:txBody>
-                  <a:tcPr marL="73152" marR="73152" marT="27432" marB="27432" anchor="ctr">
-                    <a:noFill/>
-                  </a:tcPr>
-                </a:tc>
-                <a:tc>
-                  <a:txBody>
-                    <a:bodyPr/>
-                    <a:lstStyle/>
-                    <a:p>
-                      <a:pPr algn="r"/>
-                      <a:r>
-                        <a:rPr sz="1300" b="0">
-                          <a:solidFill>
-                            <a:srgbClr val="3C3C3B"/>
-                          </a:solidFill>
-                          <a:latin typeface="Aptos"/>
-                        </a:rPr>
-                        <a:t>1.91x</a:t>
-                      </a:r>
-                    </a:p>
-                  </a:txBody>
-                  <a:tcPr marL="73152" marR="73152" marT="27432" marB="27432" anchor="ctr">
-                    <a:noFill/>
-                  </a:tcPr>
-                </a:tc>
-                <a:tc>
-                  <a:txBody>
-                    <a:bodyPr/>
-                    <a:lstStyle/>
-                    <a:p>
-                      <a:pPr algn="r"/>
-                      <a:r>
-                        <a:rPr sz="1300" b="0">
-                          <a:solidFill>
-                            <a:srgbClr val="3C3C3B"/>
-                          </a:solidFill>
-                          <a:latin typeface="Aptos"/>
-                        </a:rPr>
-                        <a:t>2.53x</a:t>
+                        <a:t>7.8%</a:t>
+                      </a:r>
+                    </a:p>
+                  </a:txBody>
+                  <a:tcPr marL="73152" marR="73152" marT="27432" marB="27432" anchor="ctr">
+                    <a:noFill/>
+                  </a:tcPr>
+                </a:tc>
+                <a:tc>
+                  <a:txBody>
+                    <a:bodyPr/>
+                    <a:lstStyle/>
+                    <a:p>
+                      <a:pPr algn="r"/>
+                      <a:r>
+                        <a:rPr sz="1300" b="0">
+                          <a:solidFill>
+                            <a:srgbClr val="3C3C3B"/>
+                          </a:solidFill>
+                          <a:latin typeface="Aptos"/>
+                        </a:rPr>
+                        <a:t>11.7%</a:t>
+                      </a:r>
+                    </a:p>
+                  </a:txBody>
+                  <a:tcPr marL="73152" marR="73152" marT="27432" marB="27432" anchor="ctr">
+                    <a:noFill/>
+                  </a:tcPr>
+                </a:tc>
+                <a:tc>
+                  <a:txBody>
+                    <a:bodyPr/>
+                    <a:lstStyle/>
+                    <a:p>
+                      <a:pPr algn="r"/>
+                      <a:r>
+                        <a:rPr sz="1300" b="0">
+                          <a:solidFill>
+                            <a:srgbClr val="3C3C3B"/>
+                          </a:solidFill>
+                          <a:latin typeface="Aptos"/>
+                        </a:rPr>
+                        <a:t>1.88x</a:t>
+                      </a:r>
+                    </a:p>
+                  </a:txBody>
+                  <a:tcPr marL="73152" marR="73152" marT="27432" marB="27432" anchor="ctr">
+                    <a:noFill/>
+                  </a:tcPr>
+                </a:tc>
+                <a:tc>
+                  <a:txBody>
+                    <a:bodyPr/>
+                    <a:lstStyle/>
+                    <a:p>
+                      <a:pPr algn="r"/>
+                      <a:r>
+                        <a:rPr sz="1300" b="0">
+                          <a:solidFill>
+                            <a:srgbClr val="3C3C3B"/>
+                          </a:solidFill>
+                          <a:latin typeface="Aptos"/>
+                        </a:rPr>
+                        <a:t>2.48x</a:t>
                       </a:r>
                     </a:p>
                   </a:txBody>
@@ -19062,28 +19062,28 @@
                           </a:solidFill>
                           <a:latin typeface="Aptos"/>
                         </a:rPr>
-                        <a:t>21.2%</a:t>
-                      </a:r>
-                    </a:p>
-                  </a:txBody>
-                  <a:tcPr marL="73152" marR="73152" marT="27432" marB="27432" anchor="ctr">
-                    <a:noFill/>
-                  </a:tcPr>
-                </a:tc>
-                <a:tc>
-                  <a:txBody>
-                    <a:bodyPr/>
-                    <a:lstStyle/>
-                    <a:p>
-                      <a:pPr algn="r"/>
-                      <a:r>
-                        <a:rPr sz="1300" b="0">
-                          <a:solidFill>
-                            <a:srgbClr val="3C3C3B"/>
-                          </a:solidFill>
-                          <a:latin typeface="Aptos"/>
-                        </a:rPr>
-                        <a:t>39.3%</a:t>
+                        <a:t>19.1%</a:t>
+                      </a:r>
+                    </a:p>
+                  </a:txBody>
+                  <a:tcPr marL="73152" marR="73152" marT="27432" marB="27432" anchor="ctr">
+                    <a:noFill/>
+                  </a:tcPr>
+                </a:tc>
+                <a:tc>
+                  <a:txBody>
+                    <a:bodyPr/>
+                    <a:lstStyle/>
+                    <a:p>
+                      <a:pPr algn="r"/>
+                      <a:r>
+                        <a:rPr sz="1300" b="0">
+                          <a:solidFill>
+                            <a:srgbClr val="3C3C3B"/>
+                          </a:solidFill>
+                          <a:latin typeface="Aptos"/>
+                        </a:rPr>
+                        <a:t>37.1%</a:t>
                       </a:r>
                     </a:p>
                   </a:txBody>
@@ -19146,70 +19146,70 @@
                           </a:solidFill>
                           <a:latin typeface="Aptos"/>
                         </a:rPr>
-                        <a:t>7.3%</a:t>
-                      </a:r>
-                    </a:p>
-                  </a:txBody>
-                  <a:tcPr marL="73152" marR="73152" marT="27432" marB="27432" anchor="ctr">
-                    <a:noFill/>
-                  </a:tcPr>
-                </a:tc>
-                <a:tc>
-                  <a:txBody>
-                    <a:bodyPr/>
-                    <a:lstStyle/>
-                    <a:p>
-                      <a:pPr algn="r"/>
-                      <a:r>
-                        <a:rPr sz="1300" b="0">
-                          <a:solidFill>
-                            <a:srgbClr val="3C3C3B"/>
-                          </a:solidFill>
-                          <a:latin typeface="Aptos"/>
-                        </a:rPr>
-                        <a:t>11.5%</a:t>
-                      </a:r>
-                    </a:p>
-                  </a:txBody>
-                  <a:tcPr marL="73152" marR="73152" marT="27432" marB="27432" anchor="ctr">
-                    <a:noFill/>
-                  </a:tcPr>
-                </a:tc>
-                <a:tc>
-                  <a:txBody>
-                    <a:bodyPr/>
-                    <a:lstStyle/>
-                    <a:p>
-                      <a:pPr algn="r"/>
-                      <a:r>
-                        <a:rPr sz="1300" b="0">
-                          <a:solidFill>
-                            <a:srgbClr val="3C3C3B"/>
-                          </a:solidFill>
-                          <a:latin typeface="Aptos"/>
-                        </a:rPr>
-                        <a:t>1.82x</a:t>
-                      </a:r>
-                    </a:p>
-                  </a:txBody>
-                  <a:tcPr marL="73152" marR="73152" marT="27432" marB="27432" anchor="ctr">
-                    <a:noFill/>
-                  </a:tcPr>
-                </a:tc>
-                <a:tc>
-                  <a:txBody>
-                    <a:bodyPr/>
-                    <a:lstStyle/>
-                    <a:p>
-                      <a:pPr algn="r"/>
-                      <a:r>
-                        <a:rPr sz="1300" b="0">
-                          <a:solidFill>
-                            <a:srgbClr val="3C3C3B"/>
-                          </a:solidFill>
-                          <a:latin typeface="Aptos"/>
-                        </a:rPr>
-                        <a:t>2.45x</a:t>
+                        <a:t>7.2%</a:t>
+                      </a:r>
+                    </a:p>
+                  </a:txBody>
+                  <a:tcPr marL="73152" marR="73152" marT="27432" marB="27432" anchor="ctr">
+                    <a:noFill/>
+                  </a:tcPr>
+                </a:tc>
+                <a:tc>
+                  <a:txBody>
+                    <a:bodyPr/>
+                    <a:lstStyle/>
+                    <a:p>
+                      <a:pPr algn="r"/>
+                      <a:r>
+                        <a:rPr sz="1300" b="0">
+                          <a:solidFill>
+                            <a:srgbClr val="3C3C3B"/>
+                          </a:solidFill>
+                          <a:latin typeface="Aptos"/>
+                        </a:rPr>
+                        <a:t>11.2%</a:t>
+                      </a:r>
+                    </a:p>
+                  </a:txBody>
+                  <a:tcPr marL="73152" marR="73152" marT="27432" marB="27432" anchor="ctr">
+                    <a:noFill/>
+                  </a:tcPr>
+                </a:tc>
+                <a:tc>
+                  <a:txBody>
+                    <a:bodyPr/>
+                    <a:lstStyle/>
+                    <a:p>
+                      <a:pPr algn="r"/>
+                      <a:r>
+                        <a:rPr sz="1300" b="0">
+                          <a:solidFill>
+                            <a:srgbClr val="3C3C3B"/>
+                          </a:solidFill>
+                          <a:latin typeface="Aptos"/>
+                        </a:rPr>
+                        <a:t>1.80x</a:t>
+                      </a:r>
+                    </a:p>
+                  </a:txBody>
+                  <a:tcPr marL="73152" marR="73152" marT="27432" marB="27432" anchor="ctr">
+                    <a:noFill/>
+                  </a:tcPr>
+                </a:tc>
+                <a:tc>
+                  <a:txBody>
+                    <a:bodyPr/>
+                    <a:lstStyle/>
+                    <a:p>
+                      <a:pPr algn="r"/>
+                      <a:r>
+                        <a:rPr sz="1300" b="0">
+                          <a:solidFill>
+                            <a:srgbClr val="3C3C3B"/>
+                          </a:solidFill>
+                          <a:latin typeface="Aptos"/>
+                        </a:rPr>
+                        <a:t>2.40x</a:t>
                       </a:r>
                     </a:p>
                   </a:txBody>
@@ -19276,28 +19276,28 @@
                           </a:solidFill>
                           <a:latin typeface="Aptos"/>
                         </a:rPr>
-                        <a:t>28.4%</a:t>
-                      </a:r>
-                    </a:p>
-                  </a:txBody>
-                  <a:tcPr marL="73152" marR="73152" marT="27432" marB="27432" anchor="ctr">
-                    <a:noFill/>
-                  </a:tcPr>
-                </a:tc>
-                <a:tc>
-                  <a:txBody>
-                    <a:bodyPr/>
-                    <a:lstStyle/>
-                    <a:p>
-                      <a:pPr algn="r"/>
-                      <a:r>
-                        <a:rPr sz="1300" b="0">
-                          <a:solidFill>
-                            <a:srgbClr val="3C3C3B"/>
-                          </a:solidFill>
-                          <a:latin typeface="Aptos"/>
-                        </a:rPr>
-                        <a:t>43.2%</a:t>
+                        <a:t>26.3%</a:t>
+                      </a:r>
+                    </a:p>
+                  </a:txBody>
+                  <a:tcPr marL="73152" marR="73152" marT="27432" marB="27432" anchor="ctr">
+                    <a:noFill/>
+                  </a:tcPr>
+                </a:tc>
+                <a:tc>
+                  <a:txBody>
+                    <a:bodyPr/>
+                    <a:lstStyle/>
+                    <a:p>
+                      <a:pPr algn="r"/>
+                      <a:r>
+                        <a:rPr sz="1300" b="0">
+                          <a:solidFill>
+                            <a:srgbClr val="3C3C3B"/>
+                          </a:solidFill>
+                          <a:latin typeface="Aptos"/>
+                        </a:rPr>
+                        <a:t>41.0%</a:t>
                       </a:r>
                     </a:p>
                   </a:txBody>
@@ -19360,70 +19360,70 @@
                           </a:solidFill>
                           <a:latin typeface="Aptos"/>
                         </a:rPr>
-                        <a:t>6.3%</a:t>
-                      </a:r>
-                    </a:p>
-                  </a:txBody>
-                  <a:tcPr marL="73152" marR="73152" marT="27432" marB="27432" anchor="ctr">
-                    <a:noFill/>
-                  </a:tcPr>
-                </a:tc>
-                <a:tc>
-                  <a:txBody>
-                    <a:bodyPr/>
-                    <a:lstStyle/>
-                    <a:p>
-                      <a:pPr algn="r"/>
-                      <a:r>
-                        <a:rPr sz="1300" b="0">
-                          <a:solidFill>
-                            <a:srgbClr val="3C3C3B"/>
-                          </a:solidFill>
-                          <a:latin typeface="Aptos"/>
-                        </a:rPr>
-                        <a:t>10.1%</a:t>
-                      </a:r>
-                    </a:p>
-                  </a:txBody>
-                  <a:tcPr marL="73152" marR="73152" marT="27432" marB="27432" anchor="ctr">
-                    <a:noFill/>
-                  </a:tcPr>
-                </a:tc>
-                <a:tc>
-                  <a:txBody>
-                    <a:bodyPr/>
-                    <a:lstStyle/>
-                    <a:p>
-                      <a:pPr algn="r"/>
-                      <a:r>
-                        <a:rPr sz="1300" b="0">
-                          <a:solidFill>
-                            <a:srgbClr val="3C3C3B"/>
-                          </a:solidFill>
-                          <a:latin typeface="Aptos"/>
-                        </a:rPr>
-                        <a:t>1.70x</a:t>
-                      </a:r>
-                    </a:p>
-                  </a:txBody>
-                  <a:tcPr marL="73152" marR="73152" marT="27432" marB="27432" anchor="ctr">
-                    <a:noFill/>
-                  </a:tcPr>
-                </a:tc>
-                <a:tc>
-                  <a:txBody>
-                    <a:bodyPr/>
-                    <a:lstStyle/>
-                    <a:p>
-                      <a:pPr algn="r"/>
-                      <a:r>
-                        <a:rPr sz="1300" b="0">
-                          <a:solidFill>
-                            <a:srgbClr val="3C3C3B"/>
-                          </a:solidFill>
-                          <a:latin typeface="Aptos"/>
-                        </a:rPr>
-                        <a:t>2.26x</a:t>
+                        <a:t>6.1%</a:t>
+                      </a:r>
+                    </a:p>
+                  </a:txBody>
+                  <a:tcPr marL="73152" marR="73152" marT="27432" marB="27432" anchor="ctr">
+                    <a:noFill/>
+                  </a:tcPr>
+                </a:tc>
+                <a:tc>
+                  <a:txBody>
+                    <a:bodyPr/>
+                    <a:lstStyle/>
+                    <a:p>
+                      <a:pPr algn="r"/>
+                      <a:r>
+                        <a:rPr sz="1300" b="0">
+                          <a:solidFill>
+                            <a:srgbClr val="3C3C3B"/>
+                          </a:solidFill>
+                          <a:latin typeface="Aptos"/>
+                        </a:rPr>
+                        <a:t>9.8%</a:t>
+                      </a:r>
+                    </a:p>
+                  </a:txBody>
+                  <a:tcPr marL="73152" marR="73152" marT="27432" marB="27432" anchor="ctr">
+                    <a:noFill/>
+                  </a:tcPr>
+                </a:tc>
+                <a:tc>
+                  <a:txBody>
+                    <a:bodyPr/>
+                    <a:lstStyle/>
+                    <a:p>
+                      <a:pPr algn="r"/>
+                      <a:r>
+                        <a:rPr sz="1300" b="0">
+                          <a:solidFill>
+                            <a:srgbClr val="3C3C3B"/>
+                          </a:solidFill>
+                          <a:latin typeface="Aptos"/>
+                        </a:rPr>
+                        <a:t>1.68x</a:t>
+                      </a:r>
+                    </a:p>
+                  </a:txBody>
+                  <a:tcPr marL="73152" marR="73152" marT="27432" marB="27432" anchor="ctr">
+                    <a:noFill/>
+                  </a:tcPr>
+                </a:tc>
+                <a:tc>
+                  <a:txBody>
+                    <a:bodyPr/>
+                    <a:lstStyle/>
+                    <a:p>
+                      <a:pPr algn="r"/>
+                      <a:r>
+                        <a:rPr sz="1300" b="0">
+                          <a:solidFill>
+                            <a:srgbClr val="3C3C3B"/>
+                          </a:solidFill>
+                          <a:latin typeface="Aptos"/>
+                        </a:rPr>
+                        <a:t>2.21x</a:t>
                       </a:r>
                     </a:p>
                   </a:txBody>
@@ -19490,154 +19490,154 @@
                           </a:solidFill>
                           <a:latin typeface="Aptos"/>
                         </a:rPr>
-                        <a:t>28.4%</a:t>
-                      </a:r>
-                    </a:p>
-                  </a:txBody>
-                  <a:tcPr marL="73152" marR="73152" marT="27432" marB="27432" anchor="ctr">
-                    <a:noFill/>
-                  </a:tcPr>
-                </a:tc>
-                <a:tc>
-                  <a:txBody>
-                    <a:bodyPr/>
-                    <a:lstStyle/>
-                    <a:p>
-                      <a:pPr algn="r"/>
-                      <a:r>
-                        <a:rPr sz="1300" b="0">
-                          <a:solidFill>
-                            <a:srgbClr val="3C3C3B"/>
-                          </a:solidFill>
-                          <a:latin typeface="Aptos"/>
-                        </a:rPr>
-                        <a:t>43.2%</a:t>
-                      </a:r>
-                    </a:p>
-                  </a:txBody>
-                  <a:tcPr marL="73152" marR="73152" marT="27432" marB="27432" anchor="ctr">
-                    <a:noFill/>
-                  </a:tcPr>
-                </a:tc>
-                <a:tc>
-                  <a:txBody>
-                    <a:bodyPr/>
-                    <a:lstStyle/>
-                    <a:p>
-                      <a:pPr algn="r"/>
-                      <a:r>
-                        <a:rPr sz="1300" b="0">
-                          <a:solidFill>
-                            <a:srgbClr val="3C3C3B"/>
-                          </a:solidFill>
-                          <a:latin typeface="Aptos"/>
-                        </a:rPr>
-                        <a:t>6.8%</a:t>
-                      </a:r>
-                    </a:p>
-                  </a:txBody>
-                  <a:tcPr marL="73152" marR="73152" marT="27432" marB="27432" anchor="ctr">
-                    <a:noFill/>
-                  </a:tcPr>
-                </a:tc>
-                <a:tc>
-                  <a:txBody>
-                    <a:bodyPr/>
-                    <a:lstStyle/>
-                    <a:p>
-                      <a:pPr algn="r"/>
-                      <a:r>
-                        <a:rPr sz="1300" b="0">
-                          <a:solidFill>
-                            <a:srgbClr val="3C3C3B"/>
-                          </a:solidFill>
-                          <a:latin typeface="Aptos"/>
-                        </a:rPr>
-                        <a:t>8.2%</a:t>
-                      </a:r>
-                    </a:p>
-                  </a:txBody>
-                  <a:tcPr marL="73152" marR="73152" marT="27432" marB="27432" anchor="ctr">
-                    <a:noFill/>
-                  </a:tcPr>
-                </a:tc>
-                <a:tc>
-                  <a:txBody>
-                    <a:bodyPr/>
-                    <a:lstStyle/>
-                    <a:p>
-                      <a:pPr algn="r"/>
-                      <a:r>
-                        <a:rPr sz="1300" b="0">
-                          <a:solidFill>
-                            <a:srgbClr val="3C3C3B"/>
-                          </a:solidFill>
-                          <a:latin typeface="Aptos"/>
-                        </a:rPr>
-                        <a:t>9.8%</a:t>
-                      </a:r>
-                    </a:p>
-                  </a:txBody>
-                  <a:tcPr marL="73152" marR="73152" marT="27432" marB="27432" anchor="ctr">
-                    <a:noFill/>
-                  </a:tcPr>
-                </a:tc>
-                <a:tc>
-                  <a:txBody>
-                    <a:bodyPr/>
-                    <a:lstStyle/>
-                    <a:p>
-                      <a:pPr algn="r"/>
-                      <a:r>
-                        <a:rPr sz="1300" b="0">
-                          <a:solidFill>
-                            <a:srgbClr val="3C3C3B"/>
-                          </a:solidFill>
-                          <a:latin typeface="Aptos"/>
-                        </a:rPr>
-                        <a:t>14.1%</a:t>
-                      </a:r>
-                    </a:p>
-                  </a:txBody>
-                  <a:tcPr marL="73152" marR="73152" marT="27432" marB="27432" anchor="ctr">
-                    <a:noFill/>
-                  </a:tcPr>
-                </a:tc>
-                <a:tc>
-                  <a:txBody>
-                    <a:bodyPr/>
-                    <a:lstStyle/>
-                    <a:p>
-                      <a:pPr algn="r"/>
-                      <a:r>
-                        <a:rPr sz="1300" b="0">
-                          <a:solidFill>
-                            <a:srgbClr val="3C3C3B"/>
-                          </a:solidFill>
-                          <a:latin typeface="Aptos"/>
-                        </a:rPr>
-                        <a:t>2.13x</a:t>
-                      </a:r>
-                    </a:p>
-                  </a:txBody>
-                  <a:tcPr marL="73152" marR="73152" marT="27432" marB="27432" anchor="ctr">
-                    <a:noFill/>
-                  </a:tcPr>
-                </a:tc>
-                <a:tc>
-                  <a:txBody>
-                    <a:bodyPr/>
-                    <a:lstStyle/>
-                    <a:p>
-                      <a:pPr algn="r"/>
-                      <a:r>
-                        <a:rPr sz="1300" b="0">
-                          <a:solidFill>
-                            <a:srgbClr val="3C3C3B"/>
-                          </a:solidFill>
-                          <a:latin typeface="Aptos"/>
-                        </a:rPr>
-                        <a:t>2.84x</a:t>
+                        <a:t>26.3%</a:t>
+                      </a:r>
+                    </a:p>
+                  </a:txBody>
+                  <a:tcPr marL="73152" marR="73152" marT="27432" marB="27432" anchor="ctr">
+                    <a:noFill/>
+                  </a:tcPr>
+                </a:tc>
+                <a:tc>
+                  <a:txBody>
+                    <a:bodyPr/>
+                    <a:lstStyle/>
+                    <a:p>
+                      <a:pPr algn="r"/>
+                      <a:r>
+                        <a:rPr sz="1300" b="0">
+                          <a:solidFill>
+                            <a:srgbClr val="3C3C3B"/>
+                          </a:solidFill>
+                          <a:latin typeface="Aptos"/>
+                        </a:rPr>
+                        <a:t>41.0%</a:t>
+                      </a:r>
+                    </a:p>
+                  </a:txBody>
+                  <a:tcPr marL="73152" marR="73152" marT="27432" marB="27432" anchor="ctr">
+                    <a:noFill/>
+                  </a:tcPr>
+                </a:tc>
+                <a:tc>
+                  <a:txBody>
+                    <a:bodyPr/>
+                    <a:lstStyle/>
+                    <a:p>
+                      <a:pPr algn="r"/>
+                      <a:r>
+                        <a:rPr sz="1300" b="0">
+                          <a:solidFill>
+                            <a:srgbClr val="3C3C3B"/>
+                          </a:solidFill>
+                          <a:latin typeface="Aptos"/>
+                        </a:rPr>
+                        <a:t>6.9%</a:t>
+                      </a:r>
+                    </a:p>
+                  </a:txBody>
+                  <a:tcPr marL="73152" marR="73152" marT="27432" marB="27432" anchor="ctr">
+                    <a:noFill/>
+                  </a:tcPr>
+                </a:tc>
+                <a:tc>
+                  <a:txBody>
+                    <a:bodyPr/>
+                    <a:lstStyle/>
+                    <a:p>
+                      <a:pPr algn="r"/>
+                      <a:r>
+                        <a:rPr sz="1300" b="0">
+                          <a:solidFill>
+                            <a:srgbClr val="3C3C3B"/>
+                          </a:solidFill>
+                          <a:latin typeface="Aptos"/>
+                        </a:rPr>
+                        <a:t>8.3%</a:t>
+                      </a:r>
+                    </a:p>
+                  </a:txBody>
+                  <a:tcPr marL="73152" marR="73152" marT="27432" marB="27432" anchor="ctr">
+                    <a:noFill/>
+                  </a:tcPr>
+                </a:tc>
+                <a:tc>
+                  <a:txBody>
+                    <a:bodyPr/>
+                    <a:lstStyle/>
+                    <a:p>
+                      <a:pPr algn="r"/>
+                      <a:r>
+                        <a:rPr sz="1300" b="0">
+                          <a:solidFill>
+                            <a:srgbClr val="3C3C3B"/>
+                          </a:solidFill>
+                          <a:latin typeface="Aptos"/>
+                        </a:rPr>
+                        <a:t>9.5%</a:t>
+                      </a:r>
+                    </a:p>
+                  </a:txBody>
+                  <a:tcPr marL="73152" marR="73152" marT="27432" marB="27432" anchor="ctr">
+                    <a:noFill/>
+                  </a:tcPr>
+                </a:tc>
+                <a:tc>
+                  <a:txBody>
+                    <a:bodyPr/>
+                    <a:lstStyle/>
+                    <a:p>
+                      <a:pPr algn="r"/>
+                      <a:r>
+                        <a:rPr sz="1300" b="0">
+                          <a:solidFill>
+                            <a:srgbClr val="3C3C3B"/>
+                          </a:solidFill>
+                          <a:latin typeface="Aptos"/>
+                        </a:rPr>
+                        <a:t>13.8%</a:t>
+                      </a:r>
+                    </a:p>
+                  </a:txBody>
+                  <a:tcPr marL="73152" marR="73152" marT="27432" marB="27432" anchor="ctr">
+                    <a:noFill/>
+                  </a:tcPr>
+                </a:tc>
+                <a:tc>
+                  <a:txBody>
+                    <a:bodyPr/>
+                    <a:lstStyle/>
+                    <a:p>
+                      <a:pPr algn="r"/>
+                      <a:r>
+                        <a:rPr sz="1300" b="0">
+                          <a:solidFill>
+                            <a:srgbClr val="3C3C3B"/>
+                          </a:solidFill>
+                          <a:latin typeface="Aptos"/>
+                        </a:rPr>
+                        <a:t>2.10x</a:t>
+                      </a:r>
+                    </a:p>
+                  </a:txBody>
+                  <a:tcPr marL="73152" marR="73152" marT="27432" marB="27432" anchor="ctr">
+                    <a:noFill/>
+                  </a:tcPr>
+                </a:tc>
+                <a:tc>
+                  <a:txBody>
+                    <a:bodyPr/>
+                    <a:lstStyle/>
+                    <a:p>
+                      <a:pPr algn="r"/>
+                      <a:r>
+                        <a:rPr sz="1300" b="0">
+                          <a:solidFill>
+                            <a:srgbClr val="3C3C3B"/>
+                          </a:solidFill>
+                          <a:latin typeface="Aptos"/>
+                        </a:rPr>
+                        <a:t>2.79x</a:t>
                       </a:r>
                     </a:p>
                   </a:txBody>
@@ -19704,28 +19704,28 @@
                           </a:solidFill>
                           <a:latin typeface="Aptos"/>
                         </a:rPr>
-                        <a:t>25.9%</a:t>
-                      </a:r>
-                    </a:p>
-                  </a:txBody>
-                  <a:tcPr marL="73152" marR="73152" marT="27432" marB="27432" anchor="ctr">
-                    <a:noFill/>
-                  </a:tcPr>
-                </a:tc>
-                <a:tc>
-                  <a:txBody>
-                    <a:bodyPr/>
-                    <a:lstStyle/>
-                    <a:p>
-                      <a:pPr algn="r"/>
-                      <a:r>
-                        <a:rPr sz="1300" b="0">
-                          <a:solidFill>
-                            <a:srgbClr val="3C3C3B"/>
-                          </a:solidFill>
-                          <a:latin typeface="Aptos"/>
-                        </a:rPr>
-                        <a:t>40.7%</a:t>
+                        <a:t>23.8%</a:t>
+                      </a:r>
+                    </a:p>
+                  </a:txBody>
+                  <a:tcPr marL="73152" marR="73152" marT="27432" marB="27432" anchor="ctr">
+                    <a:noFill/>
+                  </a:tcPr>
+                </a:tc>
+                <a:tc>
+                  <a:txBody>
+                    <a:bodyPr/>
+                    <a:lstStyle/>
+                    <a:p>
+                      <a:pPr algn="r"/>
+                      <a:r>
+                        <a:rPr sz="1300" b="0">
+                          <a:solidFill>
+                            <a:srgbClr val="3C3C3B"/>
+                          </a:solidFill>
+                          <a:latin typeface="Aptos"/>
+                        </a:rPr>
+                        <a:t>38.6%</a:t>
                       </a:r>
                     </a:p>
                   </a:txBody>
@@ -19788,70 +19788,70 @@
                           </a:solidFill>
                           <a:latin typeface="Aptos"/>
                         </a:rPr>
-                        <a:t>7.7%</a:t>
-                      </a:r>
-                    </a:p>
-                  </a:txBody>
-                  <a:tcPr marL="73152" marR="73152" marT="27432" marB="27432" anchor="ctr">
-                    <a:noFill/>
-                  </a:tcPr>
-                </a:tc>
-                <a:tc>
-                  <a:txBody>
-                    <a:bodyPr/>
-                    <a:lstStyle/>
-                    <a:p>
-                      <a:pPr algn="r"/>
-                      <a:r>
-                        <a:rPr sz="1300" b="0">
-                          <a:solidFill>
-                            <a:srgbClr val="3C3C3B"/>
-                          </a:solidFill>
-                          <a:latin typeface="Aptos"/>
-                        </a:rPr>
-                        <a:t>11.6%</a:t>
-                      </a:r>
-                    </a:p>
-                  </a:txBody>
-                  <a:tcPr marL="73152" marR="73152" marT="27432" marB="27432" anchor="ctr">
-                    <a:noFill/>
-                  </a:tcPr>
-                </a:tc>
-                <a:tc>
-                  <a:txBody>
-                    <a:bodyPr/>
-                    <a:lstStyle/>
-                    <a:p>
-                      <a:pPr algn="r"/>
-                      <a:r>
-                        <a:rPr sz="1300" b="0">
-                          <a:solidFill>
-                            <a:srgbClr val="3C3C3B"/>
-                          </a:solidFill>
-                          <a:latin typeface="Aptos"/>
-                        </a:rPr>
-                        <a:t>1.91x</a:t>
-                      </a:r>
-                    </a:p>
-                  </a:txBody>
-                  <a:tcPr marL="73152" marR="73152" marT="27432" marB="27432" anchor="ctr">
-                    <a:noFill/>
-                  </a:tcPr>
-                </a:tc>
-                <a:tc>
-                  <a:txBody>
-                    <a:bodyPr/>
-                    <a:lstStyle/>
-                    <a:p>
-                      <a:pPr algn="r"/>
-                      <a:r>
-                        <a:rPr sz="1300" b="0">
-                          <a:solidFill>
-                            <a:srgbClr val="3C3C3B"/>
-                          </a:solidFill>
-                          <a:latin typeface="Aptos"/>
-                        </a:rPr>
-                        <a:t>2.53x</a:t>
+                        <a:t>7.5%</a:t>
+                      </a:r>
+                    </a:p>
+                  </a:txBody>
+                  <a:tcPr marL="73152" marR="73152" marT="27432" marB="27432" anchor="ctr">
+                    <a:noFill/>
+                  </a:tcPr>
+                </a:tc>
+                <a:tc>
+                  <a:txBody>
+                    <a:bodyPr/>
+                    <a:lstStyle/>
+                    <a:p>
+                      <a:pPr algn="r"/>
+                      <a:r>
+                        <a:rPr sz="1300" b="0">
+                          <a:solidFill>
+                            <a:srgbClr val="3C3C3B"/>
+                          </a:solidFill>
+                          <a:latin typeface="Aptos"/>
+                        </a:rPr>
+                        <a:t>11.3%</a:t>
+                      </a:r>
+                    </a:p>
+                  </a:txBody>
+                  <a:tcPr marL="73152" marR="73152" marT="27432" marB="27432" anchor="ctr">
+                    <a:noFill/>
+                  </a:tcPr>
+                </a:tc>
+                <a:tc>
+                  <a:txBody>
+                    <a:bodyPr/>
+                    <a:lstStyle/>
+                    <a:p>
+                      <a:pPr algn="r"/>
+                      <a:r>
+                        <a:rPr sz="1300" b="0">
+                          <a:solidFill>
+                            <a:srgbClr val="3C3C3B"/>
+                          </a:solidFill>
+                          <a:latin typeface="Aptos"/>
+                        </a:rPr>
+                        <a:t>1.88x</a:t>
+                      </a:r>
+                    </a:p>
+                  </a:txBody>
+                  <a:tcPr marL="73152" marR="73152" marT="27432" marB="27432" anchor="ctr">
+                    <a:noFill/>
+                  </a:tcPr>
+                </a:tc>
+                <a:tc>
+                  <a:txBody>
+                    <a:bodyPr/>
+                    <a:lstStyle/>
+                    <a:p>
+                      <a:pPr algn="r"/>
+                      <a:r>
+                        <a:rPr sz="1300" b="0">
+                          <a:solidFill>
+                            <a:srgbClr val="3C3C3B"/>
+                          </a:solidFill>
+                          <a:latin typeface="Aptos"/>
+                        </a:rPr>
+                        <a:t>2.48x</a:t>
                       </a:r>
                     </a:p>
                   </a:txBody>
@@ -19918,28 +19918,28 @@
                           </a:solidFill>
                           <a:latin typeface="Aptos"/>
                         </a:rPr>
-                        <a:t>27.8%</a:t>
-                      </a:r>
-                    </a:p>
-                  </a:txBody>
-                  <a:tcPr marL="73152" marR="73152" marT="27432" marB="27432" anchor="ctr">
-                    <a:noFill/>
-                  </a:tcPr>
-                </a:tc>
-                <a:tc>
-                  <a:txBody>
-                    <a:bodyPr/>
-                    <a:lstStyle/>
-                    <a:p>
-                      <a:pPr algn="r"/>
-                      <a:r>
-                        <a:rPr sz="1300" b="0">
-                          <a:solidFill>
-                            <a:srgbClr val="3C3C3B"/>
-                          </a:solidFill>
-                          <a:latin typeface="Aptos"/>
-                        </a:rPr>
-                        <a:t>42.7%</a:t>
+                        <a:t>25.7%</a:t>
+                      </a:r>
+                    </a:p>
+                  </a:txBody>
+                  <a:tcPr marL="73152" marR="73152" marT="27432" marB="27432" anchor="ctr">
+                    <a:noFill/>
+                  </a:tcPr>
+                </a:tc>
+                <a:tc>
+                  <a:txBody>
+                    <a:bodyPr/>
+                    <a:lstStyle/>
+                    <a:p>
+                      <a:pPr algn="r"/>
+                      <a:r>
+                        <a:rPr sz="1300" b="0">
+                          <a:solidFill>
+                            <a:srgbClr val="3C3C3B"/>
+                          </a:solidFill>
+                          <a:latin typeface="Aptos"/>
+                        </a:rPr>
+                        <a:t>40.6%</a:t>
                       </a:r>
                     </a:p>
                   </a:txBody>
@@ -20002,70 +20002,70 @@
                           </a:solidFill>
                           <a:latin typeface="Aptos"/>
                         </a:rPr>
-                        <a:t>7.5%</a:t>
-                      </a:r>
-                    </a:p>
-                  </a:txBody>
-                  <a:tcPr marL="73152" marR="73152" marT="27432" marB="27432" anchor="ctr">
-                    <a:noFill/>
-                  </a:tcPr>
-                </a:tc>
-                <a:tc>
-                  <a:txBody>
-                    <a:bodyPr/>
-                    <a:lstStyle/>
-                    <a:p>
-                      <a:pPr algn="r"/>
-                      <a:r>
-                        <a:rPr sz="1300" b="0">
-                          <a:solidFill>
-                            <a:srgbClr val="3C3C3B"/>
-                          </a:solidFill>
-                          <a:latin typeface="Aptos"/>
-                        </a:rPr>
-                        <a:t>11.6%</a:t>
-                      </a:r>
-                    </a:p>
-                  </a:txBody>
-                  <a:tcPr marL="73152" marR="73152" marT="27432" marB="27432" anchor="ctr">
-                    <a:noFill/>
-                  </a:tcPr>
-                </a:tc>
-                <a:tc>
-                  <a:txBody>
-                    <a:bodyPr/>
-                    <a:lstStyle/>
-                    <a:p>
-                      <a:pPr algn="r"/>
-                      <a:r>
-                        <a:rPr sz="1300" b="0">
-                          <a:solidFill>
-                            <a:srgbClr val="3C3C3B"/>
-                          </a:solidFill>
-                          <a:latin typeface="Aptos"/>
-                        </a:rPr>
-                        <a:t>1.76x</a:t>
-                      </a:r>
-                    </a:p>
-                  </a:txBody>
-                  <a:tcPr marL="73152" marR="73152" marT="27432" marB="27432" anchor="ctr">
-                    <a:noFill/>
-                  </a:tcPr>
-                </a:tc>
-                <a:tc>
-                  <a:txBody>
-                    <a:bodyPr/>
-                    <a:lstStyle/>
-                    <a:p>
-                      <a:pPr algn="r"/>
-                      <a:r>
-                        <a:rPr sz="1300" b="0">
-                          <a:solidFill>
-                            <a:srgbClr val="3C3C3B"/>
-                          </a:solidFill>
-                          <a:latin typeface="Aptos"/>
-                        </a:rPr>
-                        <a:t>2.34x</a:t>
+                        <a:t>7.3%</a:t>
+                      </a:r>
+                    </a:p>
+                  </a:txBody>
+                  <a:tcPr marL="73152" marR="73152" marT="27432" marB="27432" anchor="ctr">
+                    <a:noFill/>
+                  </a:tcPr>
+                </a:tc>
+                <a:tc>
+                  <a:txBody>
+                    <a:bodyPr/>
+                    <a:lstStyle/>
+                    <a:p>
+                      <a:pPr algn="r"/>
+                      <a:r>
+                        <a:rPr sz="1300" b="0">
+                          <a:solidFill>
+                            <a:srgbClr val="3C3C3B"/>
+                          </a:solidFill>
+                          <a:latin typeface="Aptos"/>
+                        </a:rPr>
+                        <a:t>11.3%</a:t>
+                      </a:r>
+                    </a:p>
+                  </a:txBody>
+                  <a:tcPr marL="73152" marR="73152" marT="27432" marB="27432" anchor="ctr">
+                    <a:noFill/>
+                  </a:tcPr>
+                </a:tc>
+                <a:tc>
+                  <a:txBody>
+                    <a:bodyPr/>
+                    <a:lstStyle/>
+                    <a:p>
+                      <a:pPr algn="r"/>
+                      <a:r>
+                        <a:rPr sz="1300" b="0">
+                          <a:solidFill>
+                            <a:srgbClr val="3C3C3B"/>
+                          </a:solidFill>
+                          <a:latin typeface="Aptos"/>
+                        </a:rPr>
+                        <a:t>1.74x</a:t>
+                      </a:r>
+                    </a:p>
+                  </a:txBody>
+                  <a:tcPr marL="73152" marR="73152" marT="27432" marB="27432" anchor="ctr">
+                    <a:noFill/>
+                  </a:tcPr>
+                </a:tc>
+                <a:tc>
+                  <a:txBody>
+                    <a:bodyPr/>
+                    <a:lstStyle/>
+                    <a:p>
+                      <a:pPr algn="r"/>
+                      <a:r>
+                        <a:rPr sz="1300" b="0">
+                          <a:solidFill>
+                            <a:srgbClr val="3C3C3B"/>
+                          </a:solidFill>
+                          <a:latin typeface="Aptos"/>
+                        </a:rPr>
+                        <a:t>2.30x</a:t>
                       </a:r>
                     </a:p>
                   </a:txBody>
@@ -20132,28 +20132,28 @@
                           </a:solidFill>
                           <a:latin typeface="Aptos"/>
                         </a:rPr>
-                        <a:t>28.4%</a:t>
-                      </a:r>
-                    </a:p>
-                  </a:txBody>
-                  <a:tcPr marL="73152" marR="73152" marT="27432" marB="27432" anchor="ctr">
-                    <a:noFill/>
-                  </a:tcPr>
-                </a:tc>
-                <a:tc>
-                  <a:txBody>
-                    <a:bodyPr/>
-                    <a:lstStyle/>
-                    <a:p>
-                      <a:pPr algn="r"/>
-                      <a:r>
-                        <a:rPr sz="1300" b="0">
-                          <a:solidFill>
-                            <a:srgbClr val="3C3C3B"/>
-                          </a:solidFill>
-                          <a:latin typeface="Aptos"/>
-                        </a:rPr>
-                        <a:t>43.2%</a:t>
+                        <a:t>26.3%</a:t>
+                      </a:r>
+                    </a:p>
+                  </a:txBody>
+                  <a:tcPr marL="73152" marR="73152" marT="27432" marB="27432" anchor="ctr">
+                    <a:noFill/>
+                  </a:tcPr>
+                </a:tc>
+                <a:tc>
+                  <a:txBody>
+                    <a:bodyPr/>
+                    <a:lstStyle/>
+                    <a:p>
+                      <a:pPr algn="r"/>
+                      <a:r>
+                        <a:rPr sz="1300" b="0">
+                          <a:solidFill>
+                            <a:srgbClr val="3C3C3B"/>
+                          </a:solidFill>
+                          <a:latin typeface="Aptos"/>
+                        </a:rPr>
+                        <a:t>41.0%</a:t>
                       </a:r>
                     </a:p>
                   </a:txBody>
@@ -20216,70 +20216,70 @@
                           </a:solidFill>
                           <a:latin typeface="Aptos"/>
                         </a:rPr>
-                        <a:t>7.4%</a:t>
-                      </a:r>
-                    </a:p>
-                  </a:txBody>
-                  <a:tcPr marL="73152" marR="73152" marT="27432" marB="27432" anchor="ctr">
-                    <a:noFill/>
-                  </a:tcPr>
-                </a:tc>
-                <a:tc>
-                  <a:txBody>
-                    <a:bodyPr/>
-                    <a:lstStyle/>
-                    <a:p>
-                      <a:pPr algn="r"/>
-                      <a:r>
-                        <a:rPr sz="1300" b="0">
-                          <a:solidFill>
-                            <a:srgbClr val="3C3C3B"/>
-                          </a:solidFill>
-                          <a:latin typeface="Aptos"/>
-                        </a:rPr>
-                        <a:t>10.9%</a:t>
-                      </a:r>
-                    </a:p>
-                  </a:txBody>
-                  <a:tcPr marL="73152" marR="73152" marT="27432" marB="27432" anchor="ctr">
-                    <a:noFill/>
-                  </a:tcPr>
-                </a:tc>
-                <a:tc>
-                  <a:txBody>
-                    <a:bodyPr/>
-                    <a:lstStyle/>
-                    <a:p>
-                      <a:pPr algn="r"/>
-                      <a:r>
-                        <a:rPr sz="1300" b="0">
-                          <a:solidFill>
-                            <a:srgbClr val="3C3C3B"/>
-                          </a:solidFill>
-                          <a:latin typeface="Aptos"/>
-                        </a:rPr>
-                        <a:t>1.25x</a:t>
-                      </a:r>
-                    </a:p>
-                  </a:txBody>
-                  <a:tcPr marL="73152" marR="73152" marT="27432" marB="27432" anchor="ctr">
-                    <a:noFill/>
-                  </a:tcPr>
-                </a:tc>
-                <a:tc>
-                  <a:txBody>
-                    <a:bodyPr/>
-                    <a:lstStyle/>
-                    <a:p>
-                      <a:pPr algn="r"/>
-                      <a:r>
-                        <a:rPr sz="1300" b="0">
-                          <a:solidFill>
-                            <a:srgbClr val="3C3C3B"/>
-                          </a:solidFill>
-                          <a:latin typeface="Aptos"/>
-                        </a:rPr>
-                        <a:t>1.66x</a:t>
+                        <a:t>7.2%</a:t>
+                      </a:r>
+                    </a:p>
+                  </a:txBody>
+                  <a:tcPr marL="73152" marR="73152" marT="27432" marB="27432" anchor="ctr">
+                    <a:noFill/>
+                  </a:tcPr>
+                </a:tc>
+                <a:tc>
+                  <a:txBody>
+                    <a:bodyPr/>
+                    <a:lstStyle/>
+                    <a:p>
+                      <a:pPr algn="r"/>
+                      <a:r>
+                        <a:rPr sz="1300" b="0">
+                          <a:solidFill>
+                            <a:srgbClr val="3C3C3B"/>
+                          </a:solidFill>
+                          <a:latin typeface="Aptos"/>
+                        </a:rPr>
+                        <a:t>10.7%</a:t>
+                      </a:r>
+                    </a:p>
+                  </a:txBody>
+                  <a:tcPr marL="73152" marR="73152" marT="27432" marB="27432" anchor="ctr">
+                    <a:noFill/>
+                  </a:tcPr>
+                </a:tc>
+                <a:tc>
+                  <a:txBody>
+                    <a:bodyPr/>
+                    <a:lstStyle/>
+                    <a:p>
+                      <a:pPr algn="r"/>
+                      <a:r>
+                        <a:rPr sz="1300" b="0">
+                          <a:solidFill>
+                            <a:srgbClr val="3C3C3B"/>
+                          </a:solidFill>
+                          <a:latin typeface="Aptos"/>
+                        </a:rPr>
+                        <a:t>1.24x</a:t>
+                      </a:r>
+                    </a:p>
+                  </a:txBody>
+                  <a:tcPr marL="73152" marR="73152" marT="27432" marB="27432" anchor="ctr">
+                    <a:noFill/>
+                  </a:tcPr>
+                </a:tc>
+                <a:tc>
+                  <a:txBody>
+                    <a:bodyPr/>
+                    <a:lstStyle/>
+                    <a:p>
+                      <a:pPr algn="r"/>
+                      <a:r>
+                        <a:rPr sz="1300" b="0">
+                          <a:solidFill>
+                            <a:srgbClr val="3C3C3B"/>
+                          </a:solidFill>
+                          <a:latin typeface="Aptos"/>
+                        </a:rPr>
+                        <a:t>1.63x</a:t>
                       </a:r>
                     </a:p>
                   </a:txBody>
@@ -20346,28 +20346,28 @@
                           </a:solidFill>
                           <a:latin typeface="Aptos"/>
                         </a:rPr>
-                        <a:t>28.4%</a:t>
-                      </a:r>
-                    </a:p>
-                  </a:txBody>
-                  <a:tcPr marL="73152" marR="73152" marT="27432" marB="27432" anchor="ctr">
-                    <a:noFill/>
-                  </a:tcPr>
-                </a:tc>
-                <a:tc>
-                  <a:txBody>
-                    <a:bodyPr/>
-                    <a:lstStyle/>
-                    <a:p>
-                      <a:pPr algn="r"/>
-                      <a:r>
-                        <a:rPr sz="1300" b="0">
-                          <a:solidFill>
-                            <a:srgbClr val="3C3C3B"/>
-                          </a:solidFill>
-                          <a:latin typeface="Aptos"/>
-                        </a:rPr>
-                        <a:t>43.2%</a:t>
+                        <a:t>26.3%</a:t>
+                      </a:r>
+                    </a:p>
+                  </a:txBody>
+                  <a:tcPr marL="73152" marR="73152" marT="27432" marB="27432" anchor="ctr">
+                    <a:noFill/>
+                  </a:tcPr>
+                </a:tc>
+                <a:tc>
+                  <a:txBody>
+                    <a:bodyPr/>
+                    <a:lstStyle/>
+                    <a:p>
+                      <a:pPr algn="r"/>
+                      <a:r>
+                        <a:rPr sz="1300" b="0">
+                          <a:solidFill>
+                            <a:srgbClr val="3C3C3B"/>
+                          </a:solidFill>
+                          <a:latin typeface="Aptos"/>
+                        </a:rPr>
+                        <a:t>41.0%</a:t>
                       </a:r>
                     </a:p>
                   </a:txBody>
@@ -20409,91 +20409,91 @@
                           </a:solidFill>
                           <a:latin typeface="Aptos"/>
                         </a:rPr>
-                        <a:t>4.9%</a:t>
-                      </a:r>
-                    </a:p>
-                  </a:txBody>
-                  <a:tcPr marL="73152" marR="73152" marT="27432" marB="27432" anchor="ctr">
-                    <a:noFill/>
-                  </a:tcPr>
-                </a:tc>
-                <a:tc>
-                  <a:txBody>
-                    <a:bodyPr/>
-                    <a:lstStyle/>
-                    <a:p>
-                      <a:pPr algn="r"/>
-                      <a:r>
-                        <a:rPr sz="1300" b="0">
-                          <a:solidFill>
-                            <a:srgbClr val="3C3C3B"/>
-                          </a:solidFill>
-                          <a:latin typeface="Aptos"/>
-                        </a:rPr>
-                        <a:t>6.1%</a:t>
-                      </a:r>
-                    </a:p>
-                  </a:txBody>
-                  <a:tcPr marL="73152" marR="73152" marT="27432" marB="27432" anchor="ctr">
-                    <a:noFill/>
-                  </a:tcPr>
-                </a:tc>
-                <a:tc>
-                  <a:txBody>
-                    <a:bodyPr/>
-                    <a:lstStyle/>
-                    <a:p>
-                      <a:pPr algn="r"/>
-                      <a:r>
-                        <a:rPr sz="1300" b="0">
-                          <a:solidFill>
-                            <a:srgbClr val="3C3C3B"/>
-                          </a:solidFill>
-                          <a:latin typeface="Aptos"/>
-                        </a:rPr>
-                        <a:t>9.1%</a:t>
-                      </a:r>
-                    </a:p>
-                  </a:txBody>
-                  <a:tcPr marL="73152" marR="73152" marT="27432" marB="27432" anchor="ctr">
-                    <a:noFill/>
-                  </a:tcPr>
-                </a:tc>
-                <a:tc>
-                  <a:txBody>
-                    <a:bodyPr/>
-                    <a:lstStyle/>
-                    <a:p>
-                      <a:pPr algn="r"/>
-                      <a:r>
-                        <a:rPr sz="1300" b="0">
-                          <a:solidFill>
-                            <a:srgbClr val="3C3C3B"/>
-                          </a:solidFill>
-                          <a:latin typeface="Aptos"/>
-                        </a:rPr>
-                        <a:t>1.76x</a:t>
-                      </a:r>
-                    </a:p>
-                  </a:txBody>
-                  <a:tcPr marL="73152" marR="73152" marT="27432" marB="27432" anchor="ctr">
-                    <a:noFill/>
-                  </a:tcPr>
-                </a:tc>
-                <a:tc>
-                  <a:txBody>
-                    <a:bodyPr/>
-                    <a:lstStyle/>
-                    <a:p>
-                      <a:pPr algn="r"/>
-                      <a:r>
-                        <a:rPr sz="1300" b="0">
-                          <a:solidFill>
-                            <a:srgbClr val="3C3C3B"/>
-                          </a:solidFill>
-                          <a:latin typeface="Aptos"/>
-                        </a:rPr>
-                        <a:t>2.16x</a:t>
+                        <a:t>5.0%</a:t>
+                      </a:r>
+                    </a:p>
+                  </a:txBody>
+                  <a:tcPr marL="73152" marR="73152" marT="27432" marB="27432" anchor="ctr">
+                    <a:noFill/>
+                  </a:tcPr>
+                </a:tc>
+                <a:tc>
+                  <a:txBody>
+                    <a:bodyPr/>
+                    <a:lstStyle/>
+                    <a:p>
+                      <a:pPr algn="r"/>
+                      <a:r>
+                        <a:rPr sz="1300" b="0">
+                          <a:solidFill>
+                            <a:srgbClr val="3C3C3B"/>
+                          </a:solidFill>
+                          <a:latin typeface="Aptos"/>
+                        </a:rPr>
+                        <a:t>5.9%</a:t>
+                      </a:r>
+                    </a:p>
+                  </a:txBody>
+                  <a:tcPr marL="73152" marR="73152" marT="27432" marB="27432" anchor="ctr">
+                    <a:noFill/>
+                  </a:tcPr>
+                </a:tc>
+                <a:tc>
+                  <a:txBody>
+                    <a:bodyPr/>
+                    <a:lstStyle/>
+                    <a:p>
+                      <a:pPr algn="r"/>
+                      <a:r>
+                        <a:rPr sz="1300" b="0">
+                          <a:solidFill>
+                            <a:srgbClr val="3C3C3B"/>
+                          </a:solidFill>
+                          <a:latin typeface="Aptos"/>
+                        </a:rPr>
+                        <a:t>8.8%</a:t>
+                      </a:r>
+                    </a:p>
+                  </a:txBody>
+                  <a:tcPr marL="73152" marR="73152" marT="27432" marB="27432" anchor="ctr">
+                    <a:noFill/>
+                  </a:tcPr>
+                </a:tc>
+                <a:tc>
+                  <a:txBody>
+                    <a:bodyPr/>
+                    <a:lstStyle/>
+                    <a:p>
+                      <a:pPr algn="r"/>
+                      <a:r>
+                        <a:rPr sz="1300" b="0">
+                          <a:solidFill>
+                            <a:srgbClr val="3C3C3B"/>
+                          </a:solidFill>
+                          <a:latin typeface="Aptos"/>
+                        </a:rPr>
+                        <a:t>1.74x</a:t>
+                      </a:r>
+                    </a:p>
+                  </a:txBody>
+                  <a:tcPr marL="73152" marR="73152" marT="27432" marB="27432" anchor="ctr">
+                    <a:noFill/>
+                  </a:tcPr>
+                </a:tc>
+                <a:tc>
+                  <a:txBody>
+                    <a:bodyPr/>
+                    <a:lstStyle/>
+                    <a:p>
+                      <a:pPr algn="r"/>
+                      <a:r>
+                        <a:rPr sz="1300" b="0">
+                          <a:solidFill>
+                            <a:srgbClr val="3C3C3B"/>
+                          </a:solidFill>
+                          <a:latin typeface="Aptos"/>
+                        </a:rPr>
+                        <a:t>2.13x</a:t>
                       </a:r>
                     </a:p>
                   </a:txBody>
@@ -20560,28 +20560,28 @@
                           </a:solidFill>
                           <a:latin typeface="Aptos"/>
                         </a:rPr>
-                        <a:t>28.4%</a:t>
-                      </a:r>
-                    </a:p>
-                  </a:txBody>
-                  <a:tcPr marL="73152" marR="73152" marT="27432" marB="27432" anchor="ctr">
-                    <a:noFill/>
-                  </a:tcPr>
-                </a:tc>
-                <a:tc>
-                  <a:txBody>
-                    <a:bodyPr/>
-                    <a:lstStyle/>
-                    <a:p>
-                      <a:pPr algn="r"/>
-                      <a:r>
-                        <a:rPr sz="1300" b="0">
-                          <a:solidFill>
-                            <a:srgbClr val="3C3C3B"/>
-                          </a:solidFill>
-                          <a:latin typeface="Aptos"/>
-                        </a:rPr>
-                        <a:t>43.2%</a:t>
+                        <a:t>26.3%</a:t>
+                      </a:r>
+                    </a:p>
+                  </a:txBody>
+                  <a:tcPr marL="73152" marR="73152" marT="27432" marB="27432" anchor="ctr">
+                    <a:noFill/>
+                  </a:tcPr>
+                </a:tc>
+                <a:tc>
+                  <a:txBody>
+                    <a:bodyPr/>
+                    <a:lstStyle/>
+                    <a:p>
+                      <a:pPr algn="r"/>
+                      <a:r>
+                        <a:rPr sz="1300" b="0">
+                          <a:solidFill>
+                            <a:srgbClr val="3C3C3B"/>
+                          </a:solidFill>
+                          <a:latin typeface="Aptos"/>
+                        </a:rPr>
+                        <a:t>41.0%</a:t>
                       </a:r>
                     </a:p>
                   </a:txBody>
@@ -20644,70 +20644,70 @@
                           </a:solidFill>
                           <a:latin typeface="Aptos"/>
                         </a:rPr>
-                        <a:t>8.3%</a:t>
-                      </a:r>
-                    </a:p>
-                  </a:txBody>
-                  <a:tcPr marL="73152" marR="73152" marT="27432" marB="27432" anchor="ctr">
-                    <a:noFill/>
-                  </a:tcPr>
-                </a:tc>
-                <a:tc>
-                  <a:txBody>
-                    <a:bodyPr/>
-                    <a:lstStyle/>
-                    <a:p>
-                      <a:pPr algn="r"/>
-                      <a:r>
-                        <a:rPr sz="1300" b="0">
-                          <a:solidFill>
-                            <a:srgbClr val="3C3C3B"/>
-                          </a:solidFill>
-                          <a:latin typeface="Aptos"/>
-                        </a:rPr>
-                        <a:t>12.5%</a:t>
-                      </a:r>
-                    </a:p>
-                  </a:txBody>
-                  <a:tcPr marL="73152" marR="73152" marT="27432" marB="27432" anchor="ctr">
-                    <a:noFill/>
-                  </a:tcPr>
-                </a:tc>
-                <a:tc>
-                  <a:txBody>
-                    <a:bodyPr/>
-                    <a:lstStyle/>
-                    <a:p>
-                      <a:pPr algn="r"/>
-                      <a:r>
-                        <a:rPr sz="1300" b="0">
-                          <a:solidFill>
-                            <a:srgbClr val="3C3C3B"/>
-                          </a:solidFill>
-                          <a:latin typeface="Aptos"/>
-                        </a:rPr>
-                        <a:t>1.94x</a:t>
-                      </a:r>
-                    </a:p>
-                  </a:txBody>
-                  <a:tcPr marL="73152" marR="73152" marT="27432" marB="27432" anchor="ctr">
-                    <a:noFill/>
-                  </a:tcPr>
-                </a:tc>
-                <a:tc>
-                  <a:txBody>
-                    <a:bodyPr/>
-                    <a:lstStyle/>
-                    <a:p>
-                      <a:pPr algn="r"/>
-                      <a:r>
-                        <a:rPr sz="1300" b="0">
-                          <a:solidFill>
-                            <a:srgbClr val="3C3C3B"/>
-                          </a:solidFill>
-                          <a:latin typeface="Aptos"/>
-                        </a:rPr>
-                        <a:t>2.60x</a:t>
+                        <a:t>8.1%</a:t>
+                      </a:r>
+                    </a:p>
+                  </a:txBody>
+                  <a:tcPr marL="73152" marR="73152" marT="27432" marB="27432" anchor="ctr">
+                    <a:noFill/>
+                  </a:tcPr>
+                </a:tc>
+                <a:tc>
+                  <a:txBody>
+                    <a:bodyPr/>
+                    <a:lstStyle/>
+                    <a:p>
+                      <a:pPr algn="r"/>
+                      <a:r>
+                        <a:rPr sz="1300" b="0">
+                          <a:solidFill>
+                            <a:srgbClr val="3C3C3B"/>
+                          </a:solidFill>
+                          <a:latin typeface="Aptos"/>
+                        </a:rPr>
+                        <a:t>12.2%</a:t>
+                      </a:r>
+                    </a:p>
+                  </a:txBody>
+                  <a:tcPr marL="73152" marR="73152" marT="27432" marB="27432" anchor="ctr">
+                    <a:noFill/>
+                  </a:tcPr>
+                </a:tc>
+                <a:tc>
+                  <a:txBody>
+                    <a:bodyPr/>
+                    <a:lstStyle/>
+                    <a:p>
+                      <a:pPr algn="r"/>
+                      <a:r>
+                        <a:rPr sz="1300" b="0">
+                          <a:solidFill>
+                            <a:srgbClr val="3C3C3B"/>
+                          </a:solidFill>
+                          <a:latin typeface="Aptos"/>
+                        </a:rPr>
+                        <a:t>1.91x</a:t>
+                      </a:r>
+                    </a:p>
+                  </a:txBody>
+                  <a:tcPr marL="73152" marR="73152" marT="27432" marB="27432" anchor="ctr">
+                    <a:noFill/>
+                  </a:tcPr>
+                </a:tc>
+                <a:tc>
+                  <a:txBody>
+                    <a:bodyPr/>
+                    <a:lstStyle/>
+                    <a:p>
+                      <a:pPr algn="r"/>
+                      <a:r>
+                        <a:rPr sz="1300" b="0">
+                          <a:solidFill>
+                            <a:srgbClr val="3C3C3B"/>
+                          </a:solidFill>
+                          <a:latin typeface="Aptos"/>
+                        </a:rPr>
+                        <a:t>2.55x</a:t>
                       </a:r>
                     </a:p>
                   </a:txBody>
@@ -20774,28 +20774,28 @@
                           </a:solidFill>
                           <a:latin typeface="Aptos"/>
                         </a:rPr>
-                        <a:t>28.3%</a:t>
-                      </a:r>
-                    </a:p>
-                  </a:txBody>
-                  <a:tcPr marL="73152" marR="73152" marT="27432" marB="27432" anchor="ctr">
-                    <a:noFill/>
-                  </a:tcPr>
-                </a:tc>
-                <a:tc>
-                  <a:txBody>
-                    <a:bodyPr/>
-                    <a:lstStyle/>
-                    <a:p>
-                      <a:pPr algn="r"/>
-                      <a:r>
-                        <a:rPr sz="1300" b="0">
-                          <a:solidFill>
-                            <a:srgbClr val="3C3C3B"/>
-                          </a:solidFill>
-                          <a:latin typeface="Aptos"/>
-                        </a:rPr>
-                        <a:t>47.4%</a:t>
+                        <a:t>26.0%</a:t>
+                      </a:r>
+                    </a:p>
+                  </a:txBody>
+                  <a:tcPr marL="73152" marR="73152" marT="27432" marB="27432" anchor="ctr">
+                    <a:noFill/>
+                  </a:tcPr>
+                </a:tc>
+                <a:tc>
+                  <a:txBody>
+                    <a:bodyPr/>
+                    <a:lstStyle/>
+                    <a:p>
+                      <a:pPr algn="r"/>
+                      <a:r>
+                        <a:rPr sz="1300" b="0">
+                          <a:solidFill>
+                            <a:srgbClr val="3C3C3B"/>
+                          </a:solidFill>
+                          <a:latin typeface="Aptos"/>
+                        </a:rPr>
+                        <a:t>45.2%</a:t>
                       </a:r>
                     </a:p>
                   </a:txBody>
@@ -20858,70 +20858,70 @@
                           </a:solidFill>
                           <a:latin typeface="Aptos"/>
                         </a:rPr>
-                        <a:t>8.0%</a:t>
-                      </a:r>
-                    </a:p>
-                  </a:txBody>
-                  <a:tcPr marL="73152" marR="73152" marT="27432" marB="27432" anchor="ctr">
-                    <a:noFill/>
-                  </a:tcPr>
-                </a:tc>
-                <a:tc>
-                  <a:txBody>
-                    <a:bodyPr/>
-                    <a:lstStyle/>
-                    <a:p>
-                      <a:pPr algn="r"/>
-                      <a:r>
-                        <a:rPr sz="1300" b="0">
-                          <a:solidFill>
-                            <a:srgbClr val="3C3C3B"/>
-                          </a:solidFill>
-                          <a:latin typeface="Aptos"/>
-                        </a:rPr>
-                        <a:t>13.4%</a:t>
-                      </a:r>
-                    </a:p>
-                  </a:txBody>
-                  <a:tcPr marL="73152" marR="73152" marT="27432" marB="27432" anchor="ctr">
-                    <a:noFill/>
-                  </a:tcPr>
-                </a:tc>
-                <a:tc>
-                  <a:txBody>
-                    <a:bodyPr/>
-                    <a:lstStyle/>
-                    <a:p>
-                      <a:pPr algn="r"/>
-                      <a:r>
-                        <a:rPr sz="1300" b="0">
-                          <a:solidFill>
-                            <a:srgbClr val="3C3C3B"/>
-                          </a:solidFill>
-                          <a:latin typeface="Aptos"/>
-                        </a:rPr>
-                        <a:t>1.93x</a:t>
-                      </a:r>
-                    </a:p>
-                  </a:txBody>
-                  <a:tcPr marL="73152" marR="73152" marT="27432" marB="27432" anchor="ctr">
-                    <a:noFill/>
-                  </a:tcPr>
-                </a:tc>
-                <a:tc>
-                  <a:txBody>
-                    <a:bodyPr/>
-                    <a:lstStyle/>
-                    <a:p>
-                      <a:pPr algn="r"/>
-                      <a:r>
-                        <a:rPr sz="1300" b="0">
-                          <a:solidFill>
-                            <a:srgbClr val="3C3C3B"/>
-                          </a:solidFill>
-                          <a:latin typeface="Aptos"/>
-                        </a:rPr>
-                        <a:t>2.00x</a:t>
+                        <a:t>7.7%</a:t>
+                      </a:r>
+                    </a:p>
+                  </a:txBody>
+                  <a:tcPr marL="73152" marR="73152" marT="27432" marB="27432" anchor="ctr">
+                    <a:noFill/>
+                  </a:tcPr>
+                </a:tc>
+                <a:tc>
+                  <a:txBody>
+                    <a:bodyPr/>
+                    <a:lstStyle/>
+                    <a:p>
+                      <a:pPr algn="r"/>
+                      <a:r>
+                        <a:rPr sz="1300" b="0">
+                          <a:solidFill>
+                            <a:srgbClr val="3C3C3B"/>
+                          </a:solidFill>
+                          <a:latin typeface="Aptos"/>
+                        </a:rPr>
+                        <a:t>13.0%</a:t>
+                      </a:r>
+                    </a:p>
+                  </a:txBody>
+                  <a:tcPr marL="73152" marR="73152" marT="27432" marB="27432" anchor="ctr">
+                    <a:noFill/>
+                  </a:tcPr>
+                </a:tc>
+                <a:tc>
+                  <a:txBody>
+                    <a:bodyPr/>
+                    <a:lstStyle/>
+                    <a:p>
+                      <a:pPr algn="r"/>
+                      <a:r>
+                        <a:rPr sz="1300" b="0">
+                          <a:solidFill>
+                            <a:srgbClr val="3C3C3B"/>
+                          </a:solidFill>
+                          <a:latin typeface="Aptos"/>
+                        </a:rPr>
+                        <a:t>1.94x</a:t>
+                      </a:r>
+                    </a:p>
+                  </a:txBody>
+                  <a:tcPr marL="73152" marR="73152" marT="27432" marB="27432" anchor="ctr">
+                    <a:noFill/>
+                  </a:tcPr>
+                </a:tc>
+                <a:tc>
+                  <a:txBody>
+                    <a:bodyPr/>
+                    <a:lstStyle/>
+                    <a:p>
+                      <a:pPr algn="r"/>
+                      <a:r>
+                        <a:rPr sz="1300" b="0">
+                          <a:solidFill>
+                            <a:srgbClr val="3C3C3B"/>
+                          </a:solidFill>
+                          <a:latin typeface="Aptos"/>
+                        </a:rPr>
+                        <a:t>1.97x</a:t>
                       </a:r>
                     </a:p>
                   </a:txBody>
@@ -20988,28 +20988,28 @@
                           </a:solidFill>
                           <a:latin typeface="Aptos"/>
                         </a:rPr>
-                        <a:t>23.4%</a:t>
-                      </a:r>
-                    </a:p>
-                  </a:txBody>
-                  <a:tcPr marL="73152" marR="73152" marT="27432" marB="27432" anchor="ctr">
-                    <a:noFill/>
-                  </a:tcPr>
-                </a:tc>
-                <a:tc>
-                  <a:txBody>
-                    <a:bodyPr/>
-                    <a:lstStyle/>
-                    <a:p>
-                      <a:pPr algn="r"/>
-                      <a:r>
-                        <a:rPr sz="1300" b="0">
-                          <a:solidFill>
-                            <a:srgbClr val="3C3C3B"/>
-                          </a:solidFill>
-                          <a:latin typeface="Aptos"/>
-                        </a:rPr>
-                        <a:t>38.0%</a:t>
+                        <a:t>18.1%</a:t>
+                      </a:r>
+                    </a:p>
+                  </a:txBody>
+                  <a:tcPr marL="73152" marR="73152" marT="27432" marB="27432" anchor="ctr">
+                    <a:noFill/>
+                  </a:tcPr>
+                </a:tc>
+                <a:tc>
+                  <a:txBody>
+                    <a:bodyPr/>
+                    <a:lstStyle/>
+                    <a:p>
+                      <a:pPr algn="r"/>
+                      <a:r>
+                        <a:rPr sz="1300" b="0">
+                          <a:solidFill>
+                            <a:srgbClr val="3C3C3B"/>
+                          </a:solidFill>
+                          <a:latin typeface="Aptos"/>
+                        </a:rPr>
+                        <a:t>32.5%</a:t>
                       </a:r>
                     </a:p>
                   </a:txBody>
@@ -21072,70 +21072,70 @@
                           </a:solidFill>
                           <a:latin typeface="Aptos"/>
                         </a:rPr>
-                        <a:t>7.5%</a:t>
-                      </a:r>
-                    </a:p>
-                  </a:txBody>
-                  <a:tcPr marL="73152" marR="73152" marT="27432" marB="27432" anchor="ctr">
-                    <a:noFill/>
-                  </a:tcPr>
-                </a:tc>
-                <a:tc>
-                  <a:txBody>
-                    <a:bodyPr/>
-                    <a:lstStyle/>
-                    <a:p>
-                      <a:pPr algn="r"/>
-                      <a:r>
-                        <a:rPr sz="1300" b="0">
-                          <a:solidFill>
-                            <a:srgbClr val="3C3C3B"/>
-                          </a:solidFill>
-                          <a:latin typeface="Aptos"/>
-                        </a:rPr>
-                        <a:t>11.3%</a:t>
-                      </a:r>
-                    </a:p>
-                  </a:txBody>
-                  <a:tcPr marL="73152" marR="73152" marT="27432" marB="27432" anchor="ctr">
-                    <a:noFill/>
-                  </a:tcPr>
-                </a:tc>
-                <a:tc>
-                  <a:txBody>
-                    <a:bodyPr/>
-                    <a:lstStyle/>
-                    <a:p>
-                      <a:pPr algn="r"/>
-                      <a:r>
-                        <a:rPr sz="1300" b="0">
-                          <a:solidFill>
-                            <a:srgbClr val="3C3C3B"/>
-                          </a:solidFill>
-                          <a:latin typeface="Aptos"/>
-                        </a:rPr>
-                        <a:t>1.85x</a:t>
-                      </a:r>
-                    </a:p>
-                  </a:txBody>
-                  <a:tcPr marL="73152" marR="73152" marT="27432" marB="27432" anchor="ctr">
-                    <a:noFill/>
-                  </a:tcPr>
-                </a:tc>
-                <a:tc>
-                  <a:txBody>
-                    <a:bodyPr/>
-                    <a:lstStyle/>
-                    <a:p>
-                      <a:pPr algn="r"/>
-                      <a:r>
-                        <a:rPr sz="1300" b="0">
-                          <a:solidFill>
-                            <a:srgbClr val="3C3C3B"/>
-                          </a:solidFill>
-                          <a:latin typeface="Aptos"/>
-                        </a:rPr>
-                        <a:t>2.42x</a:t>
+                        <a:t>7.1%</a:t>
+                      </a:r>
+                    </a:p>
+                  </a:txBody>
+                  <a:tcPr marL="73152" marR="73152" marT="27432" marB="27432" anchor="ctr">
+                    <a:noFill/>
+                  </a:tcPr>
+                </a:tc>
+                <a:tc>
+                  <a:txBody>
+                    <a:bodyPr/>
+                    <a:lstStyle/>
+                    <a:p>
+                      <a:pPr algn="r"/>
+                      <a:r>
+                        <a:rPr sz="1300" b="0">
+                          <a:solidFill>
+                            <a:srgbClr val="3C3C3B"/>
+                          </a:solidFill>
+                          <a:latin typeface="Aptos"/>
+                        </a:rPr>
+                        <a:t>10.7%</a:t>
+                      </a:r>
+                    </a:p>
+                  </a:txBody>
+                  <a:tcPr marL="73152" marR="73152" marT="27432" marB="27432" anchor="ctr">
+                    <a:noFill/>
+                  </a:tcPr>
+                </a:tc>
+                <a:tc>
+                  <a:txBody>
+                    <a:bodyPr/>
+                    <a:lstStyle/>
+                    <a:p>
+                      <a:pPr algn="r"/>
+                      <a:r>
+                        <a:rPr sz="1300" b="0">
+                          <a:solidFill>
+                            <a:srgbClr val="3C3C3B"/>
+                          </a:solidFill>
+                          <a:latin typeface="Aptos"/>
+                        </a:rPr>
+                        <a:t>1.79x</a:t>
+                      </a:r>
+                    </a:p>
+                  </a:txBody>
+                  <a:tcPr marL="73152" marR="73152" marT="27432" marB="27432" anchor="ctr">
+                    <a:noFill/>
+                  </a:tcPr>
+                </a:tc>
+                <a:tc>
+                  <a:txBody>
+                    <a:bodyPr/>
+                    <a:lstStyle/>
+                    <a:p>
+                      <a:pPr algn="r"/>
+                      <a:r>
+                        <a:rPr sz="1300" b="0">
+                          <a:solidFill>
+                            <a:srgbClr val="3C3C3B"/>
+                          </a:solidFill>
+                          <a:latin typeface="Aptos"/>
+                        </a:rPr>
+                        <a:t>2.32x</a:t>
                       </a:r>
                     </a:p>
                   </a:txBody>
@@ -21913,7 +21913,7 @@
                 </a:solidFill>
                 <a:latin typeface="Aptos"/>
               </a:rPr>
-              <a:t>65.5 points but COD IRR 23.4% and hold IRR 7.5% (European).</a:t>
+              <a:t>65.5 points but COD IRR 18.1% and hold IRR 7.1% (European).</a:t>
             </a:r>
           </a:p>
           <a:p>
@@ -21938,7 +21938,7 @@
                 </a:solidFill>
                 <a:latin typeface="Aptos"/>
               </a:rPr>
-              <a:t>not in the base; if the 31% levy applies (its exemption covers only KÁT/METÁR plants), the hold IRR falls to 6.1% / 9.1%.</a:t>
+              <a:t>not in the base; if the 31% levy applies (its exemption covers only KÁT/METÁR plants), the hold IRR falls to 5.9% / 8.8%.</a:t>
             </a:r>
           </a:p>
           <a:p>
@@ -21988,7 +21988,7 @@
                 </a:solidFill>
                 <a:latin typeface="Aptos"/>
               </a:rPr>
-              <a:t>a 10-year tenor lowers the European minimum DSCR to 1.25x and the hold IRR to 7.4%.</a:t>
+              <a:t>a 10-year tenor lowers the European minimum DSCR to 1.24x and the hold IRR to 7.2%.</a:t>
             </a:r>
           </a:p>
           <a:p>
@@ -22013,7 +22013,7 @@
                 </a:solidFill>
                 <a:latin typeface="Aptos"/>
               </a:rPr>
-              <a:t>debt at 6x first-year EBITDA, capped at 70% of cost, is €57.3m / €54.1m; hold IRR 8.0% / 13.4%.</a:t>
+              <a:t>debt at 6x first-year EBITDA, capped at 70% of cost, is €57.3m / €55.2m; hold IRR 7.7% / 13.0%.</a:t>
             </a:r>
           </a:p>
         </p:txBody>

</xml_diff>

<commit_message>
Add a promise-or-build slide to the Bana deck
Co-Authored-By: Claude Opus 5.5 <noreply@anthropic.com>
Claude-Session: https://claude.ai/code/session_01AWS1t9WtpkQHcCU1WceGZT
</commit_message>
<xml_diff>
--- a/projects/bana/out/Bana_IC.pptx
+++ b/projects/bana/out/Bana_IC.pptx
@@ -20,6 +20,7 @@
     <p:sldId id="262" r:id="rId8"/>
     <p:sldId id="263" r:id="rId7"/>
     <p:sldId id="264" r:id="rId21"/>
+    <p:sldId id="265" r:id="rId22"/>
   </p:sldIdLst>
   <p:sldSz cx="20105688" cy="11310938"/>
   <p:notesSz cx="6858000" cy="9144000"/>
@@ -6093,7 +6094,7 @@
         </p:nvGraphicFramePr>
         <p:xfrm>
           <a:off x="0" y="0"/>
-          <a:ext cx="3767328" cy="5440680"/>
+          <a:ext cx="3767328" cy="6217920"/>
         </p:xfrm>
         <a:graphic>
           <a:graphicData uri="http://schemas.openxmlformats.org/drawingml/2006/table">
@@ -6318,6 +6319,44 @@
                           <a:latin typeface="Aptos"/>
                         </a:rPr>
                         <a:t>Sale price and buyer return</a:t>
+                      </a:r>
+                    </a:p>
+                  </a:txBody>
+                  <a:tcPr marL="180000" anchor="ctr">
+                    <a:lnL>
+                      <a:noFill/>
+                    </a:lnL>
+                    <a:lnR>
+                      <a:noFill/>
+                    </a:lnR>
+                    <a:lnT w="6350">
+                      <a:solidFill>
+                        <a:srgbClr val="3C3C3B"/>
+                      </a:solidFill>
+                    </a:lnT>
+                    <a:lnB w="6350">
+                      <a:solidFill>
+                        <a:srgbClr val="3C3C3B"/>
+                      </a:solidFill>
+                    </a:lnB>
+                    <a:noFill/>
+                  </a:tcPr>
+                </a:tc>
+              </a:tr>
+              <a:tr h="777240">
+                <a:tc>
+                  <a:txBody>
+                    <a:bodyPr/>
+                    <a:lstStyle/>
+                    <a:p>
+                      <a:r>
+                        <a:rPr sz="1800" b="0">
+                          <a:solidFill>
+                            <a:srgbClr val="3C3C3B"/>
+                          </a:solidFill>
+                          <a:latin typeface="Aptos"/>
+                        </a:rPr>
+                        <a:t>Promise or build</a:t>
                       </a:r>
                     </a:p>
                   </a:txBody>
@@ -7872,7 +7911,7 @@
         </p:nvGraphicFramePr>
         <p:xfrm>
           <a:off x="0" y="0"/>
-          <a:ext cx="3767328" cy="5440680"/>
+          <a:ext cx="3767328" cy="6217920"/>
         </p:xfrm>
         <a:graphic>
           <a:graphicData uri="http://schemas.openxmlformats.org/drawingml/2006/table">
@@ -8097,6 +8136,44 @@
                           <a:latin typeface="Aptos"/>
                         </a:rPr>
                         <a:t>Sale price and buyer return</a:t>
+                      </a:r>
+                    </a:p>
+                  </a:txBody>
+                  <a:tcPr marL="180000" anchor="ctr">
+                    <a:lnL>
+                      <a:noFill/>
+                    </a:lnL>
+                    <a:lnR>
+                      <a:noFill/>
+                    </a:lnR>
+                    <a:lnT w="6350">
+                      <a:solidFill>
+                        <a:srgbClr val="3C3C3B"/>
+                      </a:solidFill>
+                    </a:lnT>
+                    <a:lnB w="6350">
+                      <a:solidFill>
+                        <a:srgbClr val="3C3C3B"/>
+                      </a:solidFill>
+                    </a:lnB>
+                    <a:noFill/>
+                  </a:tcPr>
+                </a:tc>
+              </a:tr>
+              <a:tr h="777240">
+                <a:tc>
+                  <a:txBody>
+                    <a:bodyPr/>
+                    <a:lstStyle/>
+                    <a:p>
+                      <a:r>
+                        <a:rPr sz="1800" b="0">
+                          <a:solidFill>
+                            <a:srgbClr val="3C3C3B"/>
+                          </a:solidFill>
+                          <a:latin typeface="Aptos"/>
+                        </a:rPr>
+                        <a:t>Promise or build</a:t>
                       </a:r>
                     </a:p>
                   </a:txBody>
@@ -9743,7 +9820,7 @@
         </p:nvGraphicFramePr>
         <p:xfrm>
           <a:off x="0" y="0"/>
-          <a:ext cx="3767328" cy="5440680"/>
+          <a:ext cx="3767328" cy="6217920"/>
         </p:xfrm>
         <a:graphic>
           <a:graphicData uri="http://schemas.openxmlformats.org/drawingml/2006/table">
@@ -9968,6 +10045,44 @@
                           <a:latin typeface="Aptos"/>
                         </a:rPr>
                         <a:t>Sale price and buyer return</a:t>
+                      </a:r>
+                    </a:p>
+                  </a:txBody>
+                  <a:tcPr marL="180000" anchor="ctr">
+                    <a:lnL>
+                      <a:noFill/>
+                    </a:lnL>
+                    <a:lnR>
+                      <a:noFill/>
+                    </a:lnR>
+                    <a:lnT w="6350">
+                      <a:solidFill>
+                        <a:srgbClr val="3C3C3B"/>
+                      </a:solidFill>
+                    </a:lnT>
+                    <a:lnB w="6350">
+                      <a:solidFill>
+                        <a:srgbClr val="3C3C3B"/>
+                      </a:solidFill>
+                    </a:lnB>
+                    <a:noFill/>
+                  </a:tcPr>
+                </a:tc>
+              </a:tr>
+              <a:tr h="777240">
+                <a:tc>
+                  <a:txBody>
+                    <a:bodyPr/>
+                    <a:lstStyle/>
+                    <a:p>
+                      <a:r>
+                        <a:rPr sz="1800" b="0">
+                          <a:solidFill>
+                            <a:srgbClr val="3C3C3B"/>
+                          </a:solidFill>
+                          <a:latin typeface="Aptos"/>
+                        </a:rPr>
+                        <a:t>Promise or build</a:t>
                       </a:r>
                     </a:p>
                   </a:txBody>
@@ -11727,7 +11842,7 @@
         </p:nvGraphicFramePr>
         <p:xfrm>
           <a:off x="0" y="0"/>
-          <a:ext cx="3767328" cy="5440680"/>
+          <a:ext cx="3767328" cy="6217920"/>
         </p:xfrm>
         <a:graphic>
           <a:graphicData uri="http://schemas.openxmlformats.org/drawingml/2006/table">
@@ -11952,6 +12067,44 @@
                           <a:latin typeface="Aptos"/>
                         </a:rPr>
                         <a:t>Sale price and buyer return</a:t>
+                      </a:r>
+                    </a:p>
+                  </a:txBody>
+                  <a:tcPr marL="180000" anchor="ctr">
+                    <a:lnL>
+                      <a:noFill/>
+                    </a:lnL>
+                    <a:lnR>
+                      <a:noFill/>
+                    </a:lnR>
+                    <a:lnT w="6350">
+                      <a:solidFill>
+                        <a:srgbClr val="3C3C3B"/>
+                      </a:solidFill>
+                    </a:lnT>
+                    <a:lnB w="6350">
+                      <a:solidFill>
+                        <a:srgbClr val="3C3C3B"/>
+                      </a:solidFill>
+                    </a:lnB>
+                    <a:noFill/>
+                  </a:tcPr>
+                </a:tc>
+              </a:tr>
+              <a:tr h="777240">
+                <a:tc>
+                  <a:txBody>
+                    <a:bodyPr/>
+                    <a:lstStyle/>
+                    <a:p>
+                      <a:r>
+                        <a:rPr sz="1800" b="0">
+                          <a:solidFill>
+                            <a:srgbClr val="3C3C3B"/>
+                          </a:solidFill>
+                          <a:latin typeface="Aptos"/>
+                        </a:rPr>
+                        <a:t>Promise or build</a:t>
                       </a:r>
                     </a:p>
                   </a:txBody>
@@ -14070,7 +14223,7 @@
         </p:nvGraphicFramePr>
         <p:xfrm>
           <a:off x="0" y="0"/>
-          <a:ext cx="3767328" cy="5440680"/>
+          <a:ext cx="3767328" cy="6217920"/>
         </p:xfrm>
         <a:graphic>
           <a:graphicData uri="http://schemas.openxmlformats.org/drawingml/2006/table">
@@ -14295,6 +14448,44 @@
                           <a:latin typeface="Aptos"/>
                         </a:rPr>
                         <a:t>Sale price and buyer return</a:t>
+                      </a:r>
+                    </a:p>
+                  </a:txBody>
+                  <a:tcPr marL="180000" anchor="ctr">
+                    <a:lnL>
+                      <a:noFill/>
+                    </a:lnL>
+                    <a:lnR>
+                      <a:noFill/>
+                    </a:lnR>
+                    <a:lnT w="6350">
+                      <a:solidFill>
+                        <a:srgbClr val="3C3C3B"/>
+                      </a:solidFill>
+                    </a:lnT>
+                    <a:lnB w="6350">
+                      <a:solidFill>
+                        <a:srgbClr val="3C3C3B"/>
+                      </a:solidFill>
+                    </a:lnB>
+                    <a:noFill/>
+                  </a:tcPr>
+                </a:tc>
+              </a:tr>
+              <a:tr h="777240">
+                <a:tc>
+                  <a:txBody>
+                    <a:bodyPr/>
+                    <a:lstStyle/>
+                    <a:p>
+                      <a:r>
+                        <a:rPr sz="1800" b="0">
+                          <a:solidFill>
+                            <a:srgbClr val="3C3C3B"/>
+                          </a:solidFill>
+                          <a:latin typeface="Aptos"/>
+                        </a:rPr>
+                        <a:t>Promise or build</a:t>
                       </a:r>
                     </a:p>
                   </a:txBody>
@@ -16449,7 +16640,7 @@
         </p:nvGraphicFramePr>
         <p:xfrm>
           <a:off x="0" y="0"/>
-          <a:ext cx="3767328" cy="5440680"/>
+          <a:ext cx="3767328" cy="6217920"/>
         </p:xfrm>
         <a:graphic>
           <a:graphicData uri="http://schemas.openxmlformats.org/drawingml/2006/table">
@@ -16695,6 +16886,44 @@
                       </a:gsLst>
                       <a:lin scaled="0" ang="0"/>
                     </a:gradFill>
+                  </a:tcPr>
+                </a:tc>
+              </a:tr>
+              <a:tr h="777240">
+                <a:tc>
+                  <a:txBody>
+                    <a:bodyPr/>
+                    <a:lstStyle/>
+                    <a:p>
+                      <a:r>
+                        <a:rPr sz="1800" b="0">
+                          <a:solidFill>
+                            <a:srgbClr val="3C3C3B"/>
+                          </a:solidFill>
+                          <a:latin typeface="Aptos"/>
+                        </a:rPr>
+                        <a:t>Promise or build</a:t>
+                      </a:r>
+                    </a:p>
+                  </a:txBody>
+                  <a:tcPr marL="180000" anchor="ctr">
+                    <a:lnL>
+                      <a:noFill/>
+                    </a:lnL>
+                    <a:lnR>
+                      <a:noFill/>
+                    </a:lnR>
+                    <a:lnT w="6350">
+                      <a:solidFill>
+                        <a:srgbClr val="3C3C3B"/>
+                      </a:solidFill>
+                    </a:lnT>
+                    <a:lnB w="6350">
+                      <a:solidFill>
+                        <a:srgbClr val="3C3C3B"/>
+                      </a:solidFill>
+                    </a:lnB>
+                    <a:noFill/>
                   </a:tcPr>
                 </a:tc>
               </a:tr>
@@ -17665,6 +17894,1545 @@
 </file>
 
 <file path=ppt/slides/slide8.xml><?xml version="1.0" encoding="utf-8"?>
+<p:sld xmlns:a="http://schemas.openxmlformats.org/drawingml/2006/main" xmlns:p="http://schemas.openxmlformats.org/presentationml/2006/main" xmlns:r="http://schemas.openxmlformats.org/officeDocument/2006/relationships">
+  <p:cSld>
+    <p:spTree>
+      <p:nvGrpSpPr>
+        <p:cNvPr id="1" name=""/>
+        <p:cNvGrpSpPr/>
+        <p:nvPr/>
+      </p:nvGrpSpPr>
+      <p:grpSpPr/>
+      <p:sp>
+        <p:nvSpPr>
+          <p:cNvPr id="2" name="Title 1"/>
+          <p:cNvSpPr>
+            <a:spLocks noGrp="1"/>
+          </p:cNvSpPr>
+          <p:nvPr>
+            <p:ph type="title"/>
+          </p:nvPr>
+        </p:nvSpPr>
+        <p:spPr>
+          <a:xfrm>
+            <a:off x="4498848" y="182880"/>
+            <a:ext cx="12710160" cy="1097280"/>
+          </a:xfrm>
+        </p:spPr>
+        <p:txBody>
+          <a:bodyPr wrap="square"/>
+          <a:lstStyle/>
+          <a:p>
+            <a:r>
+              <a:t>Promising the BESS without building it lifts the sale IRR to 30.9% / 45.7% for a €0.55m PB call</a:t>
+            </a:r>
+          </a:p>
+        </p:txBody>
+      </p:sp>
+      <p:sp>
+        <p:nvSpPr>
+          <p:cNvPr id="2" name="Slide Number Placeholder 1">
+            <a:extLst>
+              <a:ext uri="{FF2B5EF4-FFF2-40B4-BE49-F238E27FC236}">
+                <a16:creationId xmlns:a16="http://schemas.microsoft.com/office/drawing/2014/main" id="{88576B7A-1C0F-D2A3-8BE9-18F63D64C454}"/>
+              </a:ext>
+            </a:extLst>
+          </p:cNvPr>
+          <p:cNvSpPr>
+            <a:spLocks noGrp="1"/>
+          </p:cNvSpPr>
+          <p:nvPr>
+            <p:ph type="sldNum" sz="quarter" idx="4"/>
+          </p:nvPr>
+        </p:nvSpPr>
+        <p:spPr>
+          <a:xfrm>
+            <a:off x="14200188" y="10483850"/>
+            <a:ext cx="4522787" cy="601663"/>
+          </a:xfrm>
+          <a:prstGeom prst="rect">
+            <a:avLst/>
+          </a:prstGeom>
+        </p:spPr>
+        <p:txBody>
+          <a:bodyPr vert="horz" lIns="91440" tIns="45720" rIns="91440" bIns="45720" rtlCol="0" anchor="ctr"/>
+          <a:lstStyle>
+            <a:lvl1pPr algn="r">
+              <a:defRPr sz="1200">
+                <a:solidFill>
+                  <a:schemeClr val="tx1">
+                    <a:tint val="82000"/>
+                  </a:schemeClr>
+                </a:solidFill>
+              </a:defRPr>
+            </a:lvl1pPr>
+          </a:lstStyle>
+          <a:p>
+            <a:fld id="{52EEA166-2877-4493-9FAA-8D6952A82FC3}" type="slidenum">
+              <a:rPr lang="en-GB" smtClean="0"/>
+              <a:t>‹#›</a:t>
+            </a:fld>
+            <a:endParaRPr lang="en-GB"/>
+          </a:p>
+        </p:txBody>
+      </p:sp>
+      <p:graphicFrame>
+        <p:nvGraphicFramePr>
+          <p:cNvPr id="3" name="Navigator"/>
+          <p:cNvGraphicFramePr>
+            <a:graphicFrameLocks noGrp="1"/>
+          </p:cNvGraphicFramePr>
+          <p:nvPr/>
+        </p:nvGraphicFramePr>
+        <p:xfrm>
+          <a:off x="0" y="0"/>
+          <a:ext cx="3767328" cy="6217920"/>
+        </p:xfrm>
+        <a:graphic>
+          <a:graphicData uri="http://schemas.openxmlformats.org/drawingml/2006/table">
+            <a:tbl>
+              <a:tblPr>
+                <a:tableStyleId>{5C22544A-7EE6-4342-B048-85BDC9FD1C3A}</a:tableStyleId>
+              </a:tblPr>
+              <a:tblGrid>
+                <a:gridCol w="3767328"/>
+              </a:tblGrid>
+              <a:tr h="777240">
+                <a:tc>
+                  <a:txBody>
+                    <a:bodyPr/>
+                    <a:lstStyle/>
+                    <a:p>
+                      <a:r>
+                        <a:rPr sz="1800" b="0">
+                          <a:solidFill>
+                            <a:srgbClr val="3C3C3B"/>
+                          </a:solidFill>
+                          <a:latin typeface="Aptos"/>
+                        </a:rPr>
+                        <a:t>Executive summary</a:t>
+                      </a:r>
+                    </a:p>
+                  </a:txBody>
+                  <a:tcPr marL="180000" anchor="ctr">
+                    <a:lnL>
+                      <a:noFill/>
+                    </a:lnL>
+                    <a:lnR>
+                      <a:noFill/>
+                    </a:lnR>
+                    <a:lnT w="6350">
+                      <a:solidFill>
+                        <a:srgbClr val="3C3C3B"/>
+                      </a:solidFill>
+                    </a:lnT>
+                    <a:lnB w="6350">
+                      <a:solidFill>
+                        <a:srgbClr val="3C3C3B"/>
+                      </a:solidFill>
+                    </a:lnB>
+                    <a:noFill/>
+                  </a:tcPr>
+                </a:tc>
+              </a:tr>
+              <a:tr h="777240">
+                <a:tc>
+                  <a:txBody>
+                    <a:bodyPr/>
+                    <a:lstStyle/>
+                    <a:p>
+                      <a:r>
+                        <a:rPr sz="1800" b="0">
+                          <a:solidFill>
+                            <a:srgbClr val="3C3C3B"/>
+                          </a:solidFill>
+                          <a:latin typeface="Aptos"/>
+                        </a:rPr>
+                        <a:t>Risks and mitigants</a:t>
+                      </a:r>
+                    </a:p>
+                  </a:txBody>
+                  <a:tcPr marL="180000" anchor="ctr">
+                    <a:lnL>
+                      <a:noFill/>
+                    </a:lnL>
+                    <a:lnR>
+                      <a:noFill/>
+                    </a:lnR>
+                    <a:lnT w="6350">
+                      <a:solidFill>
+                        <a:srgbClr val="3C3C3B"/>
+                      </a:solidFill>
+                    </a:lnT>
+                    <a:lnB w="6350">
+                      <a:solidFill>
+                        <a:srgbClr val="3C3C3B"/>
+                      </a:solidFill>
+                    </a:lnB>
+                    <a:noFill/>
+                  </a:tcPr>
+                </a:tc>
+              </a:tr>
+              <a:tr h="777240">
+                <a:tc>
+                  <a:txBody>
+                    <a:bodyPr/>
+                    <a:lstStyle/>
+                    <a:p>
+                      <a:r>
+                        <a:rPr sz="1800" b="0">
+                          <a:solidFill>
+                            <a:srgbClr val="3C3C3B"/>
+                          </a:solidFill>
+                          <a:latin typeface="Aptos"/>
+                        </a:rPr>
+                        <a:t>Technical overview and tender bid</a:t>
+                      </a:r>
+                    </a:p>
+                  </a:txBody>
+                  <a:tcPr marL="180000" anchor="ctr">
+                    <a:lnL>
+                      <a:noFill/>
+                    </a:lnL>
+                    <a:lnR>
+                      <a:noFill/>
+                    </a:lnR>
+                    <a:lnT w="6350">
+                      <a:solidFill>
+                        <a:srgbClr val="3C3C3B"/>
+                      </a:solidFill>
+                    </a:lnT>
+                    <a:lnB w="6350">
+                      <a:solidFill>
+                        <a:srgbClr val="3C3C3B"/>
+                      </a:solidFill>
+                    </a:lnB>
+                    <a:noFill/>
+                  </a:tcPr>
+                </a:tc>
+              </a:tr>
+              <a:tr h="777240">
+                <a:tc>
+                  <a:txBody>
+                    <a:bodyPr/>
+                    <a:lstStyle/>
+                    <a:p>
+                      <a:r>
+                        <a:rPr sz="1800" b="0">
+                          <a:solidFill>
+                            <a:srgbClr val="3C3C3B"/>
+                          </a:solidFill>
+                          <a:latin typeface="Aptos"/>
+                        </a:rPr>
+                        <a:t>Funding to COD</a:t>
+                      </a:r>
+                    </a:p>
+                  </a:txBody>
+                  <a:tcPr marL="180000" anchor="ctr">
+                    <a:lnL>
+                      <a:noFill/>
+                    </a:lnL>
+                    <a:lnR>
+                      <a:noFill/>
+                    </a:lnR>
+                    <a:lnT w="6350">
+                      <a:solidFill>
+                        <a:srgbClr val="3C3C3B"/>
+                      </a:solidFill>
+                    </a:lnT>
+                    <a:lnB w="6350">
+                      <a:solidFill>
+                        <a:srgbClr val="3C3C3B"/>
+                      </a:solidFill>
+                    </a:lnB>
+                    <a:noFill/>
+                  </a:tcPr>
+                </a:tc>
+              </a:tr>
+              <a:tr h="777240">
+                <a:tc>
+                  <a:txBody>
+                    <a:bodyPr/>
+                    <a:lstStyle/>
+                    <a:p>
+                      <a:r>
+                        <a:rPr sz="1800" b="0">
+                          <a:solidFill>
+                            <a:srgbClr val="3C3C3B"/>
+                          </a:solidFill>
+                          <a:latin typeface="Aptos"/>
+                        </a:rPr>
+                        <a:t>Returns: sale at COD vs hold</a:t>
+                      </a:r>
+                    </a:p>
+                  </a:txBody>
+                  <a:tcPr marL="180000" anchor="ctr">
+                    <a:lnL>
+                      <a:noFill/>
+                    </a:lnL>
+                    <a:lnR>
+                      <a:noFill/>
+                    </a:lnR>
+                    <a:lnT w="6350">
+                      <a:solidFill>
+                        <a:srgbClr val="3C3C3B"/>
+                      </a:solidFill>
+                    </a:lnT>
+                    <a:lnB w="6350">
+                      <a:solidFill>
+                        <a:srgbClr val="3C3C3B"/>
+                      </a:solidFill>
+                    </a:lnB>
+                    <a:noFill/>
+                  </a:tcPr>
+                </a:tc>
+              </a:tr>
+              <a:tr h="777240">
+                <a:tc>
+                  <a:txBody>
+                    <a:bodyPr/>
+                    <a:lstStyle/>
+                    <a:p>
+                      <a:r>
+                        <a:rPr sz="1800" b="0">
+                          <a:solidFill>
+                            <a:srgbClr val="3C3C3B"/>
+                          </a:solidFill>
+                          <a:latin typeface="Aptos"/>
+                        </a:rPr>
+                        <a:t>Sale price and buyer return</a:t>
+                      </a:r>
+                    </a:p>
+                  </a:txBody>
+                  <a:tcPr marL="180000" anchor="ctr">
+                    <a:lnL>
+                      <a:noFill/>
+                    </a:lnL>
+                    <a:lnR>
+                      <a:noFill/>
+                    </a:lnR>
+                    <a:lnT w="6350">
+                      <a:solidFill>
+                        <a:srgbClr val="3C3C3B"/>
+                      </a:solidFill>
+                    </a:lnT>
+                    <a:lnB w="6350">
+                      <a:solidFill>
+                        <a:srgbClr val="3C3C3B"/>
+                      </a:solidFill>
+                    </a:lnB>
+                    <a:noFill/>
+                  </a:tcPr>
+                </a:tc>
+              </a:tr>
+              <a:tr h="777240">
+                <a:tc>
+                  <a:txBody>
+                    <a:bodyPr/>
+                    <a:lstStyle/>
+                    <a:p>
+                      <a:r>
+                        <a:rPr sz="1800" b="1">
+                          <a:solidFill>
+                            <a:srgbClr val="FFFFFF"/>
+                          </a:solidFill>
+                          <a:latin typeface="Aptos"/>
+                        </a:rPr>
+                        <a:t>Promise or build</a:t>
+                      </a:r>
+                    </a:p>
+                  </a:txBody>
+                  <a:tcPr marL="180000" anchor="ctr">
+                    <a:lnL>
+                      <a:noFill/>
+                    </a:lnL>
+                    <a:lnR>
+                      <a:noFill/>
+                    </a:lnR>
+                    <a:lnT w="6350">
+                      <a:solidFill>
+                        <a:srgbClr val="3C3C3B"/>
+                      </a:solidFill>
+                    </a:lnT>
+                    <a:lnB w="6350">
+                      <a:solidFill>
+                        <a:srgbClr val="3C3C3B"/>
+                      </a:solidFill>
+                    </a:lnB>
+                    <a:gradFill rotWithShape="1">
+                      <a:gsLst>
+                        <a:gs pos="0">
+                          <a:srgbClr val="00A651"/>
+                        </a:gs>
+                        <a:gs pos="100000">
+                          <a:srgbClr val="00563C"/>
+                        </a:gs>
+                      </a:gsLst>
+                      <a:lin scaled="0" ang="0"/>
+                    </a:gradFill>
+                  </a:tcPr>
+                </a:tc>
+              </a:tr>
+              <a:tr h="777240">
+                <a:tc>
+                  <a:txBody>
+                    <a:bodyPr/>
+                    <a:lstStyle/>
+                    <a:p>
+                      <a:r>
+                        <a:rPr sz="1800" b="0">
+                          <a:solidFill>
+                            <a:srgbClr val="3C3C3B"/>
+                          </a:solidFill>
+                          <a:latin typeface="Aptos"/>
+                        </a:rPr>
+                        <a:t>Sensitivities</a:t>
+                      </a:r>
+                    </a:p>
+                  </a:txBody>
+                  <a:tcPr marL="180000" anchor="ctr">
+                    <a:lnL>
+                      <a:noFill/>
+                    </a:lnL>
+                    <a:lnR>
+                      <a:noFill/>
+                    </a:lnR>
+                    <a:lnT w="6350">
+                      <a:solidFill>
+                        <a:srgbClr val="3C3C3B"/>
+                      </a:solidFill>
+                    </a:lnT>
+                    <a:lnB w="6350">
+                      <a:solidFill>
+                        <a:srgbClr val="3C3C3B"/>
+                      </a:solidFill>
+                    </a:lnB>
+                    <a:noFill/>
+                  </a:tcPr>
+                </a:tc>
+              </a:tr>
+            </a:tbl>
+          </a:graphicData>
+        </a:graphic>
+      </p:graphicFrame>
+      <p:sp>
+        <p:nvSpPr>
+          <p:cNvPr id="4" name="Subtitle"/>
+          <p:cNvSpPr txBox="1"/>
+          <p:nvPr/>
+        </p:nvSpPr>
+        <p:spPr>
+          <a:xfrm>
+            <a:off x="4498848" y="1371600"/>
+            <a:ext cx="13716000" cy="685800"/>
+          </a:xfrm>
+          <a:prstGeom prst="rect">
+            <a:avLst/>
+          </a:prstGeom>
+          <a:noFill/>
+        </p:spPr>
+        <p:txBody>
+          <a:bodyPr wrap="square">
+            <a:spAutoFit/>
+          </a:bodyPr>
+          <a:lstStyle/>
+          <a:p>
+            <a:r>
+              <a:rPr sz="1800" b="1">
+                <a:solidFill>
+                  <a:srgbClr val="3C3C3B"/>
+                </a:solidFill>
+                <a:latin typeface="Aptos"/>
+              </a:rPr>
+              <a:t>The bid commits 20% overbuild (60 MW) and 20% BESS (40 MWh), 59.5 points in every case; leaving out the overbuild as well cuts the sale IRR to 26.4% / 40.6%.</a:t>
+            </a:r>
+          </a:p>
+        </p:txBody>
+      </p:sp>
+      <p:graphicFrame>
+        <p:nvGraphicFramePr>
+          <p:cNvPr id="5" name="Table"/>
+          <p:cNvGraphicFramePr>
+            <a:graphicFrameLocks noGrp="1"/>
+          </p:cNvGraphicFramePr>
+          <p:nvPr/>
+        </p:nvGraphicFramePr>
+        <p:xfrm>
+          <a:off x="4498848" y="2240280"/>
+          <a:ext cx="13716000" cy="2807208"/>
+        </p:xfrm>
+        <a:graphic>
+          <a:graphicData uri="http://schemas.openxmlformats.org/drawingml/2006/table">
+            <a:tbl>
+              <a:tblPr>
+                <a:tableStyleId>{5C22544A-7EE6-4342-B048-85BDC9FD1C3A}</a:tableStyleId>
+              </a:tblPr>
+              <a:tblGrid>
+                <a:gridCol w="3840480"/>
+                <a:gridCol w="1234440"/>
+                <a:gridCol w="1234440"/>
+                <a:gridCol w="1234440"/>
+                <a:gridCol w="1234440"/>
+                <a:gridCol w="1234440"/>
+                <a:gridCol w="1234440"/>
+                <a:gridCol w="1234440"/>
+                <a:gridCol w="1234440"/>
+              </a:tblGrid>
+              <a:tr h="539496">
+                <a:tc>
+                  <a:txBody>
+                    <a:bodyPr/>
+                    <a:lstStyle/>
+                    <a:p>
+                      <a:pPr algn="l"/>
+                      <a:r>
+                        <a:rPr sz="1300" b="1">
+                          <a:solidFill>
+                            <a:srgbClr val="FFFFFF"/>
+                          </a:solidFill>
+                          <a:latin typeface="Aptos"/>
+                        </a:rPr>
+                        <a:t>What is built</a:t>
+                      </a:r>
+                    </a:p>
+                  </a:txBody>
+                  <a:tcPr marL="73152" marR="73152" marT="27432" marB="27432" anchor="ctr">
+                    <a:solidFill>
+                      <a:srgbClr val="00A651"/>
+                    </a:solidFill>
+                  </a:tcPr>
+                </a:tc>
+                <a:tc>
+                  <a:txBody>
+                    <a:bodyPr/>
+                    <a:lstStyle/>
+                    <a:p>
+                      <a:pPr algn="l"/>
+                      <a:r>
+                        <a:rPr sz="1300" b="1">
+                          <a:solidFill>
+                            <a:srgbClr val="FFFFFF"/>
+                          </a:solidFill>
+                          <a:latin typeface="Aptos"/>
+                        </a:rPr>
+                        <a:t>PB call € m</a:t>
+                      </a:r>
+                    </a:p>
+                  </a:txBody>
+                  <a:tcPr marL="73152" marR="73152" marT="27432" marB="27432" anchor="ctr">
+                    <a:solidFill>
+                      <a:srgbClr val="00A651"/>
+                    </a:solidFill>
+                  </a:tcPr>
+                </a:tc>
+                <a:tc>
+                  <a:txBody>
+                    <a:bodyPr/>
+                    <a:lstStyle/>
+                    <a:p>
+                      <a:pPr algn="r"/>
+                      <a:r>
+                        <a:rPr sz="1300" b="1">
+                          <a:solidFill>
+                            <a:srgbClr val="FFFFFF"/>
+                          </a:solidFill>
+                          <a:latin typeface="Aptos"/>
+                        </a:rPr>
+                        <a:t>MVA lost</a:t>
+                      </a:r>
+                    </a:p>
+                  </a:txBody>
+                  <a:tcPr marL="73152" marR="73152" marT="27432" marB="27432" anchor="ctr">
+                    <a:solidFill>
+                      <a:srgbClr val="00A651"/>
+                    </a:solidFill>
+                  </a:tcPr>
+                </a:tc>
+                <a:tc>
+                  <a:txBody>
+                    <a:bodyPr/>
+                    <a:lstStyle/>
+                    <a:p>
+                      <a:pPr algn="r"/>
+                      <a:r>
+                        <a:rPr sz="1300" b="1">
+                          <a:solidFill>
+                            <a:srgbClr val="FFFFFF"/>
+                          </a:solidFill>
+                          <a:latin typeface="Aptos"/>
+                        </a:rPr>
+                        <a:t>Equity EU € m</a:t>
+                      </a:r>
+                    </a:p>
+                  </a:txBody>
+                  <a:tcPr marL="73152" marR="73152" marT="27432" marB="27432" anchor="ctr">
+                    <a:solidFill>
+                      <a:srgbClr val="00A651"/>
+                    </a:solidFill>
+                  </a:tcPr>
+                </a:tc>
+                <a:tc>
+                  <a:txBody>
+                    <a:bodyPr/>
+                    <a:lstStyle/>
+                    <a:p>
+                      <a:pPr algn="r"/>
+                      <a:r>
+                        <a:rPr sz="1300" b="1">
+                          <a:solidFill>
+                            <a:srgbClr val="FFFFFF"/>
+                          </a:solidFill>
+                          <a:latin typeface="Aptos"/>
+                        </a:rPr>
+                        <a:t>Equity CN € m</a:t>
+                      </a:r>
+                    </a:p>
+                  </a:txBody>
+                  <a:tcPr marL="73152" marR="73152" marT="27432" marB="27432" anchor="ctr">
+                    <a:solidFill>
+                      <a:srgbClr val="00A651"/>
+                    </a:solidFill>
+                  </a:tcPr>
+                </a:tc>
+                <a:tc>
+                  <a:txBody>
+                    <a:bodyPr/>
+                    <a:lstStyle/>
+                    <a:p>
+                      <a:pPr algn="r"/>
+                      <a:r>
+                        <a:rPr sz="1300" b="1">
+                          <a:solidFill>
+                            <a:srgbClr val="FFFFFF"/>
+                          </a:solidFill>
+                          <a:latin typeface="Aptos"/>
+                        </a:rPr>
+                        <a:t>Sale IRR EU</a:t>
+                      </a:r>
+                    </a:p>
+                  </a:txBody>
+                  <a:tcPr marL="73152" marR="73152" marT="27432" marB="27432" anchor="ctr">
+                    <a:solidFill>
+                      <a:srgbClr val="00A651"/>
+                    </a:solidFill>
+                  </a:tcPr>
+                </a:tc>
+                <a:tc>
+                  <a:txBody>
+                    <a:bodyPr/>
+                    <a:lstStyle/>
+                    <a:p>
+                      <a:pPr algn="r"/>
+                      <a:r>
+                        <a:rPr sz="1300" b="1">
+                          <a:solidFill>
+                            <a:srgbClr val="FFFFFF"/>
+                          </a:solidFill>
+                          <a:latin typeface="Aptos"/>
+                        </a:rPr>
+                        <a:t>Sale IRR CN</a:t>
+                      </a:r>
+                    </a:p>
+                  </a:txBody>
+                  <a:tcPr marL="73152" marR="73152" marT="27432" marB="27432" anchor="ctr">
+                    <a:solidFill>
+                      <a:srgbClr val="00A651"/>
+                    </a:solidFill>
+                  </a:tcPr>
+                </a:tc>
+                <a:tc>
+                  <a:txBody>
+                    <a:bodyPr/>
+                    <a:lstStyle/>
+                    <a:p>
+                      <a:pPr algn="r"/>
+                      <a:r>
+                        <a:rPr sz="1300" b="1">
+                          <a:solidFill>
+                            <a:srgbClr val="FFFFFF"/>
+                          </a:solidFill>
+                          <a:latin typeface="Aptos"/>
+                        </a:rPr>
+                        <a:t>Hold IRR EU</a:t>
+                      </a:r>
+                    </a:p>
+                  </a:txBody>
+                  <a:tcPr marL="73152" marR="73152" marT="27432" marB="27432" anchor="ctr">
+                    <a:solidFill>
+                      <a:srgbClr val="00A651"/>
+                    </a:solidFill>
+                  </a:tcPr>
+                </a:tc>
+                <a:tc>
+                  <a:txBody>
+                    <a:bodyPr/>
+                    <a:lstStyle/>
+                    <a:p>
+                      <a:pPr algn="r"/>
+                      <a:r>
+                        <a:rPr sz="1300" b="1">
+                          <a:solidFill>
+                            <a:srgbClr val="FFFFFF"/>
+                          </a:solidFill>
+                          <a:latin typeface="Aptos"/>
+                        </a:rPr>
+                        <a:t>Hold IRR CN</a:t>
+                      </a:r>
+                    </a:p>
+                  </a:txBody>
+                  <a:tcPr marL="73152" marR="73152" marT="27432" marB="27432" anchor="ctr">
+                    <a:solidFill>
+                      <a:srgbClr val="00A651"/>
+                    </a:solidFill>
+                  </a:tcPr>
+                </a:tc>
+              </a:tr>
+              <a:tr h="566928">
+                <a:tc>
+                  <a:txBody>
+                    <a:bodyPr/>
+                    <a:lstStyle/>
+                    <a:p>
+                      <a:pPr algn="l"/>
+                      <a:r>
+                        <a:rPr sz="1300" b="1">
+                          <a:solidFill>
+                            <a:srgbClr val="3C3C3B"/>
+                          </a:solidFill>
+                          <a:latin typeface="Aptos"/>
+                        </a:rPr>
+                        <a:t>Base: 55 MW wind and the BESS built</a:t>
+                      </a:r>
+                    </a:p>
+                  </a:txBody>
+                  <a:tcPr marL="73152" marR="73152" marT="27432" marB="27432" anchor="ctr">
+                    <a:solidFill>
+                      <a:srgbClr val="F2F2F2"/>
+                    </a:solidFill>
+                  </a:tcPr>
+                </a:tc>
+                <a:tc>
+                  <a:txBody>
+                    <a:bodyPr/>
+                    <a:lstStyle/>
+                    <a:p>
+                      <a:pPr algn="l"/>
+                      <a:r>
+                        <a:rPr sz="1300" b="1">
+                          <a:solidFill>
+                            <a:srgbClr val="3C3C3B"/>
+                          </a:solidFill>
+                          <a:latin typeface="Aptos"/>
+                        </a:rPr>
+                        <a:t>0.00</a:t>
+                      </a:r>
+                    </a:p>
+                  </a:txBody>
+                  <a:tcPr marL="73152" marR="73152" marT="27432" marB="27432" anchor="ctr">
+                    <a:solidFill>
+                      <a:srgbClr val="E6F4EC"/>
+                    </a:solidFill>
+                  </a:tcPr>
+                </a:tc>
+                <a:tc>
+                  <a:txBody>
+                    <a:bodyPr/>
+                    <a:lstStyle/>
+                    <a:p>
+                      <a:pPr algn="r"/>
+                      <a:r>
+                        <a:rPr sz="1300" b="1">
+                          <a:solidFill>
+                            <a:srgbClr val="3C3C3B"/>
+                          </a:solidFill>
+                          <a:latin typeface="Aptos"/>
+                        </a:rPr>
+                        <a:t>0.0</a:t>
+                      </a:r>
+                    </a:p>
+                  </a:txBody>
+                  <a:tcPr marL="73152" marR="73152" marT="27432" marB="27432" anchor="ctr">
+                    <a:solidFill>
+                      <a:srgbClr val="E6F4EC"/>
+                    </a:solidFill>
+                  </a:tcPr>
+                </a:tc>
+                <a:tc>
+                  <a:txBody>
+                    <a:bodyPr/>
+                    <a:lstStyle/>
+                    <a:p>
+                      <a:pPr algn="r"/>
+                      <a:r>
+                        <a:rPr sz="1300" b="1">
+                          <a:solidFill>
+                            <a:srgbClr val="3C3C3B"/>
+                          </a:solidFill>
+                          <a:latin typeface="Aptos"/>
+                        </a:rPr>
+                        <a:t>54.4</a:t>
+                      </a:r>
+                    </a:p>
+                  </a:txBody>
+                  <a:tcPr marL="73152" marR="73152" marT="27432" marB="27432" anchor="ctr">
+                    <a:solidFill>
+                      <a:srgbClr val="E6F4EC"/>
+                    </a:solidFill>
+                  </a:tcPr>
+                </a:tc>
+                <a:tc>
+                  <a:txBody>
+                    <a:bodyPr/>
+                    <a:lstStyle/>
+                    <a:p>
+                      <a:pPr algn="r"/>
+                      <a:r>
+                        <a:rPr sz="1300" b="1">
+                          <a:solidFill>
+                            <a:srgbClr val="3C3C3B"/>
+                          </a:solidFill>
+                          <a:latin typeface="Aptos"/>
+                        </a:rPr>
+                        <a:t>41.7</a:t>
+                      </a:r>
+                    </a:p>
+                  </a:txBody>
+                  <a:tcPr marL="73152" marR="73152" marT="27432" marB="27432" anchor="ctr">
+                    <a:solidFill>
+                      <a:srgbClr val="E6F4EC"/>
+                    </a:solidFill>
+                  </a:tcPr>
+                </a:tc>
+                <a:tc>
+                  <a:txBody>
+                    <a:bodyPr/>
+                    <a:lstStyle/>
+                    <a:p>
+                      <a:pPr algn="r"/>
+                      <a:r>
+                        <a:rPr sz="1300" b="1">
+                          <a:solidFill>
+                            <a:srgbClr val="3C3C3B"/>
+                          </a:solidFill>
+                          <a:latin typeface="Aptos"/>
+                        </a:rPr>
+                        <a:t>26.3%</a:t>
+                      </a:r>
+                    </a:p>
+                  </a:txBody>
+                  <a:tcPr marL="73152" marR="73152" marT="27432" marB="27432" anchor="ctr">
+                    <a:solidFill>
+                      <a:srgbClr val="E6F4EC"/>
+                    </a:solidFill>
+                  </a:tcPr>
+                </a:tc>
+                <a:tc>
+                  <a:txBody>
+                    <a:bodyPr/>
+                    <a:lstStyle/>
+                    <a:p>
+                      <a:pPr algn="r"/>
+                      <a:r>
+                        <a:rPr sz="1300" b="1">
+                          <a:solidFill>
+                            <a:srgbClr val="3C3C3B"/>
+                          </a:solidFill>
+                          <a:latin typeface="Aptos"/>
+                        </a:rPr>
+                        <a:t>41.0%</a:t>
+                      </a:r>
+                    </a:p>
+                  </a:txBody>
+                  <a:tcPr marL="73152" marR="73152" marT="27432" marB="27432" anchor="ctr">
+                    <a:solidFill>
+                      <a:srgbClr val="E6F4EC"/>
+                    </a:solidFill>
+                  </a:tcPr>
+                </a:tc>
+                <a:tc>
+                  <a:txBody>
+                    <a:bodyPr/>
+                    <a:lstStyle/>
+                    <a:p>
+                      <a:pPr algn="r"/>
+                      <a:r>
+                        <a:rPr sz="1300" b="1">
+                          <a:solidFill>
+                            <a:srgbClr val="3C3C3B"/>
+                          </a:solidFill>
+                          <a:latin typeface="Aptos"/>
+                        </a:rPr>
+                        <a:t>7.8%</a:t>
+                      </a:r>
+                    </a:p>
+                  </a:txBody>
+                  <a:tcPr marL="73152" marR="73152" marT="27432" marB="27432" anchor="ctr">
+                    <a:solidFill>
+                      <a:srgbClr val="E6F4EC"/>
+                    </a:solidFill>
+                  </a:tcPr>
+                </a:tc>
+                <a:tc>
+                  <a:txBody>
+                    <a:bodyPr/>
+                    <a:lstStyle/>
+                    <a:p>
+                      <a:pPr algn="r"/>
+                      <a:r>
+                        <a:rPr sz="1300" b="1">
+                          <a:solidFill>
+                            <a:srgbClr val="3C3C3B"/>
+                          </a:solidFill>
+                          <a:latin typeface="Aptos"/>
+                        </a:rPr>
+                        <a:t>11.7%</a:t>
+                      </a:r>
+                    </a:p>
+                  </a:txBody>
+                  <a:tcPr marL="73152" marR="73152" marT="27432" marB="27432" anchor="ctr">
+                    <a:solidFill>
+                      <a:srgbClr val="E6F4EC"/>
+                    </a:solidFill>
+                  </a:tcPr>
+                </a:tc>
+              </a:tr>
+              <a:tr h="566928">
+                <a:tc>
+                  <a:txBody>
+                    <a:bodyPr/>
+                    <a:lstStyle/>
+                    <a:p>
+                      <a:pPr algn="l"/>
+                      <a:r>
+                        <a:rPr sz="1300" b="0">
+                          <a:solidFill>
+                            <a:srgbClr val="3C3C3B"/>
+                          </a:solidFill>
+                          <a:latin typeface="Aptos"/>
+                        </a:rPr>
+                        <a:t>Wind as base, BESS not built</a:t>
+                      </a:r>
+                    </a:p>
+                  </a:txBody>
+                  <a:tcPr marL="73152" marR="73152" marT="27432" marB="27432" anchor="ctr">
+                    <a:solidFill>
+                      <a:srgbClr val="F2F2F2"/>
+                    </a:solidFill>
+                  </a:tcPr>
+                </a:tc>
+                <a:tc>
+                  <a:txBody>
+                    <a:bodyPr/>
+                    <a:lstStyle/>
+                    <a:p>
+                      <a:pPr algn="l"/>
+                      <a:r>
+                        <a:rPr sz="1300" b="0">
+                          <a:solidFill>
+                            <a:srgbClr val="3C3C3B"/>
+                          </a:solidFill>
+                          <a:latin typeface="Aptos"/>
+                        </a:rPr>
+                        <a:t>0.55</a:t>
+                      </a:r>
+                    </a:p>
+                  </a:txBody>
+                  <a:tcPr marL="73152" marR="73152" marT="27432" marB="27432" anchor="ctr">
+                    <a:noFill/>
+                  </a:tcPr>
+                </a:tc>
+                <a:tc>
+                  <a:txBody>
+                    <a:bodyPr/>
+                    <a:lstStyle/>
+                    <a:p>
+                      <a:pPr algn="r"/>
+                      <a:r>
+                        <a:rPr sz="1300" b="0">
+                          <a:solidFill>
+                            <a:srgbClr val="3C3C3B"/>
+                          </a:solidFill>
+                          <a:latin typeface="Aptos"/>
+                        </a:rPr>
+                        <a:t>0.0</a:t>
+                      </a:r>
+                    </a:p>
+                  </a:txBody>
+                  <a:tcPr marL="73152" marR="73152" marT="27432" marB="27432" anchor="ctr">
+                    <a:noFill/>
+                  </a:tcPr>
+                </a:tc>
+                <a:tc>
+                  <a:txBody>
+                    <a:bodyPr/>
+                    <a:lstStyle/>
+                    <a:p>
+                      <a:pPr algn="r"/>
+                      <a:r>
+                        <a:rPr sz="1300" b="0">
+                          <a:solidFill>
+                            <a:srgbClr val="3C3C3B"/>
+                          </a:solidFill>
+                          <a:latin typeface="Aptos"/>
+                        </a:rPr>
+                        <a:t>52.5</a:t>
+                      </a:r>
+                    </a:p>
+                  </a:txBody>
+                  <a:tcPr marL="73152" marR="73152" marT="27432" marB="27432" anchor="ctr">
+                    <a:noFill/>
+                  </a:tcPr>
+                </a:tc>
+                <a:tc>
+                  <a:txBody>
+                    <a:bodyPr/>
+                    <a:lstStyle/>
+                    <a:p>
+                      <a:pPr algn="r"/>
+                      <a:r>
+                        <a:rPr sz="1300" b="0">
+                          <a:solidFill>
+                            <a:srgbClr val="3C3C3B"/>
+                          </a:solidFill>
+                          <a:latin typeface="Aptos"/>
+                        </a:rPr>
+                        <a:t>39.8</a:t>
+                      </a:r>
+                    </a:p>
+                  </a:txBody>
+                  <a:tcPr marL="73152" marR="73152" marT="27432" marB="27432" anchor="ctr">
+                    <a:noFill/>
+                  </a:tcPr>
+                </a:tc>
+                <a:tc>
+                  <a:txBody>
+                    <a:bodyPr/>
+                    <a:lstStyle/>
+                    <a:p>
+                      <a:pPr algn="r"/>
+                      <a:r>
+                        <a:rPr sz="1300" b="0">
+                          <a:solidFill>
+                            <a:srgbClr val="3C3C3B"/>
+                          </a:solidFill>
+                          <a:latin typeface="Aptos"/>
+                        </a:rPr>
+                        <a:t>30.9%</a:t>
+                      </a:r>
+                    </a:p>
+                  </a:txBody>
+                  <a:tcPr marL="73152" marR="73152" marT="27432" marB="27432" anchor="ctr">
+                    <a:noFill/>
+                  </a:tcPr>
+                </a:tc>
+                <a:tc>
+                  <a:txBody>
+                    <a:bodyPr/>
+                    <a:lstStyle/>
+                    <a:p>
+                      <a:pPr algn="r"/>
+                      <a:r>
+                        <a:rPr sz="1300" b="0">
+                          <a:solidFill>
+                            <a:srgbClr val="3C3C3B"/>
+                          </a:solidFill>
+                          <a:latin typeface="Aptos"/>
+                        </a:rPr>
+                        <a:t>45.7%</a:t>
+                      </a:r>
+                    </a:p>
+                  </a:txBody>
+                  <a:tcPr marL="73152" marR="73152" marT="27432" marB="27432" anchor="ctr">
+                    <a:noFill/>
+                  </a:tcPr>
+                </a:tc>
+                <a:tc>
+                  <a:txBody>
+                    <a:bodyPr/>
+                    <a:lstStyle/>
+                    <a:p>
+                      <a:pPr algn="r"/>
+                      <a:r>
+                        <a:rPr sz="1300" b="0">
+                          <a:solidFill>
+                            <a:srgbClr val="3C3C3B"/>
+                          </a:solidFill>
+                          <a:latin typeface="Aptos"/>
+                        </a:rPr>
+                        <a:t>8.2%</a:t>
+                      </a:r>
+                    </a:p>
+                  </a:txBody>
+                  <a:tcPr marL="73152" marR="73152" marT="27432" marB="27432" anchor="ctr">
+                    <a:noFill/>
+                  </a:tcPr>
+                </a:tc>
+                <a:tc>
+                  <a:txBody>
+                    <a:bodyPr/>
+                    <a:lstStyle/>
+                    <a:p>
+                      <a:pPr algn="r"/>
+                      <a:r>
+                        <a:rPr sz="1300" b="0">
+                          <a:solidFill>
+                            <a:srgbClr val="3C3C3B"/>
+                          </a:solidFill>
+                          <a:latin typeface="Aptos"/>
+                        </a:rPr>
+                        <a:t>12.4%</a:t>
+                      </a:r>
+                    </a:p>
+                  </a:txBody>
+                  <a:tcPr marL="73152" marR="73152" marT="27432" marB="27432" anchor="ctr">
+                    <a:noFill/>
+                  </a:tcPr>
+                </a:tc>
+              </a:tr>
+              <a:tr h="566928">
+                <a:tc>
+                  <a:txBody>
+                    <a:bodyPr/>
+                    <a:lstStyle/>
+                    <a:p>
+                      <a:pPr algn="l"/>
+                      <a:r>
+                        <a:rPr sz="1300" b="0">
+                          <a:solidFill>
+                            <a:srgbClr val="3C3C3B"/>
+                          </a:solidFill>
+                          <a:latin typeface="Aptos"/>
+                        </a:rPr>
+                        <a:t>Neither built, PB lost pro rata (GYIK 28/30)</a:t>
+                      </a:r>
+                    </a:p>
+                  </a:txBody>
+                  <a:tcPr marL="73152" marR="73152" marT="27432" marB="27432" anchor="ctr">
+                    <a:solidFill>
+                      <a:srgbClr val="F2F2F2"/>
+                    </a:solidFill>
+                  </a:tcPr>
+                </a:tc>
+                <a:tc>
+                  <a:txBody>
+                    <a:bodyPr/>
+                    <a:lstStyle/>
+                    <a:p>
+                      <a:pPr algn="l"/>
+                      <a:r>
+                        <a:rPr sz="1300" b="0">
+                          <a:solidFill>
+                            <a:srgbClr val="3C3C3B"/>
+                          </a:solidFill>
+                          <a:latin typeface="Aptos"/>
+                        </a:rPr>
+                        <a:t>0.83</a:t>
+                      </a:r>
+                    </a:p>
+                  </a:txBody>
+                  <a:tcPr marL="73152" marR="73152" marT="27432" marB="27432" anchor="ctr">
+                    <a:noFill/>
+                  </a:tcPr>
+                </a:tc>
+                <a:tc>
+                  <a:txBody>
+                    <a:bodyPr/>
+                    <a:lstStyle/>
+                    <a:p>
+                      <a:pPr algn="r"/>
+                      <a:r>
+                        <a:rPr sz="1300" b="0">
+                          <a:solidFill>
+                            <a:srgbClr val="3C3C3B"/>
+                          </a:solidFill>
+                          <a:latin typeface="Aptos"/>
+                        </a:rPr>
+                        <a:t>8.3</a:t>
+                      </a:r>
+                    </a:p>
+                  </a:txBody>
+                  <a:tcPr marL="73152" marR="73152" marT="27432" marB="27432" anchor="ctr">
+                    <a:noFill/>
+                  </a:tcPr>
+                </a:tc>
+                <a:tc>
+                  <a:txBody>
+                    <a:bodyPr/>
+                    <a:lstStyle/>
+                    <a:p>
+                      <a:pPr algn="r"/>
+                      <a:r>
+                        <a:rPr sz="1300" b="0">
+                          <a:solidFill>
+                            <a:srgbClr val="3C3C3B"/>
+                          </a:solidFill>
+                          <a:latin typeface="Aptos"/>
+                        </a:rPr>
+                        <a:t>49.3</a:t>
+                      </a:r>
+                    </a:p>
+                  </a:txBody>
+                  <a:tcPr marL="73152" marR="73152" marT="27432" marB="27432" anchor="ctr">
+                    <a:noFill/>
+                  </a:tcPr>
+                </a:tc>
+                <a:tc>
+                  <a:txBody>
+                    <a:bodyPr/>
+                    <a:lstStyle/>
+                    <a:p>
+                      <a:pPr algn="r"/>
+                      <a:r>
+                        <a:rPr sz="1300" b="0">
+                          <a:solidFill>
+                            <a:srgbClr val="3C3C3B"/>
+                          </a:solidFill>
+                          <a:latin typeface="Aptos"/>
+                        </a:rPr>
+                        <a:t>37.7</a:t>
+                      </a:r>
+                    </a:p>
+                  </a:txBody>
+                  <a:tcPr marL="73152" marR="73152" marT="27432" marB="27432" anchor="ctr">
+                    <a:noFill/>
+                  </a:tcPr>
+                </a:tc>
+                <a:tc>
+                  <a:txBody>
+                    <a:bodyPr/>
+                    <a:lstStyle/>
+                    <a:p>
+                      <a:pPr algn="r"/>
+                      <a:r>
+                        <a:rPr sz="1300" b="0">
+                          <a:solidFill>
+                            <a:srgbClr val="3C3C3B"/>
+                          </a:solidFill>
+                          <a:latin typeface="Aptos"/>
+                        </a:rPr>
+                        <a:t>26.4%</a:t>
+                      </a:r>
+                    </a:p>
+                  </a:txBody>
+                  <a:tcPr marL="73152" marR="73152" marT="27432" marB="27432" anchor="ctr">
+                    <a:noFill/>
+                  </a:tcPr>
+                </a:tc>
+                <a:tc>
+                  <a:txBody>
+                    <a:bodyPr/>
+                    <a:lstStyle/>
+                    <a:p>
+                      <a:pPr algn="r"/>
+                      <a:r>
+                        <a:rPr sz="1300" b="0">
+                          <a:solidFill>
+                            <a:srgbClr val="3C3C3B"/>
+                          </a:solidFill>
+                          <a:latin typeface="Aptos"/>
+                        </a:rPr>
+                        <a:t>40.6%</a:t>
+                      </a:r>
+                    </a:p>
+                  </a:txBody>
+                  <a:tcPr marL="73152" marR="73152" marT="27432" marB="27432" anchor="ctr">
+                    <a:noFill/>
+                  </a:tcPr>
+                </a:tc>
+                <a:tc>
+                  <a:txBody>
+                    <a:bodyPr/>
+                    <a:lstStyle/>
+                    <a:p>
+                      <a:pPr algn="r"/>
+                      <a:r>
+                        <a:rPr sz="1300" b="0">
+                          <a:solidFill>
+                            <a:srgbClr val="3C3C3B"/>
+                          </a:solidFill>
+                          <a:latin typeface="Aptos"/>
+                        </a:rPr>
+                        <a:t>7.8%</a:t>
+                      </a:r>
+                    </a:p>
+                  </a:txBody>
+                  <a:tcPr marL="73152" marR="73152" marT="27432" marB="27432" anchor="ctr">
+                    <a:noFill/>
+                  </a:tcPr>
+                </a:tc>
+                <a:tc>
+                  <a:txBody>
+                    <a:bodyPr/>
+                    <a:lstStyle/>
+                    <a:p>
+                      <a:pPr algn="r"/>
+                      <a:r>
+                        <a:rPr sz="1300" b="0">
+                          <a:solidFill>
+                            <a:srgbClr val="3C3C3B"/>
+                          </a:solidFill>
+                          <a:latin typeface="Aptos"/>
+                        </a:rPr>
+                        <a:t>11.7%</a:t>
+                      </a:r>
+                    </a:p>
+                  </a:txBody>
+                  <a:tcPr marL="73152" marR="73152" marT="27432" marB="27432" anchor="ctr">
+                    <a:noFill/>
+                  </a:tcPr>
+                </a:tc>
+              </a:tr>
+              <a:tr h="566928">
+                <a:tc>
+                  <a:txBody>
+                    <a:bodyPr/>
+                    <a:lstStyle/>
+                    <a:p>
+                      <a:pPr algn="l"/>
+                      <a:r>
+                        <a:rPr sz="1300" b="0">
+                          <a:solidFill>
+                            <a:srgbClr val="3C3C3B"/>
+                          </a:solidFill>
+                          <a:latin typeface="Aptos"/>
+                        </a:rPr>
+                        <a:t>Neither built, full PB call (GYIK 72)</a:t>
+                      </a:r>
+                    </a:p>
+                  </a:txBody>
+                  <a:tcPr marL="73152" marR="73152" marT="27432" marB="27432" anchor="ctr">
+                    <a:solidFill>
+                      <a:srgbClr val="F2F2F2"/>
+                    </a:solidFill>
+                  </a:tcPr>
+                </a:tc>
+                <a:tc>
+                  <a:txBody>
+                    <a:bodyPr/>
+                    <a:lstStyle/>
+                    <a:p>
+                      <a:pPr algn="l"/>
+                      <a:r>
+                        <a:rPr sz="1300" b="0">
+                          <a:solidFill>
+                            <a:srgbClr val="3C3C3B"/>
+                          </a:solidFill>
+                          <a:latin typeface="Aptos"/>
+                        </a:rPr>
+                        <a:t>2.22</a:t>
+                      </a:r>
+                    </a:p>
+                  </a:txBody>
+                  <a:tcPr marL="73152" marR="73152" marT="27432" marB="27432" anchor="ctr">
+                    <a:noFill/>
+                  </a:tcPr>
+                </a:tc>
+                <a:tc>
+                  <a:txBody>
+                    <a:bodyPr/>
+                    <a:lstStyle/>
+                    <a:p>
+                      <a:pPr algn="r"/>
+                      <a:r>
+                        <a:rPr sz="1300" b="0">
+                          <a:solidFill>
+                            <a:srgbClr val="3C3C3B"/>
+                          </a:solidFill>
+                          <a:latin typeface="Aptos"/>
+                        </a:rPr>
+                        <a:t>8.3</a:t>
+                      </a:r>
+                    </a:p>
+                  </a:txBody>
+                  <a:tcPr marL="73152" marR="73152" marT="27432" marB="27432" anchor="ctr">
+                    <a:noFill/>
+                  </a:tcPr>
+                </a:tc>
+                <a:tc>
+                  <a:txBody>
+                    <a:bodyPr/>
+                    <a:lstStyle/>
+                    <a:p>
+                      <a:pPr algn="r"/>
+                      <a:r>
+                        <a:rPr sz="1300" b="0">
+                          <a:solidFill>
+                            <a:srgbClr val="3C3C3B"/>
+                          </a:solidFill>
+                          <a:latin typeface="Aptos"/>
+                        </a:rPr>
+                        <a:t>49.3</a:t>
+                      </a:r>
+                    </a:p>
+                  </a:txBody>
+                  <a:tcPr marL="73152" marR="73152" marT="27432" marB="27432" anchor="ctr">
+                    <a:noFill/>
+                  </a:tcPr>
+                </a:tc>
+                <a:tc>
+                  <a:txBody>
+                    <a:bodyPr/>
+                    <a:lstStyle/>
+                    <a:p>
+                      <a:pPr algn="r"/>
+                      <a:r>
+                        <a:rPr sz="1300" b="0">
+                          <a:solidFill>
+                            <a:srgbClr val="3C3C3B"/>
+                          </a:solidFill>
+                          <a:latin typeface="Aptos"/>
+                        </a:rPr>
+                        <a:t>37.7</a:t>
+                      </a:r>
+                    </a:p>
+                  </a:txBody>
+                  <a:tcPr marL="73152" marR="73152" marT="27432" marB="27432" anchor="ctr">
+                    <a:noFill/>
+                  </a:tcPr>
+                </a:tc>
+                <a:tc>
+                  <a:txBody>
+                    <a:bodyPr/>
+                    <a:lstStyle/>
+                    <a:p>
+                      <a:pPr algn="r"/>
+                      <a:r>
+                        <a:rPr sz="1300" b="0">
+                          <a:solidFill>
+                            <a:srgbClr val="3C3C3B"/>
+                          </a:solidFill>
+                          <a:latin typeface="Aptos"/>
+                        </a:rPr>
+                        <a:t>24.8%</a:t>
+                      </a:r>
+                    </a:p>
+                  </a:txBody>
+                  <a:tcPr marL="73152" marR="73152" marT="27432" marB="27432" anchor="ctr">
+                    <a:noFill/>
+                  </a:tcPr>
+                </a:tc>
+                <a:tc>
+                  <a:txBody>
+                    <a:bodyPr/>
+                    <a:lstStyle/>
+                    <a:p>
+                      <a:pPr algn="r"/>
+                      <a:r>
+                        <a:rPr sz="1300" b="0">
+                          <a:solidFill>
+                            <a:srgbClr val="3C3C3B"/>
+                          </a:solidFill>
+                          <a:latin typeface="Aptos"/>
+                        </a:rPr>
+                        <a:t>39.0%</a:t>
+                      </a:r>
+                    </a:p>
+                  </a:txBody>
+                  <a:tcPr marL="73152" marR="73152" marT="27432" marB="27432" anchor="ctr">
+                    <a:noFill/>
+                  </a:tcPr>
+                </a:tc>
+                <a:tc>
+                  <a:txBody>
+                    <a:bodyPr/>
+                    <a:lstStyle/>
+                    <a:p>
+                      <a:pPr algn="r"/>
+                      <a:r>
+                        <a:rPr sz="1300" b="0">
+                          <a:solidFill>
+                            <a:srgbClr val="3C3C3B"/>
+                          </a:solidFill>
+                          <a:latin typeface="Aptos"/>
+                        </a:rPr>
+                        <a:t>7.6%</a:t>
+                      </a:r>
+                    </a:p>
+                  </a:txBody>
+                  <a:tcPr marL="73152" marR="73152" marT="27432" marB="27432" anchor="ctr">
+                    <a:noFill/>
+                  </a:tcPr>
+                </a:tc>
+                <a:tc>
+                  <a:txBody>
+                    <a:bodyPr/>
+                    <a:lstStyle/>
+                    <a:p>
+                      <a:pPr algn="r"/>
+                      <a:r>
+                        <a:rPr sz="1300" b="0">
+                          <a:solidFill>
+                            <a:srgbClr val="3C3C3B"/>
+                          </a:solidFill>
+                          <a:latin typeface="Aptos"/>
+                        </a:rPr>
+                        <a:t>11.4%</a:t>
+                      </a:r>
+                    </a:p>
+                  </a:txBody>
+                  <a:tcPr marL="73152" marR="73152" marT="27432" marB="27432" anchor="ctr">
+                    <a:noFill/>
+                  </a:tcPr>
+                </a:tc>
+              </a:tr>
+            </a:tbl>
+          </a:graphicData>
+        </a:graphic>
+      </p:graphicFrame>
+      <p:sp>
+        <p:nvSpPr>
+          <p:cNvPr id="6" name="Footnote"/>
+          <p:cNvSpPr txBox="1"/>
+          <p:nvPr/>
+        </p:nvSpPr>
+        <p:spPr>
+          <a:xfrm>
+            <a:off x="4498848" y="9646920"/>
+            <a:ext cx="13167360" cy="640080"/>
+          </a:xfrm>
+          <a:prstGeom prst="rect">
+            <a:avLst/>
+          </a:prstGeom>
+          <a:noFill/>
+        </p:spPr>
+        <p:txBody>
+          <a:bodyPr wrap="square">
+            <a:spAutoFit/>
+          </a:bodyPr>
+          <a:lstStyle/>
+          <a:p>
+            <a:r>
+              <a:rPr sz="1100" b="0">
+                <a:solidFill>
+                  <a:srgbClr val="919191"/>
+                </a:solidFill>
+                <a:latin typeface="Aptos"/>
+              </a:rPr>
+              <a:t>PB call 6 months after COD. Pro rata: the shortfall above the 10 % tolerance, wind and BESS tested separately; full call: the whole PB. The connection right lost pro rata is a memo, not taken out of generation. A PB call may also trigger the 3-year group exclusion. Equity = FEP equity to COD.</a:t>
+            </a:r>
+          </a:p>
+          <a:p>
+            <a:r>
+              <a:rPr sz="1100" b="0">
+                <a:solidFill>
+                  <a:srgbClr val="919191"/>
+                </a:solidFill>
+                <a:latin typeface="Aptos"/>
+              </a:rPr>
+              <a:t>Source: Bana_Model.xlsm, 14 Oct 2026.</a:t>
+            </a:r>
+          </a:p>
+        </p:txBody>
+      </p:sp>
+    </p:spTree>
+  </p:cSld>
+  <p:clrMapOvr>
+    <a:masterClrMapping/>
+  </p:clrMapOvr>
+</p:sld>
+</file>
+
+<file path=ppt/slides/slide9.xml><?xml version="1.0" encoding="utf-8"?>
 <p:sld xmlns:a="http://schemas.openxmlformats.org/drawingml/2006/main" xmlns:p="http://schemas.openxmlformats.org/presentationml/2006/main" xmlns:r="http://schemas.openxmlformats.org/officeDocument/2006/relationships">
   <p:cSld>
     <p:spTree>
@@ -17757,7 +19525,7 @@
         </p:nvGraphicFramePr>
         <p:xfrm>
           <a:off x="0" y="0"/>
-          <a:ext cx="3767328" cy="5440680"/>
+          <a:ext cx="3767328" cy="6217920"/>
         </p:xfrm>
         <a:graphic>
           <a:graphicData uri="http://schemas.openxmlformats.org/drawingml/2006/table">
@@ -17972,6 +19740,44 @@
                           <a:latin typeface="Aptos"/>
                         </a:rPr>
                         <a:t>Sale price and buyer return</a:t>
+                      </a:r>
+                    </a:p>
+                  </a:txBody>
+                  <a:tcPr marL="180000" anchor="ctr">
+                    <a:lnL>
+                      <a:noFill/>
+                    </a:lnL>
+                    <a:lnR>
+                      <a:noFill/>
+                    </a:lnR>
+                    <a:lnT w="6350">
+                      <a:solidFill>
+                        <a:srgbClr val="3C3C3B"/>
+                      </a:solidFill>
+                    </a:lnT>
+                    <a:lnB w="6350">
+                      <a:solidFill>
+                        <a:srgbClr val="3C3C3B"/>
+                      </a:solidFill>
+                    </a:lnB>
+                    <a:noFill/>
+                  </a:tcPr>
+                </a:tc>
+              </a:tr>
+              <a:tr h="777240">
+                <a:tc>
+                  <a:txBody>
+                    <a:bodyPr/>
+                    <a:lstStyle/>
+                    <a:p>
+                      <a:r>
+                        <a:rPr sz="1800" b="0">
+                          <a:solidFill>
+                            <a:srgbClr val="3C3C3B"/>
+                          </a:solidFill>
+                          <a:latin typeface="Aptos"/>
+                        </a:rPr>
+                        <a:t>Promise or build</a:t>
                       </a:r>
                     </a:p>
                   </a:txBody>
@@ -21799,7 +23605,7 @@
         <p:spPr>
           <a:xfrm>
             <a:off x="14127480" y="2240280"/>
-            <a:ext cx="4069080" cy="7223760"/>
+            <a:ext cx="4069080" cy="5852160"/>
           </a:xfrm>
           <a:prstGeom prst="rect">
             <a:avLst/>
@@ -21864,31 +23670,6 @@
                 <a:latin typeface="Aptos"/>
               </a:rPr>
               <a:t>the permits name Goldwind; European turbines need a permit amendment and carry the most capex risk.</a:t>
-            </a:r>
-          </a:p>
-          <a:p>
-            <a:pPr algn="l">
-              <a:spcBef>
-                <a:spcPts val="800"/>
-              </a:spcBef>
-            </a:pPr>
-            <a:r>
-              <a:rPr sz="1300" b="1">
-                <a:solidFill>
-                  <a:srgbClr val="3C3C3B"/>
-                </a:solidFill>
-                <a:latin typeface="Aptos"/>
-              </a:rPr>
-              <a:t>Promise, don't build: </a:t>
-            </a:r>
-            <a:r>
-              <a:rPr sz="1300" b="0">
-                <a:solidFill>
-                  <a:srgbClr val="3C3C3B"/>
-                </a:solidFill>
-                <a:latin typeface="Aptos"/>
-              </a:rPr>
-              <a:t>if neither the overbuild nor the BESS is built, the PB call is €0.8m pro rata (€2.2m on a full call) and 8.3 MVA of connection right may be lost; COD IRR 26.4% / 40.6%, hold IRR 7.8% / 11.7% (pro rata). Not building only the BESS: COD IRR 30.9%, hold IRR 8.2%.</a:t>
             </a:r>
           </a:p>
           <a:p>

</xml_diff>

<commit_message>
Replace the partial build cases with promise all, deliver nothing (full PB call)
Co-Authored-By: Claude Opus 5.5 <noreply@anthropic.com>
Claude-Session: https://claude.ai/code/session_01AWS1t9WtpkQHcCU1WceGZT
</commit_message>
<xml_diff>
--- a/projects/bana/out/Bana_IC.pptx
+++ b/projects/bana/out/Bana_IC.pptx
@@ -251,7 +251,7 @@
                   <c:v>0.2632612602034</c:v>
                 </c:pt>
                 <c:pt idx="1">
-                  <c:v>0.0778882731983792</c:v>
+                  <c:v>0.0778882731983857</c:v>
                 </c:pt>
               </c:numCache>
             </c:numRef>
@@ -301,7 +301,7 @@
                   <c:v>0.410318082809979</c:v>
                 </c:pt>
                 <c:pt idx="1">
-                  <c:v>0.117451501890167</c:v>
+                  <c:v>0.117451501890168</c:v>
                 </c:pt>
               </c:numCache>
             </c:numRef>
@@ -17924,7 +17924,7 @@
           <a:lstStyle/>
           <a:p>
             <a:r>
-              <a:t>Promising the BESS without building it lifts the sale IRR to 30.9% / 45.7% for a €0.55m PB call</a:t>
+              <a:t>Delivering none of the commitments keeps the 59.5 / 47.5 points and costs the €2.22m PB; sale IRR 41.9% / 41.9%</a:t>
             </a:r>
           </a:p>
         </p:txBody>
@@ -18344,7 +18344,7 @@
                 </a:solidFill>
                 <a:latin typeface="Aptos"/>
               </a:rPr>
-              <a:t>The bid commits 20% overbuild (60 MW) and 20% BESS (40 MWh), 59.5 points in every case; leaving out the overbuild as well cuts the sale IRR to 26.4% / 40.6%.</a:t>
+              <a:t>Any commitment not delivered triggers the full PB call, so once one is missed the rest can be dropped too: no overbuild, no BESS, no municipal or community payments, Chinese turbines on the European route.</a:t>
             </a:r>
           </a:p>
         </p:txBody>
@@ -18359,7 +18359,7 @@
         </p:nvGraphicFramePr>
         <p:xfrm>
           <a:off x="4498848" y="2240280"/>
-          <a:ext cx="13716000" cy="2807208"/>
+          <a:ext cx="13688568" cy="1673352"/>
         </p:xfrm>
         <a:graphic>
           <a:graphicData uri="http://schemas.openxmlformats.org/drawingml/2006/table">
@@ -18368,15 +18368,16 @@
                 <a:tableStyleId>{5C22544A-7EE6-4342-B048-85BDC9FD1C3A}</a:tableStyleId>
               </a:tblPr>
               <a:tblGrid>
-                <a:gridCol w="3840480"/>
-                <a:gridCol w="1234440"/>
-                <a:gridCol w="1234440"/>
-                <a:gridCol w="1234440"/>
-                <a:gridCol w="1234440"/>
-                <a:gridCol w="1234440"/>
-                <a:gridCol w="1234440"/>
-                <a:gridCol w="1234440"/>
-                <a:gridCol w="1234440"/>
+                <a:gridCol w="2743200"/>
+                <a:gridCol w="1216152"/>
+                <a:gridCol w="1216152"/>
+                <a:gridCol w="1216152"/>
+                <a:gridCol w="1216152"/>
+                <a:gridCol w="1216152"/>
+                <a:gridCol w="1216152"/>
+                <a:gridCol w="1216152"/>
+                <a:gridCol w="1216152"/>
+                <a:gridCol w="1216152"/>
               </a:tblGrid>
               <a:tr h="539496">
                 <a:tc>
@@ -18392,7 +18393,7 @@
                           </a:solidFill>
                           <a:latin typeface="Aptos"/>
                         </a:rPr>
-                        <a:t>What is built</a:t>
+                        <a:t>Case</a:t>
                       </a:r>
                     </a:p>
                   </a:txBody>
@@ -18415,6 +18416,29 @@
                           </a:solidFill>
                           <a:latin typeface="Aptos"/>
                         </a:rPr>
+                        <a:t>Points EU</a:t>
+                      </a:r>
+                    </a:p>
+                  </a:txBody>
+                  <a:tcPr marL="73152" marR="73152" marT="27432" marB="27432" anchor="ctr">
+                    <a:solidFill>
+                      <a:srgbClr val="00A651"/>
+                    </a:solidFill>
+                  </a:tcPr>
+                </a:tc>
+                <a:tc>
+                  <a:txBody>
+                    <a:bodyPr/>
+                    <a:lstStyle/>
+                    <a:p>
+                      <a:pPr algn="r"/>
+                      <a:r>
+                        <a:rPr sz="1300" b="1">
+                          <a:solidFill>
+                            <a:srgbClr val="FFFFFF"/>
+                          </a:solidFill>
+                          <a:latin typeface="Aptos"/>
+                        </a:rPr>
                         <a:t>PB call € m</a:t>
                       </a:r>
                     </a:p>
@@ -18438,7 +18462,7 @@
                           </a:solidFill>
                           <a:latin typeface="Aptos"/>
                         </a:rPr>
-                        <a:t>MVA lost</a:t>
+                        <a:t>Equity EU € m</a:t>
                       </a:r>
                     </a:p>
                   </a:txBody>
@@ -18461,7 +18485,7 @@
                           </a:solidFill>
                           <a:latin typeface="Aptos"/>
                         </a:rPr>
-                        <a:t>Equity EU € m</a:t>
+                        <a:t>Equity CN € m</a:t>
                       </a:r>
                     </a:p>
                   </a:txBody>
@@ -18484,7 +18508,7 @@
                           </a:solidFill>
                           <a:latin typeface="Aptos"/>
                         </a:rPr>
-                        <a:t>Equity CN € m</a:t>
+                        <a:t>Sale IRR EU</a:t>
                       </a:r>
                     </a:p>
                   </a:txBody>
@@ -18507,7 +18531,7 @@
                           </a:solidFill>
                           <a:latin typeface="Aptos"/>
                         </a:rPr>
-                        <a:t>Sale IRR EU</a:t>
+                        <a:t>Sale IRR CN</a:t>
                       </a:r>
                     </a:p>
                   </a:txBody>
@@ -18530,7 +18554,7 @@
                           </a:solidFill>
                           <a:latin typeface="Aptos"/>
                         </a:rPr>
-                        <a:t>Sale IRR CN</a:t>
+                        <a:t>Hold IRR EU</a:t>
                       </a:r>
                     </a:p>
                   </a:txBody>
@@ -18553,7 +18577,7 @@
                           </a:solidFill>
                           <a:latin typeface="Aptos"/>
                         </a:rPr>
-                        <a:t>Hold IRR EU</a:t>
+                        <a:t>Hold IRR CN</a:t>
                       </a:r>
                     </a:p>
                   </a:txBody>
@@ -18576,7 +18600,7 @@
                           </a:solidFill>
                           <a:latin typeface="Aptos"/>
                         </a:rPr>
-                        <a:t>Hold IRR CN</a:t>
+                        <a:t>Buyer IRR EU</a:t>
                       </a:r>
                     </a:p>
                   </a:txBody>
@@ -18601,7 +18625,7 @@
                           </a:solidFill>
                           <a:latin typeface="Aptos"/>
                         </a:rPr>
-                        <a:t>Base: 55 MW wind and the BESS built</a:t>
+                        <a:t>Base: deliver the bid</a:t>
                       </a:r>
                     </a:p>
                   </a:txBody>
@@ -18624,6 +18648,29 @@
                           </a:solidFill>
                           <a:latin typeface="Aptos"/>
                         </a:rPr>
+                        <a:t>59.5</a:t>
+                      </a:r>
+                    </a:p>
+                  </a:txBody>
+                  <a:tcPr marL="73152" marR="73152" marT="27432" marB="27432" anchor="ctr">
+                    <a:solidFill>
+                      <a:srgbClr val="E6F4EC"/>
+                    </a:solidFill>
+                  </a:tcPr>
+                </a:tc>
+                <a:tc>
+                  <a:txBody>
+                    <a:bodyPr/>
+                    <a:lstStyle/>
+                    <a:p>
+                      <a:pPr algn="r"/>
+                      <a:r>
+                        <a:rPr sz="1300" b="1">
+                          <a:solidFill>
+                            <a:srgbClr val="3C3C3B"/>
+                          </a:solidFill>
+                          <a:latin typeface="Aptos"/>
+                        </a:rPr>
                         <a:t>0.00</a:t>
                       </a:r>
                     </a:p>
@@ -18647,7 +18694,7 @@
                           </a:solidFill>
                           <a:latin typeface="Aptos"/>
                         </a:rPr>
-                        <a:t>0.0</a:t>
+                        <a:t>54.4</a:t>
                       </a:r>
                     </a:p>
                   </a:txBody>
@@ -18670,7 +18717,7 @@
                           </a:solidFill>
                           <a:latin typeface="Aptos"/>
                         </a:rPr>
-                        <a:t>54.4</a:t>
+                        <a:t>41.7</a:t>
                       </a:r>
                     </a:p>
                   </a:txBody>
@@ -18693,7 +18740,7 @@
                           </a:solidFill>
                           <a:latin typeface="Aptos"/>
                         </a:rPr>
-                        <a:t>41.7</a:t>
+                        <a:t>26.3%</a:t>
                       </a:r>
                     </a:p>
                   </a:txBody>
@@ -18716,7 +18763,7 @@
                           </a:solidFill>
                           <a:latin typeface="Aptos"/>
                         </a:rPr>
-                        <a:t>26.3%</a:t>
+                        <a:t>41.0%</a:t>
                       </a:r>
                     </a:p>
                   </a:txBody>
@@ -18739,7 +18786,7 @@
                           </a:solidFill>
                           <a:latin typeface="Aptos"/>
                         </a:rPr>
-                        <a:t>41.0%</a:t>
+                        <a:t>7.8%</a:t>
                       </a:r>
                     </a:p>
                   </a:txBody>
@@ -18762,7 +18809,7 @@
                           </a:solidFill>
                           <a:latin typeface="Aptos"/>
                         </a:rPr>
-                        <a:t>7.8%</a:t>
+                        <a:t>11.7%</a:t>
                       </a:r>
                     </a:p>
                   </a:txBody>
@@ -18785,7 +18832,7 @@
                           </a:solidFill>
                           <a:latin typeface="Aptos"/>
                         </a:rPr>
-                        <a:t>11.7%</a:t>
+                        <a:t>5.7%</a:t>
                       </a:r>
                     </a:p>
                   </a:txBody>
@@ -18810,7 +18857,7 @@
                           </a:solidFill>
                           <a:latin typeface="Aptos"/>
                         </a:rPr>
-                        <a:t>Wind as base, BESS not built</a:t>
+                        <a:t>Promise all, deliver nothing</a:t>
                       </a:r>
                     </a:p>
                   </a:txBody>
@@ -18833,385 +18880,20 @@
                           </a:solidFill>
                           <a:latin typeface="Aptos"/>
                         </a:rPr>
-                        <a:t>0.55</a:t>
-                      </a:r>
-                    </a:p>
-                  </a:txBody>
-                  <a:tcPr marL="73152" marR="73152" marT="27432" marB="27432" anchor="ctr">
-                    <a:noFill/>
-                  </a:tcPr>
-                </a:tc>
-                <a:tc>
-                  <a:txBody>
-                    <a:bodyPr/>
-                    <a:lstStyle/>
-                    <a:p>
-                      <a:pPr algn="r"/>
-                      <a:r>
-                        <a:rPr sz="1300" b="0">
-                          <a:solidFill>
-                            <a:srgbClr val="3C3C3B"/>
-                          </a:solidFill>
-                          <a:latin typeface="Aptos"/>
-                        </a:rPr>
-                        <a:t>0.0</a:t>
-                      </a:r>
-                    </a:p>
-                  </a:txBody>
-                  <a:tcPr marL="73152" marR="73152" marT="27432" marB="27432" anchor="ctr">
-                    <a:noFill/>
-                  </a:tcPr>
-                </a:tc>
-                <a:tc>
-                  <a:txBody>
-                    <a:bodyPr/>
-                    <a:lstStyle/>
-                    <a:p>
-                      <a:pPr algn="r"/>
-                      <a:r>
-                        <a:rPr sz="1300" b="0">
-                          <a:solidFill>
-                            <a:srgbClr val="3C3C3B"/>
-                          </a:solidFill>
-                          <a:latin typeface="Aptos"/>
-                        </a:rPr>
-                        <a:t>52.5</a:t>
-                      </a:r>
-                    </a:p>
-                  </a:txBody>
-                  <a:tcPr marL="73152" marR="73152" marT="27432" marB="27432" anchor="ctr">
-                    <a:noFill/>
-                  </a:tcPr>
-                </a:tc>
-                <a:tc>
-                  <a:txBody>
-                    <a:bodyPr/>
-                    <a:lstStyle/>
-                    <a:p>
-                      <a:pPr algn="r"/>
-                      <a:r>
-                        <a:rPr sz="1300" b="0">
-                          <a:solidFill>
-                            <a:srgbClr val="3C3C3B"/>
-                          </a:solidFill>
-                          <a:latin typeface="Aptos"/>
-                        </a:rPr>
-                        <a:t>39.8</a:t>
-                      </a:r>
-                    </a:p>
-                  </a:txBody>
-                  <a:tcPr marL="73152" marR="73152" marT="27432" marB="27432" anchor="ctr">
-                    <a:noFill/>
-                  </a:tcPr>
-                </a:tc>
-                <a:tc>
-                  <a:txBody>
-                    <a:bodyPr/>
-                    <a:lstStyle/>
-                    <a:p>
-                      <a:pPr algn="r"/>
-                      <a:r>
-                        <a:rPr sz="1300" b="0">
-                          <a:solidFill>
-                            <a:srgbClr val="3C3C3B"/>
-                          </a:solidFill>
-                          <a:latin typeface="Aptos"/>
-                        </a:rPr>
-                        <a:t>30.9%</a:t>
-                      </a:r>
-                    </a:p>
-                  </a:txBody>
-                  <a:tcPr marL="73152" marR="73152" marT="27432" marB="27432" anchor="ctr">
-                    <a:noFill/>
-                  </a:tcPr>
-                </a:tc>
-                <a:tc>
-                  <a:txBody>
-                    <a:bodyPr/>
-                    <a:lstStyle/>
-                    <a:p>
-                      <a:pPr algn="r"/>
-                      <a:r>
-                        <a:rPr sz="1300" b="0">
-                          <a:solidFill>
-                            <a:srgbClr val="3C3C3B"/>
-                          </a:solidFill>
-                          <a:latin typeface="Aptos"/>
-                        </a:rPr>
-                        <a:t>45.7%</a:t>
-                      </a:r>
-                    </a:p>
-                  </a:txBody>
-                  <a:tcPr marL="73152" marR="73152" marT="27432" marB="27432" anchor="ctr">
-                    <a:noFill/>
-                  </a:tcPr>
-                </a:tc>
-                <a:tc>
-                  <a:txBody>
-                    <a:bodyPr/>
-                    <a:lstStyle/>
-                    <a:p>
-                      <a:pPr algn="r"/>
-                      <a:r>
-                        <a:rPr sz="1300" b="0">
-                          <a:solidFill>
-                            <a:srgbClr val="3C3C3B"/>
-                          </a:solidFill>
-                          <a:latin typeface="Aptos"/>
-                        </a:rPr>
-                        <a:t>8.2%</a:t>
-                      </a:r>
-                    </a:p>
-                  </a:txBody>
-                  <a:tcPr marL="73152" marR="73152" marT="27432" marB="27432" anchor="ctr">
-                    <a:noFill/>
-                  </a:tcPr>
-                </a:tc>
-                <a:tc>
-                  <a:txBody>
-                    <a:bodyPr/>
-                    <a:lstStyle/>
-                    <a:p>
-                      <a:pPr algn="r"/>
-                      <a:r>
-                        <a:rPr sz="1300" b="0">
-                          <a:solidFill>
-                            <a:srgbClr val="3C3C3B"/>
-                          </a:solidFill>
-                          <a:latin typeface="Aptos"/>
-                        </a:rPr>
-                        <a:t>12.4%</a:t>
-                      </a:r>
-                    </a:p>
-                  </a:txBody>
-                  <a:tcPr marL="73152" marR="73152" marT="27432" marB="27432" anchor="ctr">
-                    <a:noFill/>
-                  </a:tcPr>
-                </a:tc>
-              </a:tr>
-              <a:tr h="566928">
-                <a:tc>
-                  <a:txBody>
-                    <a:bodyPr/>
-                    <a:lstStyle/>
-                    <a:p>
-                      <a:pPr algn="l"/>
-                      <a:r>
-                        <a:rPr sz="1300" b="0">
-                          <a:solidFill>
-                            <a:srgbClr val="3C3C3B"/>
-                          </a:solidFill>
-                          <a:latin typeface="Aptos"/>
-                        </a:rPr>
-                        <a:t>Neither built, PB lost pro rata (GYIK 28/30)</a:t>
-                      </a:r>
-                    </a:p>
-                  </a:txBody>
-                  <a:tcPr marL="73152" marR="73152" marT="27432" marB="27432" anchor="ctr">
-                    <a:solidFill>
-                      <a:srgbClr val="F2F2F2"/>
-                    </a:solidFill>
-                  </a:tcPr>
-                </a:tc>
-                <a:tc>
-                  <a:txBody>
-                    <a:bodyPr/>
-                    <a:lstStyle/>
-                    <a:p>
-                      <a:pPr algn="l"/>
-                      <a:r>
-                        <a:rPr sz="1300" b="0">
-                          <a:solidFill>
-                            <a:srgbClr val="3C3C3B"/>
-                          </a:solidFill>
-                          <a:latin typeface="Aptos"/>
-                        </a:rPr>
-                        <a:t>0.83</a:t>
-                      </a:r>
-                    </a:p>
-                  </a:txBody>
-                  <a:tcPr marL="73152" marR="73152" marT="27432" marB="27432" anchor="ctr">
-                    <a:noFill/>
-                  </a:tcPr>
-                </a:tc>
-                <a:tc>
-                  <a:txBody>
-                    <a:bodyPr/>
-                    <a:lstStyle/>
-                    <a:p>
-                      <a:pPr algn="r"/>
-                      <a:r>
-                        <a:rPr sz="1300" b="0">
-                          <a:solidFill>
-                            <a:srgbClr val="3C3C3B"/>
-                          </a:solidFill>
-                          <a:latin typeface="Aptos"/>
-                        </a:rPr>
-                        <a:t>8.3</a:t>
-                      </a:r>
-                    </a:p>
-                  </a:txBody>
-                  <a:tcPr marL="73152" marR="73152" marT="27432" marB="27432" anchor="ctr">
-                    <a:noFill/>
-                  </a:tcPr>
-                </a:tc>
-                <a:tc>
-                  <a:txBody>
-                    <a:bodyPr/>
-                    <a:lstStyle/>
-                    <a:p>
-                      <a:pPr algn="r"/>
-                      <a:r>
-                        <a:rPr sz="1300" b="0">
-                          <a:solidFill>
-                            <a:srgbClr val="3C3C3B"/>
-                          </a:solidFill>
-                          <a:latin typeface="Aptos"/>
-                        </a:rPr>
-                        <a:t>49.3</a:t>
-                      </a:r>
-                    </a:p>
-                  </a:txBody>
-                  <a:tcPr marL="73152" marR="73152" marT="27432" marB="27432" anchor="ctr">
-                    <a:noFill/>
-                  </a:tcPr>
-                </a:tc>
-                <a:tc>
-                  <a:txBody>
-                    <a:bodyPr/>
-                    <a:lstStyle/>
-                    <a:p>
-                      <a:pPr algn="r"/>
-                      <a:r>
-                        <a:rPr sz="1300" b="0">
-                          <a:solidFill>
-                            <a:srgbClr val="3C3C3B"/>
-                          </a:solidFill>
-                          <a:latin typeface="Aptos"/>
-                        </a:rPr>
-                        <a:t>37.7</a:t>
-                      </a:r>
-                    </a:p>
-                  </a:txBody>
-                  <a:tcPr marL="73152" marR="73152" marT="27432" marB="27432" anchor="ctr">
-                    <a:noFill/>
-                  </a:tcPr>
-                </a:tc>
-                <a:tc>
-                  <a:txBody>
-                    <a:bodyPr/>
-                    <a:lstStyle/>
-                    <a:p>
-                      <a:pPr algn="r"/>
-                      <a:r>
-                        <a:rPr sz="1300" b="0">
-                          <a:solidFill>
-                            <a:srgbClr val="3C3C3B"/>
-                          </a:solidFill>
-                          <a:latin typeface="Aptos"/>
-                        </a:rPr>
-                        <a:t>26.4%</a:t>
-                      </a:r>
-                    </a:p>
-                  </a:txBody>
-                  <a:tcPr marL="73152" marR="73152" marT="27432" marB="27432" anchor="ctr">
-                    <a:noFill/>
-                  </a:tcPr>
-                </a:tc>
-                <a:tc>
-                  <a:txBody>
-                    <a:bodyPr/>
-                    <a:lstStyle/>
-                    <a:p>
-                      <a:pPr algn="r"/>
-                      <a:r>
-                        <a:rPr sz="1300" b="0">
-                          <a:solidFill>
-                            <a:srgbClr val="3C3C3B"/>
-                          </a:solidFill>
-                          <a:latin typeface="Aptos"/>
-                        </a:rPr>
-                        <a:t>40.6%</a:t>
-                      </a:r>
-                    </a:p>
-                  </a:txBody>
-                  <a:tcPr marL="73152" marR="73152" marT="27432" marB="27432" anchor="ctr">
-                    <a:noFill/>
-                  </a:tcPr>
-                </a:tc>
-                <a:tc>
-                  <a:txBody>
-                    <a:bodyPr/>
-                    <a:lstStyle/>
-                    <a:p>
-                      <a:pPr algn="r"/>
-                      <a:r>
-                        <a:rPr sz="1300" b="0">
-                          <a:solidFill>
-                            <a:srgbClr val="3C3C3B"/>
-                          </a:solidFill>
-                          <a:latin typeface="Aptos"/>
-                        </a:rPr>
-                        <a:t>7.8%</a:t>
-                      </a:r>
-                    </a:p>
-                  </a:txBody>
-                  <a:tcPr marL="73152" marR="73152" marT="27432" marB="27432" anchor="ctr">
-                    <a:noFill/>
-                  </a:tcPr>
-                </a:tc>
-                <a:tc>
-                  <a:txBody>
-                    <a:bodyPr/>
-                    <a:lstStyle/>
-                    <a:p>
-                      <a:pPr algn="r"/>
-                      <a:r>
-                        <a:rPr sz="1300" b="0">
-                          <a:solidFill>
-                            <a:srgbClr val="3C3C3B"/>
-                          </a:solidFill>
-                          <a:latin typeface="Aptos"/>
-                        </a:rPr>
-                        <a:t>11.7%</a:t>
-                      </a:r>
-                    </a:p>
-                  </a:txBody>
-                  <a:tcPr marL="73152" marR="73152" marT="27432" marB="27432" anchor="ctr">
-                    <a:noFill/>
-                  </a:tcPr>
-                </a:tc>
-              </a:tr>
-              <a:tr h="566928">
-                <a:tc>
-                  <a:txBody>
-                    <a:bodyPr/>
-                    <a:lstStyle/>
-                    <a:p>
-                      <a:pPr algn="l"/>
-                      <a:r>
-                        <a:rPr sz="1300" b="0">
-                          <a:solidFill>
-                            <a:srgbClr val="3C3C3B"/>
-                          </a:solidFill>
-                          <a:latin typeface="Aptos"/>
-                        </a:rPr>
-                        <a:t>Neither built, full PB call (GYIK 72)</a:t>
-                      </a:r>
-                    </a:p>
-                  </a:txBody>
-                  <a:tcPr marL="73152" marR="73152" marT="27432" marB="27432" anchor="ctr">
-                    <a:solidFill>
-                      <a:srgbClr val="F2F2F2"/>
-                    </a:solidFill>
-                  </a:tcPr>
-                </a:tc>
-                <a:tc>
-                  <a:txBody>
-                    <a:bodyPr/>
-                    <a:lstStyle/>
-                    <a:p>
-                      <a:pPr algn="l"/>
+                        <a:t>59.5</a:t>
+                      </a:r>
+                    </a:p>
+                  </a:txBody>
+                  <a:tcPr marL="73152" marR="73152" marT="27432" marB="27432" anchor="ctr">
+                    <a:noFill/>
+                  </a:tcPr>
+                </a:tc>
+                <a:tc>
+                  <a:txBody>
+                    <a:bodyPr/>
+                    <a:lstStyle/>
+                    <a:p>
+                      <a:pPr algn="r"/>
                       <a:r>
                         <a:rPr sz="1300" b="0">
                           <a:solidFill>
@@ -19240,133 +18922,133 @@
                           </a:solidFill>
                           <a:latin typeface="Aptos"/>
                         </a:rPr>
-                        <a:t>8.3</a:t>
-                      </a:r>
-                    </a:p>
-                  </a:txBody>
-                  <a:tcPr marL="73152" marR="73152" marT="27432" marB="27432" anchor="ctr">
-                    <a:noFill/>
-                  </a:tcPr>
-                </a:tc>
-                <a:tc>
-                  <a:txBody>
-                    <a:bodyPr/>
-                    <a:lstStyle/>
-                    <a:p>
-                      <a:pPr algn="r"/>
-                      <a:r>
-                        <a:rPr sz="1300" b="0">
-                          <a:solidFill>
-                            <a:srgbClr val="3C3C3B"/>
-                          </a:solidFill>
-                          <a:latin typeface="Aptos"/>
-                        </a:rPr>
-                        <a:t>49.3</a:t>
-                      </a:r>
-                    </a:p>
-                  </a:txBody>
-                  <a:tcPr marL="73152" marR="73152" marT="27432" marB="27432" anchor="ctr">
-                    <a:noFill/>
-                  </a:tcPr>
-                </a:tc>
-                <a:tc>
-                  <a:txBody>
-                    <a:bodyPr/>
-                    <a:lstStyle/>
-                    <a:p>
-                      <a:pPr algn="r"/>
-                      <a:r>
-                        <a:rPr sz="1300" b="0">
-                          <a:solidFill>
-                            <a:srgbClr val="3C3C3B"/>
-                          </a:solidFill>
-                          <a:latin typeface="Aptos"/>
-                        </a:rPr>
-                        <a:t>37.7</a:t>
-                      </a:r>
-                    </a:p>
-                  </a:txBody>
-                  <a:tcPr marL="73152" marR="73152" marT="27432" marB="27432" anchor="ctr">
-                    <a:noFill/>
-                  </a:tcPr>
-                </a:tc>
-                <a:tc>
-                  <a:txBody>
-                    <a:bodyPr/>
-                    <a:lstStyle/>
-                    <a:p>
-                      <a:pPr algn="r"/>
-                      <a:r>
-                        <a:rPr sz="1300" b="0">
-                          <a:solidFill>
-                            <a:srgbClr val="3C3C3B"/>
-                          </a:solidFill>
-                          <a:latin typeface="Aptos"/>
-                        </a:rPr>
-                        <a:t>24.8%</a:t>
-                      </a:r>
-                    </a:p>
-                  </a:txBody>
-                  <a:tcPr marL="73152" marR="73152" marT="27432" marB="27432" anchor="ctr">
-                    <a:noFill/>
-                  </a:tcPr>
-                </a:tc>
-                <a:tc>
-                  <a:txBody>
-                    <a:bodyPr/>
-                    <a:lstStyle/>
-                    <a:p>
-                      <a:pPr algn="r"/>
-                      <a:r>
-                        <a:rPr sz="1300" b="0">
-                          <a:solidFill>
-                            <a:srgbClr val="3C3C3B"/>
-                          </a:solidFill>
-                          <a:latin typeface="Aptos"/>
-                        </a:rPr>
-                        <a:t>39.0%</a:t>
-                      </a:r>
-                    </a:p>
-                  </a:txBody>
-                  <a:tcPr marL="73152" marR="73152" marT="27432" marB="27432" anchor="ctr">
-                    <a:noFill/>
-                  </a:tcPr>
-                </a:tc>
-                <a:tc>
-                  <a:txBody>
-                    <a:bodyPr/>
-                    <a:lstStyle/>
-                    <a:p>
-                      <a:pPr algn="r"/>
-                      <a:r>
-                        <a:rPr sz="1300" b="0">
-                          <a:solidFill>
-                            <a:srgbClr val="3C3C3B"/>
-                          </a:solidFill>
-                          <a:latin typeface="Aptos"/>
-                        </a:rPr>
-                        <a:t>7.6%</a:t>
-                      </a:r>
-                    </a:p>
-                  </a:txBody>
-                  <a:tcPr marL="73152" marR="73152" marT="27432" marB="27432" anchor="ctr">
-                    <a:noFill/>
-                  </a:tcPr>
-                </a:tc>
-                <a:tc>
-                  <a:txBody>
-                    <a:bodyPr/>
-                    <a:lstStyle/>
-                    <a:p>
-                      <a:pPr algn="r"/>
-                      <a:r>
-                        <a:rPr sz="1300" b="0">
-                          <a:solidFill>
-                            <a:srgbClr val="3C3C3B"/>
-                          </a:solidFill>
-                          <a:latin typeface="Aptos"/>
-                        </a:rPr>
-                        <a:t>11.4%</a:t>
+                        <a:t>36.5</a:t>
+                      </a:r>
+                    </a:p>
+                  </a:txBody>
+                  <a:tcPr marL="73152" marR="73152" marT="27432" marB="27432" anchor="ctr">
+                    <a:noFill/>
+                  </a:tcPr>
+                </a:tc>
+                <a:tc>
+                  <a:txBody>
+                    <a:bodyPr/>
+                    <a:lstStyle/>
+                    <a:p>
+                      <a:pPr algn="r"/>
+                      <a:r>
+                        <a:rPr sz="1300" b="0">
+                          <a:solidFill>
+                            <a:srgbClr val="3C3C3B"/>
+                          </a:solidFill>
+                          <a:latin typeface="Aptos"/>
+                        </a:rPr>
+                        <a:t>36.5</a:t>
+                      </a:r>
+                    </a:p>
+                  </a:txBody>
+                  <a:tcPr marL="73152" marR="73152" marT="27432" marB="27432" anchor="ctr">
+                    <a:noFill/>
+                  </a:tcPr>
+                </a:tc>
+                <a:tc>
+                  <a:txBody>
+                    <a:bodyPr/>
+                    <a:lstStyle/>
+                    <a:p>
+                      <a:pPr algn="r"/>
+                      <a:r>
+                        <a:rPr sz="1300" b="0">
+                          <a:solidFill>
+                            <a:srgbClr val="3C3C3B"/>
+                          </a:solidFill>
+                          <a:latin typeface="Aptos"/>
+                        </a:rPr>
+                        <a:t>41.9%</a:t>
+                      </a:r>
+                    </a:p>
+                  </a:txBody>
+                  <a:tcPr marL="73152" marR="73152" marT="27432" marB="27432" anchor="ctr">
+                    <a:noFill/>
+                  </a:tcPr>
+                </a:tc>
+                <a:tc>
+                  <a:txBody>
+                    <a:bodyPr/>
+                    <a:lstStyle/>
+                    <a:p>
+                      <a:pPr algn="r"/>
+                      <a:r>
+                        <a:rPr sz="1300" b="0">
+                          <a:solidFill>
+                            <a:srgbClr val="3C3C3B"/>
+                          </a:solidFill>
+                          <a:latin typeface="Aptos"/>
+                        </a:rPr>
+                        <a:t>41.9%</a:t>
+                      </a:r>
+                    </a:p>
+                  </a:txBody>
+                  <a:tcPr marL="73152" marR="73152" marT="27432" marB="27432" anchor="ctr">
+                    <a:noFill/>
+                  </a:tcPr>
+                </a:tc>
+                <a:tc>
+                  <a:txBody>
+                    <a:bodyPr/>
+                    <a:lstStyle/>
+                    <a:p>
+                      <a:pPr algn="r"/>
+                      <a:r>
+                        <a:rPr sz="1300" b="0">
+                          <a:solidFill>
+                            <a:srgbClr val="3C3C3B"/>
+                          </a:solidFill>
+                          <a:latin typeface="Aptos"/>
+                        </a:rPr>
+                        <a:t>12.5%</a:t>
+                      </a:r>
+                    </a:p>
+                  </a:txBody>
+                  <a:tcPr marL="73152" marR="73152" marT="27432" marB="27432" anchor="ctr">
+                    <a:noFill/>
+                  </a:tcPr>
+                </a:tc>
+                <a:tc>
+                  <a:txBody>
+                    <a:bodyPr/>
+                    <a:lstStyle/>
+                    <a:p>
+                      <a:pPr algn="r"/>
+                      <a:r>
+                        <a:rPr sz="1300" b="0">
+                          <a:solidFill>
+                            <a:srgbClr val="3C3C3B"/>
+                          </a:solidFill>
+                          <a:latin typeface="Aptos"/>
+                        </a:rPr>
+                        <a:t>12.5%</a:t>
+                      </a:r>
+                    </a:p>
+                  </a:txBody>
+                  <a:tcPr marL="73152" marR="73152" marT="27432" marB="27432" anchor="ctr">
+                    <a:noFill/>
+                  </a:tcPr>
+                </a:tc>
+                <a:tc>
+                  <a:txBody>
+                    <a:bodyPr/>
+                    <a:lstStyle/>
+                    <a:p>
+                      <a:pPr algn="r"/>
+                      <a:r>
+                        <a:rPr sz="1300" b="0">
+                          <a:solidFill>
+                            <a:srgbClr val="3C3C3B"/>
+                          </a:solidFill>
+                          <a:latin typeface="Aptos"/>
+                        </a:rPr>
+                        <a:t>7.3%</a:t>
                       </a:r>
                     </a:p>
                   </a:txBody>
@@ -19381,7 +19063,160 @@
       </p:graphicFrame>
       <p:sp>
         <p:nvSpPr>
-          <p:cNvPr id="6" name="Footnote"/>
+          <p:cNvPr id="6" name="Card"/>
+          <p:cNvSpPr/>
+          <p:nvPr/>
+        </p:nvSpPr>
+        <p:spPr>
+          <a:xfrm>
+            <a:off x="4498848" y="4572000"/>
+            <a:ext cx="13716000" cy="1737360"/>
+          </a:xfrm>
+          <a:prstGeom prst="rect">
+            <a:avLst/>
+          </a:prstGeom>
+          <a:solidFill>
+            <a:srgbClr val="F2F2F2"/>
+          </a:solidFill>
+          <a:ln>
+            <a:noFill/>
+          </a:ln>
+          <a:effectLst/>
+        </p:spPr>
+        <p:style>
+          <a:lnRef idx="1">
+            <a:schemeClr val="accent1"/>
+          </a:lnRef>
+          <a:fillRef idx="3">
+            <a:schemeClr val="accent1"/>
+          </a:fillRef>
+          <a:effectRef idx="2">
+            <a:schemeClr val="accent1"/>
+          </a:effectRef>
+          <a:fontRef idx="minor">
+            <a:schemeClr val="lt1"/>
+          </a:fontRef>
+        </p:style>
+        <p:txBody>
+          <a:bodyPr rtlCol="0" anchor="t" wrap="square" lIns="182880" rIns="182880" tIns="137160"/>
+          <a:lstStyle/>
+          <a:p>
+            <a:pPr algn="l"/>
+            <a:r>
+              <a:rPr sz="1600" b="1">
+                <a:solidFill>
+                  <a:srgbClr val="00563C"/>
+                </a:solidFill>
+                <a:latin typeface="Aptos"/>
+              </a:rPr>
+              <a:t>Before relying on it</a:t>
+            </a:r>
+          </a:p>
+          <a:p>
+            <a:pPr algn="l">
+              <a:spcBef>
+                <a:spcPts val="800"/>
+              </a:spcBef>
+            </a:pPr>
+            <a:r>
+              <a:rPr sz="1300" b="1">
+                <a:solidFill>
+                  <a:srgbClr val="3C3C3B"/>
+                </a:solidFill>
+                <a:latin typeface="Aptos"/>
+              </a:rPr>
+              <a:t>Group exclusion: </a:t>
+            </a:r>
+            <a:r>
+              <a:rPr sz="1300" b="0">
+                <a:solidFill>
+                  <a:srgbClr val="3C3C3B"/>
+                </a:solidFill>
+                <a:latin typeface="Aptos"/>
+              </a:rPr>
+              <a:t>a PB call may exclude the group from these tenders for three years.</a:t>
+            </a:r>
+          </a:p>
+          <a:p>
+            <a:pPr algn="l">
+              <a:spcBef>
+                <a:spcPts val="800"/>
+              </a:spcBef>
+            </a:pPr>
+            <a:r>
+              <a:rPr sz="1300" b="1">
+                <a:solidFill>
+                  <a:srgbClr val="3C3C3B"/>
+                </a:solidFill>
+                <a:latin typeface="Aptos"/>
+              </a:rPr>
+              <a:t>Municipality and community: </a:t>
+            </a:r>
+            <a:r>
+              <a:rPr sz="1300" b="0">
+                <a:solidFill>
+                  <a:srgbClr val="3C3C3B"/>
+                </a:solidFill>
+                <a:latin typeface="Aptos"/>
+              </a:rPr>
+              <a:t>the promised payments are public commitments; not paying them is a reputational and legal risk beyond the PB.</a:t>
+            </a:r>
+          </a:p>
+          <a:p>
+            <a:pPr algn="l">
+              <a:spcBef>
+                <a:spcPts val="800"/>
+              </a:spcBef>
+            </a:pPr>
+            <a:r>
+              <a:rPr sz="1300" b="1">
+                <a:solidFill>
+                  <a:srgbClr val="3C3C3B"/>
+                </a:solidFill>
+                <a:latin typeface="Aptos"/>
+              </a:rPr>
+              <a:t>Buyer: </a:t>
+            </a:r>
+            <a:r>
+              <a:rPr sz="1300" b="0">
+                <a:solidFill>
+                  <a:srgbClr val="3C3C3B"/>
+                </a:solidFill>
+                <a:latin typeface="Aptos"/>
+              </a:rPr>
+              <a:t>a buyer at COD sees the called PB and the missing commitments in its due diligence.</a:t>
+            </a:r>
+          </a:p>
+          <a:p>
+            <a:pPr algn="l">
+              <a:spcBef>
+                <a:spcPts val="800"/>
+              </a:spcBef>
+            </a:pPr>
+            <a:r>
+              <a:rPr sz="1300" b="1">
+                <a:solidFill>
+                  <a:srgbClr val="3C3C3B"/>
+                </a:solidFill>
+                <a:latin typeface="Aptos"/>
+              </a:rPr>
+              <a:t>Reading: </a:t>
+            </a:r>
+            <a:r>
+              <a:rPr sz="1300" b="0">
+                <a:solidFill>
+                  <a:srgbClr val="3C3C3B"/>
+                </a:solidFill>
+                <a:latin typeface="Aptos"/>
+              </a:rPr>
+              <a:t>the full call on any missed commitment follows Kiírás XIII.17 and GYIK 72; the pro-rata reading (GYIK 28/30) is the base.</a:t>
+            </a:r>
+          </a:p>
+        </p:txBody>
+      </p:sp>
+      <p:sp>
+        <p:nvSpPr>
+          <p:cNvPr id="7" name="Footnote"/>
           <p:cNvSpPr txBox="1"/>
           <p:nvPr/>
         </p:nvSpPr>
@@ -19408,7 +19243,7 @@
                 </a:solidFill>
                 <a:latin typeface="Aptos"/>
               </a:rPr>
-              <a:t>PB call 6 months after COD. Pro rata: the shortfall above the 10 % tolerance, wind and BESS tested separately; full call: the whole PB. The connection right lost pro rata is a memo, not taken out of generation. A PB call may also trigger the 3-year group exclusion. Equity = FEP equity to COD.</a:t>
+              <a:t>Deliver nothing: wind 50 MW (no overbuild), no BESS, no municipal one-off or community contribution; the European route installs Chinese turbines and sells at the Chinese price. The whole PB is called 6 months after COD. Equity = FEP equity to COD.</a:t>
             </a:r>
           </a:p>
           <a:p>
@@ -19898,7 +19733,7 @@
         </p:nvGraphicFramePr>
         <p:xfrm>
           <a:off x="4498848" y="2240280"/>
-          <a:ext cx="9509760" cy="6684264"/>
+          <a:ext cx="9509760" cy="5916168"/>
         </p:xfrm>
         <a:graphic>
           <a:graphicData uri="http://schemas.openxmlformats.org/drawingml/2006/table">
@@ -22964,7 +22799,7 @@
                           </a:solidFill>
                           <a:latin typeface="Aptos"/>
                         </a:rPr>
-                        <a:t>Not built, pro rata</a:t>
+                        <a:t>Promise all, deliver nothing</a:t>
                       </a:r>
                     </a:p>
                   </a:txBody>
@@ -23008,582 +22843,154 @@
                           </a:solidFill>
                           <a:latin typeface="Aptos"/>
                         </a:rPr>
-                        <a:t>26.4%</a:t>
-                      </a:r>
-                    </a:p>
-                  </a:txBody>
-                  <a:tcPr marL="73152" marR="73152" marT="27432" marB="27432" anchor="ctr">
-                    <a:noFill/>
-                  </a:tcPr>
-                </a:tc>
-                <a:tc>
-                  <a:txBody>
-                    <a:bodyPr/>
-                    <a:lstStyle/>
-                    <a:p>
-                      <a:pPr algn="r"/>
-                      <a:r>
-                        <a:rPr sz="1300" b="0">
-                          <a:solidFill>
-                            <a:srgbClr val="3C3C3B"/>
-                          </a:solidFill>
-                          <a:latin typeface="Aptos"/>
-                        </a:rPr>
-                        <a:t>40.6%</a:t>
-                      </a:r>
-                    </a:p>
-                  </a:txBody>
-                  <a:tcPr marL="73152" marR="73152" marT="27432" marB="27432" anchor="ctr">
-                    <a:noFill/>
-                  </a:tcPr>
-                </a:tc>
-                <a:tc>
-                  <a:txBody>
-                    <a:bodyPr/>
-                    <a:lstStyle/>
-                    <a:p>
-                      <a:pPr algn="r"/>
-                      <a:r>
-                        <a:rPr sz="1300" b="0">
-                          <a:solidFill>
-                            <a:srgbClr val="3C3C3B"/>
-                          </a:solidFill>
-                          <a:latin typeface="Aptos"/>
-                        </a:rPr>
-                        <a:t>5.7%</a:t>
-                      </a:r>
-                    </a:p>
-                  </a:txBody>
-                  <a:tcPr marL="73152" marR="73152" marT="27432" marB="27432" anchor="ctr">
-                    <a:noFill/>
-                  </a:tcPr>
-                </a:tc>
-                <a:tc>
-                  <a:txBody>
-                    <a:bodyPr/>
-                    <a:lstStyle/>
-                    <a:p>
-                      <a:pPr algn="r"/>
-                      <a:r>
-                        <a:rPr sz="1300" b="0">
-                          <a:solidFill>
-                            <a:srgbClr val="3C3C3B"/>
-                          </a:solidFill>
-                          <a:latin typeface="Aptos"/>
-                        </a:rPr>
-                        <a:t>7.0%</a:t>
-                      </a:r>
-                    </a:p>
-                  </a:txBody>
-                  <a:tcPr marL="73152" marR="73152" marT="27432" marB="27432" anchor="ctr">
-                    <a:noFill/>
-                  </a:tcPr>
-                </a:tc>
-                <a:tc>
-                  <a:txBody>
-                    <a:bodyPr/>
-                    <a:lstStyle/>
-                    <a:p>
-                      <a:pPr algn="r"/>
-                      <a:r>
-                        <a:rPr sz="1300" b="0">
-                          <a:solidFill>
-                            <a:srgbClr val="3C3C3B"/>
-                          </a:solidFill>
-                          <a:latin typeface="Aptos"/>
-                        </a:rPr>
-                        <a:t>7.8%</a:t>
-                      </a:r>
-                    </a:p>
-                  </a:txBody>
-                  <a:tcPr marL="73152" marR="73152" marT="27432" marB="27432" anchor="ctr">
-                    <a:noFill/>
-                  </a:tcPr>
-                </a:tc>
-                <a:tc>
-                  <a:txBody>
-                    <a:bodyPr/>
-                    <a:lstStyle/>
-                    <a:p>
-                      <a:pPr algn="r"/>
-                      <a:r>
-                        <a:rPr sz="1300" b="0">
-                          <a:solidFill>
-                            <a:srgbClr val="3C3C3B"/>
-                          </a:solidFill>
-                          <a:latin typeface="Aptos"/>
-                        </a:rPr>
-                        <a:t>11.7%</a:t>
-                      </a:r>
-                    </a:p>
-                  </a:txBody>
-                  <a:tcPr marL="73152" marR="73152" marT="27432" marB="27432" anchor="ctr">
-                    <a:noFill/>
-                  </a:tcPr>
-                </a:tc>
-                <a:tc>
-                  <a:txBody>
-                    <a:bodyPr/>
-                    <a:lstStyle/>
-                    <a:p>
-                      <a:pPr algn="r"/>
-                      <a:r>
-                        <a:rPr sz="1300" b="0">
-                          <a:solidFill>
-                            <a:srgbClr val="3C3C3B"/>
-                          </a:solidFill>
-                          <a:latin typeface="Aptos"/>
-                        </a:rPr>
-                        <a:t>1.92x</a:t>
-                      </a:r>
-                    </a:p>
-                  </a:txBody>
-                  <a:tcPr marL="73152" marR="73152" marT="27432" marB="27432" anchor="ctr">
-                    <a:noFill/>
-                  </a:tcPr>
-                </a:tc>
-                <a:tc>
-                  <a:txBody>
-                    <a:bodyPr/>
-                    <a:lstStyle/>
-                    <a:p>
-                      <a:pPr algn="r"/>
-                      <a:r>
-                        <a:rPr sz="1300" b="0">
-                          <a:solidFill>
-                            <a:srgbClr val="3C3C3B"/>
-                          </a:solidFill>
-                          <a:latin typeface="Aptos"/>
-                        </a:rPr>
-                        <a:t>2.55x</a:t>
-                      </a:r>
-                    </a:p>
-                  </a:txBody>
-                  <a:tcPr marL="73152" marR="73152" marT="27432" marB="27432" anchor="ctr">
-                    <a:noFill/>
-                  </a:tcPr>
-                </a:tc>
-              </a:tr>
-              <a:tr h="384048">
-                <a:tc>
-                  <a:txBody>
-                    <a:bodyPr/>
-                    <a:lstStyle/>
-                    <a:p>
-                      <a:pPr algn="l"/>
-                      <a:r>
-                        <a:rPr sz="1300" b="0">
-                          <a:solidFill>
-                            <a:srgbClr val="3C3C3B"/>
-                          </a:solidFill>
-                          <a:latin typeface="Aptos"/>
-                        </a:rPr>
-                        <a:t>Not built, full call</a:t>
-                      </a:r>
-                    </a:p>
-                  </a:txBody>
-                  <a:tcPr marL="73152" marR="73152" marT="27432" marB="27432" anchor="ctr">
-                    <a:solidFill>
-                      <a:srgbClr val="F2F2F2"/>
-                    </a:solidFill>
-                  </a:tcPr>
-                </a:tc>
-                <a:tc>
-                  <a:txBody>
-                    <a:bodyPr/>
-                    <a:lstStyle/>
-                    <a:p>
-                      <a:pPr algn="l"/>
-                      <a:r>
-                        <a:rPr sz="1300" b="0">
-                          <a:solidFill>
-                            <a:srgbClr val="3C3C3B"/>
-                          </a:solidFill>
-                          <a:latin typeface="Aptos"/>
-                        </a:rPr>
-                        <a:t>59.5</a:t>
-                      </a:r>
-                    </a:p>
-                  </a:txBody>
-                  <a:tcPr marL="73152" marR="73152" marT="27432" marB="27432" anchor="ctr">
-                    <a:noFill/>
-                  </a:tcPr>
-                </a:tc>
-                <a:tc>
-                  <a:txBody>
-                    <a:bodyPr/>
-                    <a:lstStyle/>
-                    <a:p>
-                      <a:pPr algn="r"/>
-                      <a:r>
-                        <a:rPr sz="1300" b="0">
-                          <a:solidFill>
-                            <a:srgbClr val="3C3C3B"/>
-                          </a:solidFill>
-                          <a:latin typeface="Aptos"/>
-                        </a:rPr>
-                        <a:t>24.8%</a:t>
-                      </a:r>
-                    </a:p>
-                  </a:txBody>
-                  <a:tcPr marL="73152" marR="73152" marT="27432" marB="27432" anchor="ctr">
-                    <a:noFill/>
-                  </a:tcPr>
-                </a:tc>
-                <a:tc>
-                  <a:txBody>
-                    <a:bodyPr/>
-                    <a:lstStyle/>
-                    <a:p>
-                      <a:pPr algn="r"/>
-                      <a:r>
-                        <a:rPr sz="1300" b="0">
-                          <a:solidFill>
-                            <a:srgbClr val="3C3C3B"/>
-                          </a:solidFill>
-                          <a:latin typeface="Aptos"/>
-                        </a:rPr>
-                        <a:t>39.0%</a:t>
-                      </a:r>
-                    </a:p>
-                  </a:txBody>
-                  <a:tcPr marL="73152" marR="73152" marT="27432" marB="27432" anchor="ctr">
-                    <a:noFill/>
-                  </a:tcPr>
-                </a:tc>
-                <a:tc>
-                  <a:txBody>
-                    <a:bodyPr/>
-                    <a:lstStyle/>
-                    <a:p>
-                      <a:pPr algn="r"/>
-                      <a:r>
-                        <a:rPr sz="1300" b="0">
-                          <a:solidFill>
-                            <a:srgbClr val="3C3C3B"/>
-                          </a:solidFill>
-                          <a:latin typeface="Aptos"/>
-                        </a:rPr>
-                        <a:t>5.7%</a:t>
-                      </a:r>
-                    </a:p>
-                  </a:txBody>
-                  <a:tcPr marL="73152" marR="73152" marT="27432" marB="27432" anchor="ctr">
-                    <a:noFill/>
-                  </a:tcPr>
-                </a:tc>
-                <a:tc>
-                  <a:txBody>
-                    <a:bodyPr/>
-                    <a:lstStyle/>
-                    <a:p>
-                      <a:pPr algn="r"/>
-                      <a:r>
-                        <a:rPr sz="1300" b="0">
-                          <a:solidFill>
-                            <a:srgbClr val="3C3C3B"/>
-                          </a:solidFill>
-                          <a:latin typeface="Aptos"/>
-                        </a:rPr>
-                        <a:t>7.0%</a:t>
-                      </a:r>
-                    </a:p>
-                  </a:txBody>
-                  <a:tcPr marL="73152" marR="73152" marT="27432" marB="27432" anchor="ctr">
-                    <a:noFill/>
-                  </a:tcPr>
-                </a:tc>
-                <a:tc>
-                  <a:txBody>
-                    <a:bodyPr/>
-                    <a:lstStyle/>
-                    <a:p>
-                      <a:pPr algn="r"/>
-                      <a:r>
-                        <a:rPr sz="1300" b="0">
-                          <a:solidFill>
-                            <a:srgbClr val="3C3C3B"/>
-                          </a:solidFill>
-                          <a:latin typeface="Aptos"/>
-                        </a:rPr>
-                        <a:t>7.6%</a:t>
-                      </a:r>
-                    </a:p>
-                  </a:txBody>
-                  <a:tcPr marL="73152" marR="73152" marT="27432" marB="27432" anchor="ctr">
-                    <a:noFill/>
-                  </a:tcPr>
-                </a:tc>
-                <a:tc>
-                  <a:txBody>
-                    <a:bodyPr/>
-                    <a:lstStyle/>
-                    <a:p>
-                      <a:pPr algn="r"/>
-                      <a:r>
-                        <a:rPr sz="1300" b="0">
-                          <a:solidFill>
-                            <a:srgbClr val="3C3C3B"/>
-                          </a:solidFill>
-                          <a:latin typeface="Aptos"/>
-                        </a:rPr>
-                        <a:t>11.4%</a:t>
-                      </a:r>
-                    </a:p>
-                  </a:txBody>
-                  <a:tcPr marL="73152" marR="73152" marT="27432" marB="27432" anchor="ctr">
-                    <a:noFill/>
-                  </a:tcPr>
-                </a:tc>
-                <a:tc>
-                  <a:txBody>
-                    <a:bodyPr/>
-                    <a:lstStyle/>
-                    <a:p>
-                      <a:pPr algn="r"/>
-                      <a:r>
-                        <a:rPr sz="1300" b="0">
-                          <a:solidFill>
-                            <a:srgbClr val="3C3C3B"/>
-                          </a:solidFill>
-                          <a:latin typeface="Aptos"/>
-                        </a:rPr>
-                        <a:t>1.92x</a:t>
-                      </a:r>
-                    </a:p>
-                  </a:txBody>
-                  <a:tcPr marL="73152" marR="73152" marT="27432" marB="27432" anchor="ctr">
-                    <a:noFill/>
-                  </a:tcPr>
-                </a:tc>
-                <a:tc>
-                  <a:txBody>
-                    <a:bodyPr/>
-                    <a:lstStyle/>
-                    <a:p>
-                      <a:pPr algn="r"/>
-                      <a:r>
-                        <a:rPr sz="1300" b="0">
-                          <a:solidFill>
-                            <a:srgbClr val="3C3C3B"/>
-                          </a:solidFill>
-                          <a:latin typeface="Aptos"/>
-                        </a:rPr>
-                        <a:t>2.55x</a:t>
-                      </a:r>
-                    </a:p>
-                  </a:txBody>
-                  <a:tcPr marL="73152" marR="73152" marT="27432" marB="27432" anchor="ctr">
-                    <a:noFill/>
-                  </a:tcPr>
-                </a:tc>
-              </a:tr>
-              <a:tr h="384048">
-                <a:tc>
-                  <a:txBody>
-                    <a:bodyPr/>
-                    <a:lstStyle/>
-                    <a:p>
-                      <a:pPr algn="l"/>
-                      <a:r>
-                        <a:rPr sz="1300" b="0">
-                          <a:solidFill>
-                            <a:srgbClr val="3C3C3B"/>
-                          </a:solidFill>
-                          <a:latin typeface="Aptos"/>
-                        </a:rPr>
-                        <a:t>BESS not built</a:t>
-                      </a:r>
-                    </a:p>
-                  </a:txBody>
-                  <a:tcPr marL="73152" marR="73152" marT="27432" marB="27432" anchor="ctr">
-                    <a:solidFill>
-                      <a:srgbClr val="F2F2F2"/>
-                    </a:solidFill>
-                  </a:tcPr>
-                </a:tc>
-                <a:tc>
-                  <a:txBody>
-                    <a:bodyPr/>
-                    <a:lstStyle/>
-                    <a:p>
-                      <a:pPr algn="l"/>
-                      <a:r>
-                        <a:rPr sz="1300" b="0">
-                          <a:solidFill>
-                            <a:srgbClr val="3C3C3B"/>
-                          </a:solidFill>
-                          <a:latin typeface="Aptos"/>
-                        </a:rPr>
-                        <a:t>59.5</a:t>
-                      </a:r>
-                    </a:p>
-                  </a:txBody>
-                  <a:tcPr marL="73152" marR="73152" marT="27432" marB="27432" anchor="ctr">
-                    <a:noFill/>
-                  </a:tcPr>
-                </a:tc>
-                <a:tc>
-                  <a:txBody>
-                    <a:bodyPr/>
-                    <a:lstStyle/>
-                    <a:p>
-                      <a:pPr algn="r"/>
-                      <a:r>
-                        <a:rPr sz="1300" b="0">
-                          <a:solidFill>
-                            <a:srgbClr val="3C3C3B"/>
-                          </a:solidFill>
-                          <a:latin typeface="Aptos"/>
-                        </a:rPr>
-                        <a:t>30.9%</a:t>
-                      </a:r>
-                    </a:p>
-                  </a:txBody>
-                  <a:tcPr marL="73152" marR="73152" marT="27432" marB="27432" anchor="ctr">
-                    <a:noFill/>
-                  </a:tcPr>
-                </a:tc>
-                <a:tc>
-                  <a:txBody>
-                    <a:bodyPr/>
-                    <a:lstStyle/>
-                    <a:p>
-                      <a:pPr algn="r"/>
-                      <a:r>
-                        <a:rPr sz="1300" b="0">
-                          <a:solidFill>
-                            <a:srgbClr val="3C3C3B"/>
-                          </a:solidFill>
-                          <a:latin typeface="Aptos"/>
-                        </a:rPr>
-                        <a:t>45.7%</a:t>
-                      </a:r>
-                    </a:p>
-                  </a:txBody>
-                  <a:tcPr marL="73152" marR="73152" marT="27432" marB="27432" anchor="ctr">
-                    <a:noFill/>
-                  </a:tcPr>
-                </a:tc>
-                <a:tc>
-                  <a:txBody>
-                    <a:bodyPr/>
-                    <a:lstStyle/>
-                    <a:p>
-                      <a:pPr algn="r"/>
-                      <a:r>
-                        <a:rPr sz="1300" b="0">
-                          <a:solidFill>
-                            <a:srgbClr val="3C3C3B"/>
-                          </a:solidFill>
-                          <a:latin typeface="Aptos"/>
-                        </a:rPr>
-                        <a:t>5.7%</a:t>
-                      </a:r>
-                    </a:p>
-                  </a:txBody>
-                  <a:tcPr marL="73152" marR="73152" marT="27432" marB="27432" anchor="ctr">
-                    <a:noFill/>
-                  </a:tcPr>
-                </a:tc>
-                <a:tc>
-                  <a:txBody>
-                    <a:bodyPr/>
-                    <a:lstStyle/>
-                    <a:p>
-                      <a:pPr algn="r"/>
-                      <a:r>
-                        <a:rPr sz="1300" b="0">
-                          <a:solidFill>
-                            <a:srgbClr val="3C3C3B"/>
-                          </a:solidFill>
-                          <a:latin typeface="Aptos"/>
-                        </a:rPr>
-                        <a:t>6.9%</a:t>
-                      </a:r>
-                    </a:p>
-                  </a:txBody>
-                  <a:tcPr marL="73152" marR="73152" marT="27432" marB="27432" anchor="ctr">
-                    <a:noFill/>
-                  </a:tcPr>
-                </a:tc>
-                <a:tc>
-                  <a:txBody>
-                    <a:bodyPr/>
-                    <a:lstStyle/>
-                    <a:p>
-                      <a:pPr algn="r"/>
-                      <a:r>
-                        <a:rPr sz="1300" b="0">
-                          <a:solidFill>
-                            <a:srgbClr val="3C3C3B"/>
-                          </a:solidFill>
-                          <a:latin typeface="Aptos"/>
-                        </a:rPr>
-                        <a:t>8.2%</a:t>
-                      </a:r>
-                    </a:p>
-                  </a:txBody>
-                  <a:tcPr marL="73152" marR="73152" marT="27432" marB="27432" anchor="ctr">
-                    <a:noFill/>
-                  </a:tcPr>
-                </a:tc>
-                <a:tc>
-                  <a:txBody>
-                    <a:bodyPr/>
-                    <a:lstStyle/>
-                    <a:p>
-                      <a:pPr algn="r"/>
-                      <a:r>
-                        <a:rPr sz="1300" b="0">
-                          <a:solidFill>
-                            <a:srgbClr val="3C3C3B"/>
-                          </a:solidFill>
-                          <a:latin typeface="Aptos"/>
-                        </a:rPr>
-                        <a:t>12.4%</a:t>
-                      </a:r>
-                    </a:p>
-                  </a:txBody>
-                  <a:tcPr marL="73152" marR="73152" marT="27432" marB="27432" anchor="ctr">
-                    <a:noFill/>
-                  </a:tcPr>
-                </a:tc>
-                <a:tc>
-                  <a:txBody>
-                    <a:bodyPr/>
-                    <a:lstStyle/>
-                    <a:p>
-                      <a:pPr algn="r"/>
-                      <a:r>
-                        <a:rPr sz="1300" b="0">
-                          <a:solidFill>
-                            <a:srgbClr val="3C3C3B"/>
-                          </a:solidFill>
-                          <a:latin typeface="Aptos"/>
-                        </a:rPr>
-                        <a:t>1.95x</a:t>
-                      </a:r>
-                    </a:p>
-                  </a:txBody>
-                  <a:tcPr marL="73152" marR="73152" marT="27432" marB="27432" anchor="ctr">
-                    <a:noFill/>
-                  </a:tcPr>
-                </a:tc>
-                <a:tc>
-                  <a:txBody>
-                    <a:bodyPr/>
-                    <a:lstStyle/>
-                    <a:p>
-                      <a:pPr algn="r"/>
-                      <a:r>
-                        <a:rPr sz="1300" b="0">
-                          <a:solidFill>
-                            <a:srgbClr val="3C3C3B"/>
-                          </a:solidFill>
-                          <a:latin typeface="Aptos"/>
-                        </a:rPr>
-                        <a:t>2.61x</a:t>
+                        <a:t>41.9%</a:t>
+                      </a:r>
+                    </a:p>
+                  </a:txBody>
+                  <a:tcPr marL="73152" marR="73152" marT="27432" marB="27432" anchor="ctr">
+                    <a:noFill/>
+                  </a:tcPr>
+                </a:tc>
+                <a:tc>
+                  <a:txBody>
+                    <a:bodyPr/>
+                    <a:lstStyle/>
+                    <a:p>
+                      <a:pPr algn="r"/>
+                      <a:r>
+                        <a:rPr sz="1300" b="0">
+                          <a:solidFill>
+                            <a:srgbClr val="3C3C3B"/>
+                          </a:solidFill>
+                          <a:latin typeface="Aptos"/>
+                        </a:rPr>
+                        <a:t>41.9%</a:t>
+                      </a:r>
+                    </a:p>
+                  </a:txBody>
+                  <a:tcPr marL="73152" marR="73152" marT="27432" marB="27432" anchor="ctr">
+                    <a:noFill/>
+                  </a:tcPr>
+                </a:tc>
+                <a:tc>
+                  <a:txBody>
+                    <a:bodyPr/>
+                    <a:lstStyle/>
+                    <a:p>
+                      <a:pPr algn="r"/>
+                      <a:r>
+                        <a:rPr sz="1300" b="0">
+                          <a:solidFill>
+                            <a:srgbClr val="3C3C3B"/>
+                          </a:solidFill>
+                          <a:latin typeface="Aptos"/>
+                        </a:rPr>
+                        <a:t>7.3%</a:t>
+                      </a:r>
+                    </a:p>
+                  </a:txBody>
+                  <a:tcPr marL="73152" marR="73152" marT="27432" marB="27432" anchor="ctr">
+                    <a:noFill/>
+                  </a:tcPr>
+                </a:tc>
+                <a:tc>
+                  <a:txBody>
+                    <a:bodyPr/>
+                    <a:lstStyle/>
+                    <a:p>
+                      <a:pPr algn="r"/>
+                      <a:r>
+                        <a:rPr sz="1300" b="0">
+                          <a:solidFill>
+                            <a:srgbClr val="3C3C3B"/>
+                          </a:solidFill>
+                          <a:latin typeface="Aptos"/>
+                        </a:rPr>
+                        <a:t>7.3%</a:t>
+                      </a:r>
+                    </a:p>
+                  </a:txBody>
+                  <a:tcPr marL="73152" marR="73152" marT="27432" marB="27432" anchor="ctr">
+                    <a:noFill/>
+                  </a:tcPr>
+                </a:tc>
+                <a:tc>
+                  <a:txBody>
+                    <a:bodyPr/>
+                    <a:lstStyle/>
+                    <a:p>
+                      <a:pPr algn="r"/>
+                      <a:r>
+                        <a:rPr sz="1300" b="0">
+                          <a:solidFill>
+                            <a:srgbClr val="3C3C3B"/>
+                          </a:solidFill>
+                          <a:latin typeface="Aptos"/>
+                        </a:rPr>
+                        <a:t>12.5%</a:t>
+                      </a:r>
+                    </a:p>
+                  </a:txBody>
+                  <a:tcPr marL="73152" marR="73152" marT="27432" marB="27432" anchor="ctr">
+                    <a:noFill/>
+                  </a:tcPr>
+                </a:tc>
+                <a:tc>
+                  <a:txBody>
+                    <a:bodyPr/>
+                    <a:lstStyle/>
+                    <a:p>
+                      <a:pPr algn="r"/>
+                      <a:r>
+                        <a:rPr sz="1300" b="0">
+                          <a:solidFill>
+                            <a:srgbClr val="3C3C3B"/>
+                          </a:solidFill>
+                          <a:latin typeface="Aptos"/>
+                        </a:rPr>
+                        <a:t>12.5%</a:t>
+                      </a:r>
+                    </a:p>
+                  </a:txBody>
+                  <a:tcPr marL="73152" marR="73152" marT="27432" marB="27432" anchor="ctr">
+                    <a:noFill/>
+                  </a:tcPr>
+                </a:tc>
+                <a:tc>
+                  <a:txBody>
+                    <a:bodyPr/>
+                    <a:lstStyle/>
+                    <a:p>
+                      <a:pPr algn="r"/>
+                      <a:r>
+                        <a:rPr sz="1300" b="0">
+                          <a:solidFill>
+                            <a:srgbClr val="3C3C3B"/>
+                          </a:solidFill>
+                          <a:latin typeface="Aptos"/>
+                        </a:rPr>
+                        <a:t>2.73x</a:t>
+                      </a:r>
+                    </a:p>
+                  </a:txBody>
+                  <a:tcPr marL="73152" marR="73152" marT="27432" marB="27432" anchor="ctr">
+                    <a:noFill/>
+                  </a:tcPr>
+                </a:tc>
+                <a:tc>
+                  <a:txBody>
+                    <a:bodyPr/>
+                    <a:lstStyle/>
+                    <a:p>
+                      <a:pPr algn="r"/>
+                      <a:r>
+                        <a:rPr sz="1300" b="0">
+                          <a:solidFill>
+                            <a:srgbClr val="3C3C3B"/>
+                          </a:solidFill>
+                          <a:latin typeface="Aptos"/>
+                        </a:rPr>
+                        <a:t>2.73x</a:t>
                       </a:r>
                     </a:p>
                   </a:txBody>

</xml_diff>

<commit_message>
Size Bana debt on the bank indications: 0.9 M€/MW, 15-year annuity, 1.20x DSCR; UniCredit and full-sweep sets
Co-Authored-By: Claude Opus 5.5 <noreply@anthropic.com>
Claude-Session: https://claude.ai/code/session_01AWS1t9WtpkQHcCU1WceGZT
</commit_message>
<xml_diff>
--- a/projects/bana/out/Bana_IC.pptx
+++ b/projects/bana/out/Bana_IC.pptx
@@ -248,10 +248,10 @@
                 <c:formatCode>0.0%</c:formatCode>
                 <c:ptCount val="2"/>
                 <c:pt idx="0">
-                  <c:v>0.2632612602034</c:v>
+                  <c:v>0.248075895436541</c:v>
                 </c:pt>
                 <c:pt idx="1">
-                  <c:v>0.0778882731983857</c:v>
+                  <c:v>0.0740585134078263</c:v>
                 </c:pt>
               </c:numCache>
             </c:numRef>
@@ -298,10 +298,10 @@
                 <c:formatCode>0.0%</c:formatCode>
                 <c:ptCount val="2"/>
                 <c:pt idx="0">
-                  <c:v>0.410318082809979</c:v>
+                  <c:v>0.430590128449621</c:v>
                 </c:pt>
                 <c:pt idx="1">
-                  <c:v>0.117451501890168</c:v>
+                  <c:v>0.118465201099218</c:v>
                 </c:pt>
               </c:numCache>
             </c:numRef>
@@ -6032,7 +6032,7 @@
           <a:lstStyle/>
           <a:p>
             <a:r>
-              <a:t>At €4.50m, Bana returns 26.3% (European) / 41.0% (Chinese) on a sale at COD and 7.8% / 11.7% if held</a:t>
+              <a:t>At €4.50m, Bana returns 24.8% (European) / 43.1% (Chinese) on a sale at COD and 7.4% / 11.8% if held</a:t>
             </a:r>
           </a:p>
         </p:txBody>
@@ -6452,7 +6452,7 @@
                 </a:solidFill>
                 <a:latin typeface="Aptos"/>
               </a:rPr>
-              <a:t>FEP funds €54.4m of equity to COD (€41.7m Chinese) and bids 59.5 points (47.5 Chinese) into the 30 October tender; the European route needs a permit amendment.</a:t>
+              <a:t>FEP funds €63.2m of equity to COD (€36.0m Chinese) and bids 59.5 points (47.5 Chinese) into the 30 October tender; the European route needs a permit amendment.</a:t>
             </a:r>
           </a:p>
         </p:txBody>
@@ -6869,28 +6869,28 @@
                           </a:solidFill>
                           <a:latin typeface="Aptos"/>
                         </a:rPr>
-                        <a:t>54.4</a:t>
-                      </a:r>
-                    </a:p>
-                  </a:txBody>
-                  <a:tcPr marL="73152" marR="73152" marT="27432" marB="27432" anchor="ctr">
-                    <a:noFill/>
-                  </a:tcPr>
-                </a:tc>
-                <a:tc>
-                  <a:txBody>
-                    <a:bodyPr/>
-                    <a:lstStyle/>
-                    <a:p>
-                      <a:pPr algn="r"/>
-                      <a:r>
-                        <a:rPr sz="1300" b="0">
-                          <a:solidFill>
-                            <a:srgbClr val="3C3C3B"/>
-                          </a:solidFill>
-                          <a:latin typeface="Aptos"/>
-                        </a:rPr>
-                        <a:t>41.7</a:t>
+                        <a:t>63.2</a:t>
+                      </a:r>
+                    </a:p>
+                  </a:txBody>
+                  <a:tcPr marL="73152" marR="73152" marT="27432" marB="27432" anchor="ctr">
+                    <a:noFill/>
+                  </a:tcPr>
+                </a:tc>
+                <a:tc>
+                  <a:txBody>
+                    <a:bodyPr/>
+                    <a:lstStyle/>
+                    <a:p>
+                      <a:pPr algn="r"/>
+                      <a:r>
+                        <a:rPr sz="1300" b="0">
+                          <a:solidFill>
+                            <a:srgbClr val="3C3C3B"/>
+                          </a:solidFill>
+                          <a:latin typeface="Aptos"/>
+                        </a:rPr>
+                        <a:t>36.0</a:t>
                       </a:r>
                     </a:p>
                   </a:txBody>
@@ -7026,28 +7026,28 @@
                           </a:solidFill>
                           <a:latin typeface="Aptos"/>
                         </a:rPr>
-                        <a:t>20.2</a:t>
-                      </a:r>
-                    </a:p>
-                  </a:txBody>
-                  <a:tcPr marL="73152" marR="73152" marT="27432" marB="27432" anchor="ctr">
-                    <a:noFill/>
-                  </a:tcPr>
-                </a:tc>
-                <a:tc>
-                  <a:txBody>
-                    <a:bodyPr/>
-                    <a:lstStyle/>
-                    <a:p>
-                      <a:pPr algn="r"/>
-                      <a:r>
-                        <a:rPr sz="1300" b="0">
-                          <a:solidFill>
-                            <a:srgbClr val="3C3C3B"/>
-                          </a:solidFill>
-                          <a:latin typeface="Aptos"/>
-                        </a:rPr>
-                        <a:t>29.4</a:t>
+                        <a:t>20.9</a:t>
+                      </a:r>
+                    </a:p>
+                  </a:txBody>
+                  <a:tcPr marL="73152" marR="73152" marT="27432" marB="27432" anchor="ctr">
+                    <a:noFill/>
+                  </a:tcPr>
+                </a:tc>
+                <a:tc>
+                  <a:txBody>
+                    <a:bodyPr/>
+                    <a:lstStyle/>
+                    <a:p>
+                      <a:pPr algn="r"/>
+                      <a:r>
+                        <a:rPr sz="1300" b="0">
+                          <a:solidFill>
+                            <a:srgbClr val="3C3C3B"/>
+                          </a:solidFill>
+                          <a:latin typeface="Aptos"/>
+                        </a:rPr>
+                        <a:t>29.0</a:t>
                       </a:r>
                     </a:p>
                   </a:txBody>
@@ -7116,7 +7116,7 @@
                           </a:solidFill>
                           <a:latin typeface="Aptos"/>
                         </a:rPr>
-                        <a:t>26.3%</a:t>
+                        <a:t>24.8%</a:t>
                       </a:r>
                     </a:p>
                   </a:txBody>
@@ -7139,7 +7139,7 @@
                           </a:solidFill>
                           <a:latin typeface="Aptos"/>
                         </a:rPr>
-                        <a:t>41.0%</a:t>
+                        <a:t>43.1%</a:t>
                       </a:r>
                     </a:p>
                   </a:txBody>
@@ -7210,28 +7210,28 @@
                           </a:solidFill>
                           <a:latin typeface="Aptos"/>
                         </a:rPr>
-                        <a:t>1.37x</a:t>
-                      </a:r>
-                    </a:p>
-                  </a:txBody>
-                  <a:tcPr marL="73152" marR="73152" marT="27432" marB="27432" anchor="ctr">
-                    <a:noFill/>
-                  </a:tcPr>
-                </a:tc>
-                <a:tc>
-                  <a:txBody>
-                    <a:bodyPr/>
-                    <a:lstStyle/>
-                    <a:p>
-                      <a:pPr algn="r"/>
-                      <a:r>
-                        <a:rPr sz="1300" b="0">
-                          <a:solidFill>
-                            <a:srgbClr val="3C3C3B"/>
-                          </a:solidFill>
-                          <a:latin typeface="Aptos"/>
-                        </a:rPr>
-                        <a:t>1.71x</a:t>
+                        <a:t>1.33x</a:t>
+                      </a:r>
+                    </a:p>
+                  </a:txBody>
+                  <a:tcPr marL="73152" marR="73152" marT="27432" marB="27432" anchor="ctr">
+                    <a:noFill/>
+                  </a:tcPr>
+                </a:tc>
+                <a:tc>
+                  <a:txBody>
+                    <a:bodyPr/>
+                    <a:lstStyle/>
+                    <a:p>
+                      <a:pPr algn="r"/>
+                      <a:r>
+                        <a:rPr sz="1300" b="0">
+                          <a:solidFill>
+                            <a:srgbClr val="3C3C3B"/>
+                          </a:solidFill>
+                          <a:latin typeface="Aptos"/>
+                        </a:rPr>
+                        <a:t>1.80x</a:t>
                       </a:r>
                     </a:p>
                   </a:txBody>
@@ -7300,7 +7300,7 @@
                           </a:solidFill>
                           <a:latin typeface="Aptos"/>
                         </a:rPr>
-                        <a:t>5.7%</a:t>
+                        <a:t>5.6%</a:t>
                       </a:r>
                     </a:p>
                   </a:txBody>
@@ -7457,7 +7457,7 @@
                           </a:solidFill>
                           <a:latin typeface="Aptos"/>
                         </a:rPr>
-                        <a:t>7.8%</a:t>
+                        <a:t>7.4%</a:t>
                       </a:r>
                     </a:p>
                   </a:txBody>
@@ -7480,7 +7480,7 @@
                           </a:solidFill>
                           <a:latin typeface="Aptos"/>
                         </a:rPr>
-                        <a:t>11.7%</a:t>
+                        <a:t>11.8%</a:t>
                       </a:r>
                     </a:p>
                   </a:txBody>
@@ -7551,28 +7551,28 @@
                           </a:solidFill>
                           <a:latin typeface="Aptos"/>
                         </a:rPr>
-                        <a:t>3.31x</a:t>
-                      </a:r>
-                    </a:p>
-                  </a:txBody>
-                  <a:tcPr marL="73152" marR="73152" marT="27432" marB="27432" anchor="ctr">
-                    <a:noFill/>
-                  </a:tcPr>
-                </a:tc>
-                <a:tc>
-                  <a:txBody>
-                    <a:bodyPr/>
-                    <a:lstStyle/>
-                    <a:p>
-                      <a:pPr algn="r"/>
-                      <a:r>
-                        <a:rPr sz="1300" b="0">
-                          <a:solidFill>
-                            <a:srgbClr val="3C3C3B"/>
-                          </a:solidFill>
-                          <a:latin typeface="Aptos"/>
-                        </a:rPr>
-                        <a:t>4.74x</a:t>
+                        <a:t>3.13x</a:t>
+                      </a:r>
+                    </a:p>
+                  </a:txBody>
+                  <a:tcPr marL="73152" marR="73152" marT="27432" marB="27432" anchor="ctr">
+                    <a:noFill/>
+                  </a:tcPr>
+                </a:tc>
+                <a:tc>
+                  <a:txBody>
+                    <a:bodyPr/>
+                    <a:lstStyle/>
+                    <a:p>
+                      <a:pPr algn="r"/>
+                      <a:r>
+                        <a:rPr sz="1300" b="0">
+                          <a:solidFill>
+                            <a:srgbClr val="3C3C3B"/>
+                          </a:solidFill>
+                          <a:latin typeface="Aptos"/>
+                        </a:rPr>
+                        <a:t>5.31x</a:t>
                       </a:r>
                     </a:p>
                   </a:txBody>
@@ -7641,28 +7641,28 @@
                           </a:solidFill>
                           <a:latin typeface="Aptos"/>
                         </a:rPr>
-                        <a:t>(1.2)</a:t>
-                      </a:r>
-                    </a:p>
-                  </a:txBody>
-                  <a:tcPr marL="73152" marR="73152" marT="27432" marB="27432" anchor="ctr">
-                    <a:noFill/>
-                  </a:tcPr>
-                </a:tc>
-                <a:tc>
-                  <a:txBody>
-                    <a:bodyPr/>
-                    <a:lstStyle/>
-                    <a:p>
-                      <a:pPr algn="r"/>
-                      <a:r>
-                        <a:rPr sz="1300" b="0">
-                          <a:solidFill>
-                            <a:srgbClr val="3C3C3B"/>
-                          </a:solidFill>
-                          <a:latin typeface="Aptos"/>
-                        </a:rPr>
-                        <a:t>16.7</a:t>
+                        <a:t>(3.7)</a:t>
+                      </a:r>
+                    </a:p>
+                  </a:txBody>
+                  <a:tcPr marL="73152" marR="73152" marT="27432" marB="27432" anchor="ctr">
+                    <a:noFill/>
+                  </a:tcPr>
+                </a:tc>
+                <a:tc>
+                  <a:txBody>
+                    <a:bodyPr/>
+                    <a:lstStyle/>
+                    <a:p>
+                      <a:pPr algn="r"/>
+                      <a:r>
+                        <a:rPr sz="1300" b="0">
+                          <a:solidFill>
+                            <a:srgbClr val="3C3C3B"/>
+                          </a:solidFill>
+                          <a:latin typeface="Aptos"/>
+                        </a:rPr>
+                        <a:t>16.6</a:t>
                       </a:r>
                     </a:p>
                   </a:txBody>
@@ -7731,28 +7731,28 @@
                           </a:solidFill>
                           <a:latin typeface="Aptos"/>
                         </a:rPr>
-                        <a:t>1.88x</a:t>
-                      </a:r>
-                    </a:p>
-                  </a:txBody>
-                  <a:tcPr marL="73152" marR="73152" marT="27432" marB="27432" anchor="ctr">
-                    <a:noFill/>
-                  </a:tcPr>
-                </a:tc>
-                <a:tc>
-                  <a:txBody>
-                    <a:bodyPr/>
-                    <a:lstStyle/>
-                    <a:p>
-                      <a:pPr algn="r"/>
-                      <a:r>
-                        <a:rPr sz="1300" b="0">
-                          <a:solidFill>
-                            <a:srgbClr val="3C3C3B"/>
-                          </a:solidFill>
-                          <a:latin typeface="Aptos"/>
-                        </a:rPr>
-                        <a:t>2.48x</a:t>
+                        <a:t>1.94x</a:t>
+                      </a:r>
+                    </a:p>
+                  </a:txBody>
+                  <a:tcPr marL="73152" marR="73152" marT="27432" marB="27432" anchor="ctr">
+                    <a:noFill/>
+                  </a:tcPr>
+                </a:tc>
+                <a:tc>
+                  <a:txBody>
+                    <a:bodyPr/>
+                    <a:lstStyle/>
+                    <a:p>
+                      <a:pPr algn="r"/>
+                      <a:r>
+                        <a:rPr sz="1300" b="0">
+                          <a:solidFill>
+                            <a:srgbClr val="3C3C3B"/>
+                          </a:solidFill>
+                          <a:latin typeface="Aptos"/>
+                        </a:rPr>
+                        <a:t>1.89x</a:t>
                       </a:r>
                     </a:p>
                   </a:txBody>
@@ -11780,7 +11780,7 @@
           <a:lstStyle/>
           <a:p>
             <a:r>
-              <a:t>Uses to COD of €113.4m with European turbines (€85.1m Chinese); senior debt funds 52% (51%) and FEP the rest</a:t>
+              <a:t>Uses to COD of €112.7m with European turbines (€85.5m Chinese); senior debt funds 44% (58%) and FEP the rest</a:t>
             </a:r>
           </a:p>
         </p:txBody>
@@ -12833,28 +12833,28 @@
                           </a:solidFill>
                           <a:latin typeface="Aptos"/>
                         </a:rPr>
-                        <a:t>4.2</a:t>
-                      </a:r>
-                    </a:p>
-                  </a:txBody>
-                  <a:tcPr marL="73152" marR="73152" marT="27432" marB="27432" anchor="ctr">
-                    <a:noFill/>
-                  </a:tcPr>
-                </a:tc>
-                <a:tc>
-                  <a:txBody>
-                    <a:bodyPr/>
-                    <a:lstStyle/>
-                    <a:p>
-                      <a:pPr algn="r"/>
-                      <a:r>
-                        <a:rPr sz="1300" b="0">
-                          <a:solidFill>
-                            <a:srgbClr val="3C3C3B"/>
-                          </a:solidFill>
-                          <a:latin typeface="Aptos"/>
-                        </a:rPr>
-                        <a:t>3.1</a:t>
+                        <a:t>3.5</a:t>
+                      </a:r>
+                    </a:p>
+                  </a:txBody>
+                  <a:tcPr marL="73152" marR="73152" marT="27432" marB="27432" anchor="ctr">
+                    <a:noFill/>
+                  </a:tcPr>
+                </a:tc>
+                <a:tc>
+                  <a:txBody>
+                    <a:bodyPr/>
+                    <a:lstStyle/>
+                    <a:p>
+                      <a:pPr algn="r"/>
+                      <a:r>
+                        <a:rPr sz="1300" b="0">
+                          <a:solidFill>
+                            <a:srgbClr val="3C3C3B"/>
+                          </a:solidFill>
+                          <a:latin typeface="Aptos"/>
+                        </a:rPr>
+                        <a:t>3.5</a:t>
                       </a:r>
                     </a:p>
                   </a:txBody>
@@ -13013,7 +13013,7 @@
                           </a:solidFill>
                           <a:latin typeface="Aptos"/>
                         </a:rPr>
-                        <a:t>113.4</a:t>
+                        <a:t>112.7</a:t>
                       </a:r>
                     </a:p>
                   </a:txBody>
@@ -13036,7 +13036,7 @@
                           </a:solidFill>
                           <a:latin typeface="Aptos"/>
                         </a:rPr>
-                        <a:t>85.1</a:t>
+                        <a:t>85.5</a:t>
                       </a:r>
                     </a:p>
                   </a:txBody>
@@ -13107,28 +13107,28 @@
                           </a:solidFill>
                           <a:latin typeface="Aptos"/>
                         </a:rPr>
-                        <a:t>59.1</a:t>
-                      </a:r>
-                    </a:p>
-                  </a:txBody>
-                  <a:tcPr marL="73152" marR="73152" marT="27432" marB="27432" anchor="ctr">
-                    <a:noFill/>
-                  </a:tcPr>
-                </a:tc>
-                <a:tc>
-                  <a:txBody>
-                    <a:bodyPr/>
-                    <a:lstStyle/>
-                    <a:p>
-                      <a:pPr algn="r"/>
-                      <a:r>
-                        <a:rPr sz="1300" b="0">
-                          <a:solidFill>
-                            <a:srgbClr val="3C3C3B"/>
-                          </a:solidFill>
-                          <a:latin typeface="Aptos"/>
-                        </a:rPr>
-                        <a:t>43.4</a:t>
+                        <a:t>49.5</a:t>
+                      </a:r>
+                    </a:p>
+                  </a:txBody>
+                  <a:tcPr marL="73152" marR="73152" marT="27432" marB="27432" anchor="ctr">
+                    <a:noFill/>
+                  </a:tcPr>
+                </a:tc>
+                <a:tc>
+                  <a:txBody>
+                    <a:bodyPr/>
+                    <a:lstStyle/>
+                    <a:p>
+                      <a:pPr algn="r"/>
+                      <a:r>
+                        <a:rPr sz="1300" b="0">
+                          <a:solidFill>
+                            <a:srgbClr val="3C3C3B"/>
+                          </a:solidFill>
+                          <a:latin typeface="Aptos"/>
+                        </a:rPr>
+                        <a:t>49.5</a:t>
                       </a:r>
                     </a:p>
                   </a:txBody>
@@ -13197,7 +13197,7 @@
                           </a:solidFill>
                           <a:latin typeface="Aptos"/>
                         </a:rPr>
-                        <a:t>54.4</a:t>
+                        <a:t>63.2</a:t>
                       </a:r>
                     </a:p>
                   </a:txBody>
@@ -13220,7 +13220,7 @@
                           </a:solidFill>
                           <a:latin typeface="Aptos"/>
                         </a:rPr>
-                        <a:t>41.7</a:t>
+                        <a:t>36.0</a:t>
                       </a:r>
                     </a:p>
                   </a:txBody>
@@ -13291,28 +13291,28 @@
                           </a:solidFill>
                           <a:latin typeface="Aptos"/>
                         </a:rPr>
-                        <a:t>55.6</a:t>
-                      </a:r>
-                    </a:p>
-                  </a:txBody>
-                  <a:tcPr marL="73152" marR="73152" marT="27432" marB="27432" anchor="ctr">
-                    <a:noFill/>
-                  </a:tcPr>
-                </a:tc>
-                <a:tc>
-                  <a:txBody>
-                    <a:bodyPr/>
-                    <a:lstStyle/>
-                    <a:p>
-                      <a:pPr algn="r"/>
-                      <a:r>
-                        <a:rPr sz="1300" b="0">
-                          <a:solidFill>
-                            <a:srgbClr val="3C3C3B"/>
-                          </a:solidFill>
-                          <a:latin typeface="Aptos"/>
-                        </a:rPr>
-                        <a:t>42.6</a:t>
+                        <a:t>64.4</a:t>
+                      </a:r>
+                    </a:p>
+                  </a:txBody>
+                  <a:tcPr marL="73152" marR="73152" marT="27432" marB="27432" anchor="ctr">
+                    <a:noFill/>
+                  </a:tcPr>
+                </a:tc>
+                <a:tc>
+                  <a:txBody>
+                    <a:bodyPr/>
+                    <a:lstStyle/>
+                    <a:p>
+                      <a:pPr algn="r"/>
+                      <a:r>
+                        <a:rPr sz="1300" b="0">
+                          <a:solidFill>
+                            <a:srgbClr val="3C3C3B"/>
+                          </a:solidFill>
+                          <a:latin typeface="Aptos"/>
+                        </a:rPr>
+                        <a:t>37.2</a:t>
                       </a:r>
                     </a:p>
                   </a:txBody>
@@ -14106,7 +14106,7 @@
                 </a:solidFill>
                 <a:latin typeface="Aptos"/>
               </a:rPr>
-              <a:t>Debt share = senior debt at COD ÷ total uses. Debt draws pro rata with construction costs at up to 55% of cost on both routes; interest capitalised to COD. Securities are the same on both routes; HUF amounts at 365 HUF/EUR.</a:t>
+              <a:t>Debt share = senior debt at COD ÷ total uses. Debt = €0.9m per built wind MW on both routes (bank indication), drawn pro rata with construction costs; interest capitalised to COD. Securities are the same on both routes; HUF amounts at 365 HUF/EUR.</a:t>
             </a:r>
           </a:p>
           <a:p>
@@ -14161,7 +14161,7 @@
           <a:lstStyle/>
           <a:p>
             <a:r>
-              <a:t>A sale at COD turns €54.4m of equity into €74.6m (1.37x); holding earns 7.8% at a 1.88x DSCR (European)</a:t>
+              <a:t>A sale at COD turns €63.2m of equity into €84.1m (1.33x); holding earns 7.4% at a 1.94x DSCR (European)</a:t>
             </a:r>
           </a:p>
         </p:txBody>
@@ -14581,7 +14581,7 @@
                 </a:solidFill>
                 <a:latin typeface="Aptos"/>
               </a:rPr>
-              <a:t>With Chinese turbines the sale returns 41.0% and the hold 11.7%; debt is capped at 55% of construction cost on both routes.</a:t>
+              <a:t>With Chinese turbines the sale returns 43.1% and the hold 11.8%; debt is €49.5m on both routes, a 15-year annuity.</a:t>
             </a:r>
           </a:p>
         </p:txBody>
@@ -14944,28 +14944,28 @@
                           </a:solidFill>
                           <a:latin typeface="Aptos"/>
                         </a:rPr>
-                        <a:t>(59.1)</a:t>
-                      </a:r>
-                    </a:p>
-                  </a:txBody>
-                  <a:tcPr marL="73152" marR="73152" marT="27432" marB="27432" anchor="ctr">
-                    <a:noFill/>
-                  </a:tcPr>
-                </a:tc>
-                <a:tc>
-                  <a:txBody>
-                    <a:bodyPr/>
-                    <a:lstStyle/>
-                    <a:p>
-                      <a:pPr algn="r"/>
-                      <a:r>
-                        <a:rPr sz="1300" b="0">
-                          <a:solidFill>
-                            <a:srgbClr val="3C3C3B"/>
-                          </a:solidFill>
-                          <a:latin typeface="Aptos"/>
-                        </a:rPr>
-                        <a:t>(43.4)</a:t>
+                        <a:t>(49.5)</a:t>
+                      </a:r>
+                    </a:p>
+                  </a:txBody>
+                  <a:tcPr marL="73152" marR="73152" marT="27432" marB="27432" anchor="ctr">
+                    <a:noFill/>
+                  </a:tcPr>
+                </a:tc>
+                <a:tc>
+                  <a:txBody>
+                    <a:bodyPr/>
+                    <a:lstStyle/>
+                    <a:p>
+                      <a:pPr algn="r"/>
+                      <a:r>
+                        <a:rPr sz="1300" b="0">
+                          <a:solidFill>
+                            <a:srgbClr val="3C3C3B"/>
+                          </a:solidFill>
+                          <a:latin typeface="Aptos"/>
+                        </a:rPr>
+                        <a:t>(49.5)</a:t>
                       </a:r>
                     </a:p>
                   </a:txBody>
@@ -15076,28 +15076,28 @@
                           </a:solidFill>
                           <a:latin typeface="Aptos"/>
                         </a:rPr>
-                        <a:t>74.6</a:t>
-                      </a:r>
-                    </a:p>
-                  </a:txBody>
-                  <a:tcPr marL="73152" marR="73152" marT="27432" marB="27432" anchor="ctr">
-                    <a:noFill/>
-                  </a:tcPr>
-                </a:tc>
-                <a:tc>
-                  <a:txBody>
-                    <a:bodyPr/>
-                    <a:lstStyle/>
-                    <a:p>
-                      <a:pPr algn="r"/>
-                      <a:r>
-                        <a:rPr sz="1300" b="0">
-                          <a:solidFill>
-                            <a:srgbClr val="3C3C3B"/>
-                          </a:solidFill>
-                          <a:latin typeface="Aptos"/>
-                        </a:rPr>
-                        <a:t>71.1</a:t>
+                        <a:t>84.1</a:t>
+                      </a:r>
+                    </a:p>
+                  </a:txBody>
+                  <a:tcPr marL="73152" marR="73152" marT="27432" marB="27432" anchor="ctr">
+                    <a:noFill/>
+                  </a:tcPr>
+                </a:tc>
+                <a:tc>
+                  <a:txBody>
+                    <a:bodyPr/>
+                    <a:lstStyle/>
+                    <a:p>
+                      <a:pPr algn="r"/>
+                      <a:r>
+                        <a:rPr sz="1300" b="0">
+                          <a:solidFill>
+                            <a:srgbClr val="3C3C3B"/>
+                          </a:solidFill>
+                          <a:latin typeface="Aptos"/>
+                        </a:rPr>
+                        <a:t>65.0</a:t>
                       </a:r>
                     </a:p>
                   </a:txBody>
@@ -15208,7 +15208,7 @@
                           </a:solidFill>
                           <a:latin typeface="Aptos"/>
                         </a:rPr>
-                        <a:t>5.7% / 5.9%</a:t>
+                        <a:t>5.6% / 5.7%</a:t>
                       </a:r>
                     </a:p>
                   </a:txBody>
@@ -15340,70 +15340,70 @@
                           </a:solidFill>
                           <a:latin typeface="Aptos"/>
                         </a:rPr>
-                        <a:t>54.4</a:t>
-                      </a:r>
-                    </a:p>
-                  </a:txBody>
-                  <a:tcPr marL="73152" marR="73152" marT="27432" marB="27432" anchor="ctr">
-                    <a:noFill/>
-                  </a:tcPr>
-                </a:tc>
-                <a:tc>
-                  <a:txBody>
-                    <a:bodyPr/>
-                    <a:lstStyle/>
-                    <a:p>
-                      <a:pPr algn="r"/>
-                      <a:r>
-                        <a:rPr sz="1300" b="0">
-                          <a:solidFill>
-                            <a:srgbClr val="3C3C3B"/>
-                          </a:solidFill>
-                          <a:latin typeface="Aptos"/>
-                        </a:rPr>
-                        <a:t>41.7</a:t>
-                      </a:r>
-                    </a:p>
-                  </a:txBody>
-                  <a:tcPr marL="73152" marR="73152" marT="27432" marB="27432" anchor="ctr">
-                    <a:noFill/>
-                  </a:tcPr>
-                </a:tc>
-                <a:tc>
-                  <a:txBody>
-                    <a:bodyPr/>
-                    <a:lstStyle/>
-                    <a:p>
-                      <a:pPr algn="r"/>
-                      <a:r>
-                        <a:rPr sz="1300" b="0">
-                          <a:solidFill>
-                            <a:srgbClr val="3C3C3B"/>
-                          </a:solidFill>
-                          <a:latin typeface="Aptos"/>
-                        </a:rPr>
-                        <a:t>55.6</a:t>
-                      </a:r>
-                    </a:p>
-                  </a:txBody>
-                  <a:tcPr marL="73152" marR="73152" marT="27432" marB="27432" anchor="ctr">
-                    <a:noFill/>
-                  </a:tcPr>
-                </a:tc>
-                <a:tc>
-                  <a:txBody>
-                    <a:bodyPr/>
-                    <a:lstStyle/>
-                    <a:p>
-                      <a:pPr algn="r"/>
-                      <a:r>
-                        <a:rPr sz="1300" b="0">
-                          <a:solidFill>
-                            <a:srgbClr val="3C3C3B"/>
-                          </a:solidFill>
-                          <a:latin typeface="Aptos"/>
-                        </a:rPr>
-                        <a:t>42.6</a:t>
+                        <a:t>63.2</a:t>
+                      </a:r>
+                    </a:p>
+                  </a:txBody>
+                  <a:tcPr marL="73152" marR="73152" marT="27432" marB="27432" anchor="ctr">
+                    <a:noFill/>
+                  </a:tcPr>
+                </a:tc>
+                <a:tc>
+                  <a:txBody>
+                    <a:bodyPr/>
+                    <a:lstStyle/>
+                    <a:p>
+                      <a:pPr algn="r"/>
+                      <a:r>
+                        <a:rPr sz="1300" b="0">
+                          <a:solidFill>
+                            <a:srgbClr val="3C3C3B"/>
+                          </a:solidFill>
+                          <a:latin typeface="Aptos"/>
+                        </a:rPr>
+                        <a:t>36.0</a:t>
+                      </a:r>
+                    </a:p>
+                  </a:txBody>
+                  <a:tcPr marL="73152" marR="73152" marT="27432" marB="27432" anchor="ctr">
+                    <a:noFill/>
+                  </a:tcPr>
+                </a:tc>
+                <a:tc>
+                  <a:txBody>
+                    <a:bodyPr/>
+                    <a:lstStyle/>
+                    <a:p>
+                      <a:pPr algn="r"/>
+                      <a:r>
+                        <a:rPr sz="1300" b="0">
+                          <a:solidFill>
+                            <a:srgbClr val="3C3C3B"/>
+                          </a:solidFill>
+                          <a:latin typeface="Aptos"/>
+                        </a:rPr>
+                        <a:t>64.4</a:t>
+                      </a:r>
+                    </a:p>
+                  </a:txBody>
+                  <a:tcPr marL="73152" marR="73152" marT="27432" marB="27432" anchor="ctr">
+                    <a:noFill/>
+                  </a:tcPr>
+                </a:tc>
+                <a:tc>
+                  <a:txBody>
+                    <a:bodyPr/>
+                    <a:lstStyle/>
+                    <a:p>
+                      <a:pPr algn="r"/>
+                      <a:r>
+                        <a:rPr sz="1300" b="0">
+                          <a:solidFill>
+                            <a:srgbClr val="3C3C3B"/>
+                          </a:solidFill>
+                          <a:latin typeface="Aptos"/>
+                        </a:rPr>
+                        <a:t>37.2</a:t>
                       </a:r>
                     </a:p>
                   </a:txBody>
@@ -15472,70 +15472,70 @@
                           </a:solidFill>
                           <a:latin typeface="Aptos"/>
                         </a:rPr>
-                        <a:t>20.2</a:t>
-                      </a:r>
-                    </a:p>
-                  </a:txBody>
-                  <a:tcPr marL="73152" marR="73152" marT="27432" marB="27432" anchor="ctr">
-                    <a:noFill/>
-                  </a:tcPr>
-                </a:tc>
-                <a:tc>
-                  <a:txBody>
-                    <a:bodyPr/>
-                    <a:lstStyle/>
-                    <a:p>
-                      <a:pPr algn="r"/>
-                      <a:r>
-                        <a:rPr sz="1300" b="0">
-                          <a:solidFill>
-                            <a:srgbClr val="3C3C3B"/>
-                          </a:solidFill>
-                          <a:latin typeface="Aptos"/>
-                        </a:rPr>
-                        <a:t>29.4</a:t>
-                      </a:r>
-                    </a:p>
-                  </a:txBody>
-                  <a:tcPr marL="73152" marR="73152" marT="27432" marB="27432" anchor="ctr">
-                    <a:noFill/>
-                  </a:tcPr>
-                </a:tc>
-                <a:tc>
-                  <a:txBody>
-                    <a:bodyPr/>
-                    <a:lstStyle/>
-                    <a:p>
-                      <a:pPr algn="r"/>
-                      <a:r>
-                        <a:rPr sz="1300" b="0">
-                          <a:solidFill>
-                            <a:srgbClr val="3C3C3B"/>
-                          </a:solidFill>
-                          <a:latin typeface="Aptos"/>
-                        </a:rPr>
-                        <a:t>128.4</a:t>
-                      </a:r>
-                    </a:p>
-                  </a:txBody>
-                  <a:tcPr marL="73152" marR="73152" marT="27432" marB="27432" anchor="ctr">
-                    <a:noFill/>
-                  </a:tcPr>
-                </a:tc>
-                <a:tc>
-                  <a:txBody>
-                    <a:bodyPr/>
-                    <a:lstStyle/>
-                    <a:p>
-                      <a:pPr algn="r"/>
-                      <a:r>
-                        <a:rPr sz="1300" b="0">
-                          <a:solidFill>
-                            <a:srgbClr val="3C3C3B"/>
-                          </a:solidFill>
-                          <a:latin typeface="Aptos"/>
-                        </a:rPr>
-                        <a:t>159.5</a:t>
+                        <a:t>20.9</a:t>
+                      </a:r>
+                    </a:p>
+                  </a:txBody>
+                  <a:tcPr marL="73152" marR="73152" marT="27432" marB="27432" anchor="ctr">
+                    <a:noFill/>
+                  </a:tcPr>
+                </a:tc>
+                <a:tc>
+                  <a:txBody>
+                    <a:bodyPr/>
+                    <a:lstStyle/>
+                    <a:p>
+                      <a:pPr algn="r"/>
+                      <a:r>
+                        <a:rPr sz="1300" b="0">
+                          <a:solidFill>
+                            <a:srgbClr val="3C3C3B"/>
+                          </a:solidFill>
+                          <a:latin typeface="Aptos"/>
+                        </a:rPr>
+                        <a:t>29.0</a:t>
+                      </a:r>
+                    </a:p>
+                  </a:txBody>
+                  <a:tcPr marL="73152" marR="73152" marT="27432" marB="27432" anchor="ctr">
+                    <a:noFill/>
+                  </a:tcPr>
+                </a:tc>
+                <a:tc>
+                  <a:txBody>
+                    <a:bodyPr/>
+                    <a:lstStyle/>
+                    <a:p>
+                      <a:pPr algn="r"/>
+                      <a:r>
+                        <a:rPr sz="1300" b="0">
+                          <a:solidFill>
+                            <a:srgbClr val="3C3C3B"/>
+                          </a:solidFill>
+                          <a:latin typeface="Aptos"/>
+                        </a:rPr>
+                        <a:t>137.3</a:t>
+                      </a:r>
+                    </a:p>
+                  </a:txBody>
+                  <a:tcPr marL="73152" marR="73152" marT="27432" marB="27432" anchor="ctr">
+                    <a:noFill/>
+                  </a:tcPr>
+                </a:tc>
+                <a:tc>
+                  <a:txBody>
+                    <a:bodyPr/>
+                    <a:lstStyle/>
+                    <a:p>
+                      <a:pPr algn="r"/>
+                      <a:r>
+                        <a:rPr sz="1300" b="0">
+                          <a:solidFill>
+                            <a:srgbClr val="3C3C3B"/>
+                          </a:solidFill>
+                          <a:latin typeface="Aptos"/>
+                        </a:rPr>
+                        <a:t>160.4</a:t>
                       </a:r>
                     </a:p>
                   </a:txBody>
@@ -15604,7 +15604,7 @@
                           </a:solidFill>
                           <a:latin typeface="Aptos"/>
                         </a:rPr>
-                        <a:t>26.3%</a:t>
+                        <a:t>24.8%</a:t>
                       </a:r>
                     </a:p>
                   </a:txBody>
@@ -15627,7 +15627,7 @@
                           </a:solidFill>
                           <a:latin typeface="Aptos"/>
                         </a:rPr>
-                        <a:t>41.0%</a:t>
+                        <a:t>43.1%</a:t>
                       </a:r>
                     </a:p>
                   </a:txBody>
@@ -15650,7 +15650,7 @@
                           </a:solidFill>
                           <a:latin typeface="Aptos"/>
                         </a:rPr>
-                        <a:t>7.8%</a:t>
+                        <a:t>7.4%</a:t>
                       </a:r>
                     </a:p>
                   </a:txBody>
@@ -15673,7 +15673,7 @@
                           </a:solidFill>
                           <a:latin typeface="Aptos"/>
                         </a:rPr>
-                        <a:t>11.7%</a:t>
+                        <a:t>11.8%</a:t>
                       </a:r>
                     </a:p>
                   </a:txBody>
@@ -15744,70 +15744,70 @@
                           </a:solidFill>
                           <a:latin typeface="Aptos"/>
                         </a:rPr>
-                        <a:t>1.37x</a:t>
-                      </a:r>
-                    </a:p>
-                  </a:txBody>
-                  <a:tcPr marL="73152" marR="73152" marT="27432" marB="27432" anchor="ctr">
-                    <a:noFill/>
-                  </a:tcPr>
-                </a:tc>
-                <a:tc>
-                  <a:txBody>
-                    <a:bodyPr/>
-                    <a:lstStyle/>
-                    <a:p>
-                      <a:pPr algn="r"/>
-                      <a:r>
-                        <a:rPr sz="1300" b="0">
-                          <a:solidFill>
-                            <a:srgbClr val="3C3C3B"/>
-                          </a:solidFill>
-                          <a:latin typeface="Aptos"/>
-                        </a:rPr>
-                        <a:t>1.71x</a:t>
-                      </a:r>
-                    </a:p>
-                  </a:txBody>
-                  <a:tcPr marL="73152" marR="73152" marT="27432" marB="27432" anchor="ctr">
-                    <a:noFill/>
-                  </a:tcPr>
-                </a:tc>
-                <a:tc>
-                  <a:txBody>
-                    <a:bodyPr/>
-                    <a:lstStyle/>
-                    <a:p>
-                      <a:pPr algn="r"/>
-                      <a:r>
-                        <a:rPr sz="1300" b="0">
-                          <a:solidFill>
-                            <a:srgbClr val="3C3C3B"/>
-                          </a:solidFill>
-                          <a:latin typeface="Aptos"/>
-                        </a:rPr>
-                        <a:t>3.31x</a:t>
-                      </a:r>
-                    </a:p>
-                  </a:txBody>
-                  <a:tcPr marL="73152" marR="73152" marT="27432" marB="27432" anchor="ctr">
-                    <a:noFill/>
-                  </a:tcPr>
-                </a:tc>
-                <a:tc>
-                  <a:txBody>
-                    <a:bodyPr/>
-                    <a:lstStyle/>
-                    <a:p>
-                      <a:pPr algn="r"/>
-                      <a:r>
-                        <a:rPr sz="1300" b="0">
-                          <a:solidFill>
-                            <a:srgbClr val="3C3C3B"/>
-                          </a:solidFill>
-                          <a:latin typeface="Aptos"/>
-                        </a:rPr>
-                        <a:t>4.74x</a:t>
+                        <a:t>1.33x</a:t>
+                      </a:r>
+                    </a:p>
+                  </a:txBody>
+                  <a:tcPr marL="73152" marR="73152" marT="27432" marB="27432" anchor="ctr">
+                    <a:noFill/>
+                  </a:tcPr>
+                </a:tc>
+                <a:tc>
+                  <a:txBody>
+                    <a:bodyPr/>
+                    <a:lstStyle/>
+                    <a:p>
+                      <a:pPr algn="r"/>
+                      <a:r>
+                        <a:rPr sz="1300" b="0">
+                          <a:solidFill>
+                            <a:srgbClr val="3C3C3B"/>
+                          </a:solidFill>
+                          <a:latin typeface="Aptos"/>
+                        </a:rPr>
+                        <a:t>1.80x</a:t>
+                      </a:r>
+                    </a:p>
+                  </a:txBody>
+                  <a:tcPr marL="73152" marR="73152" marT="27432" marB="27432" anchor="ctr">
+                    <a:noFill/>
+                  </a:tcPr>
+                </a:tc>
+                <a:tc>
+                  <a:txBody>
+                    <a:bodyPr/>
+                    <a:lstStyle/>
+                    <a:p>
+                      <a:pPr algn="r"/>
+                      <a:r>
+                        <a:rPr sz="1300" b="0">
+                          <a:solidFill>
+                            <a:srgbClr val="3C3C3B"/>
+                          </a:solidFill>
+                          <a:latin typeface="Aptos"/>
+                        </a:rPr>
+                        <a:t>3.13x</a:t>
+                      </a:r>
+                    </a:p>
+                  </a:txBody>
+                  <a:tcPr marL="73152" marR="73152" marT="27432" marB="27432" anchor="ctr">
+                    <a:noFill/>
+                  </a:tcPr>
+                </a:tc>
+                <a:tc>
+                  <a:txBody>
+                    <a:bodyPr/>
+                    <a:lstStyle/>
+                    <a:p>
+                      <a:pPr algn="r"/>
+                      <a:r>
+                        <a:rPr sz="1300" b="0">
+                          <a:solidFill>
+                            <a:srgbClr val="3C3C3B"/>
+                          </a:solidFill>
+                          <a:latin typeface="Aptos"/>
+                        </a:rPr>
+                        <a:t>5.31x</a:t>
                       </a:r>
                     </a:p>
                   </a:txBody>
@@ -15897,49 +15897,49 @@
                           </a:solidFill>
                           <a:latin typeface="Aptos"/>
                         </a:rPr>
-                        <a:t>18.6</a:t>
-                      </a:r>
-                    </a:p>
-                  </a:txBody>
-                  <a:tcPr marL="73152" marR="73152" marT="27432" marB="27432" anchor="ctr">
-                    <a:noFill/>
-                  </a:tcPr>
-                </a:tc>
-                <a:tc>
-                  <a:txBody>
-                    <a:bodyPr/>
-                    <a:lstStyle/>
-                    <a:p>
-                      <a:pPr algn="r"/>
-                      <a:r>
-                        <a:rPr sz="1300" b="0">
-                          <a:solidFill>
-                            <a:srgbClr val="3C3C3B"/>
-                          </a:solidFill>
-                          <a:latin typeface="Aptos"/>
-                        </a:rPr>
-                        <a:t>(1.2)</a:t>
-                      </a:r>
-                    </a:p>
-                  </a:txBody>
-                  <a:tcPr marL="73152" marR="73152" marT="27432" marB="27432" anchor="ctr">
-                    <a:noFill/>
-                  </a:tcPr>
-                </a:tc>
-                <a:tc>
-                  <a:txBody>
-                    <a:bodyPr/>
-                    <a:lstStyle/>
-                    <a:p>
-                      <a:pPr algn="r"/>
-                      <a:r>
-                        <a:rPr sz="1300" b="0">
-                          <a:solidFill>
-                            <a:srgbClr val="3C3C3B"/>
-                          </a:solidFill>
-                          <a:latin typeface="Aptos"/>
-                        </a:rPr>
-                        <a:t>16.7</a:t>
+                        <a:t>18.5</a:t>
+                      </a:r>
+                    </a:p>
+                  </a:txBody>
+                  <a:tcPr marL="73152" marR="73152" marT="27432" marB="27432" anchor="ctr">
+                    <a:noFill/>
+                  </a:tcPr>
+                </a:tc>
+                <a:tc>
+                  <a:txBody>
+                    <a:bodyPr/>
+                    <a:lstStyle/>
+                    <a:p>
+                      <a:pPr algn="r"/>
+                      <a:r>
+                        <a:rPr sz="1300" b="0">
+                          <a:solidFill>
+                            <a:srgbClr val="3C3C3B"/>
+                          </a:solidFill>
+                          <a:latin typeface="Aptos"/>
+                        </a:rPr>
+                        <a:t>(3.7)</a:t>
+                      </a:r>
+                    </a:p>
+                  </a:txBody>
+                  <a:tcPr marL="73152" marR="73152" marT="27432" marB="27432" anchor="ctr">
+                    <a:noFill/>
+                  </a:tcPr>
+                </a:tc>
+                <a:tc>
+                  <a:txBody>
+                    <a:bodyPr/>
+                    <a:lstStyle/>
+                    <a:p>
+                      <a:pPr algn="r"/>
+                      <a:r>
+                        <a:rPr sz="1300" b="0">
+                          <a:solidFill>
+                            <a:srgbClr val="3C3C3B"/>
+                          </a:solidFill>
+                          <a:latin typeface="Aptos"/>
+                        </a:rPr>
+                        <a:t>16.6</a:t>
                       </a:r>
                     </a:p>
                   </a:txBody>
@@ -16094,7 +16094,7 @@
                           </a:solidFill>
                           <a:latin typeface="Aptos"/>
                         </a:rPr>
-                        <a:t>Minimum DSCR (sculpted repayment)</a:t>
+                        <a:t>Minimum DSCR (annuity)</a:t>
                       </a:r>
                     </a:p>
                   </a:txBody>
@@ -16182,28 +16182,28 @@
                           </a:solidFill>
                           <a:latin typeface="Aptos"/>
                         </a:rPr>
-                        <a:t>1.88x</a:t>
-                      </a:r>
-                    </a:p>
-                  </a:txBody>
-                  <a:tcPr marL="73152" marR="73152" marT="27432" marB="27432" anchor="ctr">
-                    <a:noFill/>
-                  </a:tcPr>
-                </a:tc>
-                <a:tc>
-                  <a:txBody>
-                    <a:bodyPr/>
-                    <a:lstStyle/>
-                    <a:p>
-                      <a:pPr algn="r"/>
-                      <a:r>
-                        <a:rPr sz="1300" b="0">
-                          <a:solidFill>
-                            <a:srgbClr val="3C3C3B"/>
-                          </a:solidFill>
-                          <a:latin typeface="Aptos"/>
-                        </a:rPr>
-                        <a:t>2.48x</a:t>
+                        <a:t>1.94x</a:t>
+                      </a:r>
+                    </a:p>
+                  </a:txBody>
+                  <a:tcPr marL="73152" marR="73152" marT="27432" marB="27432" anchor="ctr">
+                    <a:noFill/>
+                  </a:tcPr>
+                </a:tc>
+                <a:tc>
+                  <a:txBody>
+                    <a:bodyPr/>
+                    <a:lstStyle/>
+                    <a:p>
+                      <a:pPr algn="r"/>
+                      <a:r>
+                        <a:rPr sz="1300" b="0">
+                          <a:solidFill>
+                            <a:srgbClr val="3C3C3B"/>
+                          </a:solidFill>
+                          <a:latin typeface="Aptos"/>
+                        </a:rPr>
+                        <a:t>1.89x</a:t>
                       </a:r>
                     </a:p>
                   </a:txBody>
@@ -16314,28 +16314,28 @@
                           </a:solidFill>
                           <a:latin typeface="Aptos"/>
                         </a:rPr>
-                        <a:t>(22.8)</a:t>
-                      </a:r>
-                    </a:p>
-                  </a:txBody>
-                  <a:tcPr marL="73152" marR="73152" marT="27432" marB="27432" anchor="ctr">
-                    <a:noFill/>
-                  </a:tcPr>
-                </a:tc>
-                <a:tc>
-                  <a:txBody>
-                    <a:bodyPr/>
-                    <a:lstStyle/>
-                    <a:p>
-                      <a:pPr algn="r"/>
-                      <a:r>
-                        <a:rPr sz="1300" b="0">
-                          <a:solidFill>
-                            <a:srgbClr val="3C3C3B"/>
-                          </a:solidFill>
-                          <a:latin typeface="Aptos"/>
-                        </a:rPr>
-                        <a:t>(28.1)</a:t>
+                        <a:t>(24.2)</a:t>
+                      </a:r>
+                    </a:p>
+                  </a:txBody>
+                  <a:tcPr marL="73152" marR="73152" marT="27432" marB="27432" anchor="ctr">
+                    <a:noFill/>
+                  </a:tcPr>
+                </a:tc>
+                <a:tc>
+                  <a:txBody>
+                    <a:bodyPr/>
+                    <a:lstStyle/>
+                    <a:p>
+                      <a:pPr algn="r"/>
+                      <a:r>
+                        <a:rPr sz="1300" b="0">
+                          <a:solidFill>
+                            <a:srgbClr val="3C3C3B"/>
+                          </a:solidFill>
+                          <a:latin typeface="Aptos"/>
+                        </a:rPr>
+                        <a:t>(28.3)</a:t>
                       </a:r>
                     </a:p>
                   </a:txBody>
@@ -16430,7 +16430,7 @@
                 </a:solidFill>
                 <a:latin typeface="Aptos"/>
               </a:rPr>
-              <a:t>Debt: </a:t>
+              <a:t>Debt (bank indication): </a:t>
             </a:r>
             <a:r>
               <a:rPr sz="1300" b="0">
@@ -16439,7 +16439,7 @@
                 </a:solidFill>
                 <a:latin typeface="Aptos"/>
               </a:rPr>
-              <a:t>1.20x target DSCR over 18 years, 5.0% fixed; sized at the lower of the DSCR capacity and 55% of cost on both routes; 64% / 48% of the DSCR capacity is used.</a:t>
+              <a:t>€0.9m per built MW, 15-year annuity, 5.0% fixed, minimum DSCR 1.20x on PPA revenue; LTC 46% / 63%; 62% / 63% of the DSCR capacity is used.</a:t>
             </a:r>
           </a:p>
           <a:p>
@@ -16464,7 +16464,7 @@
                 </a:solidFill>
                 <a:latin typeface="Aptos"/>
               </a:rPr>
-              <a:t>€101.0m at 1.10x / €92.6m at 1.20x DSCR European (89% / 82% of uses); €98.0m / €89.8m Chinese.</a:t>
+              <a:t>€87.4m at 1.10x / €80.1m at 1.20x DSCR European (77% / 71% of uses); €85.1m / €78.0m Chinese.</a:t>
             </a:r>
           </a:p>
           <a:p>
@@ -16578,7 +16578,7 @@
           <a:lstStyle/>
           <a:p>
             <a:r>
-              <a:t>At 2,450 / 2,100 k€/MW a buyer earns 5.7% / 7.0%; at the lower price 6.7% / 8.1%, but FEP's sale IRR falls to 9.7% / 27.4%</a:t>
+              <a:t>At 2,450 / 2,100 k€/MW a buyer earns 5.6% / 7.0%; at the lower price 6.7% / 8.1%, but FEP's sale IRR falls to 9.6% / 28.7%</a:t>
             </a:r>
           </a:p>
         </p:txBody>
@@ -17320,28 +17320,28 @@
                           </a:solidFill>
                           <a:latin typeface="Aptos"/>
                         </a:rPr>
-                        <a:t>7.5%</a:t>
-                      </a:r>
-                    </a:p>
-                  </a:txBody>
-                  <a:tcPr marL="73152" marR="73152" marT="27432" marB="27432" anchor="ctr">
-                    <a:noFill/>
-                  </a:tcPr>
-                </a:tc>
-                <a:tc>
-                  <a:txBody>
-                    <a:bodyPr/>
-                    <a:lstStyle/>
-                    <a:p>
-                      <a:pPr algn="r"/>
-                      <a:r>
-                        <a:rPr sz="1300" b="0">
-                          <a:solidFill>
-                            <a:srgbClr val="3C3C3B"/>
-                          </a:solidFill>
-                          <a:latin typeface="Aptos"/>
-                        </a:rPr>
-                        <a:t>9.7%</a:t>
+                        <a:t>7.1%</a:t>
+                      </a:r>
+                    </a:p>
+                  </a:txBody>
+                  <a:tcPr marL="73152" marR="73152" marT="27432" marB="27432" anchor="ctr">
+                    <a:noFill/>
+                  </a:tcPr>
+                </a:tc>
+                <a:tc>
+                  <a:txBody>
+                    <a:bodyPr/>
+                    <a:lstStyle/>
+                    <a:p>
+                      <a:pPr algn="r"/>
+                      <a:r>
+                        <a:rPr sz="1300" b="0">
+                          <a:solidFill>
+                            <a:srgbClr val="3C3C3B"/>
+                          </a:solidFill>
+                          <a:latin typeface="Aptos"/>
+                        </a:rPr>
+                        <a:t>9.6%</a:t>
                       </a:r>
                     </a:p>
                   </a:txBody>
@@ -17425,7 +17425,7 @@
                           </a:solidFill>
                           <a:latin typeface="Aptos"/>
                         </a:rPr>
-                        <a:t>27.4%</a:t>
+                        <a:t>28.7%</a:t>
                       </a:r>
                     </a:p>
                   </a:txBody>
@@ -17494,6 +17494,29 @@
                           </a:solidFill>
                           <a:latin typeface="Aptos"/>
                         </a:rPr>
+                        <a:t>5.6%</a:t>
+                      </a:r>
+                    </a:p>
+                  </a:txBody>
+                  <a:tcPr marL="73152" marR="73152" marT="27432" marB="27432" anchor="ctr">
+                    <a:solidFill>
+                      <a:srgbClr val="E6F4EC"/>
+                    </a:solidFill>
+                  </a:tcPr>
+                </a:tc>
+                <a:tc>
+                  <a:txBody>
+                    <a:bodyPr/>
+                    <a:lstStyle/>
+                    <a:p>
+                      <a:pPr algn="r"/>
+                      <a:r>
+                        <a:rPr sz="1300" b="1">
+                          <a:solidFill>
+                            <a:srgbClr val="3C3C3B"/>
+                          </a:solidFill>
+                          <a:latin typeface="Aptos"/>
+                        </a:rPr>
                         <a:t>5.7%</a:t>
                       </a:r>
                     </a:p>
@@ -17517,7 +17540,7 @@
                           </a:solidFill>
                           <a:latin typeface="Aptos"/>
                         </a:rPr>
-                        <a:t>5.9%</a:t>
+                        <a:t>24.8%</a:t>
                       </a:r>
                     </a:p>
                   </a:txBody>
@@ -17540,7 +17563,7 @@
                           </a:solidFill>
                           <a:latin typeface="Aptos"/>
                         </a:rPr>
-                        <a:t>26.3%</a:t>
+                        <a:t>2,100</a:t>
                       </a:r>
                     </a:p>
                   </a:txBody>
@@ -17563,7 +17586,7 @@
                           </a:solidFill>
                           <a:latin typeface="Aptos"/>
                         </a:rPr>
-                        <a:t>2,100</a:t>
+                        <a:t>7.0%</a:t>
                       </a:r>
                     </a:p>
                   </a:txBody>
@@ -17586,7 +17609,7 @@
                           </a:solidFill>
                           <a:latin typeface="Aptos"/>
                         </a:rPr>
-                        <a:t>7.0%</a:t>
+                        <a:t>7.6%</a:t>
                       </a:r>
                     </a:p>
                   </a:txBody>
@@ -17609,30 +17632,7 @@
                           </a:solidFill>
                           <a:latin typeface="Aptos"/>
                         </a:rPr>
-                        <a:t>7.6%</a:t>
-                      </a:r>
-                    </a:p>
-                  </a:txBody>
-                  <a:tcPr marL="73152" marR="73152" marT="27432" marB="27432" anchor="ctr">
-                    <a:solidFill>
-                      <a:srgbClr val="E6F4EC"/>
-                    </a:solidFill>
-                  </a:tcPr>
-                </a:tc>
-                <a:tc>
-                  <a:txBody>
-                    <a:bodyPr/>
-                    <a:lstStyle/>
-                    <a:p>
-                      <a:pPr algn="r"/>
-                      <a:r>
-                        <a:rPr sz="1300" b="1">
-                          <a:solidFill>
-                            <a:srgbClr val="3C3C3B"/>
-                          </a:solidFill>
-                          <a:latin typeface="Aptos"/>
-                        </a:rPr>
-                        <a:t>41.0%</a:t>
+                        <a:t>43.1%</a:t>
                       </a:r>
                     </a:p>
                   </a:txBody>
@@ -17701,7 +17701,7 @@
                           </a:solidFill>
                           <a:latin typeface="Aptos"/>
                         </a:rPr>
-                        <a:t>4.8%</a:t>
+                        <a:t>4.7%</a:t>
                       </a:r>
                     </a:p>
                   </a:txBody>
@@ -17743,7 +17743,7 @@
                           </a:solidFill>
                           <a:latin typeface="Aptos"/>
                         </a:rPr>
-                        <a:t>40.4%</a:t>
+                        <a:t>38.0%</a:t>
                       </a:r>
                     </a:p>
                   </a:txBody>
@@ -17827,7 +17827,7 @@
                           </a:solidFill>
                           <a:latin typeface="Aptos"/>
                         </a:rPr>
-                        <a:t>52.7%</a:t>
+                        <a:t>55.1%</a:t>
                       </a:r>
                     </a:p>
                   </a:txBody>
@@ -17924,7 +17924,7 @@
           <a:lstStyle/>
           <a:p>
             <a:r>
-              <a:t>Delivering none of the commitments keeps the 59.5 / 47.5 points and costs the €2.22m PB; sale IRR 41.9% / 41.9%</a:t>
+              <a:t>Delivering none of the commitments keeps the 59.5 / 47.5 points and costs the €2.22m PB; sale IRR 44.9% / 44.9%</a:t>
             </a:r>
           </a:p>
         </p:txBody>
@@ -18694,7 +18694,7 @@
                           </a:solidFill>
                           <a:latin typeface="Aptos"/>
                         </a:rPr>
-                        <a:t>54.4</a:t>
+                        <a:t>63.2</a:t>
                       </a:r>
                     </a:p>
                   </a:txBody>
@@ -18717,7 +18717,7 @@
                           </a:solidFill>
                           <a:latin typeface="Aptos"/>
                         </a:rPr>
-                        <a:t>41.7</a:t>
+                        <a:t>36.0</a:t>
                       </a:r>
                     </a:p>
                   </a:txBody>
@@ -18740,7 +18740,7 @@
                           </a:solidFill>
                           <a:latin typeface="Aptos"/>
                         </a:rPr>
-                        <a:t>26.3%</a:t>
+                        <a:t>24.8%</a:t>
                       </a:r>
                     </a:p>
                   </a:txBody>
@@ -18763,7 +18763,7 @@
                           </a:solidFill>
                           <a:latin typeface="Aptos"/>
                         </a:rPr>
-                        <a:t>41.0%</a:t>
+                        <a:t>43.1%</a:t>
                       </a:r>
                     </a:p>
                   </a:txBody>
@@ -18786,7 +18786,7 @@
                           </a:solidFill>
                           <a:latin typeface="Aptos"/>
                         </a:rPr>
-                        <a:t>7.8%</a:t>
+                        <a:t>7.4%</a:t>
                       </a:r>
                     </a:p>
                   </a:txBody>
@@ -18809,7 +18809,7 @@
                           </a:solidFill>
                           <a:latin typeface="Aptos"/>
                         </a:rPr>
-                        <a:t>11.7%</a:t>
+                        <a:t>11.8%</a:t>
                       </a:r>
                     </a:p>
                   </a:txBody>
@@ -18832,7 +18832,7 @@
                           </a:solidFill>
                           <a:latin typeface="Aptos"/>
                         </a:rPr>
-                        <a:t>5.7%</a:t>
+                        <a:t>5.6%</a:t>
                       </a:r>
                     </a:p>
                   </a:txBody>
@@ -18922,112 +18922,112 @@
                           </a:solidFill>
                           <a:latin typeface="Aptos"/>
                         </a:rPr>
-                        <a:t>36.5</a:t>
-                      </a:r>
-                    </a:p>
-                  </a:txBody>
-                  <a:tcPr marL="73152" marR="73152" marT="27432" marB="27432" anchor="ctr">
-                    <a:noFill/>
-                  </a:tcPr>
-                </a:tc>
-                <a:tc>
-                  <a:txBody>
-                    <a:bodyPr/>
-                    <a:lstStyle/>
-                    <a:p>
-                      <a:pPr algn="r"/>
-                      <a:r>
-                        <a:rPr sz="1300" b="0">
-                          <a:solidFill>
-                            <a:srgbClr val="3C3C3B"/>
-                          </a:solidFill>
-                          <a:latin typeface="Aptos"/>
-                        </a:rPr>
-                        <a:t>36.5</a:t>
-                      </a:r>
-                    </a:p>
-                  </a:txBody>
-                  <a:tcPr marL="73152" marR="73152" marT="27432" marB="27432" anchor="ctr">
-                    <a:noFill/>
-                  </a:tcPr>
-                </a:tc>
-                <a:tc>
-                  <a:txBody>
-                    <a:bodyPr/>
-                    <a:lstStyle/>
-                    <a:p>
-                      <a:pPr algn="r"/>
-                      <a:r>
-                        <a:rPr sz="1300" b="0">
-                          <a:solidFill>
-                            <a:srgbClr val="3C3C3B"/>
-                          </a:solidFill>
-                          <a:latin typeface="Aptos"/>
-                        </a:rPr>
-                        <a:t>41.9%</a:t>
-                      </a:r>
-                    </a:p>
-                  </a:txBody>
-                  <a:tcPr marL="73152" marR="73152" marT="27432" marB="27432" anchor="ctr">
-                    <a:noFill/>
-                  </a:tcPr>
-                </a:tc>
-                <a:tc>
-                  <a:txBody>
-                    <a:bodyPr/>
-                    <a:lstStyle/>
-                    <a:p>
-                      <a:pPr algn="r"/>
-                      <a:r>
-                        <a:rPr sz="1300" b="0">
-                          <a:solidFill>
-                            <a:srgbClr val="3C3C3B"/>
-                          </a:solidFill>
-                          <a:latin typeface="Aptos"/>
-                        </a:rPr>
-                        <a:t>41.9%</a:t>
-                      </a:r>
-                    </a:p>
-                  </a:txBody>
-                  <a:tcPr marL="73152" marR="73152" marT="27432" marB="27432" anchor="ctr">
-                    <a:noFill/>
-                  </a:tcPr>
-                </a:tc>
-                <a:tc>
-                  <a:txBody>
-                    <a:bodyPr/>
-                    <a:lstStyle/>
-                    <a:p>
-                      <a:pPr algn="r"/>
-                      <a:r>
-                        <a:rPr sz="1300" b="0">
-                          <a:solidFill>
-                            <a:srgbClr val="3C3C3B"/>
-                          </a:solidFill>
-                          <a:latin typeface="Aptos"/>
-                        </a:rPr>
-                        <a:t>12.5%</a:t>
-                      </a:r>
-                    </a:p>
-                  </a:txBody>
-                  <a:tcPr marL="73152" marR="73152" marT="27432" marB="27432" anchor="ctr">
-                    <a:noFill/>
-                  </a:tcPr>
-                </a:tc>
-                <a:tc>
-                  <a:txBody>
-                    <a:bodyPr/>
-                    <a:lstStyle/>
-                    <a:p>
-                      <a:pPr algn="r"/>
-                      <a:r>
-                        <a:rPr sz="1300" b="0">
-                          <a:solidFill>
-                            <a:srgbClr val="3C3C3B"/>
-                          </a:solidFill>
-                          <a:latin typeface="Aptos"/>
-                        </a:rPr>
-                        <a:t>12.5%</a:t>
+                        <a:t>29.2</a:t>
+                      </a:r>
+                    </a:p>
+                  </a:txBody>
+                  <a:tcPr marL="73152" marR="73152" marT="27432" marB="27432" anchor="ctr">
+                    <a:noFill/>
+                  </a:tcPr>
+                </a:tc>
+                <a:tc>
+                  <a:txBody>
+                    <a:bodyPr/>
+                    <a:lstStyle/>
+                    <a:p>
+                      <a:pPr algn="r"/>
+                      <a:r>
+                        <a:rPr sz="1300" b="0">
+                          <a:solidFill>
+                            <a:srgbClr val="3C3C3B"/>
+                          </a:solidFill>
+                          <a:latin typeface="Aptos"/>
+                        </a:rPr>
+                        <a:t>29.2</a:t>
+                      </a:r>
+                    </a:p>
+                  </a:txBody>
+                  <a:tcPr marL="73152" marR="73152" marT="27432" marB="27432" anchor="ctr">
+                    <a:noFill/>
+                  </a:tcPr>
+                </a:tc>
+                <a:tc>
+                  <a:txBody>
+                    <a:bodyPr/>
+                    <a:lstStyle/>
+                    <a:p>
+                      <a:pPr algn="r"/>
+                      <a:r>
+                        <a:rPr sz="1300" b="0">
+                          <a:solidFill>
+                            <a:srgbClr val="3C3C3B"/>
+                          </a:solidFill>
+                          <a:latin typeface="Aptos"/>
+                        </a:rPr>
+                        <a:t>44.9%</a:t>
+                      </a:r>
+                    </a:p>
+                  </a:txBody>
+                  <a:tcPr marL="73152" marR="73152" marT="27432" marB="27432" anchor="ctr">
+                    <a:noFill/>
+                  </a:tcPr>
+                </a:tc>
+                <a:tc>
+                  <a:txBody>
+                    <a:bodyPr/>
+                    <a:lstStyle/>
+                    <a:p>
+                      <a:pPr algn="r"/>
+                      <a:r>
+                        <a:rPr sz="1300" b="0">
+                          <a:solidFill>
+                            <a:srgbClr val="3C3C3B"/>
+                          </a:solidFill>
+                          <a:latin typeface="Aptos"/>
+                        </a:rPr>
+                        <a:t>44.9%</a:t>
+                      </a:r>
+                    </a:p>
+                  </a:txBody>
+                  <a:tcPr marL="73152" marR="73152" marT="27432" marB="27432" anchor="ctr">
+                    <a:noFill/>
+                  </a:tcPr>
+                </a:tc>
+                <a:tc>
+                  <a:txBody>
+                    <a:bodyPr/>
+                    <a:lstStyle/>
+                    <a:p>
+                      <a:pPr algn="r"/>
+                      <a:r>
+                        <a:rPr sz="1300" b="0">
+                          <a:solidFill>
+                            <a:srgbClr val="3C3C3B"/>
+                          </a:solidFill>
+                          <a:latin typeface="Aptos"/>
+                        </a:rPr>
+                        <a:t>12.9%</a:t>
+                      </a:r>
+                    </a:p>
+                  </a:txBody>
+                  <a:tcPr marL="73152" marR="73152" marT="27432" marB="27432" anchor="ctr">
+                    <a:noFill/>
+                  </a:tcPr>
+                </a:tc>
+                <a:tc>
+                  <a:txBody>
+                    <a:bodyPr/>
+                    <a:lstStyle/>
+                    <a:p>
+                      <a:pPr algn="r"/>
+                      <a:r>
+                        <a:rPr sz="1300" b="0">
+                          <a:solidFill>
+                            <a:srgbClr val="3C3C3B"/>
+                          </a:solidFill>
+                          <a:latin typeface="Aptos"/>
+                        </a:rPr>
+                        <a:t>12.9%</a:t>
                       </a:r>
                     </a:p>
                   </a:txBody>
@@ -19298,7 +19298,7 @@
           <a:lstStyle/>
           <a:p>
             <a:r>
-              <a:t>A lower COD price hits the sale most (9.7%); Robin Hood tax (5.9%) and lower yield (6.1%) hit the hold</a:t>
+              <a:t>A lower COD price hits the sale most (9.6%); Robin Hood tax (5.6%) and lower yield (5.9%) hit the hold</a:t>
             </a:r>
           </a:p>
         </p:txBody>
@@ -19733,7 +19733,7 @@
         </p:nvGraphicFramePr>
         <p:xfrm>
           <a:off x="4498848" y="2240280"/>
-          <a:ext cx="9509760" cy="5916168"/>
+          <a:ext cx="9509760" cy="6300216"/>
         </p:xfrm>
         <a:graphic>
           <a:graphicData uri="http://schemas.openxmlformats.org/drawingml/2006/table">
@@ -20045,7 +20045,7 @@
                           </a:solidFill>
                           <a:latin typeface="Aptos"/>
                         </a:rPr>
-                        <a:t>26.3%</a:t>
+                        <a:t>24.8%</a:t>
                       </a:r>
                     </a:p>
                   </a:txBody>
@@ -20068,7 +20068,7 @@
                           </a:solidFill>
                           <a:latin typeface="Aptos"/>
                         </a:rPr>
-                        <a:t>41.0%</a:t>
+                        <a:t>43.1%</a:t>
                       </a:r>
                     </a:p>
                   </a:txBody>
@@ -20091,7 +20091,7 @@
                           </a:solidFill>
                           <a:latin typeface="Aptos"/>
                         </a:rPr>
-                        <a:t>5.7%</a:t>
+                        <a:t>5.6%</a:t>
                       </a:r>
                     </a:p>
                   </a:txBody>
@@ -20137,7 +20137,7 @@
                           </a:solidFill>
                           <a:latin typeface="Aptos"/>
                         </a:rPr>
-                        <a:t>7.8%</a:t>
+                        <a:t>7.4%</a:t>
                       </a:r>
                     </a:p>
                   </a:txBody>
@@ -20160,7 +20160,7 @@
                           </a:solidFill>
                           <a:latin typeface="Aptos"/>
                         </a:rPr>
-                        <a:t>11.7%</a:t>
+                        <a:t>11.8%</a:t>
                       </a:r>
                     </a:p>
                   </a:txBody>
@@ -20183,7 +20183,7 @@
                           </a:solidFill>
                           <a:latin typeface="Aptos"/>
                         </a:rPr>
-                        <a:t>1.88x</a:t>
+                        <a:t>1.94x</a:t>
                       </a:r>
                     </a:p>
                   </a:txBody>
@@ -20206,7 +20206,7 @@
                           </a:solidFill>
                           <a:latin typeface="Aptos"/>
                         </a:rPr>
-                        <a:t>2.48x</a:t>
+                        <a:t>1.89x</a:t>
                       </a:r>
                     </a:p>
                   </a:txBody>
@@ -20275,28 +20275,28 @@
                           </a:solidFill>
                           <a:latin typeface="Aptos"/>
                         </a:rPr>
-                        <a:t>9.7%</a:t>
-                      </a:r>
-                    </a:p>
-                  </a:txBody>
-                  <a:tcPr marL="73152" marR="73152" marT="27432" marB="27432" anchor="ctr">
-                    <a:noFill/>
-                  </a:tcPr>
-                </a:tc>
-                <a:tc>
-                  <a:txBody>
-                    <a:bodyPr/>
-                    <a:lstStyle/>
-                    <a:p>
-                      <a:pPr algn="r"/>
-                      <a:r>
-                        <a:rPr sz="1300" b="0">
-                          <a:solidFill>
-                            <a:srgbClr val="3C3C3B"/>
-                          </a:solidFill>
-                          <a:latin typeface="Aptos"/>
-                        </a:rPr>
-                        <a:t>27.4%</a:t>
+                        <a:t>9.6%</a:t>
+                      </a:r>
+                    </a:p>
+                  </a:txBody>
+                  <a:tcPr marL="73152" marR="73152" marT="27432" marB="27432" anchor="ctr">
+                    <a:noFill/>
+                  </a:tcPr>
+                </a:tc>
+                <a:tc>
+                  <a:txBody>
+                    <a:bodyPr/>
+                    <a:lstStyle/>
+                    <a:p>
+                      <a:pPr algn="r"/>
+                      <a:r>
+                        <a:rPr sz="1300" b="0">
+                          <a:solidFill>
+                            <a:srgbClr val="3C3C3B"/>
+                          </a:solidFill>
+                          <a:latin typeface="Aptos"/>
+                        </a:rPr>
+                        <a:t>28.7%</a:t>
                       </a:r>
                     </a:p>
                   </a:txBody>
@@ -20359,70 +20359,70 @@
                           </a:solidFill>
                           <a:latin typeface="Aptos"/>
                         </a:rPr>
-                        <a:t>7.8%</a:t>
-                      </a:r>
-                    </a:p>
-                  </a:txBody>
-                  <a:tcPr marL="73152" marR="73152" marT="27432" marB="27432" anchor="ctr">
-                    <a:noFill/>
-                  </a:tcPr>
-                </a:tc>
-                <a:tc>
-                  <a:txBody>
-                    <a:bodyPr/>
-                    <a:lstStyle/>
-                    <a:p>
-                      <a:pPr algn="r"/>
-                      <a:r>
-                        <a:rPr sz="1300" b="0">
-                          <a:solidFill>
-                            <a:srgbClr val="3C3C3B"/>
-                          </a:solidFill>
-                          <a:latin typeface="Aptos"/>
-                        </a:rPr>
-                        <a:t>11.7%</a:t>
-                      </a:r>
-                    </a:p>
-                  </a:txBody>
-                  <a:tcPr marL="73152" marR="73152" marT="27432" marB="27432" anchor="ctr">
-                    <a:noFill/>
-                  </a:tcPr>
-                </a:tc>
-                <a:tc>
-                  <a:txBody>
-                    <a:bodyPr/>
-                    <a:lstStyle/>
-                    <a:p>
-                      <a:pPr algn="r"/>
-                      <a:r>
-                        <a:rPr sz="1300" b="0">
-                          <a:solidFill>
-                            <a:srgbClr val="3C3C3B"/>
-                          </a:solidFill>
-                          <a:latin typeface="Aptos"/>
-                        </a:rPr>
-                        <a:t>1.88x</a:t>
-                      </a:r>
-                    </a:p>
-                  </a:txBody>
-                  <a:tcPr marL="73152" marR="73152" marT="27432" marB="27432" anchor="ctr">
-                    <a:noFill/>
-                  </a:tcPr>
-                </a:tc>
-                <a:tc>
-                  <a:txBody>
-                    <a:bodyPr/>
-                    <a:lstStyle/>
-                    <a:p>
-                      <a:pPr algn="r"/>
-                      <a:r>
-                        <a:rPr sz="1300" b="0">
-                          <a:solidFill>
-                            <a:srgbClr val="3C3C3B"/>
-                          </a:solidFill>
-                          <a:latin typeface="Aptos"/>
-                        </a:rPr>
-                        <a:t>2.48x</a:t>
+                        <a:t>7.4%</a:t>
+                      </a:r>
+                    </a:p>
+                  </a:txBody>
+                  <a:tcPr marL="73152" marR="73152" marT="27432" marB="27432" anchor="ctr">
+                    <a:noFill/>
+                  </a:tcPr>
+                </a:tc>
+                <a:tc>
+                  <a:txBody>
+                    <a:bodyPr/>
+                    <a:lstStyle/>
+                    <a:p>
+                      <a:pPr algn="r"/>
+                      <a:r>
+                        <a:rPr sz="1300" b="0">
+                          <a:solidFill>
+                            <a:srgbClr val="3C3C3B"/>
+                          </a:solidFill>
+                          <a:latin typeface="Aptos"/>
+                        </a:rPr>
+                        <a:t>11.8%</a:t>
+                      </a:r>
+                    </a:p>
+                  </a:txBody>
+                  <a:tcPr marL="73152" marR="73152" marT="27432" marB="27432" anchor="ctr">
+                    <a:noFill/>
+                  </a:tcPr>
+                </a:tc>
+                <a:tc>
+                  <a:txBody>
+                    <a:bodyPr/>
+                    <a:lstStyle/>
+                    <a:p>
+                      <a:pPr algn="r"/>
+                      <a:r>
+                        <a:rPr sz="1300" b="0">
+                          <a:solidFill>
+                            <a:srgbClr val="3C3C3B"/>
+                          </a:solidFill>
+                          <a:latin typeface="Aptos"/>
+                        </a:rPr>
+                        <a:t>1.94x</a:t>
+                      </a:r>
+                    </a:p>
+                  </a:txBody>
+                  <a:tcPr marL="73152" marR="73152" marT="27432" marB="27432" anchor="ctr">
+                    <a:noFill/>
+                  </a:tcPr>
+                </a:tc>
+                <a:tc>
+                  <a:txBody>
+                    <a:bodyPr/>
+                    <a:lstStyle/>
+                    <a:p>
+                      <a:pPr algn="r"/>
+                      <a:r>
+                        <a:rPr sz="1300" b="0">
+                          <a:solidFill>
+                            <a:srgbClr val="3C3C3B"/>
+                          </a:solidFill>
+                          <a:latin typeface="Aptos"/>
+                        </a:rPr>
+                        <a:t>1.89x</a:t>
                       </a:r>
                     </a:p>
                   </a:txBody>
@@ -20489,49 +20489,49 @@
                           </a:solidFill>
                           <a:latin typeface="Aptos"/>
                         </a:rPr>
-                        <a:t>40.4%</a:t>
-                      </a:r>
-                    </a:p>
-                  </a:txBody>
-                  <a:tcPr marL="73152" marR="73152" marT="27432" marB="27432" anchor="ctr">
-                    <a:noFill/>
-                  </a:tcPr>
-                </a:tc>
-                <a:tc>
-                  <a:txBody>
-                    <a:bodyPr/>
-                    <a:lstStyle/>
-                    <a:p>
-                      <a:pPr algn="r"/>
-                      <a:r>
-                        <a:rPr sz="1300" b="0">
-                          <a:solidFill>
-                            <a:srgbClr val="3C3C3B"/>
-                          </a:solidFill>
-                          <a:latin typeface="Aptos"/>
-                        </a:rPr>
-                        <a:t>52.7%</a:t>
-                      </a:r>
-                    </a:p>
-                  </a:txBody>
-                  <a:tcPr marL="73152" marR="73152" marT="27432" marB="27432" anchor="ctr">
-                    <a:noFill/>
-                  </a:tcPr>
-                </a:tc>
-                <a:tc>
-                  <a:txBody>
-                    <a:bodyPr/>
-                    <a:lstStyle/>
-                    <a:p>
-                      <a:pPr algn="r"/>
-                      <a:r>
-                        <a:rPr sz="1300" b="0">
-                          <a:solidFill>
-                            <a:srgbClr val="3C3C3B"/>
-                          </a:solidFill>
-                          <a:latin typeface="Aptos"/>
-                        </a:rPr>
-                        <a:t>4.8%</a:t>
+                        <a:t>38.0%</a:t>
+                      </a:r>
+                    </a:p>
+                  </a:txBody>
+                  <a:tcPr marL="73152" marR="73152" marT="27432" marB="27432" anchor="ctr">
+                    <a:noFill/>
+                  </a:tcPr>
+                </a:tc>
+                <a:tc>
+                  <a:txBody>
+                    <a:bodyPr/>
+                    <a:lstStyle/>
+                    <a:p>
+                      <a:pPr algn="r"/>
+                      <a:r>
+                        <a:rPr sz="1300" b="0">
+                          <a:solidFill>
+                            <a:srgbClr val="3C3C3B"/>
+                          </a:solidFill>
+                          <a:latin typeface="Aptos"/>
+                        </a:rPr>
+                        <a:t>55.1%</a:t>
+                      </a:r>
+                    </a:p>
+                  </a:txBody>
+                  <a:tcPr marL="73152" marR="73152" marT="27432" marB="27432" anchor="ctr">
+                    <a:noFill/>
+                  </a:tcPr>
+                </a:tc>
+                <a:tc>
+                  <a:txBody>
+                    <a:bodyPr/>
+                    <a:lstStyle/>
+                    <a:p>
+                      <a:pPr algn="r"/>
+                      <a:r>
+                        <a:rPr sz="1300" b="0">
+                          <a:solidFill>
+                            <a:srgbClr val="3C3C3B"/>
+                          </a:solidFill>
+                          <a:latin typeface="Aptos"/>
+                        </a:rPr>
+                        <a:t>4.7%</a:t>
                       </a:r>
                     </a:p>
                   </a:txBody>
@@ -20573,70 +20573,70 @@
                           </a:solidFill>
                           <a:latin typeface="Aptos"/>
                         </a:rPr>
-                        <a:t>7.8%</a:t>
-                      </a:r>
-                    </a:p>
-                  </a:txBody>
-                  <a:tcPr marL="73152" marR="73152" marT="27432" marB="27432" anchor="ctr">
-                    <a:noFill/>
-                  </a:tcPr>
-                </a:tc>
-                <a:tc>
-                  <a:txBody>
-                    <a:bodyPr/>
-                    <a:lstStyle/>
-                    <a:p>
-                      <a:pPr algn="r"/>
-                      <a:r>
-                        <a:rPr sz="1300" b="0">
-                          <a:solidFill>
-                            <a:srgbClr val="3C3C3B"/>
-                          </a:solidFill>
-                          <a:latin typeface="Aptos"/>
-                        </a:rPr>
-                        <a:t>11.7%</a:t>
-                      </a:r>
-                    </a:p>
-                  </a:txBody>
-                  <a:tcPr marL="73152" marR="73152" marT="27432" marB="27432" anchor="ctr">
-                    <a:noFill/>
-                  </a:tcPr>
-                </a:tc>
-                <a:tc>
-                  <a:txBody>
-                    <a:bodyPr/>
-                    <a:lstStyle/>
-                    <a:p>
-                      <a:pPr algn="r"/>
-                      <a:r>
-                        <a:rPr sz="1300" b="0">
-                          <a:solidFill>
-                            <a:srgbClr val="3C3C3B"/>
-                          </a:solidFill>
-                          <a:latin typeface="Aptos"/>
-                        </a:rPr>
-                        <a:t>1.88x</a:t>
-                      </a:r>
-                    </a:p>
-                  </a:txBody>
-                  <a:tcPr marL="73152" marR="73152" marT="27432" marB="27432" anchor="ctr">
-                    <a:noFill/>
-                  </a:tcPr>
-                </a:tc>
-                <a:tc>
-                  <a:txBody>
-                    <a:bodyPr/>
-                    <a:lstStyle/>
-                    <a:p>
-                      <a:pPr algn="r"/>
-                      <a:r>
-                        <a:rPr sz="1300" b="0">
-                          <a:solidFill>
-                            <a:srgbClr val="3C3C3B"/>
-                          </a:solidFill>
-                          <a:latin typeface="Aptos"/>
-                        </a:rPr>
-                        <a:t>2.48x</a:t>
+                        <a:t>7.4%</a:t>
+                      </a:r>
+                    </a:p>
+                  </a:txBody>
+                  <a:tcPr marL="73152" marR="73152" marT="27432" marB="27432" anchor="ctr">
+                    <a:noFill/>
+                  </a:tcPr>
+                </a:tc>
+                <a:tc>
+                  <a:txBody>
+                    <a:bodyPr/>
+                    <a:lstStyle/>
+                    <a:p>
+                      <a:pPr algn="r"/>
+                      <a:r>
+                        <a:rPr sz="1300" b="0">
+                          <a:solidFill>
+                            <a:srgbClr val="3C3C3B"/>
+                          </a:solidFill>
+                          <a:latin typeface="Aptos"/>
+                        </a:rPr>
+                        <a:t>11.8%</a:t>
+                      </a:r>
+                    </a:p>
+                  </a:txBody>
+                  <a:tcPr marL="73152" marR="73152" marT="27432" marB="27432" anchor="ctr">
+                    <a:noFill/>
+                  </a:tcPr>
+                </a:tc>
+                <a:tc>
+                  <a:txBody>
+                    <a:bodyPr/>
+                    <a:lstStyle/>
+                    <a:p>
+                      <a:pPr algn="r"/>
+                      <a:r>
+                        <a:rPr sz="1300" b="0">
+                          <a:solidFill>
+                            <a:srgbClr val="3C3C3B"/>
+                          </a:solidFill>
+                          <a:latin typeface="Aptos"/>
+                        </a:rPr>
+                        <a:t>1.94x</a:t>
+                      </a:r>
+                    </a:p>
+                  </a:txBody>
+                  <a:tcPr marL="73152" marR="73152" marT="27432" marB="27432" anchor="ctr">
+                    <a:noFill/>
+                  </a:tcPr>
+                </a:tc>
+                <a:tc>
+                  <a:txBody>
+                    <a:bodyPr/>
+                    <a:lstStyle/>
+                    <a:p>
+                      <a:pPr algn="r"/>
+                      <a:r>
+                        <a:rPr sz="1300" b="0">
+                          <a:solidFill>
+                            <a:srgbClr val="3C3C3B"/>
+                          </a:solidFill>
+                          <a:latin typeface="Aptos"/>
+                        </a:rPr>
+                        <a:t>1.89x</a:t>
                       </a:r>
                     </a:p>
                   </a:txBody>
@@ -20703,28 +20703,28 @@
                           </a:solidFill>
                           <a:latin typeface="Aptos"/>
                         </a:rPr>
-                        <a:t>19.1%</a:t>
-                      </a:r>
-                    </a:p>
-                  </a:txBody>
-                  <a:tcPr marL="73152" marR="73152" marT="27432" marB="27432" anchor="ctr">
-                    <a:noFill/>
-                  </a:tcPr>
-                </a:tc>
-                <a:tc>
-                  <a:txBody>
-                    <a:bodyPr/>
-                    <a:lstStyle/>
-                    <a:p>
-                      <a:pPr algn="r"/>
-                      <a:r>
-                        <a:rPr sz="1300" b="0">
-                          <a:solidFill>
-                            <a:srgbClr val="3C3C3B"/>
-                          </a:solidFill>
-                          <a:latin typeface="Aptos"/>
-                        </a:rPr>
-                        <a:t>37.1%</a:t>
+                        <a:t>17.9%</a:t>
+                      </a:r>
+                    </a:p>
+                  </a:txBody>
+                  <a:tcPr marL="73152" marR="73152" marT="27432" marB="27432" anchor="ctr">
+                    <a:noFill/>
+                  </a:tcPr>
+                </a:tc>
+                <a:tc>
+                  <a:txBody>
+                    <a:bodyPr/>
+                    <a:lstStyle/>
+                    <a:p>
+                      <a:pPr algn="r"/>
+                      <a:r>
+                        <a:rPr sz="1300" b="0">
+                          <a:solidFill>
+                            <a:srgbClr val="3C3C3B"/>
+                          </a:solidFill>
+                          <a:latin typeface="Aptos"/>
+                        </a:rPr>
+                        <a:t>38.5%</a:t>
                       </a:r>
                     </a:p>
                   </a:txBody>
@@ -20787,7 +20787,7 @@
                           </a:solidFill>
                           <a:latin typeface="Aptos"/>
                         </a:rPr>
-                        <a:t>7.2%</a:t>
+                        <a:t>6.8%</a:t>
                       </a:r>
                     </a:p>
                   </a:txBody>
@@ -20829,28 +20829,28 @@
                           </a:solidFill>
                           <a:latin typeface="Aptos"/>
                         </a:rPr>
-                        <a:t>1.80x</a:t>
-                      </a:r>
-                    </a:p>
-                  </a:txBody>
-                  <a:tcPr marL="73152" marR="73152" marT="27432" marB="27432" anchor="ctr">
-                    <a:noFill/>
-                  </a:tcPr>
-                </a:tc>
-                <a:tc>
-                  <a:txBody>
-                    <a:bodyPr/>
-                    <a:lstStyle/>
-                    <a:p>
-                      <a:pPr algn="r"/>
-                      <a:r>
-                        <a:rPr sz="1300" b="0">
-                          <a:solidFill>
-                            <a:srgbClr val="3C3C3B"/>
-                          </a:solidFill>
-                          <a:latin typeface="Aptos"/>
-                        </a:rPr>
-                        <a:t>2.40x</a:t>
+                        <a:t>1.95x</a:t>
+                      </a:r>
+                    </a:p>
+                  </a:txBody>
+                  <a:tcPr marL="73152" marR="73152" marT="27432" marB="27432" anchor="ctr">
+                    <a:noFill/>
+                  </a:tcPr>
+                </a:tc>
+                <a:tc>
+                  <a:txBody>
+                    <a:bodyPr/>
+                    <a:lstStyle/>
+                    <a:p>
+                      <a:pPr algn="r"/>
+                      <a:r>
+                        <a:rPr sz="1300" b="0">
+                          <a:solidFill>
+                            <a:srgbClr val="3C3C3B"/>
+                          </a:solidFill>
+                          <a:latin typeface="Aptos"/>
+                        </a:rPr>
+                        <a:t>1.90x</a:t>
                       </a:r>
                     </a:p>
                   </a:txBody>
@@ -20917,49 +20917,49 @@
                           </a:solidFill>
                           <a:latin typeface="Aptos"/>
                         </a:rPr>
-                        <a:t>26.3%</a:t>
-                      </a:r>
-                    </a:p>
-                  </a:txBody>
-                  <a:tcPr marL="73152" marR="73152" marT="27432" marB="27432" anchor="ctr">
-                    <a:noFill/>
-                  </a:tcPr>
-                </a:tc>
-                <a:tc>
-                  <a:txBody>
-                    <a:bodyPr/>
-                    <a:lstStyle/>
-                    <a:p>
-                      <a:pPr algn="r"/>
-                      <a:r>
-                        <a:rPr sz="1300" b="0">
-                          <a:solidFill>
-                            <a:srgbClr val="3C3C3B"/>
-                          </a:solidFill>
-                          <a:latin typeface="Aptos"/>
-                        </a:rPr>
-                        <a:t>41.0%</a:t>
-                      </a:r>
-                    </a:p>
-                  </a:txBody>
-                  <a:tcPr marL="73152" marR="73152" marT="27432" marB="27432" anchor="ctr">
-                    <a:noFill/>
-                  </a:tcPr>
-                </a:tc>
-                <a:tc>
-                  <a:txBody>
-                    <a:bodyPr/>
-                    <a:lstStyle/>
-                    <a:p>
-                      <a:pPr algn="r"/>
-                      <a:r>
-                        <a:rPr sz="1300" b="0">
-                          <a:solidFill>
-                            <a:srgbClr val="3C3C3B"/>
-                          </a:solidFill>
-                          <a:latin typeface="Aptos"/>
-                        </a:rPr>
-                        <a:t>4.6%</a:t>
+                        <a:t>24.8%</a:t>
+                      </a:r>
+                    </a:p>
+                  </a:txBody>
+                  <a:tcPr marL="73152" marR="73152" marT="27432" marB="27432" anchor="ctr">
+                    <a:noFill/>
+                  </a:tcPr>
+                </a:tc>
+                <a:tc>
+                  <a:txBody>
+                    <a:bodyPr/>
+                    <a:lstStyle/>
+                    <a:p>
+                      <a:pPr algn="r"/>
+                      <a:r>
+                        <a:rPr sz="1300" b="0">
+                          <a:solidFill>
+                            <a:srgbClr val="3C3C3B"/>
+                          </a:solidFill>
+                          <a:latin typeface="Aptos"/>
+                        </a:rPr>
+                        <a:t>43.1%</a:t>
+                      </a:r>
+                    </a:p>
+                  </a:txBody>
+                  <a:tcPr marL="73152" marR="73152" marT="27432" marB="27432" anchor="ctr">
+                    <a:noFill/>
+                  </a:tcPr>
+                </a:tc>
+                <a:tc>
+                  <a:txBody>
+                    <a:bodyPr/>
+                    <a:lstStyle/>
+                    <a:p>
+                      <a:pPr algn="r"/>
+                      <a:r>
+                        <a:rPr sz="1300" b="0">
+                          <a:solidFill>
+                            <a:srgbClr val="3C3C3B"/>
+                          </a:solidFill>
+                          <a:latin typeface="Aptos"/>
+                        </a:rPr>
+                        <a:t>4.5%</a:t>
                       </a:r>
                     </a:p>
                   </a:txBody>
@@ -21001,28 +21001,49 @@
                           </a:solidFill>
                           <a:latin typeface="Aptos"/>
                         </a:rPr>
-                        <a:t>6.1%</a:t>
-                      </a:r>
-                    </a:p>
-                  </a:txBody>
-                  <a:tcPr marL="73152" marR="73152" marT="27432" marB="27432" anchor="ctr">
-                    <a:noFill/>
-                  </a:tcPr>
-                </a:tc>
-                <a:tc>
-                  <a:txBody>
-                    <a:bodyPr/>
-                    <a:lstStyle/>
-                    <a:p>
-                      <a:pPr algn="r"/>
-                      <a:r>
-                        <a:rPr sz="1300" b="0">
-                          <a:solidFill>
-                            <a:srgbClr val="3C3C3B"/>
-                          </a:solidFill>
-                          <a:latin typeface="Aptos"/>
-                        </a:rPr>
-                        <a:t>9.8%</a:t>
+                        <a:t>5.9%</a:t>
+                      </a:r>
+                    </a:p>
+                  </a:txBody>
+                  <a:tcPr marL="73152" marR="73152" marT="27432" marB="27432" anchor="ctr">
+                    <a:noFill/>
+                  </a:tcPr>
+                </a:tc>
+                <a:tc>
+                  <a:txBody>
+                    <a:bodyPr/>
+                    <a:lstStyle/>
+                    <a:p>
+                      <a:pPr algn="r"/>
+                      <a:r>
+                        <a:rPr sz="1300" b="0">
+                          <a:solidFill>
+                            <a:srgbClr val="3C3C3B"/>
+                          </a:solidFill>
+                          <a:latin typeface="Aptos"/>
+                        </a:rPr>
+                        <a:t>9.9%</a:t>
+                      </a:r>
+                    </a:p>
+                  </a:txBody>
+                  <a:tcPr marL="73152" marR="73152" marT="27432" marB="27432" anchor="ctr">
+                    <a:noFill/>
+                  </a:tcPr>
+                </a:tc>
+                <a:tc>
+                  <a:txBody>
+                    <a:bodyPr/>
+                    <a:lstStyle/>
+                    <a:p>
+                      <a:pPr algn="r"/>
+                      <a:r>
+                        <a:rPr sz="1300" b="0">
+                          <a:solidFill>
+                            <a:srgbClr val="3C3C3B"/>
+                          </a:solidFill>
+                          <a:latin typeface="Aptos"/>
+                        </a:rPr>
+                        <a:t>1.72x</a:t>
                       </a:r>
                     </a:p>
                   </a:txBody>
@@ -21044,27 +21065,6 @@
                           <a:latin typeface="Aptos"/>
                         </a:rPr>
                         <a:t>1.68x</a:t>
-                      </a:r>
-                    </a:p>
-                  </a:txBody>
-                  <a:tcPr marL="73152" marR="73152" marT="27432" marB="27432" anchor="ctr">
-                    <a:noFill/>
-                  </a:tcPr>
-                </a:tc>
-                <a:tc>
-                  <a:txBody>
-                    <a:bodyPr/>
-                    <a:lstStyle/>
-                    <a:p>
-                      <a:pPr algn="r"/>
-                      <a:r>
-                        <a:rPr sz="1300" b="0">
-                          <a:solidFill>
-                            <a:srgbClr val="3C3C3B"/>
-                          </a:solidFill>
-                          <a:latin typeface="Aptos"/>
-                        </a:rPr>
-                        <a:t>2.21x</a:t>
                       </a:r>
                     </a:p>
                   </a:txBody>
@@ -21131,49 +21131,49 @@
                           </a:solidFill>
                           <a:latin typeface="Aptos"/>
                         </a:rPr>
-                        <a:t>26.3%</a:t>
-                      </a:r>
-                    </a:p>
-                  </a:txBody>
-                  <a:tcPr marL="73152" marR="73152" marT="27432" marB="27432" anchor="ctr">
-                    <a:noFill/>
-                  </a:tcPr>
-                </a:tc>
-                <a:tc>
-                  <a:txBody>
-                    <a:bodyPr/>
-                    <a:lstStyle/>
-                    <a:p>
-                      <a:pPr algn="r"/>
-                      <a:r>
-                        <a:rPr sz="1300" b="0">
-                          <a:solidFill>
-                            <a:srgbClr val="3C3C3B"/>
-                          </a:solidFill>
-                          <a:latin typeface="Aptos"/>
-                        </a:rPr>
-                        <a:t>41.0%</a:t>
-                      </a:r>
-                    </a:p>
-                  </a:txBody>
-                  <a:tcPr marL="73152" marR="73152" marT="27432" marB="27432" anchor="ctr">
-                    <a:noFill/>
-                  </a:tcPr>
-                </a:tc>
-                <a:tc>
-                  <a:txBody>
-                    <a:bodyPr/>
-                    <a:lstStyle/>
-                    <a:p>
-                      <a:pPr algn="r"/>
-                      <a:r>
-                        <a:rPr sz="1300" b="0">
-                          <a:solidFill>
-                            <a:srgbClr val="3C3C3B"/>
-                          </a:solidFill>
-                          <a:latin typeface="Aptos"/>
-                        </a:rPr>
-                        <a:t>6.9%</a:t>
+                        <a:t>24.8%</a:t>
+                      </a:r>
+                    </a:p>
+                  </a:txBody>
+                  <a:tcPr marL="73152" marR="73152" marT="27432" marB="27432" anchor="ctr">
+                    <a:noFill/>
+                  </a:tcPr>
+                </a:tc>
+                <a:tc>
+                  <a:txBody>
+                    <a:bodyPr/>
+                    <a:lstStyle/>
+                    <a:p>
+                      <a:pPr algn="r"/>
+                      <a:r>
+                        <a:rPr sz="1300" b="0">
+                          <a:solidFill>
+                            <a:srgbClr val="3C3C3B"/>
+                          </a:solidFill>
+                          <a:latin typeface="Aptos"/>
+                        </a:rPr>
+                        <a:t>43.1%</a:t>
+                      </a:r>
+                    </a:p>
+                  </a:txBody>
+                  <a:tcPr marL="73152" marR="73152" marT="27432" marB="27432" anchor="ctr">
+                    <a:noFill/>
+                  </a:tcPr>
+                </a:tc>
+                <a:tc>
+                  <a:txBody>
+                    <a:bodyPr/>
+                    <a:lstStyle/>
+                    <a:p>
+                      <a:pPr algn="r"/>
+                      <a:r>
+                        <a:rPr sz="1300" b="0">
+                          <a:solidFill>
+                            <a:srgbClr val="3C3C3B"/>
+                          </a:solidFill>
+                          <a:latin typeface="Aptos"/>
+                        </a:rPr>
+                        <a:t>6.8%</a:t>
                       </a:r>
                     </a:p>
                   </a:txBody>
@@ -21215,70 +21215,70 @@
                           </a:solidFill>
                           <a:latin typeface="Aptos"/>
                         </a:rPr>
-                        <a:t>9.5%</a:t>
-                      </a:r>
-                    </a:p>
-                  </a:txBody>
-                  <a:tcPr marL="73152" marR="73152" marT="27432" marB="27432" anchor="ctr">
-                    <a:noFill/>
-                  </a:tcPr>
-                </a:tc>
-                <a:tc>
-                  <a:txBody>
-                    <a:bodyPr/>
-                    <a:lstStyle/>
-                    <a:p>
-                      <a:pPr algn="r"/>
-                      <a:r>
-                        <a:rPr sz="1300" b="0">
-                          <a:solidFill>
-                            <a:srgbClr val="3C3C3B"/>
-                          </a:solidFill>
-                          <a:latin typeface="Aptos"/>
-                        </a:rPr>
-                        <a:t>13.8%</a:t>
-                      </a:r>
-                    </a:p>
-                  </a:txBody>
-                  <a:tcPr marL="73152" marR="73152" marT="27432" marB="27432" anchor="ctr">
-                    <a:noFill/>
-                  </a:tcPr>
-                </a:tc>
-                <a:tc>
-                  <a:txBody>
-                    <a:bodyPr/>
-                    <a:lstStyle/>
-                    <a:p>
-                      <a:pPr algn="r"/>
-                      <a:r>
-                        <a:rPr sz="1300" b="0">
-                          <a:solidFill>
-                            <a:srgbClr val="3C3C3B"/>
-                          </a:solidFill>
-                          <a:latin typeface="Aptos"/>
-                        </a:rPr>
-                        <a:t>2.10x</a:t>
-                      </a:r>
-                    </a:p>
-                  </a:txBody>
-                  <a:tcPr marL="73152" marR="73152" marT="27432" marB="27432" anchor="ctr">
-                    <a:noFill/>
-                  </a:tcPr>
-                </a:tc>
-                <a:tc>
-                  <a:txBody>
-                    <a:bodyPr/>
-                    <a:lstStyle/>
-                    <a:p>
-                      <a:pPr algn="r"/>
-                      <a:r>
-                        <a:rPr sz="1300" b="0">
-                          <a:solidFill>
-                            <a:srgbClr val="3C3C3B"/>
-                          </a:solidFill>
-                          <a:latin typeface="Aptos"/>
-                        </a:rPr>
-                        <a:t>2.79x</a:t>
+                        <a:t>8.9%</a:t>
+                      </a:r>
+                    </a:p>
+                  </a:txBody>
+                  <a:tcPr marL="73152" marR="73152" marT="27432" marB="27432" anchor="ctr">
+                    <a:noFill/>
+                  </a:tcPr>
+                </a:tc>
+                <a:tc>
+                  <a:txBody>
+                    <a:bodyPr/>
+                    <a:lstStyle/>
+                    <a:p>
+                      <a:pPr algn="r"/>
+                      <a:r>
+                        <a:rPr sz="1300" b="0">
+                          <a:solidFill>
+                            <a:srgbClr val="3C3C3B"/>
+                          </a:solidFill>
+                          <a:latin typeface="Aptos"/>
+                        </a:rPr>
+                        <a:t>14.0%</a:t>
+                      </a:r>
+                    </a:p>
+                  </a:txBody>
+                  <a:tcPr marL="73152" marR="73152" marT="27432" marB="27432" anchor="ctr">
+                    <a:noFill/>
+                  </a:tcPr>
+                </a:tc>
+                <a:tc>
+                  <a:txBody>
+                    <a:bodyPr/>
+                    <a:lstStyle/>
+                    <a:p>
+                      <a:pPr algn="r"/>
+                      <a:r>
+                        <a:rPr sz="1300" b="0">
+                          <a:solidFill>
+                            <a:srgbClr val="3C3C3B"/>
+                          </a:solidFill>
+                          <a:latin typeface="Aptos"/>
+                        </a:rPr>
+                        <a:t>2.16x</a:t>
+                      </a:r>
+                    </a:p>
+                  </a:txBody>
+                  <a:tcPr marL="73152" marR="73152" marT="27432" marB="27432" anchor="ctr">
+                    <a:noFill/>
+                  </a:tcPr>
+                </a:tc>
+                <a:tc>
+                  <a:txBody>
+                    <a:bodyPr/>
+                    <a:lstStyle/>
+                    <a:p>
+                      <a:pPr algn="r"/>
+                      <a:r>
+                        <a:rPr sz="1300" b="0">
+                          <a:solidFill>
+                            <a:srgbClr val="3C3C3B"/>
+                          </a:solidFill>
+                          <a:latin typeface="Aptos"/>
+                        </a:rPr>
+                        <a:t>2.11x</a:t>
                       </a:r>
                     </a:p>
                   </a:txBody>
@@ -21345,49 +21345,49 @@
                           </a:solidFill>
                           <a:latin typeface="Aptos"/>
                         </a:rPr>
-                        <a:t>23.8%</a:t>
-                      </a:r>
-                    </a:p>
-                  </a:txBody>
-                  <a:tcPr marL="73152" marR="73152" marT="27432" marB="27432" anchor="ctr">
-                    <a:noFill/>
-                  </a:tcPr>
-                </a:tc>
-                <a:tc>
-                  <a:txBody>
-                    <a:bodyPr/>
-                    <a:lstStyle/>
-                    <a:p>
-                      <a:pPr algn="r"/>
-                      <a:r>
-                        <a:rPr sz="1300" b="0">
-                          <a:solidFill>
-                            <a:srgbClr val="3C3C3B"/>
-                          </a:solidFill>
-                          <a:latin typeface="Aptos"/>
-                        </a:rPr>
-                        <a:t>38.6%</a:t>
-                      </a:r>
-                    </a:p>
-                  </a:txBody>
-                  <a:tcPr marL="73152" marR="73152" marT="27432" marB="27432" anchor="ctr">
-                    <a:noFill/>
-                  </a:tcPr>
-                </a:tc>
-                <a:tc>
-                  <a:txBody>
-                    <a:bodyPr/>
-                    <a:lstStyle/>
-                    <a:p>
-                      <a:pPr algn="r"/>
-                      <a:r>
-                        <a:rPr sz="1300" b="0">
-                          <a:solidFill>
-                            <a:srgbClr val="3C3C3B"/>
-                          </a:solidFill>
-                          <a:latin typeface="Aptos"/>
-                        </a:rPr>
-                        <a:t>5.7%</a:t>
+                        <a:t>22.5%</a:t>
+                      </a:r>
+                    </a:p>
+                  </a:txBody>
+                  <a:tcPr marL="73152" marR="73152" marT="27432" marB="27432" anchor="ctr">
+                    <a:noFill/>
+                  </a:tcPr>
+                </a:tc>
+                <a:tc>
+                  <a:txBody>
+                    <a:bodyPr/>
+                    <a:lstStyle/>
+                    <a:p>
+                      <a:pPr algn="r"/>
+                      <a:r>
+                        <a:rPr sz="1300" b="0">
+                          <a:solidFill>
+                            <a:srgbClr val="3C3C3B"/>
+                          </a:solidFill>
+                          <a:latin typeface="Aptos"/>
+                        </a:rPr>
+                        <a:t>40.5%</a:t>
+                      </a:r>
+                    </a:p>
+                  </a:txBody>
+                  <a:tcPr marL="73152" marR="73152" marT="27432" marB="27432" anchor="ctr">
+                    <a:noFill/>
+                  </a:tcPr>
+                </a:tc>
+                <a:tc>
+                  <a:txBody>
+                    <a:bodyPr/>
+                    <a:lstStyle/>
+                    <a:p>
+                      <a:pPr algn="r"/>
+                      <a:r>
+                        <a:rPr sz="1300" b="0">
+                          <a:solidFill>
+                            <a:srgbClr val="3C3C3B"/>
+                          </a:solidFill>
+                          <a:latin typeface="Aptos"/>
+                        </a:rPr>
+                        <a:t>5.6%</a:t>
                       </a:r>
                     </a:p>
                   </a:txBody>
@@ -21429,70 +21429,70 @@
                           </a:solidFill>
                           <a:latin typeface="Aptos"/>
                         </a:rPr>
-                        <a:t>7.5%</a:t>
-                      </a:r>
-                    </a:p>
-                  </a:txBody>
-                  <a:tcPr marL="73152" marR="73152" marT="27432" marB="27432" anchor="ctr">
-                    <a:noFill/>
-                  </a:tcPr>
-                </a:tc>
-                <a:tc>
-                  <a:txBody>
-                    <a:bodyPr/>
-                    <a:lstStyle/>
-                    <a:p>
-                      <a:pPr algn="r"/>
-                      <a:r>
-                        <a:rPr sz="1300" b="0">
-                          <a:solidFill>
-                            <a:srgbClr val="3C3C3B"/>
-                          </a:solidFill>
-                          <a:latin typeface="Aptos"/>
-                        </a:rPr>
-                        <a:t>11.3%</a:t>
-                      </a:r>
-                    </a:p>
-                  </a:txBody>
-                  <a:tcPr marL="73152" marR="73152" marT="27432" marB="27432" anchor="ctr">
-                    <a:noFill/>
-                  </a:tcPr>
-                </a:tc>
-                <a:tc>
-                  <a:txBody>
-                    <a:bodyPr/>
-                    <a:lstStyle/>
-                    <a:p>
-                      <a:pPr algn="r"/>
-                      <a:r>
-                        <a:rPr sz="1300" b="0">
-                          <a:solidFill>
-                            <a:srgbClr val="3C3C3B"/>
-                          </a:solidFill>
-                          <a:latin typeface="Aptos"/>
-                        </a:rPr>
-                        <a:t>1.88x</a:t>
-                      </a:r>
-                    </a:p>
-                  </a:txBody>
-                  <a:tcPr marL="73152" marR="73152" marT="27432" marB="27432" anchor="ctr">
-                    <a:noFill/>
-                  </a:tcPr>
-                </a:tc>
-                <a:tc>
-                  <a:txBody>
-                    <a:bodyPr/>
-                    <a:lstStyle/>
-                    <a:p>
-                      <a:pPr algn="r"/>
-                      <a:r>
-                        <a:rPr sz="1300" b="0">
-                          <a:solidFill>
-                            <a:srgbClr val="3C3C3B"/>
-                          </a:solidFill>
-                          <a:latin typeface="Aptos"/>
-                        </a:rPr>
-                        <a:t>2.48x</a:t>
+                        <a:t>7.2%</a:t>
+                      </a:r>
+                    </a:p>
+                  </a:txBody>
+                  <a:tcPr marL="73152" marR="73152" marT="27432" marB="27432" anchor="ctr">
+                    <a:noFill/>
+                  </a:tcPr>
+                </a:tc>
+                <a:tc>
+                  <a:txBody>
+                    <a:bodyPr/>
+                    <a:lstStyle/>
+                    <a:p>
+                      <a:pPr algn="r"/>
+                      <a:r>
+                        <a:rPr sz="1300" b="0">
+                          <a:solidFill>
+                            <a:srgbClr val="3C3C3B"/>
+                          </a:solidFill>
+                          <a:latin typeface="Aptos"/>
+                        </a:rPr>
+                        <a:t>11.4%</a:t>
+                      </a:r>
+                    </a:p>
+                  </a:txBody>
+                  <a:tcPr marL="73152" marR="73152" marT="27432" marB="27432" anchor="ctr">
+                    <a:noFill/>
+                  </a:tcPr>
+                </a:tc>
+                <a:tc>
+                  <a:txBody>
+                    <a:bodyPr/>
+                    <a:lstStyle/>
+                    <a:p>
+                      <a:pPr algn="r"/>
+                      <a:r>
+                        <a:rPr sz="1300" b="0">
+                          <a:solidFill>
+                            <a:srgbClr val="3C3C3B"/>
+                          </a:solidFill>
+                          <a:latin typeface="Aptos"/>
+                        </a:rPr>
+                        <a:t>1.94x</a:t>
+                      </a:r>
+                    </a:p>
+                  </a:txBody>
+                  <a:tcPr marL="73152" marR="73152" marT="27432" marB="27432" anchor="ctr">
+                    <a:noFill/>
+                  </a:tcPr>
+                </a:tc>
+                <a:tc>
+                  <a:txBody>
+                    <a:bodyPr/>
+                    <a:lstStyle/>
+                    <a:p>
+                      <a:pPr algn="r"/>
+                      <a:r>
+                        <a:rPr sz="1300" b="0">
+                          <a:solidFill>
+                            <a:srgbClr val="3C3C3B"/>
+                          </a:solidFill>
+                          <a:latin typeface="Aptos"/>
+                        </a:rPr>
+                        <a:t>1.89x</a:t>
                       </a:r>
                     </a:p>
                   </a:txBody>
@@ -21559,28 +21559,28 @@
                           </a:solidFill>
                           <a:latin typeface="Aptos"/>
                         </a:rPr>
-                        <a:t>25.7%</a:t>
-                      </a:r>
-                    </a:p>
-                  </a:txBody>
-                  <a:tcPr marL="73152" marR="73152" marT="27432" marB="27432" anchor="ctr">
-                    <a:noFill/>
-                  </a:tcPr>
-                </a:tc>
-                <a:tc>
-                  <a:txBody>
-                    <a:bodyPr/>
-                    <a:lstStyle/>
-                    <a:p>
-                      <a:pPr algn="r"/>
-                      <a:r>
-                        <a:rPr sz="1300" b="0">
-                          <a:solidFill>
-                            <a:srgbClr val="3C3C3B"/>
-                          </a:solidFill>
-                          <a:latin typeface="Aptos"/>
-                        </a:rPr>
-                        <a:t>40.6%</a:t>
+                        <a:t>24.3%</a:t>
+                      </a:r>
+                    </a:p>
+                  </a:txBody>
+                  <a:tcPr marL="73152" marR="73152" marT="27432" marB="27432" anchor="ctr">
+                    <a:noFill/>
+                  </a:tcPr>
+                </a:tc>
+                <a:tc>
+                  <a:txBody>
+                    <a:bodyPr/>
+                    <a:lstStyle/>
+                    <a:p>
+                      <a:pPr algn="r"/>
+                      <a:r>
+                        <a:rPr sz="1300" b="0">
+                          <a:solidFill>
+                            <a:srgbClr val="3C3C3B"/>
+                          </a:solidFill>
+                          <a:latin typeface="Aptos"/>
+                        </a:rPr>
+                        <a:t>42.4%</a:t>
                       </a:r>
                     </a:p>
                   </a:txBody>
@@ -21643,7 +21643,7 @@
                           </a:solidFill>
                           <a:latin typeface="Aptos"/>
                         </a:rPr>
-                        <a:t>7.3%</a:t>
+                        <a:t>7.1%</a:t>
                       </a:r>
                     </a:p>
                   </a:txBody>
@@ -21685,28 +21685,28 @@
                           </a:solidFill>
                           <a:latin typeface="Aptos"/>
                         </a:rPr>
-                        <a:t>1.74x</a:t>
-                      </a:r>
-                    </a:p>
-                  </a:txBody>
-                  <a:tcPr marL="73152" marR="73152" marT="27432" marB="27432" anchor="ctr">
-                    <a:noFill/>
-                  </a:tcPr>
-                </a:tc>
-                <a:tc>
-                  <a:txBody>
-                    <a:bodyPr/>
-                    <a:lstStyle/>
-                    <a:p>
-                      <a:pPr algn="r"/>
-                      <a:r>
-                        <a:rPr sz="1300" b="0">
-                          <a:solidFill>
-                            <a:srgbClr val="3C3C3B"/>
-                          </a:solidFill>
-                          <a:latin typeface="Aptos"/>
-                        </a:rPr>
-                        <a:t>2.30x</a:t>
+                        <a:t>1.82x</a:t>
+                      </a:r>
+                    </a:p>
+                  </a:txBody>
+                  <a:tcPr marL="73152" marR="73152" marT="27432" marB="27432" anchor="ctr">
+                    <a:noFill/>
+                  </a:tcPr>
+                </a:tc>
+                <a:tc>
+                  <a:txBody>
+                    <a:bodyPr/>
+                    <a:lstStyle/>
+                    <a:p>
+                      <a:pPr algn="r"/>
+                      <a:r>
+                        <a:rPr sz="1300" b="0">
+                          <a:solidFill>
+                            <a:srgbClr val="3C3C3B"/>
+                          </a:solidFill>
+                          <a:latin typeface="Aptos"/>
+                        </a:rPr>
+                        <a:t>1.78x</a:t>
                       </a:r>
                     </a:p>
                   </a:txBody>
@@ -21773,28 +21773,28 @@
                           </a:solidFill>
                           <a:latin typeface="Aptos"/>
                         </a:rPr>
-                        <a:t>26.3%</a:t>
-                      </a:r>
-                    </a:p>
-                  </a:txBody>
-                  <a:tcPr marL="73152" marR="73152" marT="27432" marB="27432" anchor="ctr">
-                    <a:noFill/>
-                  </a:tcPr>
-                </a:tc>
-                <a:tc>
-                  <a:txBody>
-                    <a:bodyPr/>
-                    <a:lstStyle/>
-                    <a:p>
-                      <a:pPr algn="r"/>
-                      <a:r>
-                        <a:rPr sz="1300" b="0">
-                          <a:solidFill>
-                            <a:srgbClr val="3C3C3B"/>
-                          </a:solidFill>
-                          <a:latin typeface="Aptos"/>
-                        </a:rPr>
-                        <a:t>41.0%</a:t>
+                        <a:t>24.8%</a:t>
+                      </a:r>
+                    </a:p>
+                  </a:txBody>
+                  <a:tcPr marL="73152" marR="73152" marT="27432" marB="27432" anchor="ctr">
+                    <a:noFill/>
+                  </a:tcPr>
+                </a:tc>
+                <a:tc>
+                  <a:txBody>
+                    <a:bodyPr/>
+                    <a:lstStyle/>
+                    <a:p>
+                      <a:pPr algn="r"/>
+                      <a:r>
+                        <a:rPr sz="1300" b="0">
+                          <a:solidFill>
+                            <a:srgbClr val="3C3C3B"/>
+                          </a:solidFill>
+                          <a:latin typeface="Aptos"/>
+                        </a:rPr>
+                        <a:t>43.1%</a:t>
                       </a:r>
                     </a:p>
                   </a:txBody>
@@ -21878,49 +21878,49 @@
                           </a:solidFill>
                           <a:latin typeface="Aptos"/>
                         </a:rPr>
-                        <a:t>10.7%</a:t>
-                      </a:r>
-                    </a:p>
-                  </a:txBody>
-                  <a:tcPr marL="73152" marR="73152" marT="27432" marB="27432" anchor="ctr">
-                    <a:noFill/>
-                  </a:tcPr>
-                </a:tc>
-                <a:tc>
-                  <a:txBody>
-                    <a:bodyPr/>
-                    <a:lstStyle/>
-                    <a:p>
-                      <a:pPr algn="r"/>
-                      <a:r>
-                        <a:rPr sz="1300" b="0">
-                          <a:solidFill>
-                            <a:srgbClr val="3C3C3B"/>
-                          </a:solidFill>
-                          <a:latin typeface="Aptos"/>
-                        </a:rPr>
-                        <a:t>1.24x</a:t>
-                      </a:r>
-                    </a:p>
-                  </a:txBody>
-                  <a:tcPr marL="73152" marR="73152" marT="27432" marB="27432" anchor="ctr">
-                    <a:noFill/>
-                  </a:tcPr>
-                </a:tc>
-                <a:tc>
-                  <a:txBody>
-                    <a:bodyPr/>
-                    <a:lstStyle/>
-                    <a:p>
-                      <a:pPr algn="r"/>
-                      <a:r>
-                        <a:rPr sz="1300" b="0">
-                          <a:solidFill>
-                            <a:srgbClr val="3C3C3B"/>
-                          </a:solidFill>
-                          <a:latin typeface="Aptos"/>
-                        </a:rPr>
-                        <a:t>1.63x</a:t>
+                        <a:t>11.0%</a:t>
+                      </a:r>
+                    </a:p>
+                  </a:txBody>
+                  <a:tcPr marL="73152" marR="73152" marT="27432" marB="27432" anchor="ctr">
+                    <a:noFill/>
+                  </a:tcPr>
+                </a:tc>
+                <a:tc>
+                  <a:txBody>
+                    <a:bodyPr/>
+                    <a:lstStyle/>
+                    <a:p>
+                      <a:pPr algn="r"/>
+                      <a:r>
+                        <a:rPr sz="1300" b="0">
+                          <a:solidFill>
+                            <a:srgbClr val="3C3C3B"/>
+                          </a:solidFill>
+                          <a:latin typeface="Aptos"/>
+                        </a:rPr>
+                        <a:t>1.44x</a:t>
+                      </a:r>
+                    </a:p>
+                  </a:txBody>
+                  <a:tcPr marL="73152" marR="73152" marT="27432" marB="27432" anchor="ctr">
+                    <a:noFill/>
+                  </a:tcPr>
+                </a:tc>
+                <a:tc>
+                  <a:txBody>
+                    <a:bodyPr/>
+                    <a:lstStyle/>
+                    <a:p>
+                      <a:pPr algn="r"/>
+                      <a:r>
+                        <a:rPr sz="1300" b="0">
+                          <a:solidFill>
+                            <a:srgbClr val="3C3C3B"/>
+                          </a:solidFill>
+                          <a:latin typeface="Aptos"/>
+                        </a:rPr>
+                        <a:t>1.40x</a:t>
                       </a:r>
                     </a:p>
                   </a:txBody>
@@ -21987,49 +21987,49 @@
                           </a:solidFill>
                           <a:latin typeface="Aptos"/>
                         </a:rPr>
-                        <a:t>26.3%</a:t>
-                      </a:r>
-                    </a:p>
-                  </a:txBody>
-                  <a:tcPr marL="73152" marR="73152" marT="27432" marB="27432" anchor="ctr">
-                    <a:noFill/>
-                  </a:tcPr>
-                </a:tc>
-                <a:tc>
-                  <a:txBody>
-                    <a:bodyPr/>
-                    <a:lstStyle/>
-                    <a:p>
-                      <a:pPr algn="r"/>
-                      <a:r>
-                        <a:rPr sz="1300" b="0">
-                          <a:solidFill>
-                            <a:srgbClr val="3C3C3B"/>
-                          </a:solidFill>
-                          <a:latin typeface="Aptos"/>
-                        </a:rPr>
-                        <a:t>41.0%</a:t>
-                      </a:r>
-                    </a:p>
-                  </a:txBody>
-                  <a:tcPr marL="73152" marR="73152" marT="27432" marB="27432" anchor="ctr">
-                    <a:noFill/>
-                  </a:tcPr>
-                </a:tc>
-                <a:tc>
-                  <a:txBody>
-                    <a:bodyPr/>
-                    <a:lstStyle/>
-                    <a:p>
-                      <a:pPr algn="r"/>
-                      <a:r>
-                        <a:rPr sz="1300" b="0">
-                          <a:solidFill>
-                            <a:srgbClr val="3C3C3B"/>
-                          </a:solidFill>
-                          <a:latin typeface="Aptos"/>
-                        </a:rPr>
-                        <a:t>4.3%</a:t>
+                        <a:t>24.8%</a:t>
+                      </a:r>
+                    </a:p>
+                  </a:txBody>
+                  <a:tcPr marL="73152" marR="73152" marT="27432" marB="27432" anchor="ctr">
+                    <a:noFill/>
+                  </a:tcPr>
+                </a:tc>
+                <a:tc>
+                  <a:txBody>
+                    <a:bodyPr/>
+                    <a:lstStyle/>
+                    <a:p>
+                      <a:pPr algn="r"/>
+                      <a:r>
+                        <a:rPr sz="1300" b="0">
+                          <a:solidFill>
+                            <a:srgbClr val="3C3C3B"/>
+                          </a:solidFill>
+                          <a:latin typeface="Aptos"/>
+                        </a:rPr>
+                        <a:t>43.1%</a:t>
+                      </a:r>
+                    </a:p>
+                  </a:txBody>
+                  <a:tcPr marL="73152" marR="73152" marT="27432" marB="27432" anchor="ctr">
+                    <a:noFill/>
+                  </a:tcPr>
+                </a:tc>
+                <a:tc>
+                  <a:txBody>
+                    <a:bodyPr/>
+                    <a:lstStyle/>
+                    <a:p>
+                      <a:pPr algn="r"/>
+                      <a:r>
+                        <a:rPr sz="1300" b="0">
+                          <a:solidFill>
+                            <a:srgbClr val="3C3C3B"/>
+                          </a:solidFill>
+                          <a:latin typeface="Aptos"/>
+                        </a:rPr>
+                        <a:t>4.1%</a:t>
                       </a:r>
                     </a:p>
                   </a:txBody>
@@ -22071,70 +22071,70 @@
                           </a:solidFill>
                           <a:latin typeface="Aptos"/>
                         </a:rPr>
-                        <a:t>5.9%</a:t>
-                      </a:r>
-                    </a:p>
-                  </a:txBody>
-                  <a:tcPr marL="73152" marR="73152" marT="27432" marB="27432" anchor="ctr">
-                    <a:noFill/>
-                  </a:tcPr>
-                </a:tc>
-                <a:tc>
-                  <a:txBody>
-                    <a:bodyPr/>
-                    <a:lstStyle/>
-                    <a:p>
-                      <a:pPr algn="r"/>
-                      <a:r>
-                        <a:rPr sz="1300" b="0">
-                          <a:solidFill>
-                            <a:srgbClr val="3C3C3B"/>
-                          </a:solidFill>
-                          <a:latin typeface="Aptos"/>
-                        </a:rPr>
-                        <a:t>8.8%</a:t>
-                      </a:r>
-                    </a:p>
-                  </a:txBody>
-                  <a:tcPr marL="73152" marR="73152" marT="27432" marB="27432" anchor="ctr">
-                    <a:noFill/>
-                  </a:tcPr>
-                </a:tc>
-                <a:tc>
-                  <a:txBody>
-                    <a:bodyPr/>
-                    <a:lstStyle/>
-                    <a:p>
-                      <a:pPr algn="r"/>
-                      <a:r>
-                        <a:rPr sz="1300" b="0">
-                          <a:solidFill>
-                            <a:srgbClr val="3C3C3B"/>
-                          </a:solidFill>
-                          <a:latin typeface="Aptos"/>
-                        </a:rPr>
-                        <a:t>1.74x</a:t>
-                      </a:r>
-                    </a:p>
-                  </a:txBody>
-                  <a:tcPr marL="73152" marR="73152" marT="27432" marB="27432" anchor="ctr">
-                    <a:noFill/>
-                  </a:tcPr>
-                </a:tc>
-                <a:tc>
-                  <a:txBody>
-                    <a:bodyPr/>
-                    <a:lstStyle/>
-                    <a:p>
-                      <a:pPr algn="r"/>
-                      <a:r>
-                        <a:rPr sz="1300" b="0">
-                          <a:solidFill>
-                            <a:srgbClr val="3C3C3B"/>
-                          </a:solidFill>
-                          <a:latin typeface="Aptos"/>
-                        </a:rPr>
-                        <a:t>2.13x</a:t>
+                        <a:t>5.6%</a:t>
+                      </a:r>
+                    </a:p>
+                  </a:txBody>
+                  <a:tcPr marL="73152" marR="73152" marT="27432" marB="27432" anchor="ctr">
+                    <a:noFill/>
+                  </a:tcPr>
+                </a:tc>
+                <a:tc>
+                  <a:txBody>
+                    <a:bodyPr/>
+                    <a:lstStyle/>
+                    <a:p>
+                      <a:pPr algn="r"/>
+                      <a:r>
+                        <a:rPr sz="1300" b="0">
+                          <a:solidFill>
+                            <a:srgbClr val="3C3C3B"/>
+                          </a:solidFill>
+                          <a:latin typeface="Aptos"/>
+                        </a:rPr>
+                        <a:t>8.9%</a:t>
+                      </a:r>
+                    </a:p>
+                  </a:txBody>
+                  <a:tcPr marL="73152" marR="73152" marT="27432" marB="27432" anchor="ctr">
+                    <a:noFill/>
+                  </a:tcPr>
+                </a:tc>
+                <a:tc>
+                  <a:txBody>
+                    <a:bodyPr/>
+                    <a:lstStyle/>
+                    <a:p>
+                      <a:pPr algn="r"/>
+                      <a:r>
+                        <a:rPr sz="1300" b="0">
+                          <a:solidFill>
+                            <a:srgbClr val="3C3C3B"/>
+                          </a:solidFill>
+                          <a:latin typeface="Aptos"/>
+                        </a:rPr>
+                        <a:t>1.67x</a:t>
+                      </a:r>
+                    </a:p>
+                  </a:txBody>
+                  <a:tcPr marL="73152" marR="73152" marT="27432" marB="27432" anchor="ctr">
+                    <a:noFill/>
+                  </a:tcPr>
+                </a:tc>
+                <a:tc>
+                  <a:txBody>
+                    <a:bodyPr/>
+                    <a:lstStyle/>
+                    <a:p>
+                      <a:pPr algn="r"/>
+                      <a:r>
+                        <a:rPr sz="1300" b="0">
+                          <a:solidFill>
+                            <a:srgbClr val="3C3C3B"/>
+                          </a:solidFill>
+                          <a:latin typeface="Aptos"/>
+                        </a:rPr>
+                        <a:t>1.54x</a:t>
                       </a:r>
                     </a:p>
                   </a:txBody>
@@ -22201,28 +22201,28 @@
                           </a:solidFill>
                           <a:latin typeface="Aptos"/>
                         </a:rPr>
-                        <a:t>26.3%</a:t>
-                      </a:r>
-                    </a:p>
-                  </a:txBody>
-                  <a:tcPr marL="73152" marR="73152" marT="27432" marB="27432" anchor="ctr">
-                    <a:noFill/>
-                  </a:tcPr>
-                </a:tc>
-                <a:tc>
-                  <a:txBody>
-                    <a:bodyPr/>
-                    <a:lstStyle/>
-                    <a:p>
-                      <a:pPr algn="r"/>
-                      <a:r>
-                        <a:rPr sz="1300" b="0">
-                          <a:solidFill>
-                            <a:srgbClr val="3C3C3B"/>
-                          </a:solidFill>
-                          <a:latin typeface="Aptos"/>
-                        </a:rPr>
-                        <a:t>41.0%</a:t>
+                        <a:t>24.8%</a:t>
+                      </a:r>
+                    </a:p>
+                  </a:txBody>
+                  <a:tcPr marL="73152" marR="73152" marT="27432" marB="27432" anchor="ctr">
+                    <a:noFill/>
+                  </a:tcPr>
+                </a:tc>
+                <a:tc>
+                  <a:txBody>
+                    <a:bodyPr/>
+                    <a:lstStyle/>
+                    <a:p>
+                      <a:pPr algn="r"/>
+                      <a:r>
+                        <a:rPr sz="1300" b="0">
+                          <a:solidFill>
+                            <a:srgbClr val="3C3C3B"/>
+                          </a:solidFill>
+                          <a:latin typeface="Aptos"/>
+                        </a:rPr>
+                        <a:t>43.1%</a:t>
                       </a:r>
                     </a:p>
                   </a:txBody>
@@ -22285,70 +22285,70 @@
                           </a:solidFill>
                           <a:latin typeface="Aptos"/>
                         </a:rPr>
-                        <a:t>8.1%</a:t>
-                      </a:r>
-                    </a:p>
-                  </a:txBody>
-                  <a:tcPr marL="73152" marR="73152" marT="27432" marB="27432" anchor="ctr">
-                    <a:noFill/>
-                  </a:tcPr>
-                </a:tc>
-                <a:tc>
-                  <a:txBody>
-                    <a:bodyPr/>
-                    <a:lstStyle/>
-                    <a:p>
-                      <a:pPr algn="r"/>
-                      <a:r>
-                        <a:rPr sz="1300" b="0">
-                          <a:solidFill>
-                            <a:srgbClr val="3C3C3B"/>
-                          </a:solidFill>
-                          <a:latin typeface="Aptos"/>
-                        </a:rPr>
-                        <a:t>12.2%</a:t>
-                      </a:r>
-                    </a:p>
-                  </a:txBody>
-                  <a:tcPr marL="73152" marR="73152" marT="27432" marB="27432" anchor="ctr">
-                    <a:noFill/>
-                  </a:tcPr>
-                </a:tc>
-                <a:tc>
-                  <a:txBody>
-                    <a:bodyPr/>
-                    <a:lstStyle/>
-                    <a:p>
-                      <a:pPr algn="r"/>
-                      <a:r>
-                        <a:rPr sz="1300" b="0">
-                          <a:solidFill>
-                            <a:srgbClr val="3C3C3B"/>
-                          </a:solidFill>
-                          <a:latin typeface="Aptos"/>
-                        </a:rPr>
-                        <a:t>1.91x</a:t>
-                      </a:r>
-                    </a:p>
-                  </a:txBody>
-                  <a:tcPr marL="73152" marR="73152" marT="27432" marB="27432" anchor="ctr">
-                    <a:noFill/>
-                  </a:tcPr>
-                </a:tc>
-                <a:tc>
-                  <a:txBody>
-                    <a:bodyPr/>
-                    <a:lstStyle/>
-                    <a:p>
-                      <a:pPr algn="r"/>
-                      <a:r>
-                        <a:rPr sz="1300" b="0">
-                          <a:solidFill>
-                            <a:srgbClr val="3C3C3B"/>
-                          </a:solidFill>
-                          <a:latin typeface="Aptos"/>
-                        </a:rPr>
-                        <a:t>2.55x</a:t>
+                        <a:t>7.7%</a:t>
+                      </a:r>
+                    </a:p>
+                  </a:txBody>
+                  <a:tcPr marL="73152" marR="73152" marT="27432" marB="27432" anchor="ctr">
+                    <a:noFill/>
+                  </a:tcPr>
+                </a:tc>
+                <a:tc>
+                  <a:txBody>
+                    <a:bodyPr/>
+                    <a:lstStyle/>
+                    <a:p>
+                      <a:pPr algn="r"/>
+                      <a:r>
+                        <a:rPr sz="1300" b="0">
+                          <a:solidFill>
+                            <a:srgbClr val="3C3C3B"/>
+                          </a:solidFill>
+                          <a:latin typeface="Aptos"/>
+                        </a:rPr>
+                        <a:t>12.3%</a:t>
+                      </a:r>
+                    </a:p>
+                  </a:txBody>
+                  <a:tcPr marL="73152" marR="73152" marT="27432" marB="27432" anchor="ctr">
+                    <a:noFill/>
+                  </a:tcPr>
+                </a:tc>
+                <a:tc>
+                  <a:txBody>
+                    <a:bodyPr/>
+                    <a:lstStyle/>
+                    <a:p>
+                      <a:pPr algn="r"/>
+                      <a:r>
+                        <a:rPr sz="1300" b="0">
+                          <a:solidFill>
+                            <a:srgbClr val="3C3C3B"/>
+                          </a:solidFill>
+                          <a:latin typeface="Aptos"/>
+                        </a:rPr>
+                        <a:t>1.96x</a:t>
+                      </a:r>
+                    </a:p>
+                  </a:txBody>
+                  <a:tcPr marL="73152" marR="73152" marT="27432" marB="27432" anchor="ctr">
+                    <a:noFill/>
+                  </a:tcPr>
+                </a:tc>
+                <a:tc>
+                  <a:txBody>
+                    <a:bodyPr/>
+                    <a:lstStyle/>
+                    <a:p>
+                      <a:pPr algn="r"/>
+                      <a:r>
+                        <a:rPr sz="1300" b="0">
+                          <a:solidFill>
+                            <a:srgbClr val="3C3C3B"/>
+                          </a:solidFill>
+                          <a:latin typeface="Aptos"/>
+                        </a:rPr>
+                        <a:t>1.93x</a:t>
                       </a:r>
                     </a:p>
                   </a:txBody>
@@ -22371,7 +22371,7 @@
                           </a:solidFill>
                           <a:latin typeface="Aptos"/>
                         </a:rPr>
-                        <a:t>Debt 6x EBITDA</a:t>
+                        <a:t>UniCredit terms</a:t>
                       </a:r>
                     </a:p>
                   </a:txBody>
@@ -22415,49 +22415,49 @@
                           </a:solidFill>
                           <a:latin typeface="Aptos"/>
                         </a:rPr>
-                        <a:t>26.0%</a:t>
-                      </a:r>
-                    </a:p>
-                  </a:txBody>
-                  <a:tcPr marL="73152" marR="73152" marT="27432" marB="27432" anchor="ctr">
-                    <a:noFill/>
-                  </a:tcPr>
-                </a:tc>
-                <a:tc>
-                  <a:txBody>
-                    <a:bodyPr/>
-                    <a:lstStyle/>
-                    <a:p>
-                      <a:pPr algn="r"/>
-                      <a:r>
-                        <a:rPr sz="1300" b="0">
-                          <a:solidFill>
-                            <a:srgbClr val="3C3C3B"/>
-                          </a:solidFill>
-                          <a:latin typeface="Aptos"/>
-                        </a:rPr>
-                        <a:t>45.2%</a:t>
-                      </a:r>
-                    </a:p>
-                  </a:txBody>
-                  <a:tcPr marL="73152" marR="73152" marT="27432" marB="27432" anchor="ctr">
-                    <a:noFill/>
-                  </a:tcPr>
-                </a:tc>
-                <a:tc>
-                  <a:txBody>
-                    <a:bodyPr/>
-                    <a:lstStyle/>
-                    <a:p>
-                      <a:pPr algn="r"/>
-                      <a:r>
-                        <a:rPr sz="1300" b="0">
-                          <a:solidFill>
-                            <a:srgbClr val="3C3C3B"/>
-                          </a:solidFill>
-                          <a:latin typeface="Aptos"/>
-                        </a:rPr>
-                        <a:t>5.7%</a:t>
+                        <a:t>24.8%</a:t>
+                      </a:r>
+                    </a:p>
+                  </a:txBody>
+                  <a:tcPr marL="73152" marR="73152" marT="27432" marB="27432" anchor="ctr">
+                    <a:noFill/>
+                  </a:tcPr>
+                </a:tc>
+                <a:tc>
+                  <a:txBody>
+                    <a:bodyPr/>
+                    <a:lstStyle/>
+                    <a:p>
+                      <a:pPr algn="r"/>
+                      <a:r>
+                        <a:rPr sz="1300" b="0">
+                          <a:solidFill>
+                            <a:srgbClr val="3C3C3B"/>
+                          </a:solidFill>
+                          <a:latin typeface="Aptos"/>
+                        </a:rPr>
+                        <a:t>43.1%</a:t>
+                      </a:r>
+                    </a:p>
+                  </a:txBody>
+                  <a:tcPr marL="73152" marR="73152" marT="27432" marB="27432" anchor="ctr">
+                    <a:noFill/>
+                  </a:tcPr>
+                </a:tc>
+                <a:tc>
+                  <a:txBody>
+                    <a:bodyPr/>
+                    <a:lstStyle/>
+                    <a:p>
+                      <a:pPr algn="r"/>
+                      <a:r>
+                        <a:rPr sz="1300" b="0">
+                          <a:solidFill>
+                            <a:srgbClr val="3C3C3B"/>
+                          </a:solidFill>
+                          <a:latin typeface="Aptos"/>
+                        </a:rPr>
+                        <a:t>5.6%</a:t>
                       </a:r>
                     </a:p>
                   </a:txBody>
@@ -22499,70 +22499,70 @@
                           </a:solidFill>
                           <a:latin typeface="Aptos"/>
                         </a:rPr>
-                        <a:t>7.7%</a:t>
-                      </a:r>
-                    </a:p>
-                  </a:txBody>
-                  <a:tcPr marL="73152" marR="73152" marT="27432" marB="27432" anchor="ctr">
-                    <a:noFill/>
-                  </a:tcPr>
-                </a:tc>
-                <a:tc>
-                  <a:txBody>
-                    <a:bodyPr/>
-                    <a:lstStyle/>
-                    <a:p>
-                      <a:pPr algn="r"/>
-                      <a:r>
-                        <a:rPr sz="1300" b="0">
-                          <a:solidFill>
-                            <a:srgbClr val="3C3C3B"/>
-                          </a:solidFill>
-                          <a:latin typeface="Aptos"/>
-                        </a:rPr>
-                        <a:t>13.0%</a:t>
-                      </a:r>
-                    </a:p>
-                  </a:txBody>
-                  <a:tcPr marL="73152" marR="73152" marT="27432" marB="27432" anchor="ctr">
-                    <a:noFill/>
-                  </a:tcPr>
-                </a:tc>
-                <a:tc>
-                  <a:txBody>
-                    <a:bodyPr/>
-                    <a:lstStyle/>
-                    <a:p>
-                      <a:pPr algn="r"/>
-                      <a:r>
-                        <a:rPr sz="1300" b="0">
-                          <a:solidFill>
-                            <a:srgbClr val="3C3C3B"/>
-                          </a:solidFill>
-                          <a:latin typeface="Aptos"/>
-                        </a:rPr>
-                        <a:t>1.94x</a:t>
-                      </a:r>
-                    </a:p>
-                  </a:txBody>
-                  <a:tcPr marL="73152" marR="73152" marT="27432" marB="27432" anchor="ctr">
-                    <a:noFill/>
-                  </a:tcPr>
-                </a:tc>
-                <a:tc>
-                  <a:txBody>
-                    <a:bodyPr/>
-                    <a:lstStyle/>
-                    <a:p>
-                      <a:pPr algn="r"/>
-                      <a:r>
-                        <a:rPr sz="1300" b="0">
-                          <a:solidFill>
-                            <a:srgbClr val="3C3C3B"/>
-                          </a:solidFill>
-                          <a:latin typeface="Aptos"/>
-                        </a:rPr>
-                        <a:t>1.97x</a:t>
+                        <a:t>7.3%</a:t>
+                      </a:r>
+                    </a:p>
+                  </a:txBody>
+                  <a:tcPr marL="73152" marR="73152" marT="27432" marB="27432" anchor="ctr">
+                    <a:noFill/>
+                  </a:tcPr>
+                </a:tc>
+                <a:tc>
+                  <a:txBody>
+                    <a:bodyPr/>
+                    <a:lstStyle/>
+                    <a:p>
+                      <a:pPr algn="r"/>
+                      <a:r>
+                        <a:rPr sz="1300" b="0">
+                          <a:solidFill>
+                            <a:srgbClr val="3C3C3B"/>
+                          </a:solidFill>
+                          <a:latin typeface="Aptos"/>
+                        </a:rPr>
+                        <a:t>11.3%</a:t>
+                      </a:r>
+                    </a:p>
+                  </a:txBody>
+                  <a:tcPr marL="73152" marR="73152" marT="27432" marB="27432" anchor="ctr">
+                    <a:noFill/>
+                  </a:tcPr>
+                </a:tc>
+                <a:tc>
+                  <a:txBody>
+                    <a:bodyPr/>
+                    <a:lstStyle/>
+                    <a:p>
+                      <a:pPr algn="r"/>
+                      <a:r>
+                        <a:rPr sz="1300" b="0">
+                          <a:solidFill>
+                            <a:srgbClr val="3C3C3B"/>
+                          </a:solidFill>
+                          <a:latin typeface="Aptos"/>
+                        </a:rPr>
+                        <a:t>1.65x</a:t>
+                      </a:r>
+                    </a:p>
+                  </a:txBody>
+                  <a:tcPr marL="73152" marR="73152" marT="27432" marB="27432" anchor="ctr">
+                    <a:noFill/>
+                  </a:tcPr>
+                </a:tc>
+                <a:tc>
+                  <a:txBody>
+                    <a:bodyPr/>
+                    <a:lstStyle/>
+                    <a:p>
+                      <a:pPr algn="r"/>
+                      <a:r>
+                        <a:rPr sz="1300" b="0">
+                          <a:solidFill>
+                            <a:srgbClr val="3C3C3B"/>
+                          </a:solidFill>
+                          <a:latin typeface="Aptos"/>
+                        </a:rPr>
+                        <a:t>1.61x</a:t>
                       </a:r>
                     </a:p>
                   </a:txBody>
@@ -22629,28 +22629,28 @@
                           </a:solidFill>
                           <a:latin typeface="Aptos"/>
                         </a:rPr>
-                        <a:t>18.1%</a:t>
-                      </a:r>
-                    </a:p>
-                  </a:txBody>
-                  <a:tcPr marL="73152" marR="73152" marT="27432" marB="27432" anchor="ctr">
-                    <a:noFill/>
-                  </a:tcPr>
-                </a:tc>
-                <a:tc>
-                  <a:txBody>
-                    <a:bodyPr/>
-                    <a:lstStyle/>
-                    <a:p>
-                      <a:pPr algn="r"/>
-                      <a:r>
-                        <a:rPr sz="1300" b="0">
-                          <a:solidFill>
-                            <a:srgbClr val="3C3C3B"/>
-                          </a:solidFill>
-                          <a:latin typeface="Aptos"/>
-                        </a:rPr>
-                        <a:t>32.5%</a:t>
+                        <a:t>17.0%</a:t>
+                      </a:r>
+                    </a:p>
+                  </a:txBody>
+                  <a:tcPr marL="73152" marR="73152" marT="27432" marB="27432" anchor="ctr">
+                    <a:noFill/>
+                  </a:tcPr>
+                </a:tc>
+                <a:tc>
+                  <a:txBody>
+                    <a:bodyPr/>
+                    <a:lstStyle/>
+                    <a:p>
+                      <a:pPr algn="r"/>
+                      <a:r>
+                        <a:rPr sz="1300" b="0">
+                          <a:solidFill>
+                            <a:srgbClr val="3C3C3B"/>
+                          </a:solidFill>
+                          <a:latin typeface="Aptos"/>
+                        </a:rPr>
+                        <a:t>33.2%</a:t>
                       </a:r>
                     </a:p>
                   </a:txBody>
@@ -22713,70 +22713,70 @@
                           </a:solidFill>
                           <a:latin typeface="Aptos"/>
                         </a:rPr>
-                        <a:t>7.1%</a:t>
-                      </a:r>
-                    </a:p>
-                  </a:txBody>
-                  <a:tcPr marL="73152" marR="73152" marT="27432" marB="27432" anchor="ctr">
-                    <a:noFill/>
-                  </a:tcPr>
-                </a:tc>
-                <a:tc>
-                  <a:txBody>
-                    <a:bodyPr/>
-                    <a:lstStyle/>
-                    <a:p>
-                      <a:pPr algn="r"/>
-                      <a:r>
-                        <a:rPr sz="1300" b="0">
-                          <a:solidFill>
-                            <a:srgbClr val="3C3C3B"/>
-                          </a:solidFill>
-                          <a:latin typeface="Aptos"/>
-                        </a:rPr>
-                        <a:t>10.7%</a:t>
-                      </a:r>
-                    </a:p>
-                  </a:txBody>
-                  <a:tcPr marL="73152" marR="73152" marT="27432" marB="27432" anchor="ctr">
-                    <a:noFill/>
-                  </a:tcPr>
-                </a:tc>
-                <a:tc>
-                  <a:txBody>
-                    <a:bodyPr/>
-                    <a:lstStyle/>
-                    <a:p>
-                      <a:pPr algn="r"/>
-                      <a:r>
-                        <a:rPr sz="1300" b="0">
-                          <a:solidFill>
-                            <a:srgbClr val="3C3C3B"/>
-                          </a:solidFill>
-                          <a:latin typeface="Aptos"/>
-                        </a:rPr>
-                        <a:t>1.79x</a:t>
-                      </a:r>
-                    </a:p>
-                  </a:txBody>
-                  <a:tcPr marL="73152" marR="73152" marT="27432" marB="27432" anchor="ctr">
-                    <a:noFill/>
-                  </a:tcPr>
-                </a:tc>
-                <a:tc>
-                  <a:txBody>
-                    <a:bodyPr/>
-                    <a:lstStyle/>
-                    <a:p>
-                      <a:pPr algn="r"/>
-                      <a:r>
-                        <a:rPr sz="1300" b="0">
-                          <a:solidFill>
-                            <a:srgbClr val="3C3C3B"/>
-                          </a:solidFill>
-                          <a:latin typeface="Aptos"/>
-                        </a:rPr>
-                        <a:t>2.32x</a:t>
+                        <a:t>6.7%</a:t>
+                      </a:r>
+                    </a:p>
+                  </a:txBody>
+                  <a:tcPr marL="73152" marR="73152" marT="27432" marB="27432" anchor="ctr">
+                    <a:noFill/>
+                  </a:tcPr>
+                </a:tc>
+                <a:tc>
+                  <a:txBody>
+                    <a:bodyPr/>
+                    <a:lstStyle/>
+                    <a:p>
+                      <a:pPr algn="r"/>
+                      <a:r>
+                        <a:rPr sz="1300" b="0">
+                          <a:solidFill>
+                            <a:srgbClr val="3C3C3B"/>
+                          </a:solidFill>
+                          <a:latin typeface="Aptos"/>
+                        </a:rPr>
+                        <a:t>10.5%</a:t>
+                      </a:r>
+                    </a:p>
+                  </a:txBody>
+                  <a:tcPr marL="73152" marR="73152" marT="27432" marB="27432" anchor="ctr">
+                    <a:noFill/>
+                  </a:tcPr>
+                </a:tc>
+                <a:tc>
+                  <a:txBody>
+                    <a:bodyPr/>
+                    <a:lstStyle/>
+                    <a:p>
+                      <a:pPr algn="r"/>
+                      <a:r>
+                        <a:rPr sz="1300" b="0">
+                          <a:solidFill>
+                            <a:srgbClr val="3C3C3B"/>
+                          </a:solidFill>
+                          <a:latin typeface="Aptos"/>
+                        </a:rPr>
+                        <a:t>1.95x</a:t>
+                      </a:r>
+                    </a:p>
+                  </a:txBody>
+                  <a:tcPr marL="73152" marR="73152" marT="27432" marB="27432" anchor="ctr">
+                    <a:noFill/>
+                  </a:tcPr>
+                </a:tc>
+                <a:tc>
+                  <a:txBody>
+                    <a:bodyPr/>
+                    <a:lstStyle/>
+                    <a:p>
+                      <a:pPr algn="r"/>
+                      <a:r>
+                        <a:rPr sz="1300" b="0">
+                          <a:solidFill>
+                            <a:srgbClr val="3C3C3B"/>
+                          </a:solidFill>
+                          <a:latin typeface="Aptos"/>
+                        </a:rPr>
+                        <a:t>1.89x</a:t>
                       </a:r>
                     </a:p>
                   </a:txBody>
@@ -22843,28 +22843,28 @@
                           </a:solidFill>
                           <a:latin typeface="Aptos"/>
                         </a:rPr>
-                        <a:t>41.9%</a:t>
-                      </a:r>
-                    </a:p>
-                  </a:txBody>
-                  <a:tcPr marL="73152" marR="73152" marT="27432" marB="27432" anchor="ctr">
-                    <a:noFill/>
-                  </a:tcPr>
-                </a:tc>
-                <a:tc>
-                  <a:txBody>
-                    <a:bodyPr/>
-                    <a:lstStyle/>
-                    <a:p>
-                      <a:pPr algn="r"/>
-                      <a:r>
-                        <a:rPr sz="1300" b="0">
-                          <a:solidFill>
-                            <a:srgbClr val="3C3C3B"/>
-                          </a:solidFill>
-                          <a:latin typeface="Aptos"/>
-                        </a:rPr>
-                        <a:t>41.9%</a:t>
+                        <a:t>44.9%</a:t>
+                      </a:r>
+                    </a:p>
+                  </a:txBody>
+                  <a:tcPr marL="73152" marR="73152" marT="27432" marB="27432" anchor="ctr">
+                    <a:noFill/>
+                  </a:tcPr>
+                </a:tc>
+                <a:tc>
+                  <a:txBody>
+                    <a:bodyPr/>
+                    <a:lstStyle/>
+                    <a:p>
+                      <a:pPr algn="r"/>
+                      <a:r>
+                        <a:rPr sz="1300" b="0">
+                          <a:solidFill>
+                            <a:srgbClr val="3C3C3B"/>
+                          </a:solidFill>
+                          <a:latin typeface="Aptos"/>
+                        </a:rPr>
+                        <a:t>44.9%</a:t>
                       </a:r>
                     </a:p>
                   </a:txBody>
@@ -22927,70 +22927,284 @@
                           </a:solidFill>
                           <a:latin typeface="Aptos"/>
                         </a:rPr>
-                        <a:t>12.5%</a:t>
-                      </a:r>
-                    </a:p>
-                  </a:txBody>
-                  <a:tcPr marL="73152" marR="73152" marT="27432" marB="27432" anchor="ctr">
-                    <a:noFill/>
-                  </a:tcPr>
-                </a:tc>
-                <a:tc>
-                  <a:txBody>
-                    <a:bodyPr/>
-                    <a:lstStyle/>
-                    <a:p>
-                      <a:pPr algn="r"/>
-                      <a:r>
-                        <a:rPr sz="1300" b="0">
-                          <a:solidFill>
-                            <a:srgbClr val="3C3C3B"/>
-                          </a:solidFill>
-                          <a:latin typeface="Aptos"/>
-                        </a:rPr>
-                        <a:t>12.5%</a:t>
-                      </a:r>
-                    </a:p>
-                  </a:txBody>
-                  <a:tcPr marL="73152" marR="73152" marT="27432" marB="27432" anchor="ctr">
-                    <a:noFill/>
-                  </a:tcPr>
-                </a:tc>
-                <a:tc>
-                  <a:txBody>
-                    <a:bodyPr/>
-                    <a:lstStyle/>
-                    <a:p>
-                      <a:pPr algn="r"/>
-                      <a:r>
-                        <a:rPr sz="1300" b="0">
-                          <a:solidFill>
-                            <a:srgbClr val="3C3C3B"/>
-                          </a:solidFill>
-                          <a:latin typeface="Aptos"/>
-                        </a:rPr>
-                        <a:t>2.73x</a:t>
-                      </a:r>
-                    </a:p>
-                  </a:txBody>
-                  <a:tcPr marL="73152" marR="73152" marT="27432" marB="27432" anchor="ctr">
-                    <a:noFill/>
-                  </a:tcPr>
-                </a:tc>
-                <a:tc>
-                  <a:txBody>
-                    <a:bodyPr/>
-                    <a:lstStyle/>
-                    <a:p>
-                      <a:pPr algn="r"/>
-                      <a:r>
-                        <a:rPr sz="1300" b="0">
-                          <a:solidFill>
-                            <a:srgbClr val="3C3C3B"/>
-                          </a:solidFill>
-                          <a:latin typeface="Aptos"/>
-                        </a:rPr>
-                        <a:t>2.73x</a:t>
+                        <a:t>12.9%</a:t>
+                      </a:r>
+                    </a:p>
+                  </a:txBody>
+                  <a:tcPr marL="73152" marR="73152" marT="27432" marB="27432" anchor="ctr">
+                    <a:noFill/>
+                  </a:tcPr>
+                </a:tc>
+                <a:tc>
+                  <a:txBody>
+                    <a:bodyPr/>
+                    <a:lstStyle/>
+                    <a:p>
+                      <a:pPr algn="r"/>
+                      <a:r>
+                        <a:rPr sz="1300" b="0">
+                          <a:solidFill>
+                            <a:srgbClr val="3C3C3B"/>
+                          </a:solidFill>
+                          <a:latin typeface="Aptos"/>
+                        </a:rPr>
+                        <a:t>12.9%</a:t>
+                      </a:r>
+                    </a:p>
+                  </a:txBody>
+                  <a:tcPr marL="73152" marR="73152" marT="27432" marB="27432" anchor="ctr">
+                    <a:noFill/>
+                  </a:tcPr>
+                </a:tc>
+                <a:tc>
+                  <a:txBody>
+                    <a:bodyPr/>
+                    <a:lstStyle/>
+                    <a:p>
+                      <a:pPr algn="r"/>
+                      <a:r>
+                        <a:rPr sz="1300" b="0">
+                          <a:solidFill>
+                            <a:srgbClr val="3C3C3B"/>
+                          </a:solidFill>
+                          <a:latin typeface="Aptos"/>
+                        </a:rPr>
+                        <a:t>1.96x</a:t>
+                      </a:r>
+                    </a:p>
+                  </a:txBody>
+                  <a:tcPr marL="73152" marR="73152" marT="27432" marB="27432" anchor="ctr">
+                    <a:noFill/>
+                  </a:tcPr>
+                </a:tc>
+                <a:tc>
+                  <a:txBody>
+                    <a:bodyPr/>
+                    <a:lstStyle/>
+                    <a:p>
+                      <a:pPr algn="r"/>
+                      <a:r>
+                        <a:rPr sz="1300" b="0">
+                          <a:solidFill>
+                            <a:srgbClr val="3C3C3B"/>
+                          </a:solidFill>
+                          <a:latin typeface="Aptos"/>
+                        </a:rPr>
+                        <a:t>1.96x</a:t>
+                      </a:r>
+                    </a:p>
+                  </a:txBody>
+                  <a:tcPr marL="73152" marR="73152" marT="27432" marB="27432" anchor="ctr">
+                    <a:noFill/>
+                  </a:tcPr>
+                </a:tc>
+              </a:tr>
+              <a:tr h="384048">
+                <a:tc>
+                  <a:txBody>
+                    <a:bodyPr/>
+                    <a:lstStyle/>
+                    <a:p>
+                      <a:pPr algn="l"/>
+                      <a:r>
+                        <a:rPr sz="1300" b="0">
+                          <a:solidFill>
+                            <a:srgbClr val="3C3C3B"/>
+                          </a:solidFill>
+                          <a:latin typeface="Aptos"/>
+                        </a:rPr>
+                        <a:t>Full cash sweep</a:t>
+                      </a:r>
+                    </a:p>
+                  </a:txBody>
+                  <a:tcPr marL="73152" marR="73152" marT="27432" marB="27432" anchor="ctr">
+                    <a:solidFill>
+                      <a:srgbClr val="F2F2F2"/>
+                    </a:solidFill>
+                  </a:tcPr>
+                </a:tc>
+                <a:tc>
+                  <a:txBody>
+                    <a:bodyPr/>
+                    <a:lstStyle/>
+                    <a:p>
+                      <a:pPr algn="l"/>
+                      <a:r>
+                        <a:rPr sz="1300" b="0">
+                          <a:solidFill>
+                            <a:srgbClr val="3C3C3B"/>
+                          </a:solidFill>
+                          <a:latin typeface="Aptos"/>
+                        </a:rPr>
+                        <a:t>59.5</a:t>
+                      </a:r>
+                    </a:p>
+                  </a:txBody>
+                  <a:tcPr marL="73152" marR="73152" marT="27432" marB="27432" anchor="ctr">
+                    <a:noFill/>
+                  </a:tcPr>
+                </a:tc>
+                <a:tc>
+                  <a:txBody>
+                    <a:bodyPr/>
+                    <a:lstStyle/>
+                    <a:p>
+                      <a:pPr algn="r"/>
+                      <a:r>
+                        <a:rPr sz="1300" b="0">
+                          <a:solidFill>
+                            <a:srgbClr val="3C3C3B"/>
+                          </a:solidFill>
+                          <a:latin typeface="Aptos"/>
+                        </a:rPr>
+                        <a:t>24.8%</a:t>
+                      </a:r>
+                    </a:p>
+                  </a:txBody>
+                  <a:tcPr marL="73152" marR="73152" marT="27432" marB="27432" anchor="ctr">
+                    <a:noFill/>
+                  </a:tcPr>
+                </a:tc>
+                <a:tc>
+                  <a:txBody>
+                    <a:bodyPr/>
+                    <a:lstStyle/>
+                    <a:p>
+                      <a:pPr algn="r"/>
+                      <a:r>
+                        <a:rPr sz="1300" b="0">
+                          <a:solidFill>
+                            <a:srgbClr val="3C3C3B"/>
+                          </a:solidFill>
+                          <a:latin typeface="Aptos"/>
+                        </a:rPr>
+                        <a:t>43.1%</a:t>
+                      </a:r>
+                    </a:p>
+                  </a:txBody>
+                  <a:tcPr marL="73152" marR="73152" marT="27432" marB="27432" anchor="ctr">
+                    <a:noFill/>
+                  </a:tcPr>
+                </a:tc>
+                <a:tc>
+                  <a:txBody>
+                    <a:bodyPr/>
+                    <a:lstStyle/>
+                    <a:p>
+                      <a:pPr algn="r"/>
+                      <a:r>
+                        <a:rPr sz="1300" b="0">
+                          <a:solidFill>
+                            <a:srgbClr val="3C3C3B"/>
+                          </a:solidFill>
+                          <a:latin typeface="Aptos"/>
+                        </a:rPr>
+                        <a:t>5.5%</a:t>
+                      </a:r>
+                    </a:p>
+                  </a:txBody>
+                  <a:tcPr marL="73152" marR="73152" marT="27432" marB="27432" anchor="ctr">
+                    <a:noFill/>
+                  </a:tcPr>
+                </a:tc>
+                <a:tc>
+                  <a:txBody>
+                    <a:bodyPr/>
+                    <a:lstStyle/>
+                    <a:p>
+                      <a:pPr algn="r"/>
+                      <a:r>
+                        <a:rPr sz="1300" b="0">
+                          <a:solidFill>
+                            <a:srgbClr val="3C3C3B"/>
+                          </a:solidFill>
+                          <a:latin typeface="Aptos"/>
+                        </a:rPr>
+                        <a:t>6.9%</a:t>
+                      </a:r>
+                    </a:p>
+                  </a:txBody>
+                  <a:tcPr marL="73152" marR="73152" marT="27432" marB="27432" anchor="ctr">
+                    <a:noFill/>
+                  </a:tcPr>
+                </a:tc>
+                <a:tc>
+                  <a:txBody>
+                    <a:bodyPr/>
+                    <a:lstStyle/>
+                    <a:p>
+                      <a:pPr algn="r"/>
+                      <a:r>
+                        <a:rPr sz="1300" b="0">
+                          <a:solidFill>
+                            <a:srgbClr val="3C3C3B"/>
+                          </a:solidFill>
+                          <a:latin typeface="Aptos"/>
+                        </a:rPr>
+                        <a:t>7.0%</a:t>
+                      </a:r>
+                    </a:p>
+                  </a:txBody>
+                  <a:tcPr marL="73152" marR="73152" marT="27432" marB="27432" anchor="ctr">
+                    <a:noFill/>
+                  </a:tcPr>
+                </a:tc>
+                <a:tc>
+                  <a:txBody>
+                    <a:bodyPr/>
+                    <a:lstStyle/>
+                    <a:p>
+                      <a:pPr algn="r"/>
+                      <a:r>
+                        <a:rPr sz="1300" b="0">
+                          <a:solidFill>
+                            <a:srgbClr val="3C3C3B"/>
+                          </a:solidFill>
+                          <a:latin typeface="Aptos"/>
+                        </a:rPr>
+                        <a:t>10.4%</a:t>
+                      </a:r>
+                    </a:p>
+                  </a:txBody>
+                  <a:tcPr marL="73152" marR="73152" marT="27432" marB="27432" anchor="ctr">
+                    <a:noFill/>
+                  </a:tcPr>
+                </a:tc>
+                <a:tc>
+                  <a:txBody>
+                    <a:bodyPr/>
+                    <a:lstStyle/>
+                    <a:p>
+                      <a:pPr algn="r"/>
+                      <a:r>
+                        <a:rPr sz="1300" b="0">
+                          <a:solidFill>
+                            <a:srgbClr val="3C3C3B"/>
+                          </a:solidFill>
+                          <a:latin typeface="Aptos"/>
+                        </a:rPr>
+                        <a:t>1.92x</a:t>
+                      </a:r>
+                    </a:p>
+                  </a:txBody>
+                  <a:tcPr marL="73152" marR="73152" marT="27432" marB="27432" anchor="ctr">
+                    <a:noFill/>
+                  </a:tcPr>
+                </a:tc>
+                <a:tc>
+                  <a:txBody>
+                    <a:bodyPr/>
+                    <a:lstStyle/>
+                    <a:p>
+                      <a:pPr algn="r"/>
+                      <a:r>
+                        <a:rPr sz="1300" b="0">
+                          <a:solidFill>
+                            <a:srgbClr val="3C3C3B"/>
+                          </a:solidFill>
+                          <a:latin typeface="Aptos"/>
+                        </a:rPr>
+                        <a:t>1.87x</a:t>
                       </a:r>
                     </a:p>
                   </a:txBody>
@@ -23101,7 +23315,7 @@
                 </a:solidFill>
                 <a:latin typeface="Aptos"/>
               </a:rPr>
-              <a:t>65.5 points but COD IRR 18.1% and hold IRR 7.1% (European).</a:t>
+              <a:t>65.5 points but COD IRR 17.0% and hold IRR 6.7% (European).</a:t>
             </a:r>
           </a:p>
           <a:p>
@@ -23126,7 +23340,7 @@
                 </a:solidFill>
                 <a:latin typeface="Aptos"/>
               </a:rPr>
-              <a:t>not in the base; if the 31% levy applies (its exemption covers only KÁT/METÁR plants), the hold IRR falls to 5.9% / 8.8%.</a:t>
+              <a:t>not in the base; if the 31% levy applies (its exemption covers only KÁT/METÁR plants), the hold IRR falls to 5.6% / 8.9%.</a:t>
             </a:r>
           </a:p>
           <a:p>
@@ -23176,7 +23390,7 @@
                 </a:solidFill>
                 <a:latin typeface="Aptos"/>
               </a:rPr>
-              <a:t>a 10-year tenor lowers the European minimum DSCR to 1.24x and the hold IRR to 7.2%.</a:t>
+              <a:t>a 10-year tenor lowers the European minimum DSCR to 1.44x and the hold IRR to 7.2%.</a:t>
             </a:r>
           </a:p>
           <a:p>
@@ -23192,7 +23406,7 @@
                 </a:solidFill>
                 <a:latin typeface="Aptos"/>
               </a:rPr>
-              <a:t>Higher gearing: </a:t>
+              <a:t>Bank terms: </a:t>
             </a:r>
             <a:r>
               <a:rPr sz="1300" b="0">
@@ -23201,7 +23415,7 @@
                 </a:solidFill>
                 <a:latin typeface="Aptos"/>
               </a:rPr>
-              <a:t>debt at 6x first-year EBITDA, capped at 70% of cost, is €57.3m / €55.2m; hold IRR 7.7% / 13.0%.</a:t>
+              <a:t>on the stricter terms (1.30x DSCR, 12-year annuity) debt is €49.5m / €49.5m and the hold IRR 7.3% / 11.3%; a full cash sweep gives 7.0% / 10.4%.</a:t>
             </a:r>
           </a:p>
         </p:txBody>

</xml_diff>

<commit_message>
Make Raiffeisen and UniCredit the two Bana base cases; drop municipality legal risk wording
Co-Authored-By: Claude Opus 5.5 <noreply@anthropic.com>
Claude-Session: https://claude.ai/code/session_01AWS1t9WtpkQHcCU1WceGZT
</commit_message>
<xml_diff>
--- a/projects/bana/out/Bana_IC.pptx
+++ b/projects/bana/out/Bana_IC.pptx
@@ -216,7 +216,7 @@
               <c:strCache>
                 <c:ptCount val="1"/>
                 <c:pt idx="0">
-                  <c:v>European turbine</c:v>
+                  <c:v>European, Raiffeisen</c:v>
                 </c:pt>
               </c:strCache>
             </c:strRef>
@@ -266,7 +266,7 @@
               <c:strCache>
                 <c:ptCount val="1"/>
                 <c:pt idx="0">
-                  <c:v>Chinese turbine</c:v>
+                  <c:v>European, UniCredit</c:v>
                 </c:pt>
               </c:strCache>
             </c:strRef>
@@ -298,10 +298,110 @@
                 <c:formatCode>0.0%</c:formatCode>
                 <c:ptCount val="2"/>
                 <c:pt idx="0">
+                  <c:v>0.23404236710695</c:v>
+                </c:pt>
+                <c:pt idx="1">
+                  <c:v>0.0712462533399166</c:v>
+                </c:pt>
+              </c:numCache>
+            </c:numRef>
+          </c:val>
+        </c:ser>
+        <c:ser>
+          <c:idx val="2"/>
+          <c:order val="2"/>
+          <c:tx>
+            <c:strRef>
+              <c:f>Sheet1!$D$1</c:f>
+              <c:strCache>
+                <c:ptCount val="1"/>
+                <c:pt idx="0">
+                  <c:v>Chinese, Raiffeisen</c:v>
+                </c:pt>
+              </c:strCache>
+            </c:strRef>
+          </c:tx>
+          <c:spPr>
+            <a:solidFill>
+              <a:srgbClr val="8CC63F"/>
+            </a:solidFill>
+          </c:spPr>
+          <c:invertIfNegative val="0"/>
+          <c:cat>
+            <c:strRef>
+              <c:f>Sheet1!$A$2:$A$3</c:f>
+              <c:strCache>
+                <c:ptCount val="2"/>
+                <c:pt idx="0">
+                  <c:v>Sale at COD</c:v>
+                </c:pt>
+                <c:pt idx="1">
+                  <c:v>Hold to maturity</c:v>
+                </c:pt>
+              </c:strCache>
+            </c:strRef>
+          </c:cat>
+          <c:val>
+            <c:numRef>
+              <c:f>Sheet1!$D$2:$D$3</c:f>
+              <c:numCache>
+                <c:formatCode>0.0%</c:formatCode>
+                <c:ptCount val="2"/>
+                <c:pt idx="0">
                   <c:v>0.430590128449621</c:v>
                 </c:pt>
                 <c:pt idx="1">
                   <c:v>0.118465201099218</c:v>
+                </c:pt>
+              </c:numCache>
+            </c:numRef>
+          </c:val>
+        </c:ser>
+        <c:ser>
+          <c:idx val="3"/>
+          <c:order val="3"/>
+          <c:tx>
+            <c:strRef>
+              <c:f>Sheet1!$E$1</c:f>
+              <c:strCache>
+                <c:ptCount val="1"/>
+                <c:pt idx="0">
+                  <c:v>Chinese, UniCredit</c:v>
+                </c:pt>
+              </c:strCache>
+            </c:strRef>
+          </c:tx>
+          <c:spPr>
+            <a:solidFill>
+              <a:srgbClr val="A6A6A6"/>
+            </a:solidFill>
+          </c:spPr>
+          <c:invertIfNegative val="0"/>
+          <c:cat>
+            <c:strRef>
+              <c:f>Sheet1!$A$2:$A$3</c:f>
+              <c:strCache>
+                <c:ptCount val="2"/>
+                <c:pt idx="0">
+                  <c:v>Sale at COD</c:v>
+                </c:pt>
+                <c:pt idx="1">
+                  <c:v>Hold to maturity</c:v>
+                </c:pt>
+              </c:strCache>
+            </c:strRef>
+          </c:cat>
+          <c:val>
+            <c:numRef>
+              <c:f>Sheet1!$E$2:$E$3</c:f>
+              <c:numCache>
+                <c:formatCode>0.0%</c:formatCode>
+                <c:ptCount val="2"/>
+                <c:pt idx="0">
+                  <c:v>0.397063407929472</c:v>
+                </c:pt>
+                <c:pt idx="1">
+                  <c:v>0.107429706179022</c:v>
                 </c:pt>
               </c:numCache>
             </c:numRef>
@@ -6032,7 +6132,7 @@
           <a:lstStyle/>
           <a:p>
             <a:r>
-              <a:t>At €4.50m, Bana returns 24.8% (European) / 43.1% (Chinese) on a sale at COD and 7.4% / 11.8% if held</a:t>
+              <a:t>At €4.50m, Bana returns 24.8% / 43.1% (European / Chinese) on a sale at COD and 7.4% / 11.8% if held, on Raiffeisen terms</a:t>
             </a:r>
           </a:p>
         </p:txBody>
@@ -6452,7 +6552,7 @@
                 </a:solidFill>
                 <a:latin typeface="Aptos"/>
               </a:rPr>
-              <a:t>FEP funds €63.2m of equity to COD (€36.0m Chinese) and bids 59.5 points (47.5 Chinese) into the 30 October tender; the European route needs a permit amendment.</a:t>
+              <a:t>On UniCredit terms (less debt) the sale returns 23.4% / 39.7% and the hold 7.1% / 10.7%. FEP bids 59.5 / 47.5 points into the 30 October tender; the European route needs a permit amendment.</a:t>
             </a:r>
           </a:p>
         </p:txBody>
@@ -6611,7 +6711,7 @@
         </p:nvGraphicFramePr>
         <p:xfrm>
           <a:off x="11750040" y="2240280"/>
-          <a:ext cx="6446520" cy="6245352"/>
+          <a:ext cx="6446520" cy="6757409"/>
         </p:xfrm>
         <a:graphic>
           <a:graphicData uri="http://schemas.openxmlformats.org/drawingml/2006/table">
@@ -6620,10 +6720,12 @@
                 <a:tableStyleId>{5C22544A-7EE6-4342-B048-85BDC9FD1C3A}</a:tableStyleId>
               </a:tblPr>
               <a:tblGrid>
-                <a:gridCol w="2788920"/>
-                <a:gridCol w="822960"/>
-                <a:gridCol w="1417320"/>
-                <a:gridCol w="1417320"/>
+                <a:gridCol w="1965960"/>
+                <a:gridCol w="640080"/>
+                <a:gridCol w="960120"/>
+                <a:gridCol w="960120"/>
+                <a:gridCol w="960120"/>
+                <a:gridCol w="960120"/>
               </a:tblGrid>
               <a:tr h="539496">
                 <a:tc>
@@ -6685,7 +6787,7 @@
                           </a:solidFill>
                           <a:latin typeface="Aptos"/>
                         </a:rPr>
-                        <a:t>European</a:t>
+                        <a:t>Raiffeisen European</a:t>
                       </a:r>
                     </a:p>
                   </a:txBody>
@@ -6708,7 +6810,7 @@
                           </a:solidFill>
                           <a:latin typeface="Aptos"/>
                         </a:rPr>
-                        <a:t>Chinese</a:t>
+                        <a:t>Raiffeisen Chinese</a:t>
                       </a:r>
                     </a:p>
                   </a:txBody>
@@ -6718,8 +6820,54 @@
                     </a:solidFill>
                   </a:tcPr>
                 </a:tc>
+                <a:tc>
+                  <a:txBody>
+                    <a:bodyPr/>
+                    <a:lstStyle/>
+                    <a:p>
+                      <a:pPr algn="r"/>
+                      <a:r>
+                        <a:rPr sz="1300" b="1">
+                          <a:solidFill>
+                            <a:srgbClr val="FFFFFF"/>
+                          </a:solidFill>
+                          <a:latin typeface="Aptos"/>
+                        </a:rPr>
+                        <a:t>UniCredit European</a:t>
+                      </a:r>
+                    </a:p>
+                  </a:txBody>
+                  <a:tcPr marL="73152" marR="73152" marT="27432" marB="27432" anchor="ctr">
+                    <a:solidFill>
+                      <a:srgbClr val="00A651"/>
+                    </a:solidFill>
+                  </a:tcPr>
+                </a:tc>
+                <a:tc>
+                  <a:txBody>
+                    <a:bodyPr/>
+                    <a:lstStyle/>
+                    <a:p>
+                      <a:pPr algn="r"/>
+                      <a:r>
+                        <a:rPr sz="1300" b="1">
+                          <a:solidFill>
+                            <a:srgbClr val="FFFFFF"/>
+                          </a:solidFill>
+                          <a:latin typeface="Aptos"/>
+                        </a:rPr>
+                        <a:t>UniCredit Chinese</a:t>
+                      </a:r>
+                    </a:p>
+                  </a:txBody>
+                  <a:tcPr marL="73152" marR="73152" marT="27432" marB="27432" anchor="ctr">
+                    <a:solidFill>
+                      <a:srgbClr val="00A651"/>
+                    </a:solidFill>
+                  </a:tcPr>
+                </a:tc>
               </a:tr>
-              <a:tr h="475488">
+              <a:tr h="478301">
                 <a:tc>
                   <a:txBody>
                     <a:bodyPr/>
@@ -6808,8 +6956,182 @@
                     <a:noFill/>
                   </a:tcPr>
                 </a:tc>
+                <a:tc>
+                  <a:txBody>
+                    <a:bodyPr/>
+                    <a:lstStyle/>
+                    <a:p>
+                      <a:pPr algn="r"/>
+                      <a:r>
+                        <a:rPr sz="1300" b="0">
+                          <a:solidFill>
+                            <a:srgbClr val="3C3C3B"/>
+                          </a:solidFill>
+                          <a:latin typeface="Aptos"/>
+                        </a:rPr>
+                        <a:t>59.5</a:t>
+                      </a:r>
+                    </a:p>
+                  </a:txBody>
+                  <a:tcPr marL="73152" marR="73152" marT="27432" marB="27432" anchor="ctr">
+                    <a:noFill/>
+                  </a:tcPr>
+                </a:tc>
+                <a:tc>
+                  <a:txBody>
+                    <a:bodyPr/>
+                    <a:lstStyle/>
+                    <a:p>
+                      <a:pPr algn="r"/>
+                      <a:r>
+                        <a:rPr sz="1300" b="0">
+                          <a:solidFill>
+                            <a:srgbClr val="3C3C3B"/>
+                          </a:solidFill>
+                          <a:latin typeface="Aptos"/>
+                        </a:rPr>
+                        <a:t>47.5</a:t>
+                      </a:r>
+                    </a:p>
+                  </a:txBody>
+                  <a:tcPr marL="73152" marR="73152" marT="27432" marB="27432" anchor="ctr">
+                    <a:noFill/>
+                  </a:tcPr>
+                </a:tc>
               </a:tr>
-              <a:tr h="475488">
+              <a:tr h="478301">
+                <a:tc>
+                  <a:txBody>
+                    <a:bodyPr/>
+                    <a:lstStyle/>
+                    <a:p>
+                      <a:pPr algn="l"/>
+                      <a:r>
+                        <a:rPr sz="1300" b="0">
+                          <a:solidFill>
+                            <a:srgbClr val="3C3C3B"/>
+                          </a:solidFill>
+                          <a:latin typeface="Aptos"/>
+                        </a:rPr>
+                        <a:t>Senior debt at COD</a:t>
+                      </a:r>
+                    </a:p>
+                  </a:txBody>
+                  <a:tcPr marL="73152" marR="73152" marT="27432" marB="27432" anchor="ctr">
+                    <a:solidFill>
+                      <a:srgbClr val="F2F2F2"/>
+                    </a:solidFill>
+                  </a:tcPr>
+                </a:tc>
+                <a:tc>
+                  <a:txBody>
+                    <a:bodyPr/>
+                    <a:lstStyle/>
+                    <a:p>
+                      <a:pPr algn="l"/>
+                      <a:r>
+                        <a:rPr sz="1300" b="0">
+                          <a:solidFill>
+                            <a:srgbClr val="919191"/>
+                          </a:solidFill>
+                          <a:latin typeface="Aptos"/>
+                        </a:rPr>
+                        <a:t>€ m</a:t>
+                      </a:r>
+                    </a:p>
+                  </a:txBody>
+                  <a:tcPr marL="73152" marR="73152" marT="27432" marB="27432" anchor="ctr">
+                    <a:solidFill>
+                      <a:srgbClr val="F2F2F2"/>
+                    </a:solidFill>
+                  </a:tcPr>
+                </a:tc>
+                <a:tc>
+                  <a:txBody>
+                    <a:bodyPr/>
+                    <a:lstStyle/>
+                    <a:p>
+                      <a:pPr algn="r"/>
+                      <a:r>
+                        <a:rPr sz="1300" b="0">
+                          <a:solidFill>
+                            <a:srgbClr val="3C3C3B"/>
+                          </a:solidFill>
+                          <a:latin typeface="Aptos"/>
+                        </a:rPr>
+                        <a:t>49.5</a:t>
+                      </a:r>
+                    </a:p>
+                  </a:txBody>
+                  <a:tcPr marL="73152" marR="73152" marT="27432" marB="27432" anchor="ctr">
+                    <a:noFill/>
+                  </a:tcPr>
+                </a:tc>
+                <a:tc>
+                  <a:txBody>
+                    <a:bodyPr/>
+                    <a:lstStyle/>
+                    <a:p>
+                      <a:pPr algn="r"/>
+                      <a:r>
+                        <a:rPr sz="1300" b="0">
+                          <a:solidFill>
+                            <a:srgbClr val="3C3C3B"/>
+                          </a:solidFill>
+                          <a:latin typeface="Aptos"/>
+                        </a:rPr>
+                        <a:t>49.5</a:t>
+                      </a:r>
+                    </a:p>
+                  </a:txBody>
+                  <a:tcPr marL="73152" marR="73152" marT="27432" marB="27432" anchor="ctr">
+                    <a:noFill/>
+                  </a:tcPr>
+                </a:tc>
+                <a:tc>
+                  <a:txBody>
+                    <a:bodyPr/>
+                    <a:lstStyle/>
+                    <a:p>
+                      <a:pPr algn="r"/>
+                      <a:r>
+                        <a:rPr sz="1300" b="0">
+                          <a:solidFill>
+                            <a:srgbClr val="3C3C3B"/>
+                          </a:solidFill>
+                          <a:latin typeface="Aptos"/>
+                        </a:rPr>
+                        <a:t>39.0</a:t>
+                      </a:r>
+                    </a:p>
+                  </a:txBody>
+                  <a:tcPr marL="73152" marR="73152" marT="27432" marB="27432" anchor="ctr">
+                    <a:noFill/>
+                  </a:tcPr>
+                </a:tc>
+                <a:tc>
+                  <a:txBody>
+                    <a:bodyPr/>
+                    <a:lstStyle/>
+                    <a:p>
+                      <a:pPr algn="r"/>
+                      <a:r>
+                        <a:rPr sz="1300" b="0">
+                          <a:solidFill>
+                            <a:srgbClr val="3C3C3B"/>
+                          </a:solidFill>
+                          <a:latin typeface="Aptos"/>
+                        </a:rPr>
+                        <a:t>39.0</a:t>
+                      </a:r>
+                    </a:p>
+                  </a:txBody>
+                  <a:tcPr marL="73152" marR="73152" marT="27432" marB="27432" anchor="ctr">
+                    <a:noFill/>
+                  </a:tcPr>
+                </a:tc>
+              </a:tr>
+              <a:tr h="478301">
                 <a:tc>
                   <a:txBody>
                     <a:bodyPr/>
@@ -6898,8 +7220,50 @@
                     <a:noFill/>
                   </a:tcPr>
                 </a:tc>
+                <a:tc>
+                  <a:txBody>
+                    <a:bodyPr/>
+                    <a:lstStyle/>
+                    <a:p>
+                      <a:pPr algn="r"/>
+                      <a:r>
+                        <a:rPr sz="1300" b="0">
+                          <a:solidFill>
+                            <a:srgbClr val="3C3C3B"/>
+                          </a:solidFill>
+                          <a:latin typeface="Aptos"/>
+                        </a:rPr>
+                        <a:t>73.0</a:t>
+                      </a:r>
+                    </a:p>
+                  </a:txBody>
+                  <a:tcPr marL="73152" marR="73152" marT="27432" marB="27432" anchor="ctr">
+                    <a:noFill/>
+                  </a:tcPr>
+                </a:tc>
+                <a:tc>
+                  <a:txBody>
+                    <a:bodyPr/>
+                    <a:lstStyle/>
+                    <a:p>
+                      <a:pPr algn="r"/>
+                      <a:r>
+                        <a:rPr sz="1300" b="0">
+                          <a:solidFill>
+                            <a:srgbClr val="3C3C3B"/>
+                          </a:solidFill>
+                          <a:latin typeface="Aptos"/>
+                        </a:rPr>
+                        <a:t>45.7</a:t>
+                      </a:r>
+                    </a:p>
+                  </a:txBody>
+                  <a:tcPr marL="73152" marR="73152" marT="27432" marB="27432" anchor="ctr">
+                    <a:noFill/>
+                  </a:tcPr>
+                </a:tc>
               </a:tr>
-              <a:tr h="475488">
+              <a:tr h="478301">
                 <a:tc>
                   <a:txBody>
                     <a:bodyPr/>
@@ -6965,8 +7329,36 @@
                     </a:solidFill>
                   </a:tcPr>
                 </a:tc>
+                <a:tc>
+                  <a:txBody>
+                    <a:bodyPr/>
+                    <a:lstStyle/>
+                    <a:p>
+                      <a:pPr algn="r"/>
+                    </a:p>
+                  </a:txBody>
+                  <a:tcPr marL="73152" marR="73152" marT="27432" marB="27432" anchor="ctr">
+                    <a:solidFill>
+                      <a:srgbClr val="E6F4EC"/>
+                    </a:solidFill>
+                  </a:tcPr>
+                </a:tc>
+                <a:tc>
+                  <a:txBody>
+                    <a:bodyPr/>
+                    <a:lstStyle/>
+                    <a:p>
+                      <a:pPr algn="r"/>
+                    </a:p>
+                  </a:txBody>
+                  <a:tcPr marL="73152" marR="73152" marT="27432" marB="27432" anchor="ctr">
+                    <a:solidFill>
+                      <a:srgbClr val="E6F4EC"/>
+                    </a:solidFill>
+                  </a:tcPr>
+                </a:tc>
               </a:tr>
-              <a:tr h="475488">
+              <a:tr h="478301">
                 <a:tc>
                   <a:txBody>
                     <a:bodyPr/>
@@ -7055,8 +7447,50 @@
                     <a:noFill/>
                   </a:tcPr>
                 </a:tc>
+                <a:tc>
+                  <a:txBody>
+                    <a:bodyPr/>
+                    <a:lstStyle/>
+                    <a:p>
+                      <a:pPr algn="r"/>
+                      <a:r>
+                        <a:rPr sz="1300" b="0">
+                          <a:solidFill>
+                            <a:srgbClr val="3C3C3B"/>
+                          </a:solidFill>
+                          <a:latin typeface="Aptos"/>
+                        </a:rPr>
+                        <a:t>21.6</a:t>
+                      </a:r>
+                    </a:p>
+                  </a:txBody>
+                  <a:tcPr marL="73152" marR="73152" marT="27432" marB="27432" anchor="ctr">
+                    <a:noFill/>
+                  </a:tcPr>
+                </a:tc>
+                <a:tc>
+                  <a:txBody>
+                    <a:bodyPr/>
+                    <a:lstStyle/>
+                    <a:p>
+                      <a:pPr algn="r"/>
+                      <a:r>
+                        <a:rPr sz="1300" b="0">
+                          <a:solidFill>
+                            <a:srgbClr val="3C3C3B"/>
+                          </a:solidFill>
+                          <a:latin typeface="Aptos"/>
+                        </a:rPr>
+                        <a:t>29.7</a:t>
+                      </a:r>
+                    </a:p>
+                  </a:txBody>
+                  <a:tcPr marL="73152" marR="73152" marT="27432" marB="27432" anchor="ctr">
+                    <a:noFill/>
+                  </a:tcPr>
+                </a:tc>
               </a:tr>
-              <a:tr h="475488">
+              <a:tr h="478301">
                 <a:tc>
                   <a:txBody>
                     <a:bodyPr/>
@@ -7149,8 +7583,54 @@
                     </a:solidFill>
                   </a:tcPr>
                 </a:tc>
+                <a:tc>
+                  <a:txBody>
+                    <a:bodyPr/>
+                    <a:lstStyle/>
+                    <a:p>
+                      <a:pPr algn="r"/>
+                      <a:r>
+                        <a:rPr sz="1300" b="1">
+                          <a:solidFill>
+                            <a:srgbClr val="3C3C3B"/>
+                          </a:solidFill>
+                          <a:latin typeface="Aptos"/>
+                        </a:rPr>
+                        <a:t>23.4%</a:t>
+                      </a:r>
+                    </a:p>
+                  </a:txBody>
+                  <a:tcPr marL="73152" marR="73152" marT="27432" marB="27432" anchor="ctr">
+                    <a:solidFill>
+                      <a:srgbClr val="E6F4EC"/>
+                    </a:solidFill>
+                  </a:tcPr>
+                </a:tc>
+                <a:tc>
+                  <a:txBody>
+                    <a:bodyPr/>
+                    <a:lstStyle/>
+                    <a:p>
+                      <a:pPr algn="r"/>
+                      <a:r>
+                        <a:rPr sz="1300" b="1">
+                          <a:solidFill>
+                            <a:srgbClr val="3C3C3B"/>
+                          </a:solidFill>
+                          <a:latin typeface="Aptos"/>
+                        </a:rPr>
+                        <a:t>39.7%</a:t>
+                      </a:r>
+                    </a:p>
+                  </a:txBody>
+                  <a:tcPr marL="73152" marR="73152" marT="27432" marB="27432" anchor="ctr">
+                    <a:solidFill>
+                      <a:srgbClr val="E6F4EC"/>
+                    </a:solidFill>
+                  </a:tcPr>
+                </a:tc>
               </a:tr>
-              <a:tr h="475488">
+              <a:tr h="478301">
                 <a:tc>
                   <a:txBody>
                     <a:bodyPr/>
@@ -7239,8 +7719,50 @@
                     <a:noFill/>
                   </a:tcPr>
                 </a:tc>
+                <a:tc>
+                  <a:txBody>
+                    <a:bodyPr/>
+                    <a:lstStyle/>
+                    <a:p>
+                      <a:pPr algn="r"/>
+                      <a:r>
+                        <a:rPr sz="1300" b="0">
+                          <a:solidFill>
+                            <a:srgbClr val="3C3C3B"/>
+                          </a:solidFill>
+                          <a:latin typeface="Aptos"/>
+                        </a:rPr>
+                        <a:t>1.30x</a:t>
+                      </a:r>
+                    </a:p>
+                  </a:txBody>
+                  <a:tcPr marL="73152" marR="73152" marT="27432" marB="27432" anchor="ctr">
+                    <a:noFill/>
+                  </a:tcPr>
+                </a:tc>
+                <a:tc>
+                  <a:txBody>
+                    <a:bodyPr/>
+                    <a:lstStyle/>
+                    <a:p>
+                      <a:pPr algn="r"/>
+                      <a:r>
+                        <a:rPr sz="1300" b="0">
+                          <a:solidFill>
+                            <a:srgbClr val="3C3C3B"/>
+                          </a:solidFill>
+                          <a:latin typeface="Aptos"/>
+                        </a:rPr>
+                        <a:t>1.65x</a:t>
+                      </a:r>
+                    </a:p>
+                  </a:txBody>
+                  <a:tcPr marL="73152" marR="73152" marT="27432" marB="27432" anchor="ctr">
+                    <a:noFill/>
+                  </a:tcPr>
+                </a:tc>
               </a:tr>
-              <a:tr h="475488">
+              <a:tr h="478301">
                 <a:tc>
                   <a:txBody>
                     <a:bodyPr/>
@@ -7329,8 +7851,50 @@
                     <a:noFill/>
                   </a:tcPr>
                 </a:tc>
+                <a:tc>
+                  <a:txBody>
+                    <a:bodyPr/>
+                    <a:lstStyle/>
+                    <a:p>
+                      <a:pPr algn="r"/>
+                      <a:r>
+                        <a:rPr sz="1300" b="0">
+                          <a:solidFill>
+                            <a:srgbClr val="3C3C3B"/>
+                          </a:solidFill>
+                          <a:latin typeface="Aptos"/>
+                        </a:rPr>
+                        <a:t>5.6%</a:t>
+                      </a:r>
+                    </a:p>
+                  </a:txBody>
+                  <a:tcPr marL="73152" marR="73152" marT="27432" marB="27432" anchor="ctr">
+                    <a:noFill/>
+                  </a:tcPr>
+                </a:tc>
+                <a:tc>
+                  <a:txBody>
+                    <a:bodyPr/>
+                    <a:lstStyle/>
+                    <a:p>
+                      <a:pPr algn="r"/>
+                      <a:r>
+                        <a:rPr sz="1300" b="0">
+                          <a:solidFill>
+                            <a:srgbClr val="3C3C3B"/>
+                          </a:solidFill>
+                          <a:latin typeface="Aptos"/>
+                        </a:rPr>
+                        <a:t>6.9%</a:t>
+                      </a:r>
+                    </a:p>
+                  </a:txBody>
+                  <a:tcPr marL="73152" marR="73152" marT="27432" marB="27432" anchor="ctr">
+                    <a:noFill/>
+                  </a:tcPr>
+                </a:tc>
               </a:tr>
-              <a:tr h="475488">
+              <a:tr h="478301">
                 <a:tc>
                   <a:txBody>
                     <a:bodyPr/>
@@ -7396,8 +7960,36 @@
                     </a:solidFill>
                   </a:tcPr>
                 </a:tc>
+                <a:tc>
+                  <a:txBody>
+                    <a:bodyPr/>
+                    <a:lstStyle/>
+                    <a:p>
+                      <a:pPr algn="r"/>
+                    </a:p>
+                  </a:txBody>
+                  <a:tcPr marL="73152" marR="73152" marT="27432" marB="27432" anchor="ctr">
+                    <a:solidFill>
+                      <a:srgbClr val="E6F4EC"/>
+                    </a:solidFill>
+                  </a:tcPr>
+                </a:tc>
+                <a:tc>
+                  <a:txBody>
+                    <a:bodyPr/>
+                    <a:lstStyle/>
+                    <a:p>
+                      <a:pPr algn="r"/>
+                    </a:p>
+                  </a:txBody>
+                  <a:tcPr marL="73152" marR="73152" marT="27432" marB="27432" anchor="ctr">
+                    <a:solidFill>
+                      <a:srgbClr val="E6F4EC"/>
+                    </a:solidFill>
+                  </a:tcPr>
+                </a:tc>
               </a:tr>
-              <a:tr h="475488">
+              <a:tr h="478301">
                 <a:tc>
                   <a:txBody>
                     <a:bodyPr/>
@@ -7490,8 +8082,54 @@
                     </a:solidFill>
                   </a:tcPr>
                 </a:tc>
+                <a:tc>
+                  <a:txBody>
+                    <a:bodyPr/>
+                    <a:lstStyle/>
+                    <a:p>
+                      <a:pPr algn="r"/>
+                      <a:r>
+                        <a:rPr sz="1300" b="1">
+                          <a:solidFill>
+                            <a:srgbClr val="3C3C3B"/>
+                          </a:solidFill>
+                          <a:latin typeface="Aptos"/>
+                        </a:rPr>
+                        <a:t>7.1%</a:t>
+                      </a:r>
+                    </a:p>
+                  </a:txBody>
+                  <a:tcPr marL="73152" marR="73152" marT="27432" marB="27432" anchor="ctr">
+                    <a:solidFill>
+                      <a:srgbClr val="E6F4EC"/>
+                    </a:solidFill>
+                  </a:tcPr>
+                </a:tc>
+                <a:tc>
+                  <a:txBody>
+                    <a:bodyPr/>
+                    <a:lstStyle/>
+                    <a:p>
+                      <a:pPr algn="r"/>
+                      <a:r>
+                        <a:rPr sz="1300" b="1">
+                          <a:solidFill>
+                            <a:srgbClr val="3C3C3B"/>
+                          </a:solidFill>
+                          <a:latin typeface="Aptos"/>
+                        </a:rPr>
+                        <a:t>10.7%</a:t>
+                      </a:r>
+                    </a:p>
+                  </a:txBody>
+                  <a:tcPr marL="73152" marR="73152" marT="27432" marB="27432" anchor="ctr">
+                    <a:solidFill>
+                      <a:srgbClr val="E6F4EC"/>
+                    </a:solidFill>
+                  </a:tcPr>
+                </a:tc>
               </a:tr>
-              <a:tr h="475488">
+              <a:tr h="478301">
                 <a:tc>
                   <a:txBody>
                     <a:bodyPr/>
@@ -7580,8 +8218,50 @@
                     <a:noFill/>
                   </a:tcPr>
                 </a:tc>
+                <a:tc>
+                  <a:txBody>
+                    <a:bodyPr/>
+                    <a:lstStyle/>
+                    <a:p>
+                      <a:pPr algn="r"/>
+                      <a:r>
+                        <a:rPr sz="1300" b="0">
+                          <a:solidFill>
+                            <a:srgbClr val="3C3C3B"/>
+                          </a:solidFill>
+                          <a:latin typeface="Aptos"/>
+                        </a:rPr>
+                        <a:t>2.95x</a:t>
+                      </a:r>
+                    </a:p>
+                  </a:txBody>
+                  <a:tcPr marL="73152" marR="73152" marT="27432" marB="27432" anchor="ctr">
+                    <a:noFill/>
+                  </a:tcPr>
+                </a:tc>
+                <a:tc>
+                  <a:txBody>
+                    <a:bodyPr/>
+                    <a:lstStyle/>
+                    <a:p>
+                      <a:pPr algn="r"/>
+                      <a:r>
+                        <a:rPr sz="1300" b="0">
+                          <a:solidFill>
+                            <a:srgbClr val="3C3C3B"/>
+                          </a:solidFill>
+                          <a:latin typeface="Aptos"/>
+                        </a:rPr>
+                        <a:t>4.59x</a:t>
+                      </a:r>
+                    </a:p>
+                  </a:txBody>
+                  <a:tcPr marL="73152" marR="73152" marT="27432" marB="27432" anchor="ctr">
+                    <a:noFill/>
+                  </a:tcPr>
+                </a:tc>
               </a:tr>
-              <a:tr h="475488">
+              <a:tr h="478301">
                 <a:tc>
                   <a:txBody>
                     <a:bodyPr/>
@@ -7670,8 +8350,50 @@
                     <a:noFill/>
                   </a:tcPr>
                 </a:tc>
+                <a:tc>
+                  <a:txBody>
+                    <a:bodyPr/>
+                    <a:lstStyle/>
+                    <a:p>
+                      <a:pPr algn="r"/>
+                      <a:r>
+                        <a:rPr sz="1300" b="0">
+                          <a:solidFill>
+                            <a:srgbClr val="3C3C3B"/>
+                          </a:solidFill>
+                          <a:latin typeface="Aptos"/>
+                        </a:rPr>
+                        <a:t>(6.2)</a:t>
+                      </a:r>
+                    </a:p>
+                  </a:txBody>
+                  <a:tcPr marL="73152" marR="73152" marT="27432" marB="27432" anchor="ctr">
+                    <a:noFill/>
+                  </a:tcPr>
+                </a:tc>
+                <a:tc>
+                  <a:txBody>
+                    <a:bodyPr/>
+                    <a:lstStyle/>
+                    <a:p>
+                      <a:pPr algn="r"/>
+                      <a:r>
+                        <a:rPr sz="1300" b="0">
+                          <a:solidFill>
+                            <a:srgbClr val="3C3C3B"/>
+                          </a:solidFill>
+                          <a:latin typeface="Aptos"/>
+                        </a:rPr>
+                        <a:t>14.2</a:t>
+                      </a:r>
+                    </a:p>
+                  </a:txBody>
+                  <a:tcPr marL="73152" marR="73152" marT="27432" marB="27432" anchor="ctr">
+                    <a:noFill/>
+                  </a:tcPr>
+                </a:tc>
               </a:tr>
-              <a:tr h="475488">
+              <a:tr h="478301">
                 <a:tc>
                   <a:txBody>
                     <a:bodyPr/>
@@ -7753,6 +8475,48 @@
                           <a:latin typeface="Aptos"/>
                         </a:rPr>
                         <a:t>1.89x</a:t>
+                      </a:r>
+                    </a:p>
+                  </a:txBody>
+                  <a:tcPr marL="73152" marR="73152" marT="27432" marB="27432" anchor="ctr">
+                    <a:noFill/>
+                  </a:tcPr>
+                </a:tc>
+                <a:tc>
+                  <a:txBody>
+                    <a:bodyPr/>
+                    <a:lstStyle/>
+                    <a:p>
+                      <a:pPr algn="r"/>
+                      <a:r>
+                        <a:rPr sz="1300" b="0">
+                          <a:solidFill>
+                            <a:srgbClr val="3C3C3B"/>
+                          </a:solidFill>
+                          <a:latin typeface="Aptos"/>
+                        </a:rPr>
+                        <a:t>2.08x</a:t>
+                      </a:r>
+                    </a:p>
+                  </a:txBody>
+                  <a:tcPr marL="73152" marR="73152" marT="27432" marB="27432" anchor="ctr">
+                    <a:noFill/>
+                  </a:tcPr>
+                </a:tc>
+                <a:tc>
+                  <a:txBody>
+                    <a:bodyPr/>
+                    <a:lstStyle/>
+                    <a:p>
+                      <a:pPr algn="r"/>
+                      <a:r>
+                        <a:rPr sz="1300" b="0">
+                          <a:solidFill>
+                            <a:srgbClr val="3C3C3B"/>
+                          </a:solidFill>
+                          <a:latin typeface="Aptos"/>
+                        </a:rPr>
+                        <a:t>2.03x</a:t>
                       </a:r>
                     </a:p>
                   </a:txBody>
@@ -7794,7 +8558,7 @@
                 </a:solidFill>
                 <a:latin typeface="Aptos"/>
               </a:rPr>
-              <a:t>Post-tax, FEP 100 %. Purchase price paid at closing (31‑Dec‑26), after the award. PPA 90 €/MWh for the whole life; NPV at 8%. Chinese = the permitted Goldwind turbines.</a:t>
+              <a:t>Post-tax, FEP 100 %. Purchase price paid at closing (31‑Dec‑26), after the award. PPA 90 €/MWh for the whole life; NPV at 8%. Chinese = the permitted Goldwind turbines. Bank cases: Raiffeisen 0.90 and UniCredit 0.71 M€ per built MW, 15- and 12-year annuity, 1.20x and 1.30x minimum DSCR.</a:t>
             </a:r>
           </a:p>
           <a:p>
@@ -11780,7 +12544,7 @@
           <a:lstStyle/>
           <a:p>
             <a:r>
-              <a:t>Uses to COD of €112.7m with European turbines (€85.5m Chinese); senior debt funds 44% (58%) and FEP the rest</a:t>
+              <a:t>Uses to COD of €112.7m European (€85.5m Chinese); Raiffeisen debt funds 44% (58%), FEP the rest</a:t>
             </a:r>
           </a:p>
         </p:txBody>
@@ -14106,7 +14870,7 @@
                 </a:solidFill>
                 <a:latin typeface="Aptos"/>
               </a:rPr>
-              <a:t>Debt share = senior debt at COD ÷ total uses. Debt = €0.9m per built wind MW on both routes (bank indication), drawn pro rata with construction costs; interest capitalised to COD. Securities are the same on both routes; HUF amounts at 365 HUF/EUR.</a:t>
+              <a:t>Debt share = senior debt at COD ÷ total uses. Raiffeisen: €0.90m per built wind MW on both routes; UniCredit: €0.71m (debt €39.0m / €39.0m, equity €73.0m / €45.7m). Drawn pro rata with construction costs; interest capitalised to COD. HUF amounts at 365 HUF/EUR.</a:t>
             </a:r>
           </a:p>
           <a:p>
@@ -14161,7 +14925,7 @@
           <a:lstStyle/>
           <a:p>
             <a:r>
-              <a:t>A sale at COD turns €63.2m of equity into €84.1m (1.33x); holding earns 7.4% at a 1.94x DSCR (European)</a:t>
+              <a:t>A sale at COD turns €63.2m of equity into €84.1m (1.33x); holding earns 7.4% at a 1.94x DSCR (European, Raiffeisen)</a:t>
             </a:r>
           </a:p>
         </p:txBody>
@@ -14581,7 +15345,7 @@
                 </a:solidFill>
                 <a:latin typeface="Aptos"/>
               </a:rPr>
-              <a:t>With Chinese turbines the sale returns 43.1% and the hold 11.8%; debt is €49.5m on both routes, a 15-year annuity.</a:t>
+              <a:t>Chinese: sale 43.1%, hold 11.8%. On UniCredit terms debt falls from €49.5m to €39.0m and the hold earns 7.1% / 10.7%.</a:t>
             </a:r>
           </a:p>
         </p:txBody>
@@ -14596,7 +15360,7 @@
         </p:nvGraphicFramePr>
         <p:xfrm>
           <a:off x="4498848" y="2240280"/>
-          <a:ext cx="9418320" cy="6245352"/>
+          <a:ext cx="9418320" cy="6830568"/>
         </p:xfrm>
         <a:graphic>
           <a:graphicData uri="http://schemas.openxmlformats.org/drawingml/2006/table">
@@ -14626,7 +15390,7 @@
                           </a:solidFill>
                           <a:latin typeface="Aptos"/>
                         </a:rPr>
-                        <a:t>FEP, post-tax</a:t>
+                        <a:t>FEP, post-tax, Raiffeisen terms</a:t>
                       </a:r>
                     </a:p>
                   </a:txBody>
@@ -14752,7 +15516,7 @@
                   </a:tcPr>
                 </a:tc>
               </a:tr>
-              <a:tr h="475488">
+              <a:tr h="393192">
                 <a:tc>
                   <a:txBody>
                     <a:bodyPr/>
@@ -14884,7 +15648,7 @@
                   </a:tcPr>
                 </a:tc>
               </a:tr>
-              <a:tr h="475488">
+              <a:tr h="393192">
                 <a:tc>
                   <a:txBody>
                     <a:bodyPr/>
@@ -15016,7 +15780,7 @@
                   </a:tcPr>
                 </a:tc>
               </a:tr>
-              <a:tr h="475488">
+              <a:tr h="393192">
                 <a:tc>
                   <a:txBody>
                     <a:bodyPr/>
@@ -15148,7 +15912,7 @@
                   </a:tcPr>
                 </a:tc>
               </a:tr>
-              <a:tr h="475488">
+              <a:tr h="393192">
                 <a:tc>
                   <a:txBody>
                     <a:bodyPr/>
@@ -15280,7 +16044,7 @@
                   </a:tcPr>
                 </a:tc>
               </a:tr>
-              <a:tr h="475488">
+              <a:tr h="393192">
                 <a:tc>
                   <a:txBody>
                     <a:bodyPr/>
@@ -15412,7 +16176,7 @@
                   </a:tcPr>
                 </a:tc>
               </a:tr>
-              <a:tr h="475488">
+              <a:tr h="393192">
                 <a:tc>
                   <a:txBody>
                     <a:bodyPr/>
@@ -15544,7 +16308,7 @@
                   </a:tcPr>
                 </a:tc>
               </a:tr>
-              <a:tr h="475488">
+              <a:tr h="393192">
                 <a:tc>
                   <a:txBody>
                     <a:bodyPr/>
@@ -15684,7 +16448,7 @@
                   </a:tcPr>
                 </a:tc>
               </a:tr>
-              <a:tr h="475488">
+              <a:tr h="393192">
                 <a:tc>
                   <a:txBody>
                     <a:bodyPr/>
@@ -15816,7 +16580,7 @@
                   </a:tcPr>
                 </a:tc>
               </a:tr>
-              <a:tr h="475488">
+              <a:tr h="393192">
                 <a:tc>
                   <a:txBody>
                     <a:bodyPr/>
@@ -15948,7 +16712,7 @@
                   </a:tcPr>
                 </a:tc>
               </a:tr>
-              <a:tr h="475488">
+              <a:tr h="393192">
                 <a:tc>
                   <a:txBody>
                     <a:bodyPr/>
@@ -16080,7 +16844,7 @@
                   </a:tcPr>
                 </a:tc>
               </a:tr>
-              <a:tr h="475488">
+              <a:tr h="393192">
                 <a:tc>
                   <a:txBody>
                     <a:bodyPr/>
@@ -16212,7 +16976,7 @@
                   </a:tcPr>
                 </a:tc>
               </a:tr>
-              <a:tr h="475488">
+              <a:tr h="393192">
                 <a:tc>
                   <a:txBody>
                     <a:bodyPr/>
@@ -16336,6 +17100,505 @@
                           <a:latin typeface="Aptos"/>
                         </a:rPr>
                         <a:t>(28.3)</a:t>
+                      </a:r>
+                    </a:p>
+                  </a:txBody>
+                  <a:tcPr marL="73152" marR="73152" marT="27432" marB="27432" anchor="ctr">
+                    <a:noFill/>
+                  </a:tcPr>
+                </a:tc>
+              </a:tr>
+              <a:tr h="393192">
+                <a:tc>
+                  <a:txBody>
+                    <a:bodyPr/>
+                    <a:lstStyle/>
+                    <a:p>
+                      <a:pPr algn="l"/>
+                      <a:r>
+                        <a:rPr sz="1300" b="1">
+                          <a:solidFill>
+                            <a:srgbClr val="00563C"/>
+                          </a:solidFill>
+                          <a:latin typeface="Aptos"/>
+                        </a:rPr>
+                        <a:t>UniCredit terms</a:t>
+                      </a:r>
+                    </a:p>
+                  </a:txBody>
+                  <a:tcPr marL="73152" marR="73152" marT="27432" marB="27432" anchor="ctr">
+                    <a:solidFill>
+                      <a:srgbClr val="E6F4EC"/>
+                    </a:solidFill>
+                  </a:tcPr>
+                </a:tc>
+                <a:tc>
+                  <a:txBody>
+                    <a:bodyPr/>
+                    <a:lstStyle/>
+                    <a:p>
+                      <a:pPr algn="l"/>
+                    </a:p>
+                  </a:txBody>
+                  <a:tcPr marL="73152" marR="73152" marT="27432" marB="27432" anchor="ctr">
+                    <a:solidFill>
+                      <a:srgbClr val="E6F4EC"/>
+                    </a:solidFill>
+                  </a:tcPr>
+                </a:tc>
+                <a:tc>
+                  <a:txBody>
+                    <a:bodyPr/>
+                    <a:lstStyle/>
+                    <a:p>
+                      <a:pPr algn="r"/>
+                    </a:p>
+                  </a:txBody>
+                  <a:tcPr marL="73152" marR="73152" marT="27432" marB="27432" anchor="ctr">
+                    <a:solidFill>
+                      <a:srgbClr val="E6F4EC"/>
+                    </a:solidFill>
+                  </a:tcPr>
+                </a:tc>
+                <a:tc>
+                  <a:txBody>
+                    <a:bodyPr/>
+                    <a:lstStyle/>
+                    <a:p>
+                      <a:pPr algn="r"/>
+                    </a:p>
+                  </a:txBody>
+                  <a:tcPr marL="73152" marR="73152" marT="27432" marB="27432" anchor="ctr">
+                    <a:solidFill>
+                      <a:srgbClr val="E6F4EC"/>
+                    </a:solidFill>
+                  </a:tcPr>
+                </a:tc>
+                <a:tc>
+                  <a:txBody>
+                    <a:bodyPr/>
+                    <a:lstStyle/>
+                    <a:p>
+                      <a:pPr algn="r"/>
+                    </a:p>
+                  </a:txBody>
+                  <a:tcPr marL="73152" marR="73152" marT="27432" marB="27432" anchor="ctr">
+                    <a:solidFill>
+                      <a:srgbClr val="E6F4EC"/>
+                    </a:solidFill>
+                  </a:tcPr>
+                </a:tc>
+                <a:tc>
+                  <a:txBody>
+                    <a:bodyPr/>
+                    <a:lstStyle/>
+                    <a:p>
+                      <a:pPr algn="r"/>
+                    </a:p>
+                  </a:txBody>
+                  <a:tcPr marL="73152" marR="73152" marT="27432" marB="27432" anchor="ctr">
+                    <a:solidFill>
+                      <a:srgbClr val="E6F4EC"/>
+                    </a:solidFill>
+                  </a:tcPr>
+                </a:tc>
+              </a:tr>
+              <a:tr h="393192">
+                <a:tc>
+                  <a:txBody>
+                    <a:bodyPr/>
+                    <a:lstStyle/>
+                    <a:p>
+                      <a:pPr algn="l"/>
+                      <a:r>
+                        <a:rPr sz="1300" b="0">
+                          <a:solidFill>
+                            <a:srgbClr val="3C3C3B"/>
+                          </a:solidFill>
+                          <a:latin typeface="Aptos"/>
+                        </a:rPr>
+                        <a:t>Senior debt assumed by the buyer</a:t>
+                      </a:r>
+                    </a:p>
+                  </a:txBody>
+                  <a:tcPr marL="73152" marR="73152" marT="27432" marB="27432" anchor="ctr">
+                    <a:solidFill>
+                      <a:srgbClr val="F2F2F2"/>
+                    </a:solidFill>
+                  </a:tcPr>
+                </a:tc>
+                <a:tc>
+                  <a:txBody>
+                    <a:bodyPr/>
+                    <a:lstStyle/>
+                    <a:p>
+                      <a:pPr algn="l"/>
+                      <a:r>
+                        <a:rPr sz="1300" b="0">
+                          <a:solidFill>
+                            <a:srgbClr val="919191"/>
+                          </a:solidFill>
+                          <a:latin typeface="Aptos"/>
+                        </a:rPr>
+                        <a:t>€ m</a:t>
+                      </a:r>
+                    </a:p>
+                  </a:txBody>
+                  <a:tcPr marL="73152" marR="73152" marT="27432" marB="27432" anchor="ctr">
+                    <a:solidFill>
+                      <a:srgbClr val="F2F2F2"/>
+                    </a:solidFill>
+                  </a:tcPr>
+                </a:tc>
+                <a:tc>
+                  <a:txBody>
+                    <a:bodyPr/>
+                    <a:lstStyle/>
+                    <a:p>
+                      <a:pPr algn="r"/>
+                      <a:r>
+                        <a:rPr sz="1300" b="0">
+                          <a:solidFill>
+                            <a:srgbClr val="3C3C3B"/>
+                          </a:solidFill>
+                          <a:latin typeface="Aptos"/>
+                        </a:rPr>
+                        <a:t>(39.0)</a:t>
+                      </a:r>
+                    </a:p>
+                  </a:txBody>
+                  <a:tcPr marL="73152" marR="73152" marT="27432" marB="27432" anchor="ctr">
+                    <a:noFill/>
+                  </a:tcPr>
+                </a:tc>
+                <a:tc>
+                  <a:txBody>
+                    <a:bodyPr/>
+                    <a:lstStyle/>
+                    <a:p>
+                      <a:pPr algn="r"/>
+                      <a:r>
+                        <a:rPr sz="1300" b="0">
+                          <a:solidFill>
+                            <a:srgbClr val="3C3C3B"/>
+                          </a:solidFill>
+                          <a:latin typeface="Aptos"/>
+                        </a:rPr>
+                        <a:t>(39.0)</a:t>
+                      </a:r>
+                    </a:p>
+                  </a:txBody>
+                  <a:tcPr marL="73152" marR="73152" marT="27432" marB="27432" anchor="ctr">
+                    <a:noFill/>
+                  </a:tcPr>
+                </a:tc>
+                <a:tc>
+                  <a:txBody>
+                    <a:bodyPr/>
+                    <a:lstStyle/>
+                    <a:p>
+                      <a:pPr algn="r"/>
+                      <a:r>
+                        <a:rPr sz="1300" b="0">
+                          <a:solidFill>
+                            <a:srgbClr val="3C3C3B"/>
+                          </a:solidFill>
+                          <a:latin typeface="Aptos"/>
+                        </a:rPr>
+                        <a:t>–</a:t>
+                      </a:r>
+                    </a:p>
+                  </a:txBody>
+                  <a:tcPr marL="73152" marR="73152" marT="27432" marB="27432" anchor="ctr">
+                    <a:noFill/>
+                  </a:tcPr>
+                </a:tc>
+                <a:tc>
+                  <a:txBody>
+                    <a:bodyPr/>
+                    <a:lstStyle/>
+                    <a:p>
+                      <a:pPr algn="r"/>
+                      <a:r>
+                        <a:rPr sz="1300" b="0">
+                          <a:solidFill>
+                            <a:srgbClr val="3C3C3B"/>
+                          </a:solidFill>
+                          <a:latin typeface="Aptos"/>
+                        </a:rPr>
+                        <a:t>–</a:t>
+                      </a:r>
+                    </a:p>
+                  </a:txBody>
+                  <a:tcPr marL="73152" marR="73152" marT="27432" marB="27432" anchor="ctr">
+                    <a:noFill/>
+                  </a:tcPr>
+                </a:tc>
+              </a:tr>
+              <a:tr h="393192">
+                <a:tc>
+                  <a:txBody>
+                    <a:bodyPr/>
+                    <a:lstStyle/>
+                    <a:p>
+                      <a:pPr algn="l"/>
+                      <a:r>
+                        <a:rPr sz="1300" b="1">
+                          <a:solidFill>
+                            <a:srgbClr val="3C3C3B"/>
+                          </a:solidFill>
+                          <a:latin typeface="Aptos"/>
+                        </a:rPr>
+                        <a:t>FEP IRR</a:t>
+                      </a:r>
+                    </a:p>
+                  </a:txBody>
+                  <a:tcPr marL="73152" marR="73152" marT="27432" marB="27432" anchor="ctr">
+                    <a:solidFill>
+                      <a:srgbClr val="F2F2F2"/>
+                    </a:solidFill>
+                  </a:tcPr>
+                </a:tc>
+                <a:tc>
+                  <a:txBody>
+                    <a:bodyPr/>
+                    <a:lstStyle/>
+                    <a:p>
+                      <a:pPr algn="l"/>
+                      <a:r>
+                        <a:rPr sz="1300" b="1">
+                          <a:solidFill>
+                            <a:srgbClr val="919191"/>
+                          </a:solidFill>
+                          <a:latin typeface="Aptos"/>
+                        </a:rPr>
+                        <a:t>%</a:t>
+                      </a:r>
+                    </a:p>
+                  </a:txBody>
+                  <a:tcPr marL="73152" marR="73152" marT="27432" marB="27432" anchor="ctr">
+                    <a:solidFill>
+                      <a:srgbClr val="F2F2F2"/>
+                    </a:solidFill>
+                  </a:tcPr>
+                </a:tc>
+                <a:tc>
+                  <a:txBody>
+                    <a:bodyPr/>
+                    <a:lstStyle/>
+                    <a:p>
+                      <a:pPr algn="r"/>
+                      <a:r>
+                        <a:rPr sz="1300" b="1">
+                          <a:solidFill>
+                            <a:srgbClr val="3C3C3B"/>
+                          </a:solidFill>
+                          <a:latin typeface="Aptos"/>
+                        </a:rPr>
+                        <a:t>23.4%</a:t>
+                      </a:r>
+                    </a:p>
+                  </a:txBody>
+                  <a:tcPr marL="73152" marR="73152" marT="27432" marB="27432" anchor="ctr">
+                    <a:solidFill>
+                      <a:srgbClr val="E6F4EC"/>
+                    </a:solidFill>
+                  </a:tcPr>
+                </a:tc>
+                <a:tc>
+                  <a:txBody>
+                    <a:bodyPr/>
+                    <a:lstStyle/>
+                    <a:p>
+                      <a:pPr algn="r"/>
+                      <a:r>
+                        <a:rPr sz="1300" b="1">
+                          <a:solidFill>
+                            <a:srgbClr val="3C3C3B"/>
+                          </a:solidFill>
+                          <a:latin typeface="Aptos"/>
+                        </a:rPr>
+                        <a:t>39.7%</a:t>
+                      </a:r>
+                    </a:p>
+                  </a:txBody>
+                  <a:tcPr marL="73152" marR="73152" marT="27432" marB="27432" anchor="ctr">
+                    <a:solidFill>
+                      <a:srgbClr val="E6F4EC"/>
+                    </a:solidFill>
+                  </a:tcPr>
+                </a:tc>
+                <a:tc>
+                  <a:txBody>
+                    <a:bodyPr/>
+                    <a:lstStyle/>
+                    <a:p>
+                      <a:pPr algn="r"/>
+                      <a:r>
+                        <a:rPr sz="1300" b="1">
+                          <a:solidFill>
+                            <a:srgbClr val="3C3C3B"/>
+                          </a:solidFill>
+                          <a:latin typeface="Aptos"/>
+                        </a:rPr>
+                        <a:t>7.1%</a:t>
+                      </a:r>
+                    </a:p>
+                  </a:txBody>
+                  <a:tcPr marL="73152" marR="73152" marT="27432" marB="27432" anchor="ctr">
+                    <a:solidFill>
+                      <a:srgbClr val="E6F4EC"/>
+                    </a:solidFill>
+                  </a:tcPr>
+                </a:tc>
+                <a:tc>
+                  <a:txBody>
+                    <a:bodyPr/>
+                    <a:lstStyle/>
+                    <a:p>
+                      <a:pPr algn="r"/>
+                      <a:r>
+                        <a:rPr sz="1300" b="1">
+                          <a:solidFill>
+                            <a:srgbClr val="3C3C3B"/>
+                          </a:solidFill>
+                          <a:latin typeface="Aptos"/>
+                        </a:rPr>
+                        <a:t>10.7%</a:t>
+                      </a:r>
+                    </a:p>
+                  </a:txBody>
+                  <a:tcPr marL="73152" marR="73152" marT="27432" marB="27432" anchor="ctr">
+                    <a:solidFill>
+                      <a:srgbClr val="E6F4EC"/>
+                    </a:solidFill>
+                  </a:tcPr>
+                </a:tc>
+              </a:tr>
+              <a:tr h="393192">
+                <a:tc>
+                  <a:txBody>
+                    <a:bodyPr/>
+                    <a:lstStyle/>
+                    <a:p>
+                      <a:pPr algn="l"/>
+                      <a:r>
+                        <a:rPr sz="1300" b="0">
+                          <a:solidFill>
+                            <a:srgbClr val="3C3C3B"/>
+                          </a:solidFill>
+                          <a:latin typeface="Aptos"/>
+                        </a:rPr>
+                        <a:t>Minimum DSCR (annuity)</a:t>
+                      </a:r>
+                    </a:p>
+                  </a:txBody>
+                  <a:tcPr marL="73152" marR="73152" marT="27432" marB="27432" anchor="ctr">
+                    <a:solidFill>
+                      <a:srgbClr val="F2F2F2"/>
+                    </a:solidFill>
+                  </a:tcPr>
+                </a:tc>
+                <a:tc>
+                  <a:txBody>
+                    <a:bodyPr/>
+                    <a:lstStyle/>
+                    <a:p>
+                      <a:pPr algn="l"/>
+                      <a:r>
+                        <a:rPr sz="1300" b="0">
+                          <a:solidFill>
+                            <a:srgbClr val="919191"/>
+                          </a:solidFill>
+                          <a:latin typeface="Aptos"/>
+                        </a:rPr>
+                        <a:t>x</a:t>
+                      </a:r>
+                    </a:p>
+                  </a:txBody>
+                  <a:tcPr marL="73152" marR="73152" marT="27432" marB="27432" anchor="ctr">
+                    <a:solidFill>
+                      <a:srgbClr val="F2F2F2"/>
+                    </a:solidFill>
+                  </a:tcPr>
+                </a:tc>
+                <a:tc>
+                  <a:txBody>
+                    <a:bodyPr/>
+                    <a:lstStyle/>
+                    <a:p>
+                      <a:pPr algn="r"/>
+                      <a:r>
+                        <a:rPr sz="1300" b="0">
+                          <a:solidFill>
+                            <a:srgbClr val="3C3C3B"/>
+                          </a:solidFill>
+                          <a:latin typeface="Aptos"/>
+                        </a:rPr>
+                        <a:t>–</a:t>
+                      </a:r>
+                    </a:p>
+                  </a:txBody>
+                  <a:tcPr marL="73152" marR="73152" marT="27432" marB="27432" anchor="ctr">
+                    <a:noFill/>
+                  </a:tcPr>
+                </a:tc>
+                <a:tc>
+                  <a:txBody>
+                    <a:bodyPr/>
+                    <a:lstStyle/>
+                    <a:p>
+                      <a:pPr algn="r"/>
+                      <a:r>
+                        <a:rPr sz="1300" b="0">
+                          <a:solidFill>
+                            <a:srgbClr val="3C3C3B"/>
+                          </a:solidFill>
+                          <a:latin typeface="Aptos"/>
+                        </a:rPr>
+                        <a:t>–</a:t>
+                      </a:r>
+                    </a:p>
+                  </a:txBody>
+                  <a:tcPr marL="73152" marR="73152" marT="27432" marB="27432" anchor="ctr">
+                    <a:noFill/>
+                  </a:tcPr>
+                </a:tc>
+                <a:tc>
+                  <a:txBody>
+                    <a:bodyPr/>
+                    <a:lstStyle/>
+                    <a:p>
+                      <a:pPr algn="r"/>
+                      <a:r>
+                        <a:rPr sz="1300" b="0">
+                          <a:solidFill>
+                            <a:srgbClr val="3C3C3B"/>
+                          </a:solidFill>
+                          <a:latin typeface="Aptos"/>
+                        </a:rPr>
+                        <a:t>2.08x</a:t>
+                      </a:r>
+                    </a:p>
+                  </a:txBody>
+                  <a:tcPr marL="73152" marR="73152" marT="27432" marB="27432" anchor="ctr">
+                    <a:noFill/>
+                  </a:tcPr>
+                </a:tc>
+                <a:tc>
+                  <a:txBody>
+                    <a:bodyPr/>
+                    <a:lstStyle/>
+                    <a:p>
+                      <a:pPr algn="r"/>
+                      <a:r>
+                        <a:rPr sz="1300" b="0">
+                          <a:solidFill>
+                            <a:srgbClr val="3C3C3B"/>
+                          </a:solidFill>
+                          <a:latin typeface="Aptos"/>
+                        </a:rPr>
+                        <a:t>2.03x</a:t>
                       </a:r>
                     </a:p>
                   </a:txBody>
@@ -16358,7 +17621,7 @@
         </p:nvGraphicFramePr>
         <p:xfrm>
           <a:off x="14127480" y="2240280"/>
-          <a:ext cx="4069080" cy="3291840"/>
+          <a:ext cx="4069080" cy="2834640"/>
         </p:xfrm>
         <a:graphic>
           <a:graphicData uri="http://schemas.openxmlformats.org/drawingml/2006/chart">
@@ -16374,8 +17637,8 @@
         </p:nvSpPr>
         <p:spPr>
           <a:xfrm>
-            <a:off x="14127480" y="5715000"/>
-            <a:ext cx="4069080" cy="3840480"/>
+            <a:off x="14127480" y="5212080"/>
+            <a:ext cx="4069080" cy="4343400"/>
           </a:xfrm>
           <a:prstGeom prst="rect">
             <a:avLst/>
@@ -16430,7 +17693,7 @@
                 </a:solidFill>
                 <a:latin typeface="Aptos"/>
               </a:rPr>
-              <a:t>Debt (bank indication): </a:t>
+              <a:t>Raiffeisen: </a:t>
             </a:r>
             <a:r>
               <a:rPr sz="1300" b="0">
@@ -16439,7 +17702,7 @@
                 </a:solidFill>
                 <a:latin typeface="Aptos"/>
               </a:rPr>
-              <a:t>€0.9m per built MW, 15-year annuity, 5.0% fixed, minimum DSCR 1.20x on PPA revenue; LTC 46% / 63%; 62% / 63% of the DSCR capacity is used.</a:t>
+              <a:t>€0.90m per built MW, 15-year annuity, minimum DSCR 1.20x on PPA revenue; LTC 46% / 63%; 62% / 63% of the DSCR capacity is used.</a:t>
             </a:r>
           </a:p>
           <a:p>
@@ -16455,7 +17718,32 @@
                 </a:solidFill>
                 <a:latin typeface="Aptos"/>
               </a:rPr>
-              <a:t>Maximum debt, no cap: </a:t>
+              <a:t>UniCredit: </a:t>
+            </a:r>
+            <a:r>
+              <a:rPr sz="1300" b="0">
+                <a:solidFill>
+                  <a:srgbClr val="3C3C3B"/>
+                </a:solidFill>
+                <a:latin typeface="Aptos"/>
+              </a:rPr>
+              <a:t>12-year annuity, minimum DSCR 1.30x, margin above 2.3 %; €0.71m per MW (Raiffeisen quantum scaled to tenor and DSCR); LTC 36% / 49%. Both 5.0% fixed.</a:t>
+            </a:r>
+          </a:p>
+          <a:p>
+            <a:pPr algn="l">
+              <a:spcBef>
+                <a:spcPts val="800"/>
+              </a:spcBef>
+            </a:pPr>
+            <a:r>
+              <a:rPr sz="1300" b="1">
+                <a:solidFill>
+                  <a:srgbClr val="3C3C3B"/>
+                </a:solidFill>
+                <a:latin typeface="Aptos"/>
+              </a:rPr>
+              <a:t>Maximum debt, no cap (Raiffeisen tenor): </a:t>
             </a:r>
             <a:r>
               <a:rPr sz="1300" b="0">
@@ -16489,7 +17777,7 @@
                 </a:solidFill>
                 <a:latin typeface="Aptos"/>
               </a:rPr>
-              <a:t>CIT 15%, a proxy for 9 % plus a possible Pillar Two top-up. Robin Hood tax (31%) is not in the base; it may apply, as its exemption covers only KÁT/METÁR plants (see sensitivities). 20-year depreciation; losses capped at 50% of the base and lapse after 5 years. Gain on the COD share sale exempt.</a:t>
+              <a:t>CIT 15% (9 % + possible Pillar Two top-up); Robin Hood (31%) only as a sensitivity. 20-year depreciation; losses capped at 50%, lapse after 5 years. COD share-sale gain exempt.</a:t>
             </a:r>
           </a:p>
         </p:txBody>
@@ -17448,7 +18736,7 @@
                           </a:solidFill>
                           <a:latin typeface="Aptos"/>
                         </a:rPr>
-                        <a:t>Base</a:t>
+                        <a:t>Base: Raiffeisen</a:t>
                       </a:r>
                     </a:p>
                   </a:txBody>
@@ -17869,7 +19157,7 @@
                 </a:solidFill>
                 <a:latin typeface="Aptos"/>
               </a:rPr>
-              <a:t>Buyer unlevered: pays the enterprise value at COD and receives EBITDA less tax, guarantee fees and any PB call. Buyer levered: pays the price less the senior debt, funds the DSRA and services the debt. Share deal: SPV tax, debt and depreciation continue; the unlevered IRR uses the SPV's actual tax.</a:t>
+              <a:t>Buyer unlevered: pays the enterprise value at COD and receives EBITDA less tax, guarantee fees and any PB call. Buyer levered: pays the price less the senior debt, funds the DSRA and services the debt. Share deal: SPV tax, debt and depreciation continue; the unlevered IRR uses the SPV's actual tax. Raiffeisen debt terms.</a:t>
             </a:r>
           </a:p>
           <a:p>
@@ -18625,7 +19913,7 @@
                           </a:solidFill>
                           <a:latin typeface="Aptos"/>
                         </a:rPr>
-                        <a:t>Base: deliver the bid</a:t>
+                        <a:t>Deliver the bid (Raiffeisen)</a:t>
                       </a:r>
                     </a:p>
                   </a:txBody>
@@ -19159,7 +20447,7 @@
                 </a:solidFill>
                 <a:latin typeface="Aptos"/>
               </a:rPr>
-              <a:t>the promised payments are public commitments; not paying them is a reputational and legal risk beyond the PB.</a:t>
+              <a:t>the payments are a commitment to MEKH in the bid, not a contract with them; the PB call is the sanction.</a:t>
             </a:r>
           </a:p>
           <a:p>
@@ -19999,7 +21287,7 @@
                           </a:solidFill>
                           <a:latin typeface="Aptos"/>
                         </a:rPr>
-                        <a:t>Base</a:t>
+                        <a:t>Base: Raiffeisen</a:t>
                       </a:r>
                     </a:p>
                   </a:txBody>
@@ -20225,13 +21513,13 @@
                     <a:p>
                       <a:pPr algn="l"/>
                       <a:r>
-                        <a:rPr sz="1300" b="0">
-                          <a:solidFill>
-                            <a:srgbClr val="3C3C3B"/>
-                          </a:solidFill>
-                          <a:latin typeface="Aptos"/>
-                        </a:rPr>
-                        <a:t>COD price −10%</a:t>
+                        <a:rPr sz="1300" b="1">
+                          <a:solidFill>
+                            <a:srgbClr val="3C3C3B"/>
+                          </a:solidFill>
+                          <a:latin typeface="Aptos"/>
+                        </a:rPr>
+                        <a:t>Base: UniCredit</a:t>
                       </a:r>
                     </a:p>
                   </a:txBody>
@@ -20248,7 +21536,7 @@
                     <a:p>
                       <a:pPr algn="l"/>
                       <a:r>
-                        <a:rPr sz="1300" b="0">
+                        <a:rPr sz="1300" b="1">
                           <a:solidFill>
                             <a:srgbClr val="3C3C3B"/>
                           </a:solidFill>
@@ -20259,175 +21547,193 @@
                     </a:p>
                   </a:txBody>
                   <a:tcPr marL="73152" marR="73152" marT="27432" marB="27432" anchor="ctr">
-                    <a:noFill/>
-                  </a:tcPr>
-                </a:tc>
-                <a:tc>
-                  <a:txBody>
-                    <a:bodyPr/>
-                    <a:lstStyle/>
-                    <a:p>
-                      <a:pPr algn="r"/>
-                      <a:r>
-                        <a:rPr sz="1300" b="0">
-                          <a:solidFill>
-                            <a:srgbClr val="3C3C3B"/>
-                          </a:solidFill>
-                          <a:latin typeface="Aptos"/>
-                        </a:rPr>
-                        <a:t>9.6%</a:t>
-                      </a:r>
-                    </a:p>
-                  </a:txBody>
-                  <a:tcPr marL="73152" marR="73152" marT="27432" marB="27432" anchor="ctr">
-                    <a:noFill/>
-                  </a:tcPr>
-                </a:tc>
-                <a:tc>
-                  <a:txBody>
-                    <a:bodyPr/>
-                    <a:lstStyle/>
-                    <a:p>
-                      <a:pPr algn="r"/>
-                      <a:r>
-                        <a:rPr sz="1300" b="0">
-                          <a:solidFill>
-                            <a:srgbClr val="3C3C3B"/>
-                          </a:solidFill>
-                          <a:latin typeface="Aptos"/>
-                        </a:rPr>
-                        <a:t>28.7%</a:t>
-                      </a:r>
-                    </a:p>
-                  </a:txBody>
-                  <a:tcPr marL="73152" marR="73152" marT="27432" marB="27432" anchor="ctr">
-                    <a:noFill/>
-                  </a:tcPr>
-                </a:tc>
-                <a:tc>
-                  <a:txBody>
-                    <a:bodyPr/>
-                    <a:lstStyle/>
-                    <a:p>
-                      <a:pPr algn="r"/>
-                      <a:r>
-                        <a:rPr sz="1300" b="0">
-                          <a:solidFill>
-                            <a:srgbClr val="3C3C3B"/>
-                          </a:solidFill>
-                          <a:latin typeface="Aptos"/>
-                        </a:rPr>
-                        <a:t>6.7%</a:t>
-                      </a:r>
-                    </a:p>
-                  </a:txBody>
-                  <a:tcPr marL="73152" marR="73152" marT="27432" marB="27432" anchor="ctr">
-                    <a:noFill/>
-                  </a:tcPr>
-                </a:tc>
-                <a:tc>
-                  <a:txBody>
-                    <a:bodyPr/>
-                    <a:lstStyle/>
-                    <a:p>
-                      <a:pPr algn="r"/>
-                      <a:r>
-                        <a:rPr sz="1300" b="0">
-                          <a:solidFill>
-                            <a:srgbClr val="3C3C3B"/>
-                          </a:solidFill>
-                          <a:latin typeface="Aptos"/>
-                        </a:rPr>
-                        <a:t>8.1%</a:t>
-                      </a:r>
-                    </a:p>
-                  </a:txBody>
-                  <a:tcPr marL="73152" marR="73152" marT="27432" marB="27432" anchor="ctr">
-                    <a:noFill/>
-                  </a:tcPr>
-                </a:tc>
-                <a:tc>
-                  <a:txBody>
-                    <a:bodyPr/>
-                    <a:lstStyle/>
-                    <a:p>
-                      <a:pPr algn="r"/>
-                      <a:r>
-                        <a:rPr sz="1300" b="0">
-                          <a:solidFill>
-                            <a:srgbClr val="3C3C3B"/>
-                          </a:solidFill>
-                          <a:latin typeface="Aptos"/>
-                        </a:rPr>
-                        <a:t>7.4%</a:t>
-                      </a:r>
-                    </a:p>
-                  </a:txBody>
-                  <a:tcPr marL="73152" marR="73152" marT="27432" marB="27432" anchor="ctr">
-                    <a:noFill/>
-                  </a:tcPr>
-                </a:tc>
-                <a:tc>
-                  <a:txBody>
-                    <a:bodyPr/>
-                    <a:lstStyle/>
-                    <a:p>
-                      <a:pPr algn="r"/>
-                      <a:r>
-                        <a:rPr sz="1300" b="0">
-                          <a:solidFill>
-                            <a:srgbClr val="3C3C3B"/>
-                          </a:solidFill>
-                          <a:latin typeface="Aptos"/>
-                        </a:rPr>
-                        <a:t>11.8%</a:t>
-                      </a:r>
-                    </a:p>
-                  </a:txBody>
-                  <a:tcPr marL="73152" marR="73152" marT="27432" marB="27432" anchor="ctr">
-                    <a:noFill/>
-                  </a:tcPr>
-                </a:tc>
-                <a:tc>
-                  <a:txBody>
-                    <a:bodyPr/>
-                    <a:lstStyle/>
-                    <a:p>
-                      <a:pPr algn="r"/>
-                      <a:r>
-                        <a:rPr sz="1300" b="0">
-                          <a:solidFill>
-                            <a:srgbClr val="3C3C3B"/>
-                          </a:solidFill>
-                          <a:latin typeface="Aptos"/>
-                        </a:rPr>
-                        <a:t>1.94x</a:t>
-                      </a:r>
-                    </a:p>
-                  </a:txBody>
-                  <a:tcPr marL="73152" marR="73152" marT="27432" marB="27432" anchor="ctr">
-                    <a:noFill/>
-                  </a:tcPr>
-                </a:tc>
-                <a:tc>
-                  <a:txBody>
-                    <a:bodyPr/>
-                    <a:lstStyle/>
-                    <a:p>
-                      <a:pPr algn="r"/>
-                      <a:r>
-                        <a:rPr sz="1300" b="0">
-                          <a:solidFill>
-                            <a:srgbClr val="3C3C3B"/>
-                          </a:solidFill>
-                          <a:latin typeface="Aptos"/>
-                        </a:rPr>
-                        <a:t>1.89x</a:t>
-                      </a:r>
-                    </a:p>
-                  </a:txBody>
-                  <a:tcPr marL="73152" marR="73152" marT="27432" marB="27432" anchor="ctr">
-                    <a:noFill/>
+                    <a:solidFill>
+                      <a:srgbClr val="E6F4EC"/>
+                    </a:solidFill>
+                  </a:tcPr>
+                </a:tc>
+                <a:tc>
+                  <a:txBody>
+                    <a:bodyPr/>
+                    <a:lstStyle/>
+                    <a:p>
+                      <a:pPr algn="r"/>
+                      <a:r>
+                        <a:rPr sz="1300" b="1">
+                          <a:solidFill>
+                            <a:srgbClr val="3C3C3B"/>
+                          </a:solidFill>
+                          <a:latin typeface="Aptos"/>
+                        </a:rPr>
+                        <a:t>23.4%</a:t>
+                      </a:r>
+                    </a:p>
+                  </a:txBody>
+                  <a:tcPr marL="73152" marR="73152" marT="27432" marB="27432" anchor="ctr">
+                    <a:solidFill>
+                      <a:srgbClr val="E6F4EC"/>
+                    </a:solidFill>
+                  </a:tcPr>
+                </a:tc>
+                <a:tc>
+                  <a:txBody>
+                    <a:bodyPr/>
+                    <a:lstStyle/>
+                    <a:p>
+                      <a:pPr algn="r"/>
+                      <a:r>
+                        <a:rPr sz="1300" b="1">
+                          <a:solidFill>
+                            <a:srgbClr val="3C3C3B"/>
+                          </a:solidFill>
+                          <a:latin typeface="Aptos"/>
+                        </a:rPr>
+                        <a:t>39.7%</a:t>
+                      </a:r>
+                    </a:p>
+                  </a:txBody>
+                  <a:tcPr marL="73152" marR="73152" marT="27432" marB="27432" anchor="ctr">
+                    <a:solidFill>
+                      <a:srgbClr val="E6F4EC"/>
+                    </a:solidFill>
+                  </a:tcPr>
+                </a:tc>
+                <a:tc>
+                  <a:txBody>
+                    <a:bodyPr/>
+                    <a:lstStyle/>
+                    <a:p>
+                      <a:pPr algn="r"/>
+                      <a:r>
+                        <a:rPr sz="1300" b="1">
+                          <a:solidFill>
+                            <a:srgbClr val="3C3C3B"/>
+                          </a:solidFill>
+                          <a:latin typeface="Aptos"/>
+                        </a:rPr>
+                        <a:t>5.6%</a:t>
+                      </a:r>
+                    </a:p>
+                  </a:txBody>
+                  <a:tcPr marL="73152" marR="73152" marT="27432" marB="27432" anchor="ctr">
+                    <a:solidFill>
+                      <a:srgbClr val="E6F4EC"/>
+                    </a:solidFill>
+                  </a:tcPr>
+                </a:tc>
+                <a:tc>
+                  <a:txBody>
+                    <a:bodyPr/>
+                    <a:lstStyle/>
+                    <a:p>
+                      <a:pPr algn="r"/>
+                      <a:r>
+                        <a:rPr sz="1300" b="1">
+                          <a:solidFill>
+                            <a:srgbClr val="3C3C3B"/>
+                          </a:solidFill>
+                          <a:latin typeface="Aptos"/>
+                        </a:rPr>
+                        <a:t>6.9%</a:t>
+                      </a:r>
+                    </a:p>
+                  </a:txBody>
+                  <a:tcPr marL="73152" marR="73152" marT="27432" marB="27432" anchor="ctr">
+                    <a:solidFill>
+                      <a:srgbClr val="E6F4EC"/>
+                    </a:solidFill>
+                  </a:tcPr>
+                </a:tc>
+                <a:tc>
+                  <a:txBody>
+                    <a:bodyPr/>
+                    <a:lstStyle/>
+                    <a:p>
+                      <a:pPr algn="r"/>
+                      <a:r>
+                        <a:rPr sz="1300" b="1">
+                          <a:solidFill>
+                            <a:srgbClr val="3C3C3B"/>
+                          </a:solidFill>
+                          <a:latin typeface="Aptos"/>
+                        </a:rPr>
+                        <a:t>7.1%</a:t>
+                      </a:r>
+                    </a:p>
+                  </a:txBody>
+                  <a:tcPr marL="73152" marR="73152" marT="27432" marB="27432" anchor="ctr">
+                    <a:solidFill>
+                      <a:srgbClr val="E6F4EC"/>
+                    </a:solidFill>
+                  </a:tcPr>
+                </a:tc>
+                <a:tc>
+                  <a:txBody>
+                    <a:bodyPr/>
+                    <a:lstStyle/>
+                    <a:p>
+                      <a:pPr algn="r"/>
+                      <a:r>
+                        <a:rPr sz="1300" b="1">
+                          <a:solidFill>
+                            <a:srgbClr val="3C3C3B"/>
+                          </a:solidFill>
+                          <a:latin typeface="Aptos"/>
+                        </a:rPr>
+                        <a:t>10.7%</a:t>
+                      </a:r>
+                    </a:p>
+                  </a:txBody>
+                  <a:tcPr marL="73152" marR="73152" marT="27432" marB="27432" anchor="ctr">
+                    <a:solidFill>
+                      <a:srgbClr val="E6F4EC"/>
+                    </a:solidFill>
+                  </a:tcPr>
+                </a:tc>
+                <a:tc>
+                  <a:txBody>
+                    <a:bodyPr/>
+                    <a:lstStyle/>
+                    <a:p>
+                      <a:pPr algn="r"/>
+                      <a:r>
+                        <a:rPr sz="1300" b="1">
+                          <a:solidFill>
+                            <a:srgbClr val="3C3C3B"/>
+                          </a:solidFill>
+                          <a:latin typeface="Aptos"/>
+                        </a:rPr>
+                        <a:t>2.08x</a:t>
+                      </a:r>
+                    </a:p>
+                  </a:txBody>
+                  <a:tcPr marL="73152" marR="73152" marT="27432" marB="27432" anchor="ctr">
+                    <a:solidFill>
+                      <a:srgbClr val="E6F4EC"/>
+                    </a:solidFill>
+                  </a:tcPr>
+                </a:tc>
+                <a:tc>
+                  <a:txBody>
+                    <a:bodyPr/>
+                    <a:lstStyle/>
+                    <a:p>
+                      <a:pPr algn="r"/>
+                      <a:r>
+                        <a:rPr sz="1300" b="1">
+                          <a:solidFill>
+                            <a:srgbClr val="3C3C3B"/>
+                          </a:solidFill>
+                          <a:latin typeface="Aptos"/>
+                        </a:rPr>
+                        <a:t>2.03x</a:t>
+                      </a:r>
+                    </a:p>
+                  </a:txBody>
+                  <a:tcPr marL="73152" marR="73152" marT="27432" marB="27432" anchor="ctr">
+                    <a:solidFill>
+                      <a:srgbClr val="E6F4EC"/>
+                    </a:solidFill>
                   </a:tcPr>
                 </a:tc>
               </a:tr>
@@ -20445,7 +21751,7 @@
                           </a:solidFill>
                           <a:latin typeface="Aptos"/>
                         </a:rPr>
-                        <a:t>COD price +10%</a:t>
+                        <a:t>COD price −10%</a:t>
                       </a:r>
                     </a:p>
                   </a:txBody>
@@ -20489,70 +21795,70 @@
                           </a:solidFill>
                           <a:latin typeface="Aptos"/>
                         </a:rPr>
-                        <a:t>38.0%</a:t>
-                      </a:r>
-                    </a:p>
-                  </a:txBody>
-                  <a:tcPr marL="73152" marR="73152" marT="27432" marB="27432" anchor="ctr">
-                    <a:noFill/>
-                  </a:tcPr>
-                </a:tc>
-                <a:tc>
-                  <a:txBody>
-                    <a:bodyPr/>
-                    <a:lstStyle/>
-                    <a:p>
-                      <a:pPr algn="r"/>
-                      <a:r>
-                        <a:rPr sz="1300" b="0">
-                          <a:solidFill>
-                            <a:srgbClr val="3C3C3B"/>
-                          </a:solidFill>
-                          <a:latin typeface="Aptos"/>
-                        </a:rPr>
-                        <a:t>55.1%</a:t>
-                      </a:r>
-                    </a:p>
-                  </a:txBody>
-                  <a:tcPr marL="73152" marR="73152" marT="27432" marB="27432" anchor="ctr">
-                    <a:noFill/>
-                  </a:tcPr>
-                </a:tc>
-                <a:tc>
-                  <a:txBody>
-                    <a:bodyPr/>
-                    <a:lstStyle/>
-                    <a:p>
-                      <a:pPr algn="r"/>
-                      <a:r>
-                        <a:rPr sz="1300" b="0">
-                          <a:solidFill>
-                            <a:srgbClr val="3C3C3B"/>
-                          </a:solidFill>
-                          <a:latin typeface="Aptos"/>
-                        </a:rPr>
-                        <a:t>4.7%</a:t>
-                      </a:r>
-                    </a:p>
-                  </a:txBody>
-                  <a:tcPr marL="73152" marR="73152" marT="27432" marB="27432" anchor="ctr">
-                    <a:noFill/>
-                  </a:tcPr>
-                </a:tc>
-                <a:tc>
-                  <a:txBody>
-                    <a:bodyPr/>
-                    <a:lstStyle/>
-                    <a:p>
-                      <a:pPr algn="r"/>
-                      <a:r>
-                        <a:rPr sz="1300" b="0">
-                          <a:solidFill>
-                            <a:srgbClr val="3C3C3B"/>
-                          </a:solidFill>
-                          <a:latin typeface="Aptos"/>
-                        </a:rPr>
-                        <a:t>6.0%</a:t>
+                        <a:t>9.6%</a:t>
+                      </a:r>
+                    </a:p>
+                  </a:txBody>
+                  <a:tcPr marL="73152" marR="73152" marT="27432" marB="27432" anchor="ctr">
+                    <a:noFill/>
+                  </a:tcPr>
+                </a:tc>
+                <a:tc>
+                  <a:txBody>
+                    <a:bodyPr/>
+                    <a:lstStyle/>
+                    <a:p>
+                      <a:pPr algn="r"/>
+                      <a:r>
+                        <a:rPr sz="1300" b="0">
+                          <a:solidFill>
+                            <a:srgbClr val="3C3C3B"/>
+                          </a:solidFill>
+                          <a:latin typeface="Aptos"/>
+                        </a:rPr>
+                        <a:t>28.7%</a:t>
+                      </a:r>
+                    </a:p>
+                  </a:txBody>
+                  <a:tcPr marL="73152" marR="73152" marT="27432" marB="27432" anchor="ctr">
+                    <a:noFill/>
+                  </a:tcPr>
+                </a:tc>
+                <a:tc>
+                  <a:txBody>
+                    <a:bodyPr/>
+                    <a:lstStyle/>
+                    <a:p>
+                      <a:pPr algn="r"/>
+                      <a:r>
+                        <a:rPr sz="1300" b="0">
+                          <a:solidFill>
+                            <a:srgbClr val="3C3C3B"/>
+                          </a:solidFill>
+                          <a:latin typeface="Aptos"/>
+                        </a:rPr>
+                        <a:t>6.7%</a:t>
+                      </a:r>
+                    </a:p>
+                  </a:txBody>
+                  <a:tcPr marL="73152" marR="73152" marT="27432" marB="27432" anchor="ctr">
+                    <a:noFill/>
+                  </a:tcPr>
+                </a:tc>
+                <a:tc>
+                  <a:txBody>
+                    <a:bodyPr/>
+                    <a:lstStyle/>
+                    <a:p>
+                      <a:pPr algn="r"/>
+                      <a:r>
+                        <a:rPr sz="1300" b="0">
+                          <a:solidFill>
+                            <a:srgbClr val="3C3C3B"/>
+                          </a:solidFill>
+                          <a:latin typeface="Aptos"/>
+                        </a:rPr>
+                        <a:t>8.1%</a:t>
                       </a:r>
                     </a:p>
                   </a:txBody>
@@ -20659,7 +21965,7 @@
                           </a:solidFill>
                           <a:latin typeface="Aptos"/>
                         </a:rPr>
-                        <a:t>Turbine +10%</a:t>
+                        <a:t>COD price +10%</a:t>
                       </a:r>
                     </a:p>
                   </a:txBody>
@@ -20703,154 +22009,154 @@
                           </a:solidFill>
                           <a:latin typeface="Aptos"/>
                         </a:rPr>
-                        <a:t>17.9%</a:t>
-                      </a:r>
-                    </a:p>
-                  </a:txBody>
-                  <a:tcPr marL="73152" marR="73152" marT="27432" marB="27432" anchor="ctr">
-                    <a:noFill/>
-                  </a:tcPr>
-                </a:tc>
-                <a:tc>
-                  <a:txBody>
-                    <a:bodyPr/>
-                    <a:lstStyle/>
-                    <a:p>
-                      <a:pPr algn="r"/>
-                      <a:r>
-                        <a:rPr sz="1300" b="0">
-                          <a:solidFill>
-                            <a:srgbClr val="3C3C3B"/>
-                          </a:solidFill>
-                          <a:latin typeface="Aptos"/>
-                        </a:rPr>
-                        <a:t>38.5%</a:t>
-                      </a:r>
-                    </a:p>
-                  </a:txBody>
-                  <a:tcPr marL="73152" marR="73152" marT="27432" marB="27432" anchor="ctr">
-                    <a:noFill/>
-                  </a:tcPr>
-                </a:tc>
-                <a:tc>
-                  <a:txBody>
-                    <a:bodyPr/>
-                    <a:lstStyle/>
-                    <a:p>
-                      <a:pPr algn="r"/>
-                      <a:r>
-                        <a:rPr sz="1300" b="0">
-                          <a:solidFill>
-                            <a:srgbClr val="3C3C3B"/>
-                          </a:solidFill>
-                          <a:latin typeface="Aptos"/>
-                        </a:rPr>
-                        <a:t>5.7%</a:t>
-                      </a:r>
-                    </a:p>
-                  </a:txBody>
-                  <a:tcPr marL="73152" marR="73152" marT="27432" marB="27432" anchor="ctr">
-                    <a:noFill/>
-                  </a:tcPr>
-                </a:tc>
-                <a:tc>
-                  <a:txBody>
-                    <a:bodyPr/>
-                    <a:lstStyle/>
-                    <a:p>
-                      <a:pPr algn="r"/>
-                      <a:r>
-                        <a:rPr sz="1300" b="0">
-                          <a:solidFill>
-                            <a:srgbClr val="3C3C3B"/>
-                          </a:solidFill>
-                          <a:latin typeface="Aptos"/>
-                        </a:rPr>
-                        <a:t>7.0%</a:t>
-                      </a:r>
-                    </a:p>
-                  </a:txBody>
-                  <a:tcPr marL="73152" marR="73152" marT="27432" marB="27432" anchor="ctr">
-                    <a:noFill/>
-                  </a:tcPr>
-                </a:tc>
-                <a:tc>
-                  <a:txBody>
-                    <a:bodyPr/>
-                    <a:lstStyle/>
-                    <a:p>
-                      <a:pPr algn="r"/>
-                      <a:r>
-                        <a:rPr sz="1300" b="0">
-                          <a:solidFill>
-                            <a:srgbClr val="3C3C3B"/>
-                          </a:solidFill>
-                          <a:latin typeface="Aptos"/>
-                        </a:rPr>
-                        <a:t>6.8%</a:t>
-                      </a:r>
-                    </a:p>
-                  </a:txBody>
-                  <a:tcPr marL="73152" marR="73152" marT="27432" marB="27432" anchor="ctr">
-                    <a:noFill/>
-                  </a:tcPr>
-                </a:tc>
-                <a:tc>
-                  <a:txBody>
-                    <a:bodyPr/>
-                    <a:lstStyle/>
-                    <a:p>
-                      <a:pPr algn="r"/>
-                      <a:r>
-                        <a:rPr sz="1300" b="0">
-                          <a:solidFill>
-                            <a:srgbClr val="3C3C3B"/>
-                          </a:solidFill>
-                          <a:latin typeface="Aptos"/>
-                        </a:rPr>
-                        <a:t>11.2%</a:t>
-                      </a:r>
-                    </a:p>
-                  </a:txBody>
-                  <a:tcPr marL="73152" marR="73152" marT="27432" marB="27432" anchor="ctr">
-                    <a:noFill/>
-                  </a:tcPr>
-                </a:tc>
-                <a:tc>
-                  <a:txBody>
-                    <a:bodyPr/>
-                    <a:lstStyle/>
-                    <a:p>
-                      <a:pPr algn="r"/>
-                      <a:r>
-                        <a:rPr sz="1300" b="0">
-                          <a:solidFill>
-                            <a:srgbClr val="3C3C3B"/>
-                          </a:solidFill>
-                          <a:latin typeface="Aptos"/>
-                        </a:rPr>
-                        <a:t>1.95x</a:t>
-                      </a:r>
-                    </a:p>
-                  </a:txBody>
-                  <a:tcPr marL="73152" marR="73152" marT="27432" marB="27432" anchor="ctr">
-                    <a:noFill/>
-                  </a:tcPr>
-                </a:tc>
-                <a:tc>
-                  <a:txBody>
-                    <a:bodyPr/>
-                    <a:lstStyle/>
-                    <a:p>
-                      <a:pPr algn="r"/>
-                      <a:r>
-                        <a:rPr sz="1300" b="0">
-                          <a:solidFill>
-                            <a:srgbClr val="3C3C3B"/>
-                          </a:solidFill>
-                          <a:latin typeface="Aptos"/>
-                        </a:rPr>
-                        <a:t>1.90x</a:t>
+                        <a:t>38.0%</a:t>
+                      </a:r>
+                    </a:p>
+                  </a:txBody>
+                  <a:tcPr marL="73152" marR="73152" marT="27432" marB="27432" anchor="ctr">
+                    <a:noFill/>
+                  </a:tcPr>
+                </a:tc>
+                <a:tc>
+                  <a:txBody>
+                    <a:bodyPr/>
+                    <a:lstStyle/>
+                    <a:p>
+                      <a:pPr algn="r"/>
+                      <a:r>
+                        <a:rPr sz="1300" b="0">
+                          <a:solidFill>
+                            <a:srgbClr val="3C3C3B"/>
+                          </a:solidFill>
+                          <a:latin typeface="Aptos"/>
+                        </a:rPr>
+                        <a:t>55.1%</a:t>
+                      </a:r>
+                    </a:p>
+                  </a:txBody>
+                  <a:tcPr marL="73152" marR="73152" marT="27432" marB="27432" anchor="ctr">
+                    <a:noFill/>
+                  </a:tcPr>
+                </a:tc>
+                <a:tc>
+                  <a:txBody>
+                    <a:bodyPr/>
+                    <a:lstStyle/>
+                    <a:p>
+                      <a:pPr algn="r"/>
+                      <a:r>
+                        <a:rPr sz="1300" b="0">
+                          <a:solidFill>
+                            <a:srgbClr val="3C3C3B"/>
+                          </a:solidFill>
+                          <a:latin typeface="Aptos"/>
+                        </a:rPr>
+                        <a:t>4.7%</a:t>
+                      </a:r>
+                    </a:p>
+                  </a:txBody>
+                  <a:tcPr marL="73152" marR="73152" marT="27432" marB="27432" anchor="ctr">
+                    <a:noFill/>
+                  </a:tcPr>
+                </a:tc>
+                <a:tc>
+                  <a:txBody>
+                    <a:bodyPr/>
+                    <a:lstStyle/>
+                    <a:p>
+                      <a:pPr algn="r"/>
+                      <a:r>
+                        <a:rPr sz="1300" b="0">
+                          <a:solidFill>
+                            <a:srgbClr val="3C3C3B"/>
+                          </a:solidFill>
+                          <a:latin typeface="Aptos"/>
+                        </a:rPr>
+                        <a:t>6.0%</a:t>
+                      </a:r>
+                    </a:p>
+                  </a:txBody>
+                  <a:tcPr marL="73152" marR="73152" marT="27432" marB="27432" anchor="ctr">
+                    <a:noFill/>
+                  </a:tcPr>
+                </a:tc>
+                <a:tc>
+                  <a:txBody>
+                    <a:bodyPr/>
+                    <a:lstStyle/>
+                    <a:p>
+                      <a:pPr algn="r"/>
+                      <a:r>
+                        <a:rPr sz="1300" b="0">
+                          <a:solidFill>
+                            <a:srgbClr val="3C3C3B"/>
+                          </a:solidFill>
+                          <a:latin typeface="Aptos"/>
+                        </a:rPr>
+                        <a:t>7.4%</a:t>
+                      </a:r>
+                    </a:p>
+                  </a:txBody>
+                  <a:tcPr marL="73152" marR="73152" marT="27432" marB="27432" anchor="ctr">
+                    <a:noFill/>
+                  </a:tcPr>
+                </a:tc>
+                <a:tc>
+                  <a:txBody>
+                    <a:bodyPr/>
+                    <a:lstStyle/>
+                    <a:p>
+                      <a:pPr algn="r"/>
+                      <a:r>
+                        <a:rPr sz="1300" b="0">
+                          <a:solidFill>
+                            <a:srgbClr val="3C3C3B"/>
+                          </a:solidFill>
+                          <a:latin typeface="Aptos"/>
+                        </a:rPr>
+                        <a:t>11.8%</a:t>
+                      </a:r>
+                    </a:p>
+                  </a:txBody>
+                  <a:tcPr marL="73152" marR="73152" marT="27432" marB="27432" anchor="ctr">
+                    <a:noFill/>
+                  </a:tcPr>
+                </a:tc>
+                <a:tc>
+                  <a:txBody>
+                    <a:bodyPr/>
+                    <a:lstStyle/>
+                    <a:p>
+                      <a:pPr algn="r"/>
+                      <a:r>
+                        <a:rPr sz="1300" b="0">
+                          <a:solidFill>
+                            <a:srgbClr val="3C3C3B"/>
+                          </a:solidFill>
+                          <a:latin typeface="Aptos"/>
+                        </a:rPr>
+                        <a:t>1.94x</a:t>
+                      </a:r>
+                    </a:p>
+                  </a:txBody>
+                  <a:tcPr marL="73152" marR="73152" marT="27432" marB="27432" anchor="ctr">
+                    <a:noFill/>
+                  </a:tcPr>
+                </a:tc>
+                <a:tc>
+                  <a:txBody>
+                    <a:bodyPr/>
+                    <a:lstStyle/>
+                    <a:p>
+                      <a:pPr algn="r"/>
+                      <a:r>
+                        <a:rPr sz="1300" b="0">
+                          <a:solidFill>
+                            <a:srgbClr val="3C3C3B"/>
+                          </a:solidFill>
+                          <a:latin typeface="Aptos"/>
+                        </a:rPr>
+                        <a:t>1.89x</a:t>
                       </a:r>
                     </a:p>
                   </a:txBody>
@@ -20873,7 +22179,7 @@
                           </a:solidFill>
                           <a:latin typeface="Aptos"/>
                         </a:rPr>
-                        <a:t>Yield −10%</a:t>
+                        <a:t>Turbine +10%</a:t>
                       </a:r>
                     </a:p>
                   </a:txBody>
@@ -20917,154 +22223,154 @@
                           </a:solidFill>
                           <a:latin typeface="Aptos"/>
                         </a:rPr>
-                        <a:t>24.8%</a:t>
-                      </a:r>
-                    </a:p>
-                  </a:txBody>
-                  <a:tcPr marL="73152" marR="73152" marT="27432" marB="27432" anchor="ctr">
-                    <a:noFill/>
-                  </a:tcPr>
-                </a:tc>
-                <a:tc>
-                  <a:txBody>
-                    <a:bodyPr/>
-                    <a:lstStyle/>
-                    <a:p>
-                      <a:pPr algn="r"/>
-                      <a:r>
-                        <a:rPr sz="1300" b="0">
-                          <a:solidFill>
-                            <a:srgbClr val="3C3C3B"/>
-                          </a:solidFill>
-                          <a:latin typeface="Aptos"/>
-                        </a:rPr>
-                        <a:t>43.1%</a:t>
-                      </a:r>
-                    </a:p>
-                  </a:txBody>
-                  <a:tcPr marL="73152" marR="73152" marT="27432" marB="27432" anchor="ctr">
-                    <a:noFill/>
-                  </a:tcPr>
-                </a:tc>
-                <a:tc>
-                  <a:txBody>
-                    <a:bodyPr/>
-                    <a:lstStyle/>
-                    <a:p>
-                      <a:pPr algn="r"/>
-                      <a:r>
-                        <a:rPr sz="1300" b="0">
-                          <a:solidFill>
-                            <a:srgbClr val="3C3C3B"/>
-                          </a:solidFill>
-                          <a:latin typeface="Aptos"/>
-                        </a:rPr>
-                        <a:t>4.5%</a:t>
-                      </a:r>
-                    </a:p>
-                  </a:txBody>
-                  <a:tcPr marL="73152" marR="73152" marT="27432" marB="27432" anchor="ctr">
-                    <a:noFill/>
-                  </a:tcPr>
-                </a:tc>
-                <a:tc>
-                  <a:txBody>
-                    <a:bodyPr/>
-                    <a:lstStyle/>
-                    <a:p>
-                      <a:pPr algn="r"/>
-                      <a:r>
-                        <a:rPr sz="1300" b="0">
-                          <a:solidFill>
-                            <a:srgbClr val="3C3C3B"/>
-                          </a:solidFill>
-                          <a:latin typeface="Aptos"/>
-                        </a:rPr>
-                        <a:t>5.8%</a:t>
-                      </a:r>
-                    </a:p>
-                  </a:txBody>
-                  <a:tcPr marL="73152" marR="73152" marT="27432" marB="27432" anchor="ctr">
-                    <a:noFill/>
-                  </a:tcPr>
-                </a:tc>
-                <a:tc>
-                  <a:txBody>
-                    <a:bodyPr/>
-                    <a:lstStyle/>
-                    <a:p>
-                      <a:pPr algn="r"/>
-                      <a:r>
-                        <a:rPr sz="1300" b="0">
-                          <a:solidFill>
-                            <a:srgbClr val="3C3C3B"/>
-                          </a:solidFill>
-                          <a:latin typeface="Aptos"/>
-                        </a:rPr>
-                        <a:t>5.9%</a:t>
-                      </a:r>
-                    </a:p>
-                  </a:txBody>
-                  <a:tcPr marL="73152" marR="73152" marT="27432" marB="27432" anchor="ctr">
-                    <a:noFill/>
-                  </a:tcPr>
-                </a:tc>
-                <a:tc>
-                  <a:txBody>
-                    <a:bodyPr/>
-                    <a:lstStyle/>
-                    <a:p>
-                      <a:pPr algn="r"/>
-                      <a:r>
-                        <a:rPr sz="1300" b="0">
-                          <a:solidFill>
-                            <a:srgbClr val="3C3C3B"/>
-                          </a:solidFill>
-                          <a:latin typeface="Aptos"/>
-                        </a:rPr>
-                        <a:t>9.9%</a:t>
-                      </a:r>
-                    </a:p>
-                  </a:txBody>
-                  <a:tcPr marL="73152" marR="73152" marT="27432" marB="27432" anchor="ctr">
-                    <a:noFill/>
-                  </a:tcPr>
-                </a:tc>
-                <a:tc>
-                  <a:txBody>
-                    <a:bodyPr/>
-                    <a:lstStyle/>
-                    <a:p>
-                      <a:pPr algn="r"/>
-                      <a:r>
-                        <a:rPr sz="1300" b="0">
-                          <a:solidFill>
-                            <a:srgbClr val="3C3C3B"/>
-                          </a:solidFill>
-                          <a:latin typeface="Aptos"/>
-                        </a:rPr>
-                        <a:t>1.72x</a:t>
-                      </a:r>
-                    </a:p>
-                  </a:txBody>
-                  <a:tcPr marL="73152" marR="73152" marT="27432" marB="27432" anchor="ctr">
-                    <a:noFill/>
-                  </a:tcPr>
-                </a:tc>
-                <a:tc>
-                  <a:txBody>
-                    <a:bodyPr/>
-                    <a:lstStyle/>
-                    <a:p>
-                      <a:pPr algn="r"/>
-                      <a:r>
-                        <a:rPr sz="1300" b="0">
-                          <a:solidFill>
-                            <a:srgbClr val="3C3C3B"/>
-                          </a:solidFill>
-                          <a:latin typeface="Aptos"/>
-                        </a:rPr>
-                        <a:t>1.68x</a:t>
+                        <a:t>17.9%</a:t>
+                      </a:r>
+                    </a:p>
+                  </a:txBody>
+                  <a:tcPr marL="73152" marR="73152" marT="27432" marB="27432" anchor="ctr">
+                    <a:noFill/>
+                  </a:tcPr>
+                </a:tc>
+                <a:tc>
+                  <a:txBody>
+                    <a:bodyPr/>
+                    <a:lstStyle/>
+                    <a:p>
+                      <a:pPr algn="r"/>
+                      <a:r>
+                        <a:rPr sz="1300" b="0">
+                          <a:solidFill>
+                            <a:srgbClr val="3C3C3B"/>
+                          </a:solidFill>
+                          <a:latin typeface="Aptos"/>
+                        </a:rPr>
+                        <a:t>38.5%</a:t>
+                      </a:r>
+                    </a:p>
+                  </a:txBody>
+                  <a:tcPr marL="73152" marR="73152" marT="27432" marB="27432" anchor="ctr">
+                    <a:noFill/>
+                  </a:tcPr>
+                </a:tc>
+                <a:tc>
+                  <a:txBody>
+                    <a:bodyPr/>
+                    <a:lstStyle/>
+                    <a:p>
+                      <a:pPr algn="r"/>
+                      <a:r>
+                        <a:rPr sz="1300" b="0">
+                          <a:solidFill>
+                            <a:srgbClr val="3C3C3B"/>
+                          </a:solidFill>
+                          <a:latin typeface="Aptos"/>
+                        </a:rPr>
+                        <a:t>5.7%</a:t>
+                      </a:r>
+                    </a:p>
+                  </a:txBody>
+                  <a:tcPr marL="73152" marR="73152" marT="27432" marB="27432" anchor="ctr">
+                    <a:noFill/>
+                  </a:tcPr>
+                </a:tc>
+                <a:tc>
+                  <a:txBody>
+                    <a:bodyPr/>
+                    <a:lstStyle/>
+                    <a:p>
+                      <a:pPr algn="r"/>
+                      <a:r>
+                        <a:rPr sz="1300" b="0">
+                          <a:solidFill>
+                            <a:srgbClr val="3C3C3B"/>
+                          </a:solidFill>
+                          <a:latin typeface="Aptos"/>
+                        </a:rPr>
+                        <a:t>7.0%</a:t>
+                      </a:r>
+                    </a:p>
+                  </a:txBody>
+                  <a:tcPr marL="73152" marR="73152" marT="27432" marB="27432" anchor="ctr">
+                    <a:noFill/>
+                  </a:tcPr>
+                </a:tc>
+                <a:tc>
+                  <a:txBody>
+                    <a:bodyPr/>
+                    <a:lstStyle/>
+                    <a:p>
+                      <a:pPr algn="r"/>
+                      <a:r>
+                        <a:rPr sz="1300" b="0">
+                          <a:solidFill>
+                            <a:srgbClr val="3C3C3B"/>
+                          </a:solidFill>
+                          <a:latin typeface="Aptos"/>
+                        </a:rPr>
+                        <a:t>6.8%</a:t>
+                      </a:r>
+                    </a:p>
+                  </a:txBody>
+                  <a:tcPr marL="73152" marR="73152" marT="27432" marB="27432" anchor="ctr">
+                    <a:noFill/>
+                  </a:tcPr>
+                </a:tc>
+                <a:tc>
+                  <a:txBody>
+                    <a:bodyPr/>
+                    <a:lstStyle/>
+                    <a:p>
+                      <a:pPr algn="r"/>
+                      <a:r>
+                        <a:rPr sz="1300" b="0">
+                          <a:solidFill>
+                            <a:srgbClr val="3C3C3B"/>
+                          </a:solidFill>
+                          <a:latin typeface="Aptos"/>
+                        </a:rPr>
+                        <a:t>11.2%</a:t>
+                      </a:r>
+                    </a:p>
+                  </a:txBody>
+                  <a:tcPr marL="73152" marR="73152" marT="27432" marB="27432" anchor="ctr">
+                    <a:noFill/>
+                  </a:tcPr>
+                </a:tc>
+                <a:tc>
+                  <a:txBody>
+                    <a:bodyPr/>
+                    <a:lstStyle/>
+                    <a:p>
+                      <a:pPr algn="r"/>
+                      <a:r>
+                        <a:rPr sz="1300" b="0">
+                          <a:solidFill>
+                            <a:srgbClr val="3C3C3B"/>
+                          </a:solidFill>
+                          <a:latin typeface="Aptos"/>
+                        </a:rPr>
+                        <a:t>1.95x</a:t>
+                      </a:r>
+                    </a:p>
+                  </a:txBody>
+                  <a:tcPr marL="73152" marR="73152" marT="27432" marB="27432" anchor="ctr">
+                    <a:noFill/>
+                  </a:tcPr>
+                </a:tc>
+                <a:tc>
+                  <a:txBody>
+                    <a:bodyPr/>
+                    <a:lstStyle/>
+                    <a:p>
+                      <a:pPr algn="r"/>
+                      <a:r>
+                        <a:rPr sz="1300" b="0">
+                          <a:solidFill>
+                            <a:srgbClr val="3C3C3B"/>
+                          </a:solidFill>
+                          <a:latin typeface="Aptos"/>
+                        </a:rPr>
+                        <a:t>1.90x</a:t>
                       </a:r>
                     </a:p>
                   </a:txBody>
@@ -21087,7 +22393,7 @@
                           </a:solidFill>
                           <a:latin typeface="Aptos"/>
                         </a:rPr>
-                        <a:t>PPA +10%</a:t>
+                        <a:t>Yield −10%</a:t>
                       </a:r>
                     </a:p>
                   </a:txBody>
@@ -21173,112 +22479,112 @@
                           </a:solidFill>
                           <a:latin typeface="Aptos"/>
                         </a:rPr>
-                        <a:t>6.8%</a:t>
-                      </a:r>
-                    </a:p>
-                  </a:txBody>
-                  <a:tcPr marL="73152" marR="73152" marT="27432" marB="27432" anchor="ctr">
-                    <a:noFill/>
-                  </a:tcPr>
-                </a:tc>
-                <a:tc>
-                  <a:txBody>
-                    <a:bodyPr/>
-                    <a:lstStyle/>
-                    <a:p>
-                      <a:pPr algn="r"/>
-                      <a:r>
-                        <a:rPr sz="1300" b="0">
-                          <a:solidFill>
-                            <a:srgbClr val="3C3C3B"/>
-                          </a:solidFill>
-                          <a:latin typeface="Aptos"/>
-                        </a:rPr>
-                        <a:t>8.3%</a:t>
-                      </a:r>
-                    </a:p>
-                  </a:txBody>
-                  <a:tcPr marL="73152" marR="73152" marT="27432" marB="27432" anchor="ctr">
-                    <a:noFill/>
-                  </a:tcPr>
-                </a:tc>
-                <a:tc>
-                  <a:txBody>
-                    <a:bodyPr/>
-                    <a:lstStyle/>
-                    <a:p>
-                      <a:pPr algn="r"/>
-                      <a:r>
-                        <a:rPr sz="1300" b="0">
-                          <a:solidFill>
-                            <a:srgbClr val="3C3C3B"/>
-                          </a:solidFill>
-                          <a:latin typeface="Aptos"/>
-                        </a:rPr>
-                        <a:t>8.9%</a:t>
-                      </a:r>
-                    </a:p>
-                  </a:txBody>
-                  <a:tcPr marL="73152" marR="73152" marT="27432" marB="27432" anchor="ctr">
-                    <a:noFill/>
-                  </a:tcPr>
-                </a:tc>
-                <a:tc>
-                  <a:txBody>
-                    <a:bodyPr/>
-                    <a:lstStyle/>
-                    <a:p>
-                      <a:pPr algn="r"/>
-                      <a:r>
-                        <a:rPr sz="1300" b="0">
-                          <a:solidFill>
-                            <a:srgbClr val="3C3C3B"/>
-                          </a:solidFill>
-                          <a:latin typeface="Aptos"/>
-                        </a:rPr>
-                        <a:t>14.0%</a:t>
-                      </a:r>
-                    </a:p>
-                  </a:txBody>
-                  <a:tcPr marL="73152" marR="73152" marT="27432" marB="27432" anchor="ctr">
-                    <a:noFill/>
-                  </a:tcPr>
-                </a:tc>
-                <a:tc>
-                  <a:txBody>
-                    <a:bodyPr/>
-                    <a:lstStyle/>
-                    <a:p>
-                      <a:pPr algn="r"/>
-                      <a:r>
-                        <a:rPr sz="1300" b="0">
-                          <a:solidFill>
-                            <a:srgbClr val="3C3C3B"/>
-                          </a:solidFill>
-                          <a:latin typeface="Aptos"/>
-                        </a:rPr>
-                        <a:t>2.16x</a:t>
-                      </a:r>
-                    </a:p>
-                  </a:txBody>
-                  <a:tcPr marL="73152" marR="73152" marT="27432" marB="27432" anchor="ctr">
-                    <a:noFill/>
-                  </a:tcPr>
-                </a:tc>
-                <a:tc>
-                  <a:txBody>
-                    <a:bodyPr/>
-                    <a:lstStyle/>
-                    <a:p>
-                      <a:pPr algn="r"/>
-                      <a:r>
-                        <a:rPr sz="1300" b="0">
-                          <a:solidFill>
-                            <a:srgbClr val="3C3C3B"/>
-                          </a:solidFill>
-                          <a:latin typeface="Aptos"/>
-                        </a:rPr>
-                        <a:t>2.11x</a:t>
+                        <a:t>4.5%</a:t>
+                      </a:r>
+                    </a:p>
+                  </a:txBody>
+                  <a:tcPr marL="73152" marR="73152" marT="27432" marB="27432" anchor="ctr">
+                    <a:noFill/>
+                  </a:tcPr>
+                </a:tc>
+                <a:tc>
+                  <a:txBody>
+                    <a:bodyPr/>
+                    <a:lstStyle/>
+                    <a:p>
+                      <a:pPr algn="r"/>
+                      <a:r>
+                        <a:rPr sz="1300" b="0">
+                          <a:solidFill>
+                            <a:srgbClr val="3C3C3B"/>
+                          </a:solidFill>
+                          <a:latin typeface="Aptos"/>
+                        </a:rPr>
+                        <a:t>5.8%</a:t>
+                      </a:r>
+                    </a:p>
+                  </a:txBody>
+                  <a:tcPr marL="73152" marR="73152" marT="27432" marB="27432" anchor="ctr">
+                    <a:noFill/>
+                  </a:tcPr>
+                </a:tc>
+                <a:tc>
+                  <a:txBody>
+                    <a:bodyPr/>
+                    <a:lstStyle/>
+                    <a:p>
+                      <a:pPr algn="r"/>
+                      <a:r>
+                        <a:rPr sz="1300" b="0">
+                          <a:solidFill>
+                            <a:srgbClr val="3C3C3B"/>
+                          </a:solidFill>
+                          <a:latin typeface="Aptos"/>
+                        </a:rPr>
+                        <a:t>5.9%</a:t>
+                      </a:r>
+                    </a:p>
+                  </a:txBody>
+                  <a:tcPr marL="73152" marR="73152" marT="27432" marB="27432" anchor="ctr">
+                    <a:noFill/>
+                  </a:tcPr>
+                </a:tc>
+                <a:tc>
+                  <a:txBody>
+                    <a:bodyPr/>
+                    <a:lstStyle/>
+                    <a:p>
+                      <a:pPr algn="r"/>
+                      <a:r>
+                        <a:rPr sz="1300" b="0">
+                          <a:solidFill>
+                            <a:srgbClr val="3C3C3B"/>
+                          </a:solidFill>
+                          <a:latin typeface="Aptos"/>
+                        </a:rPr>
+                        <a:t>9.9%</a:t>
+                      </a:r>
+                    </a:p>
+                  </a:txBody>
+                  <a:tcPr marL="73152" marR="73152" marT="27432" marB="27432" anchor="ctr">
+                    <a:noFill/>
+                  </a:tcPr>
+                </a:tc>
+                <a:tc>
+                  <a:txBody>
+                    <a:bodyPr/>
+                    <a:lstStyle/>
+                    <a:p>
+                      <a:pPr algn="r"/>
+                      <a:r>
+                        <a:rPr sz="1300" b="0">
+                          <a:solidFill>
+                            <a:srgbClr val="3C3C3B"/>
+                          </a:solidFill>
+                          <a:latin typeface="Aptos"/>
+                        </a:rPr>
+                        <a:t>1.72x</a:t>
+                      </a:r>
+                    </a:p>
+                  </a:txBody>
+                  <a:tcPr marL="73152" marR="73152" marT="27432" marB="27432" anchor="ctr">
+                    <a:noFill/>
+                  </a:tcPr>
+                </a:tc>
+                <a:tc>
+                  <a:txBody>
+                    <a:bodyPr/>
+                    <a:lstStyle/>
+                    <a:p>
+                      <a:pPr algn="r"/>
+                      <a:r>
+                        <a:rPr sz="1300" b="0">
+                          <a:solidFill>
+                            <a:srgbClr val="3C3C3B"/>
+                          </a:solidFill>
+                          <a:latin typeface="Aptos"/>
+                        </a:rPr>
+                        <a:t>1.68x</a:t>
                       </a:r>
                     </a:p>
                   </a:txBody>
@@ -21301,7 +22607,7 @@
                           </a:solidFill>
                           <a:latin typeface="Aptos"/>
                         </a:rPr>
-                        <a:t>Full PB call</a:t>
+                        <a:t>PPA +10%</a:t>
                       </a:r>
                     </a:p>
                   </a:txBody>
@@ -21345,154 +22651,154 @@
                           </a:solidFill>
                           <a:latin typeface="Aptos"/>
                         </a:rPr>
-                        <a:t>22.5%</a:t>
-                      </a:r>
-                    </a:p>
-                  </a:txBody>
-                  <a:tcPr marL="73152" marR="73152" marT="27432" marB="27432" anchor="ctr">
-                    <a:noFill/>
-                  </a:tcPr>
-                </a:tc>
-                <a:tc>
-                  <a:txBody>
-                    <a:bodyPr/>
-                    <a:lstStyle/>
-                    <a:p>
-                      <a:pPr algn="r"/>
-                      <a:r>
-                        <a:rPr sz="1300" b="0">
-                          <a:solidFill>
-                            <a:srgbClr val="3C3C3B"/>
-                          </a:solidFill>
-                          <a:latin typeface="Aptos"/>
-                        </a:rPr>
-                        <a:t>40.5%</a:t>
-                      </a:r>
-                    </a:p>
-                  </a:txBody>
-                  <a:tcPr marL="73152" marR="73152" marT="27432" marB="27432" anchor="ctr">
-                    <a:noFill/>
-                  </a:tcPr>
-                </a:tc>
-                <a:tc>
-                  <a:txBody>
-                    <a:bodyPr/>
-                    <a:lstStyle/>
-                    <a:p>
-                      <a:pPr algn="r"/>
-                      <a:r>
-                        <a:rPr sz="1300" b="0">
-                          <a:solidFill>
-                            <a:srgbClr val="3C3C3B"/>
-                          </a:solidFill>
-                          <a:latin typeface="Aptos"/>
-                        </a:rPr>
-                        <a:t>5.6%</a:t>
-                      </a:r>
-                    </a:p>
-                  </a:txBody>
-                  <a:tcPr marL="73152" marR="73152" marT="27432" marB="27432" anchor="ctr">
-                    <a:noFill/>
-                  </a:tcPr>
-                </a:tc>
-                <a:tc>
-                  <a:txBody>
-                    <a:bodyPr/>
-                    <a:lstStyle/>
-                    <a:p>
-                      <a:pPr algn="r"/>
-                      <a:r>
-                        <a:rPr sz="1300" b="0">
-                          <a:solidFill>
-                            <a:srgbClr val="3C3C3B"/>
-                          </a:solidFill>
-                          <a:latin typeface="Aptos"/>
-                        </a:rPr>
-                        <a:t>7.0%</a:t>
-                      </a:r>
-                    </a:p>
-                  </a:txBody>
-                  <a:tcPr marL="73152" marR="73152" marT="27432" marB="27432" anchor="ctr">
-                    <a:noFill/>
-                  </a:tcPr>
-                </a:tc>
-                <a:tc>
-                  <a:txBody>
-                    <a:bodyPr/>
-                    <a:lstStyle/>
-                    <a:p>
-                      <a:pPr algn="r"/>
-                      <a:r>
-                        <a:rPr sz="1300" b="0">
-                          <a:solidFill>
-                            <a:srgbClr val="3C3C3B"/>
-                          </a:solidFill>
-                          <a:latin typeface="Aptos"/>
-                        </a:rPr>
-                        <a:t>7.2%</a:t>
-                      </a:r>
-                    </a:p>
-                  </a:txBody>
-                  <a:tcPr marL="73152" marR="73152" marT="27432" marB="27432" anchor="ctr">
-                    <a:noFill/>
-                  </a:tcPr>
-                </a:tc>
-                <a:tc>
-                  <a:txBody>
-                    <a:bodyPr/>
-                    <a:lstStyle/>
-                    <a:p>
-                      <a:pPr algn="r"/>
-                      <a:r>
-                        <a:rPr sz="1300" b="0">
-                          <a:solidFill>
-                            <a:srgbClr val="3C3C3B"/>
-                          </a:solidFill>
-                          <a:latin typeface="Aptos"/>
-                        </a:rPr>
-                        <a:t>11.4%</a:t>
-                      </a:r>
-                    </a:p>
-                  </a:txBody>
-                  <a:tcPr marL="73152" marR="73152" marT="27432" marB="27432" anchor="ctr">
-                    <a:noFill/>
-                  </a:tcPr>
-                </a:tc>
-                <a:tc>
-                  <a:txBody>
-                    <a:bodyPr/>
-                    <a:lstStyle/>
-                    <a:p>
-                      <a:pPr algn="r"/>
-                      <a:r>
-                        <a:rPr sz="1300" b="0">
-                          <a:solidFill>
-                            <a:srgbClr val="3C3C3B"/>
-                          </a:solidFill>
-                          <a:latin typeface="Aptos"/>
-                        </a:rPr>
-                        <a:t>1.94x</a:t>
-                      </a:r>
-                    </a:p>
-                  </a:txBody>
-                  <a:tcPr marL="73152" marR="73152" marT="27432" marB="27432" anchor="ctr">
-                    <a:noFill/>
-                  </a:tcPr>
-                </a:tc>
-                <a:tc>
-                  <a:txBody>
-                    <a:bodyPr/>
-                    <a:lstStyle/>
-                    <a:p>
-                      <a:pPr algn="r"/>
-                      <a:r>
-                        <a:rPr sz="1300" b="0">
-                          <a:solidFill>
-                            <a:srgbClr val="3C3C3B"/>
-                          </a:solidFill>
-                          <a:latin typeface="Aptos"/>
-                        </a:rPr>
-                        <a:t>1.89x</a:t>
+                        <a:t>24.8%</a:t>
+                      </a:r>
+                    </a:p>
+                  </a:txBody>
+                  <a:tcPr marL="73152" marR="73152" marT="27432" marB="27432" anchor="ctr">
+                    <a:noFill/>
+                  </a:tcPr>
+                </a:tc>
+                <a:tc>
+                  <a:txBody>
+                    <a:bodyPr/>
+                    <a:lstStyle/>
+                    <a:p>
+                      <a:pPr algn="r"/>
+                      <a:r>
+                        <a:rPr sz="1300" b="0">
+                          <a:solidFill>
+                            <a:srgbClr val="3C3C3B"/>
+                          </a:solidFill>
+                          <a:latin typeface="Aptos"/>
+                        </a:rPr>
+                        <a:t>43.1%</a:t>
+                      </a:r>
+                    </a:p>
+                  </a:txBody>
+                  <a:tcPr marL="73152" marR="73152" marT="27432" marB="27432" anchor="ctr">
+                    <a:noFill/>
+                  </a:tcPr>
+                </a:tc>
+                <a:tc>
+                  <a:txBody>
+                    <a:bodyPr/>
+                    <a:lstStyle/>
+                    <a:p>
+                      <a:pPr algn="r"/>
+                      <a:r>
+                        <a:rPr sz="1300" b="0">
+                          <a:solidFill>
+                            <a:srgbClr val="3C3C3B"/>
+                          </a:solidFill>
+                          <a:latin typeface="Aptos"/>
+                        </a:rPr>
+                        <a:t>6.8%</a:t>
+                      </a:r>
+                    </a:p>
+                  </a:txBody>
+                  <a:tcPr marL="73152" marR="73152" marT="27432" marB="27432" anchor="ctr">
+                    <a:noFill/>
+                  </a:tcPr>
+                </a:tc>
+                <a:tc>
+                  <a:txBody>
+                    <a:bodyPr/>
+                    <a:lstStyle/>
+                    <a:p>
+                      <a:pPr algn="r"/>
+                      <a:r>
+                        <a:rPr sz="1300" b="0">
+                          <a:solidFill>
+                            <a:srgbClr val="3C3C3B"/>
+                          </a:solidFill>
+                          <a:latin typeface="Aptos"/>
+                        </a:rPr>
+                        <a:t>8.3%</a:t>
+                      </a:r>
+                    </a:p>
+                  </a:txBody>
+                  <a:tcPr marL="73152" marR="73152" marT="27432" marB="27432" anchor="ctr">
+                    <a:noFill/>
+                  </a:tcPr>
+                </a:tc>
+                <a:tc>
+                  <a:txBody>
+                    <a:bodyPr/>
+                    <a:lstStyle/>
+                    <a:p>
+                      <a:pPr algn="r"/>
+                      <a:r>
+                        <a:rPr sz="1300" b="0">
+                          <a:solidFill>
+                            <a:srgbClr val="3C3C3B"/>
+                          </a:solidFill>
+                          <a:latin typeface="Aptos"/>
+                        </a:rPr>
+                        <a:t>8.9%</a:t>
+                      </a:r>
+                    </a:p>
+                  </a:txBody>
+                  <a:tcPr marL="73152" marR="73152" marT="27432" marB="27432" anchor="ctr">
+                    <a:noFill/>
+                  </a:tcPr>
+                </a:tc>
+                <a:tc>
+                  <a:txBody>
+                    <a:bodyPr/>
+                    <a:lstStyle/>
+                    <a:p>
+                      <a:pPr algn="r"/>
+                      <a:r>
+                        <a:rPr sz="1300" b="0">
+                          <a:solidFill>
+                            <a:srgbClr val="3C3C3B"/>
+                          </a:solidFill>
+                          <a:latin typeface="Aptos"/>
+                        </a:rPr>
+                        <a:t>14.0%</a:t>
+                      </a:r>
+                    </a:p>
+                  </a:txBody>
+                  <a:tcPr marL="73152" marR="73152" marT="27432" marB="27432" anchor="ctr">
+                    <a:noFill/>
+                  </a:tcPr>
+                </a:tc>
+                <a:tc>
+                  <a:txBody>
+                    <a:bodyPr/>
+                    <a:lstStyle/>
+                    <a:p>
+                      <a:pPr algn="r"/>
+                      <a:r>
+                        <a:rPr sz="1300" b="0">
+                          <a:solidFill>
+                            <a:srgbClr val="3C3C3B"/>
+                          </a:solidFill>
+                          <a:latin typeface="Aptos"/>
+                        </a:rPr>
+                        <a:t>2.16x</a:t>
+                      </a:r>
+                    </a:p>
+                  </a:txBody>
+                  <a:tcPr marL="73152" marR="73152" marT="27432" marB="27432" anchor="ctr">
+                    <a:noFill/>
+                  </a:tcPr>
+                </a:tc>
+                <a:tc>
+                  <a:txBody>
+                    <a:bodyPr/>
+                    <a:lstStyle/>
+                    <a:p>
+                      <a:pPr algn="r"/>
+                      <a:r>
+                        <a:rPr sz="1300" b="0">
+                          <a:solidFill>
+                            <a:srgbClr val="3C3C3B"/>
+                          </a:solidFill>
+                          <a:latin typeface="Aptos"/>
+                        </a:rPr>
+                        <a:t>2.11x</a:t>
                       </a:r>
                     </a:p>
                   </a:txBody>
@@ -21515,7 +22821,7 @@
                           </a:solidFill>
                           <a:latin typeface="Aptos"/>
                         </a:rPr>
-                        <a:t>Rate +1 pp</a:t>
+                        <a:t>Full PB call</a:t>
                       </a:r>
                     </a:p>
                   </a:txBody>
@@ -21559,49 +22865,49 @@
                           </a:solidFill>
                           <a:latin typeface="Aptos"/>
                         </a:rPr>
-                        <a:t>24.3%</a:t>
-                      </a:r>
-                    </a:p>
-                  </a:txBody>
-                  <a:tcPr marL="73152" marR="73152" marT="27432" marB="27432" anchor="ctr">
-                    <a:noFill/>
-                  </a:tcPr>
-                </a:tc>
-                <a:tc>
-                  <a:txBody>
-                    <a:bodyPr/>
-                    <a:lstStyle/>
-                    <a:p>
-                      <a:pPr algn="r"/>
-                      <a:r>
-                        <a:rPr sz="1300" b="0">
-                          <a:solidFill>
-                            <a:srgbClr val="3C3C3B"/>
-                          </a:solidFill>
-                          <a:latin typeface="Aptos"/>
-                        </a:rPr>
-                        <a:t>42.4%</a:t>
-                      </a:r>
-                    </a:p>
-                  </a:txBody>
-                  <a:tcPr marL="73152" marR="73152" marT="27432" marB="27432" anchor="ctr">
-                    <a:noFill/>
-                  </a:tcPr>
-                </a:tc>
-                <a:tc>
-                  <a:txBody>
-                    <a:bodyPr/>
-                    <a:lstStyle/>
-                    <a:p>
-                      <a:pPr algn="r"/>
-                      <a:r>
-                        <a:rPr sz="1300" b="0">
-                          <a:solidFill>
-                            <a:srgbClr val="3C3C3B"/>
-                          </a:solidFill>
-                          <a:latin typeface="Aptos"/>
-                        </a:rPr>
-                        <a:t>5.7%</a:t>
+                        <a:t>22.5%</a:t>
+                      </a:r>
+                    </a:p>
+                  </a:txBody>
+                  <a:tcPr marL="73152" marR="73152" marT="27432" marB="27432" anchor="ctr">
+                    <a:noFill/>
+                  </a:tcPr>
+                </a:tc>
+                <a:tc>
+                  <a:txBody>
+                    <a:bodyPr/>
+                    <a:lstStyle/>
+                    <a:p>
+                      <a:pPr algn="r"/>
+                      <a:r>
+                        <a:rPr sz="1300" b="0">
+                          <a:solidFill>
+                            <a:srgbClr val="3C3C3B"/>
+                          </a:solidFill>
+                          <a:latin typeface="Aptos"/>
+                        </a:rPr>
+                        <a:t>40.5%</a:t>
+                      </a:r>
+                    </a:p>
+                  </a:txBody>
+                  <a:tcPr marL="73152" marR="73152" marT="27432" marB="27432" anchor="ctr">
+                    <a:noFill/>
+                  </a:tcPr>
+                </a:tc>
+                <a:tc>
+                  <a:txBody>
+                    <a:bodyPr/>
+                    <a:lstStyle/>
+                    <a:p>
+                      <a:pPr algn="r"/>
+                      <a:r>
+                        <a:rPr sz="1300" b="0">
+                          <a:solidFill>
+                            <a:srgbClr val="3C3C3B"/>
+                          </a:solidFill>
+                          <a:latin typeface="Aptos"/>
+                        </a:rPr>
+                        <a:t>5.6%</a:t>
                       </a:r>
                     </a:p>
                   </a:txBody>
@@ -21643,70 +22949,70 @@
                           </a:solidFill>
                           <a:latin typeface="Aptos"/>
                         </a:rPr>
-                        <a:t>7.1%</a:t>
-                      </a:r>
-                    </a:p>
-                  </a:txBody>
-                  <a:tcPr marL="73152" marR="73152" marT="27432" marB="27432" anchor="ctr">
-                    <a:noFill/>
-                  </a:tcPr>
-                </a:tc>
-                <a:tc>
-                  <a:txBody>
-                    <a:bodyPr/>
-                    <a:lstStyle/>
-                    <a:p>
-                      <a:pPr algn="r"/>
-                      <a:r>
-                        <a:rPr sz="1300" b="0">
-                          <a:solidFill>
-                            <a:srgbClr val="3C3C3B"/>
-                          </a:solidFill>
-                          <a:latin typeface="Aptos"/>
-                        </a:rPr>
-                        <a:t>11.3%</a:t>
-                      </a:r>
-                    </a:p>
-                  </a:txBody>
-                  <a:tcPr marL="73152" marR="73152" marT="27432" marB="27432" anchor="ctr">
-                    <a:noFill/>
-                  </a:tcPr>
-                </a:tc>
-                <a:tc>
-                  <a:txBody>
-                    <a:bodyPr/>
-                    <a:lstStyle/>
-                    <a:p>
-                      <a:pPr algn="r"/>
-                      <a:r>
-                        <a:rPr sz="1300" b="0">
-                          <a:solidFill>
-                            <a:srgbClr val="3C3C3B"/>
-                          </a:solidFill>
-                          <a:latin typeface="Aptos"/>
-                        </a:rPr>
-                        <a:t>1.82x</a:t>
-                      </a:r>
-                    </a:p>
-                  </a:txBody>
-                  <a:tcPr marL="73152" marR="73152" marT="27432" marB="27432" anchor="ctr">
-                    <a:noFill/>
-                  </a:tcPr>
-                </a:tc>
-                <a:tc>
-                  <a:txBody>
-                    <a:bodyPr/>
-                    <a:lstStyle/>
-                    <a:p>
-                      <a:pPr algn="r"/>
-                      <a:r>
-                        <a:rPr sz="1300" b="0">
-                          <a:solidFill>
-                            <a:srgbClr val="3C3C3B"/>
-                          </a:solidFill>
-                          <a:latin typeface="Aptos"/>
-                        </a:rPr>
-                        <a:t>1.78x</a:t>
+                        <a:t>7.2%</a:t>
+                      </a:r>
+                    </a:p>
+                  </a:txBody>
+                  <a:tcPr marL="73152" marR="73152" marT="27432" marB="27432" anchor="ctr">
+                    <a:noFill/>
+                  </a:tcPr>
+                </a:tc>
+                <a:tc>
+                  <a:txBody>
+                    <a:bodyPr/>
+                    <a:lstStyle/>
+                    <a:p>
+                      <a:pPr algn="r"/>
+                      <a:r>
+                        <a:rPr sz="1300" b="0">
+                          <a:solidFill>
+                            <a:srgbClr val="3C3C3B"/>
+                          </a:solidFill>
+                          <a:latin typeface="Aptos"/>
+                        </a:rPr>
+                        <a:t>11.4%</a:t>
+                      </a:r>
+                    </a:p>
+                  </a:txBody>
+                  <a:tcPr marL="73152" marR="73152" marT="27432" marB="27432" anchor="ctr">
+                    <a:noFill/>
+                  </a:tcPr>
+                </a:tc>
+                <a:tc>
+                  <a:txBody>
+                    <a:bodyPr/>
+                    <a:lstStyle/>
+                    <a:p>
+                      <a:pPr algn="r"/>
+                      <a:r>
+                        <a:rPr sz="1300" b="0">
+                          <a:solidFill>
+                            <a:srgbClr val="3C3C3B"/>
+                          </a:solidFill>
+                          <a:latin typeface="Aptos"/>
+                        </a:rPr>
+                        <a:t>1.94x</a:t>
+                      </a:r>
+                    </a:p>
+                  </a:txBody>
+                  <a:tcPr marL="73152" marR="73152" marT="27432" marB="27432" anchor="ctr">
+                    <a:noFill/>
+                  </a:tcPr>
+                </a:tc>
+                <a:tc>
+                  <a:txBody>
+                    <a:bodyPr/>
+                    <a:lstStyle/>
+                    <a:p>
+                      <a:pPr algn="r"/>
+                      <a:r>
+                        <a:rPr sz="1300" b="0">
+                          <a:solidFill>
+                            <a:srgbClr val="3C3C3B"/>
+                          </a:solidFill>
+                          <a:latin typeface="Aptos"/>
+                        </a:rPr>
+                        <a:t>1.89x</a:t>
                       </a:r>
                     </a:p>
                   </a:txBody>
@@ -21729,7 +23035,7 @@
                           </a:solidFill>
                           <a:latin typeface="Aptos"/>
                         </a:rPr>
-                        <a:t>Tenor 10 years</a:t>
+                        <a:t>Rate +1 pp</a:t>
                       </a:r>
                     </a:p>
                   </a:txBody>
@@ -21773,154 +23079,154 @@
                           </a:solidFill>
                           <a:latin typeface="Aptos"/>
                         </a:rPr>
-                        <a:t>24.8%</a:t>
-                      </a:r>
-                    </a:p>
-                  </a:txBody>
-                  <a:tcPr marL="73152" marR="73152" marT="27432" marB="27432" anchor="ctr">
-                    <a:noFill/>
-                  </a:tcPr>
-                </a:tc>
-                <a:tc>
-                  <a:txBody>
-                    <a:bodyPr/>
-                    <a:lstStyle/>
-                    <a:p>
-                      <a:pPr algn="r"/>
-                      <a:r>
-                        <a:rPr sz="1300" b="0">
-                          <a:solidFill>
-                            <a:srgbClr val="3C3C3B"/>
-                          </a:solidFill>
-                          <a:latin typeface="Aptos"/>
-                        </a:rPr>
-                        <a:t>43.1%</a:t>
-                      </a:r>
-                    </a:p>
-                  </a:txBody>
-                  <a:tcPr marL="73152" marR="73152" marT="27432" marB="27432" anchor="ctr">
-                    <a:noFill/>
-                  </a:tcPr>
-                </a:tc>
-                <a:tc>
-                  <a:txBody>
-                    <a:bodyPr/>
-                    <a:lstStyle/>
-                    <a:p>
-                      <a:pPr algn="r"/>
-                      <a:r>
-                        <a:rPr sz="1300" b="0">
-                          <a:solidFill>
-                            <a:srgbClr val="3C3C3B"/>
-                          </a:solidFill>
-                          <a:latin typeface="Aptos"/>
-                        </a:rPr>
-                        <a:t>5.6%</a:t>
-                      </a:r>
-                    </a:p>
-                  </a:txBody>
-                  <a:tcPr marL="73152" marR="73152" marT="27432" marB="27432" anchor="ctr">
-                    <a:noFill/>
-                  </a:tcPr>
-                </a:tc>
-                <a:tc>
-                  <a:txBody>
-                    <a:bodyPr/>
-                    <a:lstStyle/>
-                    <a:p>
-                      <a:pPr algn="r"/>
-                      <a:r>
-                        <a:rPr sz="1300" b="0">
-                          <a:solidFill>
-                            <a:srgbClr val="3C3C3B"/>
-                          </a:solidFill>
-                          <a:latin typeface="Aptos"/>
-                        </a:rPr>
-                        <a:t>6.9%</a:t>
-                      </a:r>
-                    </a:p>
-                  </a:txBody>
-                  <a:tcPr marL="73152" marR="73152" marT="27432" marB="27432" anchor="ctr">
-                    <a:noFill/>
-                  </a:tcPr>
-                </a:tc>
-                <a:tc>
-                  <a:txBody>
-                    <a:bodyPr/>
-                    <a:lstStyle/>
-                    <a:p>
-                      <a:pPr algn="r"/>
-                      <a:r>
-                        <a:rPr sz="1300" b="0">
-                          <a:solidFill>
-                            <a:srgbClr val="3C3C3B"/>
-                          </a:solidFill>
-                          <a:latin typeface="Aptos"/>
-                        </a:rPr>
-                        <a:t>7.2%</a:t>
-                      </a:r>
-                    </a:p>
-                  </a:txBody>
-                  <a:tcPr marL="73152" marR="73152" marT="27432" marB="27432" anchor="ctr">
-                    <a:noFill/>
-                  </a:tcPr>
-                </a:tc>
-                <a:tc>
-                  <a:txBody>
-                    <a:bodyPr/>
-                    <a:lstStyle/>
-                    <a:p>
-                      <a:pPr algn="r"/>
-                      <a:r>
-                        <a:rPr sz="1300" b="0">
-                          <a:solidFill>
-                            <a:srgbClr val="3C3C3B"/>
-                          </a:solidFill>
-                          <a:latin typeface="Aptos"/>
-                        </a:rPr>
-                        <a:t>11.0%</a:t>
-                      </a:r>
-                    </a:p>
-                  </a:txBody>
-                  <a:tcPr marL="73152" marR="73152" marT="27432" marB="27432" anchor="ctr">
-                    <a:noFill/>
-                  </a:tcPr>
-                </a:tc>
-                <a:tc>
-                  <a:txBody>
-                    <a:bodyPr/>
-                    <a:lstStyle/>
-                    <a:p>
-                      <a:pPr algn="r"/>
-                      <a:r>
-                        <a:rPr sz="1300" b="0">
-                          <a:solidFill>
-                            <a:srgbClr val="3C3C3B"/>
-                          </a:solidFill>
-                          <a:latin typeface="Aptos"/>
-                        </a:rPr>
-                        <a:t>1.44x</a:t>
-                      </a:r>
-                    </a:p>
-                  </a:txBody>
-                  <a:tcPr marL="73152" marR="73152" marT="27432" marB="27432" anchor="ctr">
-                    <a:noFill/>
-                  </a:tcPr>
-                </a:tc>
-                <a:tc>
-                  <a:txBody>
-                    <a:bodyPr/>
-                    <a:lstStyle/>
-                    <a:p>
-                      <a:pPr algn="r"/>
-                      <a:r>
-                        <a:rPr sz="1300" b="0">
-                          <a:solidFill>
-                            <a:srgbClr val="3C3C3B"/>
-                          </a:solidFill>
-                          <a:latin typeface="Aptos"/>
-                        </a:rPr>
-                        <a:t>1.40x</a:t>
+                        <a:t>24.3%</a:t>
+                      </a:r>
+                    </a:p>
+                  </a:txBody>
+                  <a:tcPr marL="73152" marR="73152" marT="27432" marB="27432" anchor="ctr">
+                    <a:noFill/>
+                  </a:tcPr>
+                </a:tc>
+                <a:tc>
+                  <a:txBody>
+                    <a:bodyPr/>
+                    <a:lstStyle/>
+                    <a:p>
+                      <a:pPr algn="r"/>
+                      <a:r>
+                        <a:rPr sz="1300" b="0">
+                          <a:solidFill>
+                            <a:srgbClr val="3C3C3B"/>
+                          </a:solidFill>
+                          <a:latin typeface="Aptos"/>
+                        </a:rPr>
+                        <a:t>42.4%</a:t>
+                      </a:r>
+                    </a:p>
+                  </a:txBody>
+                  <a:tcPr marL="73152" marR="73152" marT="27432" marB="27432" anchor="ctr">
+                    <a:noFill/>
+                  </a:tcPr>
+                </a:tc>
+                <a:tc>
+                  <a:txBody>
+                    <a:bodyPr/>
+                    <a:lstStyle/>
+                    <a:p>
+                      <a:pPr algn="r"/>
+                      <a:r>
+                        <a:rPr sz="1300" b="0">
+                          <a:solidFill>
+                            <a:srgbClr val="3C3C3B"/>
+                          </a:solidFill>
+                          <a:latin typeface="Aptos"/>
+                        </a:rPr>
+                        <a:t>5.7%</a:t>
+                      </a:r>
+                    </a:p>
+                  </a:txBody>
+                  <a:tcPr marL="73152" marR="73152" marT="27432" marB="27432" anchor="ctr">
+                    <a:noFill/>
+                  </a:tcPr>
+                </a:tc>
+                <a:tc>
+                  <a:txBody>
+                    <a:bodyPr/>
+                    <a:lstStyle/>
+                    <a:p>
+                      <a:pPr algn="r"/>
+                      <a:r>
+                        <a:rPr sz="1300" b="0">
+                          <a:solidFill>
+                            <a:srgbClr val="3C3C3B"/>
+                          </a:solidFill>
+                          <a:latin typeface="Aptos"/>
+                        </a:rPr>
+                        <a:t>7.0%</a:t>
+                      </a:r>
+                    </a:p>
+                  </a:txBody>
+                  <a:tcPr marL="73152" marR="73152" marT="27432" marB="27432" anchor="ctr">
+                    <a:noFill/>
+                  </a:tcPr>
+                </a:tc>
+                <a:tc>
+                  <a:txBody>
+                    <a:bodyPr/>
+                    <a:lstStyle/>
+                    <a:p>
+                      <a:pPr algn="r"/>
+                      <a:r>
+                        <a:rPr sz="1300" b="0">
+                          <a:solidFill>
+                            <a:srgbClr val="3C3C3B"/>
+                          </a:solidFill>
+                          <a:latin typeface="Aptos"/>
+                        </a:rPr>
+                        <a:t>7.1%</a:t>
+                      </a:r>
+                    </a:p>
+                  </a:txBody>
+                  <a:tcPr marL="73152" marR="73152" marT="27432" marB="27432" anchor="ctr">
+                    <a:noFill/>
+                  </a:tcPr>
+                </a:tc>
+                <a:tc>
+                  <a:txBody>
+                    <a:bodyPr/>
+                    <a:lstStyle/>
+                    <a:p>
+                      <a:pPr algn="r"/>
+                      <a:r>
+                        <a:rPr sz="1300" b="0">
+                          <a:solidFill>
+                            <a:srgbClr val="3C3C3B"/>
+                          </a:solidFill>
+                          <a:latin typeface="Aptos"/>
+                        </a:rPr>
+                        <a:t>11.3%</a:t>
+                      </a:r>
+                    </a:p>
+                  </a:txBody>
+                  <a:tcPr marL="73152" marR="73152" marT="27432" marB="27432" anchor="ctr">
+                    <a:noFill/>
+                  </a:tcPr>
+                </a:tc>
+                <a:tc>
+                  <a:txBody>
+                    <a:bodyPr/>
+                    <a:lstStyle/>
+                    <a:p>
+                      <a:pPr algn="r"/>
+                      <a:r>
+                        <a:rPr sz="1300" b="0">
+                          <a:solidFill>
+                            <a:srgbClr val="3C3C3B"/>
+                          </a:solidFill>
+                          <a:latin typeface="Aptos"/>
+                        </a:rPr>
+                        <a:t>1.82x</a:t>
+                      </a:r>
+                    </a:p>
+                  </a:txBody>
+                  <a:tcPr marL="73152" marR="73152" marT="27432" marB="27432" anchor="ctr">
+                    <a:noFill/>
+                  </a:tcPr>
+                </a:tc>
+                <a:tc>
+                  <a:txBody>
+                    <a:bodyPr/>
+                    <a:lstStyle/>
+                    <a:p>
+                      <a:pPr algn="r"/>
+                      <a:r>
+                        <a:rPr sz="1300" b="0">
+                          <a:solidFill>
+                            <a:srgbClr val="3C3C3B"/>
+                          </a:solidFill>
+                          <a:latin typeface="Aptos"/>
+                        </a:rPr>
+                        <a:t>1.78x</a:t>
                       </a:r>
                     </a:p>
                   </a:txBody>
@@ -21943,7 +23249,7 @@
                           </a:solidFill>
                           <a:latin typeface="Aptos"/>
                         </a:rPr>
-                        <a:t>Robin Hood 31%</a:t>
+                        <a:t>Tenor 10 years</a:t>
                       </a:r>
                     </a:p>
                   </a:txBody>
@@ -22029,48 +23335,6 @@
                           </a:solidFill>
                           <a:latin typeface="Aptos"/>
                         </a:rPr>
-                        <a:t>4.1%</a:t>
-                      </a:r>
-                    </a:p>
-                  </a:txBody>
-                  <a:tcPr marL="73152" marR="73152" marT="27432" marB="27432" anchor="ctr">
-                    <a:noFill/>
-                  </a:tcPr>
-                </a:tc>
-                <a:tc>
-                  <a:txBody>
-                    <a:bodyPr/>
-                    <a:lstStyle/>
-                    <a:p>
-                      <a:pPr algn="r"/>
-                      <a:r>
-                        <a:rPr sz="1300" b="0">
-                          <a:solidFill>
-                            <a:srgbClr val="3C3C3B"/>
-                          </a:solidFill>
-                          <a:latin typeface="Aptos"/>
-                        </a:rPr>
-                        <a:t>5.0%</a:t>
-                      </a:r>
-                    </a:p>
-                  </a:txBody>
-                  <a:tcPr marL="73152" marR="73152" marT="27432" marB="27432" anchor="ctr">
-                    <a:noFill/>
-                  </a:tcPr>
-                </a:tc>
-                <a:tc>
-                  <a:txBody>
-                    <a:bodyPr/>
-                    <a:lstStyle/>
-                    <a:p>
-                      <a:pPr algn="r"/>
-                      <a:r>
-                        <a:rPr sz="1300" b="0">
-                          <a:solidFill>
-                            <a:srgbClr val="3C3C3B"/>
-                          </a:solidFill>
-                          <a:latin typeface="Aptos"/>
-                        </a:rPr>
                         <a:t>5.6%</a:t>
                       </a:r>
                     </a:p>
@@ -22092,49 +23356,91 @@
                           </a:solidFill>
                           <a:latin typeface="Aptos"/>
                         </a:rPr>
-                        <a:t>8.9%</a:t>
-                      </a:r>
-                    </a:p>
-                  </a:txBody>
-                  <a:tcPr marL="73152" marR="73152" marT="27432" marB="27432" anchor="ctr">
-                    <a:noFill/>
-                  </a:tcPr>
-                </a:tc>
-                <a:tc>
-                  <a:txBody>
-                    <a:bodyPr/>
-                    <a:lstStyle/>
-                    <a:p>
-                      <a:pPr algn="r"/>
-                      <a:r>
-                        <a:rPr sz="1300" b="0">
-                          <a:solidFill>
-                            <a:srgbClr val="3C3C3B"/>
-                          </a:solidFill>
-                          <a:latin typeface="Aptos"/>
-                        </a:rPr>
-                        <a:t>1.67x</a:t>
-                      </a:r>
-                    </a:p>
-                  </a:txBody>
-                  <a:tcPr marL="73152" marR="73152" marT="27432" marB="27432" anchor="ctr">
-                    <a:noFill/>
-                  </a:tcPr>
-                </a:tc>
-                <a:tc>
-                  <a:txBody>
-                    <a:bodyPr/>
-                    <a:lstStyle/>
-                    <a:p>
-                      <a:pPr algn="r"/>
-                      <a:r>
-                        <a:rPr sz="1300" b="0">
-                          <a:solidFill>
-                            <a:srgbClr val="3C3C3B"/>
-                          </a:solidFill>
-                          <a:latin typeface="Aptos"/>
-                        </a:rPr>
-                        <a:t>1.54x</a:t>
+                        <a:t>6.9%</a:t>
+                      </a:r>
+                    </a:p>
+                  </a:txBody>
+                  <a:tcPr marL="73152" marR="73152" marT="27432" marB="27432" anchor="ctr">
+                    <a:noFill/>
+                  </a:tcPr>
+                </a:tc>
+                <a:tc>
+                  <a:txBody>
+                    <a:bodyPr/>
+                    <a:lstStyle/>
+                    <a:p>
+                      <a:pPr algn="r"/>
+                      <a:r>
+                        <a:rPr sz="1300" b="0">
+                          <a:solidFill>
+                            <a:srgbClr val="3C3C3B"/>
+                          </a:solidFill>
+                          <a:latin typeface="Aptos"/>
+                        </a:rPr>
+                        <a:t>7.2%</a:t>
+                      </a:r>
+                    </a:p>
+                  </a:txBody>
+                  <a:tcPr marL="73152" marR="73152" marT="27432" marB="27432" anchor="ctr">
+                    <a:noFill/>
+                  </a:tcPr>
+                </a:tc>
+                <a:tc>
+                  <a:txBody>
+                    <a:bodyPr/>
+                    <a:lstStyle/>
+                    <a:p>
+                      <a:pPr algn="r"/>
+                      <a:r>
+                        <a:rPr sz="1300" b="0">
+                          <a:solidFill>
+                            <a:srgbClr val="3C3C3B"/>
+                          </a:solidFill>
+                          <a:latin typeface="Aptos"/>
+                        </a:rPr>
+                        <a:t>11.0%</a:t>
+                      </a:r>
+                    </a:p>
+                  </a:txBody>
+                  <a:tcPr marL="73152" marR="73152" marT="27432" marB="27432" anchor="ctr">
+                    <a:noFill/>
+                  </a:tcPr>
+                </a:tc>
+                <a:tc>
+                  <a:txBody>
+                    <a:bodyPr/>
+                    <a:lstStyle/>
+                    <a:p>
+                      <a:pPr algn="r"/>
+                      <a:r>
+                        <a:rPr sz="1300" b="0">
+                          <a:solidFill>
+                            <a:srgbClr val="3C3C3B"/>
+                          </a:solidFill>
+                          <a:latin typeface="Aptos"/>
+                        </a:rPr>
+                        <a:t>1.44x</a:t>
+                      </a:r>
+                    </a:p>
+                  </a:txBody>
+                  <a:tcPr marL="73152" marR="73152" marT="27432" marB="27432" anchor="ctr">
+                    <a:noFill/>
+                  </a:tcPr>
+                </a:tc>
+                <a:tc>
+                  <a:txBody>
+                    <a:bodyPr/>
+                    <a:lstStyle/>
+                    <a:p>
+                      <a:pPr algn="r"/>
+                      <a:r>
+                        <a:rPr sz="1300" b="0">
+                          <a:solidFill>
+                            <a:srgbClr val="3C3C3B"/>
+                          </a:solidFill>
+                          <a:latin typeface="Aptos"/>
+                        </a:rPr>
+                        <a:t>1.40x</a:t>
                       </a:r>
                     </a:p>
                   </a:txBody>
@@ -22157,7 +23463,7 @@
                           </a:solidFill>
                           <a:latin typeface="Aptos"/>
                         </a:rPr>
-                        <a:t>CIT 9%</a:t>
+                        <a:t>Robin Hood 31%</a:t>
                       </a:r>
                     </a:p>
                   </a:txBody>
@@ -22243,112 +23549,112 @@
                           </a:solidFill>
                           <a:latin typeface="Aptos"/>
                         </a:rPr>
-                        <a:t>5.9%</a:t>
-                      </a:r>
-                    </a:p>
-                  </a:txBody>
-                  <a:tcPr marL="73152" marR="73152" marT="27432" marB="27432" anchor="ctr">
-                    <a:noFill/>
-                  </a:tcPr>
-                </a:tc>
-                <a:tc>
-                  <a:txBody>
-                    <a:bodyPr/>
-                    <a:lstStyle/>
-                    <a:p>
-                      <a:pPr algn="r"/>
-                      <a:r>
-                        <a:rPr sz="1300" b="0">
-                          <a:solidFill>
-                            <a:srgbClr val="3C3C3B"/>
-                          </a:solidFill>
-                          <a:latin typeface="Aptos"/>
-                        </a:rPr>
-                        <a:t>7.3%</a:t>
-                      </a:r>
-                    </a:p>
-                  </a:txBody>
-                  <a:tcPr marL="73152" marR="73152" marT="27432" marB="27432" anchor="ctr">
-                    <a:noFill/>
-                  </a:tcPr>
-                </a:tc>
-                <a:tc>
-                  <a:txBody>
-                    <a:bodyPr/>
-                    <a:lstStyle/>
-                    <a:p>
-                      <a:pPr algn="r"/>
-                      <a:r>
-                        <a:rPr sz="1300" b="0">
-                          <a:solidFill>
-                            <a:srgbClr val="3C3C3B"/>
-                          </a:solidFill>
-                          <a:latin typeface="Aptos"/>
-                        </a:rPr>
-                        <a:t>7.7%</a:t>
-                      </a:r>
-                    </a:p>
-                  </a:txBody>
-                  <a:tcPr marL="73152" marR="73152" marT="27432" marB="27432" anchor="ctr">
-                    <a:noFill/>
-                  </a:tcPr>
-                </a:tc>
-                <a:tc>
-                  <a:txBody>
-                    <a:bodyPr/>
-                    <a:lstStyle/>
-                    <a:p>
-                      <a:pPr algn="r"/>
-                      <a:r>
-                        <a:rPr sz="1300" b="0">
-                          <a:solidFill>
-                            <a:srgbClr val="3C3C3B"/>
-                          </a:solidFill>
-                          <a:latin typeface="Aptos"/>
-                        </a:rPr>
-                        <a:t>12.3%</a:t>
-                      </a:r>
-                    </a:p>
-                  </a:txBody>
-                  <a:tcPr marL="73152" marR="73152" marT="27432" marB="27432" anchor="ctr">
-                    <a:noFill/>
-                  </a:tcPr>
-                </a:tc>
-                <a:tc>
-                  <a:txBody>
-                    <a:bodyPr/>
-                    <a:lstStyle/>
-                    <a:p>
-                      <a:pPr algn="r"/>
-                      <a:r>
-                        <a:rPr sz="1300" b="0">
-                          <a:solidFill>
-                            <a:srgbClr val="3C3C3B"/>
-                          </a:solidFill>
-                          <a:latin typeface="Aptos"/>
-                        </a:rPr>
-                        <a:t>1.96x</a:t>
-                      </a:r>
-                    </a:p>
-                  </a:txBody>
-                  <a:tcPr marL="73152" marR="73152" marT="27432" marB="27432" anchor="ctr">
-                    <a:noFill/>
-                  </a:tcPr>
-                </a:tc>
-                <a:tc>
-                  <a:txBody>
-                    <a:bodyPr/>
-                    <a:lstStyle/>
-                    <a:p>
-                      <a:pPr algn="r"/>
-                      <a:r>
-                        <a:rPr sz="1300" b="0">
-                          <a:solidFill>
-                            <a:srgbClr val="3C3C3B"/>
-                          </a:solidFill>
-                          <a:latin typeface="Aptos"/>
-                        </a:rPr>
-                        <a:t>1.93x</a:t>
+                        <a:t>4.1%</a:t>
+                      </a:r>
+                    </a:p>
+                  </a:txBody>
+                  <a:tcPr marL="73152" marR="73152" marT="27432" marB="27432" anchor="ctr">
+                    <a:noFill/>
+                  </a:tcPr>
+                </a:tc>
+                <a:tc>
+                  <a:txBody>
+                    <a:bodyPr/>
+                    <a:lstStyle/>
+                    <a:p>
+                      <a:pPr algn="r"/>
+                      <a:r>
+                        <a:rPr sz="1300" b="0">
+                          <a:solidFill>
+                            <a:srgbClr val="3C3C3B"/>
+                          </a:solidFill>
+                          <a:latin typeface="Aptos"/>
+                        </a:rPr>
+                        <a:t>5.0%</a:t>
+                      </a:r>
+                    </a:p>
+                  </a:txBody>
+                  <a:tcPr marL="73152" marR="73152" marT="27432" marB="27432" anchor="ctr">
+                    <a:noFill/>
+                  </a:tcPr>
+                </a:tc>
+                <a:tc>
+                  <a:txBody>
+                    <a:bodyPr/>
+                    <a:lstStyle/>
+                    <a:p>
+                      <a:pPr algn="r"/>
+                      <a:r>
+                        <a:rPr sz="1300" b="0">
+                          <a:solidFill>
+                            <a:srgbClr val="3C3C3B"/>
+                          </a:solidFill>
+                          <a:latin typeface="Aptos"/>
+                        </a:rPr>
+                        <a:t>5.6%</a:t>
+                      </a:r>
+                    </a:p>
+                  </a:txBody>
+                  <a:tcPr marL="73152" marR="73152" marT="27432" marB="27432" anchor="ctr">
+                    <a:noFill/>
+                  </a:tcPr>
+                </a:tc>
+                <a:tc>
+                  <a:txBody>
+                    <a:bodyPr/>
+                    <a:lstStyle/>
+                    <a:p>
+                      <a:pPr algn="r"/>
+                      <a:r>
+                        <a:rPr sz="1300" b="0">
+                          <a:solidFill>
+                            <a:srgbClr val="3C3C3B"/>
+                          </a:solidFill>
+                          <a:latin typeface="Aptos"/>
+                        </a:rPr>
+                        <a:t>8.9%</a:t>
+                      </a:r>
+                    </a:p>
+                  </a:txBody>
+                  <a:tcPr marL="73152" marR="73152" marT="27432" marB="27432" anchor="ctr">
+                    <a:noFill/>
+                  </a:tcPr>
+                </a:tc>
+                <a:tc>
+                  <a:txBody>
+                    <a:bodyPr/>
+                    <a:lstStyle/>
+                    <a:p>
+                      <a:pPr algn="r"/>
+                      <a:r>
+                        <a:rPr sz="1300" b="0">
+                          <a:solidFill>
+                            <a:srgbClr val="3C3C3B"/>
+                          </a:solidFill>
+                          <a:latin typeface="Aptos"/>
+                        </a:rPr>
+                        <a:t>1.67x</a:t>
+                      </a:r>
+                    </a:p>
+                  </a:txBody>
+                  <a:tcPr marL="73152" marR="73152" marT="27432" marB="27432" anchor="ctr">
+                    <a:noFill/>
+                  </a:tcPr>
+                </a:tc>
+                <a:tc>
+                  <a:txBody>
+                    <a:bodyPr/>
+                    <a:lstStyle/>
+                    <a:p>
+                      <a:pPr algn="r"/>
+                      <a:r>
+                        <a:rPr sz="1300" b="0">
+                          <a:solidFill>
+                            <a:srgbClr val="3C3C3B"/>
+                          </a:solidFill>
+                          <a:latin typeface="Aptos"/>
+                        </a:rPr>
+                        <a:t>1.54x</a:t>
                       </a:r>
                     </a:p>
                   </a:txBody>
@@ -22371,7 +23677,7 @@
                           </a:solidFill>
                           <a:latin typeface="Aptos"/>
                         </a:rPr>
-                        <a:t>UniCredit terms</a:t>
+                        <a:t>CIT 9%</a:t>
                       </a:r>
                     </a:p>
                   </a:txBody>
@@ -22457,28 +23763,7 @@
                           </a:solidFill>
                           <a:latin typeface="Aptos"/>
                         </a:rPr>
-                        <a:t>5.6%</a:t>
-                      </a:r>
-                    </a:p>
-                  </a:txBody>
-                  <a:tcPr marL="73152" marR="73152" marT="27432" marB="27432" anchor="ctr">
-                    <a:noFill/>
-                  </a:tcPr>
-                </a:tc>
-                <a:tc>
-                  <a:txBody>
-                    <a:bodyPr/>
-                    <a:lstStyle/>
-                    <a:p>
-                      <a:pPr algn="r"/>
-                      <a:r>
-                        <a:rPr sz="1300" b="0">
-                          <a:solidFill>
-                            <a:srgbClr val="3C3C3B"/>
-                          </a:solidFill>
-                          <a:latin typeface="Aptos"/>
-                        </a:rPr>
-                        <a:t>7.0%</a:t>
+                        <a:t>5.9%</a:t>
                       </a:r>
                     </a:p>
                   </a:txBody>
@@ -22520,49 +23805,70 @@
                           </a:solidFill>
                           <a:latin typeface="Aptos"/>
                         </a:rPr>
-                        <a:t>11.3%</a:t>
-                      </a:r>
-                    </a:p>
-                  </a:txBody>
-                  <a:tcPr marL="73152" marR="73152" marT="27432" marB="27432" anchor="ctr">
-                    <a:noFill/>
-                  </a:tcPr>
-                </a:tc>
-                <a:tc>
-                  <a:txBody>
-                    <a:bodyPr/>
-                    <a:lstStyle/>
-                    <a:p>
-                      <a:pPr algn="r"/>
-                      <a:r>
-                        <a:rPr sz="1300" b="0">
-                          <a:solidFill>
-                            <a:srgbClr val="3C3C3B"/>
-                          </a:solidFill>
-                          <a:latin typeface="Aptos"/>
-                        </a:rPr>
-                        <a:t>1.65x</a:t>
-                      </a:r>
-                    </a:p>
-                  </a:txBody>
-                  <a:tcPr marL="73152" marR="73152" marT="27432" marB="27432" anchor="ctr">
-                    <a:noFill/>
-                  </a:tcPr>
-                </a:tc>
-                <a:tc>
-                  <a:txBody>
-                    <a:bodyPr/>
-                    <a:lstStyle/>
-                    <a:p>
-                      <a:pPr algn="r"/>
-                      <a:r>
-                        <a:rPr sz="1300" b="0">
-                          <a:solidFill>
-                            <a:srgbClr val="3C3C3B"/>
-                          </a:solidFill>
-                          <a:latin typeface="Aptos"/>
-                        </a:rPr>
-                        <a:t>1.61x</a:t>
+                        <a:t>7.7%</a:t>
+                      </a:r>
+                    </a:p>
+                  </a:txBody>
+                  <a:tcPr marL="73152" marR="73152" marT="27432" marB="27432" anchor="ctr">
+                    <a:noFill/>
+                  </a:tcPr>
+                </a:tc>
+                <a:tc>
+                  <a:txBody>
+                    <a:bodyPr/>
+                    <a:lstStyle/>
+                    <a:p>
+                      <a:pPr algn="r"/>
+                      <a:r>
+                        <a:rPr sz="1300" b="0">
+                          <a:solidFill>
+                            <a:srgbClr val="3C3C3B"/>
+                          </a:solidFill>
+                          <a:latin typeface="Aptos"/>
+                        </a:rPr>
+                        <a:t>12.3%</a:t>
+                      </a:r>
+                    </a:p>
+                  </a:txBody>
+                  <a:tcPr marL="73152" marR="73152" marT="27432" marB="27432" anchor="ctr">
+                    <a:noFill/>
+                  </a:tcPr>
+                </a:tc>
+                <a:tc>
+                  <a:txBody>
+                    <a:bodyPr/>
+                    <a:lstStyle/>
+                    <a:p>
+                      <a:pPr algn="r"/>
+                      <a:r>
+                        <a:rPr sz="1300" b="0">
+                          <a:solidFill>
+                            <a:srgbClr val="3C3C3B"/>
+                          </a:solidFill>
+                          <a:latin typeface="Aptos"/>
+                        </a:rPr>
+                        <a:t>1.96x</a:t>
+                      </a:r>
+                    </a:p>
+                  </a:txBody>
+                  <a:tcPr marL="73152" marR="73152" marT="27432" marB="27432" anchor="ctr">
+                    <a:noFill/>
+                  </a:tcPr>
+                </a:tc>
+                <a:tc>
+                  <a:txBody>
+                    <a:bodyPr/>
+                    <a:lstStyle/>
+                    <a:p>
+                      <a:pPr algn="r"/>
+                      <a:r>
+                        <a:rPr sz="1300" b="0">
+                          <a:solidFill>
+                            <a:srgbClr val="3C3C3B"/>
+                          </a:solidFill>
+                          <a:latin typeface="Aptos"/>
+                        </a:rPr>
+                        <a:t>1.93x</a:t>
                       </a:r>
                     </a:p>
                   </a:txBody>
@@ -23406,7 +24712,7 @@
                 </a:solidFill>
                 <a:latin typeface="Aptos"/>
               </a:rPr>
-              <a:t>Bank terms: </a:t>
+              <a:t>Cash sweep: </a:t>
             </a:r>
             <a:r>
               <a:rPr sz="1300" b="0">
@@ -23415,7 +24721,7 @@
                 </a:solidFill>
                 <a:latin typeface="Aptos"/>
               </a:rPr>
-              <a:t>on the stricter terms (1.30x DSCR, 12-year annuity) debt is €49.5m / €49.5m and the hold IRR 7.3% / 11.3%; a full cash sweep gives 7.0% / 10.4%.</a:t>
+              <a:t>Raiffeisen asks for a significant one, up to full; a full sweep cuts the hold IRR to 7.0% / 10.4%.</a:t>
             </a:r>
           </a:p>
         </p:txBody>
@@ -23449,7 +24755,7 @@
                 </a:solidFill>
                 <a:latin typeface="Aptos"/>
               </a:rPr>
-              <a:t>Each set changes only the inputs its name describes; tenor 10 years. Stored by the scenario macro with the tax solver; base = live model. Model checks in every set: all pass.</a:t>
+              <a:t>Each set changes only the inputs its name describes, from the Raiffeisen base; tenor 10 years. Stored by the scenario macro with the tax solver; base = live model. Model checks in every set: all pass.</a:t>
             </a:r>
           </a:p>
           <a:p>

</xml_diff>

<commit_message>
Fix Bana deck audit findings: bind the sanction lag, drop Bora reference, clarify the sensitivity base
Co-Authored-By: Claude Opus 5.5 <noreply@anthropic.com>
Claude-Session: https://claude.ai/code/session_01AWS1t9WtpkQHcCU1WceGZT
</commit_message>
<xml_diff>
--- a/projects/bana/out/Bana_IC.pptx
+++ b/projects/bana/out/Bana_IC.pptx
@@ -12489,7 +12489,7 @@
                 </a:solidFill>
                 <a:latin typeface="Aptos"/>
               </a:rPr>
-              <a:t>Points are the model's own score on the MEKH 2026 bands (Kiírás Annex 3-4). ÖSZ-4 is scored on net MVA (as Bora); BESS at capex only, no revenue or opex, not in the COD price. Brownfield (ÖSZ-7) is not available. Build shortfall 8.3% against the commitment, inside the 10% tolerance (GYIK 28/30). The municipal one-off is paid at COD.</a:t>
+              <a:t>Points are the model's own score on the MEKH 2026 bands (Kiírás Annex 3-4). ÖSZ-4 is scored on net MVA; BESS at capex only, no revenue or opex, not in the COD price. Brownfield (ÖSZ-7) is not available. Build shortfall 8.3% against the commitment, inside the 10% tolerance (GYIK 28/30). The municipal one-off is paid at COD.</a:t>
             </a:r>
           </a:p>
           <a:p>
@@ -24755,7 +24755,7 @@
                 </a:solidFill>
                 <a:latin typeface="Aptos"/>
               </a:rPr>
-              <a:t>Each set changes only the inputs its name describes, from the Raiffeisen base; tenor 10 years. Stored by the scenario macro with the tax solver; base = live model. Model checks in every set: all pass.</a:t>
+              <a:t>Each set changes only the inputs its name describes, from the Raiffeisen base (15-year tenor). Stored by the scenario macro with the tax solver; base = live model. Model checks in every set: all pass.</a:t>
             </a:r>
           </a:p>
           <a:p>

</xml_diff>

<commit_message>
Date the Bana model 15-Oct-2026 and write dated copies of the model and deck
Co-Authored-By: Claude Opus 5.5 <noreply@anthropic.com>
Claude-Session: https://claude.ai/code/session_01AWS1t9WtpkQHcCU1WceGZT
</commit_message>
<xml_diff>
--- a/projects/bana/out/Bana_IC.pptx
+++ b/projects/bana/out/Bana_IC.pptx
@@ -6020,7 +6020,7 @@
                 <a:latin typeface="Aptos"/>
                 <a:cs typeface="Aptos"/>
               </a:rPr>
-              <a:t>14 October 2026</a:t>
+              <a:t>15 October 2026</a:t>
             </a:r>
             <a:endParaRPr lang="en-GB" sz="4950" spc="-10" noProof="0" dirty="0">
               <a:solidFill>
@@ -8569,7 +8569,7 @@
                 </a:solidFill>
                 <a:latin typeface="Aptos"/>
               </a:rPr>
-              <a:t>Source: Bana_Model.xlsm, 14 Oct 2026.</a:t>
+              <a:t>Source: Bana_Model_20261015.xlsm, 15 Oct 2026.</a:t>
             </a:r>
           </a:p>
         </p:txBody>
@@ -12500,7 +12500,7 @@
                 </a:solidFill>
                 <a:latin typeface="Aptos"/>
               </a:rPr>
-              <a:t>Source: Bana_Model.xlsm, 14 Oct 2026.</a:t>
+              <a:t>Source: Bana_Model_20261015.xlsm, 15 Oct 2026.</a:t>
             </a:r>
           </a:p>
         </p:txBody>
@@ -14881,7 +14881,7 @@
                 </a:solidFill>
                 <a:latin typeface="Aptos"/>
               </a:rPr>
-              <a:t>Source: Bana_Model.xlsm, 14 Oct 2026.</a:t>
+              <a:t>Source: Bana_Model_20261015.xlsm, 15 Oct 2026.</a:t>
             </a:r>
           </a:p>
         </p:txBody>
@@ -17822,7 +17822,7 @@
                 </a:solidFill>
                 <a:latin typeface="Aptos"/>
               </a:rPr>
-              <a:t>Source: Bana_Model.xlsm, 14 Oct 2026.</a:t>
+              <a:t>Source: Bana_Model_20261015.xlsm, 15 Oct 2026.</a:t>
             </a:r>
           </a:p>
         </p:txBody>
@@ -19168,7 +19168,7 @@
                 </a:solidFill>
                 <a:latin typeface="Aptos"/>
               </a:rPr>
-              <a:t>Source: Bana_Model.xlsm, 14 Oct 2026.</a:t>
+              <a:t>Source: Bana_Model_20261015.xlsm, 15 Oct 2026.</a:t>
             </a:r>
           </a:p>
         </p:txBody>
@@ -20542,7 +20542,7 @@
                 </a:solidFill>
                 <a:latin typeface="Aptos"/>
               </a:rPr>
-              <a:t>Source: Bana_Model.xlsm, 14 Oct 2026.</a:t>
+              <a:t>Source: Bana_Model_20261015.xlsm, 15 Oct 2026.</a:t>
             </a:r>
           </a:p>
         </p:txBody>
@@ -24766,7 +24766,7 @@
                 </a:solidFill>
                 <a:latin typeface="Aptos"/>
               </a:rPr>
-              <a:t>Source: Bana_Model.xlsm, 14 Oct 2026.</a:t>
+              <a:t>Source: Bana_Model_20261015.xlsm, 15 Oct 2026.</a:t>
             </a:r>
           </a:p>
         </p:txBody>

</xml_diff>

<commit_message>
Bana: bind slide 6 figures, refresh reconciliation for the 55 % base
Co-Authored-By: Claude Opus 5.5 <noreply@anthropic.com>
Claude-Session: https://claude.ai/code/session_01AWS1t9WtpkQHcCU1WceGZT
</commit_message>
<xml_diff>
--- a/projects/bana/out/Bana_IC.pptx
+++ b/projects/bana/out/Bana_IC.pptx
@@ -19320,7 +19320,7 @@
                 </a:solidFill>
                 <a:latin typeface="Aptos"/>
               </a:rPr>
-              <a:t>Two bank meetings on the 50 MW wind + 10 MW BESS project; both indicative and verbal, with no commitment. The base case keeps 55 % gearing.</a:t>
+              <a:t>Two bank meetings on the 50 MW wind + 10 MW BESS project; both indicative and verbal, with no commitment. The base case keeps 55% gearing.</a:t>
             </a:r>
           </a:p>
         </p:txBody>
@@ -20713,7 +20713,7 @@
                 </a:solidFill>
                 <a:latin typeface="Aptos"/>
               </a:rPr>
-              <a:t>Bank terms as reported in the FEP notes of the Raiffeisen and UniCredit meetings (October 2026). *UniCredit gave no amount: Raiffeisen's quantum scaled to its tenor and DSCR. Bank cases: 70 % LTC cap, same 5 % rate; stored key-assumption sets.</a:t>
+              <a:t>Bank terms as reported in the FEP notes of the Raiffeisen and UniCredit meetings (October 2026). *UniCredit gave no amount: Raiffeisen's quantum scaled to its tenor and DSCR. Bank cases: 70% LTC cap, same 5.0% rate; stored key-assumption sets.</a:t>
             </a:r>
           </a:p>
           <a:p>

</xml_diff>

<commit_message>
Bana: upside cases (2,850 h, zero bid, PPA 100/105, 60 % gearing) and slide; allow 18 key-assumption sets
Co-Authored-By: Claude Opus 5.5 <noreply@anthropic.com>
Claude-Session: https://claude.ai/code/session_01AWS1t9WtpkQHcCU1WceGZT
</commit_message>
<xml_diff>
--- a/projects/bana/out/Bana_IC.pptx
+++ b/projects/bana/out/Bana_IC.pptx
@@ -22,6 +22,7 @@
     <p:sldId id="264" r:id="rId21"/>
     <p:sldId id="265" r:id="rId22"/>
     <p:sldId id="266" r:id="rId23"/>
+    <p:sldId id="267" r:id="rId24"/>
   </p:sldIdLst>
   <p:sldSz cx="20105688" cy="11310938"/>
   <p:notesSz cx="6858000" cy="9144000"/>
@@ -5921,7 +5922,7 @@
                 <a:latin typeface="Aptos"/>
                 <a:cs typeface="Aptos"/>
               </a:rPr>
-              <a:t>15 October 2026</a:t>
+              <a:t>18 October 2026</a:t>
             </a:r>
             <a:endParaRPr lang="en-GB" sz="4950" spc="-10" noProof="0" dirty="0">
               <a:solidFill>
@@ -6033,6 +6034,2501 @@
           <a:lstStyle/>
           <a:p>
             <a:r>
+              <a:t>With 2,850 h, a zero bid and a 100 / 105 €/MWh PPA, the hold IRR rises to 11.9% / 12.9% (European) from 7.6%</a:t>
+            </a:r>
+          </a:p>
+        </p:txBody>
+      </p:sp>
+      <p:sp>
+        <p:nvSpPr>
+          <p:cNvPr id="2" name="Slide Number Placeholder 1">
+            <a:extLst>
+              <a:ext uri="{FF2B5EF4-FFF2-40B4-BE49-F238E27FC236}">
+                <a16:creationId xmlns:a16="http://schemas.microsoft.com/office/drawing/2014/main" id="{88576B7A-1C0F-D2A3-8BE9-18F63D64C454}"/>
+              </a:ext>
+            </a:extLst>
+          </p:cNvPr>
+          <p:cNvSpPr>
+            <a:spLocks noGrp="1"/>
+          </p:cNvSpPr>
+          <p:nvPr>
+            <p:ph type="sldNum" sz="quarter" idx="4"/>
+          </p:nvPr>
+        </p:nvSpPr>
+        <p:spPr>
+          <a:xfrm>
+            <a:off x="14200188" y="10483850"/>
+            <a:ext cx="4522787" cy="601663"/>
+          </a:xfrm>
+          <a:prstGeom prst="rect">
+            <a:avLst/>
+          </a:prstGeom>
+        </p:spPr>
+        <p:txBody>
+          <a:bodyPr vert="horz" lIns="91440" tIns="45720" rIns="91440" bIns="45720" rtlCol="0" anchor="ctr"/>
+          <a:lstStyle>
+            <a:lvl1pPr algn="r">
+              <a:defRPr sz="1200">
+                <a:solidFill>
+                  <a:schemeClr val="tx1">
+                    <a:tint val="82000"/>
+                  </a:schemeClr>
+                </a:solidFill>
+              </a:defRPr>
+            </a:lvl1pPr>
+          </a:lstStyle>
+          <a:p>
+            <a:fld id="{52EEA166-2877-4493-9FAA-8D6952A82FC3}" type="slidenum">
+              <a:rPr lang="en-GB" smtClean="0"/>
+              <a:t>‹#›</a:t>
+            </a:fld>
+            <a:endParaRPr lang="en-GB"/>
+          </a:p>
+        </p:txBody>
+      </p:sp>
+      <p:graphicFrame>
+        <p:nvGraphicFramePr>
+          <p:cNvPr id="3" name="Navigator"/>
+          <p:cNvGraphicFramePr>
+            <a:graphicFrameLocks noGrp="1"/>
+          </p:cNvGraphicFramePr>
+          <p:nvPr/>
+        </p:nvGraphicFramePr>
+        <p:xfrm>
+          <a:off x="0" y="0"/>
+          <a:ext cx="3767328" cy="7772400"/>
+        </p:xfrm>
+        <a:graphic>
+          <a:graphicData uri="http://schemas.openxmlformats.org/drawingml/2006/table">
+            <a:tbl>
+              <a:tblPr>
+                <a:tableStyleId>{5C22544A-7EE6-4342-B048-85BDC9FD1C3A}</a:tableStyleId>
+              </a:tblPr>
+              <a:tblGrid>
+                <a:gridCol w="3767328"/>
+              </a:tblGrid>
+              <a:tr h="777240">
+                <a:tc>
+                  <a:txBody>
+                    <a:bodyPr/>
+                    <a:lstStyle/>
+                    <a:p>
+                      <a:r>
+                        <a:rPr sz="1800" b="0">
+                          <a:solidFill>
+                            <a:srgbClr val="3C3C3B"/>
+                          </a:solidFill>
+                          <a:latin typeface="Aptos"/>
+                        </a:rPr>
+                        <a:t>Executive summary</a:t>
+                      </a:r>
+                    </a:p>
+                  </a:txBody>
+                  <a:tcPr marL="180000" anchor="ctr">
+                    <a:lnL>
+                      <a:noFill/>
+                    </a:lnL>
+                    <a:lnR>
+                      <a:noFill/>
+                    </a:lnR>
+                    <a:lnT w="6350">
+                      <a:solidFill>
+                        <a:srgbClr val="3C3C3B"/>
+                      </a:solidFill>
+                    </a:lnT>
+                    <a:lnB w="6350">
+                      <a:solidFill>
+                        <a:srgbClr val="3C3C3B"/>
+                      </a:solidFill>
+                    </a:lnB>
+                    <a:noFill/>
+                  </a:tcPr>
+                </a:tc>
+              </a:tr>
+              <a:tr h="777240">
+                <a:tc>
+                  <a:txBody>
+                    <a:bodyPr/>
+                    <a:lstStyle/>
+                    <a:p>
+                      <a:r>
+                        <a:rPr sz="1800" b="0">
+                          <a:solidFill>
+                            <a:srgbClr val="3C3C3B"/>
+                          </a:solidFill>
+                          <a:latin typeface="Aptos"/>
+                        </a:rPr>
+                        <a:t>Risks and mitigants</a:t>
+                      </a:r>
+                    </a:p>
+                  </a:txBody>
+                  <a:tcPr marL="180000" anchor="ctr">
+                    <a:lnL>
+                      <a:noFill/>
+                    </a:lnL>
+                    <a:lnR>
+                      <a:noFill/>
+                    </a:lnR>
+                    <a:lnT w="6350">
+                      <a:solidFill>
+                        <a:srgbClr val="3C3C3B"/>
+                      </a:solidFill>
+                    </a:lnT>
+                    <a:lnB w="6350">
+                      <a:solidFill>
+                        <a:srgbClr val="3C3C3B"/>
+                      </a:solidFill>
+                    </a:lnB>
+                    <a:noFill/>
+                  </a:tcPr>
+                </a:tc>
+              </a:tr>
+              <a:tr h="777240">
+                <a:tc>
+                  <a:txBody>
+                    <a:bodyPr/>
+                    <a:lstStyle/>
+                    <a:p>
+                      <a:r>
+                        <a:rPr sz="1800" b="0">
+                          <a:solidFill>
+                            <a:srgbClr val="3C3C3B"/>
+                          </a:solidFill>
+                          <a:latin typeface="Aptos"/>
+                        </a:rPr>
+                        <a:t>Technical overview and tender bid</a:t>
+                      </a:r>
+                    </a:p>
+                  </a:txBody>
+                  <a:tcPr marL="180000" anchor="ctr">
+                    <a:lnL>
+                      <a:noFill/>
+                    </a:lnL>
+                    <a:lnR>
+                      <a:noFill/>
+                    </a:lnR>
+                    <a:lnT w="6350">
+                      <a:solidFill>
+                        <a:srgbClr val="3C3C3B"/>
+                      </a:solidFill>
+                    </a:lnT>
+                    <a:lnB w="6350">
+                      <a:solidFill>
+                        <a:srgbClr val="3C3C3B"/>
+                      </a:solidFill>
+                    </a:lnB>
+                    <a:noFill/>
+                  </a:tcPr>
+                </a:tc>
+              </a:tr>
+              <a:tr h="777240">
+                <a:tc>
+                  <a:txBody>
+                    <a:bodyPr/>
+                    <a:lstStyle/>
+                    <a:p>
+                      <a:r>
+                        <a:rPr sz="1800" b="0">
+                          <a:solidFill>
+                            <a:srgbClr val="3C3C3B"/>
+                          </a:solidFill>
+                          <a:latin typeface="Aptos"/>
+                        </a:rPr>
+                        <a:t>Funding to COD</a:t>
+                      </a:r>
+                    </a:p>
+                  </a:txBody>
+                  <a:tcPr marL="180000" anchor="ctr">
+                    <a:lnL>
+                      <a:noFill/>
+                    </a:lnL>
+                    <a:lnR>
+                      <a:noFill/>
+                    </a:lnR>
+                    <a:lnT w="6350">
+                      <a:solidFill>
+                        <a:srgbClr val="3C3C3B"/>
+                      </a:solidFill>
+                    </a:lnT>
+                    <a:lnB w="6350">
+                      <a:solidFill>
+                        <a:srgbClr val="3C3C3B"/>
+                      </a:solidFill>
+                    </a:lnB>
+                    <a:noFill/>
+                  </a:tcPr>
+                </a:tc>
+              </a:tr>
+              <a:tr h="777240">
+                <a:tc>
+                  <a:txBody>
+                    <a:bodyPr/>
+                    <a:lstStyle/>
+                    <a:p>
+                      <a:r>
+                        <a:rPr sz="1800" b="0">
+                          <a:solidFill>
+                            <a:srgbClr val="3C3C3B"/>
+                          </a:solidFill>
+                          <a:latin typeface="Aptos"/>
+                        </a:rPr>
+                        <a:t>Bank feedback</a:t>
+                      </a:r>
+                    </a:p>
+                  </a:txBody>
+                  <a:tcPr marL="180000" anchor="ctr">
+                    <a:lnL>
+                      <a:noFill/>
+                    </a:lnL>
+                    <a:lnR>
+                      <a:noFill/>
+                    </a:lnR>
+                    <a:lnT w="6350">
+                      <a:solidFill>
+                        <a:srgbClr val="3C3C3B"/>
+                      </a:solidFill>
+                    </a:lnT>
+                    <a:lnB w="6350">
+                      <a:solidFill>
+                        <a:srgbClr val="3C3C3B"/>
+                      </a:solidFill>
+                    </a:lnB>
+                    <a:noFill/>
+                  </a:tcPr>
+                </a:tc>
+              </a:tr>
+              <a:tr h="777240">
+                <a:tc>
+                  <a:txBody>
+                    <a:bodyPr/>
+                    <a:lstStyle/>
+                    <a:p>
+                      <a:r>
+                        <a:rPr sz="1800" b="0">
+                          <a:solidFill>
+                            <a:srgbClr val="3C3C3B"/>
+                          </a:solidFill>
+                          <a:latin typeface="Aptos"/>
+                        </a:rPr>
+                        <a:t>Returns: sale at COD vs hold</a:t>
+                      </a:r>
+                    </a:p>
+                  </a:txBody>
+                  <a:tcPr marL="180000" anchor="ctr">
+                    <a:lnL>
+                      <a:noFill/>
+                    </a:lnL>
+                    <a:lnR>
+                      <a:noFill/>
+                    </a:lnR>
+                    <a:lnT w="6350">
+                      <a:solidFill>
+                        <a:srgbClr val="3C3C3B"/>
+                      </a:solidFill>
+                    </a:lnT>
+                    <a:lnB w="6350">
+                      <a:solidFill>
+                        <a:srgbClr val="3C3C3B"/>
+                      </a:solidFill>
+                    </a:lnB>
+                    <a:noFill/>
+                  </a:tcPr>
+                </a:tc>
+              </a:tr>
+              <a:tr h="777240">
+                <a:tc>
+                  <a:txBody>
+                    <a:bodyPr/>
+                    <a:lstStyle/>
+                    <a:p>
+                      <a:r>
+                        <a:rPr sz="1800" b="0">
+                          <a:solidFill>
+                            <a:srgbClr val="3C3C3B"/>
+                          </a:solidFill>
+                          <a:latin typeface="Aptos"/>
+                        </a:rPr>
+                        <a:t>Sale price and buyer return</a:t>
+                      </a:r>
+                    </a:p>
+                  </a:txBody>
+                  <a:tcPr marL="180000" anchor="ctr">
+                    <a:lnL>
+                      <a:noFill/>
+                    </a:lnL>
+                    <a:lnR>
+                      <a:noFill/>
+                    </a:lnR>
+                    <a:lnT w="6350">
+                      <a:solidFill>
+                        <a:srgbClr val="3C3C3B"/>
+                      </a:solidFill>
+                    </a:lnT>
+                    <a:lnB w="6350">
+                      <a:solidFill>
+                        <a:srgbClr val="3C3C3B"/>
+                      </a:solidFill>
+                    </a:lnB>
+                    <a:noFill/>
+                  </a:tcPr>
+                </a:tc>
+              </a:tr>
+              <a:tr h="777240">
+                <a:tc>
+                  <a:txBody>
+                    <a:bodyPr/>
+                    <a:lstStyle/>
+                    <a:p>
+                      <a:r>
+                        <a:rPr sz="1800" b="0">
+                          <a:solidFill>
+                            <a:srgbClr val="3C3C3B"/>
+                          </a:solidFill>
+                          <a:latin typeface="Aptos"/>
+                        </a:rPr>
+                        <a:t>Promise or build</a:t>
+                      </a:r>
+                    </a:p>
+                  </a:txBody>
+                  <a:tcPr marL="180000" anchor="ctr">
+                    <a:lnL>
+                      <a:noFill/>
+                    </a:lnL>
+                    <a:lnR>
+                      <a:noFill/>
+                    </a:lnR>
+                    <a:lnT w="6350">
+                      <a:solidFill>
+                        <a:srgbClr val="3C3C3B"/>
+                      </a:solidFill>
+                    </a:lnT>
+                    <a:lnB w="6350">
+                      <a:solidFill>
+                        <a:srgbClr val="3C3C3B"/>
+                      </a:solidFill>
+                    </a:lnB>
+                    <a:noFill/>
+                  </a:tcPr>
+                </a:tc>
+              </a:tr>
+              <a:tr h="777240">
+                <a:tc>
+                  <a:txBody>
+                    <a:bodyPr/>
+                    <a:lstStyle/>
+                    <a:p>
+                      <a:r>
+                        <a:rPr sz="1800" b="1">
+                          <a:solidFill>
+                            <a:srgbClr val="FFFFFF"/>
+                          </a:solidFill>
+                          <a:latin typeface="Aptos"/>
+                        </a:rPr>
+                        <a:t>Upside case</a:t>
+                      </a:r>
+                    </a:p>
+                  </a:txBody>
+                  <a:tcPr marL="180000" anchor="ctr">
+                    <a:lnL>
+                      <a:noFill/>
+                    </a:lnL>
+                    <a:lnR>
+                      <a:noFill/>
+                    </a:lnR>
+                    <a:lnT w="6350">
+                      <a:solidFill>
+                        <a:srgbClr val="3C3C3B"/>
+                      </a:solidFill>
+                    </a:lnT>
+                    <a:lnB w="6350">
+                      <a:solidFill>
+                        <a:srgbClr val="3C3C3B"/>
+                      </a:solidFill>
+                    </a:lnB>
+                    <a:gradFill rotWithShape="1">
+                      <a:gsLst>
+                        <a:gs pos="0">
+                          <a:srgbClr val="00A651"/>
+                        </a:gs>
+                        <a:gs pos="100000">
+                          <a:srgbClr val="00563C"/>
+                        </a:gs>
+                      </a:gsLst>
+                      <a:lin scaled="0" ang="0"/>
+                    </a:gradFill>
+                  </a:tcPr>
+                </a:tc>
+              </a:tr>
+              <a:tr h="777240">
+                <a:tc>
+                  <a:txBody>
+                    <a:bodyPr/>
+                    <a:lstStyle/>
+                    <a:p>
+                      <a:r>
+                        <a:rPr sz="1800" b="0">
+                          <a:solidFill>
+                            <a:srgbClr val="3C3C3B"/>
+                          </a:solidFill>
+                          <a:latin typeface="Aptos"/>
+                        </a:rPr>
+                        <a:t>Sensitivities</a:t>
+                      </a:r>
+                    </a:p>
+                  </a:txBody>
+                  <a:tcPr marL="180000" anchor="ctr">
+                    <a:lnL>
+                      <a:noFill/>
+                    </a:lnL>
+                    <a:lnR>
+                      <a:noFill/>
+                    </a:lnR>
+                    <a:lnT w="6350">
+                      <a:solidFill>
+                        <a:srgbClr val="3C3C3B"/>
+                      </a:solidFill>
+                    </a:lnT>
+                    <a:lnB w="6350">
+                      <a:solidFill>
+                        <a:srgbClr val="3C3C3B"/>
+                      </a:solidFill>
+                    </a:lnB>
+                    <a:noFill/>
+                  </a:tcPr>
+                </a:tc>
+              </a:tr>
+            </a:tbl>
+          </a:graphicData>
+        </a:graphic>
+      </p:graphicFrame>
+      <p:sp>
+        <p:nvSpPr>
+          <p:cNvPr id="4" name="Subtitle"/>
+          <p:cNvSpPr txBox="1"/>
+          <p:nvPr/>
+        </p:nvSpPr>
+        <p:spPr>
+          <a:xfrm>
+            <a:off x="4498848" y="1371600"/>
+            <a:ext cx="13716000" cy="685800"/>
+          </a:xfrm>
+          <a:prstGeom prst="rect">
+            <a:avLst/>
+          </a:prstGeom>
+          <a:noFill/>
+        </p:spPr>
+        <p:txBody>
+          <a:bodyPr wrap="square">
+            <a:spAutoFit/>
+          </a:bodyPr>
+          <a:lstStyle/>
+          <a:p>
+            <a:r>
+              <a:rPr sz="1800" b="1">
+                <a:solidFill>
+                  <a:srgbClr val="3C3C3B"/>
+                </a:solidFill>
+                <a:latin typeface="Aptos"/>
+              </a:rPr>
+              <a:t>But the zero bid scores only 12 points European (0 Chinese) against 59.5 (47.5), so winning the tender becomes the main risk.</a:t>
+            </a:r>
+          </a:p>
+        </p:txBody>
+      </p:sp>
+      <p:graphicFrame>
+        <p:nvGraphicFramePr>
+          <p:cNvPr id="5" name="Table"/>
+          <p:cNvGraphicFramePr>
+            <a:graphicFrameLocks noGrp="1"/>
+          </p:cNvGraphicFramePr>
+          <p:nvPr/>
+        </p:nvGraphicFramePr>
+        <p:xfrm>
+          <a:off x="4498848" y="2240280"/>
+          <a:ext cx="9509760" cy="6848856"/>
+        </p:xfrm>
+        <a:graphic>
+          <a:graphicData uri="http://schemas.openxmlformats.org/drawingml/2006/table">
+            <a:tbl>
+              <a:tblPr>
+                <a:tableStyleId>{5C22544A-7EE6-4342-B048-85BDC9FD1C3A}</a:tableStyleId>
+              </a:tblPr>
+              <a:tblGrid>
+                <a:gridCol w="3200400"/>
+                <a:gridCol w="1188720"/>
+                <a:gridCol w="1737360"/>
+                <a:gridCol w="1691640"/>
+                <a:gridCol w="1691640"/>
+              </a:tblGrid>
+              <a:tr h="539496">
+                <a:tc>
+                  <a:txBody>
+                    <a:bodyPr/>
+                    <a:lstStyle/>
+                    <a:p>
+                      <a:pPr algn="l"/>
+                      <a:r>
+                        <a:rPr sz="1300" b="1">
+                          <a:solidFill>
+                            <a:srgbClr val="FFFFFF"/>
+                          </a:solidFill>
+                          <a:latin typeface="Aptos"/>
+                        </a:rPr>
+                        <a:t>Case</a:t>
+                      </a:r>
+                    </a:p>
+                  </a:txBody>
+                  <a:tcPr marL="73152" marR="73152" marT="27432" marB="27432" anchor="ctr">
+                    <a:solidFill>
+                      <a:srgbClr val="00A651"/>
+                    </a:solidFill>
+                  </a:tcPr>
+                </a:tc>
+                <a:tc>
+                  <a:txBody>
+                    <a:bodyPr/>
+                    <a:lstStyle/>
+                    <a:p>
+                      <a:pPr algn="l"/>
+                      <a:r>
+                        <a:rPr sz="1300" b="1">
+                          <a:solidFill>
+                            <a:srgbClr val="FFFFFF"/>
+                          </a:solidFill>
+                          <a:latin typeface="Aptos"/>
+                        </a:rPr>
+                        <a:t>Unit</a:t>
+                      </a:r>
+                    </a:p>
+                  </a:txBody>
+                  <a:tcPr marL="73152" marR="73152" marT="27432" marB="27432" anchor="ctr">
+                    <a:solidFill>
+                      <a:srgbClr val="00A651"/>
+                    </a:solidFill>
+                  </a:tcPr>
+                </a:tc>
+                <a:tc>
+                  <a:txBody>
+                    <a:bodyPr/>
+                    <a:lstStyle/>
+                    <a:p>
+                      <a:pPr algn="r"/>
+                      <a:r>
+                        <a:rPr sz="1300" b="1">
+                          <a:solidFill>
+                            <a:srgbClr val="FFFFFF"/>
+                          </a:solidFill>
+                          <a:latin typeface="Aptos"/>
+                        </a:rPr>
+                        <a:t>Base</a:t>
+                      </a:r>
+                    </a:p>
+                  </a:txBody>
+                  <a:tcPr marL="73152" marR="73152" marT="27432" marB="27432" anchor="ctr">
+                    <a:solidFill>
+                      <a:srgbClr val="00A651"/>
+                    </a:solidFill>
+                  </a:tcPr>
+                </a:tc>
+                <a:tc>
+                  <a:txBody>
+                    <a:bodyPr/>
+                    <a:lstStyle/>
+                    <a:p>
+                      <a:pPr algn="r"/>
+                      <a:r>
+                        <a:rPr sz="1300" b="1">
+                          <a:solidFill>
+                            <a:srgbClr val="FFFFFF"/>
+                          </a:solidFill>
+                          <a:latin typeface="Aptos"/>
+                        </a:rPr>
+                        <a:t>Upside: PPA 100</a:t>
+                      </a:r>
+                    </a:p>
+                  </a:txBody>
+                  <a:tcPr marL="73152" marR="73152" marT="27432" marB="27432" anchor="ctr">
+                    <a:solidFill>
+                      <a:srgbClr val="00A651"/>
+                    </a:solidFill>
+                  </a:tcPr>
+                </a:tc>
+                <a:tc>
+                  <a:txBody>
+                    <a:bodyPr/>
+                    <a:lstStyle/>
+                    <a:p>
+                      <a:pPr algn="r"/>
+                      <a:r>
+                        <a:rPr sz="1300" b="1">
+                          <a:solidFill>
+                            <a:srgbClr val="FFFFFF"/>
+                          </a:solidFill>
+                          <a:latin typeface="Aptos"/>
+                        </a:rPr>
+                        <a:t>Upside: PPA 105</a:t>
+                      </a:r>
+                    </a:p>
+                  </a:txBody>
+                  <a:tcPr marL="73152" marR="73152" marT="27432" marB="27432" anchor="ctr">
+                    <a:solidFill>
+                      <a:srgbClr val="00A651"/>
+                    </a:solidFill>
+                  </a:tcPr>
+                </a:tc>
+              </a:tr>
+              <a:tr h="420624">
+                <a:tc>
+                  <a:txBody>
+                    <a:bodyPr/>
+                    <a:lstStyle/>
+                    <a:p>
+                      <a:pPr algn="l"/>
+                      <a:r>
+                        <a:rPr sz="1300" b="1">
+                          <a:solidFill>
+                            <a:srgbClr val="00563C"/>
+                          </a:solidFill>
+                          <a:latin typeface="Aptos"/>
+                        </a:rPr>
+                        <a:t>What changes</a:t>
+                      </a:r>
+                    </a:p>
+                  </a:txBody>
+                  <a:tcPr marL="73152" marR="73152" marT="27432" marB="27432" anchor="ctr">
+                    <a:solidFill>
+                      <a:srgbClr val="E6F4EC"/>
+                    </a:solidFill>
+                  </a:tcPr>
+                </a:tc>
+                <a:tc>
+                  <a:txBody>
+                    <a:bodyPr/>
+                    <a:lstStyle/>
+                    <a:p>
+                      <a:pPr algn="l"/>
+                    </a:p>
+                  </a:txBody>
+                  <a:tcPr marL="73152" marR="73152" marT="27432" marB="27432" anchor="ctr">
+                    <a:solidFill>
+                      <a:srgbClr val="E6F4EC"/>
+                    </a:solidFill>
+                  </a:tcPr>
+                </a:tc>
+                <a:tc>
+                  <a:txBody>
+                    <a:bodyPr/>
+                    <a:lstStyle/>
+                    <a:p>
+                      <a:pPr algn="r"/>
+                    </a:p>
+                  </a:txBody>
+                  <a:tcPr marL="73152" marR="73152" marT="27432" marB="27432" anchor="ctr">
+                    <a:solidFill>
+                      <a:srgbClr val="E6F4EC"/>
+                    </a:solidFill>
+                  </a:tcPr>
+                </a:tc>
+                <a:tc>
+                  <a:txBody>
+                    <a:bodyPr/>
+                    <a:lstStyle/>
+                    <a:p>
+                      <a:pPr algn="r"/>
+                    </a:p>
+                  </a:txBody>
+                  <a:tcPr marL="73152" marR="73152" marT="27432" marB="27432" anchor="ctr">
+                    <a:solidFill>
+                      <a:srgbClr val="E6F4EC"/>
+                    </a:solidFill>
+                  </a:tcPr>
+                </a:tc>
+                <a:tc>
+                  <a:txBody>
+                    <a:bodyPr/>
+                    <a:lstStyle/>
+                    <a:p>
+                      <a:pPr algn="r"/>
+                    </a:p>
+                  </a:txBody>
+                  <a:tcPr marL="73152" marR="73152" marT="27432" marB="27432" anchor="ctr">
+                    <a:solidFill>
+                      <a:srgbClr val="E6F4EC"/>
+                    </a:solidFill>
+                  </a:tcPr>
+                </a:tc>
+              </a:tr>
+              <a:tr h="420624">
+                <a:tc>
+                  <a:txBody>
+                    <a:bodyPr/>
+                    <a:lstStyle/>
+                    <a:p>
+                      <a:pPr algn="l"/>
+                      <a:r>
+                        <a:rPr sz="1300" b="0">
+                          <a:solidFill>
+                            <a:srgbClr val="3C3C3B"/>
+                          </a:solidFill>
+                          <a:latin typeface="Aptos"/>
+                        </a:rPr>
+                        <a:t>Net P50 hours</a:t>
+                      </a:r>
+                    </a:p>
+                  </a:txBody>
+                  <a:tcPr marL="73152" marR="73152" marT="27432" marB="27432" anchor="ctr">
+                    <a:solidFill>
+                      <a:srgbClr val="F2F2F2"/>
+                    </a:solidFill>
+                  </a:tcPr>
+                </a:tc>
+                <a:tc>
+                  <a:txBody>
+                    <a:bodyPr/>
+                    <a:lstStyle/>
+                    <a:p>
+                      <a:pPr algn="l"/>
+                      <a:r>
+                        <a:rPr sz="1300" b="0">
+                          <a:solidFill>
+                            <a:srgbClr val="919191"/>
+                          </a:solidFill>
+                          <a:latin typeface="Aptos"/>
+                        </a:rPr>
+                        <a:t>h</a:t>
+                      </a:r>
+                    </a:p>
+                  </a:txBody>
+                  <a:tcPr marL="73152" marR="73152" marT="27432" marB="27432" anchor="ctr">
+                    <a:solidFill>
+                      <a:srgbClr val="F2F2F2"/>
+                    </a:solidFill>
+                  </a:tcPr>
+                </a:tc>
+                <a:tc>
+                  <a:txBody>
+                    <a:bodyPr/>
+                    <a:lstStyle/>
+                    <a:p>
+                      <a:pPr algn="r"/>
+                      <a:r>
+                        <a:rPr sz="1300" b="0">
+                          <a:solidFill>
+                            <a:srgbClr val="3C3C3B"/>
+                          </a:solidFill>
+                          <a:latin typeface="Aptos"/>
+                        </a:rPr>
+                        <a:t>2,600</a:t>
+                      </a:r>
+                    </a:p>
+                  </a:txBody>
+                  <a:tcPr marL="73152" marR="73152" marT="27432" marB="27432" anchor="ctr">
+                    <a:noFill/>
+                  </a:tcPr>
+                </a:tc>
+                <a:tc>
+                  <a:txBody>
+                    <a:bodyPr/>
+                    <a:lstStyle/>
+                    <a:p>
+                      <a:pPr algn="r"/>
+                      <a:r>
+                        <a:rPr sz="1300" b="0">
+                          <a:solidFill>
+                            <a:srgbClr val="3C3C3B"/>
+                          </a:solidFill>
+                          <a:latin typeface="Aptos"/>
+                        </a:rPr>
+                        <a:t>2,850</a:t>
+                      </a:r>
+                    </a:p>
+                  </a:txBody>
+                  <a:tcPr marL="73152" marR="73152" marT="27432" marB="27432" anchor="ctr">
+                    <a:noFill/>
+                  </a:tcPr>
+                </a:tc>
+                <a:tc>
+                  <a:txBody>
+                    <a:bodyPr/>
+                    <a:lstStyle/>
+                    <a:p>
+                      <a:pPr algn="r"/>
+                      <a:r>
+                        <a:rPr sz="1300" b="0">
+                          <a:solidFill>
+                            <a:srgbClr val="3C3C3B"/>
+                          </a:solidFill>
+                          <a:latin typeface="Aptos"/>
+                        </a:rPr>
+                        <a:t>2,850</a:t>
+                      </a:r>
+                    </a:p>
+                  </a:txBody>
+                  <a:tcPr marL="73152" marR="73152" marT="27432" marB="27432" anchor="ctr">
+                    <a:noFill/>
+                  </a:tcPr>
+                </a:tc>
+              </a:tr>
+              <a:tr h="420624">
+                <a:tc>
+                  <a:txBody>
+                    <a:bodyPr/>
+                    <a:lstStyle/>
+                    <a:p>
+                      <a:pPr algn="l"/>
+                      <a:r>
+                        <a:rPr sz="1300" b="0">
+                          <a:solidFill>
+                            <a:srgbClr val="3C3C3B"/>
+                          </a:solidFill>
+                          <a:latin typeface="Aptos"/>
+                        </a:rPr>
+                        <a:t>Bid: overbuild / BESS</a:t>
+                      </a:r>
+                    </a:p>
+                  </a:txBody>
+                  <a:tcPr marL="73152" marR="73152" marT="27432" marB="27432" anchor="ctr">
+                    <a:solidFill>
+                      <a:srgbClr val="F2F2F2"/>
+                    </a:solidFill>
+                  </a:tcPr>
+                </a:tc>
+                <a:tc>
+                  <a:txBody>
+                    <a:bodyPr/>
+                    <a:lstStyle/>
+                    <a:p>
+                      <a:pPr algn="l"/>
+                      <a:r>
+                        <a:rPr sz="1300" b="0">
+                          <a:solidFill>
+                            <a:srgbClr val="919191"/>
+                          </a:solidFill>
+                          <a:latin typeface="Aptos"/>
+                        </a:rPr>
+                        <a:t>% of MVA</a:t>
+                      </a:r>
+                    </a:p>
+                  </a:txBody>
+                  <a:tcPr marL="73152" marR="73152" marT="27432" marB="27432" anchor="ctr">
+                    <a:solidFill>
+                      <a:srgbClr val="F2F2F2"/>
+                    </a:solidFill>
+                  </a:tcPr>
+                </a:tc>
+                <a:tc>
+                  <a:txBody>
+                    <a:bodyPr/>
+                    <a:lstStyle/>
+                    <a:p>
+                      <a:pPr algn="r"/>
+                      <a:r>
+                        <a:rPr sz="1300" b="0">
+                          <a:solidFill>
+                            <a:srgbClr val="3C3C3B"/>
+                          </a:solidFill>
+                          <a:latin typeface="Aptos"/>
+                        </a:rPr>
+                        <a:t>20% / 20%</a:t>
+                      </a:r>
+                    </a:p>
+                  </a:txBody>
+                  <a:tcPr marL="73152" marR="73152" marT="27432" marB="27432" anchor="ctr">
+                    <a:noFill/>
+                  </a:tcPr>
+                </a:tc>
+                <a:tc>
+                  <a:txBody>
+                    <a:bodyPr/>
+                    <a:lstStyle/>
+                    <a:p>
+                      <a:pPr algn="r"/>
+                      <a:r>
+                        <a:rPr sz="1300" b="0">
+                          <a:solidFill>
+                            <a:srgbClr val="3C3C3B"/>
+                          </a:solidFill>
+                          <a:latin typeface="Aptos"/>
+                        </a:rPr>
+                        <a:t>none</a:t>
+                      </a:r>
+                    </a:p>
+                  </a:txBody>
+                  <a:tcPr marL="73152" marR="73152" marT="27432" marB="27432" anchor="ctr">
+                    <a:noFill/>
+                  </a:tcPr>
+                </a:tc>
+                <a:tc>
+                  <a:txBody>
+                    <a:bodyPr/>
+                    <a:lstStyle/>
+                    <a:p>
+                      <a:pPr algn="r"/>
+                      <a:r>
+                        <a:rPr sz="1300" b="0">
+                          <a:solidFill>
+                            <a:srgbClr val="3C3C3B"/>
+                          </a:solidFill>
+                          <a:latin typeface="Aptos"/>
+                        </a:rPr>
+                        <a:t>none</a:t>
+                      </a:r>
+                    </a:p>
+                  </a:txBody>
+                  <a:tcPr marL="73152" marR="73152" marT="27432" marB="27432" anchor="ctr">
+                    <a:noFill/>
+                  </a:tcPr>
+                </a:tc>
+              </a:tr>
+              <a:tr h="420624">
+                <a:tc>
+                  <a:txBody>
+                    <a:bodyPr/>
+                    <a:lstStyle/>
+                    <a:p>
+                      <a:pPr algn="l"/>
+                      <a:r>
+                        <a:rPr sz="1300" b="0">
+                          <a:solidFill>
+                            <a:srgbClr val="3C3C3B"/>
+                          </a:solidFill>
+                          <a:latin typeface="Aptos"/>
+                        </a:rPr>
+                        <a:t>Bid: municipal / community</a:t>
+                      </a:r>
+                    </a:p>
+                  </a:txBody>
+                  <a:tcPr marL="73152" marR="73152" marT="27432" marB="27432" anchor="ctr">
+                    <a:solidFill>
+                      <a:srgbClr val="F2F2F2"/>
+                    </a:solidFill>
+                  </a:tcPr>
+                </a:tc>
+                <a:tc>
+                  <a:txBody>
+                    <a:bodyPr/>
+                    <a:lstStyle/>
+                    <a:p>
+                      <a:pPr algn="l"/>
+                      <a:r>
+                        <a:rPr sz="1300" b="0">
+                          <a:solidFill>
+                            <a:srgbClr val="919191"/>
+                          </a:solidFill>
+                          <a:latin typeface="Aptos"/>
+                        </a:rPr>
+                        <a:t>k€/MW, €/MWh</a:t>
+                      </a:r>
+                    </a:p>
+                  </a:txBody>
+                  <a:tcPr marL="73152" marR="73152" marT="27432" marB="27432" anchor="ctr">
+                    <a:solidFill>
+                      <a:srgbClr val="F2F2F2"/>
+                    </a:solidFill>
+                  </a:tcPr>
+                </a:tc>
+                <a:tc>
+                  <a:txBody>
+                    <a:bodyPr/>
+                    <a:lstStyle/>
+                    <a:p>
+                      <a:pPr algn="r"/>
+                      <a:r>
+                        <a:rPr sz="1300" b="0">
+                          <a:solidFill>
+                            <a:srgbClr val="3C3C3B"/>
+                          </a:solidFill>
+                          <a:latin typeface="Aptos"/>
+                        </a:rPr>
+                        <a:t>50 / 3.0</a:t>
+                      </a:r>
+                    </a:p>
+                  </a:txBody>
+                  <a:tcPr marL="73152" marR="73152" marT="27432" marB="27432" anchor="ctr">
+                    <a:noFill/>
+                  </a:tcPr>
+                </a:tc>
+                <a:tc>
+                  <a:txBody>
+                    <a:bodyPr/>
+                    <a:lstStyle/>
+                    <a:p>
+                      <a:pPr algn="r"/>
+                      <a:r>
+                        <a:rPr sz="1300" b="0">
+                          <a:solidFill>
+                            <a:srgbClr val="3C3C3B"/>
+                          </a:solidFill>
+                          <a:latin typeface="Aptos"/>
+                        </a:rPr>
+                        <a:t>10 / 2.0</a:t>
+                      </a:r>
+                    </a:p>
+                  </a:txBody>
+                  <a:tcPr marL="73152" marR="73152" marT="27432" marB="27432" anchor="ctr">
+                    <a:noFill/>
+                  </a:tcPr>
+                </a:tc>
+                <a:tc>
+                  <a:txBody>
+                    <a:bodyPr/>
+                    <a:lstStyle/>
+                    <a:p>
+                      <a:pPr algn="r"/>
+                      <a:r>
+                        <a:rPr sz="1300" b="0">
+                          <a:solidFill>
+                            <a:srgbClr val="3C3C3B"/>
+                          </a:solidFill>
+                          <a:latin typeface="Aptos"/>
+                        </a:rPr>
+                        <a:t>10 / 2.0</a:t>
+                      </a:r>
+                    </a:p>
+                  </a:txBody>
+                  <a:tcPr marL="73152" marR="73152" marT="27432" marB="27432" anchor="ctr">
+                    <a:noFill/>
+                  </a:tcPr>
+                </a:tc>
+              </a:tr>
+              <a:tr h="420624">
+                <a:tc>
+                  <a:txBody>
+                    <a:bodyPr/>
+                    <a:lstStyle/>
+                    <a:p>
+                      <a:pPr algn="l"/>
+                      <a:r>
+                        <a:rPr sz="1300" b="0">
+                          <a:solidFill>
+                            <a:srgbClr val="3C3C3B"/>
+                          </a:solidFill>
+                          <a:latin typeface="Aptos"/>
+                        </a:rPr>
+                        <a:t>PPA price, whole life</a:t>
+                      </a:r>
+                    </a:p>
+                  </a:txBody>
+                  <a:tcPr marL="73152" marR="73152" marT="27432" marB="27432" anchor="ctr">
+                    <a:solidFill>
+                      <a:srgbClr val="F2F2F2"/>
+                    </a:solidFill>
+                  </a:tcPr>
+                </a:tc>
+                <a:tc>
+                  <a:txBody>
+                    <a:bodyPr/>
+                    <a:lstStyle/>
+                    <a:p>
+                      <a:pPr algn="l"/>
+                      <a:r>
+                        <a:rPr sz="1300" b="0">
+                          <a:solidFill>
+                            <a:srgbClr val="919191"/>
+                          </a:solidFill>
+                          <a:latin typeface="Aptos"/>
+                        </a:rPr>
+                        <a:t>€/MWh</a:t>
+                      </a:r>
+                    </a:p>
+                  </a:txBody>
+                  <a:tcPr marL="73152" marR="73152" marT="27432" marB="27432" anchor="ctr">
+                    <a:solidFill>
+                      <a:srgbClr val="F2F2F2"/>
+                    </a:solidFill>
+                  </a:tcPr>
+                </a:tc>
+                <a:tc>
+                  <a:txBody>
+                    <a:bodyPr/>
+                    <a:lstStyle/>
+                    <a:p>
+                      <a:pPr algn="r"/>
+                      <a:r>
+                        <a:rPr sz="1300" b="0">
+                          <a:solidFill>
+                            <a:srgbClr val="3C3C3B"/>
+                          </a:solidFill>
+                          <a:latin typeface="Aptos"/>
+                        </a:rPr>
+                        <a:t>90</a:t>
+                      </a:r>
+                    </a:p>
+                  </a:txBody>
+                  <a:tcPr marL="73152" marR="73152" marT="27432" marB="27432" anchor="ctr">
+                    <a:noFill/>
+                  </a:tcPr>
+                </a:tc>
+                <a:tc>
+                  <a:txBody>
+                    <a:bodyPr/>
+                    <a:lstStyle/>
+                    <a:p>
+                      <a:pPr algn="r"/>
+                      <a:r>
+                        <a:rPr sz="1300" b="0">
+                          <a:solidFill>
+                            <a:srgbClr val="3C3C3B"/>
+                          </a:solidFill>
+                          <a:latin typeface="Aptos"/>
+                        </a:rPr>
+                        <a:t>100</a:t>
+                      </a:r>
+                    </a:p>
+                  </a:txBody>
+                  <a:tcPr marL="73152" marR="73152" marT="27432" marB="27432" anchor="ctr">
+                    <a:noFill/>
+                  </a:tcPr>
+                </a:tc>
+                <a:tc>
+                  <a:txBody>
+                    <a:bodyPr/>
+                    <a:lstStyle/>
+                    <a:p>
+                      <a:pPr algn="r"/>
+                      <a:r>
+                        <a:rPr sz="1300" b="0">
+                          <a:solidFill>
+                            <a:srgbClr val="3C3C3B"/>
+                          </a:solidFill>
+                          <a:latin typeface="Aptos"/>
+                        </a:rPr>
+                        <a:t>105</a:t>
+                      </a:r>
+                    </a:p>
+                  </a:txBody>
+                  <a:tcPr marL="73152" marR="73152" marT="27432" marB="27432" anchor="ctr">
+                    <a:noFill/>
+                  </a:tcPr>
+                </a:tc>
+              </a:tr>
+              <a:tr h="420624">
+                <a:tc>
+                  <a:txBody>
+                    <a:bodyPr/>
+                    <a:lstStyle/>
+                    <a:p>
+                      <a:pPr algn="l"/>
+                      <a:r>
+                        <a:rPr sz="1300" b="0">
+                          <a:solidFill>
+                            <a:srgbClr val="3C3C3B"/>
+                          </a:solidFill>
+                          <a:latin typeface="Aptos"/>
+                        </a:rPr>
+                        <a:t>Gearing (debt / construction cost)</a:t>
+                      </a:r>
+                    </a:p>
+                  </a:txBody>
+                  <a:tcPr marL="73152" marR="73152" marT="27432" marB="27432" anchor="ctr">
+                    <a:solidFill>
+                      <a:srgbClr val="F2F2F2"/>
+                    </a:solidFill>
+                  </a:tcPr>
+                </a:tc>
+                <a:tc>
+                  <a:txBody>
+                    <a:bodyPr/>
+                    <a:lstStyle/>
+                    <a:p>
+                      <a:pPr algn="l"/>
+                      <a:r>
+                        <a:rPr sz="1300" b="0">
+                          <a:solidFill>
+                            <a:srgbClr val="919191"/>
+                          </a:solidFill>
+                          <a:latin typeface="Aptos"/>
+                        </a:rPr>
+                        <a:t>%</a:t>
+                      </a:r>
+                    </a:p>
+                  </a:txBody>
+                  <a:tcPr marL="73152" marR="73152" marT="27432" marB="27432" anchor="ctr">
+                    <a:solidFill>
+                      <a:srgbClr val="F2F2F2"/>
+                    </a:solidFill>
+                  </a:tcPr>
+                </a:tc>
+                <a:tc>
+                  <a:txBody>
+                    <a:bodyPr/>
+                    <a:lstStyle/>
+                    <a:p>
+                      <a:pPr algn="r"/>
+                      <a:r>
+                        <a:rPr sz="1300" b="0">
+                          <a:solidFill>
+                            <a:srgbClr val="3C3C3B"/>
+                          </a:solidFill>
+                          <a:latin typeface="Aptos"/>
+                        </a:rPr>
+                        <a:t>55%</a:t>
+                      </a:r>
+                    </a:p>
+                  </a:txBody>
+                  <a:tcPr marL="73152" marR="73152" marT="27432" marB="27432" anchor="ctr">
+                    <a:noFill/>
+                  </a:tcPr>
+                </a:tc>
+                <a:tc>
+                  <a:txBody>
+                    <a:bodyPr/>
+                    <a:lstStyle/>
+                    <a:p>
+                      <a:pPr algn="r"/>
+                      <a:r>
+                        <a:rPr sz="1300" b="0">
+                          <a:solidFill>
+                            <a:srgbClr val="3C3C3B"/>
+                          </a:solidFill>
+                          <a:latin typeface="Aptos"/>
+                        </a:rPr>
+                        <a:t>60%</a:t>
+                      </a:r>
+                    </a:p>
+                  </a:txBody>
+                  <a:tcPr marL="73152" marR="73152" marT="27432" marB="27432" anchor="ctr">
+                    <a:noFill/>
+                  </a:tcPr>
+                </a:tc>
+                <a:tc>
+                  <a:txBody>
+                    <a:bodyPr/>
+                    <a:lstStyle/>
+                    <a:p>
+                      <a:pPr algn="r"/>
+                      <a:r>
+                        <a:rPr sz="1300" b="0">
+                          <a:solidFill>
+                            <a:srgbClr val="3C3C3B"/>
+                          </a:solidFill>
+                          <a:latin typeface="Aptos"/>
+                        </a:rPr>
+                        <a:t>60%</a:t>
+                      </a:r>
+                    </a:p>
+                  </a:txBody>
+                  <a:tcPr marL="73152" marR="73152" marT="27432" marB="27432" anchor="ctr">
+                    <a:noFill/>
+                  </a:tcPr>
+                </a:tc>
+              </a:tr>
+              <a:tr h="420624">
+                <a:tc>
+                  <a:txBody>
+                    <a:bodyPr/>
+                    <a:lstStyle/>
+                    <a:p>
+                      <a:pPr algn="l"/>
+                      <a:r>
+                        <a:rPr sz="1300" b="1">
+                          <a:solidFill>
+                            <a:srgbClr val="00563C"/>
+                          </a:solidFill>
+                          <a:latin typeface="Aptos"/>
+                        </a:rPr>
+                        <a:t>Results (European / Chinese)</a:t>
+                      </a:r>
+                    </a:p>
+                  </a:txBody>
+                  <a:tcPr marL="73152" marR="73152" marT="27432" marB="27432" anchor="ctr">
+                    <a:solidFill>
+                      <a:srgbClr val="E6F4EC"/>
+                    </a:solidFill>
+                  </a:tcPr>
+                </a:tc>
+                <a:tc>
+                  <a:txBody>
+                    <a:bodyPr/>
+                    <a:lstStyle/>
+                    <a:p>
+                      <a:pPr algn="l"/>
+                    </a:p>
+                  </a:txBody>
+                  <a:tcPr marL="73152" marR="73152" marT="27432" marB="27432" anchor="ctr">
+                    <a:solidFill>
+                      <a:srgbClr val="E6F4EC"/>
+                    </a:solidFill>
+                  </a:tcPr>
+                </a:tc>
+                <a:tc>
+                  <a:txBody>
+                    <a:bodyPr/>
+                    <a:lstStyle/>
+                    <a:p>
+                      <a:pPr algn="r"/>
+                    </a:p>
+                  </a:txBody>
+                  <a:tcPr marL="73152" marR="73152" marT="27432" marB="27432" anchor="ctr">
+                    <a:solidFill>
+                      <a:srgbClr val="E6F4EC"/>
+                    </a:solidFill>
+                  </a:tcPr>
+                </a:tc>
+                <a:tc>
+                  <a:txBody>
+                    <a:bodyPr/>
+                    <a:lstStyle/>
+                    <a:p>
+                      <a:pPr algn="r"/>
+                    </a:p>
+                  </a:txBody>
+                  <a:tcPr marL="73152" marR="73152" marT="27432" marB="27432" anchor="ctr">
+                    <a:solidFill>
+                      <a:srgbClr val="E6F4EC"/>
+                    </a:solidFill>
+                  </a:tcPr>
+                </a:tc>
+                <a:tc>
+                  <a:txBody>
+                    <a:bodyPr/>
+                    <a:lstStyle/>
+                    <a:p>
+                      <a:pPr algn="r"/>
+                    </a:p>
+                  </a:txBody>
+                  <a:tcPr marL="73152" marR="73152" marT="27432" marB="27432" anchor="ctr">
+                    <a:solidFill>
+                      <a:srgbClr val="E6F4EC"/>
+                    </a:solidFill>
+                  </a:tcPr>
+                </a:tc>
+              </a:tr>
+              <a:tr h="420624">
+                <a:tc>
+                  <a:txBody>
+                    <a:bodyPr/>
+                    <a:lstStyle/>
+                    <a:p>
+                      <a:pPr algn="l"/>
+                      <a:r>
+                        <a:rPr sz="1300" b="0">
+                          <a:solidFill>
+                            <a:srgbClr val="3C3C3B"/>
+                          </a:solidFill>
+                          <a:latin typeface="Aptos"/>
+                        </a:rPr>
+                        <a:t>Tender points</a:t>
+                      </a:r>
+                    </a:p>
+                  </a:txBody>
+                  <a:tcPr marL="73152" marR="73152" marT="27432" marB="27432" anchor="ctr">
+                    <a:solidFill>
+                      <a:srgbClr val="F2F2F2"/>
+                    </a:solidFill>
+                  </a:tcPr>
+                </a:tc>
+                <a:tc>
+                  <a:txBody>
+                    <a:bodyPr/>
+                    <a:lstStyle/>
+                    <a:p>
+                      <a:pPr algn="l"/>
+                      <a:r>
+                        <a:rPr sz="1300" b="0">
+                          <a:solidFill>
+                            <a:srgbClr val="919191"/>
+                          </a:solidFill>
+                          <a:latin typeface="Aptos"/>
+                        </a:rPr>
+                        <a:t>points</a:t>
+                      </a:r>
+                    </a:p>
+                  </a:txBody>
+                  <a:tcPr marL="73152" marR="73152" marT="27432" marB="27432" anchor="ctr">
+                    <a:solidFill>
+                      <a:srgbClr val="F2F2F2"/>
+                    </a:solidFill>
+                  </a:tcPr>
+                </a:tc>
+                <a:tc>
+                  <a:txBody>
+                    <a:bodyPr/>
+                    <a:lstStyle/>
+                    <a:p>
+                      <a:pPr algn="r"/>
+                      <a:r>
+                        <a:rPr sz="1300" b="0">
+                          <a:solidFill>
+                            <a:srgbClr val="3C3C3B"/>
+                          </a:solidFill>
+                          <a:latin typeface="Aptos"/>
+                        </a:rPr>
+                        <a:t>59.5 / 47.5</a:t>
+                      </a:r>
+                    </a:p>
+                  </a:txBody>
+                  <a:tcPr marL="73152" marR="73152" marT="27432" marB="27432" anchor="ctr">
+                    <a:noFill/>
+                  </a:tcPr>
+                </a:tc>
+                <a:tc>
+                  <a:txBody>
+                    <a:bodyPr/>
+                    <a:lstStyle/>
+                    <a:p>
+                      <a:pPr algn="r"/>
+                      <a:r>
+                        <a:rPr sz="1300" b="0">
+                          <a:solidFill>
+                            <a:srgbClr val="3C3C3B"/>
+                          </a:solidFill>
+                          <a:latin typeface="Aptos"/>
+                        </a:rPr>
+                        <a:t>12 / 0</a:t>
+                      </a:r>
+                    </a:p>
+                  </a:txBody>
+                  <a:tcPr marL="73152" marR="73152" marT="27432" marB="27432" anchor="ctr">
+                    <a:noFill/>
+                  </a:tcPr>
+                </a:tc>
+                <a:tc>
+                  <a:txBody>
+                    <a:bodyPr/>
+                    <a:lstStyle/>
+                    <a:p>
+                      <a:pPr algn="r"/>
+                      <a:r>
+                        <a:rPr sz="1300" b="0">
+                          <a:solidFill>
+                            <a:srgbClr val="3C3C3B"/>
+                          </a:solidFill>
+                          <a:latin typeface="Aptos"/>
+                        </a:rPr>
+                        <a:t>12 / 0</a:t>
+                      </a:r>
+                    </a:p>
+                  </a:txBody>
+                  <a:tcPr marL="73152" marR="73152" marT="27432" marB="27432" anchor="ctr">
+                    <a:noFill/>
+                  </a:tcPr>
+                </a:tc>
+              </a:tr>
+              <a:tr h="420624">
+                <a:tc>
+                  <a:txBody>
+                    <a:bodyPr/>
+                    <a:lstStyle/>
+                    <a:p>
+                      <a:pPr algn="l"/>
+                      <a:r>
+                        <a:rPr sz="1300" b="0">
+                          <a:solidFill>
+                            <a:srgbClr val="3C3C3B"/>
+                          </a:solidFill>
+                          <a:latin typeface="Aptos"/>
+                        </a:rPr>
+                        <a:t>Total uses to COD</a:t>
+                      </a:r>
+                    </a:p>
+                  </a:txBody>
+                  <a:tcPr marL="73152" marR="73152" marT="27432" marB="27432" anchor="ctr">
+                    <a:solidFill>
+                      <a:srgbClr val="F2F2F2"/>
+                    </a:solidFill>
+                  </a:tcPr>
+                </a:tc>
+                <a:tc>
+                  <a:txBody>
+                    <a:bodyPr/>
+                    <a:lstStyle/>
+                    <a:p>
+                      <a:pPr algn="l"/>
+                      <a:r>
+                        <a:rPr sz="1300" b="0">
+                          <a:solidFill>
+                            <a:srgbClr val="919191"/>
+                          </a:solidFill>
+                          <a:latin typeface="Aptos"/>
+                        </a:rPr>
+                        <a:t>€ m</a:t>
+                      </a:r>
+                    </a:p>
+                  </a:txBody>
+                  <a:tcPr marL="73152" marR="73152" marT="27432" marB="27432" anchor="ctr">
+                    <a:solidFill>
+                      <a:srgbClr val="F2F2F2"/>
+                    </a:solidFill>
+                  </a:tcPr>
+                </a:tc>
+                <a:tc>
+                  <a:txBody>
+                    <a:bodyPr/>
+                    <a:lstStyle/>
+                    <a:p>
+                      <a:pPr algn="r"/>
+                      <a:r>
+                        <a:rPr sz="1300" b="0">
+                          <a:solidFill>
+                            <a:srgbClr val="3C3C3B"/>
+                          </a:solidFill>
+                          <a:latin typeface="Aptos"/>
+                        </a:rPr>
+                        <a:t>113.4 / 85.1</a:t>
+                      </a:r>
+                    </a:p>
+                  </a:txBody>
+                  <a:tcPr marL="73152" marR="73152" marT="27432" marB="27432" anchor="ctr">
+                    <a:noFill/>
+                  </a:tcPr>
+                </a:tc>
+                <a:tc>
+                  <a:txBody>
+                    <a:bodyPr/>
+                    <a:lstStyle/>
+                    <a:p>
+                      <a:pPr algn="r"/>
+                      <a:r>
+                        <a:rPr sz="1300" b="0">
+                          <a:solidFill>
+                            <a:srgbClr val="3C3C3B"/>
+                          </a:solidFill>
+                          <a:latin typeface="Aptos"/>
+                        </a:rPr>
+                        <a:t>100.2 / 74.2</a:t>
+                      </a:r>
+                    </a:p>
+                  </a:txBody>
+                  <a:tcPr marL="73152" marR="73152" marT="27432" marB="27432" anchor="ctr">
+                    <a:noFill/>
+                  </a:tcPr>
+                </a:tc>
+                <a:tc>
+                  <a:txBody>
+                    <a:bodyPr/>
+                    <a:lstStyle/>
+                    <a:p>
+                      <a:pPr algn="r"/>
+                      <a:r>
+                        <a:rPr sz="1300" b="0">
+                          <a:solidFill>
+                            <a:srgbClr val="3C3C3B"/>
+                          </a:solidFill>
+                          <a:latin typeface="Aptos"/>
+                        </a:rPr>
+                        <a:t>100.2 / 74.2</a:t>
+                      </a:r>
+                    </a:p>
+                  </a:txBody>
+                  <a:tcPr marL="73152" marR="73152" marT="27432" marB="27432" anchor="ctr">
+                    <a:noFill/>
+                  </a:tcPr>
+                </a:tc>
+              </a:tr>
+              <a:tr h="420624">
+                <a:tc>
+                  <a:txBody>
+                    <a:bodyPr/>
+                    <a:lstStyle/>
+                    <a:p>
+                      <a:pPr algn="l"/>
+                      <a:r>
+                        <a:rPr sz="1300" b="0">
+                          <a:solidFill>
+                            <a:srgbClr val="3C3C3B"/>
+                          </a:solidFill>
+                          <a:latin typeface="Aptos"/>
+                        </a:rPr>
+                        <a:t>FEP equity to COD</a:t>
+                      </a:r>
+                    </a:p>
+                  </a:txBody>
+                  <a:tcPr marL="73152" marR="73152" marT="27432" marB="27432" anchor="ctr">
+                    <a:solidFill>
+                      <a:srgbClr val="F2F2F2"/>
+                    </a:solidFill>
+                  </a:tcPr>
+                </a:tc>
+                <a:tc>
+                  <a:txBody>
+                    <a:bodyPr/>
+                    <a:lstStyle/>
+                    <a:p>
+                      <a:pPr algn="l"/>
+                      <a:r>
+                        <a:rPr sz="1300" b="0">
+                          <a:solidFill>
+                            <a:srgbClr val="919191"/>
+                          </a:solidFill>
+                          <a:latin typeface="Aptos"/>
+                        </a:rPr>
+                        <a:t>€ m</a:t>
+                      </a:r>
+                    </a:p>
+                  </a:txBody>
+                  <a:tcPr marL="73152" marR="73152" marT="27432" marB="27432" anchor="ctr">
+                    <a:solidFill>
+                      <a:srgbClr val="F2F2F2"/>
+                    </a:solidFill>
+                  </a:tcPr>
+                </a:tc>
+                <a:tc>
+                  <a:txBody>
+                    <a:bodyPr/>
+                    <a:lstStyle/>
+                    <a:p>
+                      <a:pPr algn="r"/>
+                      <a:r>
+                        <a:rPr sz="1300" b="0">
+                          <a:solidFill>
+                            <a:srgbClr val="3C3C3B"/>
+                          </a:solidFill>
+                          <a:latin typeface="Aptos"/>
+                        </a:rPr>
+                        <a:t>54.4 / 41.7</a:t>
+                      </a:r>
+                    </a:p>
+                  </a:txBody>
+                  <a:tcPr marL="73152" marR="73152" marT="27432" marB="27432" anchor="ctr">
+                    <a:noFill/>
+                  </a:tcPr>
+                </a:tc>
+                <a:tc>
+                  <a:txBody>
+                    <a:bodyPr/>
+                    <a:lstStyle/>
+                    <a:p>
+                      <a:pPr algn="r"/>
+                      <a:r>
+                        <a:rPr sz="1300" b="0">
+                          <a:solidFill>
+                            <a:srgbClr val="3C3C3B"/>
+                          </a:solidFill>
+                          <a:latin typeface="Aptos"/>
+                        </a:rPr>
+                        <a:t>43.8 / 33.4</a:t>
+                      </a:r>
+                    </a:p>
+                  </a:txBody>
+                  <a:tcPr marL="73152" marR="73152" marT="27432" marB="27432" anchor="ctr">
+                    <a:noFill/>
+                  </a:tcPr>
+                </a:tc>
+                <a:tc>
+                  <a:txBody>
+                    <a:bodyPr/>
+                    <a:lstStyle/>
+                    <a:p>
+                      <a:pPr algn="r"/>
+                      <a:r>
+                        <a:rPr sz="1300" b="0">
+                          <a:solidFill>
+                            <a:srgbClr val="3C3C3B"/>
+                          </a:solidFill>
+                          <a:latin typeface="Aptos"/>
+                        </a:rPr>
+                        <a:t>43.8 / 33.4</a:t>
+                      </a:r>
+                    </a:p>
+                  </a:txBody>
+                  <a:tcPr marL="73152" marR="73152" marT="27432" marB="27432" anchor="ctr">
+                    <a:noFill/>
+                  </a:tcPr>
+                </a:tc>
+              </a:tr>
+              <a:tr h="420624">
+                <a:tc>
+                  <a:txBody>
+                    <a:bodyPr/>
+                    <a:lstStyle/>
+                    <a:p>
+                      <a:pPr algn="l"/>
+                      <a:r>
+                        <a:rPr sz="1300" b="0">
+                          <a:solidFill>
+                            <a:srgbClr val="3C3C3B"/>
+                          </a:solidFill>
+                          <a:latin typeface="Aptos"/>
+                        </a:rPr>
+                        <a:t>FEP IRR, sale at COD</a:t>
+                      </a:r>
+                    </a:p>
+                  </a:txBody>
+                  <a:tcPr marL="73152" marR="73152" marT="27432" marB="27432" anchor="ctr">
+                    <a:solidFill>
+                      <a:srgbClr val="F2F2F2"/>
+                    </a:solidFill>
+                  </a:tcPr>
+                </a:tc>
+                <a:tc>
+                  <a:txBody>
+                    <a:bodyPr/>
+                    <a:lstStyle/>
+                    <a:p>
+                      <a:pPr algn="l"/>
+                      <a:r>
+                        <a:rPr sz="1300" b="0">
+                          <a:solidFill>
+                            <a:srgbClr val="919191"/>
+                          </a:solidFill>
+                          <a:latin typeface="Aptos"/>
+                        </a:rPr>
+                        <a:t>%</a:t>
+                      </a:r>
+                    </a:p>
+                  </a:txBody>
+                  <a:tcPr marL="73152" marR="73152" marT="27432" marB="27432" anchor="ctr">
+                    <a:solidFill>
+                      <a:srgbClr val="F2F2F2"/>
+                    </a:solidFill>
+                  </a:tcPr>
+                </a:tc>
+                <a:tc>
+                  <a:txBody>
+                    <a:bodyPr/>
+                    <a:lstStyle/>
+                    <a:p>
+                      <a:pPr algn="r"/>
+                      <a:r>
+                        <a:rPr sz="1300" b="0">
+                          <a:solidFill>
+                            <a:srgbClr val="3C3C3B"/>
+                          </a:solidFill>
+                          <a:latin typeface="Aptos"/>
+                        </a:rPr>
+                        <a:t>26.3% / 41.0%</a:t>
+                      </a:r>
+                    </a:p>
+                  </a:txBody>
+                  <a:tcPr marL="73152" marR="73152" marT="27432" marB="27432" anchor="ctr">
+                    <a:noFill/>
+                  </a:tcPr>
+                </a:tc>
+                <a:tc>
+                  <a:txBody>
+                    <a:bodyPr/>
+                    <a:lstStyle/>
+                    <a:p>
+                      <a:pPr algn="r"/>
+                      <a:r>
+                        <a:rPr sz="1300" b="0">
+                          <a:solidFill>
+                            <a:srgbClr val="3C3C3B"/>
+                          </a:solidFill>
+                          <a:latin typeface="Aptos"/>
+                        </a:rPr>
+                        <a:t>31.3% / 45.5%</a:t>
+                      </a:r>
+                    </a:p>
+                  </a:txBody>
+                  <a:tcPr marL="73152" marR="73152" marT="27432" marB="27432" anchor="ctr">
+                    <a:noFill/>
+                  </a:tcPr>
+                </a:tc>
+                <a:tc>
+                  <a:txBody>
+                    <a:bodyPr/>
+                    <a:lstStyle/>
+                    <a:p>
+                      <a:pPr algn="r"/>
+                      <a:r>
+                        <a:rPr sz="1300" b="0">
+                          <a:solidFill>
+                            <a:srgbClr val="3C3C3B"/>
+                          </a:solidFill>
+                          <a:latin typeface="Aptos"/>
+                        </a:rPr>
+                        <a:t>31.3% / 45.5%</a:t>
+                      </a:r>
+                    </a:p>
+                  </a:txBody>
+                  <a:tcPr marL="73152" marR="73152" marT="27432" marB="27432" anchor="ctr">
+                    <a:noFill/>
+                  </a:tcPr>
+                </a:tc>
+              </a:tr>
+              <a:tr h="420624">
+                <a:tc>
+                  <a:txBody>
+                    <a:bodyPr/>
+                    <a:lstStyle/>
+                    <a:p>
+                      <a:pPr algn="l"/>
+                      <a:r>
+                        <a:rPr sz="1300" b="1">
+                          <a:solidFill>
+                            <a:srgbClr val="3C3C3B"/>
+                          </a:solidFill>
+                          <a:latin typeface="Aptos"/>
+                        </a:rPr>
+                        <a:t>FEP IRR, hold</a:t>
+                      </a:r>
+                    </a:p>
+                  </a:txBody>
+                  <a:tcPr marL="73152" marR="73152" marT="27432" marB="27432" anchor="ctr">
+                    <a:solidFill>
+                      <a:srgbClr val="F2F2F2"/>
+                    </a:solidFill>
+                  </a:tcPr>
+                </a:tc>
+                <a:tc>
+                  <a:txBody>
+                    <a:bodyPr/>
+                    <a:lstStyle/>
+                    <a:p>
+                      <a:pPr algn="l"/>
+                      <a:r>
+                        <a:rPr sz="1300" b="1">
+                          <a:solidFill>
+                            <a:srgbClr val="919191"/>
+                          </a:solidFill>
+                          <a:latin typeface="Aptos"/>
+                        </a:rPr>
+                        <a:t>%</a:t>
+                      </a:r>
+                    </a:p>
+                  </a:txBody>
+                  <a:tcPr marL="73152" marR="73152" marT="27432" marB="27432" anchor="ctr">
+                    <a:solidFill>
+                      <a:srgbClr val="F2F2F2"/>
+                    </a:solidFill>
+                  </a:tcPr>
+                </a:tc>
+                <a:tc>
+                  <a:txBody>
+                    <a:bodyPr/>
+                    <a:lstStyle/>
+                    <a:p>
+                      <a:pPr algn="r"/>
+                      <a:r>
+                        <a:rPr sz="1300" b="1">
+                          <a:solidFill>
+                            <a:srgbClr val="3C3C3B"/>
+                          </a:solidFill>
+                          <a:latin typeface="Aptos"/>
+                        </a:rPr>
+                        <a:t>7.6% / 11.4%</a:t>
+                      </a:r>
+                    </a:p>
+                  </a:txBody>
+                  <a:tcPr marL="73152" marR="73152" marT="27432" marB="27432" anchor="ctr">
+                    <a:solidFill>
+                      <a:srgbClr val="E6F4EC"/>
+                    </a:solidFill>
+                  </a:tcPr>
+                </a:tc>
+                <a:tc>
+                  <a:txBody>
+                    <a:bodyPr/>
+                    <a:lstStyle/>
+                    <a:p>
+                      <a:pPr algn="r"/>
+                      <a:r>
+                        <a:rPr sz="1300" b="1">
+                          <a:solidFill>
+                            <a:srgbClr val="3C3C3B"/>
+                          </a:solidFill>
+                          <a:latin typeface="Aptos"/>
+                        </a:rPr>
+                        <a:t>11.9% / 16.8%</a:t>
+                      </a:r>
+                    </a:p>
+                  </a:txBody>
+                  <a:tcPr marL="73152" marR="73152" marT="27432" marB="27432" anchor="ctr">
+                    <a:solidFill>
+                      <a:srgbClr val="E6F4EC"/>
+                    </a:solidFill>
+                  </a:tcPr>
+                </a:tc>
+                <a:tc>
+                  <a:txBody>
+                    <a:bodyPr/>
+                    <a:lstStyle/>
+                    <a:p>
+                      <a:pPr algn="r"/>
+                      <a:r>
+                        <a:rPr sz="1300" b="1">
+                          <a:solidFill>
+                            <a:srgbClr val="3C3C3B"/>
+                          </a:solidFill>
+                          <a:latin typeface="Aptos"/>
+                        </a:rPr>
+                        <a:t>12.9% / 17.9%</a:t>
+                      </a:r>
+                    </a:p>
+                  </a:txBody>
+                  <a:tcPr marL="73152" marR="73152" marT="27432" marB="27432" anchor="ctr">
+                    <a:solidFill>
+                      <a:srgbClr val="E6F4EC"/>
+                    </a:solidFill>
+                  </a:tcPr>
+                </a:tc>
+              </a:tr>
+              <a:tr h="420624">
+                <a:tc>
+                  <a:txBody>
+                    <a:bodyPr/>
+                    <a:lstStyle/>
+                    <a:p>
+                      <a:pPr algn="l"/>
+                      <a:r>
+                        <a:rPr sz="1300" b="0">
+                          <a:solidFill>
+                            <a:srgbClr val="3C3C3B"/>
+                          </a:solidFill>
+                          <a:latin typeface="Aptos"/>
+                        </a:rPr>
+                        <a:t>FEP NPV, hold</a:t>
+                      </a:r>
+                    </a:p>
+                  </a:txBody>
+                  <a:tcPr marL="73152" marR="73152" marT="27432" marB="27432" anchor="ctr">
+                    <a:solidFill>
+                      <a:srgbClr val="F2F2F2"/>
+                    </a:solidFill>
+                  </a:tcPr>
+                </a:tc>
+                <a:tc>
+                  <a:txBody>
+                    <a:bodyPr/>
+                    <a:lstStyle/>
+                    <a:p>
+                      <a:pPr algn="l"/>
+                      <a:r>
+                        <a:rPr sz="1300" b="0">
+                          <a:solidFill>
+                            <a:srgbClr val="919191"/>
+                          </a:solidFill>
+                          <a:latin typeface="Aptos"/>
+                        </a:rPr>
+                        <a:t>€ m</a:t>
+                      </a:r>
+                    </a:p>
+                  </a:txBody>
+                  <a:tcPr marL="73152" marR="73152" marT="27432" marB="27432" anchor="ctr">
+                    <a:solidFill>
+                      <a:srgbClr val="F2F2F2"/>
+                    </a:solidFill>
+                  </a:tcPr>
+                </a:tc>
+                <a:tc>
+                  <a:txBody>
+                    <a:bodyPr/>
+                    <a:lstStyle/>
+                    <a:p>
+                      <a:pPr algn="r"/>
+                      <a:r>
+                        <a:rPr sz="1300" b="0">
+                          <a:solidFill>
+                            <a:srgbClr val="3C3C3B"/>
+                          </a:solidFill>
+                          <a:latin typeface="Aptos"/>
+                        </a:rPr>
+                        <a:t>(2.4) / 15.7</a:t>
+                      </a:r>
+                    </a:p>
+                  </a:txBody>
+                  <a:tcPr marL="73152" marR="73152" marT="27432" marB="27432" anchor="ctr">
+                    <a:noFill/>
+                  </a:tcPr>
+                </a:tc>
+                <a:tc>
+                  <a:txBody>
+                    <a:bodyPr/>
+                    <a:lstStyle/>
+                    <a:p>
+                      <a:pPr algn="r"/>
+                      <a:r>
+                        <a:rPr sz="1300" b="0">
+                          <a:solidFill>
+                            <a:srgbClr val="3C3C3B"/>
+                          </a:solidFill>
+                          <a:latin typeface="Aptos"/>
+                        </a:rPr>
+                        <a:t>20.2 / 36.5</a:t>
+                      </a:r>
+                    </a:p>
+                  </a:txBody>
+                  <a:tcPr marL="73152" marR="73152" marT="27432" marB="27432" anchor="ctr">
+                    <a:noFill/>
+                  </a:tcPr>
+                </a:tc>
+                <a:tc>
+                  <a:txBody>
+                    <a:bodyPr/>
+                    <a:lstStyle/>
+                    <a:p>
+                      <a:pPr algn="r"/>
+                      <a:r>
+                        <a:rPr sz="1300" b="0">
+                          <a:solidFill>
+                            <a:srgbClr val="3C3C3B"/>
+                          </a:solidFill>
+                          <a:latin typeface="Aptos"/>
+                        </a:rPr>
+                        <a:t>25.6 / 41.9</a:t>
+                      </a:r>
+                    </a:p>
+                  </a:txBody>
+                  <a:tcPr marL="73152" marR="73152" marT="27432" marB="27432" anchor="ctr">
+                    <a:noFill/>
+                  </a:tcPr>
+                </a:tc>
+              </a:tr>
+              <a:tr h="420624">
+                <a:tc>
+                  <a:txBody>
+                    <a:bodyPr/>
+                    <a:lstStyle/>
+                    <a:p>
+                      <a:pPr algn="l"/>
+                      <a:r>
+                        <a:rPr sz="1300" b="0">
+                          <a:solidFill>
+                            <a:srgbClr val="3C3C3B"/>
+                          </a:solidFill>
+                          <a:latin typeface="Aptos"/>
+                        </a:rPr>
+                        <a:t>Minimum DSCR</a:t>
+                      </a:r>
+                    </a:p>
+                  </a:txBody>
+                  <a:tcPr marL="73152" marR="73152" marT="27432" marB="27432" anchor="ctr">
+                    <a:solidFill>
+                      <a:srgbClr val="F2F2F2"/>
+                    </a:solidFill>
+                  </a:tcPr>
+                </a:tc>
+                <a:tc>
+                  <a:txBody>
+                    <a:bodyPr/>
+                    <a:lstStyle/>
+                    <a:p>
+                      <a:pPr algn="l"/>
+                      <a:r>
+                        <a:rPr sz="1300" b="0">
+                          <a:solidFill>
+                            <a:srgbClr val="919191"/>
+                          </a:solidFill>
+                          <a:latin typeface="Aptos"/>
+                        </a:rPr>
+                        <a:t>x</a:t>
+                      </a:r>
+                    </a:p>
+                  </a:txBody>
+                  <a:tcPr marL="73152" marR="73152" marT="27432" marB="27432" anchor="ctr">
+                    <a:solidFill>
+                      <a:srgbClr val="F2F2F2"/>
+                    </a:solidFill>
+                  </a:tcPr>
+                </a:tc>
+                <a:tc>
+                  <a:txBody>
+                    <a:bodyPr/>
+                    <a:lstStyle/>
+                    <a:p>
+                      <a:pPr algn="r"/>
+                      <a:r>
+                        <a:rPr sz="1300" b="0">
+                          <a:solidFill>
+                            <a:srgbClr val="3C3C3B"/>
+                          </a:solidFill>
+                          <a:latin typeface="Aptos"/>
+                        </a:rPr>
+                        <a:t>1.63x / 2.15x</a:t>
+                      </a:r>
+                    </a:p>
+                  </a:txBody>
+                  <a:tcPr marL="73152" marR="73152" marT="27432" marB="27432" anchor="ctr">
+                    <a:noFill/>
+                  </a:tcPr>
+                </a:tc>
+                <a:tc>
+                  <a:txBody>
+                    <a:bodyPr/>
+                    <a:lstStyle/>
+                    <a:p>
+                      <a:pPr algn="r"/>
+                      <a:r>
+                        <a:rPr sz="1300" b="0">
+                          <a:solidFill>
+                            <a:srgbClr val="3C3C3B"/>
+                          </a:solidFill>
+                          <a:latin typeface="Aptos"/>
+                        </a:rPr>
+                        <a:t>1.96x / 2.63x</a:t>
+                      </a:r>
+                    </a:p>
+                  </a:txBody>
+                  <a:tcPr marL="73152" marR="73152" marT="27432" marB="27432" anchor="ctr">
+                    <a:noFill/>
+                  </a:tcPr>
+                </a:tc>
+                <a:tc>
+                  <a:txBody>
+                    <a:bodyPr/>
+                    <a:lstStyle/>
+                    <a:p>
+                      <a:pPr algn="r"/>
+                      <a:r>
+                        <a:rPr sz="1300" b="0">
+                          <a:solidFill>
+                            <a:srgbClr val="3C3C3B"/>
+                          </a:solidFill>
+                          <a:latin typeface="Aptos"/>
+                        </a:rPr>
+                        <a:t>2.07x / 2.78x</a:t>
+                      </a:r>
+                    </a:p>
+                  </a:txBody>
+                  <a:tcPr marL="73152" marR="73152" marT="27432" marB="27432" anchor="ctr">
+                    <a:noFill/>
+                  </a:tcPr>
+                </a:tc>
+              </a:tr>
+              <a:tr h="420624">
+                <a:tc>
+                  <a:txBody>
+                    <a:bodyPr/>
+                    <a:lstStyle/>
+                    <a:p>
+                      <a:pPr algn="l"/>
+                      <a:r>
+                        <a:rPr sz="1300" b="0">
+                          <a:solidFill>
+                            <a:srgbClr val="3C3C3B"/>
+                          </a:solidFill>
+                          <a:latin typeface="Aptos"/>
+                        </a:rPr>
+                        <a:t>Buyer IRR, unlevered</a:t>
+                      </a:r>
+                    </a:p>
+                  </a:txBody>
+                  <a:tcPr marL="73152" marR="73152" marT="27432" marB="27432" anchor="ctr">
+                    <a:solidFill>
+                      <a:srgbClr val="F2F2F2"/>
+                    </a:solidFill>
+                  </a:tcPr>
+                </a:tc>
+                <a:tc>
+                  <a:txBody>
+                    <a:bodyPr/>
+                    <a:lstStyle/>
+                    <a:p>
+                      <a:pPr algn="l"/>
+                      <a:r>
+                        <a:rPr sz="1300" b="0">
+                          <a:solidFill>
+                            <a:srgbClr val="919191"/>
+                          </a:solidFill>
+                          <a:latin typeface="Aptos"/>
+                        </a:rPr>
+                        <a:t>%</a:t>
+                      </a:r>
+                    </a:p>
+                  </a:txBody>
+                  <a:tcPr marL="73152" marR="73152" marT="27432" marB="27432" anchor="ctr">
+                    <a:solidFill>
+                      <a:srgbClr val="F2F2F2"/>
+                    </a:solidFill>
+                  </a:tcPr>
+                </a:tc>
+                <a:tc>
+                  <a:txBody>
+                    <a:bodyPr/>
+                    <a:lstStyle/>
+                    <a:p>
+                      <a:pPr algn="r"/>
+                      <a:r>
+                        <a:rPr sz="1300" b="0">
+                          <a:solidFill>
+                            <a:srgbClr val="3C3C3B"/>
+                          </a:solidFill>
+                          <a:latin typeface="Aptos"/>
+                        </a:rPr>
+                        <a:t>5.7% / 7.0%</a:t>
+                      </a:r>
+                    </a:p>
+                  </a:txBody>
+                  <a:tcPr marL="73152" marR="73152" marT="27432" marB="27432" anchor="ctr">
+                    <a:noFill/>
+                  </a:tcPr>
+                </a:tc>
+                <a:tc>
+                  <a:txBody>
+                    <a:bodyPr/>
+                    <a:lstStyle/>
+                    <a:p>
+                      <a:pPr algn="r"/>
+                      <a:r>
+                        <a:rPr sz="1300" b="0">
+                          <a:solidFill>
+                            <a:srgbClr val="3C3C3B"/>
+                          </a:solidFill>
+                          <a:latin typeface="Aptos"/>
+                        </a:rPr>
+                        <a:t>8.1% / 9.7%</a:t>
+                      </a:r>
+                    </a:p>
+                  </a:txBody>
+                  <a:tcPr marL="73152" marR="73152" marT="27432" marB="27432" anchor="ctr">
+                    <a:noFill/>
+                  </a:tcPr>
+                </a:tc>
+                <a:tc>
+                  <a:txBody>
+                    <a:bodyPr/>
+                    <a:lstStyle/>
+                    <a:p>
+                      <a:pPr algn="r"/>
+                      <a:r>
+                        <a:rPr sz="1300" b="0">
+                          <a:solidFill>
+                            <a:srgbClr val="3C3C3B"/>
+                          </a:solidFill>
+                          <a:latin typeface="Aptos"/>
+                        </a:rPr>
+                        <a:t>8.8% / 10.4%</a:t>
+                      </a:r>
+                    </a:p>
+                  </a:txBody>
+                  <a:tcPr marL="73152" marR="73152" marT="27432" marB="27432" anchor="ctr">
+                    <a:noFill/>
+                  </a:tcPr>
+                </a:tc>
+              </a:tr>
+            </a:tbl>
+          </a:graphicData>
+        </a:graphic>
+      </p:graphicFrame>
+      <p:sp>
+        <p:nvSpPr>
+          <p:cNvPr id="6" name="Card"/>
+          <p:cNvSpPr/>
+          <p:nvPr/>
+        </p:nvSpPr>
+        <p:spPr>
+          <a:xfrm>
+            <a:off x="14127480" y="2240280"/>
+            <a:ext cx="4069080" cy="6949440"/>
+          </a:xfrm>
+          <a:prstGeom prst="rect">
+            <a:avLst/>
+          </a:prstGeom>
+          <a:solidFill>
+            <a:srgbClr val="F2F2F2"/>
+          </a:solidFill>
+          <a:ln>
+            <a:noFill/>
+          </a:ln>
+          <a:effectLst/>
+        </p:spPr>
+        <p:style>
+          <a:lnRef idx="1">
+            <a:schemeClr val="accent1"/>
+          </a:lnRef>
+          <a:fillRef idx="3">
+            <a:schemeClr val="accent1"/>
+          </a:fillRef>
+          <a:effectRef idx="2">
+            <a:schemeClr val="accent1"/>
+          </a:effectRef>
+          <a:fontRef idx="minor">
+            <a:schemeClr val="lt1"/>
+          </a:fontRef>
+        </p:style>
+        <p:txBody>
+          <a:bodyPr rtlCol="0" anchor="t" wrap="square" lIns="182880" rIns="182880" tIns="137160"/>
+          <a:lstStyle/>
+          <a:p>
+            <a:pPr algn="l"/>
+            <a:r>
+              <a:rPr sz="1600" b="1">
+                <a:solidFill>
+                  <a:srgbClr val="00563C"/>
+                </a:solidFill>
+                <a:latin typeface="Aptos"/>
+              </a:rPr>
+              <a:t>Why, and what to check</a:t>
+            </a:r>
+          </a:p>
+          <a:p>
+            <a:pPr algn="l">
+              <a:spcBef>
+                <a:spcPts val="800"/>
+              </a:spcBef>
+            </a:pPr>
+            <a:r>
+              <a:rPr sz="1300" b="1">
+                <a:solidFill>
+                  <a:srgbClr val="3C3C3B"/>
+                </a:solidFill>
+                <a:latin typeface="Aptos"/>
+              </a:rPr>
+              <a:t>Yield: </a:t>
+            </a:r>
+            <a:r>
+              <a:rPr sz="1300" b="0">
+                <a:solidFill>
+                  <a:srgbClr val="3C3C3B"/>
+                </a:solidFill>
+                <a:latin typeface="Aptos"/>
+              </a:rPr>
+              <a:t>2,850 h instead of 2,600; the EYA is not in the data room, so this needs the study first.</a:t>
+            </a:r>
+          </a:p>
+          <a:p>
+            <a:pPr algn="l">
+              <a:spcBef>
+                <a:spcPts val="800"/>
+              </a:spcBef>
+            </a:pPr>
+            <a:r>
+              <a:rPr sz="1300" b="1">
+                <a:solidFill>
+                  <a:srgbClr val="3C3C3B"/>
+                </a:solidFill>
+                <a:latin typeface="Aptos"/>
+              </a:rPr>
+              <a:t>Zero bid: </a:t>
+            </a:r>
+            <a:r>
+              <a:rPr sz="1300" b="0">
+                <a:solidFill>
+                  <a:srgbClr val="3C3C3B"/>
+                </a:solidFill>
+                <a:latin typeface="Aptos"/>
+              </a:rPr>
+              <a:t>no overbuild and no BESS; municipal 10 k€/MW and community 2.0 €/MWh, the minimum the law may make mandatory anyway. Total uses fall from €113.4m to €100.2m (European).</a:t>
+            </a:r>
+          </a:p>
+          <a:p>
+            <a:pPr algn="l">
+              <a:spcBef>
+                <a:spcPts val="800"/>
+              </a:spcBef>
+            </a:pPr>
+            <a:r>
+              <a:rPr sz="1300" b="1">
+                <a:solidFill>
+                  <a:srgbClr val="3C3C3B"/>
+                </a:solidFill>
+                <a:latin typeface="Aptos"/>
+              </a:rPr>
+              <a:t>PPA: </a:t>
+            </a:r>
+            <a:r>
+              <a:rPr sz="1300" b="0">
+                <a:solidFill>
+                  <a:srgbClr val="3C3C3B"/>
+                </a:solidFill>
+                <a:latin typeface="Aptos"/>
+              </a:rPr>
+              <a:t>COD is 2030 at the earliest, which leaves two years to sign a bankable long-term PPA. Aurora is conservative, and today's high prices may last longer than expected.</a:t>
+            </a:r>
+          </a:p>
+          <a:p>
+            <a:pPr algn="l">
+              <a:spcBef>
+                <a:spcPts val="800"/>
+              </a:spcBef>
+            </a:pPr>
+            <a:r>
+              <a:rPr sz="1300" b="1">
+                <a:solidFill>
+                  <a:srgbClr val="3C3C3B"/>
+                </a:solidFill>
+                <a:latin typeface="Aptos"/>
+              </a:rPr>
+              <a:t>Sale at COD: </a:t>
+            </a:r>
+            <a:r>
+              <a:rPr sz="1300" b="0">
+                <a:solidFill>
+                  <a:srgbClr val="3C3C3B"/>
+                </a:solidFill>
+                <a:latin typeface="Aptos"/>
+              </a:rPr>
+              <a:t>the same in both upside cases, because the sale price is fixed per MW; a higher PPA would support a higher price.</a:t>
+            </a:r>
+          </a:p>
+        </p:txBody>
+      </p:sp>
+      <p:sp>
+        <p:nvSpPr>
+          <p:cNvPr id="7" name="Footnote"/>
+          <p:cNvSpPr txBox="1"/>
+          <p:nvPr/>
+        </p:nvSpPr>
+        <p:spPr>
+          <a:xfrm>
+            <a:off x="4498848" y="9646920"/>
+            <a:ext cx="13167360" cy="640080"/>
+          </a:xfrm>
+          <a:prstGeom prst="rect">
+            <a:avLst/>
+          </a:prstGeom>
+          <a:noFill/>
+        </p:spPr>
+        <p:txBody>
+          <a:bodyPr wrap="square">
+            <a:spAutoFit/>
+          </a:bodyPr>
+          <a:lstStyle/>
+          <a:p>
+            <a:r>
+              <a:rPr sz="1100" b="0">
+                <a:solidFill>
+                  <a:srgbClr val="919191"/>
+                </a:solidFill>
+                <a:latin typeface="Aptos"/>
+              </a:rPr>
+              <a:t>Upside sets change only the inputs in the table, from the base; the zero bid keeps the turbine route and the PB multiple. Stored by the scenario macro with the tax solver.</a:t>
+            </a:r>
+          </a:p>
+          <a:p>
+            <a:r>
+              <a:rPr sz="1100" b="0">
+                <a:solidFill>
+                  <a:srgbClr val="919191"/>
+                </a:solidFill>
+                <a:latin typeface="Aptos"/>
+              </a:rPr>
+              <a:t>Source: Bana_Model_20261018.xlsm, 18 Oct 2026.</a:t>
+            </a:r>
+          </a:p>
+        </p:txBody>
+      </p:sp>
+    </p:spTree>
+  </p:cSld>
+  <p:clrMapOvr>
+    <a:masterClrMapping/>
+  </p:clrMapOvr>
+</p:sld>
+</file>
+
+<file path=ppt/slides/slide11.xml><?xml version="1.0" encoding="utf-8"?>
+<p:sld xmlns:a="http://schemas.openxmlformats.org/drawingml/2006/main" xmlns:p="http://schemas.openxmlformats.org/presentationml/2006/main" xmlns:r="http://schemas.openxmlformats.org/officeDocument/2006/relationships">
+  <p:cSld>
+    <p:spTree>
+      <p:nvGrpSpPr>
+        <p:cNvPr id="1" name=""/>
+        <p:cNvGrpSpPr/>
+        <p:nvPr/>
+      </p:nvGrpSpPr>
+      <p:grpSpPr/>
+      <p:sp>
+        <p:nvSpPr>
+          <p:cNvPr id="2" name="Title 1"/>
+          <p:cNvSpPr>
+            <a:spLocks noGrp="1"/>
+          </p:cNvSpPr>
+          <p:nvPr>
+            <p:ph type="title"/>
+          </p:nvPr>
+        </p:nvSpPr>
+        <p:spPr>
+          <a:xfrm>
+            <a:off x="4498848" y="182880"/>
+            <a:ext cx="12710160" cy="1097280"/>
+          </a:xfrm>
+        </p:spPr>
+        <p:txBody>
+          <a:bodyPr wrap="square"/>
+          <a:lstStyle/>
+          <a:p>
+            <a:r>
               <a:t>A lower COD price hits the sale most (9.7%); Robin Hood tax (5.7%) and lower yield (6.0%) hit the hold</a:t>
             </a:r>
           </a:p>
@@ -6095,7 +8591,7 @@
         </p:nvGraphicFramePr>
         <p:xfrm>
           <a:off x="0" y="0"/>
-          <a:ext cx="3767328" cy="6995159"/>
+          <a:ext cx="3767328" cy="7772400"/>
         </p:xfrm>
         <a:graphic>
           <a:graphicData uri="http://schemas.openxmlformats.org/drawingml/2006/table">
@@ -6106,7 +8602,7 @@
               <a:tblGrid>
                 <a:gridCol w="3767328"/>
               </a:tblGrid>
-              <a:tr h="777239">
+              <a:tr h="777240">
                 <a:tc>
                   <a:txBody>
                     <a:bodyPr/>
@@ -6144,7 +8640,7 @@
                   </a:tcPr>
                 </a:tc>
               </a:tr>
-              <a:tr h="777239">
+              <a:tr h="777240">
                 <a:tc>
                   <a:txBody>
                     <a:bodyPr/>
@@ -6182,7 +8678,7 @@
                   </a:tcPr>
                 </a:tc>
               </a:tr>
-              <a:tr h="777239">
+              <a:tr h="777240">
                 <a:tc>
                   <a:txBody>
                     <a:bodyPr/>
@@ -6220,7 +8716,7 @@
                   </a:tcPr>
                 </a:tc>
               </a:tr>
-              <a:tr h="777239">
+              <a:tr h="777240">
                 <a:tc>
                   <a:txBody>
                     <a:bodyPr/>
@@ -6258,7 +8754,7 @@
                   </a:tcPr>
                 </a:tc>
               </a:tr>
-              <a:tr h="777239">
+              <a:tr h="777240">
                 <a:tc>
                   <a:txBody>
                     <a:bodyPr/>
@@ -6296,7 +8792,7 @@
                   </a:tcPr>
                 </a:tc>
               </a:tr>
-              <a:tr h="777239">
+              <a:tr h="777240">
                 <a:tc>
                   <a:txBody>
                     <a:bodyPr/>
@@ -6334,7 +8830,7 @@
                   </a:tcPr>
                 </a:tc>
               </a:tr>
-              <a:tr h="777239">
+              <a:tr h="777240">
                 <a:tc>
                   <a:txBody>
                     <a:bodyPr/>
@@ -6372,7 +8868,7 @@
                   </a:tcPr>
                 </a:tc>
               </a:tr>
-              <a:tr h="777239">
+              <a:tr h="777240">
                 <a:tc>
                   <a:txBody>
                     <a:bodyPr/>
@@ -6410,7 +8906,45 @@
                   </a:tcPr>
                 </a:tc>
               </a:tr>
-              <a:tr h="777247">
+              <a:tr h="777240">
+                <a:tc>
+                  <a:txBody>
+                    <a:bodyPr/>
+                    <a:lstStyle/>
+                    <a:p>
+                      <a:r>
+                        <a:rPr sz="1800" b="0">
+                          <a:solidFill>
+                            <a:srgbClr val="3C3C3B"/>
+                          </a:solidFill>
+                          <a:latin typeface="Aptos"/>
+                        </a:rPr>
+                        <a:t>Upside case</a:t>
+                      </a:r>
+                    </a:p>
+                  </a:txBody>
+                  <a:tcPr marL="180000" anchor="ctr">
+                    <a:lnL>
+                      <a:noFill/>
+                    </a:lnL>
+                    <a:lnR>
+                      <a:noFill/>
+                    </a:lnR>
+                    <a:lnT w="6350">
+                      <a:solidFill>
+                        <a:srgbClr val="3C3C3B"/>
+                      </a:solidFill>
+                    </a:lnT>
+                    <a:lnB w="6350">
+                      <a:solidFill>
+                        <a:srgbClr val="3C3C3B"/>
+                      </a:solidFill>
+                    </a:lnB>
+                    <a:noFill/>
+                  </a:tcPr>
+                </a:tc>
+              </a:tr>
+              <a:tr h="777240">
                 <a:tc>
                   <a:txBody>
                     <a:bodyPr/>
@@ -10447,7 +12981,7 @@
                 </a:solidFill>
                 <a:latin typeface="Aptos"/>
               </a:rPr>
-              <a:t>Source: Bana_Model_20261015.xlsm, 15 Oct 2026.</a:t>
+              <a:t>Source: Bana_Model_20261018.xlsm, 18 Oct 2026.</a:t>
             </a:r>
           </a:p>
         </p:txBody>
@@ -10553,7 +13087,7 @@
         </p:nvGraphicFramePr>
         <p:xfrm>
           <a:off x="0" y="0"/>
-          <a:ext cx="3767328" cy="6995159"/>
+          <a:ext cx="3767328" cy="7772400"/>
         </p:xfrm>
         <a:graphic>
           <a:graphicData uri="http://schemas.openxmlformats.org/drawingml/2006/table">
@@ -10564,7 +13098,7 @@
               <a:tblGrid>
                 <a:gridCol w="3767328"/>
               </a:tblGrid>
-              <a:tr h="777239">
+              <a:tr h="777240">
                 <a:tc>
                   <a:txBody>
                     <a:bodyPr/>
@@ -10612,7 +13146,7 @@
                   </a:tcPr>
                 </a:tc>
               </a:tr>
-              <a:tr h="777239">
+              <a:tr h="777240">
                 <a:tc>
                   <a:txBody>
                     <a:bodyPr/>
@@ -10650,7 +13184,7 @@
                   </a:tcPr>
                 </a:tc>
               </a:tr>
-              <a:tr h="777239">
+              <a:tr h="777240">
                 <a:tc>
                   <a:txBody>
                     <a:bodyPr/>
@@ -10688,7 +13222,7 @@
                   </a:tcPr>
                 </a:tc>
               </a:tr>
-              <a:tr h="777239">
+              <a:tr h="777240">
                 <a:tc>
                   <a:txBody>
                     <a:bodyPr/>
@@ -10726,7 +13260,7 @@
                   </a:tcPr>
                 </a:tc>
               </a:tr>
-              <a:tr h="777239">
+              <a:tr h="777240">
                 <a:tc>
                   <a:txBody>
                     <a:bodyPr/>
@@ -10764,7 +13298,7 @@
                   </a:tcPr>
                 </a:tc>
               </a:tr>
-              <a:tr h="777239">
+              <a:tr h="777240">
                 <a:tc>
                   <a:txBody>
                     <a:bodyPr/>
@@ -10802,7 +13336,7 @@
                   </a:tcPr>
                 </a:tc>
               </a:tr>
-              <a:tr h="777239">
+              <a:tr h="777240">
                 <a:tc>
                   <a:txBody>
                     <a:bodyPr/>
@@ -10840,7 +13374,7 @@
                   </a:tcPr>
                 </a:tc>
               </a:tr>
-              <a:tr h="777239">
+              <a:tr h="777240">
                 <a:tc>
                   <a:txBody>
                     <a:bodyPr/>
@@ -10878,7 +13412,45 @@
                   </a:tcPr>
                 </a:tc>
               </a:tr>
-              <a:tr h="777247">
+              <a:tr h="777240">
+                <a:tc>
+                  <a:txBody>
+                    <a:bodyPr/>
+                    <a:lstStyle/>
+                    <a:p>
+                      <a:r>
+                        <a:rPr sz="1800" b="0">
+                          <a:solidFill>
+                            <a:srgbClr val="3C3C3B"/>
+                          </a:solidFill>
+                          <a:latin typeface="Aptos"/>
+                        </a:rPr>
+                        <a:t>Upside case</a:t>
+                      </a:r>
+                    </a:p>
+                  </a:txBody>
+                  <a:tcPr marL="180000" anchor="ctr">
+                    <a:lnL>
+                      <a:noFill/>
+                    </a:lnL>
+                    <a:lnR>
+                      <a:noFill/>
+                    </a:lnR>
+                    <a:lnT w="6350">
+                      <a:solidFill>
+                        <a:srgbClr val="3C3C3B"/>
+                      </a:solidFill>
+                    </a:lnT>
+                    <a:lnB w="6350">
+                      <a:solidFill>
+                        <a:srgbClr val="3C3C3B"/>
+                      </a:solidFill>
+                    </a:lnB>
+                    <a:noFill/>
+                  </a:tcPr>
+                </a:tc>
+              </a:tr>
+              <a:tr h="777240">
                 <a:tc>
                   <a:txBody>
                     <a:bodyPr/>
@@ -12392,7 +14964,7 @@
                 </a:solidFill>
                 <a:latin typeface="Aptos"/>
               </a:rPr>
-              <a:t>Source: Bana_Model_20261015.xlsm, 15 Oct 2026.</a:t>
+              <a:t>Source: Bana_Model_20261018.xlsm, 18 Oct 2026.</a:t>
             </a:r>
           </a:p>
         </p:txBody>
@@ -12498,7 +15070,7 @@
         </p:nvGraphicFramePr>
         <p:xfrm>
           <a:off x="0" y="0"/>
-          <a:ext cx="3767328" cy="6995159"/>
+          <a:ext cx="3767328" cy="7772400"/>
         </p:xfrm>
         <a:graphic>
           <a:graphicData uri="http://schemas.openxmlformats.org/drawingml/2006/table">
@@ -12509,7 +15081,7 @@
               <a:tblGrid>
                 <a:gridCol w="3767328"/>
               </a:tblGrid>
-              <a:tr h="777239">
+              <a:tr h="777240">
                 <a:tc>
                   <a:txBody>
                     <a:bodyPr/>
@@ -12547,7 +15119,7 @@
                   </a:tcPr>
                 </a:tc>
               </a:tr>
-              <a:tr h="777239">
+              <a:tr h="777240">
                 <a:tc>
                   <a:txBody>
                     <a:bodyPr/>
@@ -12595,7 +15167,7 @@
                   </a:tcPr>
                 </a:tc>
               </a:tr>
-              <a:tr h="777239">
+              <a:tr h="777240">
                 <a:tc>
                   <a:txBody>
                     <a:bodyPr/>
@@ -12633,7 +15205,7 @@
                   </a:tcPr>
                 </a:tc>
               </a:tr>
-              <a:tr h="777239">
+              <a:tr h="777240">
                 <a:tc>
                   <a:txBody>
                     <a:bodyPr/>
@@ -12671,7 +15243,7 @@
                   </a:tcPr>
                 </a:tc>
               </a:tr>
-              <a:tr h="777239">
+              <a:tr h="777240">
                 <a:tc>
                   <a:txBody>
                     <a:bodyPr/>
@@ -12709,7 +15281,7 @@
                   </a:tcPr>
                 </a:tc>
               </a:tr>
-              <a:tr h="777239">
+              <a:tr h="777240">
                 <a:tc>
                   <a:txBody>
                     <a:bodyPr/>
@@ -12747,7 +15319,7 @@
                   </a:tcPr>
                 </a:tc>
               </a:tr>
-              <a:tr h="777239">
+              <a:tr h="777240">
                 <a:tc>
                   <a:txBody>
                     <a:bodyPr/>
@@ -12785,7 +15357,7 @@
                   </a:tcPr>
                 </a:tc>
               </a:tr>
-              <a:tr h="777239">
+              <a:tr h="777240">
                 <a:tc>
                   <a:txBody>
                     <a:bodyPr/>
@@ -12823,7 +15395,45 @@
                   </a:tcPr>
                 </a:tc>
               </a:tr>
-              <a:tr h="777247">
+              <a:tr h="777240">
+                <a:tc>
+                  <a:txBody>
+                    <a:bodyPr/>
+                    <a:lstStyle/>
+                    <a:p>
+                      <a:r>
+                        <a:rPr sz="1800" b="0">
+                          <a:solidFill>
+                            <a:srgbClr val="3C3C3B"/>
+                          </a:solidFill>
+                          <a:latin typeface="Aptos"/>
+                        </a:rPr>
+                        <a:t>Upside case</a:t>
+                      </a:r>
+                    </a:p>
+                  </a:txBody>
+                  <a:tcPr marL="180000" anchor="ctr">
+                    <a:lnL>
+                      <a:noFill/>
+                    </a:lnL>
+                    <a:lnR>
+                      <a:noFill/>
+                    </a:lnR>
+                    <a:lnT w="6350">
+                      <a:solidFill>
+                        <a:srgbClr val="3C3C3B"/>
+                      </a:solidFill>
+                    </a:lnT>
+                    <a:lnB w="6350">
+                      <a:solidFill>
+                        <a:srgbClr val="3C3C3B"/>
+                      </a:solidFill>
+                    </a:lnB>
+                    <a:noFill/>
+                  </a:tcPr>
+                </a:tc>
+              </a:tr>
+              <a:tr h="777240">
                 <a:tc>
                   <a:txBody>
                     <a:bodyPr/>
@@ -14445,7 +17055,7 @@
         </p:nvGraphicFramePr>
         <p:xfrm>
           <a:off x="0" y="0"/>
-          <a:ext cx="3767328" cy="6995159"/>
+          <a:ext cx="3767328" cy="7772400"/>
         </p:xfrm>
         <a:graphic>
           <a:graphicData uri="http://schemas.openxmlformats.org/drawingml/2006/table">
@@ -14456,7 +17066,7 @@
               <a:tblGrid>
                 <a:gridCol w="3767328"/>
               </a:tblGrid>
-              <a:tr h="777239">
+              <a:tr h="777240">
                 <a:tc>
                   <a:txBody>
                     <a:bodyPr/>
@@ -14494,7 +17104,7 @@
                   </a:tcPr>
                 </a:tc>
               </a:tr>
-              <a:tr h="777239">
+              <a:tr h="777240">
                 <a:tc>
                   <a:txBody>
                     <a:bodyPr/>
@@ -14532,7 +17142,7 @@
                   </a:tcPr>
                 </a:tc>
               </a:tr>
-              <a:tr h="777239">
+              <a:tr h="777240">
                 <a:tc>
                   <a:txBody>
                     <a:bodyPr/>
@@ -14580,7 +17190,7 @@
                   </a:tcPr>
                 </a:tc>
               </a:tr>
-              <a:tr h="777239">
+              <a:tr h="777240">
                 <a:tc>
                   <a:txBody>
                     <a:bodyPr/>
@@ -14618,7 +17228,7 @@
                   </a:tcPr>
                 </a:tc>
               </a:tr>
-              <a:tr h="777239">
+              <a:tr h="777240">
                 <a:tc>
                   <a:txBody>
                     <a:bodyPr/>
@@ -14656,7 +17266,7 @@
                   </a:tcPr>
                 </a:tc>
               </a:tr>
-              <a:tr h="777239">
+              <a:tr h="777240">
                 <a:tc>
                   <a:txBody>
                     <a:bodyPr/>
@@ -14694,7 +17304,7 @@
                   </a:tcPr>
                 </a:tc>
               </a:tr>
-              <a:tr h="777239">
+              <a:tr h="777240">
                 <a:tc>
                   <a:txBody>
                     <a:bodyPr/>
@@ -14732,7 +17342,7 @@
                   </a:tcPr>
                 </a:tc>
               </a:tr>
-              <a:tr h="777239">
+              <a:tr h="777240">
                 <a:tc>
                   <a:txBody>
                     <a:bodyPr/>
@@ -14770,7 +17380,45 @@
                   </a:tcPr>
                 </a:tc>
               </a:tr>
-              <a:tr h="777247">
+              <a:tr h="777240">
+                <a:tc>
+                  <a:txBody>
+                    <a:bodyPr/>
+                    <a:lstStyle/>
+                    <a:p>
+                      <a:r>
+                        <a:rPr sz="1800" b="0">
+                          <a:solidFill>
+                            <a:srgbClr val="3C3C3B"/>
+                          </a:solidFill>
+                          <a:latin typeface="Aptos"/>
+                        </a:rPr>
+                        <a:t>Upside case</a:t>
+                      </a:r>
+                    </a:p>
+                  </a:txBody>
+                  <a:tcPr marL="180000" anchor="ctr">
+                    <a:lnL>
+                      <a:noFill/>
+                    </a:lnL>
+                    <a:lnR>
+                      <a:noFill/>
+                    </a:lnR>
+                    <a:lnT w="6350">
+                      <a:solidFill>
+                        <a:srgbClr val="3C3C3B"/>
+                      </a:solidFill>
+                    </a:lnT>
+                    <a:lnB w="6350">
+                      <a:solidFill>
+                        <a:srgbClr val="3C3C3B"/>
+                      </a:solidFill>
+                    </a:lnB>
+                    <a:noFill/>
+                  </a:tcPr>
+                </a:tc>
+              </a:tr>
+              <a:tr h="777240">
                 <a:tc>
                   <a:txBody>
                     <a:bodyPr/>
@@ -16399,7 +19047,7 @@
                 </a:solidFill>
                 <a:latin typeface="Aptos"/>
               </a:rPr>
-              <a:t>Source: Bana_Model_20261015.xlsm, 15 Oct 2026.</a:t>
+              <a:t>Source: Bana_Model_20261018.xlsm, 18 Oct 2026.</a:t>
             </a:r>
           </a:p>
         </p:txBody>
@@ -16505,7 +19153,7 @@
         </p:nvGraphicFramePr>
         <p:xfrm>
           <a:off x="0" y="0"/>
-          <a:ext cx="3767328" cy="6995159"/>
+          <a:ext cx="3767328" cy="7772400"/>
         </p:xfrm>
         <a:graphic>
           <a:graphicData uri="http://schemas.openxmlformats.org/drawingml/2006/table">
@@ -16516,7 +19164,7 @@
               <a:tblGrid>
                 <a:gridCol w="3767328"/>
               </a:tblGrid>
-              <a:tr h="777239">
+              <a:tr h="777240">
                 <a:tc>
                   <a:txBody>
                     <a:bodyPr/>
@@ -16554,7 +19202,7 @@
                   </a:tcPr>
                 </a:tc>
               </a:tr>
-              <a:tr h="777239">
+              <a:tr h="777240">
                 <a:tc>
                   <a:txBody>
                     <a:bodyPr/>
@@ -16592,7 +19240,7 @@
                   </a:tcPr>
                 </a:tc>
               </a:tr>
-              <a:tr h="777239">
+              <a:tr h="777240">
                 <a:tc>
                   <a:txBody>
                     <a:bodyPr/>
@@ -16630,7 +19278,7 @@
                   </a:tcPr>
                 </a:tc>
               </a:tr>
-              <a:tr h="777239">
+              <a:tr h="777240">
                 <a:tc>
                   <a:txBody>
                     <a:bodyPr/>
@@ -16678,7 +19326,7 @@
                   </a:tcPr>
                 </a:tc>
               </a:tr>
-              <a:tr h="777239">
+              <a:tr h="777240">
                 <a:tc>
                   <a:txBody>
                     <a:bodyPr/>
@@ -16716,7 +19364,7 @@
                   </a:tcPr>
                 </a:tc>
               </a:tr>
-              <a:tr h="777239">
+              <a:tr h="777240">
                 <a:tc>
                   <a:txBody>
                     <a:bodyPr/>
@@ -16754,7 +19402,7 @@
                   </a:tcPr>
                 </a:tc>
               </a:tr>
-              <a:tr h="777239">
+              <a:tr h="777240">
                 <a:tc>
                   <a:txBody>
                     <a:bodyPr/>
@@ -16792,7 +19440,7 @@
                   </a:tcPr>
                 </a:tc>
               </a:tr>
-              <a:tr h="777239">
+              <a:tr h="777240">
                 <a:tc>
                   <a:txBody>
                     <a:bodyPr/>
@@ -16830,7 +19478,45 @@
                   </a:tcPr>
                 </a:tc>
               </a:tr>
-              <a:tr h="777247">
+              <a:tr h="777240">
+                <a:tc>
+                  <a:txBody>
+                    <a:bodyPr/>
+                    <a:lstStyle/>
+                    <a:p>
+                      <a:r>
+                        <a:rPr sz="1800" b="0">
+                          <a:solidFill>
+                            <a:srgbClr val="3C3C3B"/>
+                          </a:solidFill>
+                          <a:latin typeface="Aptos"/>
+                        </a:rPr>
+                        <a:t>Upside case</a:t>
+                      </a:r>
+                    </a:p>
+                  </a:txBody>
+                  <a:tcPr marL="180000" anchor="ctr">
+                    <a:lnL>
+                      <a:noFill/>
+                    </a:lnL>
+                    <a:lnR>
+                      <a:noFill/>
+                    </a:lnR>
+                    <a:lnT w="6350">
+                      <a:solidFill>
+                        <a:srgbClr val="3C3C3B"/>
+                      </a:solidFill>
+                    </a:lnT>
+                    <a:lnB w="6350">
+                      <a:solidFill>
+                        <a:srgbClr val="3C3C3B"/>
+                      </a:solidFill>
+                    </a:lnB>
+                    <a:noFill/>
+                  </a:tcPr>
+                </a:tc>
+              </a:tr>
+              <a:tr h="777240">
                 <a:tc>
                   <a:txBody>
                     <a:bodyPr/>
@@ -18818,7 +21504,7 @@
                 </a:solidFill>
                 <a:latin typeface="Aptos"/>
               </a:rPr>
-              <a:t>Source: Bana_Model_20261015.xlsm, 15 Oct 2026.</a:t>
+              <a:t>Source: Bana_Model_20261018.xlsm, 18 Oct 2026.</a:t>
             </a:r>
           </a:p>
         </p:txBody>
@@ -18924,7 +21610,7 @@
         </p:nvGraphicFramePr>
         <p:xfrm>
           <a:off x="0" y="0"/>
-          <a:ext cx="3767328" cy="6995159"/>
+          <a:ext cx="3767328" cy="7772400"/>
         </p:xfrm>
         <a:graphic>
           <a:graphicData uri="http://schemas.openxmlformats.org/drawingml/2006/table">
@@ -18935,7 +21621,7 @@
               <a:tblGrid>
                 <a:gridCol w="3767328"/>
               </a:tblGrid>
-              <a:tr h="777239">
+              <a:tr h="777240">
                 <a:tc>
                   <a:txBody>
                     <a:bodyPr/>
@@ -18973,7 +21659,7 @@
                   </a:tcPr>
                 </a:tc>
               </a:tr>
-              <a:tr h="777239">
+              <a:tr h="777240">
                 <a:tc>
                   <a:txBody>
                     <a:bodyPr/>
@@ -19011,7 +21697,7 @@
                   </a:tcPr>
                 </a:tc>
               </a:tr>
-              <a:tr h="777239">
+              <a:tr h="777240">
                 <a:tc>
                   <a:txBody>
                     <a:bodyPr/>
@@ -19049,7 +21735,7 @@
                   </a:tcPr>
                 </a:tc>
               </a:tr>
-              <a:tr h="777239">
+              <a:tr h="777240">
                 <a:tc>
                   <a:txBody>
                     <a:bodyPr/>
@@ -19087,7 +21773,7 @@
                   </a:tcPr>
                 </a:tc>
               </a:tr>
-              <a:tr h="777239">
+              <a:tr h="777240">
                 <a:tc>
                   <a:txBody>
                     <a:bodyPr/>
@@ -19135,7 +21821,7 @@
                   </a:tcPr>
                 </a:tc>
               </a:tr>
-              <a:tr h="777239">
+              <a:tr h="777240">
                 <a:tc>
                   <a:txBody>
                     <a:bodyPr/>
@@ -19173,7 +21859,7 @@
                   </a:tcPr>
                 </a:tc>
               </a:tr>
-              <a:tr h="777239">
+              <a:tr h="777240">
                 <a:tc>
                   <a:txBody>
                     <a:bodyPr/>
@@ -19211,7 +21897,7 @@
                   </a:tcPr>
                 </a:tc>
               </a:tr>
-              <a:tr h="777239">
+              <a:tr h="777240">
                 <a:tc>
                   <a:txBody>
                     <a:bodyPr/>
@@ -19249,7 +21935,45 @@
                   </a:tcPr>
                 </a:tc>
               </a:tr>
-              <a:tr h="777247">
+              <a:tr h="777240">
+                <a:tc>
+                  <a:txBody>
+                    <a:bodyPr/>
+                    <a:lstStyle/>
+                    <a:p>
+                      <a:r>
+                        <a:rPr sz="1800" b="0">
+                          <a:solidFill>
+                            <a:srgbClr val="3C3C3B"/>
+                          </a:solidFill>
+                          <a:latin typeface="Aptos"/>
+                        </a:rPr>
+                        <a:t>Upside case</a:t>
+                      </a:r>
+                    </a:p>
+                  </a:txBody>
+                  <a:tcPr marL="180000" anchor="ctr">
+                    <a:lnL>
+                      <a:noFill/>
+                    </a:lnL>
+                    <a:lnR>
+                      <a:noFill/>
+                    </a:lnR>
+                    <a:lnT w="6350">
+                      <a:solidFill>
+                        <a:srgbClr val="3C3C3B"/>
+                      </a:solidFill>
+                    </a:lnT>
+                    <a:lnB w="6350">
+                      <a:solidFill>
+                        <a:srgbClr val="3C3C3B"/>
+                      </a:solidFill>
+                    </a:lnB>
+                    <a:noFill/>
+                  </a:tcPr>
+                </a:tc>
+              </a:tr>
+              <a:tr h="777240">
                 <a:tc>
                   <a:txBody>
                     <a:bodyPr/>
@@ -20724,7 +23448,7 @@
                 </a:solidFill>
                 <a:latin typeface="Aptos"/>
               </a:rPr>
-              <a:t>Source: Bana_Model_20261015.xlsm, 15 Oct 2026.</a:t>
+              <a:t>Source: Bana_Model_20261018.xlsm, 18 Oct 2026.</a:t>
             </a:r>
           </a:p>
         </p:txBody>
@@ -20830,7 +23554,7 @@
         </p:nvGraphicFramePr>
         <p:xfrm>
           <a:off x="0" y="0"/>
-          <a:ext cx="3767328" cy="6995159"/>
+          <a:ext cx="3767328" cy="7772400"/>
         </p:xfrm>
         <a:graphic>
           <a:graphicData uri="http://schemas.openxmlformats.org/drawingml/2006/table">
@@ -20841,7 +23565,7 @@
               <a:tblGrid>
                 <a:gridCol w="3767328"/>
               </a:tblGrid>
-              <a:tr h="777239">
+              <a:tr h="777240">
                 <a:tc>
                   <a:txBody>
                     <a:bodyPr/>
@@ -20879,7 +23603,7 @@
                   </a:tcPr>
                 </a:tc>
               </a:tr>
-              <a:tr h="777239">
+              <a:tr h="777240">
                 <a:tc>
                   <a:txBody>
                     <a:bodyPr/>
@@ -20917,7 +23641,7 @@
                   </a:tcPr>
                 </a:tc>
               </a:tr>
-              <a:tr h="777239">
+              <a:tr h="777240">
                 <a:tc>
                   <a:txBody>
                     <a:bodyPr/>
@@ -20955,7 +23679,7 @@
                   </a:tcPr>
                 </a:tc>
               </a:tr>
-              <a:tr h="777239">
+              <a:tr h="777240">
                 <a:tc>
                   <a:txBody>
                     <a:bodyPr/>
@@ -20993,7 +23717,7 @@
                   </a:tcPr>
                 </a:tc>
               </a:tr>
-              <a:tr h="777239">
+              <a:tr h="777240">
                 <a:tc>
                   <a:txBody>
                     <a:bodyPr/>
@@ -21031,7 +23755,7 @@
                   </a:tcPr>
                 </a:tc>
               </a:tr>
-              <a:tr h="777239">
+              <a:tr h="777240">
                 <a:tc>
                   <a:txBody>
                     <a:bodyPr/>
@@ -21079,7 +23803,7 @@
                   </a:tcPr>
                 </a:tc>
               </a:tr>
-              <a:tr h="777239">
+              <a:tr h="777240">
                 <a:tc>
                   <a:txBody>
                     <a:bodyPr/>
@@ -21117,7 +23841,7 @@
                   </a:tcPr>
                 </a:tc>
               </a:tr>
-              <a:tr h="777239">
+              <a:tr h="777240">
                 <a:tc>
                   <a:txBody>
                     <a:bodyPr/>
@@ -21155,7 +23879,45 @@
                   </a:tcPr>
                 </a:tc>
               </a:tr>
-              <a:tr h="777247">
+              <a:tr h="777240">
+                <a:tc>
+                  <a:txBody>
+                    <a:bodyPr/>
+                    <a:lstStyle/>
+                    <a:p>
+                      <a:r>
+                        <a:rPr sz="1800" b="0">
+                          <a:solidFill>
+                            <a:srgbClr val="3C3C3B"/>
+                          </a:solidFill>
+                          <a:latin typeface="Aptos"/>
+                        </a:rPr>
+                        <a:t>Upside case</a:t>
+                      </a:r>
+                    </a:p>
+                  </a:txBody>
+                  <a:tcPr marL="180000" anchor="ctr">
+                    <a:lnL>
+                      <a:noFill/>
+                    </a:lnL>
+                    <a:lnR>
+                      <a:noFill/>
+                    </a:lnR>
+                    <a:lnT w="6350">
+                      <a:solidFill>
+                        <a:srgbClr val="3C3C3B"/>
+                      </a:solidFill>
+                    </a:lnT>
+                    <a:lnB w="6350">
+                      <a:solidFill>
+                        <a:srgbClr val="3C3C3B"/>
+                      </a:solidFill>
+                    </a:lnB>
+                    <a:noFill/>
+                  </a:tcPr>
+                </a:tc>
+              </a:tr>
+              <a:tr h="777240">
                 <a:tc>
                   <a:txBody>
                     <a:bodyPr/>
@@ -23179,7 +25941,7 @@
                 </a:solidFill>
                 <a:latin typeface="Aptos"/>
               </a:rPr>
-              <a:t>Source: Bana_Model_20261015.xlsm, 15 Oct 2026.</a:t>
+              <a:t>Source: Bana_Model_20261018.xlsm, 18 Oct 2026.</a:t>
             </a:r>
           </a:p>
         </p:txBody>
@@ -23285,7 +26047,7 @@
         </p:nvGraphicFramePr>
         <p:xfrm>
           <a:off x="0" y="0"/>
-          <a:ext cx="3767328" cy="6995159"/>
+          <a:ext cx="3767328" cy="7772400"/>
         </p:xfrm>
         <a:graphic>
           <a:graphicData uri="http://schemas.openxmlformats.org/drawingml/2006/table">
@@ -23296,7 +26058,7 @@
               <a:tblGrid>
                 <a:gridCol w="3767328"/>
               </a:tblGrid>
-              <a:tr h="777239">
+              <a:tr h="777240">
                 <a:tc>
                   <a:txBody>
                     <a:bodyPr/>
@@ -23334,7 +26096,7 @@
                   </a:tcPr>
                 </a:tc>
               </a:tr>
-              <a:tr h="777239">
+              <a:tr h="777240">
                 <a:tc>
                   <a:txBody>
                     <a:bodyPr/>
@@ -23372,7 +26134,7 @@
                   </a:tcPr>
                 </a:tc>
               </a:tr>
-              <a:tr h="777239">
+              <a:tr h="777240">
                 <a:tc>
                   <a:txBody>
                     <a:bodyPr/>
@@ -23410,7 +26172,7 @@
                   </a:tcPr>
                 </a:tc>
               </a:tr>
-              <a:tr h="777239">
+              <a:tr h="777240">
                 <a:tc>
                   <a:txBody>
                     <a:bodyPr/>
@@ -23448,7 +26210,7 @@
                   </a:tcPr>
                 </a:tc>
               </a:tr>
-              <a:tr h="777239">
+              <a:tr h="777240">
                 <a:tc>
                   <a:txBody>
                     <a:bodyPr/>
@@ -23486,7 +26248,7 @@
                   </a:tcPr>
                 </a:tc>
               </a:tr>
-              <a:tr h="777239">
+              <a:tr h="777240">
                 <a:tc>
                   <a:txBody>
                     <a:bodyPr/>
@@ -23524,7 +26286,7 @@
                   </a:tcPr>
                 </a:tc>
               </a:tr>
-              <a:tr h="777239">
+              <a:tr h="777240">
                 <a:tc>
                   <a:txBody>
                     <a:bodyPr/>
@@ -23572,7 +26334,7 @@
                   </a:tcPr>
                 </a:tc>
               </a:tr>
-              <a:tr h="777239">
+              <a:tr h="777240">
                 <a:tc>
                   <a:txBody>
                     <a:bodyPr/>
@@ -23610,7 +26372,45 @@
                   </a:tcPr>
                 </a:tc>
               </a:tr>
-              <a:tr h="777247">
+              <a:tr h="777240">
+                <a:tc>
+                  <a:txBody>
+                    <a:bodyPr/>
+                    <a:lstStyle/>
+                    <a:p>
+                      <a:r>
+                        <a:rPr sz="1800" b="0">
+                          <a:solidFill>
+                            <a:srgbClr val="3C3C3B"/>
+                          </a:solidFill>
+                          <a:latin typeface="Aptos"/>
+                        </a:rPr>
+                        <a:t>Upside case</a:t>
+                      </a:r>
+                    </a:p>
+                  </a:txBody>
+                  <a:tcPr marL="180000" anchor="ctr">
+                    <a:lnL>
+                      <a:noFill/>
+                    </a:lnL>
+                    <a:lnR>
+                      <a:noFill/>
+                    </a:lnR>
+                    <a:lnT w="6350">
+                      <a:solidFill>
+                        <a:srgbClr val="3C3C3B"/>
+                      </a:solidFill>
+                    </a:lnT>
+                    <a:lnB w="6350">
+                      <a:solidFill>
+                        <a:srgbClr val="3C3C3B"/>
+                      </a:solidFill>
+                    </a:lnB>
+                    <a:noFill/>
+                  </a:tcPr>
+                </a:tc>
+              </a:tr>
+              <a:tr h="777240">
                 <a:tc>
                   <a:txBody>
                     <a:bodyPr/>
@@ -24563,7 +27363,7 @@
                 </a:solidFill>
                 <a:latin typeface="Aptos"/>
               </a:rPr>
-              <a:t>Source: Bana_Model_20261015.xlsm, 15 Oct 2026.</a:t>
+              <a:t>Source: Bana_Model_20261018.xlsm, 18 Oct 2026.</a:t>
             </a:r>
           </a:p>
         </p:txBody>
@@ -24669,7 +27469,7 @@
         </p:nvGraphicFramePr>
         <p:xfrm>
           <a:off x="0" y="0"/>
-          <a:ext cx="3767328" cy="6995159"/>
+          <a:ext cx="3767328" cy="7772400"/>
         </p:xfrm>
         <a:graphic>
           <a:graphicData uri="http://schemas.openxmlformats.org/drawingml/2006/table">
@@ -24680,7 +27480,7 @@
               <a:tblGrid>
                 <a:gridCol w="3767328"/>
               </a:tblGrid>
-              <a:tr h="777239">
+              <a:tr h="777240">
                 <a:tc>
                   <a:txBody>
                     <a:bodyPr/>
@@ -24718,7 +27518,7 @@
                   </a:tcPr>
                 </a:tc>
               </a:tr>
-              <a:tr h="777239">
+              <a:tr h="777240">
                 <a:tc>
                   <a:txBody>
                     <a:bodyPr/>
@@ -24756,7 +27556,7 @@
                   </a:tcPr>
                 </a:tc>
               </a:tr>
-              <a:tr h="777239">
+              <a:tr h="777240">
                 <a:tc>
                   <a:txBody>
                     <a:bodyPr/>
@@ -24794,7 +27594,7 @@
                   </a:tcPr>
                 </a:tc>
               </a:tr>
-              <a:tr h="777239">
+              <a:tr h="777240">
                 <a:tc>
                   <a:txBody>
                     <a:bodyPr/>
@@ -24832,7 +27632,7 @@
                   </a:tcPr>
                 </a:tc>
               </a:tr>
-              <a:tr h="777239">
+              <a:tr h="777240">
                 <a:tc>
                   <a:txBody>
                     <a:bodyPr/>
@@ -24870,7 +27670,7 @@
                   </a:tcPr>
                 </a:tc>
               </a:tr>
-              <a:tr h="777239">
+              <a:tr h="777240">
                 <a:tc>
                   <a:txBody>
                     <a:bodyPr/>
@@ -24908,7 +27708,7 @@
                   </a:tcPr>
                 </a:tc>
               </a:tr>
-              <a:tr h="777239">
+              <a:tr h="777240">
                 <a:tc>
                   <a:txBody>
                     <a:bodyPr/>
@@ -24946,7 +27746,7 @@
                   </a:tcPr>
                 </a:tc>
               </a:tr>
-              <a:tr h="777239">
+              <a:tr h="777240">
                 <a:tc>
                   <a:txBody>
                     <a:bodyPr/>
@@ -24994,7 +27794,45 @@
                   </a:tcPr>
                 </a:tc>
               </a:tr>
-              <a:tr h="777247">
+              <a:tr h="777240">
+                <a:tc>
+                  <a:txBody>
+                    <a:bodyPr/>
+                    <a:lstStyle/>
+                    <a:p>
+                      <a:r>
+                        <a:rPr sz="1800" b="0">
+                          <a:solidFill>
+                            <a:srgbClr val="3C3C3B"/>
+                          </a:solidFill>
+                          <a:latin typeface="Aptos"/>
+                        </a:rPr>
+                        <a:t>Upside case</a:t>
+                      </a:r>
+                    </a:p>
+                  </a:txBody>
+                  <a:tcPr marL="180000" anchor="ctr">
+                    <a:lnL>
+                      <a:noFill/>
+                    </a:lnL>
+                    <a:lnR>
+                      <a:noFill/>
+                    </a:lnR>
+                    <a:lnT w="6350">
+                      <a:solidFill>
+                        <a:srgbClr val="3C3C3B"/>
+                      </a:solidFill>
+                    </a:lnT>
+                    <a:lnB w="6350">
+                      <a:solidFill>
+                        <a:srgbClr val="3C3C3B"/>
+                      </a:solidFill>
+                    </a:lnB>
+                    <a:noFill/>
+                  </a:tcPr>
+                </a:tc>
+              </a:tr>
+              <a:tr h="777240">
                 <a:tc>
                   <a:txBody>
                     <a:bodyPr/>
@@ -25975,7 +28813,7 @@
                 </a:solidFill>
                 <a:latin typeface="Aptos"/>
               </a:rPr>
-              <a:t>Source: Bana_Model_20261015.xlsm, 15 Oct 2026.</a:t>
+              <a:t>Source: Bana_Model_20261018.xlsm, 18 Oct 2026.</a:t>
             </a:r>
           </a:p>
         </p:txBody>

</xml_diff>

<commit_message>
Bana: three cases – base, full zero bid, 20 %+ IRR combination
Co-Authored-By: Claude Opus 5.5 <noreply@anthropic.com>
Claude-Session: https://claude.ai/code/session_01AWS1t9WtpkQHcCU1WceGZT
</commit_message>
<xml_diff>
--- a/projects/bana/out/Bana_IC.pptx
+++ b/projects/bana/out/Bana_IC.pptx
@@ -6034,7 +6034,7 @@
           <a:lstStyle/>
           <a:p>
             <a:r>
-              <a:t>With 2,850 h, a zero bid and a 100 / 105 €/MWh PPA, the hold IRR rises to 11.9% / 12.9% (European) from 7.6%</a:t>
+              <a:t>Case 3 lifts the hold IRR to 22.0% with Chinese turbines (16.1% European), against 11.4% in the base</a:t>
             </a:r>
           </a:p>
         </p:txBody>
@@ -6424,7 +6424,7 @@
                           </a:solidFill>
                           <a:latin typeface="Aptos"/>
                         </a:rPr>
-                        <a:t>Upside case</a:t>
+                        <a:t>Three cases</a:t>
                       </a:r>
                     </a:p>
                   </a:txBody>
@@ -6530,7 +6530,7 @@
                 </a:solidFill>
                 <a:latin typeface="Aptos"/>
               </a:rPr>
-              <a:t>But the zero bid scores only 12 points European (0 Chinese) against 59.5 (47.5), so winning the tender becomes the main risk.</a:t>
+              <a:t>It needs a 105 €/MWh PPA, 70% gearing over 18 years at 4.5% and 300 k€/MW of BoP and other wind capex (from 355); the zero bid scores 12 / 0 points.</a:t>
             </a:r>
           </a:p>
         </p:txBody>
@@ -6545,7 +6545,7 @@
         </p:nvGraphicFramePr>
         <p:xfrm>
           <a:off x="4498848" y="2240280"/>
-          <a:ext cx="9509760" cy="6848856"/>
+          <a:ext cx="9509760" cy="6711696"/>
         </p:xfrm>
         <a:graphic>
           <a:graphicData uri="http://schemas.openxmlformats.org/drawingml/2006/table">
@@ -6554,11 +6554,11 @@
                 <a:tableStyleId>{5C22544A-7EE6-4342-B048-85BDC9FD1C3A}</a:tableStyleId>
               </a:tblPr>
               <a:tblGrid>
-                <a:gridCol w="3200400"/>
-                <a:gridCol w="1188720"/>
+                <a:gridCol w="3291840"/>
+                <a:gridCol w="914400"/>
+                <a:gridCol w="1828800"/>
                 <a:gridCol w="1737360"/>
-                <a:gridCol w="1691640"/>
-                <a:gridCol w="1691640"/>
+                <a:gridCol w="1737360"/>
               </a:tblGrid>
               <a:tr h="539496">
                 <a:tc>
@@ -6567,6 +6567,20 @@
                     <a:lstStyle/>
                     <a:p>
                       <a:pPr algn="l"/>
+                    </a:p>
+                  </a:txBody>
+                  <a:tcPr marL="73152" marR="73152" marT="27432" marB="27432" anchor="ctr">
+                    <a:solidFill>
+                      <a:srgbClr val="00A651"/>
+                    </a:solidFill>
+                  </a:tcPr>
+                </a:tc>
+                <a:tc>
+                  <a:txBody>
+                    <a:bodyPr/>
+                    <a:lstStyle/>
+                    <a:p>
+                      <a:pPr algn="l"/>
                       <a:r>
                         <a:rPr sz="1300" b="1">
                           <a:solidFill>
@@ -6574,7 +6588,7 @@
                           </a:solidFill>
                           <a:latin typeface="Aptos"/>
                         </a:rPr>
-                        <a:t>Case</a:t>
+                        <a:t>Unit</a:t>
                       </a:r>
                     </a:p>
                   </a:txBody>
@@ -6589,7 +6603,7 @@
                     <a:bodyPr/>
                     <a:lstStyle/>
                     <a:p>
-                      <a:pPr algn="l"/>
+                      <a:pPr algn="r"/>
                       <a:r>
                         <a:rPr sz="1300" b="1">
                           <a:solidFill>
@@ -6597,7 +6611,7 @@
                           </a:solidFill>
                           <a:latin typeface="Aptos"/>
                         </a:rPr>
-                        <a:t>Unit</a:t>
+                        <a:t>Case 1: base</a:t>
                       </a:r>
                     </a:p>
                   </a:txBody>
@@ -6620,7 +6634,7 @@
                           </a:solidFill>
                           <a:latin typeface="Aptos"/>
                         </a:rPr>
-                        <a:t>Base</a:t>
+                        <a:t>Case 2: zero bid</a:t>
                       </a:r>
                     </a:p>
                   </a:txBody>
@@ -6643,7 +6657,7 @@
                           </a:solidFill>
                           <a:latin typeface="Aptos"/>
                         </a:rPr>
-                        <a:t>Upside: PPA 100</a:t>
+                        <a:t>Case 3: 20 %+ IRR</a:t>
                       </a:r>
                     </a:p>
                   </a:txBody>
@@ -6653,31 +6667,746 @@
                     </a:solidFill>
                   </a:tcPr>
                 </a:tc>
-                <a:tc>
-                  <a:txBody>
-                    <a:bodyPr/>
-                    <a:lstStyle/>
-                    <a:p>
-                      <a:pPr algn="r"/>
+              </a:tr>
+              <a:tr h="411480">
+                <a:tc>
+                  <a:txBody>
+                    <a:bodyPr/>
+                    <a:lstStyle/>
+                    <a:p>
+                      <a:pPr algn="l"/>
                       <a:r>
                         <a:rPr sz="1300" b="1">
                           <a:solidFill>
-                            <a:srgbClr val="FFFFFF"/>
-                          </a:solidFill>
-                          <a:latin typeface="Aptos"/>
-                        </a:rPr>
-                        <a:t>Upside: PPA 105</a:t>
-                      </a:r>
-                    </a:p>
-                  </a:txBody>
-                  <a:tcPr marL="73152" marR="73152" marT="27432" marB="27432" anchor="ctr">
-                    <a:solidFill>
-                      <a:srgbClr val="00A651"/>
+                            <a:srgbClr val="00563C"/>
+                          </a:solidFill>
+                          <a:latin typeface="Aptos"/>
+                        </a:rPr>
+                        <a:t>Assumptions</a:t>
+                      </a:r>
+                    </a:p>
+                  </a:txBody>
+                  <a:tcPr marL="73152" marR="73152" marT="27432" marB="27432" anchor="ctr">
+                    <a:solidFill>
+                      <a:srgbClr val="E6F4EC"/>
+                    </a:solidFill>
+                  </a:tcPr>
+                </a:tc>
+                <a:tc>
+                  <a:txBody>
+                    <a:bodyPr/>
+                    <a:lstStyle/>
+                    <a:p>
+                      <a:pPr algn="l"/>
+                    </a:p>
+                  </a:txBody>
+                  <a:tcPr marL="73152" marR="73152" marT="27432" marB="27432" anchor="ctr">
+                    <a:solidFill>
+                      <a:srgbClr val="E6F4EC"/>
+                    </a:solidFill>
+                  </a:tcPr>
+                </a:tc>
+                <a:tc>
+                  <a:txBody>
+                    <a:bodyPr/>
+                    <a:lstStyle/>
+                    <a:p>
+                      <a:pPr algn="r"/>
+                    </a:p>
+                  </a:txBody>
+                  <a:tcPr marL="73152" marR="73152" marT="27432" marB="27432" anchor="ctr">
+                    <a:solidFill>
+                      <a:srgbClr val="E6F4EC"/>
+                    </a:solidFill>
+                  </a:tcPr>
+                </a:tc>
+                <a:tc>
+                  <a:txBody>
+                    <a:bodyPr/>
+                    <a:lstStyle/>
+                    <a:p>
+                      <a:pPr algn="r"/>
+                    </a:p>
+                  </a:txBody>
+                  <a:tcPr marL="73152" marR="73152" marT="27432" marB="27432" anchor="ctr">
+                    <a:solidFill>
+                      <a:srgbClr val="E6F4EC"/>
+                    </a:solidFill>
+                  </a:tcPr>
+                </a:tc>
+                <a:tc>
+                  <a:txBody>
+                    <a:bodyPr/>
+                    <a:lstStyle/>
+                    <a:p>
+                      <a:pPr algn="r"/>
+                    </a:p>
+                  </a:txBody>
+                  <a:tcPr marL="73152" marR="73152" marT="27432" marB="27432" anchor="ctr">
+                    <a:solidFill>
+                      <a:srgbClr val="E6F4EC"/>
                     </a:solidFill>
                   </a:tcPr>
                 </a:tc>
               </a:tr>
-              <a:tr h="420624">
+              <a:tr h="411480">
+                <a:tc>
+                  <a:txBody>
+                    <a:bodyPr/>
+                    <a:lstStyle/>
+                    <a:p>
+                      <a:pPr algn="l"/>
+                      <a:r>
+                        <a:rPr sz="1300" b="0">
+                          <a:solidFill>
+                            <a:srgbClr val="3C3C3B"/>
+                          </a:solidFill>
+                          <a:latin typeface="Aptos"/>
+                        </a:rPr>
+                        <a:t>Net P50 hours</a:t>
+                      </a:r>
+                    </a:p>
+                  </a:txBody>
+                  <a:tcPr marL="73152" marR="73152" marT="27432" marB="27432" anchor="ctr">
+                    <a:solidFill>
+                      <a:srgbClr val="F2F2F2"/>
+                    </a:solidFill>
+                  </a:tcPr>
+                </a:tc>
+                <a:tc>
+                  <a:txBody>
+                    <a:bodyPr/>
+                    <a:lstStyle/>
+                    <a:p>
+                      <a:pPr algn="l"/>
+                      <a:r>
+                        <a:rPr sz="1300" b="0">
+                          <a:solidFill>
+                            <a:srgbClr val="919191"/>
+                          </a:solidFill>
+                          <a:latin typeface="Aptos"/>
+                        </a:rPr>
+                        <a:t>h</a:t>
+                      </a:r>
+                    </a:p>
+                  </a:txBody>
+                  <a:tcPr marL="73152" marR="73152" marT="27432" marB="27432" anchor="ctr">
+                    <a:solidFill>
+                      <a:srgbClr val="F2F2F2"/>
+                    </a:solidFill>
+                  </a:tcPr>
+                </a:tc>
+                <a:tc>
+                  <a:txBody>
+                    <a:bodyPr/>
+                    <a:lstStyle/>
+                    <a:p>
+                      <a:pPr algn="r"/>
+                      <a:r>
+                        <a:rPr sz="1300" b="0">
+                          <a:solidFill>
+                            <a:srgbClr val="3C3C3B"/>
+                          </a:solidFill>
+                          <a:latin typeface="Aptos"/>
+                        </a:rPr>
+                        <a:t>2,600</a:t>
+                      </a:r>
+                    </a:p>
+                  </a:txBody>
+                  <a:tcPr marL="73152" marR="73152" marT="27432" marB="27432" anchor="ctr">
+                    <a:noFill/>
+                  </a:tcPr>
+                </a:tc>
+                <a:tc>
+                  <a:txBody>
+                    <a:bodyPr/>
+                    <a:lstStyle/>
+                    <a:p>
+                      <a:pPr algn="r"/>
+                      <a:r>
+                        <a:rPr sz="1300" b="0">
+                          <a:solidFill>
+                            <a:srgbClr val="3C3C3B"/>
+                          </a:solidFill>
+                          <a:latin typeface="Aptos"/>
+                        </a:rPr>
+                        <a:t>2,850</a:t>
+                      </a:r>
+                    </a:p>
+                  </a:txBody>
+                  <a:tcPr marL="73152" marR="73152" marT="27432" marB="27432" anchor="ctr">
+                    <a:noFill/>
+                  </a:tcPr>
+                </a:tc>
+                <a:tc>
+                  <a:txBody>
+                    <a:bodyPr/>
+                    <a:lstStyle/>
+                    <a:p>
+                      <a:pPr algn="r"/>
+                      <a:r>
+                        <a:rPr sz="1300" b="0">
+                          <a:solidFill>
+                            <a:srgbClr val="3C3C3B"/>
+                          </a:solidFill>
+                          <a:latin typeface="Aptos"/>
+                        </a:rPr>
+                        <a:t>2,850</a:t>
+                      </a:r>
+                    </a:p>
+                  </a:txBody>
+                  <a:tcPr marL="73152" marR="73152" marT="27432" marB="27432" anchor="ctr">
+                    <a:noFill/>
+                  </a:tcPr>
+                </a:tc>
+              </a:tr>
+              <a:tr h="411480">
+                <a:tc>
+                  <a:txBody>
+                    <a:bodyPr/>
+                    <a:lstStyle/>
+                    <a:p>
+                      <a:pPr algn="l"/>
+                      <a:r>
+                        <a:rPr sz="1300" b="0">
+                          <a:solidFill>
+                            <a:srgbClr val="3C3C3B"/>
+                          </a:solidFill>
+                          <a:latin typeface="Aptos"/>
+                        </a:rPr>
+                        <a:t>Bid: overbuild / BESS / municipal / community</a:t>
+                      </a:r>
+                    </a:p>
+                  </a:txBody>
+                  <a:tcPr marL="73152" marR="73152" marT="27432" marB="27432" anchor="ctr">
+                    <a:solidFill>
+                      <a:srgbClr val="F2F2F2"/>
+                    </a:solidFill>
+                  </a:tcPr>
+                </a:tc>
+                <a:tc>
+                  <a:txBody>
+                    <a:bodyPr/>
+                    <a:lstStyle/>
+                    <a:p>
+                      <a:pPr algn="l"/>
+                    </a:p>
+                  </a:txBody>
+                  <a:tcPr marL="73152" marR="73152" marT="27432" marB="27432" anchor="ctr">
+                    <a:solidFill>
+                      <a:srgbClr val="F2F2F2"/>
+                    </a:solidFill>
+                  </a:tcPr>
+                </a:tc>
+                <a:tc>
+                  <a:txBody>
+                    <a:bodyPr/>
+                    <a:lstStyle/>
+                    <a:p>
+                      <a:pPr algn="r"/>
+                      <a:r>
+                        <a:rPr sz="1300" b="0">
+                          <a:solidFill>
+                            <a:srgbClr val="3C3C3B"/>
+                          </a:solidFill>
+                          <a:latin typeface="Aptos"/>
+                        </a:rPr>
+                        <a:t>20% / 20% / 50 / 3.0</a:t>
+                      </a:r>
+                    </a:p>
+                  </a:txBody>
+                  <a:tcPr marL="73152" marR="73152" marT="27432" marB="27432" anchor="ctr">
+                    <a:noFill/>
+                  </a:tcPr>
+                </a:tc>
+                <a:tc>
+                  <a:txBody>
+                    <a:bodyPr/>
+                    <a:lstStyle/>
+                    <a:p>
+                      <a:pPr algn="r"/>
+                      <a:r>
+                        <a:rPr sz="1300" b="0">
+                          <a:solidFill>
+                            <a:srgbClr val="3C3C3B"/>
+                          </a:solidFill>
+                          <a:latin typeface="Aptos"/>
+                        </a:rPr>
+                        <a:t>none</a:t>
+                      </a:r>
+                    </a:p>
+                  </a:txBody>
+                  <a:tcPr marL="73152" marR="73152" marT="27432" marB="27432" anchor="ctr">
+                    <a:noFill/>
+                  </a:tcPr>
+                </a:tc>
+                <a:tc>
+                  <a:txBody>
+                    <a:bodyPr/>
+                    <a:lstStyle/>
+                    <a:p>
+                      <a:pPr algn="r"/>
+                      <a:r>
+                        <a:rPr sz="1300" b="0">
+                          <a:solidFill>
+                            <a:srgbClr val="3C3C3B"/>
+                          </a:solidFill>
+                          <a:latin typeface="Aptos"/>
+                        </a:rPr>
+                        <a:t>none</a:t>
+                      </a:r>
+                    </a:p>
+                  </a:txBody>
+                  <a:tcPr marL="73152" marR="73152" marT="27432" marB="27432" anchor="ctr">
+                    <a:noFill/>
+                  </a:tcPr>
+                </a:tc>
+              </a:tr>
+              <a:tr h="411480">
+                <a:tc>
+                  <a:txBody>
+                    <a:bodyPr/>
+                    <a:lstStyle/>
+                    <a:p>
+                      <a:pPr algn="l"/>
+                      <a:r>
+                        <a:rPr sz="1300" b="0">
+                          <a:solidFill>
+                            <a:srgbClr val="3C3C3B"/>
+                          </a:solidFill>
+                          <a:latin typeface="Aptos"/>
+                        </a:rPr>
+                        <a:t>PPA price, whole life</a:t>
+                      </a:r>
+                    </a:p>
+                  </a:txBody>
+                  <a:tcPr marL="73152" marR="73152" marT="27432" marB="27432" anchor="ctr">
+                    <a:solidFill>
+                      <a:srgbClr val="F2F2F2"/>
+                    </a:solidFill>
+                  </a:tcPr>
+                </a:tc>
+                <a:tc>
+                  <a:txBody>
+                    <a:bodyPr/>
+                    <a:lstStyle/>
+                    <a:p>
+                      <a:pPr algn="l"/>
+                      <a:r>
+                        <a:rPr sz="1300" b="0">
+                          <a:solidFill>
+                            <a:srgbClr val="919191"/>
+                          </a:solidFill>
+                          <a:latin typeface="Aptos"/>
+                        </a:rPr>
+                        <a:t>€/MWh</a:t>
+                      </a:r>
+                    </a:p>
+                  </a:txBody>
+                  <a:tcPr marL="73152" marR="73152" marT="27432" marB="27432" anchor="ctr">
+                    <a:solidFill>
+                      <a:srgbClr val="F2F2F2"/>
+                    </a:solidFill>
+                  </a:tcPr>
+                </a:tc>
+                <a:tc>
+                  <a:txBody>
+                    <a:bodyPr/>
+                    <a:lstStyle/>
+                    <a:p>
+                      <a:pPr algn="r"/>
+                      <a:r>
+                        <a:rPr sz="1300" b="0">
+                          <a:solidFill>
+                            <a:srgbClr val="3C3C3B"/>
+                          </a:solidFill>
+                          <a:latin typeface="Aptos"/>
+                        </a:rPr>
+                        <a:t>90</a:t>
+                      </a:r>
+                    </a:p>
+                  </a:txBody>
+                  <a:tcPr marL="73152" marR="73152" marT="27432" marB="27432" anchor="ctr">
+                    <a:noFill/>
+                  </a:tcPr>
+                </a:tc>
+                <a:tc>
+                  <a:txBody>
+                    <a:bodyPr/>
+                    <a:lstStyle/>
+                    <a:p>
+                      <a:pPr algn="r"/>
+                      <a:r>
+                        <a:rPr sz="1300" b="0">
+                          <a:solidFill>
+                            <a:srgbClr val="3C3C3B"/>
+                          </a:solidFill>
+                          <a:latin typeface="Aptos"/>
+                        </a:rPr>
+                        <a:t>100</a:t>
+                      </a:r>
+                    </a:p>
+                  </a:txBody>
+                  <a:tcPr marL="73152" marR="73152" marT="27432" marB="27432" anchor="ctr">
+                    <a:noFill/>
+                  </a:tcPr>
+                </a:tc>
+                <a:tc>
+                  <a:txBody>
+                    <a:bodyPr/>
+                    <a:lstStyle/>
+                    <a:p>
+                      <a:pPr algn="r"/>
+                      <a:r>
+                        <a:rPr sz="1300" b="0">
+                          <a:solidFill>
+                            <a:srgbClr val="3C3C3B"/>
+                          </a:solidFill>
+                          <a:latin typeface="Aptos"/>
+                        </a:rPr>
+                        <a:t>105</a:t>
+                      </a:r>
+                    </a:p>
+                  </a:txBody>
+                  <a:tcPr marL="73152" marR="73152" marT="27432" marB="27432" anchor="ctr">
+                    <a:noFill/>
+                  </a:tcPr>
+                </a:tc>
+              </a:tr>
+              <a:tr h="411480">
+                <a:tc>
+                  <a:txBody>
+                    <a:bodyPr/>
+                    <a:lstStyle/>
+                    <a:p>
+                      <a:pPr algn="l"/>
+                      <a:r>
+                        <a:rPr sz="1300" b="0">
+                          <a:solidFill>
+                            <a:srgbClr val="3C3C3B"/>
+                          </a:solidFill>
+                          <a:latin typeface="Aptos"/>
+                        </a:rPr>
+                        <a:t>Gearing (debt / construction cost)</a:t>
+                      </a:r>
+                    </a:p>
+                  </a:txBody>
+                  <a:tcPr marL="73152" marR="73152" marT="27432" marB="27432" anchor="ctr">
+                    <a:solidFill>
+                      <a:srgbClr val="F2F2F2"/>
+                    </a:solidFill>
+                  </a:tcPr>
+                </a:tc>
+                <a:tc>
+                  <a:txBody>
+                    <a:bodyPr/>
+                    <a:lstStyle/>
+                    <a:p>
+                      <a:pPr algn="l"/>
+                      <a:r>
+                        <a:rPr sz="1300" b="0">
+                          <a:solidFill>
+                            <a:srgbClr val="919191"/>
+                          </a:solidFill>
+                          <a:latin typeface="Aptos"/>
+                        </a:rPr>
+                        <a:t>%</a:t>
+                      </a:r>
+                    </a:p>
+                  </a:txBody>
+                  <a:tcPr marL="73152" marR="73152" marT="27432" marB="27432" anchor="ctr">
+                    <a:solidFill>
+                      <a:srgbClr val="F2F2F2"/>
+                    </a:solidFill>
+                  </a:tcPr>
+                </a:tc>
+                <a:tc>
+                  <a:txBody>
+                    <a:bodyPr/>
+                    <a:lstStyle/>
+                    <a:p>
+                      <a:pPr algn="r"/>
+                      <a:r>
+                        <a:rPr sz="1300" b="0">
+                          <a:solidFill>
+                            <a:srgbClr val="3C3C3B"/>
+                          </a:solidFill>
+                          <a:latin typeface="Aptos"/>
+                        </a:rPr>
+                        <a:t>55%</a:t>
+                      </a:r>
+                    </a:p>
+                  </a:txBody>
+                  <a:tcPr marL="73152" marR="73152" marT="27432" marB="27432" anchor="ctr">
+                    <a:noFill/>
+                  </a:tcPr>
+                </a:tc>
+                <a:tc>
+                  <a:txBody>
+                    <a:bodyPr/>
+                    <a:lstStyle/>
+                    <a:p>
+                      <a:pPr algn="r"/>
+                      <a:r>
+                        <a:rPr sz="1300" b="0">
+                          <a:solidFill>
+                            <a:srgbClr val="3C3C3B"/>
+                          </a:solidFill>
+                          <a:latin typeface="Aptos"/>
+                        </a:rPr>
+                        <a:t>60%</a:t>
+                      </a:r>
+                    </a:p>
+                  </a:txBody>
+                  <a:tcPr marL="73152" marR="73152" marT="27432" marB="27432" anchor="ctr">
+                    <a:noFill/>
+                  </a:tcPr>
+                </a:tc>
+                <a:tc>
+                  <a:txBody>
+                    <a:bodyPr/>
+                    <a:lstStyle/>
+                    <a:p>
+                      <a:pPr algn="r"/>
+                      <a:r>
+                        <a:rPr sz="1300" b="0">
+                          <a:solidFill>
+                            <a:srgbClr val="3C3C3B"/>
+                          </a:solidFill>
+                          <a:latin typeface="Aptos"/>
+                        </a:rPr>
+                        <a:t>70%</a:t>
+                      </a:r>
+                    </a:p>
+                  </a:txBody>
+                  <a:tcPr marL="73152" marR="73152" marT="27432" marB="27432" anchor="ctr">
+                    <a:noFill/>
+                  </a:tcPr>
+                </a:tc>
+              </a:tr>
+              <a:tr h="411480">
+                <a:tc>
+                  <a:txBody>
+                    <a:bodyPr/>
+                    <a:lstStyle/>
+                    <a:p>
+                      <a:pPr algn="l"/>
+                      <a:r>
+                        <a:rPr sz="1300" b="0">
+                          <a:solidFill>
+                            <a:srgbClr val="3C3C3B"/>
+                          </a:solidFill>
+                          <a:latin typeface="Aptos"/>
+                        </a:rPr>
+                        <a:t>Debt tenor / all-in rate</a:t>
+                      </a:r>
+                    </a:p>
+                  </a:txBody>
+                  <a:tcPr marL="73152" marR="73152" marT="27432" marB="27432" anchor="ctr">
+                    <a:solidFill>
+                      <a:srgbClr val="F2F2F2"/>
+                    </a:solidFill>
+                  </a:tcPr>
+                </a:tc>
+                <a:tc>
+                  <a:txBody>
+                    <a:bodyPr/>
+                    <a:lstStyle/>
+                    <a:p>
+                      <a:pPr algn="l"/>
+                      <a:r>
+                        <a:rPr sz="1300" b="0">
+                          <a:solidFill>
+                            <a:srgbClr val="919191"/>
+                          </a:solidFill>
+                          <a:latin typeface="Aptos"/>
+                        </a:rPr>
+                        <a:t>y / %</a:t>
+                      </a:r>
+                    </a:p>
+                  </a:txBody>
+                  <a:tcPr marL="73152" marR="73152" marT="27432" marB="27432" anchor="ctr">
+                    <a:solidFill>
+                      <a:srgbClr val="F2F2F2"/>
+                    </a:solidFill>
+                  </a:tcPr>
+                </a:tc>
+                <a:tc>
+                  <a:txBody>
+                    <a:bodyPr/>
+                    <a:lstStyle/>
+                    <a:p>
+                      <a:pPr algn="r"/>
+                      <a:r>
+                        <a:rPr sz="1300" b="0">
+                          <a:solidFill>
+                            <a:srgbClr val="3C3C3B"/>
+                          </a:solidFill>
+                          <a:latin typeface="Aptos"/>
+                        </a:rPr>
+                        <a:t>15 / 5.0%</a:t>
+                      </a:r>
+                    </a:p>
+                  </a:txBody>
+                  <a:tcPr marL="73152" marR="73152" marT="27432" marB="27432" anchor="ctr">
+                    <a:noFill/>
+                  </a:tcPr>
+                </a:tc>
+                <a:tc>
+                  <a:txBody>
+                    <a:bodyPr/>
+                    <a:lstStyle/>
+                    <a:p>
+                      <a:pPr algn="r"/>
+                      <a:r>
+                        <a:rPr sz="1300" b="0">
+                          <a:solidFill>
+                            <a:srgbClr val="3C3C3B"/>
+                          </a:solidFill>
+                          <a:latin typeface="Aptos"/>
+                        </a:rPr>
+                        <a:t>15 / 5.0%</a:t>
+                      </a:r>
+                    </a:p>
+                  </a:txBody>
+                  <a:tcPr marL="73152" marR="73152" marT="27432" marB="27432" anchor="ctr">
+                    <a:noFill/>
+                  </a:tcPr>
+                </a:tc>
+                <a:tc>
+                  <a:txBody>
+                    <a:bodyPr/>
+                    <a:lstStyle/>
+                    <a:p>
+                      <a:pPr algn="r"/>
+                      <a:r>
+                        <a:rPr sz="1300" b="0">
+                          <a:solidFill>
+                            <a:srgbClr val="3C3C3B"/>
+                          </a:solidFill>
+                          <a:latin typeface="Aptos"/>
+                        </a:rPr>
+                        <a:t>18 / 4.5%</a:t>
+                      </a:r>
+                    </a:p>
+                  </a:txBody>
+                  <a:tcPr marL="73152" marR="73152" marT="27432" marB="27432" anchor="ctr">
+                    <a:noFill/>
+                  </a:tcPr>
+                </a:tc>
+              </a:tr>
+              <a:tr h="411480">
+                <a:tc>
+                  <a:txBody>
+                    <a:bodyPr/>
+                    <a:lstStyle/>
+                    <a:p>
+                      <a:pPr algn="l"/>
+                      <a:r>
+                        <a:rPr sz="1300" b="0">
+                          <a:solidFill>
+                            <a:srgbClr val="3C3C3B"/>
+                          </a:solidFill>
+                          <a:latin typeface="Aptos"/>
+                        </a:rPr>
+                        <a:t>BoP and other wind capex</a:t>
+                      </a:r>
+                    </a:p>
+                  </a:txBody>
+                  <a:tcPr marL="73152" marR="73152" marT="27432" marB="27432" anchor="ctr">
+                    <a:solidFill>
+                      <a:srgbClr val="F2F2F2"/>
+                    </a:solidFill>
+                  </a:tcPr>
+                </a:tc>
+                <a:tc>
+                  <a:txBody>
+                    <a:bodyPr/>
+                    <a:lstStyle/>
+                    <a:p>
+                      <a:pPr algn="l"/>
+                      <a:r>
+                        <a:rPr sz="1300" b="0">
+                          <a:solidFill>
+                            <a:srgbClr val="919191"/>
+                          </a:solidFill>
+                          <a:latin typeface="Aptos"/>
+                        </a:rPr>
+                        <a:t>k€/MW</a:t>
+                      </a:r>
+                    </a:p>
+                  </a:txBody>
+                  <a:tcPr marL="73152" marR="73152" marT="27432" marB="27432" anchor="ctr">
+                    <a:solidFill>
+                      <a:srgbClr val="F2F2F2"/>
+                    </a:solidFill>
+                  </a:tcPr>
+                </a:tc>
+                <a:tc>
+                  <a:txBody>
+                    <a:bodyPr/>
+                    <a:lstStyle/>
+                    <a:p>
+                      <a:pPr algn="r"/>
+                      <a:r>
+                        <a:rPr sz="1300" b="0">
+                          <a:solidFill>
+                            <a:srgbClr val="3C3C3B"/>
+                          </a:solidFill>
+                          <a:latin typeface="Aptos"/>
+                        </a:rPr>
+                        <a:t>355</a:t>
+                      </a:r>
+                    </a:p>
+                  </a:txBody>
+                  <a:tcPr marL="73152" marR="73152" marT="27432" marB="27432" anchor="ctr">
+                    <a:noFill/>
+                  </a:tcPr>
+                </a:tc>
+                <a:tc>
+                  <a:txBody>
+                    <a:bodyPr/>
+                    <a:lstStyle/>
+                    <a:p>
+                      <a:pPr algn="r"/>
+                      <a:r>
+                        <a:rPr sz="1300" b="0">
+                          <a:solidFill>
+                            <a:srgbClr val="3C3C3B"/>
+                          </a:solidFill>
+                          <a:latin typeface="Aptos"/>
+                        </a:rPr>
+                        <a:t>355</a:t>
+                      </a:r>
+                    </a:p>
+                  </a:txBody>
+                  <a:tcPr marL="73152" marR="73152" marT="27432" marB="27432" anchor="ctr">
+                    <a:noFill/>
+                  </a:tcPr>
+                </a:tc>
+                <a:tc>
+                  <a:txBody>
+                    <a:bodyPr/>
+                    <a:lstStyle/>
+                    <a:p>
+                      <a:pPr algn="r"/>
+                      <a:r>
+                        <a:rPr sz="1300" b="0">
+                          <a:solidFill>
+                            <a:srgbClr val="3C3C3B"/>
+                          </a:solidFill>
+                          <a:latin typeface="Aptos"/>
+                        </a:rPr>
+                        <a:t>300</a:t>
+                      </a:r>
+                    </a:p>
+                  </a:txBody>
+                  <a:tcPr marL="73152" marR="73152" marT="27432" marB="27432" anchor="ctr">
+                    <a:noFill/>
+                  </a:tcPr>
+                </a:tc>
+              </a:tr>
+              <a:tr h="411480">
                 <a:tc>
                   <a:txBody>
                     <a:bodyPr/>
@@ -6691,7 +7420,7 @@
                           </a:solidFill>
                           <a:latin typeface="Aptos"/>
                         </a:rPr>
-                        <a:t>What changes</a:t>
+                        <a:t>Results (European / Chinese)</a:t>
                       </a:r>
                     </a:p>
                   </a:txBody>
@@ -6758,21 +7487,21 @@
                   </a:tcPr>
                 </a:tc>
               </a:tr>
-              <a:tr h="420624">
-                <a:tc>
-                  <a:txBody>
-                    <a:bodyPr/>
-                    <a:lstStyle/>
-                    <a:p>
-                      <a:pPr algn="l"/>
-                      <a:r>
-                        <a:rPr sz="1300" b="0">
-                          <a:solidFill>
-                            <a:srgbClr val="3C3C3B"/>
-                          </a:solidFill>
-                          <a:latin typeface="Aptos"/>
-                        </a:rPr>
-                        <a:t>Net P50 hours</a:t>
+              <a:tr h="411480">
+                <a:tc>
+                  <a:txBody>
+                    <a:bodyPr/>
+                    <a:lstStyle/>
+                    <a:p>
+                      <a:pPr algn="l"/>
+                      <a:r>
+                        <a:rPr sz="1300" b="0">
+                          <a:solidFill>
+                            <a:srgbClr val="3C3C3B"/>
+                          </a:solidFill>
+                          <a:latin typeface="Aptos"/>
+                        </a:rPr>
+                        <a:t>Tender points</a:t>
                       </a:r>
                     </a:p>
                   </a:txBody>
@@ -6795,7 +7524,7 @@
                           </a:solidFill>
                           <a:latin typeface="Aptos"/>
                         </a:rPr>
-                        <a:t>h</a:t>
+                        <a:t>points</a:t>
                       </a:r>
                     </a:p>
                   </a:txBody>
@@ -6818,49 +7547,49 @@
                           </a:solidFill>
                           <a:latin typeface="Aptos"/>
                         </a:rPr>
-                        <a:t>2,600</a:t>
-                      </a:r>
-                    </a:p>
-                  </a:txBody>
-                  <a:tcPr marL="73152" marR="73152" marT="27432" marB="27432" anchor="ctr">
-                    <a:noFill/>
-                  </a:tcPr>
-                </a:tc>
-                <a:tc>
-                  <a:txBody>
-                    <a:bodyPr/>
-                    <a:lstStyle/>
-                    <a:p>
-                      <a:pPr algn="r"/>
-                      <a:r>
-                        <a:rPr sz="1300" b="0">
-                          <a:solidFill>
-                            <a:srgbClr val="3C3C3B"/>
-                          </a:solidFill>
-                          <a:latin typeface="Aptos"/>
-                        </a:rPr>
-                        <a:t>2,850</a:t>
-                      </a:r>
-                    </a:p>
-                  </a:txBody>
-                  <a:tcPr marL="73152" marR="73152" marT="27432" marB="27432" anchor="ctr">
-                    <a:noFill/>
-                  </a:tcPr>
-                </a:tc>
-                <a:tc>
-                  <a:txBody>
-                    <a:bodyPr/>
-                    <a:lstStyle/>
-                    <a:p>
-                      <a:pPr algn="r"/>
-                      <a:r>
-                        <a:rPr sz="1300" b="0">
-                          <a:solidFill>
-                            <a:srgbClr val="3C3C3B"/>
-                          </a:solidFill>
-                          <a:latin typeface="Aptos"/>
-                        </a:rPr>
-                        <a:t>2,850</a:t>
+                        <a:t>59.5 / 47.5</a:t>
+                      </a:r>
+                    </a:p>
+                  </a:txBody>
+                  <a:tcPr marL="73152" marR="73152" marT="27432" marB="27432" anchor="ctr">
+                    <a:noFill/>
+                  </a:tcPr>
+                </a:tc>
+                <a:tc>
+                  <a:txBody>
+                    <a:bodyPr/>
+                    <a:lstStyle/>
+                    <a:p>
+                      <a:pPr algn="r"/>
+                      <a:r>
+                        <a:rPr sz="1300" b="0">
+                          <a:solidFill>
+                            <a:srgbClr val="3C3C3B"/>
+                          </a:solidFill>
+                          <a:latin typeface="Aptos"/>
+                        </a:rPr>
+                        <a:t>12 / 0</a:t>
+                      </a:r>
+                    </a:p>
+                  </a:txBody>
+                  <a:tcPr marL="73152" marR="73152" marT="27432" marB="27432" anchor="ctr">
+                    <a:noFill/>
+                  </a:tcPr>
+                </a:tc>
+                <a:tc>
+                  <a:txBody>
+                    <a:bodyPr/>
+                    <a:lstStyle/>
+                    <a:p>
+                      <a:pPr algn="r"/>
+                      <a:r>
+                        <a:rPr sz="1300" b="0">
+                          <a:solidFill>
+                            <a:srgbClr val="3C3C3B"/>
+                          </a:solidFill>
+                          <a:latin typeface="Aptos"/>
+                        </a:rPr>
+                        <a:t>12 / 0</a:t>
                       </a:r>
                     </a:p>
                   </a:txBody>
@@ -6869,21 +7598,21 @@
                   </a:tcPr>
                 </a:tc>
               </a:tr>
-              <a:tr h="420624">
-                <a:tc>
-                  <a:txBody>
-                    <a:bodyPr/>
-                    <a:lstStyle/>
-                    <a:p>
-                      <a:pPr algn="l"/>
-                      <a:r>
-                        <a:rPr sz="1300" b="0">
-                          <a:solidFill>
-                            <a:srgbClr val="3C3C3B"/>
-                          </a:solidFill>
-                          <a:latin typeface="Aptos"/>
-                        </a:rPr>
-                        <a:t>Bid: overbuild / BESS</a:t>
+              <a:tr h="411480">
+                <a:tc>
+                  <a:txBody>
+                    <a:bodyPr/>
+                    <a:lstStyle/>
+                    <a:p>
+                      <a:pPr algn="l"/>
+                      <a:r>
+                        <a:rPr sz="1300" b="0">
+                          <a:solidFill>
+                            <a:srgbClr val="3C3C3B"/>
+                          </a:solidFill>
+                          <a:latin typeface="Aptos"/>
+                        </a:rPr>
+                        <a:t>Total uses to COD</a:t>
                       </a:r>
                     </a:p>
                   </a:txBody>
@@ -6906,7 +7635,7 @@
                           </a:solidFill>
                           <a:latin typeface="Aptos"/>
                         </a:rPr>
-                        <a:t>% of MVA</a:t>
+                        <a:t>€ m</a:t>
                       </a:r>
                     </a:p>
                   </a:txBody>
@@ -6929,49 +7658,49 @@
                           </a:solidFill>
                           <a:latin typeface="Aptos"/>
                         </a:rPr>
-                        <a:t>20% / 20%</a:t>
-                      </a:r>
-                    </a:p>
-                  </a:txBody>
-                  <a:tcPr marL="73152" marR="73152" marT="27432" marB="27432" anchor="ctr">
-                    <a:noFill/>
-                  </a:tcPr>
-                </a:tc>
-                <a:tc>
-                  <a:txBody>
-                    <a:bodyPr/>
-                    <a:lstStyle/>
-                    <a:p>
-                      <a:pPr algn="r"/>
-                      <a:r>
-                        <a:rPr sz="1300" b="0">
-                          <a:solidFill>
-                            <a:srgbClr val="3C3C3B"/>
-                          </a:solidFill>
-                          <a:latin typeface="Aptos"/>
-                        </a:rPr>
-                        <a:t>none</a:t>
-                      </a:r>
-                    </a:p>
-                  </a:txBody>
-                  <a:tcPr marL="73152" marR="73152" marT="27432" marB="27432" anchor="ctr">
-                    <a:noFill/>
-                  </a:tcPr>
-                </a:tc>
-                <a:tc>
-                  <a:txBody>
-                    <a:bodyPr/>
-                    <a:lstStyle/>
-                    <a:p>
-                      <a:pPr algn="r"/>
-                      <a:r>
-                        <a:rPr sz="1300" b="0">
-                          <a:solidFill>
-                            <a:srgbClr val="3C3C3B"/>
-                          </a:solidFill>
-                          <a:latin typeface="Aptos"/>
-                        </a:rPr>
-                        <a:t>none</a:t>
+                        <a:t>113.4 / 85.1</a:t>
+                      </a:r>
+                    </a:p>
+                  </a:txBody>
+                  <a:tcPr marL="73152" marR="73152" marT="27432" marB="27432" anchor="ctr">
+                    <a:noFill/>
+                  </a:tcPr>
+                </a:tc>
+                <a:tc>
+                  <a:txBody>
+                    <a:bodyPr/>
+                    <a:lstStyle/>
+                    <a:p>
+                      <a:pPr algn="r"/>
+                      <a:r>
+                        <a:rPr sz="1300" b="0">
+                          <a:solidFill>
+                            <a:srgbClr val="3C3C3B"/>
+                          </a:solidFill>
+                          <a:latin typeface="Aptos"/>
+                        </a:rPr>
+                        <a:t>99.7 / 73.7</a:t>
+                      </a:r>
+                    </a:p>
+                  </a:txBody>
+                  <a:tcPr marL="73152" marR="73152" marT="27432" marB="27432" anchor="ctr">
+                    <a:noFill/>
+                  </a:tcPr>
+                </a:tc>
+                <a:tc>
+                  <a:txBody>
+                    <a:bodyPr/>
+                    <a:lstStyle/>
+                    <a:p>
+                      <a:pPr algn="r"/>
+                      <a:r>
+                        <a:rPr sz="1300" b="0">
+                          <a:solidFill>
+                            <a:srgbClr val="3C3C3B"/>
+                          </a:solidFill>
+                          <a:latin typeface="Aptos"/>
+                        </a:rPr>
+                        <a:t>97.1 / 71.0</a:t>
                       </a:r>
                     </a:p>
                   </a:txBody>
@@ -6980,21 +7709,21 @@
                   </a:tcPr>
                 </a:tc>
               </a:tr>
-              <a:tr h="420624">
-                <a:tc>
-                  <a:txBody>
-                    <a:bodyPr/>
-                    <a:lstStyle/>
-                    <a:p>
-                      <a:pPr algn="l"/>
-                      <a:r>
-                        <a:rPr sz="1300" b="0">
-                          <a:solidFill>
-                            <a:srgbClr val="3C3C3B"/>
-                          </a:solidFill>
-                          <a:latin typeface="Aptos"/>
-                        </a:rPr>
-                        <a:t>Bid: municipal / community</a:t>
+              <a:tr h="411480">
+                <a:tc>
+                  <a:txBody>
+                    <a:bodyPr/>
+                    <a:lstStyle/>
+                    <a:p>
+                      <a:pPr algn="l"/>
+                      <a:r>
+                        <a:rPr sz="1300" b="0">
+                          <a:solidFill>
+                            <a:srgbClr val="3C3C3B"/>
+                          </a:solidFill>
+                          <a:latin typeface="Aptos"/>
+                        </a:rPr>
+                        <a:t>FEP equity to COD</a:t>
                       </a:r>
                     </a:p>
                   </a:txBody>
@@ -7017,7 +7746,7 @@
                           </a:solidFill>
                           <a:latin typeface="Aptos"/>
                         </a:rPr>
-                        <a:t>k€/MW, €/MWh</a:t>
+                        <a:t>€ m</a:t>
                       </a:r>
                     </a:p>
                   </a:txBody>
@@ -7040,49 +7769,49 @@
                           </a:solidFill>
                           <a:latin typeface="Aptos"/>
                         </a:rPr>
-                        <a:t>50 / 3.0</a:t>
-                      </a:r>
-                    </a:p>
-                  </a:txBody>
-                  <a:tcPr marL="73152" marR="73152" marT="27432" marB="27432" anchor="ctr">
-                    <a:noFill/>
-                  </a:tcPr>
-                </a:tc>
-                <a:tc>
-                  <a:txBody>
-                    <a:bodyPr/>
-                    <a:lstStyle/>
-                    <a:p>
-                      <a:pPr algn="r"/>
-                      <a:r>
-                        <a:rPr sz="1300" b="0">
-                          <a:solidFill>
-                            <a:srgbClr val="3C3C3B"/>
-                          </a:solidFill>
-                          <a:latin typeface="Aptos"/>
-                        </a:rPr>
-                        <a:t>10 / 2.0</a:t>
-                      </a:r>
-                    </a:p>
-                  </a:txBody>
-                  <a:tcPr marL="73152" marR="73152" marT="27432" marB="27432" anchor="ctr">
-                    <a:noFill/>
-                  </a:tcPr>
-                </a:tc>
-                <a:tc>
-                  <a:txBody>
-                    <a:bodyPr/>
-                    <a:lstStyle/>
-                    <a:p>
-                      <a:pPr algn="r"/>
-                      <a:r>
-                        <a:rPr sz="1300" b="0">
-                          <a:solidFill>
-                            <a:srgbClr val="3C3C3B"/>
-                          </a:solidFill>
-                          <a:latin typeface="Aptos"/>
-                        </a:rPr>
-                        <a:t>10 / 2.0</a:t>
+                        <a:t>54.4 / 41.7</a:t>
+                      </a:r>
+                    </a:p>
+                  </a:txBody>
+                  <a:tcPr marL="73152" marR="73152" marT="27432" marB="27432" anchor="ctr">
+                    <a:noFill/>
+                  </a:tcPr>
+                </a:tc>
+                <a:tc>
+                  <a:txBody>
+                    <a:bodyPr/>
+                    <a:lstStyle/>
+                    <a:p>
+                      <a:pPr algn="r"/>
+                      <a:r>
+                        <a:rPr sz="1300" b="0">
+                          <a:solidFill>
+                            <a:srgbClr val="3C3C3B"/>
+                          </a:solidFill>
+                          <a:latin typeface="Aptos"/>
+                        </a:rPr>
+                        <a:t>43.6 / 33.2</a:t>
+                      </a:r>
+                    </a:p>
+                  </a:txBody>
+                  <a:tcPr marL="73152" marR="73152" marT="27432" marB="27432" anchor="ctr">
+                    <a:noFill/>
+                  </a:tcPr>
+                </a:tc>
+                <a:tc>
+                  <a:txBody>
+                    <a:bodyPr/>
+                    <a:lstStyle/>
+                    <a:p>
+                      <a:pPr algn="r"/>
+                      <a:r>
+                        <a:rPr sz="1300" b="0">
+                          <a:solidFill>
+                            <a:srgbClr val="3C3C3B"/>
+                          </a:solidFill>
+                          <a:latin typeface="Aptos"/>
+                        </a:rPr>
+                        <a:t>34.0 / 26.0</a:t>
                       </a:r>
                     </a:p>
                   </a:txBody>
@@ -7091,21 +7820,21 @@
                   </a:tcPr>
                 </a:tc>
               </a:tr>
-              <a:tr h="420624">
-                <a:tc>
-                  <a:txBody>
-                    <a:bodyPr/>
-                    <a:lstStyle/>
-                    <a:p>
-                      <a:pPr algn="l"/>
-                      <a:r>
-                        <a:rPr sz="1300" b="0">
-                          <a:solidFill>
-                            <a:srgbClr val="3C3C3B"/>
-                          </a:solidFill>
-                          <a:latin typeface="Aptos"/>
-                        </a:rPr>
-                        <a:t>PPA price, whole life</a:t>
+              <a:tr h="411480">
+                <a:tc>
+                  <a:txBody>
+                    <a:bodyPr/>
+                    <a:lstStyle/>
+                    <a:p>
+                      <a:pPr algn="l"/>
+                      <a:r>
+                        <a:rPr sz="1300" b="0">
+                          <a:solidFill>
+                            <a:srgbClr val="3C3C3B"/>
+                          </a:solidFill>
+                          <a:latin typeface="Aptos"/>
+                        </a:rPr>
+                        <a:t>FEP IRR, sale at COD</a:t>
                       </a:r>
                     </a:p>
                   </a:txBody>
@@ -7128,7 +7857,7 @@
                           </a:solidFill>
                           <a:latin typeface="Aptos"/>
                         </a:rPr>
-                        <a:t>€/MWh</a:t>
+                        <a:t>%</a:t>
                       </a:r>
                     </a:p>
                   </a:txBody>
@@ -7151,49 +7880,49 @@
                           </a:solidFill>
                           <a:latin typeface="Aptos"/>
                         </a:rPr>
-                        <a:t>90</a:t>
-                      </a:r>
-                    </a:p>
-                  </a:txBody>
-                  <a:tcPr marL="73152" marR="73152" marT="27432" marB="27432" anchor="ctr">
-                    <a:noFill/>
-                  </a:tcPr>
-                </a:tc>
-                <a:tc>
-                  <a:txBody>
-                    <a:bodyPr/>
-                    <a:lstStyle/>
-                    <a:p>
-                      <a:pPr algn="r"/>
-                      <a:r>
-                        <a:rPr sz="1300" b="0">
-                          <a:solidFill>
-                            <a:srgbClr val="3C3C3B"/>
-                          </a:solidFill>
-                          <a:latin typeface="Aptos"/>
-                        </a:rPr>
-                        <a:t>100</a:t>
-                      </a:r>
-                    </a:p>
-                  </a:txBody>
-                  <a:tcPr marL="73152" marR="73152" marT="27432" marB="27432" anchor="ctr">
-                    <a:noFill/>
-                  </a:tcPr>
-                </a:tc>
-                <a:tc>
-                  <a:txBody>
-                    <a:bodyPr/>
-                    <a:lstStyle/>
-                    <a:p>
-                      <a:pPr algn="r"/>
-                      <a:r>
-                        <a:rPr sz="1300" b="0">
-                          <a:solidFill>
-                            <a:srgbClr val="3C3C3B"/>
-                          </a:solidFill>
-                          <a:latin typeface="Aptos"/>
-                        </a:rPr>
-                        <a:t>105</a:t>
+                        <a:t>26.3% / 41.0%</a:t>
+                      </a:r>
+                    </a:p>
+                  </a:txBody>
+                  <a:tcPr marL="73152" marR="73152" marT="27432" marB="27432" anchor="ctr">
+                    <a:noFill/>
+                  </a:tcPr>
+                </a:tc>
+                <a:tc>
+                  <a:txBody>
+                    <a:bodyPr/>
+                    <a:lstStyle/>
+                    <a:p>
+                      <a:pPr algn="r"/>
+                      <a:r>
+                        <a:rPr sz="1300" b="0">
+                          <a:solidFill>
+                            <a:srgbClr val="3C3C3B"/>
+                          </a:solidFill>
+                          <a:latin typeface="Aptos"/>
+                        </a:rPr>
+                        <a:t>31.9% / 46.1%</a:t>
+                      </a:r>
+                    </a:p>
+                  </a:txBody>
+                  <a:tcPr marL="73152" marR="73152" marT="27432" marB="27432" anchor="ctr">
+                    <a:noFill/>
+                  </a:tcPr>
+                </a:tc>
+                <a:tc>
+                  <a:txBody>
+                    <a:bodyPr/>
+                    <a:lstStyle/>
+                    <a:p>
+                      <a:pPr algn="r"/>
+                      <a:r>
+                        <a:rPr sz="1300" b="0">
+                          <a:solidFill>
+                            <a:srgbClr val="3C3C3B"/>
+                          </a:solidFill>
+                          <a:latin typeface="Aptos"/>
+                        </a:rPr>
+                        <a:t>39.0% / 53.2%</a:t>
                       </a:r>
                     </a:p>
                   </a:txBody>
@@ -7202,21 +7931,21 @@
                   </a:tcPr>
                 </a:tc>
               </a:tr>
-              <a:tr h="420624">
-                <a:tc>
-                  <a:txBody>
-                    <a:bodyPr/>
-                    <a:lstStyle/>
-                    <a:p>
-                      <a:pPr algn="l"/>
-                      <a:r>
-                        <a:rPr sz="1300" b="0">
-                          <a:solidFill>
-                            <a:srgbClr val="3C3C3B"/>
-                          </a:solidFill>
-                          <a:latin typeface="Aptos"/>
-                        </a:rPr>
-                        <a:t>Gearing (debt / construction cost)</a:t>
+              <a:tr h="411480">
+                <a:tc>
+                  <a:txBody>
+                    <a:bodyPr/>
+                    <a:lstStyle/>
+                    <a:p>
+                      <a:pPr algn="l"/>
+                      <a:r>
+                        <a:rPr sz="1300" b="1">
+                          <a:solidFill>
+                            <a:srgbClr val="3C3C3B"/>
+                          </a:solidFill>
+                          <a:latin typeface="Aptos"/>
+                        </a:rPr>
+                        <a:t>FEP IRR, hold</a:t>
                       </a:r>
                     </a:p>
                   </a:txBody>
@@ -7233,7 +7962,7 @@
                     <a:p>
                       <a:pPr algn="l"/>
                       <a:r>
-                        <a:rPr sz="1300" b="0">
+                        <a:rPr sz="1300" b="1">
                           <a:solidFill>
                             <a:srgbClr val="919191"/>
                           </a:solidFill>
@@ -7256,159 +7985,195 @@
                     <a:p>
                       <a:pPr algn="r"/>
                       <a:r>
-                        <a:rPr sz="1300" b="0">
-                          <a:solidFill>
-                            <a:srgbClr val="3C3C3B"/>
-                          </a:solidFill>
-                          <a:latin typeface="Aptos"/>
-                        </a:rPr>
-                        <a:t>55%</a:t>
-                      </a:r>
-                    </a:p>
-                  </a:txBody>
-                  <a:tcPr marL="73152" marR="73152" marT="27432" marB="27432" anchor="ctr">
-                    <a:noFill/>
-                  </a:tcPr>
-                </a:tc>
-                <a:tc>
-                  <a:txBody>
-                    <a:bodyPr/>
-                    <a:lstStyle/>
-                    <a:p>
-                      <a:pPr algn="r"/>
-                      <a:r>
-                        <a:rPr sz="1300" b="0">
-                          <a:solidFill>
-                            <a:srgbClr val="3C3C3B"/>
-                          </a:solidFill>
-                          <a:latin typeface="Aptos"/>
-                        </a:rPr>
-                        <a:t>60%</a:t>
-                      </a:r>
-                    </a:p>
-                  </a:txBody>
-                  <a:tcPr marL="73152" marR="73152" marT="27432" marB="27432" anchor="ctr">
-                    <a:noFill/>
-                  </a:tcPr>
-                </a:tc>
-                <a:tc>
-                  <a:txBody>
-                    <a:bodyPr/>
-                    <a:lstStyle/>
-                    <a:p>
-                      <a:pPr algn="r"/>
-                      <a:r>
-                        <a:rPr sz="1300" b="0">
-                          <a:solidFill>
-                            <a:srgbClr val="3C3C3B"/>
-                          </a:solidFill>
-                          <a:latin typeface="Aptos"/>
-                        </a:rPr>
-                        <a:t>60%</a:t>
-                      </a:r>
-                    </a:p>
-                  </a:txBody>
-                  <a:tcPr marL="73152" marR="73152" marT="27432" marB="27432" anchor="ctr">
-                    <a:noFill/>
+                        <a:rPr sz="1300" b="1">
+                          <a:solidFill>
+                            <a:srgbClr val="3C3C3B"/>
+                          </a:solidFill>
+                          <a:latin typeface="Aptos"/>
+                        </a:rPr>
+                        <a:t>7.6% / 11.4%</a:t>
+                      </a:r>
+                    </a:p>
+                  </a:txBody>
+                  <a:tcPr marL="73152" marR="73152" marT="27432" marB="27432" anchor="ctr">
+                    <a:solidFill>
+                      <a:srgbClr val="E6F4EC"/>
+                    </a:solidFill>
+                  </a:tcPr>
+                </a:tc>
+                <a:tc>
+                  <a:txBody>
+                    <a:bodyPr/>
+                    <a:lstStyle/>
+                    <a:p>
+                      <a:pPr algn="r"/>
+                      <a:r>
+                        <a:rPr sz="1300" b="1">
+                          <a:solidFill>
+                            <a:srgbClr val="3C3C3B"/>
+                          </a:solidFill>
+                          <a:latin typeface="Aptos"/>
+                        </a:rPr>
+                        <a:t>12.4% / 17.3%</a:t>
+                      </a:r>
+                    </a:p>
+                  </a:txBody>
+                  <a:tcPr marL="73152" marR="73152" marT="27432" marB="27432" anchor="ctr">
+                    <a:solidFill>
+                      <a:srgbClr val="E6F4EC"/>
+                    </a:solidFill>
+                  </a:tcPr>
+                </a:tc>
+                <a:tc>
+                  <a:txBody>
+                    <a:bodyPr/>
+                    <a:lstStyle/>
+                    <a:p>
+                      <a:pPr algn="r"/>
+                      <a:r>
+                        <a:rPr sz="1300" b="1">
+                          <a:solidFill>
+                            <a:srgbClr val="3C3C3B"/>
+                          </a:solidFill>
+                          <a:latin typeface="Aptos"/>
+                        </a:rPr>
+                        <a:t>16.1% / 22.0%</a:t>
+                      </a:r>
+                    </a:p>
+                  </a:txBody>
+                  <a:tcPr marL="73152" marR="73152" marT="27432" marB="27432" anchor="ctr">
+                    <a:solidFill>
+                      <a:srgbClr val="E6F4EC"/>
+                    </a:solidFill>
                   </a:tcPr>
                 </a:tc>
               </a:tr>
-              <a:tr h="420624">
-                <a:tc>
-                  <a:txBody>
-                    <a:bodyPr/>
-                    <a:lstStyle/>
-                    <a:p>
-                      <a:pPr algn="l"/>
-                      <a:r>
-                        <a:rPr sz="1300" b="1">
-                          <a:solidFill>
-                            <a:srgbClr val="00563C"/>
-                          </a:solidFill>
-                          <a:latin typeface="Aptos"/>
-                        </a:rPr>
-                        <a:t>Results (European / Chinese)</a:t>
-                      </a:r>
-                    </a:p>
-                  </a:txBody>
-                  <a:tcPr marL="73152" marR="73152" marT="27432" marB="27432" anchor="ctr">
-                    <a:solidFill>
-                      <a:srgbClr val="E6F4EC"/>
-                    </a:solidFill>
-                  </a:tcPr>
-                </a:tc>
-                <a:tc>
-                  <a:txBody>
-                    <a:bodyPr/>
-                    <a:lstStyle/>
-                    <a:p>
-                      <a:pPr algn="l"/>
-                    </a:p>
-                  </a:txBody>
-                  <a:tcPr marL="73152" marR="73152" marT="27432" marB="27432" anchor="ctr">
-                    <a:solidFill>
-                      <a:srgbClr val="E6F4EC"/>
-                    </a:solidFill>
-                  </a:tcPr>
-                </a:tc>
-                <a:tc>
-                  <a:txBody>
-                    <a:bodyPr/>
-                    <a:lstStyle/>
-                    <a:p>
-                      <a:pPr algn="r"/>
-                    </a:p>
-                  </a:txBody>
-                  <a:tcPr marL="73152" marR="73152" marT="27432" marB="27432" anchor="ctr">
-                    <a:solidFill>
-                      <a:srgbClr val="E6F4EC"/>
-                    </a:solidFill>
-                  </a:tcPr>
-                </a:tc>
-                <a:tc>
-                  <a:txBody>
-                    <a:bodyPr/>
-                    <a:lstStyle/>
-                    <a:p>
-                      <a:pPr algn="r"/>
-                    </a:p>
-                  </a:txBody>
-                  <a:tcPr marL="73152" marR="73152" marT="27432" marB="27432" anchor="ctr">
-                    <a:solidFill>
-                      <a:srgbClr val="E6F4EC"/>
-                    </a:solidFill>
-                  </a:tcPr>
-                </a:tc>
-                <a:tc>
-                  <a:txBody>
-                    <a:bodyPr/>
-                    <a:lstStyle/>
-                    <a:p>
-                      <a:pPr algn="r"/>
-                    </a:p>
-                  </a:txBody>
-                  <a:tcPr marL="73152" marR="73152" marT="27432" marB="27432" anchor="ctr">
-                    <a:solidFill>
-                      <a:srgbClr val="E6F4EC"/>
-                    </a:solidFill>
+              <a:tr h="411480">
+                <a:tc>
+                  <a:txBody>
+                    <a:bodyPr/>
+                    <a:lstStyle/>
+                    <a:p>
+                      <a:pPr algn="l"/>
+                      <a:r>
+                        <a:rPr sz="1300" b="0">
+                          <a:solidFill>
+                            <a:srgbClr val="3C3C3B"/>
+                          </a:solidFill>
+                          <a:latin typeface="Aptos"/>
+                        </a:rPr>
+                        <a:t>FEP NPV, hold</a:t>
+                      </a:r>
+                    </a:p>
+                  </a:txBody>
+                  <a:tcPr marL="73152" marR="73152" marT="27432" marB="27432" anchor="ctr">
+                    <a:solidFill>
+                      <a:srgbClr val="F2F2F2"/>
+                    </a:solidFill>
+                  </a:tcPr>
+                </a:tc>
+                <a:tc>
+                  <a:txBody>
+                    <a:bodyPr/>
+                    <a:lstStyle/>
+                    <a:p>
+                      <a:pPr algn="l"/>
+                      <a:r>
+                        <a:rPr sz="1300" b="0">
+                          <a:solidFill>
+                            <a:srgbClr val="919191"/>
+                          </a:solidFill>
+                          <a:latin typeface="Aptos"/>
+                        </a:rPr>
+                        <a:t>€ m</a:t>
+                      </a:r>
+                    </a:p>
+                  </a:txBody>
+                  <a:tcPr marL="73152" marR="73152" marT="27432" marB="27432" anchor="ctr">
+                    <a:solidFill>
+                      <a:srgbClr val="F2F2F2"/>
+                    </a:solidFill>
+                  </a:tcPr>
+                </a:tc>
+                <a:tc>
+                  <a:txBody>
+                    <a:bodyPr/>
+                    <a:lstStyle/>
+                    <a:p>
+                      <a:pPr algn="r"/>
+                      <a:r>
+                        <a:rPr sz="1300" b="0">
+                          <a:solidFill>
+                            <a:srgbClr val="3C3C3B"/>
+                          </a:solidFill>
+                          <a:latin typeface="Aptos"/>
+                        </a:rPr>
+                        <a:t>(2.4) / 15.7</a:t>
+                      </a:r>
+                    </a:p>
+                  </a:txBody>
+                  <a:tcPr marL="73152" marR="73152" marT="27432" marB="27432" anchor="ctr">
+                    <a:noFill/>
+                  </a:tcPr>
+                </a:tc>
+                <a:tc>
+                  <a:txBody>
+                    <a:bodyPr/>
+                    <a:lstStyle/>
+                    <a:p>
+                      <a:pPr algn="r"/>
+                      <a:r>
+                        <a:rPr sz="1300" b="0">
+                          <a:solidFill>
+                            <a:srgbClr val="3C3C3B"/>
+                          </a:solidFill>
+                          <a:latin typeface="Aptos"/>
+                        </a:rPr>
+                        <a:t>22.5 / 38.8</a:t>
+                      </a:r>
+                    </a:p>
+                  </a:txBody>
+                  <a:tcPr marL="73152" marR="73152" marT="27432" marB="27432" anchor="ctr">
+                    <a:noFill/>
+                  </a:tcPr>
+                </a:tc>
+                <a:tc>
+                  <a:txBody>
+                    <a:bodyPr/>
+                    <a:lstStyle/>
+                    <a:p>
+                      <a:pPr algn="r"/>
+                      <a:r>
+                        <a:rPr sz="1300" b="0">
+                          <a:solidFill>
+                            <a:srgbClr val="3C3C3B"/>
+                          </a:solidFill>
+                          <a:latin typeface="Aptos"/>
+                        </a:rPr>
+                        <a:t>33.9 / 49.1</a:t>
+                      </a:r>
+                    </a:p>
+                  </a:txBody>
+                  <a:tcPr marL="73152" marR="73152" marT="27432" marB="27432" anchor="ctr">
+                    <a:noFill/>
                   </a:tcPr>
                 </a:tc>
               </a:tr>
-              <a:tr h="420624">
-                <a:tc>
-                  <a:txBody>
-                    <a:bodyPr/>
-                    <a:lstStyle/>
-                    <a:p>
-                      <a:pPr algn="l"/>
-                      <a:r>
-                        <a:rPr sz="1300" b="0">
-                          <a:solidFill>
-                            <a:srgbClr val="3C3C3B"/>
-                          </a:solidFill>
-                          <a:latin typeface="Aptos"/>
-                        </a:rPr>
-                        <a:t>Tender points</a:t>
+              <a:tr h="411480">
+                <a:tc>
+                  <a:txBody>
+                    <a:bodyPr/>
+                    <a:lstStyle/>
+                    <a:p>
+                      <a:pPr algn="l"/>
+                      <a:r>
+                        <a:rPr sz="1300" b="0">
+                          <a:solidFill>
+                            <a:srgbClr val="3C3C3B"/>
+                          </a:solidFill>
+                          <a:latin typeface="Aptos"/>
+                        </a:rPr>
+                        <a:t>Minimum DSCR</a:t>
                       </a:r>
                     </a:p>
                   </a:txBody>
@@ -7431,7 +8196,7 @@
                           </a:solidFill>
                           <a:latin typeface="Aptos"/>
                         </a:rPr>
-                        <a:t>points</a:t>
+                        <a:t>x</a:t>
                       </a:r>
                     </a:p>
                   </a:txBody>
@@ -7454,678 +8219,6 @@
                           </a:solidFill>
                           <a:latin typeface="Aptos"/>
                         </a:rPr>
-                        <a:t>59.5 / 47.5</a:t>
-                      </a:r>
-                    </a:p>
-                  </a:txBody>
-                  <a:tcPr marL="73152" marR="73152" marT="27432" marB="27432" anchor="ctr">
-                    <a:noFill/>
-                  </a:tcPr>
-                </a:tc>
-                <a:tc>
-                  <a:txBody>
-                    <a:bodyPr/>
-                    <a:lstStyle/>
-                    <a:p>
-                      <a:pPr algn="r"/>
-                      <a:r>
-                        <a:rPr sz="1300" b="0">
-                          <a:solidFill>
-                            <a:srgbClr val="3C3C3B"/>
-                          </a:solidFill>
-                          <a:latin typeface="Aptos"/>
-                        </a:rPr>
-                        <a:t>12 / 0</a:t>
-                      </a:r>
-                    </a:p>
-                  </a:txBody>
-                  <a:tcPr marL="73152" marR="73152" marT="27432" marB="27432" anchor="ctr">
-                    <a:noFill/>
-                  </a:tcPr>
-                </a:tc>
-                <a:tc>
-                  <a:txBody>
-                    <a:bodyPr/>
-                    <a:lstStyle/>
-                    <a:p>
-                      <a:pPr algn="r"/>
-                      <a:r>
-                        <a:rPr sz="1300" b="0">
-                          <a:solidFill>
-                            <a:srgbClr val="3C3C3B"/>
-                          </a:solidFill>
-                          <a:latin typeface="Aptos"/>
-                        </a:rPr>
-                        <a:t>12 / 0</a:t>
-                      </a:r>
-                    </a:p>
-                  </a:txBody>
-                  <a:tcPr marL="73152" marR="73152" marT="27432" marB="27432" anchor="ctr">
-                    <a:noFill/>
-                  </a:tcPr>
-                </a:tc>
-              </a:tr>
-              <a:tr h="420624">
-                <a:tc>
-                  <a:txBody>
-                    <a:bodyPr/>
-                    <a:lstStyle/>
-                    <a:p>
-                      <a:pPr algn="l"/>
-                      <a:r>
-                        <a:rPr sz="1300" b="0">
-                          <a:solidFill>
-                            <a:srgbClr val="3C3C3B"/>
-                          </a:solidFill>
-                          <a:latin typeface="Aptos"/>
-                        </a:rPr>
-                        <a:t>Total uses to COD</a:t>
-                      </a:r>
-                    </a:p>
-                  </a:txBody>
-                  <a:tcPr marL="73152" marR="73152" marT="27432" marB="27432" anchor="ctr">
-                    <a:solidFill>
-                      <a:srgbClr val="F2F2F2"/>
-                    </a:solidFill>
-                  </a:tcPr>
-                </a:tc>
-                <a:tc>
-                  <a:txBody>
-                    <a:bodyPr/>
-                    <a:lstStyle/>
-                    <a:p>
-                      <a:pPr algn="l"/>
-                      <a:r>
-                        <a:rPr sz="1300" b="0">
-                          <a:solidFill>
-                            <a:srgbClr val="919191"/>
-                          </a:solidFill>
-                          <a:latin typeface="Aptos"/>
-                        </a:rPr>
-                        <a:t>€ m</a:t>
-                      </a:r>
-                    </a:p>
-                  </a:txBody>
-                  <a:tcPr marL="73152" marR="73152" marT="27432" marB="27432" anchor="ctr">
-                    <a:solidFill>
-                      <a:srgbClr val="F2F2F2"/>
-                    </a:solidFill>
-                  </a:tcPr>
-                </a:tc>
-                <a:tc>
-                  <a:txBody>
-                    <a:bodyPr/>
-                    <a:lstStyle/>
-                    <a:p>
-                      <a:pPr algn="r"/>
-                      <a:r>
-                        <a:rPr sz="1300" b="0">
-                          <a:solidFill>
-                            <a:srgbClr val="3C3C3B"/>
-                          </a:solidFill>
-                          <a:latin typeface="Aptos"/>
-                        </a:rPr>
-                        <a:t>113.4 / 85.1</a:t>
-                      </a:r>
-                    </a:p>
-                  </a:txBody>
-                  <a:tcPr marL="73152" marR="73152" marT="27432" marB="27432" anchor="ctr">
-                    <a:noFill/>
-                  </a:tcPr>
-                </a:tc>
-                <a:tc>
-                  <a:txBody>
-                    <a:bodyPr/>
-                    <a:lstStyle/>
-                    <a:p>
-                      <a:pPr algn="r"/>
-                      <a:r>
-                        <a:rPr sz="1300" b="0">
-                          <a:solidFill>
-                            <a:srgbClr val="3C3C3B"/>
-                          </a:solidFill>
-                          <a:latin typeface="Aptos"/>
-                        </a:rPr>
-                        <a:t>100.2 / 74.2</a:t>
-                      </a:r>
-                    </a:p>
-                  </a:txBody>
-                  <a:tcPr marL="73152" marR="73152" marT="27432" marB="27432" anchor="ctr">
-                    <a:noFill/>
-                  </a:tcPr>
-                </a:tc>
-                <a:tc>
-                  <a:txBody>
-                    <a:bodyPr/>
-                    <a:lstStyle/>
-                    <a:p>
-                      <a:pPr algn="r"/>
-                      <a:r>
-                        <a:rPr sz="1300" b="0">
-                          <a:solidFill>
-                            <a:srgbClr val="3C3C3B"/>
-                          </a:solidFill>
-                          <a:latin typeface="Aptos"/>
-                        </a:rPr>
-                        <a:t>100.2 / 74.2</a:t>
-                      </a:r>
-                    </a:p>
-                  </a:txBody>
-                  <a:tcPr marL="73152" marR="73152" marT="27432" marB="27432" anchor="ctr">
-                    <a:noFill/>
-                  </a:tcPr>
-                </a:tc>
-              </a:tr>
-              <a:tr h="420624">
-                <a:tc>
-                  <a:txBody>
-                    <a:bodyPr/>
-                    <a:lstStyle/>
-                    <a:p>
-                      <a:pPr algn="l"/>
-                      <a:r>
-                        <a:rPr sz="1300" b="0">
-                          <a:solidFill>
-                            <a:srgbClr val="3C3C3B"/>
-                          </a:solidFill>
-                          <a:latin typeface="Aptos"/>
-                        </a:rPr>
-                        <a:t>FEP equity to COD</a:t>
-                      </a:r>
-                    </a:p>
-                  </a:txBody>
-                  <a:tcPr marL="73152" marR="73152" marT="27432" marB="27432" anchor="ctr">
-                    <a:solidFill>
-                      <a:srgbClr val="F2F2F2"/>
-                    </a:solidFill>
-                  </a:tcPr>
-                </a:tc>
-                <a:tc>
-                  <a:txBody>
-                    <a:bodyPr/>
-                    <a:lstStyle/>
-                    <a:p>
-                      <a:pPr algn="l"/>
-                      <a:r>
-                        <a:rPr sz="1300" b="0">
-                          <a:solidFill>
-                            <a:srgbClr val="919191"/>
-                          </a:solidFill>
-                          <a:latin typeface="Aptos"/>
-                        </a:rPr>
-                        <a:t>€ m</a:t>
-                      </a:r>
-                    </a:p>
-                  </a:txBody>
-                  <a:tcPr marL="73152" marR="73152" marT="27432" marB="27432" anchor="ctr">
-                    <a:solidFill>
-                      <a:srgbClr val="F2F2F2"/>
-                    </a:solidFill>
-                  </a:tcPr>
-                </a:tc>
-                <a:tc>
-                  <a:txBody>
-                    <a:bodyPr/>
-                    <a:lstStyle/>
-                    <a:p>
-                      <a:pPr algn="r"/>
-                      <a:r>
-                        <a:rPr sz="1300" b="0">
-                          <a:solidFill>
-                            <a:srgbClr val="3C3C3B"/>
-                          </a:solidFill>
-                          <a:latin typeface="Aptos"/>
-                        </a:rPr>
-                        <a:t>54.4 / 41.7</a:t>
-                      </a:r>
-                    </a:p>
-                  </a:txBody>
-                  <a:tcPr marL="73152" marR="73152" marT="27432" marB="27432" anchor="ctr">
-                    <a:noFill/>
-                  </a:tcPr>
-                </a:tc>
-                <a:tc>
-                  <a:txBody>
-                    <a:bodyPr/>
-                    <a:lstStyle/>
-                    <a:p>
-                      <a:pPr algn="r"/>
-                      <a:r>
-                        <a:rPr sz="1300" b="0">
-                          <a:solidFill>
-                            <a:srgbClr val="3C3C3B"/>
-                          </a:solidFill>
-                          <a:latin typeface="Aptos"/>
-                        </a:rPr>
-                        <a:t>43.8 / 33.4</a:t>
-                      </a:r>
-                    </a:p>
-                  </a:txBody>
-                  <a:tcPr marL="73152" marR="73152" marT="27432" marB="27432" anchor="ctr">
-                    <a:noFill/>
-                  </a:tcPr>
-                </a:tc>
-                <a:tc>
-                  <a:txBody>
-                    <a:bodyPr/>
-                    <a:lstStyle/>
-                    <a:p>
-                      <a:pPr algn="r"/>
-                      <a:r>
-                        <a:rPr sz="1300" b="0">
-                          <a:solidFill>
-                            <a:srgbClr val="3C3C3B"/>
-                          </a:solidFill>
-                          <a:latin typeface="Aptos"/>
-                        </a:rPr>
-                        <a:t>43.8 / 33.4</a:t>
-                      </a:r>
-                    </a:p>
-                  </a:txBody>
-                  <a:tcPr marL="73152" marR="73152" marT="27432" marB="27432" anchor="ctr">
-                    <a:noFill/>
-                  </a:tcPr>
-                </a:tc>
-              </a:tr>
-              <a:tr h="420624">
-                <a:tc>
-                  <a:txBody>
-                    <a:bodyPr/>
-                    <a:lstStyle/>
-                    <a:p>
-                      <a:pPr algn="l"/>
-                      <a:r>
-                        <a:rPr sz="1300" b="0">
-                          <a:solidFill>
-                            <a:srgbClr val="3C3C3B"/>
-                          </a:solidFill>
-                          <a:latin typeface="Aptos"/>
-                        </a:rPr>
-                        <a:t>FEP IRR, sale at COD</a:t>
-                      </a:r>
-                    </a:p>
-                  </a:txBody>
-                  <a:tcPr marL="73152" marR="73152" marT="27432" marB="27432" anchor="ctr">
-                    <a:solidFill>
-                      <a:srgbClr val="F2F2F2"/>
-                    </a:solidFill>
-                  </a:tcPr>
-                </a:tc>
-                <a:tc>
-                  <a:txBody>
-                    <a:bodyPr/>
-                    <a:lstStyle/>
-                    <a:p>
-                      <a:pPr algn="l"/>
-                      <a:r>
-                        <a:rPr sz="1300" b="0">
-                          <a:solidFill>
-                            <a:srgbClr val="919191"/>
-                          </a:solidFill>
-                          <a:latin typeface="Aptos"/>
-                        </a:rPr>
-                        <a:t>%</a:t>
-                      </a:r>
-                    </a:p>
-                  </a:txBody>
-                  <a:tcPr marL="73152" marR="73152" marT="27432" marB="27432" anchor="ctr">
-                    <a:solidFill>
-                      <a:srgbClr val="F2F2F2"/>
-                    </a:solidFill>
-                  </a:tcPr>
-                </a:tc>
-                <a:tc>
-                  <a:txBody>
-                    <a:bodyPr/>
-                    <a:lstStyle/>
-                    <a:p>
-                      <a:pPr algn="r"/>
-                      <a:r>
-                        <a:rPr sz="1300" b="0">
-                          <a:solidFill>
-                            <a:srgbClr val="3C3C3B"/>
-                          </a:solidFill>
-                          <a:latin typeface="Aptos"/>
-                        </a:rPr>
-                        <a:t>26.3% / 41.0%</a:t>
-                      </a:r>
-                    </a:p>
-                  </a:txBody>
-                  <a:tcPr marL="73152" marR="73152" marT="27432" marB="27432" anchor="ctr">
-                    <a:noFill/>
-                  </a:tcPr>
-                </a:tc>
-                <a:tc>
-                  <a:txBody>
-                    <a:bodyPr/>
-                    <a:lstStyle/>
-                    <a:p>
-                      <a:pPr algn="r"/>
-                      <a:r>
-                        <a:rPr sz="1300" b="0">
-                          <a:solidFill>
-                            <a:srgbClr val="3C3C3B"/>
-                          </a:solidFill>
-                          <a:latin typeface="Aptos"/>
-                        </a:rPr>
-                        <a:t>31.3% / 45.5%</a:t>
-                      </a:r>
-                    </a:p>
-                  </a:txBody>
-                  <a:tcPr marL="73152" marR="73152" marT="27432" marB="27432" anchor="ctr">
-                    <a:noFill/>
-                  </a:tcPr>
-                </a:tc>
-                <a:tc>
-                  <a:txBody>
-                    <a:bodyPr/>
-                    <a:lstStyle/>
-                    <a:p>
-                      <a:pPr algn="r"/>
-                      <a:r>
-                        <a:rPr sz="1300" b="0">
-                          <a:solidFill>
-                            <a:srgbClr val="3C3C3B"/>
-                          </a:solidFill>
-                          <a:latin typeface="Aptos"/>
-                        </a:rPr>
-                        <a:t>31.3% / 45.5%</a:t>
-                      </a:r>
-                    </a:p>
-                  </a:txBody>
-                  <a:tcPr marL="73152" marR="73152" marT="27432" marB="27432" anchor="ctr">
-                    <a:noFill/>
-                  </a:tcPr>
-                </a:tc>
-              </a:tr>
-              <a:tr h="420624">
-                <a:tc>
-                  <a:txBody>
-                    <a:bodyPr/>
-                    <a:lstStyle/>
-                    <a:p>
-                      <a:pPr algn="l"/>
-                      <a:r>
-                        <a:rPr sz="1300" b="1">
-                          <a:solidFill>
-                            <a:srgbClr val="3C3C3B"/>
-                          </a:solidFill>
-                          <a:latin typeface="Aptos"/>
-                        </a:rPr>
-                        <a:t>FEP IRR, hold</a:t>
-                      </a:r>
-                    </a:p>
-                  </a:txBody>
-                  <a:tcPr marL="73152" marR="73152" marT="27432" marB="27432" anchor="ctr">
-                    <a:solidFill>
-                      <a:srgbClr val="F2F2F2"/>
-                    </a:solidFill>
-                  </a:tcPr>
-                </a:tc>
-                <a:tc>
-                  <a:txBody>
-                    <a:bodyPr/>
-                    <a:lstStyle/>
-                    <a:p>
-                      <a:pPr algn="l"/>
-                      <a:r>
-                        <a:rPr sz="1300" b="1">
-                          <a:solidFill>
-                            <a:srgbClr val="919191"/>
-                          </a:solidFill>
-                          <a:latin typeface="Aptos"/>
-                        </a:rPr>
-                        <a:t>%</a:t>
-                      </a:r>
-                    </a:p>
-                  </a:txBody>
-                  <a:tcPr marL="73152" marR="73152" marT="27432" marB="27432" anchor="ctr">
-                    <a:solidFill>
-                      <a:srgbClr val="F2F2F2"/>
-                    </a:solidFill>
-                  </a:tcPr>
-                </a:tc>
-                <a:tc>
-                  <a:txBody>
-                    <a:bodyPr/>
-                    <a:lstStyle/>
-                    <a:p>
-                      <a:pPr algn="r"/>
-                      <a:r>
-                        <a:rPr sz="1300" b="1">
-                          <a:solidFill>
-                            <a:srgbClr val="3C3C3B"/>
-                          </a:solidFill>
-                          <a:latin typeface="Aptos"/>
-                        </a:rPr>
-                        <a:t>7.6% / 11.4%</a:t>
-                      </a:r>
-                    </a:p>
-                  </a:txBody>
-                  <a:tcPr marL="73152" marR="73152" marT="27432" marB="27432" anchor="ctr">
-                    <a:solidFill>
-                      <a:srgbClr val="E6F4EC"/>
-                    </a:solidFill>
-                  </a:tcPr>
-                </a:tc>
-                <a:tc>
-                  <a:txBody>
-                    <a:bodyPr/>
-                    <a:lstStyle/>
-                    <a:p>
-                      <a:pPr algn="r"/>
-                      <a:r>
-                        <a:rPr sz="1300" b="1">
-                          <a:solidFill>
-                            <a:srgbClr val="3C3C3B"/>
-                          </a:solidFill>
-                          <a:latin typeface="Aptos"/>
-                        </a:rPr>
-                        <a:t>11.9% / 16.8%</a:t>
-                      </a:r>
-                    </a:p>
-                  </a:txBody>
-                  <a:tcPr marL="73152" marR="73152" marT="27432" marB="27432" anchor="ctr">
-                    <a:solidFill>
-                      <a:srgbClr val="E6F4EC"/>
-                    </a:solidFill>
-                  </a:tcPr>
-                </a:tc>
-                <a:tc>
-                  <a:txBody>
-                    <a:bodyPr/>
-                    <a:lstStyle/>
-                    <a:p>
-                      <a:pPr algn="r"/>
-                      <a:r>
-                        <a:rPr sz="1300" b="1">
-                          <a:solidFill>
-                            <a:srgbClr val="3C3C3B"/>
-                          </a:solidFill>
-                          <a:latin typeface="Aptos"/>
-                        </a:rPr>
-                        <a:t>12.9% / 17.9%</a:t>
-                      </a:r>
-                    </a:p>
-                  </a:txBody>
-                  <a:tcPr marL="73152" marR="73152" marT="27432" marB="27432" anchor="ctr">
-                    <a:solidFill>
-                      <a:srgbClr val="E6F4EC"/>
-                    </a:solidFill>
-                  </a:tcPr>
-                </a:tc>
-              </a:tr>
-              <a:tr h="420624">
-                <a:tc>
-                  <a:txBody>
-                    <a:bodyPr/>
-                    <a:lstStyle/>
-                    <a:p>
-                      <a:pPr algn="l"/>
-                      <a:r>
-                        <a:rPr sz="1300" b="0">
-                          <a:solidFill>
-                            <a:srgbClr val="3C3C3B"/>
-                          </a:solidFill>
-                          <a:latin typeface="Aptos"/>
-                        </a:rPr>
-                        <a:t>FEP NPV, hold</a:t>
-                      </a:r>
-                    </a:p>
-                  </a:txBody>
-                  <a:tcPr marL="73152" marR="73152" marT="27432" marB="27432" anchor="ctr">
-                    <a:solidFill>
-                      <a:srgbClr val="F2F2F2"/>
-                    </a:solidFill>
-                  </a:tcPr>
-                </a:tc>
-                <a:tc>
-                  <a:txBody>
-                    <a:bodyPr/>
-                    <a:lstStyle/>
-                    <a:p>
-                      <a:pPr algn="l"/>
-                      <a:r>
-                        <a:rPr sz="1300" b="0">
-                          <a:solidFill>
-                            <a:srgbClr val="919191"/>
-                          </a:solidFill>
-                          <a:latin typeface="Aptos"/>
-                        </a:rPr>
-                        <a:t>€ m</a:t>
-                      </a:r>
-                    </a:p>
-                  </a:txBody>
-                  <a:tcPr marL="73152" marR="73152" marT="27432" marB="27432" anchor="ctr">
-                    <a:solidFill>
-                      <a:srgbClr val="F2F2F2"/>
-                    </a:solidFill>
-                  </a:tcPr>
-                </a:tc>
-                <a:tc>
-                  <a:txBody>
-                    <a:bodyPr/>
-                    <a:lstStyle/>
-                    <a:p>
-                      <a:pPr algn="r"/>
-                      <a:r>
-                        <a:rPr sz="1300" b="0">
-                          <a:solidFill>
-                            <a:srgbClr val="3C3C3B"/>
-                          </a:solidFill>
-                          <a:latin typeface="Aptos"/>
-                        </a:rPr>
-                        <a:t>(2.4) / 15.7</a:t>
-                      </a:r>
-                    </a:p>
-                  </a:txBody>
-                  <a:tcPr marL="73152" marR="73152" marT="27432" marB="27432" anchor="ctr">
-                    <a:noFill/>
-                  </a:tcPr>
-                </a:tc>
-                <a:tc>
-                  <a:txBody>
-                    <a:bodyPr/>
-                    <a:lstStyle/>
-                    <a:p>
-                      <a:pPr algn="r"/>
-                      <a:r>
-                        <a:rPr sz="1300" b="0">
-                          <a:solidFill>
-                            <a:srgbClr val="3C3C3B"/>
-                          </a:solidFill>
-                          <a:latin typeface="Aptos"/>
-                        </a:rPr>
-                        <a:t>20.2 / 36.5</a:t>
-                      </a:r>
-                    </a:p>
-                  </a:txBody>
-                  <a:tcPr marL="73152" marR="73152" marT="27432" marB="27432" anchor="ctr">
-                    <a:noFill/>
-                  </a:tcPr>
-                </a:tc>
-                <a:tc>
-                  <a:txBody>
-                    <a:bodyPr/>
-                    <a:lstStyle/>
-                    <a:p>
-                      <a:pPr algn="r"/>
-                      <a:r>
-                        <a:rPr sz="1300" b="0">
-                          <a:solidFill>
-                            <a:srgbClr val="3C3C3B"/>
-                          </a:solidFill>
-                          <a:latin typeface="Aptos"/>
-                        </a:rPr>
-                        <a:t>25.6 / 41.9</a:t>
-                      </a:r>
-                    </a:p>
-                  </a:txBody>
-                  <a:tcPr marL="73152" marR="73152" marT="27432" marB="27432" anchor="ctr">
-                    <a:noFill/>
-                  </a:tcPr>
-                </a:tc>
-              </a:tr>
-              <a:tr h="420624">
-                <a:tc>
-                  <a:txBody>
-                    <a:bodyPr/>
-                    <a:lstStyle/>
-                    <a:p>
-                      <a:pPr algn="l"/>
-                      <a:r>
-                        <a:rPr sz="1300" b="0">
-                          <a:solidFill>
-                            <a:srgbClr val="3C3C3B"/>
-                          </a:solidFill>
-                          <a:latin typeface="Aptos"/>
-                        </a:rPr>
-                        <a:t>Minimum DSCR</a:t>
-                      </a:r>
-                    </a:p>
-                  </a:txBody>
-                  <a:tcPr marL="73152" marR="73152" marT="27432" marB="27432" anchor="ctr">
-                    <a:solidFill>
-                      <a:srgbClr val="F2F2F2"/>
-                    </a:solidFill>
-                  </a:tcPr>
-                </a:tc>
-                <a:tc>
-                  <a:txBody>
-                    <a:bodyPr/>
-                    <a:lstStyle/>
-                    <a:p>
-                      <a:pPr algn="l"/>
-                      <a:r>
-                        <a:rPr sz="1300" b="0">
-                          <a:solidFill>
-                            <a:srgbClr val="919191"/>
-                          </a:solidFill>
-                          <a:latin typeface="Aptos"/>
-                        </a:rPr>
-                        <a:t>x</a:t>
-                      </a:r>
-                    </a:p>
-                  </a:txBody>
-                  <a:tcPr marL="73152" marR="73152" marT="27432" marB="27432" anchor="ctr">
-                    <a:solidFill>
-                      <a:srgbClr val="F2F2F2"/>
-                    </a:solidFill>
-                  </a:tcPr>
-                </a:tc>
-                <a:tc>
-                  <a:txBody>
-                    <a:bodyPr/>
-                    <a:lstStyle/>
-                    <a:p>
-                      <a:pPr algn="r"/>
-                      <a:r>
-                        <a:rPr sz="1300" b="0">
-                          <a:solidFill>
-                            <a:srgbClr val="3C3C3B"/>
-                          </a:solidFill>
-                          <a:latin typeface="Aptos"/>
-                        </a:rPr>
                         <a:t>1.63x / 2.15x</a:t>
                       </a:r>
                     </a:p>
@@ -8147,139 +8240,28 @@
                           </a:solidFill>
                           <a:latin typeface="Aptos"/>
                         </a:rPr>
-                        <a:t>1.96x / 2.63x</a:t>
-                      </a:r>
-                    </a:p>
-                  </a:txBody>
-                  <a:tcPr marL="73152" marR="73152" marT="27432" marB="27432" anchor="ctr">
-                    <a:noFill/>
-                  </a:tcPr>
-                </a:tc>
-                <a:tc>
-                  <a:txBody>
-                    <a:bodyPr/>
-                    <a:lstStyle/>
-                    <a:p>
-                      <a:pPr algn="r"/>
-                      <a:r>
-                        <a:rPr sz="1300" b="0">
-                          <a:solidFill>
-                            <a:srgbClr val="3C3C3B"/>
-                          </a:solidFill>
-                          <a:latin typeface="Aptos"/>
-                        </a:rPr>
-                        <a:t>2.07x / 2.78x</a:t>
-                      </a:r>
-                    </a:p>
-                  </a:txBody>
-                  <a:tcPr marL="73152" marR="73152" marT="27432" marB="27432" anchor="ctr">
-                    <a:noFill/>
-                  </a:tcPr>
-                </a:tc>
-              </a:tr>
-              <a:tr h="420624">
-                <a:tc>
-                  <a:txBody>
-                    <a:bodyPr/>
-                    <a:lstStyle/>
-                    <a:p>
-                      <a:pPr algn="l"/>
-                      <a:r>
-                        <a:rPr sz="1300" b="0">
-                          <a:solidFill>
-                            <a:srgbClr val="3C3C3B"/>
-                          </a:solidFill>
-                          <a:latin typeface="Aptos"/>
-                        </a:rPr>
-                        <a:t>Buyer IRR, unlevered</a:t>
-                      </a:r>
-                    </a:p>
-                  </a:txBody>
-                  <a:tcPr marL="73152" marR="73152" marT="27432" marB="27432" anchor="ctr">
-                    <a:solidFill>
-                      <a:srgbClr val="F2F2F2"/>
-                    </a:solidFill>
-                  </a:tcPr>
-                </a:tc>
-                <a:tc>
-                  <a:txBody>
-                    <a:bodyPr/>
-                    <a:lstStyle/>
-                    <a:p>
-                      <a:pPr algn="l"/>
-                      <a:r>
-                        <a:rPr sz="1300" b="0">
-                          <a:solidFill>
-                            <a:srgbClr val="919191"/>
-                          </a:solidFill>
-                          <a:latin typeface="Aptos"/>
-                        </a:rPr>
-                        <a:t>%</a:t>
-                      </a:r>
-                    </a:p>
-                  </a:txBody>
-                  <a:tcPr marL="73152" marR="73152" marT="27432" marB="27432" anchor="ctr">
-                    <a:solidFill>
-                      <a:srgbClr val="F2F2F2"/>
-                    </a:solidFill>
-                  </a:tcPr>
-                </a:tc>
-                <a:tc>
-                  <a:txBody>
-                    <a:bodyPr/>
-                    <a:lstStyle/>
-                    <a:p>
-                      <a:pPr algn="r"/>
-                      <a:r>
-                        <a:rPr sz="1300" b="0">
-                          <a:solidFill>
-                            <a:srgbClr val="3C3C3B"/>
-                          </a:solidFill>
-                          <a:latin typeface="Aptos"/>
-                        </a:rPr>
-                        <a:t>5.7% / 7.0%</a:t>
-                      </a:r>
-                    </a:p>
-                  </a:txBody>
-                  <a:tcPr marL="73152" marR="73152" marT="27432" marB="27432" anchor="ctr">
-                    <a:noFill/>
-                  </a:tcPr>
-                </a:tc>
-                <a:tc>
-                  <a:txBody>
-                    <a:bodyPr/>
-                    <a:lstStyle/>
-                    <a:p>
-                      <a:pPr algn="r"/>
-                      <a:r>
-                        <a:rPr sz="1300" b="0">
-                          <a:solidFill>
-                            <a:srgbClr val="3C3C3B"/>
-                          </a:solidFill>
-                          <a:latin typeface="Aptos"/>
-                        </a:rPr>
-                        <a:t>8.1% / 9.7%</a:t>
-                      </a:r>
-                    </a:p>
-                  </a:txBody>
-                  <a:tcPr marL="73152" marR="73152" marT="27432" marB="27432" anchor="ctr">
-                    <a:noFill/>
-                  </a:tcPr>
-                </a:tc>
-                <a:tc>
-                  <a:txBody>
-                    <a:bodyPr/>
-                    <a:lstStyle/>
-                    <a:p>
-                      <a:pPr algn="r"/>
-                      <a:r>
-                        <a:rPr sz="1300" b="0">
-                          <a:solidFill>
-                            <a:srgbClr val="3C3C3B"/>
-                          </a:solidFill>
-                          <a:latin typeface="Aptos"/>
-                        </a:rPr>
-                        <a:t>8.8% / 10.4%</a:t>
+                        <a:t>2.01x / 2.71x</a:t>
+                      </a:r>
+                    </a:p>
+                  </a:txBody>
+                  <a:tcPr marL="73152" marR="73152" marT="27432" marB="27432" anchor="ctr">
+                    <a:noFill/>
+                  </a:tcPr>
+                </a:tc>
+                <a:tc>
+                  <a:txBody>
+                    <a:bodyPr/>
+                    <a:lstStyle/>
+                    <a:p>
+                      <a:pPr algn="r"/>
+                      <a:r>
+                        <a:rPr sz="1300" b="0">
+                          <a:solidFill>
+                            <a:srgbClr val="3C3C3B"/>
+                          </a:solidFill>
+                          <a:latin typeface="Aptos"/>
+                        </a:rPr>
+                        <a:t>2.21x / 3.01x</a:t>
                       </a:r>
                     </a:p>
                   </a:txBody>
@@ -8301,7 +8283,7 @@
         <p:spPr>
           <a:xfrm>
             <a:off x="14127480" y="2240280"/>
-            <a:ext cx="4069080" cy="6949440"/>
+            <a:ext cx="4069080" cy="7223760"/>
           </a:xfrm>
           <a:prstGeom prst="rect">
             <a:avLst/>
@@ -8340,7 +8322,7 @@
                 </a:solidFill>
                 <a:latin typeface="Aptos"/>
               </a:rPr>
-              <a:t>Why, and what to check</a:t>
+              <a:t>What it takes</a:t>
             </a:r>
           </a:p>
           <a:p>
@@ -8365,7 +8347,7 @@
                 </a:solidFill>
                 <a:latin typeface="Aptos"/>
               </a:rPr>
-              <a:t>2,850 h instead of 2,600; the EYA is not in the data room, so this needs the study first.</a:t>
+              <a:t>2,850 h in cases 2-3, from 2,600; the EYA is not in the data room, so the study comes first.</a:t>
             </a:r>
           </a:p>
           <a:p>
@@ -8390,7 +8372,7 @@
                 </a:solidFill>
                 <a:latin typeface="Aptos"/>
               </a:rPr>
-              <a:t>no overbuild and no BESS; municipal 10 k€/MW and community 2.0 €/MWh, the minimum the law may make mandatory anyway. Total uses fall from €113.4m to €100.2m (European).</a:t>
+              <a:t>no overbuild, BESS, municipal or community payment: lower capex and opex, but few points, so winning the tender is the main risk; a coming law may still require minimum payments.</a:t>
             </a:r>
           </a:p>
           <a:p>
@@ -8406,7 +8388,7 @@
                 </a:solidFill>
                 <a:latin typeface="Aptos"/>
               </a:rPr>
-              <a:t>PPA: </a:t>
+              <a:t>Price: </a:t>
             </a:r>
             <a:r>
               <a:rPr sz="1300" b="0">
@@ -8415,7 +8397,57 @@
                 </a:solidFill>
                 <a:latin typeface="Aptos"/>
               </a:rPr>
-              <a:t>COD is 2030 at the earliest, which leaves two years to sign a bankable long-term PPA. Aurora is conservative, and today's high prices may last longer than expected.</a:t>
+              <a:t>COD is 2030 at the earliest, leaving two years to sign a bankable long-term PPA; Aurora is conservative and today's high prices may last longer.</a:t>
+            </a:r>
+          </a:p>
+          <a:p>
+            <a:pPr algn="l">
+              <a:spcBef>
+                <a:spcPts val="800"/>
+              </a:spcBef>
+            </a:pPr>
+            <a:r>
+              <a:rPr sz="1300" b="1">
+                <a:solidFill>
+                  <a:srgbClr val="3C3C3B"/>
+                </a:solidFill>
+                <a:latin typeface="Aptos"/>
+              </a:rPr>
+              <a:t>Debt: </a:t>
+            </a:r>
+            <a:r>
+              <a:rPr sz="1300" b="0">
+                <a:solidFill>
+                  <a:srgbClr val="3C3C3B"/>
+                </a:solidFill>
+                <a:latin typeface="Aptos"/>
+              </a:rPr>
+              <a:t>a long PPA supports more debt for longer than the banks' first view; the DSCR stays at 3.01x (Chinese).</a:t>
+            </a:r>
+          </a:p>
+          <a:p>
+            <a:pPr algn="l">
+              <a:spcBef>
+                <a:spcPts val="800"/>
+              </a:spcBef>
+            </a:pPr>
+            <a:r>
+              <a:rPr sz="1300" b="1">
+                <a:solidFill>
+                  <a:srgbClr val="3C3C3B"/>
+                </a:solidFill>
+                <a:latin typeface="Aptos"/>
+              </a:rPr>
+              <a:t>European route: </a:t>
+            </a:r>
+            <a:r>
+              <a:rPr sz="1300" b="0">
+                <a:solidFill>
+                  <a:srgbClr val="3C3C3B"/>
+                </a:solidFill>
+                <a:latin typeface="Aptos"/>
+              </a:rPr>
+              <a:t>stays well below the Chinese one; it would also need much cheaper turbines and a higher PPA.</a:t>
             </a:r>
           </a:p>
           <a:p>
@@ -8440,7 +8472,7 @@
                 </a:solidFill>
                 <a:latin typeface="Aptos"/>
               </a:rPr>
-              <a:t>the same in both upside cases, because the sale price is fixed per MW; a higher PPA would support a higher price.</a:t>
+              <a:t>the price is fixed per MW, so a higher PPA does not show in the sale IRR.</a:t>
             </a:r>
           </a:p>
         </p:txBody>
@@ -8474,7 +8506,7 @@
                 </a:solidFill>
                 <a:latin typeface="Aptos"/>
               </a:rPr>
-              <a:t>Upside sets change only the inputs in the table, from the base; the zero bid keeps the turbine route and the PB multiple. Stored by the scenario macro with the tax solver.</a:t>
+              <a:t>Cases 2-3 change only the assumptions in the table, from the base; turbine route and PB multiple unchanged. Stored by the scenario macro with the tax solver.</a:t>
             </a:r>
           </a:p>
           <a:p>
@@ -8919,7 +8951,7 @@
                           </a:solidFill>
                           <a:latin typeface="Aptos"/>
                         </a:rPr>
-                        <a:t>Upside case</a:t>
+                        <a:t>Three cases</a:t>
                       </a:r>
                     </a:p>
                   </a:txBody>
@@ -13425,7 +13457,7 @@
                           </a:solidFill>
                           <a:latin typeface="Aptos"/>
                         </a:rPr>
-                        <a:t>Upside case</a:t>
+                        <a:t>Three cases</a:t>
                       </a:r>
                     </a:p>
                   </a:txBody>
@@ -15408,7 +15440,7 @@
                           </a:solidFill>
                           <a:latin typeface="Aptos"/>
                         </a:rPr>
-                        <a:t>Upside case</a:t>
+                        <a:t>Three cases</a:t>
                       </a:r>
                     </a:p>
                   </a:txBody>
@@ -17393,7 +17425,7 @@
                           </a:solidFill>
                           <a:latin typeface="Aptos"/>
                         </a:rPr>
-                        <a:t>Upside case</a:t>
+                        <a:t>Three cases</a:t>
                       </a:r>
                     </a:p>
                   </a:txBody>
@@ -19491,7 +19523,7 @@
                           </a:solidFill>
                           <a:latin typeface="Aptos"/>
                         </a:rPr>
-                        <a:t>Upside case</a:t>
+                        <a:t>Three cases</a:t>
                       </a:r>
                     </a:p>
                   </a:txBody>
@@ -21948,7 +21980,7 @@
                           </a:solidFill>
                           <a:latin typeface="Aptos"/>
                         </a:rPr>
-                        <a:t>Upside case</a:t>
+                        <a:t>Three cases</a:t>
                       </a:r>
                     </a:p>
                   </a:txBody>
@@ -23892,7 +23924,7 @@
                           </a:solidFill>
                           <a:latin typeface="Aptos"/>
                         </a:rPr>
-                        <a:t>Upside case</a:t>
+                        <a:t>Three cases</a:t>
                       </a:r>
                     </a:p>
                   </a:txBody>
@@ -26385,7 +26417,7 @@
                           </a:solidFill>
                           <a:latin typeface="Aptos"/>
                         </a:rPr>
-                        <a:t>Upside case</a:t>
+                        <a:t>Three cases</a:t>
                       </a:r>
                     </a:p>
                   </a:txBody>
@@ -27807,7 +27839,7 @@
                           </a:solidFill>
                           <a:latin typeface="Aptos"/>
                         </a:rPr>
-                        <a:t>Upside case</a:t>
+                        <a:t>Three cases</a:t>
                       </a:r>
                     </a:p>
                   </a:txBody>

</xml_diff>